<commit_message>
Rename proposal files to projectproposal.txt and projectproposal.docx.
</commit_message>
<xml_diff>
--- a/bundesliga_transfer_traits.pptx
+++ b/bundesliga_transfer_traits.pptx
@@ -5134,7 +5134,7 @@
                 </a:solidFill>
                 <a:latin typeface="Arial"/>
               </a:rPr>
-              <a:t>conrad.docx — proposal
+              <a:t>projectproposal.docx — proposal
 methodology_results_brief.html — short method deck
 bundesliga_transfer_traits.pptx — this template
 mock_pizza_bundesliga.png — pizza mock</a:t>
@@ -5229,7 +5229,7 @@
               </a:rPr>
               <a:t>interactive_player_explorer.html — dropdown by position + pizza
 cohort_data.json — open-data stress-test cohort
-CONRAD_PROPOSAL.txt — editable source for the Word doc</a:t>
+projectproposal.txt — editable source for the Word doc</a:t>
             </a:r>
           </a:p>
         </p:txBody>

</xml_diff>

<commit_message>
Add redundancy-picks slide from Step 2 PDF; gitignore StatsBomb-only decision tool.
</commit_message>
<xml_diff>
--- a/bundesliga_transfer_traits.pptx
+++ b/bundesliga_transfer_traits.pptx
@@ -10,6 +10,7 @@
     <p:sldId id="258" r:id="rId9"/>
     <p:sldId id="262" r:id="rId13"/>
     <p:sldId id="259" r:id="rId10"/>
+    <p:sldId id="263" r:id="rId14"/>
     <p:sldId id="260" r:id="rId11"/>
     <p:sldId id="261" r:id="rId12"/>
   </p:sldIdLst>
@@ -4349,901 +4350,6 @@
 </file>
 
 <file path=ppt/slides/slide4.xml><?xml version="1.0" encoding="utf-8"?>
-<p:sld xmlns:a="http://schemas.openxmlformats.org/drawingml/2006/main" xmlns:p="http://schemas.openxmlformats.org/presentationml/2006/main" xmlns:r="http://schemas.openxmlformats.org/officeDocument/2006/relationships">
-  <p:cSld>
-    <p:spTree>
-      <p:nvGrpSpPr>
-        <p:cNvPr id="1" name=""/>
-        <p:cNvGrpSpPr/>
-        <p:nvPr/>
-      </p:nvGrpSpPr>
-      <p:grpSpPr/>
-      <p:sp>
-        <p:nvSpPr>
-          <p:cNvPr id="2" name="Rectangle 1"/>
-          <p:cNvSpPr/>
-          <p:nvPr/>
-        </p:nvSpPr>
-        <p:spPr>
-          <a:xfrm>
-            <a:off x="0" y="0"/>
-            <a:ext cx="12191695" cy="6858000"/>
-          </a:xfrm>
-          <a:prstGeom prst="rect">
-            <a:avLst/>
-          </a:prstGeom>
-          <a:solidFill>
-            <a:srgbClr val="FFFFFF"/>
-          </a:solidFill>
-          <a:ln>
-            <a:noFill/>
-          </a:ln>
-        </p:spPr>
-        <p:style>
-          <a:lnRef idx="1">
-            <a:schemeClr val="accent1"/>
-          </a:lnRef>
-          <a:fillRef idx="3">
-            <a:schemeClr val="accent1"/>
-          </a:fillRef>
-          <a:effectRef idx="2">
-            <a:schemeClr val="accent1"/>
-          </a:effectRef>
-          <a:fontRef idx="minor">
-            <a:schemeClr val="lt1"/>
-          </a:fontRef>
-        </p:style>
-        <p:txBody>
-          <a:bodyPr rtlCol="0" anchor="ctr"/>
-          <a:lstStyle/>
-          <a:p>
-            <a:pPr algn="ctr"/>
-          </a:p>
-        </p:txBody>
-      </p:sp>
-      <p:sp>
-        <p:nvSpPr>
-          <p:cNvPr id="3" name="TextBox 2"/>
-          <p:cNvSpPr txBox="1"/>
-          <p:nvPr/>
-        </p:nvSpPr>
-        <p:spPr>
-          <a:xfrm>
-            <a:off x="457200" y="228600"/>
-            <a:ext cx="10972800" cy="274320"/>
-          </a:xfrm>
-          <a:prstGeom prst="rect">
-            <a:avLst/>
-          </a:prstGeom>
-          <a:noFill/>
-        </p:spPr>
-        <p:txBody>
-          <a:bodyPr wrap="none">
-            <a:spAutoFit/>
-          </a:bodyPr>
-          <a:lstStyle/>
-          <a:p>
-            <a:r>
-              <a:rPr sz="1100" b="1">
-                <a:solidFill>
-                  <a:srgbClr val="3D5A80"/>
-                </a:solidFill>
-                <a:latin typeface="Arial"/>
-              </a:rPr>
-              <a:t>OUTPUT · MOCK PIZZA · FBREF / OPEN-DATA STYLE</a:t>
-            </a:r>
-          </a:p>
-        </p:txBody>
-      </p:sp>
-      <p:sp>
-        <p:nvSpPr>
-          <p:cNvPr id="4" name="TextBox 3"/>
-          <p:cNvSpPr txBox="1"/>
-          <p:nvPr/>
-        </p:nvSpPr>
-        <p:spPr>
-          <a:xfrm>
-            <a:off x="457200" y="457200"/>
-            <a:ext cx="10972800" cy="548640"/>
-          </a:xfrm>
-          <a:prstGeom prst="rect">
-            <a:avLst/>
-          </a:prstGeom>
-          <a:noFill/>
-        </p:spPr>
-        <p:txBody>
-          <a:bodyPr wrap="none">
-            <a:spAutoFit/>
-          </a:bodyPr>
-          <a:lstStyle/>
-          <a:p>
-            <a:r>
-              <a:rPr sz="2800" b="1">
-                <a:solidFill>
-                  <a:srgbClr val="1C1C1C"/>
-                </a:solidFill>
-                <a:latin typeface="Georgia"/>
-              </a:rPr>
-              <a:t>Example player profile (mock)</a:t>
-            </a:r>
-          </a:p>
-        </p:txBody>
-      </p:sp>
-      <p:sp>
-        <p:nvSpPr>
-          <p:cNvPr id="5" name="TextBox 4"/>
-          <p:cNvSpPr txBox="1"/>
-          <p:nvPr/>
-        </p:nvSpPr>
-        <p:spPr>
-          <a:xfrm>
-            <a:off x="457200" y="960120"/>
-            <a:ext cx="10972800" cy="365760"/>
-          </a:xfrm>
-          <a:prstGeom prst="rect">
-            <a:avLst/>
-          </a:prstGeom>
-          <a:noFill/>
-        </p:spPr>
-        <p:txBody>
-          <a:bodyPr wrap="none">
-            <a:spAutoFit/>
-          </a:bodyPr>
-          <a:lstStyle/>
-          <a:p>
-            <a:r>
-              <a:rPr sz="1400" b="0">
-                <a:solidFill>
-                  <a:srgbClr val="555555"/>
-                </a:solidFill>
-                <a:latin typeface="Arial"/>
-              </a:rPr>
-              <a:t>Built from traits that passed stability + redundancy · not market value</a:t>
-            </a:r>
-          </a:p>
-        </p:txBody>
-      </p:sp>
-      <p:pic>
-        <p:nvPicPr>
-          <p:cNvPr id="6" name="Picture 5" descr="mock_pizza_bundesliga.png"/>
-          <p:cNvPicPr>
-            <a:picLocks noChangeAspect="1"/>
-          </p:cNvPicPr>
-          <p:nvPr/>
-        </p:nvPicPr>
-        <p:blipFill>
-          <a:blip r:embed="rId2"/>
-          <a:stretch>
-            <a:fillRect/>
-          </a:stretch>
-        </p:blipFill>
-        <p:spPr>
-          <a:xfrm>
-            <a:off x="457200" y="1325880"/>
-            <a:ext cx="7589520" cy="5059680"/>
-          </a:xfrm>
-          <a:prstGeom prst="rect">
-            <a:avLst/>
-          </a:prstGeom>
-        </p:spPr>
-      </p:pic>
-      <p:sp>
-        <p:nvSpPr>
-          <p:cNvPr id="7" name="Rounded Rectangle 6"/>
-          <p:cNvSpPr/>
-          <p:nvPr/>
-        </p:nvSpPr>
-        <p:spPr>
-          <a:xfrm>
-            <a:off x="8229600" y="1554480"/>
-            <a:ext cx="3474720" cy="4114800"/>
-          </a:xfrm>
-          <a:prstGeom prst="roundRect">
-            <a:avLst/>
-          </a:prstGeom>
-          <a:solidFill>
-            <a:srgbClr val="F4F5F7"/>
-          </a:solidFill>
-          <a:ln>
-            <a:solidFill>
-              <a:srgbClr val="D0D4DB"/>
-            </a:solidFill>
-          </a:ln>
-        </p:spPr>
-        <p:style>
-          <a:lnRef idx="1">
-            <a:schemeClr val="accent1"/>
-          </a:lnRef>
-          <a:fillRef idx="3">
-            <a:schemeClr val="accent1"/>
-          </a:fillRef>
-          <a:effectRef idx="2">
-            <a:schemeClr val="accent1"/>
-          </a:effectRef>
-          <a:fontRef idx="minor">
-            <a:schemeClr val="lt1"/>
-          </a:fontRef>
-        </p:style>
-        <p:txBody>
-          <a:bodyPr rtlCol="0" anchor="ctr"/>
-          <a:lstStyle/>
-          <a:p>
-            <a:pPr algn="ctr"/>
-          </a:p>
-        </p:txBody>
-      </p:sp>
-      <p:sp>
-        <p:nvSpPr>
-          <p:cNvPr id="8" name="TextBox 7"/>
-          <p:cNvSpPr txBox="1"/>
-          <p:nvPr/>
-        </p:nvSpPr>
-        <p:spPr>
-          <a:xfrm>
-            <a:off x="8366760" y="1691639"/>
-            <a:ext cx="3200400" cy="3840480"/>
-          </a:xfrm>
-          <a:prstGeom prst="rect">
-            <a:avLst/>
-          </a:prstGeom>
-          <a:noFill/>
-        </p:spPr>
-        <p:txBody>
-          <a:bodyPr wrap="square">
-            <a:spAutoFit/>
-          </a:bodyPr>
-          <a:lstStyle/>
-          <a:p>
-            <a:r>
-              <a:rPr sz="1400" b="1">
-                <a:solidFill>
-                  <a:srgbClr val="3D5A80"/>
-                </a:solidFill>
-                <a:latin typeface="Arial"/>
-              </a:rPr>
-              <a:t>How to read</a:t>
-            </a:r>
-          </a:p>
-          <a:p>
-            <a:r>
-              <a:rPr sz="1200" b="0">
-                <a:solidFill>
-                  <a:srgbClr val="1C1C1C"/>
-                </a:solidFill>
-                <a:latin typeface="Arial"/>
-              </a:rPr>
-              <a:t>Filled wedges = Year-1 Bundesliga percentiles.
-Dashed arc = avg peer at position.
-Solid arc = top peer.
-Only metrics that transferred well (stable) and are non-redundant appear on the pizza.
-Dropdown HTML explorer sorts players by position.</a:t>
-            </a:r>
-          </a:p>
-        </p:txBody>
-      </p:sp>
-    </p:spTree>
-  </p:cSld>
-  <p:clrMapOvr>
-    <a:masterClrMapping/>
-  </p:clrMapOvr>
-</p:sld>
-</file>
-
-<file path=ppt/slides/slide5.xml><?xml version="1.0" encoding="utf-8"?>
-<p:sld xmlns:a="http://schemas.openxmlformats.org/drawingml/2006/main" xmlns:p="http://schemas.openxmlformats.org/presentationml/2006/main" xmlns:r="http://schemas.openxmlformats.org/officeDocument/2006/relationships">
-  <p:cSld>
-    <p:spTree>
-      <p:nvGrpSpPr>
-        <p:cNvPr id="1" name=""/>
-        <p:cNvGrpSpPr/>
-        <p:nvPr/>
-      </p:nvGrpSpPr>
-      <p:grpSpPr/>
-      <p:sp>
-        <p:nvSpPr>
-          <p:cNvPr id="2" name="Rectangle 1"/>
-          <p:cNvSpPr/>
-          <p:nvPr/>
-        </p:nvSpPr>
-        <p:spPr>
-          <a:xfrm>
-            <a:off x="0" y="0"/>
-            <a:ext cx="12191695" cy="6858000"/>
-          </a:xfrm>
-          <a:prstGeom prst="rect">
-            <a:avLst/>
-          </a:prstGeom>
-          <a:solidFill>
-            <a:srgbClr val="FFFFFF"/>
-          </a:solidFill>
-          <a:ln>
-            <a:noFill/>
-          </a:ln>
-        </p:spPr>
-        <p:style>
-          <a:lnRef idx="1">
-            <a:schemeClr val="accent1"/>
-          </a:lnRef>
-          <a:fillRef idx="3">
-            <a:schemeClr val="accent1"/>
-          </a:fillRef>
-          <a:effectRef idx="2">
-            <a:schemeClr val="accent1"/>
-          </a:effectRef>
-          <a:fontRef idx="minor">
-            <a:schemeClr val="lt1"/>
-          </a:fontRef>
-        </p:style>
-        <p:txBody>
-          <a:bodyPr rtlCol="0" anchor="ctr"/>
-          <a:lstStyle/>
-          <a:p>
-            <a:pPr algn="ctr"/>
-          </a:p>
-        </p:txBody>
-      </p:sp>
-      <p:sp>
-        <p:nvSpPr>
-          <p:cNvPr id="3" name="TextBox 2"/>
-          <p:cNvSpPr txBox="1"/>
-          <p:nvPr/>
-        </p:nvSpPr>
-        <p:spPr>
-          <a:xfrm>
-            <a:off x="457200" y="228600"/>
-            <a:ext cx="10972800" cy="274320"/>
-          </a:xfrm>
-          <a:prstGeom prst="rect">
-            <a:avLst/>
-          </a:prstGeom>
-          <a:noFill/>
-        </p:spPr>
-        <p:txBody>
-          <a:bodyPr wrap="none">
-            <a:spAutoFit/>
-          </a:bodyPr>
-          <a:lstStyle/>
-          <a:p>
-            <a:r>
-              <a:rPr sz="1100" b="1">
-                <a:solidFill>
-                  <a:srgbClr val="3D5A80"/>
-                </a:solidFill>
-                <a:latin typeface="Arial"/>
-              </a:rPr>
-              <a:t>RESULTS FRAMING</a:t>
-            </a:r>
-          </a:p>
-        </p:txBody>
-      </p:sp>
-      <p:sp>
-        <p:nvSpPr>
-          <p:cNvPr id="4" name="TextBox 3"/>
-          <p:cNvSpPr txBox="1"/>
-          <p:nvPr/>
-        </p:nvSpPr>
-        <p:spPr>
-          <a:xfrm>
-            <a:off x="457200" y="457200"/>
-            <a:ext cx="10972800" cy="548640"/>
-          </a:xfrm>
-          <a:prstGeom prst="rect">
-            <a:avLst/>
-          </a:prstGeom>
-          <a:noFill/>
-        </p:spPr>
-        <p:txBody>
-          <a:bodyPr wrap="none">
-            <a:spAutoFit/>
-          </a:bodyPr>
-          <a:lstStyle/>
-          <a:p>
-            <a:r>
-              <a:rPr sz="2800" b="1">
-                <a:solidFill>
-                  <a:srgbClr val="1C1C1C"/>
-                </a:solidFill>
-                <a:latin typeface="Georgia"/>
-              </a:rPr>
-              <a:t>Traits to target · leagues to prioritize</a:t>
-            </a:r>
-          </a:p>
-        </p:txBody>
-      </p:sp>
-      <p:sp>
-        <p:nvSpPr>
-          <p:cNvPr id="5" name="TextBox 4"/>
-          <p:cNvSpPr txBox="1"/>
-          <p:nvPr/>
-        </p:nvSpPr>
-        <p:spPr>
-          <a:xfrm>
-            <a:off x="457200" y="960120"/>
-            <a:ext cx="10972800" cy="365760"/>
-          </a:xfrm>
-          <a:prstGeom prst="rect">
-            <a:avLst/>
-          </a:prstGeom>
-          <a:noFill/>
-        </p:spPr>
-        <p:txBody>
-          <a:bodyPr wrap="none">
-            <a:spAutoFit/>
-          </a:bodyPr>
-          <a:lstStyle/>
-          <a:p>
-            <a:r>
-              <a:rPr sz="1400" b="0">
-                <a:solidFill>
-                  <a:srgbClr val="555555"/>
-                </a:solidFill>
-                <a:latin typeface="Arial"/>
-              </a:rPr>
-              <a:t>Illustrative placeholders until FBref Tier-2 run is complete</a:t>
-            </a:r>
-          </a:p>
-        </p:txBody>
-      </p:sp>
-      <p:sp>
-        <p:nvSpPr>
-          <p:cNvPr id="6" name="TextBox 5"/>
-          <p:cNvSpPr txBox="1"/>
-          <p:nvPr/>
-        </p:nvSpPr>
-        <p:spPr>
-          <a:xfrm>
-            <a:off x="457200" y="1463040"/>
-            <a:ext cx="10972800" cy="4572000"/>
-          </a:xfrm>
-          <a:prstGeom prst="rect">
-            <a:avLst/>
-          </a:prstGeom>
-          <a:noFill/>
-        </p:spPr>
-        <p:txBody>
-          <a:bodyPr wrap="square">
-            <a:spAutoFit/>
-          </a:bodyPr>
-          <a:lstStyle/>
-          <a:p>
-            <a:pPr>
-              <a:spcAft>
-                <a:spcPts val="800"/>
-              </a:spcAft>
-            </a:pPr>
-            <a:r>
-              <a:rPr sz="1600" b="0">
-                <a:solidFill>
-                  <a:srgbClr val="1C1C1C"/>
-                </a:solidFill>
-                <a:latin typeface="Arial"/>
-              </a:rPr>
-              <a:t>Traits that typically travel (directional): aerials, xG finishing, short/volume passing, carry length.</a:t>
-            </a:r>
-          </a:p>
-          <a:p>
-            <a:pPr>
-              <a:spcAft>
-                <a:spcPts val="800"/>
-              </a:spcAft>
-            </a:pPr>
-            <a:r>
-              <a:rPr sz="1600" b="0">
-                <a:solidFill>
-                  <a:srgbClr val="1C1C1C"/>
-                </a:solidFill>
-                <a:latin typeface="Arial"/>
-              </a:rPr>
-              <a:t>Traits often league-style dependent: pressing volume, progressive-pass rate, possession-chain volume.</a:t>
-            </a:r>
-          </a:p>
-          <a:p>
-            <a:pPr>
-              <a:spcAft>
-                <a:spcPts val="800"/>
-              </a:spcAft>
-            </a:pPr>
-            <a:r>
-              <a:rPr sz="1600" b="0">
-                <a:solidFill>
-                  <a:srgbClr val="1C1C1C"/>
-                </a:solidFill>
-                <a:latin typeface="Arial"/>
-              </a:rPr>
-              <a:t/>
-            </a:r>
-          </a:p>
-          <a:p>
-            <a:pPr>
-              <a:spcAft>
-                <a:spcPts val="800"/>
-              </a:spcAft>
-            </a:pPr>
-            <a:r>
-              <a:rPr sz="1600" b="0">
-                <a:solidFill>
-                  <a:srgbClr val="1C1C1C"/>
-                </a:solidFill>
-                <a:latin typeface="Arial"/>
-              </a:rPr>
-              <a:t>Source-league scorecard (Tier 1+2): rank prior leagues by Y1 minutes + profile strength on kept traits.</a:t>
-            </a:r>
-          </a:p>
-          <a:p>
-            <a:pPr>
-              <a:spcAft>
-                <a:spcPts val="800"/>
-              </a:spcAft>
-            </a:pPr>
-            <a:r>
-              <a:rPr sz="1600" b="0">
-                <a:solidFill>
-                  <a:srgbClr val="1C1C1C"/>
-                </a:solidFill>
-                <a:latin typeface="Arial"/>
-              </a:rPr>
-              <a:t>Open-data preview feeders: World Cup, Euro, Ligue 1, La Liga, Champions League, Premier League.</a:t>
-            </a:r>
-          </a:p>
-        </p:txBody>
-      </p:sp>
-    </p:spTree>
-  </p:cSld>
-  <p:clrMapOvr>
-    <a:masterClrMapping/>
-  </p:clrMapOvr>
-</p:sld>
-</file>
-
-<file path=ppt/slides/slide6.xml><?xml version="1.0" encoding="utf-8"?>
-<p:sld xmlns:a="http://schemas.openxmlformats.org/drawingml/2006/main" xmlns:p="http://schemas.openxmlformats.org/presentationml/2006/main" xmlns:r="http://schemas.openxmlformats.org/officeDocument/2006/relationships">
-  <p:cSld>
-    <p:spTree>
-      <p:nvGrpSpPr>
-        <p:cNvPr id="1" name=""/>
-        <p:cNvGrpSpPr/>
-        <p:nvPr/>
-      </p:nvGrpSpPr>
-      <p:grpSpPr/>
-      <p:sp>
-        <p:nvSpPr>
-          <p:cNvPr id="2" name="Rectangle 1"/>
-          <p:cNvSpPr/>
-          <p:nvPr/>
-        </p:nvSpPr>
-        <p:spPr>
-          <a:xfrm>
-            <a:off x="0" y="0"/>
-            <a:ext cx="12191695" cy="6858000"/>
-          </a:xfrm>
-          <a:prstGeom prst="rect">
-            <a:avLst/>
-          </a:prstGeom>
-          <a:solidFill>
-            <a:srgbClr val="FFFFFF"/>
-          </a:solidFill>
-          <a:ln>
-            <a:noFill/>
-          </a:ln>
-        </p:spPr>
-        <p:style>
-          <a:lnRef idx="1">
-            <a:schemeClr val="accent1"/>
-          </a:lnRef>
-          <a:fillRef idx="3">
-            <a:schemeClr val="accent1"/>
-          </a:fillRef>
-          <a:effectRef idx="2">
-            <a:schemeClr val="accent1"/>
-          </a:effectRef>
-          <a:fontRef idx="minor">
-            <a:schemeClr val="lt1"/>
-          </a:fontRef>
-        </p:style>
-        <p:txBody>
-          <a:bodyPr rtlCol="0" anchor="ctr"/>
-          <a:lstStyle/>
-          <a:p>
-            <a:pPr algn="ctr"/>
-          </a:p>
-        </p:txBody>
-      </p:sp>
-      <p:sp>
-        <p:nvSpPr>
-          <p:cNvPr id="3" name="TextBox 2"/>
-          <p:cNvSpPr txBox="1"/>
-          <p:nvPr/>
-        </p:nvSpPr>
-        <p:spPr>
-          <a:xfrm>
-            <a:off x="457200" y="228600"/>
-            <a:ext cx="10972800" cy="274320"/>
-          </a:xfrm>
-          <a:prstGeom prst="rect">
-            <a:avLst/>
-          </a:prstGeom>
-          <a:noFill/>
-        </p:spPr>
-        <p:txBody>
-          <a:bodyPr wrap="none">
-            <a:spAutoFit/>
-          </a:bodyPr>
-          <a:lstStyle/>
-          <a:p>
-            <a:r>
-              <a:rPr sz="1100" b="1">
-                <a:solidFill>
-                  <a:srgbClr val="3D5A80"/>
-                </a:solidFill>
-                <a:latin typeface="Arial"/>
-              </a:rPr>
-              <a:t>DELIVERABLES · CAL PACKAGE</a:t>
-            </a:r>
-          </a:p>
-        </p:txBody>
-      </p:sp>
-      <p:sp>
-        <p:nvSpPr>
-          <p:cNvPr id="4" name="TextBox 3"/>
-          <p:cNvSpPr txBox="1"/>
-          <p:nvPr/>
-        </p:nvSpPr>
-        <p:spPr>
-          <a:xfrm>
-            <a:off x="457200" y="457200"/>
-            <a:ext cx="10972800" cy="548640"/>
-          </a:xfrm>
-          <a:prstGeom prst="rect">
-            <a:avLst/>
-          </a:prstGeom>
-          <a:noFill/>
-        </p:spPr>
-        <p:txBody>
-          <a:bodyPr wrap="none">
-            <a:spAutoFit/>
-          </a:bodyPr>
-          <a:lstStyle/>
-          <a:p>
-            <a:r>
-              <a:rPr sz="2800" b="1">
-                <a:solidFill>
-                  <a:srgbClr val="1C1C1C"/>
-                </a:solidFill>
-                <a:latin typeface="Georgia"/>
-              </a:rPr>
-              <a:t>What ships</a:t>
-            </a:r>
-          </a:p>
-        </p:txBody>
-      </p:sp>
-      <p:sp>
-        <p:nvSpPr>
-          <p:cNvPr id="5" name="TextBox 4"/>
-          <p:cNvSpPr txBox="1"/>
-          <p:nvPr/>
-        </p:nvSpPr>
-        <p:spPr>
-          <a:xfrm>
-            <a:off x="457200" y="960120"/>
-            <a:ext cx="10972800" cy="365760"/>
-          </a:xfrm>
-          <a:prstGeom prst="rect">
-            <a:avLst/>
-          </a:prstGeom>
-          <a:noFill/>
-        </p:spPr>
-        <p:txBody>
-          <a:bodyPr wrap="none">
-            <a:spAutoFit/>
-          </a:bodyPr>
-          <a:lstStyle/>
-          <a:p>
-            <a:r>
-              <a:rPr sz="1400" b="0">
-                <a:solidFill>
-                  <a:srgbClr val="555555"/>
-                </a:solidFill>
-                <a:latin typeface="Arial"/>
-              </a:rPr>
-              <a:t>GitHub: colbymorris08/bundesliga-transfer-traits</a:t>
-            </a:r>
-          </a:p>
-        </p:txBody>
-      </p:sp>
-      <p:sp>
-        <p:nvSpPr>
-          <p:cNvPr id="6" name="Rounded Rectangle 5"/>
-          <p:cNvSpPr/>
-          <p:nvPr/>
-        </p:nvSpPr>
-        <p:spPr>
-          <a:xfrm>
-            <a:off x="457200" y="1554480"/>
-            <a:ext cx="5486400" cy="3657600"/>
-          </a:xfrm>
-          <a:prstGeom prst="roundRect">
-            <a:avLst/>
-          </a:prstGeom>
-          <a:solidFill>
-            <a:srgbClr val="F4F5F7"/>
-          </a:solidFill>
-          <a:ln>
-            <a:solidFill>
-              <a:srgbClr val="D0D4DB"/>
-            </a:solidFill>
-          </a:ln>
-        </p:spPr>
-        <p:style>
-          <a:lnRef idx="1">
-            <a:schemeClr val="accent1"/>
-          </a:lnRef>
-          <a:fillRef idx="3">
-            <a:schemeClr val="accent1"/>
-          </a:fillRef>
-          <a:effectRef idx="2">
-            <a:schemeClr val="accent1"/>
-          </a:effectRef>
-          <a:fontRef idx="minor">
-            <a:schemeClr val="lt1"/>
-          </a:fontRef>
-        </p:style>
-        <p:txBody>
-          <a:bodyPr rtlCol="0" anchor="ctr"/>
-          <a:lstStyle/>
-          <a:p>
-            <a:pPr algn="ctr"/>
-          </a:p>
-        </p:txBody>
-      </p:sp>
-      <p:sp>
-        <p:nvSpPr>
-          <p:cNvPr id="7" name="TextBox 6"/>
-          <p:cNvSpPr txBox="1"/>
-          <p:nvPr/>
-        </p:nvSpPr>
-        <p:spPr>
-          <a:xfrm>
-            <a:off x="594360" y="1691639"/>
-            <a:ext cx="5212080" cy="3383280"/>
-          </a:xfrm>
-          <a:prstGeom prst="rect">
-            <a:avLst/>
-          </a:prstGeom>
-          <a:noFill/>
-        </p:spPr>
-        <p:txBody>
-          <a:bodyPr wrap="square">
-            <a:spAutoFit/>
-          </a:bodyPr>
-          <a:lstStyle/>
-          <a:p>
-            <a:r>
-              <a:rPr sz="1400" b="1">
-                <a:solidFill>
-                  <a:srgbClr val="3D5A80"/>
-                </a:solidFill>
-                <a:latin typeface="Arial"/>
-              </a:rPr>
-              <a:t>For Conrad / review</a:t>
-            </a:r>
-          </a:p>
-          <a:p>
-            <a:r>
-              <a:rPr sz="1200" b="0">
-                <a:solidFill>
-                  <a:srgbClr val="1C1C1C"/>
-                </a:solidFill>
-                <a:latin typeface="Arial"/>
-              </a:rPr>
-              <a:t>projectproposal.docx — proposal
-methodology_results_brief.html — short method deck
-bundesliga_transfer_traits.pptx — this template
-mock_pizza_bundesliga.png — pizza mock</a:t>
-            </a:r>
-          </a:p>
-        </p:txBody>
-      </p:sp>
-      <p:sp>
-        <p:nvSpPr>
-          <p:cNvPr id="8" name="Rounded Rectangle 7"/>
-          <p:cNvSpPr/>
-          <p:nvPr/>
-        </p:nvSpPr>
-        <p:spPr>
-          <a:xfrm>
-            <a:off x="6217920" y="1554480"/>
-            <a:ext cx="5486400" cy="3657600"/>
-          </a:xfrm>
-          <a:prstGeom prst="roundRect">
-            <a:avLst/>
-          </a:prstGeom>
-          <a:solidFill>
-            <a:srgbClr val="F4F5F7"/>
-          </a:solidFill>
-          <a:ln>
-            <a:solidFill>
-              <a:srgbClr val="D0D4DB"/>
-            </a:solidFill>
-          </a:ln>
-        </p:spPr>
-        <p:style>
-          <a:lnRef idx="1">
-            <a:schemeClr val="accent1"/>
-          </a:lnRef>
-          <a:fillRef idx="3">
-            <a:schemeClr val="accent1"/>
-          </a:fillRef>
-          <a:effectRef idx="2">
-            <a:schemeClr val="accent1"/>
-          </a:effectRef>
-          <a:fontRef idx="minor">
-            <a:schemeClr val="lt1"/>
-          </a:fontRef>
-        </p:style>
-        <p:txBody>
-          <a:bodyPr rtlCol="0" anchor="ctr"/>
-          <a:lstStyle/>
-          <a:p>
-            <a:pPr algn="ctr"/>
-          </a:p>
-        </p:txBody>
-      </p:sp>
-      <p:sp>
-        <p:nvSpPr>
-          <p:cNvPr id="9" name="TextBox 8"/>
-          <p:cNvSpPr txBox="1"/>
-          <p:nvPr/>
-        </p:nvSpPr>
-        <p:spPr>
-          <a:xfrm>
-            <a:off x="6355080" y="1691639"/>
-            <a:ext cx="5212080" cy="3383280"/>
-          </a:xfrm>
-          <a:prstGeom prst="rect">
-            <a:avLst/>
-          </a:prstGeom>
-          <a:noFill/>
-        </p:spPr>
-        <p:txBody>
-          <a:bodyPr wrap="square">
-            <a:spAutoFit/>
-          </a:bodyPr>
-          <a:lstStyle/>
-          <a:p>
-            <a:r>
-              <a:rPr sz="1400" b="1">
-                <a:solidFill>
-                  <a:srgbClr val="3D5A80"/>
-                </a:solidFill>
-                <a:latin typeface="Arial"/>
-              </a:rPr>
-              <a:t>Interactive / data</a:t>
-            </a:r>
-          </a:p>
-          <a:p>
-            <a:r>
-              <a:rPr sz="1200" b="0">
-                <a:solidFill>
-                  <a:srgbClr val="1C1C1C"/>
-                </a:solidFill>
-                <a:latin typeface="Arial"/>
-              </a:rPr>
-              <a:t>interactive_player_explorer.html — dropdown by position + pizza
-cohort_data.json — open-data stress-test cohort
-projectproposal.txt — editable source for the Word doc</a:t>
-            </a:r>
-          </a:p>
-        </p:txBody>
-      </p:sp>
-    </p:spTree>
-  </p:cSld>
-  <p:clrMapOvr>
-    <a:masterClrMapping/>
-  </p:clrMapOvr>
-</p:sld>
-</file>
-
-<file path=ppt/slides/slide7.xml><?xml version="1.0" encoding="utf-8"?>
 <p:sld xmlns:a="http://schemas.openxmlformats.org/drawingml/2006/main" xmlns:p="http://schemas.openxmlformats.org/presentationml/2006/main" xmlns:r="http://schemas.openxmlformats.org/officeDocument/2006/relationships">
   <p:cSld>
     <p:spTree>
@@ -6822,6 +5928,1754 @@
 </p:sld>
 </file>
 
+<file path=ppt/slides/slide5.xml><?xml version="1.0" encoding="utf-8"?>
+<p:sld xmlns:a="http://schemas.openxmlformats.org/drawingml/2006/main" xmlns:p="http://schemas.openxmlformats.org/presentationml/2006/main" xmlns:r="http://schemas.openxmlformats.org/officeDocument/2006/relationships">
+  <p:cSld>
+    <p:spTree>
+      <p:nvGrpSpPr>
+        <p:cNvPr id="1" name=""/>
+        <p:cNvGrpSpPr/>
+        <p:nvPr/>
+      </p:nvGrpSpPr>
+      <p:grpSpPr/>
+      <p:sp>
+        <p:nvSpPr>
+          <p:cNvPr id="2" name="Rectangle 1"/>
+          <p:cNvSpPr/>
+          <p:nvPr/>
+        </p:nvSpPr>
+        <p:spPr>
+          <a:xfrm>
+            <a:off x="0" y="0"/>
+            <a:ext cx="12191695" cy="6858000"/>
+          </a:xfrm>
+          <a:prstGeom prst="rect">
+            <a:avLst/>
+          </a:prstGeom>
+          <a:solidFill>
+            <a:srgbClr val="FFFFFF"/>
+          </a:solidFill>
+          <a:ln>
+            <a:noFill/>
+          </a:ln>
+        </p:spPr>
+        <p:style>
+          <a:lnRef idx="1">
+            <a:schemeClr val="accent1"/>
+          </a:lnRef>
+          <a:fillRef idx="3">
+            <a:schemeClr val="accent1"/>
+          </a:fillRef>
+          <a:effectRef idx="2">
+            <a:schemeClr val="accent1"/>
+          </a:effectRef>
+          <a:fontRef idx="minor">
+            <a:schemeClr val="lt1"/>
+          </a:fontRef>
+        </p:style>
+        <p:txBody>
+          <a:bodyPr rtlCol="0" anchor="ctr"/>
+          <a:lstStyle/>
+          <a:p>
+            <a:pPr algn="ctr"/>
+          </a:p>
+        </p:txBody>
+      </p:sp>
+      <p:sp>
+        <p:nvSpPr>
+          <p:cNvPr id="3" name="TextBox 2"/>
+          <p:cNvSpPr txBox="1"/>
+          <p:nvPr/>
+        </p:nvSpPr>
+        <p:spPr>
+          <a:xfrm>
+            <a:off x="457200" y="228600"/>
+            <a:ext cx="10972800" cy="274320"/>
+          </a:xfrm>
+          <a:prstGeom prst="rect">
+            <a:avLst/>
+          </a:prstGeom>
+          <a:noFill/>
+        </p:spPr>
+        <p:txBody>
+          <a:bodyPr wrap="none">
+            <a:spAutoFit/>
+          </a:bodyPr>
+          <a:lstStyle/>
+          <a:p>
+            <a:r>
+              <a:rPr sz="1100" b="1">
+                <a:solidFill>
+                  <a:srgbClr val="3D5A80"/>
+                </a:solidFill>
+                <a:latin typeface="Arial"/>
+              </a:rPr>
+              <a:t>OUTPUT · MOCK PIZZA · FBREF / OPEN-DATA STYLE</a:t>
+            </a:r>
+          </a:p>
+        </p:txBody>
+      </p:sp>
+      <p:sp>
+        <p:nvSpPr>
+          <p:cNvPr id="4" name="TextBox 3"/>
+          <p:cNvSpPr txBox="1"/>
+          <p:nvPr/>
+        </p:nvSpPr>
+        <p:spPr>
+          <a:xfrm>
+            <a:off x="457200" y="457200"/>
+            <a:ext cx="10972800" cy="548640"/>
+          </a:xfrm>
+          <a:prstGeom prst="rect">
+            <a:avLst/>
+          </a:prstGeom>
+          <a:noFill/>
+        </p:spPr>
+        <p:txBody>
+          <a:bodyPr wrap="none">
+            <a:spAutoFit/>
+          </a:bodyPr>
+          <a:lstStyle/>
+          <a:p>
+            <a:r>
+              <a:rPr sz="2800" b="1">
+                <a:solidFill>
+                  <a:srgbClr val="1C1C1C"/>
+                </a:solidFill>
+                <a:latin typeface="Georgia"/>
+              </a:rPr>
+              <a:t>Example player profile (mock)</a:t>
+            </a:r>
+          </a:p>
+        </p:txBody>
+      </p:sp>
+      <p:sp>
+        <p:nvSpPr>
+          <p:cNvPr id="5" name="TextBox 4"/>
+          <p:cNvSpPr txBox="1"/>
+          <p:nvPr/>
+        </p:nvSpPr>
+        <p:spPr>
+          <a:xfrm>
+            <a:off x="457200" y="960120"/>
+            <a:ext cx="10972800" cy="365760"/>
+          </a:xfrm>
+          <a:prstGeom prst="rect">
+            <a:avLst/>
+          </a:prstGeom>
+          <a:noFill/>
+        </p:spPr>
+        <p:txBody>
+          <a:bodyPr wrap="none">
+            <a:spAutoFit/>
+          </a:bodyPr>
+          <a:lstStyle/>
+          <a:p>
+            <a:r>
+              <a:rPr sz="1400" b="0">
+                <a:solidFill>
+                  <a:srgbClr val="555555"/>
+                </a:solidFill>
+                <a:latin typeface="Arial"/>
+              </a:rPr>
+              <a:t>Built from traits that passed stability + redundancy · not market value</a:t>
+            </a:r>
+          </a:p>
+        </p:txBody>
+      </p:sp>
+      <p:pic>
+        <p:nvPicPr>
+          <p:cNvPr id="6" name="Picture 5" descr="mock_pizza_bundesliga.png"/>
+          <p:cNvPicPr>
+            <a:picLocks noChangeAspect="1"/>
+          </p:cNvPicPr>
+          <p:nvPr/>
+        </p:nvPicPr>
+        <p:blipFill>
+          <a:blip r:embed="rId2"/>
+          <a:stretch>
+            <a:fillRect/>
+          </a:stretch>
+        </p:blipFill>
+        <p:spPr>
+          <a:xfrm>
+            <a:off x="457200" y="1325880"/>
+            <a:ext cx="7589520" cy="5059680"/>
+          </a:xfrm>
+          <a:prstGeom prst="rect">
+            <a:avLst/>
+          </a:prstGeom>
+        </p:spPr>
+      </p:pic>
+      <p:sp>
+        <p:nvSpPr>
+          <p:cNvPr id="7" name="Rounded Rectangle 6"/>
+          <p:cNvSpPr/>
+          <p:nvPr/>
+        </p:nvSpPr>
+        <p:spPr>
+          <a:xfrm>
+            <a:off x="8229600" y="1554480"/>
+            <a:ext cx="3474720" cy="4114800"/>
+          </a:xfrm>
+          <a:prstGeom prst="roundRect">
+            <a:avLst/>
+          </a:prstGeom>
+          <a:solidFill>
+            <a:srgbClr val="F4F5F7"/>
+          </a:solidFill>
+          <a:ln>
+            <a:solidFill>
+              <a:srgbClr val="D0D4DB"/>
+            </a:solidFill>
+          </a:ln>
+        </p:spPr>
+        <p:style>
+          <a:lnRef idx="1">
+            <a:schemeClr val="accent1"/>
+          </a:lnRef>
+          <a:fillRef idx="3">
+            <a:schemeClr val="accent1"/>
+          </a:fillRef>
+          <a:effectRef idx="2">
+            <a:schemeClr val="accent1"/>
+          </a:effectRef>
+          <a:fontRef idx="minor">
+            <a:schemeClr val="lt1"/>
+          </a:fontRef>
+        </p:style>
+        <p:txBody>
+          <a:bodyPr rtlCol="0" anchor="ctr"/>
+          <a:lstStyle/>
+          <a:p>
+            <a:pPr algn="ctr"/>
+          </a:p>
+        </p:txBody>
+      </p:sp>
+      <p:sp>
+        <p:nvSpPr>
+          <p:cNvPr id="8" name="TextBox 7"/>
+          <p:cNvSpPr txBox="1"/>
+          <p:nvPr/>
+        </p:nvSpPr>
+        <p:spPr>
+          <a:xfrm>
+            <a:off x="8366760" y="1691639"/>
+            <a:ext cx="3200400" cy="3840480"/>
+          </a:xfrm>
+          <a:prstGeom prst="rect">
+            <a:avLst/>
+          </a:prstGeom>
+          <a:noFill/>
+        </p:spPr>
+        <p:txBody>
+          <a:bodyPr wrap="square">
+            <a:spAutoFit/>
+          </a:bodyPr>
+          <a:lstStyle/>
+          <a:p>
+            <a:r>
+              <a:rPr sz="1400" b="1">
+                <a:solidFill>
+                  <a:srgbClr val="3D5A80"/>
+                </a:solidFill>
+                <a:latin typeface="Arial"/>
+              </a:rPr>
+              <a:t>How to read</a:t>
+            </a:r>
+          </a:p>
+          <a:p>
+            <a:r>
+              <a:rPr sz="1200" b="0">
+                <a:solidFill>
+                  <a:srgbClr val="1C1C1C"/>
+                </a:solidFill>
+                <a:latin typeface="Arial"/>
+              </a:rPr>
+              <a:t>Filled wedges = Year-1 Bundesliga percentiles.
+Dashed arc = avg peer at position.
+Solid arc = top peer.
+Only metrics that transferred well (stable) and are non-redundant appear on the pizza.
+Dropdown HTML explorer sorts players by position.</a:t>
+            </a:r>
+          </a:p>
+        </p:txBody>
+      </p:sp>
+    </p:spTree>
+  </p:cSld>
+  <p:clrMapOvr>
+    <a:masterClrMapping/>
+  </p:clrMapOvr>
+</p:sld>
+</file>
+
+<file path=ppt/slides/slide6.xml><?xml version="1.0" encoding="utf-8"?>
+<p:sld xmlns:a="http://schemas.openxmlformats.org/drawingml/2006/main" xmlns:p="http://schemas.openxmlformats.org/presentationml/2006/main" xmlns:r="http://schemas.openxmlformats.org/officeDocument/2006/relationships">
+  <p:cSld>
+    <p:spTree>
+      <p:nvGrpSpPr>
+        <p:cNvPr id="1" name=""/>
+        <p:cNvGrpSpPr/>
+        <p:nvPr/>
+      </p:nvGrpSpPr>
+      <p:grpSpPr/>
+      <p:sp>
+        <p:nvSpPr>
+          <p:cNvPr id="2" name="Rectangle 1"/>
+          <p:cNvSpPr/>
+          <p:nvPr/>
+        </p:nvSpPr>
+        <p:spPr>
+          <a:xfrm>
+            <a:off x="0" y="0"/>
+            <a:ext cx="12191695" cy="6858000"/>
+          </a:xfrm>
+          <a:prstGeom prst="rect">
+            <a:avLst/>
+          </a:prstGeom>
+          <a:solidFill>
+            <a:srgbClr val="FFFFFF"/>
+          </a:solidFill>
+          <a:ln>
+            <a:noFill/>
+          </a:ln>
+        </p:spPr>
+        <p:style>
+          <a:lnRef idx="1">
+            <a:schemeClr val="accent1"/>
+          </a:lnRef>
+          <a:fillRef idx="3">
+            <a:schemeClr val="accent1"/>
+          </a:fillRef>
+          <a:effectRef idx="2">
+            <a:schemeClr val="accent1"/>
+          </a:effectRef>
+          <a:fontRef idx="minor">
+            <a:schemeClr val="lt1"/>
+          </a:fontRef>
+        </p:style>
+        <p:txBody>
+          <a:bodyPr rtlCol="0" anchor="ctr"/>
+          <a:lstStyle/>
+          <a:p>
+            <a:pPr algn="ctr"/>
+          </a:p>
+        </p:txBody>
+      </p:sp>
+      <p:sp>
+        <p:nvSpPr>
+          <p:cNvPr id="3" name="TextBox 2"/>
+          <p:cNvSpPr txBox="1"/>
+          <p:nvPr/>
+        </p:nvSpPr>
+        <p:spPr>
+          <a:xfrm>
+            <a:off x="457200" y="228600"/>
+            <a:ext cx="10972800" cy="274320"/>
+          </a:xfrm>
+          <a:prstGeom prst="rect">
+            <a:avLst/>
+          </a:prstGeom>
+          <a:noFill/>
+        </p:spPr>
+        <p:txBody>
+          <a:bodyPr wrap="none">
+            <a:spAutoFit/>
+          </a:bodyPr>
+          <a:lstStyle/>
+          <a:p>
+            <a:r>
+              <a:rPr sz="1100" b="1">
+                <a:solidFill>
+                  <a:srgbClr val="3D5A80"/>
+                </a:solidFill>
+                <a:latin typeface="Arial"/>
+              </a:rPr>
+              <a:t>RESULTS FRAMING</a:t>
+            </a:r>
+          </a:p>
+        </p:txBody>
+      </p:sp>
+      <p:sp>
+        <p:nvSpPr>
+          <p:cNvPr id="4" name="TextBox 3"/>
+          <p:cNvSpPr txBox="1"/>
+          <p:nvPr/>
+        </p:nvSpPr>
+        <p:spPr>
+          <a:xfrm>
+            <a:off x="457200" y="457200"/>
+            <a:ext cx="10972800" cy="548640"/>
+          </a:xfrm>
+          <a:prstGeom prst="rect">
+            <a:avLst/>
+          </a:prstGeom>
+          <a:noFill/>
+        </p:spPr>
+        <p:txBody>
+          <a:bodyPr wrap="none">
+            <a:spAutoFit/>
+          </a:bodyPr>
+          <a:lstStyle/>
+          <a:p>
+            <a:r>
+              <a:rPr sz="2800" b="1">
+                <a:solidFill>
+                  <a:srgbClr val="1C1C1C"/>
+                </a:solidFill>
+                <a:latin typeface="Georgia"/>
+              </a:rPr>
+              <a:t>Traits to target · leagues to prioritize</a:t>
+            </a:r>
+          </a:p>
+        </p:txBody>
+      </p:sp>
+      <p:sp>
+        <p:nvSpPr>
+          <p:cNvPr id="5" name="TextBox 4"/>
+          <p:cNvSpPr txBox="1"/>
+          <p:nvPr/>
+        </p:nvSpPr>
+        <p:spPr>
+          <a:xfrm>
+            <a:off x="457200" y="960120"/>
+            <a:ext cx="10972800" cy="365760"/>
+          </a:xfrm>
+          <a:prstGeom prst="rect">
+            <a:avLst/>
+          </a:prstGeom>
+          <a:noFill/>
+        </p:spPr>
+        <p:txBody>
+          <a:bodyPr wrap="none">
+            <a:spAutoFit/>
+          </a:bodyPr>
+          <a:lstStyle/>
+          <a:p>
+            <a:r>
+              <a:rPr sz="1400" b="0">
+                <a:solidFill>
+                  <a:srgbClr val="555555"/>
+                </a:solidFill>
+                <a:latin typeface="Arial"/>
+              </a:rPr>
+              <a:t>Illustrative placeholders until FBref Tier-2 run is complete</a:t>
+            </a:r>
+          </a:p>
+        </p:txBody>
+      </p:sp>
+      <p:sp>
+        <p:nvSpPr>
+          <p:cNvPr id="6" name="TextBox 5"/>
+          <p:cNvSpPr txBox="1"/>
+          <p:nvPr/>
+        </p:nvSpPr>
+        <p:spPr>
+          <a:xfrm>
+            <a:off x="457200" y="1463040"/>
+            <a:ext cx="10972800" cy="4572000"/>
+          </a:xfrm>
+          <a:prstGeom prst="rect">
+            <a:avLst/>
+          </a:prstGeom>
+          <a:noFill/>
+        </p:spPr>
+        <p:txBody>
+          <a:bodyPr wrap="square">
+            <a:spAutoFit/>
+          </a:bodyPr>
+          <a:lstStyle/>
+          <a:p>
+            <a:pPr>
+              <a:spcAft>
+                <a:spcPts val="800"/>
+              </a:spcAft>
+            </a:pPr>
+            <a:r>
+              <a:rPr sz="1600" b="0">
+                <a:solidFill>
+                  <a:srgbClr val="1C1C1C"/>
+                </a:solidFill>
+                <a:latin typeface="Arial"/>
+              </a:rPr>
+              <a:t>Traits that typically travel (directional): aerials, xG finishing, short/volume passing, carry length.</a:t>
+            </a:r>
+          </a:p>
+          <a:p>
+            <a:pPr>
+              <a:spcAft>
+                <a:spcPts val="800"/>
+              </a:spcAft>
+            </a:pPr>
+            <a:r>
+              <a:rPr sz="1600" b="0">
+                <a:solidFill>
+                  <a:srgbClr val="1C1C1C"/>
+                </a:solidFill>
+                <a:latin typeface="Arial"/>
+              </a:rPr>
+              <a:t>Traits often league-style dependent: pressing volume, progressive-pass rate, possession-chain volume.</a:t>
+            </a:r>
+          </a:p>
+          <a:p>
+            <a:pPr>
+              <a:spcAft>
+                <a:spcPts val="800"/>
+              </a:spcAft>
+            </a:pPr>
+            <a:r>
+              <a:rPr sz="1600" b="0">
+                <a:solidFill>
+                  <a:srgbClr val="1C1C1C"/>
+                </a:solidFill>
+                <a:latin typeface="Arial"/>
+              </a:rPr>
+              <a:t/>
+            </a:r>
+          </a:p>
+          <a:p>
+            <a:pPr>
+              <a:spcAft>
+                <a:spcPts val="800"/>
+              </a:spcAft>
+            </a:pPr>
+            <a:r>
+              <a:rPr sz="1600" b="0">
+                <a:solidFill>
+                  <a:srgbClr val="1C1C1C"/>
+                </a:solidFill>
+                <a:latin typeface="Arial"/>
+              </a:rPr>
+              <a:t>Source-league scorecard (Tier 1+2): rank prior leagues by Y1 minutes + profile strength on kept traits.</a:t>
+            </a:r>
+          </a:p>
+          <a:p>
+            <a:pPr>
+              <a:spcAft>
+                <a:spcPts val="800"/>
+              </a:spcAft>
+            </a:pPr>
+            <a:r>
+              <a:rPr sz="1600" b="0">
+                <a:solidFill>
+                  <a:srgbClr val="1C1C1C"/>
+                </a:solidFill>
+                <a:latin typeface="Arial"/>
+              </a:rPr>
+              <a:t>Open-data preview feeders: World Cup, Euro, Ligue 1, La Liga, Champions League, Premier League.</a:t>
+            </a:r>
+          </a:p>
+        </p:txBody>
+      </p:sp>
+    </p:spTree>
+  </p:cSld>
+  <p:clrMapOvr>
+    <a:masterClrMapping/>
+  </p:clrMapOvr>
+</p:sld>
+</file>
+
+<file path=ppt/slides/slide7.xml><?xml version="1.0" encoding="utf-8"?>
+<p:sld xmlns:a="http://schemas.openxmlformats.org/drawingml/2006/main" xmlns:p="http://schemas.openxmlformats.org/presentationml/2006/main" xmlns:r="http://schemas.openxmlformats.org/officeDocument/2006/relationships">
+  <p:cSld>
+    <p:spTree>
+      <p:nvGrpSpPr>
+        <p:cNvPr id="1" name=""/>
+        <p:cNvGrpSpPr/>
+        <p:nvPr/>
+      </p:nvGrpSpPr>
+      <p:grpSpPr/>
+      <p:sp>
+        <p:nvSpPr>
+          <p:cNvPr id="2" name="Rectangle 1"/>
+          <p:cNvSpPr/>
+          <p:nvPr/>
+        </p:nvSpPr>
+        <p:spPr>
+          <a:xfrm>
+            <a:off x="0" y="0"/>
+            <a:ext cx="12191695" cy="6858000"/>
+          </a:xfrm>
+          <a:prstGeom prst="rect">
+            <a:avLst/>
+          </a:prstGeom>
+          <a:solidFill>
+            <a:srgbClr val="FFFFFF"/>
+          </a:solidFill>
+          <a:ln>
+            <a:noFill/>
+          </a:ln>
+        </p:spPr>
+        <p:style>
+          <a:lnRef idx="1">
+            <a:schemeClr val="accent1"/>
+          </a:lnRef>
+          <a:fillRef idx="3">
+            <a:schemeClr val="accent1"/>
+          </a:fillRef>
+          <a:effectRef idx="2">
+            <a:schemeClr val="accent1"/>
+          </a:effectRef>
+          <a:fontRef idx="minor">
+            <a:schemeClr val="lt1"/>
+          </a:fontRef>
+        </p:style>
+        <p:txBody>
+          <a:bodyPr rtlCol="0" anchor="ctr"/>
+          <a:lstStyle/>
+          <a:p>
+            <a:pPr algn="ctr"/>
+          </a:p>
+        </p:txBody>
+      </p:sp>
+      <p:sp>
+        <p:nvSpPr>
+          <p:cNvPr id="3" name="TextBox 2"/>
+          <p:cNvSpPr txBox="1"/>
+          <p:nvPr/>
+        </p:nvSpPr>
+        <p:spPr>
+          <a:xfrm>
+            <a:off x="457200" y="228600"/>
+            <a:ext cx="10972800" cy="274320"/>
+          </a:xfrm>
+          <a:prstGeom prst="rect">
+            <a:avLst/>
+          </a:prstGeom>
+          <a:noFill/>
+        </p:spPr>
+        <p:txBody>
+          <a:bodyPr wrap="none">
+            <a:spAutoFit/>
+          </a:bodyPr>
+          <a:lstStyle/>
+          <a:p>
+            <a:r>
+              <a:rPr sz="1100" b="1">
+                <a:solidFill>
+                  <a:srgbClr val="3D5A80"/>
+                </a:solidFill>
+                <a:latin typeface="Arial"/>
+              </a:rPr>
+              <a:t>DELIVERABLES · CAL PACKAGE</a:t>
+            </a:r>
+          </a:p>
+        </p:txBody>
+      </p:sp>
+      <p:sp>
+        <p:nvSpPr>
+          <p:cNvPr id="4" name="TextBox 3"/>
+          <p:cNvSpPr txBox="1"/>
+          <p:nvPr/>
+        </p:nvSpPr>
+        <p:spPr>
+          <a:xfrm>
+            <a:off x="457200" y="457200"/>
+            <a:ext cx="10972800" cy="548640"/>
+          </a:xfrm>
+          <a:prstGeom prst="rect">
+            <a:avLst/>
+          </a:prstGeom>
+          <a:noFill/>
+        </p:spPr>
+        <p:txBody>
+          <a:bodyPr wrap="none">
+            <a:spAutoFit/>
+          </a:bodyPr>
+          <a:lstStyle/>
+          <a:p>
+            <a:r>
+              <a:rPr sz="2800" b="1">
+                <a:solidFill>
+                  <a:srgbClr val="1C1C1C"/>
+                </a:solidFill>
+                <a:latin typeface="Georgia"/>
+              </a:rPr>
+              <a:t>What ships</a:t>
+            </a:r>
+          </a:p>
+        </p:txBody>
+      </p:sp>
+      <p:sp>
+        <p:nvSpPr>
+          <p:cNvPr id="5" name="TextBox 4"/>
+          <p:cNvSpPr txBox="1"/>
+          <p:nvPr/>
+        </p:nvSpPr>
+        <p:spPr>
+          <a:xfrm>
+            <a:off x="457200" y="960120"/>
+            <a:ext cx="10972800" cy="365760"/>
+          </a:xfrm>
+          <a:prstGeom prst="rect">
+            <a:avLst/>
+          </a:prstGeom>
+          <a:noFill/>
+        </p:spPr>
+        <p:txBody>
+          <a:bodyPr wrap="none">
+            <a:spAutoFit/>
+          </a:bodyPr>
+          <a:lstStyle/>
+          <a:p>
+            <a:r>
+              <a:rPr sz="1400" b="0">
+                <a:solidFill>
+                  <a:srgbClr val="555555"/>
+                </a:solidFill>
+                <a:latin typeface="Arial"/>
+              </a:rPr>
+              <a:t>GitHub: colbymorris08/bundesliga-transfer-traits</a:t>
+            </a:r>
+          </a:p>
+        </p:txBody>
+      </p:sp>
+      <p:sp>
+        <p:nvSpPr>
+          <p:cNvPr id="6" name="Rounded Rectangle 5"/>
+          <p:cNvSpPr/>
+          <p:nvPr/>
+        </p:nvSpPr>
+        <p:spPr>
+          <a:xfrm>
+            <a:off x="457200" y="1554480"/>
+            <a:ext cx="5486400" cy="3657600"/>
+          </a:xfrm>
+          <a:prstGeom prst="roundRect">
+            <a:avLst/>
+          </a:prstGeom>
+          <a:solidFill>
+            <a:srgbClr val="F4F5F7"/>
+          </a:solidFill>
+          <a:ln>
+            <a:solidFill>
+              <a:srgbClr val="D0D4DB"/>
+            </a:solidFill>
+          </a:ln>
+        </p:spPr>
+        <p:style>
+          <a:lnRef idx="1">
+            <a:schemeClr val="accent1"/>
+          </a:lnRef>
+          <a:fillRef idx="3">
+            <a:schemeClr val="accent1"/>
+          </a:fillRef>
+          <a:effectRef idx="2">
+            <a:schemeClr val="accent1"/>
+          </a:effectRef>
+          <a:fontRef idx="minor">
+            <a:schemeClr val="lt1"/>
+          </a:fontRef>
+        </p:style>
+        <p:txBody>
+          <a:bodyPr rtlCol="0" anchor="ctr"/>
+          <a:lstStyle/>
+          <a:p>
+            <a:pPr algn="ctr"/>
+          </a:p>
+        </p:txBody>
+      </p:sp>
+      <p:sp>
+        <p:nvSpPr>
+          <p:cNvPr id="7" name="TextBox 6"/>
+          <p:cNvSpPr txBox="1"/>
+          <p:nvPr/>
+        </p:nvSpPr>
+        <p:spPr>
+          <a:xfrm>
+            <a:off x="594360" y="1691639"/>
+            <a:ext cx="5212080" cy="3383280"/>
+          </a:xfrm>
+          <a:prstGeom prst="rect">
+            <a:avLst/>
+          </a:prstGeom>
+          <a:noFill/>
+        </p:spPr>
+        <p:txBody>
+          <a:bodyPr wrap="square">
+            <a:spAutoFit/>
+          </a:bodyPr>
+          <a:lstStyle/>
+          <a:p>
+            <a:r>
+              <a:rPr sz="1400" b="1">
+                <a:solidFill>
+                  <a:srgbClr val="3D5A80"/>
+                </a:solidFill>
+                <a:latin typeface="Arial"/>
+              </a:rPr>
+              <a:t>For Conrad / review</a:t>
+            </a:r>
+          </a:p>
+          <a:p>
+            <a:r>
+              <a:rPr sz="1200" b="0">
+                <a:solidFill>
+                  <a:srgbClr val="1C1C1C"/>
+                </a:solidFill>
+                <a:latin typeface="Arial"/>
+              </a:rPr>
+              <a:t>projectproposal.docx — proposal
+methodology_results_brief.html — short method deck
+bundesliga_transfer_traits.pptx — this template
+mock_pizza_bundesliga.png — pizza mock</a:t>
+            </a:r>
+          </a:p>
+        </p:txBody>
+      </p:sp>
+      <p:sp>
+        <p:nvSpPr>
+          <p:cNvPr id="8" name="Rounded Rectangle 7"/>
+          <p:cNvSpPr/>
+          <p:nvPr/>
+        </p:nvSpPr>
+        <p:spPr>
+          <a:xfrm>
+            <a:off x="6217920" y="1554480"/>
+            <a:ext cx="5486400" cy="3657600"/>
+          </a:xfrm>
+          <a:prstGeom prst="roundRect">
+            <a:avLst/>
+          </a:prstGeom>
+          <a:solidFill>
+            <a:srgbClr val="F4F5F7"/>
+          </a:solidFill>
+          <a:ln>
+            <a:solidFill>
+              <a:srgbClr val="D0D4DB"/>
+            </a:solidFill>
+          </a:ln>
+        </p:spPr>
+        <p:style>
+          <a:lnRef idx="1">
+            <a:schemeClr val="accent1"/>
+          </a:lnRef>
+          <a:fillRef idx="3">
+            <a:schemeClr val="accent1"/>
+          </a:fillRef>
+          <a:effectRef idx="2">
+            <a:schemeClr val="accent1"/>
+          </a:effectRef>
+          <a:fontRef idx="minor">
+            <a:schemeClr val="lt1"/>
+          </a:fontRef>
+        </p:style>
+        <p:txBody>
+          <a:bodyPr rtlCol="0" anchor="ctr"/>
+          <a:lstStyle/>
+          <a:p>
+            <a:pPr algn="ctr"/>
+          </a:p>
+        </p:txBody>
+      </p:sp>
+      <p:sp>
+        <p:nvSpPr>
+          <p:cNvPr id="9" name="TextBox 8"/>
+          <p:cNvSpPr txBox="1"/>
+          <p:nvPr/>
+        </p:nvSpPr>
+        <p:spPr>
+          <a:xfrm>
+            <a:off x="6355080" y="1691639"/>
+            <a:ext cx="5212080" cy="3383280"/>
+          </a:xfrm>
+          <a:prstGeom prst="rect">
+            <a:avLst/>
+          </a:prstGeom>
+          <a:noFill/>
+        </p:spPr>
+        <p:txBody>
+          <a:bodyPr wrap="square">
+            <a:spAutoFit/>
+          </a:bodyPr>
+          <a:lstStyle/>
+          <a:p>
+            <a:r>
+              <a:rPr sz="1400" b="1">
+                <a:solidFill>
+                  <a:srgbClr val="3D5A80"/>
+                </a:solidFill>
+                <a:latin typeface="Arial"/>
+              </a:rPr>
+              <a:t>Interactive / data</a:t>
+            </a:r>
+          </a:p>
+          <a:p>
+            <a:r>
+              <a:rPr sz="1200" b="0">
+                <a:solidFill>
+                  <a:srgbClr val="1C1C1C"/>
+                </a:solidFill>
+                <a:latin typeface="Arial"/>
+              </a:rPr>
+              <a:t>interactive_player_explorer.html — dropdown by position + pizza
+cohort_data.json — open-data stress-test cohort
+projectproposal.txt — editable source for the Word doc</a:t>
+            </a:r>
+          </a:p>
+        </p:txBody>
+      </p:sp>
+    </p:spTree>
+  </p:cSld>
+  <p:clrMapOvr>
+    <a:masterClrMapping/>
+  </p:clrMapOvr>
+</p:sld>
+</file>
+
+<file path=ppt/slides/slide8.xml><?xml version="1.0" encoding="utf-8"?>
+<p:sld xmlns:a="http://schemas.openxmlformats.org/drawingml/2006/main" xmlns:p="http://schemas.openxmlformats.org/presentationml/2006/main" xmlns:r="http://schemas.openxmlformats.org/officeDocument/2006/relationships">
+  <p:cSld>
+    <p:spTree>
+      <p:nvGrpSpPr>
+        <p:cNvPr id="1" name=""/>
+        <p:cNvGrpSpPr/>
+        <p:nvPr/>
+      </p:nvGrpSpPr>
+      <p:grpSpPr/>
+      <p:sp>
+        <p:nvSpPr>
+          <p:cNvPr id="2" name="Rectangle 1"/>
+          <p:cNvSpPr/>
+          <p:nvPr/>
+        </p:nvSpPr>
+        <p:spPr>
+          <a:xfrm>
+            <a:off x="0" y="0"/>
+            <a:ext cx="12191695" cy="6858000"/>
+          </a:xfrm>
+          <a:prstGeom prst="rect">
+            <a:avLst/>
+          </a:prstGeom>
+          <a:solidFill>
+            <a:srgbClr val="F4F5F7"/>
+          </a:solidFill>
+          <a:ln>
+            <a:noFill/>
+          </a:ln>
+        </p:spPr>
+        <p:style>
+          <a:lnRef idx="1">
+            <a:schemeClr val="accent1"/>
+          </a:lnRef>
+          <a:fillRef idx="3">
+            <a:schemeClr val="accent1"/>
+          </a:fillRef>
+          <a:effectRef idx="2">
+            <a:schemeClr val="accent1"/>
+          </a:effectRef>
+          <a:fontRef idx="minor">
+            <a:schemeClr val="lt1"/>
+          </a:fontRef>
+        </p:style>
+        <p:txBody>
+          <a:bodyPr rtlCol="0" anchor="ctr"/>
+          <a:lstStyle/>
+          <a:p>
+            <a:pPr algn="ctr"/>
+          </a:p>
+        </p:txBody>
+      </p:sp>
+      <p:sp>
+        <p:nvSpPr>
+          <p:cNvPr id="3" name="Rectangle 2"/>
+          <p:cNvSpPr/>
+          <p:nvPr/>
+        </p:nvSpPr>
+        <p:spPr>
+          <a:xfrm>
+            <a:off x="0" y="0"/>
+            <a:ext cx="137160" cy="6858000"/>
+          </a:xfrm>
+          <a:prstGeom prst="rect">
+            <a:avLst/>
+          </a:prstGeom>
+          <a:solidFill>
+            <a:srgbClr val="3D5A80"/>
+          </a:solidFill>
+          <a:ln>
+            <a:noFill/>
+          </a:ln>
+        </p:spPr>
+        <p:style>
+          <a:lnRef idx="1">
+            <a:schemeClr val="accent1"/>
+          </a:lnRef>
+          <a:fillRef idx="3">
+            <a:schemeClr val="accent1"/>
+          </a:fillRef>
+          <a:effectRef idx="2">
+            <a:schemeClr val="accent1"/>
+          </a:effectRef>
+          <a:fontRef idx="minor">
+            <a:schemeClr val="lt1"/>
+          </a:fontRef>
+        </p:style>
+        <p:txBody>
+          <a:bodyPr rtlCol="0" anchor="ctr"/>
+          <a:lstStyle/>
+          <a:p>
+            <a:pPr algn="ctr"/>
+          </a:p>
+        </p:txBody>
+      </p:sp>
+      <p:sp>
+        <p:nvSpPr>
+          <p:cNvPr id="4" name="TextBox 3"/>
+          <p:cNvSpPr txBox="1"/>
+          <p:nvPr/>
+        </p:nvSpPr>
+        <p:spPr>
+          <a:xfrm>
+            <a:off x="502920" y="292608"/>
+            <a:ext cx="11155680" cy="457200"/>
+          </a:xfrm>
+          <a:prstGeom prst="rect">
+            <a:avLst/>
+          </a:prstGeom>
+          <a:noFill/>
+        </p:spPr>
+        <p:txBody>
+          <a:bodyPr wrap="square">
+            <a:spAutoFit/>
+          </a:bodyPr>
+          <a:lstStyle/>
+          <a:p>
+            <a:r>
+              <a:rPr sz="2400" b="1">
+                <a:solidFill>
+                  <a:srgbClr val="1C1C1C"/>
+                </a:solidFill>
+                <a:latin typeface="Georgia"/>
+              </a:rPr>
+              <a:t>Step 2 — redundancy picks (keep the more stable metric)</a:t>
+            </a:r>
+          </a:p>
+        </p:txBody>
+      </p:sp>
+      <p:sp>
+        <p:nvSpPr>
+          <p:cNvPr id="5" name="TextBox 4"/>
+          <p:cNvSpPr txBox="1"/>
+          <p:nvPr/>
+        </p:nvSpPr>
+        <p:spPr>
+          <a:xfrm>
+            <a:off x="502920" y="804672"/>
+            <a:ext cx="11155680" cy="411480"/>
+          </a:xfrm>
+          <a:prstGeom prst="rect">
+            <a:avLst/>
+          </a:prstGeom>
+          <a:noFill/>
+        </p:spPr>
+        <p:txBody>
+          <a:bodyPr wrap="square">
+            <a:spAutoFit/>
+          </a:bodyPr>
+          <a:lstStyle/>
+          <a:p>
+            <a:r>
+              <a:rPr sz="1300" b="0">
+                <a:solidFill>
+                  <a:srgbClr val="555555"/>
+                </a:solidFill>
+                <a:latin typeface="Arial"/>
+              </a:rPr>
+              <a:t>Among stability passers (r ≥ 0.41), resolve |r| ≥ 0.70 clusters by keeping the trait with higher prior→Bundesliga Y1 stability.</a:t>
+            </a:r>
+          </a:p>
+        </p:txBody>
+      </p:sp>
+      <p:graphicFrame>
+        <p:nvGraphicFramePr>
+          <p:cNvPr id="6" name="Table 5"/>
+          <p:cNvGraphicFramePr>
+            <a:graphicFrameLocks noGrp="1"/>
+          </p:cNvGraphicFramePr>
+          <p:nvPr/>
+        </p:nvGraphicFramePr>
+        <p:xfrm>
+          <a:off x="502920" y="1325880"/>
+          <a:ext cx="11155680" cy="1828800"/>
+        </p:xfrm>
+        <a:graphic>
+          <a:graphicData uri="http://schemas.openxmlformats.org/drawingml/2006/table">
+            <a:tbl>
+              <a:tblPr firstRow="1" bandRow="1">
+                <a:tableStyleId>{5C22544A-7EE6-4342-B048-85BDC9FD1C3A}</a:tableStyleId>
+              </a:tblPr>
+              <a:tblGrid>
+                <a:gridCol w="1645920"/>
+                <a:gridCol w="731520"/>
+                <a:gridCol w="3291840"/>
+                <a:gridCol w="1371600"/>
+                <a:gridCol w="4114800"/>
+              </a:tblGrid>
+              <a:tr h="457200">
+                <a:tc>
+                  <a:txBody>
+                    <a:bodyPr/>
+                    <a:lstStyle/>
+                    <a:p>
+                      <a:r>
+                        <a:rPr sz="1100" b="1">
+                          <a:solidFill>
+                            <a:srgbClr val="FFFFFF"/>
+                          </a:solidFill>
+                          <a:latin typeface="Arial"/>
+                        </a:rPr>
+                        <a:t>Cluster</a:t>
+                      </a:r>
+                    </a:p>
+                  </a:txBody>
+                  <a:tcPr>
+                    <a:solidFill>
+                      <a:srgbClr val="1C1C1C"/>
+                    </a:solidFill>
+                  </a:tcPr>
+                </a:tc>
+                <a:tc>
+                  <a:txBody>
+                    <a:bodyPr/>
+                    <a:lstStyle/>
+                    <a:p>
+                      <a:r>
+                        <a:rPr sz="1100" b="1">
+                          <a:solidFill>
+                            <a:srgbClr val="FFFFFF"/>
+                          </a:solidFill>
+                          <a:latin typeface="Arial"/>
+                        </a:rPr>
+                        <a:t>|r|</a:t>
+                      </a:r>
+                    </a:p>
+                  </a:txBody>
+                  <a:tcPr>
+                    <a:solidFill>
+                      <a:srgbClr val="1C1C1C"/>
+                    </a:solidFill>
+                  </a:tcPr>
+                </a:tc>
+                <a:tc>
+                  <a:txBody>
+                    <a:bodyPr/>
+                    <a:lstStyle/>
+                    <a:p>
+                      <a:r>
+                        <a:rPr sz="1100" b="1">
+                          <a:solidFill>
+                            <a:srgbClr val="FFFFFF"/>
+                          </a:solidFill>
+                          <a:latin typeface="Arial"/>
+                        </a:rPr>
+                        <a:t>Kept (more stable)</a:t>
+                      </a:r>
+                    </a:p>
+                  </a:txBody>
+                  <a:tcPr>
+                    <a:solidFill>
+                      <a:srgbClr val="1C1C1C"/>
+                    </a:solidFill>
+                  </a:tcPr>
+                </a:tc>
+                <a:tc>
+                  <a:txBody>
+                    <a:bodyPr/>
+                    <a:lstStyle/>
+                    <a:p>
+                      <a:r>
+                        <a:rPr sz="1100" b="1">
+                          <a:solidFill>
+                            <a:srgbClr val="FFFFFF"/>
+                          </a:solidFill>
+                          <a:latin typeface="Arial"/>
+                        </a:rPr>
+                        <a:t>Stability r</a:t>
+                      </a:r>
+                    </a:p>
+                  </a:txBody>
+                  <a:tcPr>
+                    <a:solidFill>
+                      <a:srgbClr val="1C1C1C"/>
+                    </a:solidFill>
+                  </a:tcPr>
+                </a:tc>
+                <a:tc>
+                  <a:txBody>
+                    <a:bodyPr/>
+                    <a:lstStyle/>
+                    <a:p>
+                      <a:r>
+                        <a:rPr sz="1100" b="1">
+                          <a:solidFill>
+                            <a:srgbClr val="FFFFFF"/>
+                          </a:solidFill>
+                          <a:latin typeface="Arial"/>
+                        </a:rPr>
+                        <a:t>Dropped</a:t>
+                      </a:r>
+                    </a:p>
+                  </a:txBody>
+                  <a:tcPr>
+                    <a:solidFill>
+                      <a:srgbClr val="1C1C1C"/>
+                    </a:solidFill>
+                  </a:tcPr>
+                </a:tc>
+              </a:tr>
+              <a:tr h="457200">
+                <a:tc>
+                  <a:txBody>
+                    <a:bodyPr/>
+                    <a:lstStyle/>
+                    <a:p>
+                      <a:r>
+                        <a:rPr sz="1100" b="1">
+                          <a:solidFill>
+                            <a:srgbClr val="1C1C1C"/>
+                          </a:solidFill>
+                          <a:latin typeface="Arial"/>
+                        </a:rPr>
+                        <a:t>PAS ↔ CRY</a:t>
+                      </a:r>
+                    </a:p>
+                  </a:txBody>
+                  <a:tcPr>
+                    <a:solidFill>
+                      <a:srgbClr val="F0FAF4"/>
+                    </a:solidFill>
+                  </a:tcPr>
+                </a:tc>
+                <a:tc>
+                  <a:txBody>
+                    <a:bodyPr/>
+                    <a:lstStyle/>
+                    <a:p>
+                      <a:r>
+                        <a:rPr sz="1100" b="0">
+                          <a:solidFill>
+                            <a:srgbClr val="1C1C1C"/>
+                          </a:solidFill>
+                          <a:latin typeface="Arial"/>
+                        </a:rPr>
+                        <a:t>0.93</a:t>
+                      </a:r>
+                    </a:p>
+                  </a:txBody>
+                  <a:tcPr>
+                    <a:solidFill>
+                      <a:srgbClr val="F0FAF4"/>
+                    </a:solidFill>
+                  </a:tcPr>
+                </a:tc>
+                <a:tc>
+                  <a:txBody>
+                    <a:bodyPr/>
+                    <a:lstStyle/>
+                    <a:p>
+                      <a:r>
+                        <a:rPr sz="1100" b="1">
+                          <a:solidFill>
+                            <a:srgbClr val="1C1C1C"/>
+                          </a:solidFill>
+                          <a:latin typeface="Arial"/>
+                        </a:rPr>
+                        <a:t>PAS — Pass volume</a:t>
+                      </a:r>
+                    </a:p>
+                  </a:txBody>
+                  <a:tcPr>
+                    <a:solidFill>
+                      <a:srgbClr val="F0FAF4"/>
+                    </a:solidFill>
+                  </a:tcPr>
+                </a:tc>
+                <a:tc>
+                  <a:txBody>
+                    <a:bodyPr/>
+                    <a:lstStyle/>
+                    <a:p>
+                      <a:r>
+                        <a:rPr sz="1100" b="1">
+                          <a:solidFill>
+                            <a:srgbClr val="1C1C1C"/>
+                          </a:solidFill>
+                          <a:latin typeface="Arial"/>
+                        </a:rPr>
+                        <a:t>0.532</a:t>
+                      </a:r>
+                    </a:p>
+                  </a:txBody>
+                  <a:tcPr>
+                    <a:solidFill>
+                      <a:srgbClr val="F0FAF4"/>
+                    </a:solidFill>
+                  </a:tcPr>
+                </a:tc>
+                <a:tc>
+                  <a:txBody>
+                    <a:bodyPr/>
+                    <a:lstStyle/>
+                    <a:p>
+                      <a:r>
+                        <a:rPr sz="1100" b="0">
+                          <a:solidFill>
+                            <a:srgbClr val="1C1C1C"/>
+                          </a:solidFill>
+                          <a:latin typeface="Arial"/>
+                        </a:rPr>
+                        <a:t>CRY — Carries (r=0.413)</a:t>
+                      </a:r>
+                    </a:p>
+                  </a:txBody>
+                  <a:tcPr>
+                    <a:solidFill>
+                      <a:srgbClr val="F0FAF4"/>
+                    </a:solidFill>
+                  </a:tcPr>
+                </a:tc>
+              </a:tr>
+              <a:tr h="457200">
+                <a:tc>
+                  <a:txBody>
+                    <a:bodyPr/>
+                    <a:lstStyle/>
+                    <a:p>
+                      <a:r>
+                        <a:rPr sz="1100" b="1">
+                          <a:solidFill>
+                            <a:srgbClr val="1C1C1C"/>
+                          </a:solidFill>
+                          <a:latin typeface="Arial"/>
+                        </a:rPr>
+                        <a:t>XG ↔ SH</a:t>
+                      </a:r>
+                    </a:p>
+                  </a:txBody>
+                  <a:tcPr>
+                    <a:solidFill>
+                      <a:srgbClr val="F0FAF4"/>
+                    </a:solidFill>
+                  </a:tcPr>
+                </a:tc>
+                <a:tc>
+                  <a:txBody>
+                    <a:bodyPr/>
+                    <a:lstStyle/>
+                    <a:p>
+                      <a:r>
+                        <a:rPr sz="1100" b="0">
+                          <a:solidFill>
+                            <a:srgbClr val="1C1C1C"/>
+                          </a:solidFill>
+                          <a:latin typeface="Arial"/>
+                        </a:rPr>
+                        <a:t>0.86</a:t>
+                      </a:r>
+                    </a:p>
+                  </a:txBody>
+                  <a:tcPr>
+                    <a:solidFill>
+                      <a:srgbClr val="F0FAF4"/>
+                    </a:solidFill>
+                  </a:tcPr>
+                </a:tc>
+                <a:tc>
+                  <a:txBody>
+                    <a:bodyPr/>
+                    <a:lstStyle/>
+                    <a:p>
+                      <a:r>
+                        <a:rPr sz="1100" b="1">
+                          <a:solidFill>
+                            <a:srgbClr val="1C1C1C"/>
+                          </a:solidFill>
+                          <a:latin typeface="Arial"/>
+                        </a:rPr>
+                        <a:t>XG — Non-pen xG</a:t>
+                      </a:r>
+                    </a:p>
+                  </a:txBody>
+                  <a:tcPr>
+                    <a:solidFill>
+                      <a:srgbClr val="F0FAF4"/>
+                    </a:solidFill>
+                  </a:tcPr>
+                </a:tc>
+                <a:tc>
+                  <a:txBody>
+                    <a:bodyPr/>
+                    <a:lstStyle/>
+                    <a:p>
+                      <a:r>
+                        <a:rPr sz="1100" b="1">
+                          <a:solidFill>
+                            <a:srgbClr val="1C1C1C"/>
+                          </a:solidFill>
+                          <a:latin typeface="Arial"/>
+                        </a:rPr>
+                        <a:t>0.483</a:t>
+                      </a:r>
+                    </a:p>
+                  </a:txBody>
+                  <a:tcPr>
+                    <a:solidFill>
+                      <a:srgbClr val="F0FAF4"/>
+                    </a:solidFill>
+                  </a:tcPr>
+                </a:tc>
+                <a:tc>
+                  <a:txBody>
+                    <a:bodyPr/>
+                    <a:lstStyle/>
+                    <a:p>
+                      <a:r>
+                        <a:rPr sz="1100" b="0">
+                          <a:solidFill>
+                            <a:srgbClr val="1C1C1C"/>
+                          </a:solidFill>
+                          <a:latin typeface="Arial"/>
+                        </a:rPr>
+                        <a:t>SH — Shots (r=0.447)</a:t>
+                      </a:r>
+                    </a:p>
+                  </a:txBody>
+                  <a:tcPr>
+                    <a:solidFill>
+                      <a:srgbClr val="F0FAF4"/>
+                    </a:solidFill>
+                  </a:tcPr>
+                </a:tc>
+              </a:tr>
+              <a:tr h="457200">
+                <a:tc>
+                  <a:txBody>
+                    <a:bodyPr/>
+                    <a:lstStyle/>
+                    <a:p>
+                      <a:r>
+                        <a:rPr sz="1100" b="1">
+                          <a:solidFill>
+                            <a:srgbClr val="1C1C1C"/>
+                          </a:solidFill>
+                          <a:latin typeface="Arial"/>
+                        </a:rPr>
+                        <a:t>PPC ↔ PAS</a:t>
+                      </a:r>
+                    </a:p>
+                  </a:txBody>
+                  <a:tcPr>
+                    <a:solidFill>
+                      <a:srgbClr val="F0FAF4"/>
+                    </a:solidFill>
+                  </a:tcPr>
+                </a:tc>
+                <a:tc>
+                  <a:txBody>
+                    <a:bodyPr/>
+                    <a:lstStyle/>
+                    <a:p>
+                      <a:r>
+                        <a:rPr sz="1100" b="0">
+                          <a:solidFill>
+                            <a:srgbClr val="1C1C1C"/>
+                          </a:solidFill>
+                          <a:latin typeface="Arial"/>
+                        </a:rPr>
+                        <a:t>0.79</a:t>
+                      </a:r>
+                    </a:p>
+                  </a:txBody>
+                  <a:tcPr>
+                    <a:solidFill>
+                      <a:srgbClr val="F0FAF4"/>
+                    </a:solidFill>
+                  </a:tcPr>
+                </a:tc>
+                <a:tc>
+                  <a:txBody>
+                    <a:bodyPr/>
+                    <a:lstStyle/>
+                    <a:p>
+                      <a:r>
+                        <a:rPr sz="1100" b="1">
+                          <a:solidFill>
+                            <a:srgbClr val="1C1C1C"/>
+                          </a:solidFill>
+                          <a:latin typeface="Arial"/>
+                        </a:rPr>
+                        <a:t>PPC — Progressive passes</a:t>
+                      </a:r>
+                    </a:p>
+                  </a:txBody>
+                  <a:tcPr>
+                    <a:solidFill>
+                      <a:srgbClr val="F0FAF4"/>
+                    </a:solidFill>
+                  </a:tcPr>
+                </a:tc>
+                <a:tc>
+                  <a:txBody>
+                    <a:bodyPr/>
+                    <a:lstStyle/>
+                    <a:p>
+                      <a:r>
+                        <a:rPr sz="1100" b="1">
+                          <a:solidFill>
+                            <a:srgbClr val="1C1C1C"/>
+                          </a:solidFill>
+                          <a:latin typeface="Arial"/>
+                        </a:rPr>
+                        <a:t>0.720</a:t>
+                      </a:r>
+                    </a:p>
+                  </a:txBody>
+                  <a:tcPr>
+                    <a:solidFill>
+                      <a:srgbClr val="F0FAF4"/>
+                    </a:solidFill>
+                  </a:tcPr>
+                </a:tc>
+                <a:tc>
+                  <a:txBody>
+                    <a:bodyPr/>
+                    <a:lstStyle/>
+                    <a:p>
+                      <a:r>
+                        <a:rPr sz="1100" b="0">
+                          <a:solidFill>
+                            <a:srgbClr val="1C1C1C"/>
+                          </a:solidFill>
+                          <a:latin typeface="Arial"/>
+                        </a:rPr>
+                        <a:t>PAS — Pass volume (r=0.532)</a:t>
+                      </a:r>
+                    </a:p>
+                  </a:txBody>
+                  <a:tcPr>
+                    <a:solidFill>
+                      <a:srgbClr val="F0FAF4"/>
+                    </a:solidFill>
+                  </a:tcPr>
+                </a:tc>
+              </a:tr>
+            </a:tbl>
+          </a:graphicData>
+        </a:graphic>
+      </p:graphicFrame>
+      <p:sp>
+        <p:nvSpPr>
+          <p:cNvPr id="7" name="TextBox 6"/>
+          <p:cNvSpPr txBox="1"/>
+          <p:nvPr/>
+        </p:nvSpPr>
+        <p:spPr>
+          <a:xfrm>
+            <a:off x="502920" y="3337560"/>
+            <a:ext cx="11155680" cy="320040"/>
+          </a:xfrm>
+          <a:prstGeom prst="rect">
+            <a:avLst/>
+          </a:prstGeom>
+          <a:noFill/>
+        </p:spPr>
+        <p:txBody>
+          <a:bodyPr wrap="square">
+            <a:spAutoFit/>
+          </a:bodyPr>
+          <a:lstStyle/>
+          <a:p>
+            <a:r>
+              <a:rPr sz="1300" b="1">
+                <a:solidFill>
+                  <a:srgbClr val="1C1C1C"/>
+                </a:solidFill>
+                <a:latin typeface="Arial"/>
+              </a:rPr>
+              <a:t>Rule: when two portable metrics largely measure the same thing, keep the one that travels better.</a:t>
+            </a:r>
+          </a:p>
+        </p:txBody>
+      </p:sp>
+      <p:sp>
+        <p:nvSpPr>
+          <p:cNvPr id="8" name="TextBox 7"/>
+          <p:cNvSpPr txBox="1"/>
+          <p:nvPr/>
+        </p:nvSpPr>
+        <p:spPr>
+          <a:xfrm>
+            <a:off x="502920" y="3749039"/>
+            <a:ext cx="11155680" cy="320040"/>
+          </a:xfrm>
+          <a:prstGeom prst="rect">
+            <a:avLst/>
+          </a:prstGeom>
+          <a:noFill/>
+        </p:spPr>
+        <p:txBody>
+          <a:bodyPr wrap="square">
+            <a:spAutoFit/>
+          </a:bodyPr>
+          <a:lstStyle/>
+          <a:p>
+            <a:r>
+              <a:rPr sz="1300" b="0">
+                <a:solidFill>
+                  <a:srgbClr val="1C1C1C"/>
+                </a:solidFill>
+                <a:latin typeface="Arial"/>
+              </a:rPr>
+              <a:t>StatsBomb final shortlist (9): DIS · PPC · PRS · PAS · TAC · CLR · XG · DRB · PATT</a:t>
+            </a:r>
+          </a:p>
+        </p:txBody>
+      </p:sp>
+      <p:sp>
+        <p:nvSpPr>
+          <p:cNvPr id="9" name="TextBox 8"/>
+          <p:cNvSpPr txBox="1"/>
+          <p:nvPr/>
+        </p:nvSpPr>
+        <p:spPr>
+          <a:xfrm>
+            <a:off x="502920" y="4114800"/>
+            <a:ext cx="11155680" cy="365760"/>
+          </a:xfrm>
+          <a:prstGeom prst="rect">
+            <a:avLst/>
+          </a:prstGeom>
+          <a:noFill/>
+        </p:spPr>
+        <p:txBody>
+          <a:bodyPr wrap="square">
+            <a:spAutoFit/>
+          </a:bodyPr>
+          <a:lstStyle/>
+          <a:p>
+            <a:r>
+              <a:rPr sz="1300" b="0">
+                <a:solidFill>
+                  <a:srgbClr val="555555"/>
+                </a:solidFill>
+                <a:latin typeface="Arial"/>
+              </a:rPr>
+              <a:t>FBref planned picks (same rule via SB analogues): PrgP over Passes · Carries over PrgC · npxG over Shots</a:t>
+            </a:r>
+          </a:p>
+        </p:txBody>
+      </p:sp>
+      <p:sp>
+        <p:nvSpPr>
+          <p:cNvPr id="10" name="TextBox 9"/>
+          <p:cNvSpPr txBox="1"/>
+          <p:nvPr/>
+        </p:nvSpPr>
+        <p:spPr>
+          <a:xfrm>
+            <a:off x="502920" y="4572000"/>
+            <a:ext cx="11155680" cy="320040"/>
+          </a:xfrm>
+          <a:prstGeom prst="rect">
+            <a:avLst/>
+          </a:prstGeom>
+          <a:noFill/>
+        </p:spPr>
+        <p:txBody>
+          <a:bodyPr wrap="square">
+            <a:spAutoFit/>
+          </a:bodyPr>
+          <a:lstStyle/>
+          <a:p>
+            <a:r>
+              <a:rPr sz="1200" b="0">
+                <a:solidFill>
+                  <a:srgbClr val="555555"/>
+                </a:solidFill>
+                <a:latin typeface="Arial"/>
+              </a:rPr>
+              <a:t>FBref shortlist (8): PrgP · Carries · npxG · SCA · Tackles · Interceptions · Aerials won · Att-pen touches</a:t>
+            </a:r>
+          </a:p>
+        </p:txBody>
+      </p:sp>
+      <p:sp>
+        <p:nvSpPr>
+          <p:cNvPr id="11" name="TextBox 10"/>
+          <p:cNvSpPr txBox="1"/>
+          <p:nvPr/>
+        </p:nvSpPr>
+        <p:spPr>
+          <a:xfrm>
+            <a:off x="502920" y="5074920"/>
+            <a:ext cx="11155680" cy="411480"/>
+          </a:xfrm>
+          <a:prstGeom prst="rect">
+            <a:avLst/>
+          </a:prstGeom>
+          <a:noFill/>
+        </p:spPr>
+        <p:txBody>
+          <a:bodyPr wrap="square">
+            <a:spAutoFit/>
+          </a:bodyPr>
+          <a:lstStyle/>
+          <a:p>
+            <a:r>
+              <a:rPr sz="1200" b="0">
+                <a:solidFill>
+                  <a:srgbClr val="555555"/>
+                </a:solidFill>
+                <a:latin typeface="Arial"/>
+              </a:rPr>
+              <a:t>Dropped from StatsBomb scout card: CRY (vs PAS), SH (vs XG); PAS contested vs PPC but retained from the PAS↔CRY keep.</a:t>
+            </a:r>
+          </a:p>
+        </p:txBody>
+      </p:sp>
+      <p:sp>
+        <p:nvSpPr>
+          <p:cNvPr id="12" name="TextBox 11"/>
+          <p:cNvSpPr txBox="1"/>
+          <p:nvPr/>
+        </p:nvSpPr>
+        <p:spPr>
+          <a:xfrm>
+            <a:off x="502920" y="5623560"/>
+            <a:ext cx="11155680" cy="320040"/>
+          </a:xfrm>
+          <a:prstGeom prst="rect">
+            <a:avLst/>
+          </a:prstGeom>
+          <a:noFill/>
+        </p:spPr>
+        <p:txBody>
+          <a:bodyPr wrap="square">
+            <a:spAutoFit/>
+          </a:bodyPr>
+          <a:lstStyle/>
+          <a:p>
+            <a:r>
+              <a:rPr sz="1100" b="0">
+                <a:solidFill>
+                  <a:srgbClr val="555555"/>
+                </a:solidFill>
+                <a:latin typeface="Arial"/>
+              </a:rPr>
+              <a:t>Source: Step 2 Decision Tool PDF · stability gate r ≥ 0.41 · redundancy |r| ≥ 0.70 · cohort N=60</a:t>
+            </a:r>
+          </a:p>
+        </p:txBody>
+      </p:sp>
+    </p:spTree>
+  </p:cSld>
+  <p:clrMapOvr>
+    <a:masterClrMapping/>
+  </p:clrMapOvr>
+</p:sld>
+</file>
+
 <file path=ppt/theme/theme1.xml><?xml version="1.0" encoding="utf-8"?>
 <a:theme xmlns:a="http://schemas.openxmlformats.org/drawingml/2006/main" name="Office Theme">
   <a:themeElements>

</xml_diff>

<commit_message>
Clarify tiers vs data sources; add FBref stability status slide; fix pizza percentile scale.
</commit_message>
<xml_diff>
--- a/bundesliga_transfer_traits.pptx
+++ b/bundesliga_transfer_traits.pptx
@@ -9,6 +9,7 @@
     <p:sldId id="257" r:id="rId8"/>
     <p:sldId id="258" r:id="rId9"/>
     <p:sldId id="262" r:id="rId13"/>
+    <p:sldId id="264" r:id="rId15"/>
     <p:sldId id="259" r:id="rId10"/>
     <p:sldId id="263" r:id="rId14"/>
     <p:sldId id="260" r:id="rId11"/>
@@ -3677,19 +3678,129 @@
           <a:noFill/>
         </p:spPr>
         <p:txBody>
-          <a:bodyPr wrap="none">
+          <a:bodyPr wrap="square">
             <a:spAutoFit/>
           </a:bodyPr>
           <a:lstStyle/>
           <a:p>
             <a:r>
-              <a:rPr sz="2800" b="1">
+              <a:rPr sz="1600" b="1">
                 <a:solidFill>
                   <a:srgbClr val="1C1C1C"/>
                 </a:solidFill>
-                <a:latin typeface="Georgia"/>
+                <a:latin typeface="Arial"/>
               </a:rPr>
-              <a:t>Two-tier design · Bundesliga only</a:t>
+              <a:t>Tiers = sample scope (how big / how deep) — NOT “FBref vs StatsBomb”</a:t>
+            </a:r>
+          </a:p>
+          <a:p>
+            <a:r>
+              <a:rPr sz="1000" b="0">
+                <a:solidFill>
+                  <a:srgbClr val="555555"/>
+                </a:solidFill>
+                <a:latin typeface="Arial"/>
+              </a:rPr>
+              <a:t/>
+            </a:r>
+          </a:p>
+          <a:p>
+            <a:r>
+              <a:rPr sz="1400" b="1">
+                <a:solidFill>
+                  <a:srgbClr val="1C1C1C"/>
+                </a:solidFill>
+                <a:latin typeface="Arial"/>
+              </a:rPr>
+              <a:t>Tier 1 — Wide outcomes (target N ≥ 500)</a:t>
+            </a:r>
+          </a:p>
+          <a:p>
+            <a:r>
+              <a:rPr sz="1200" b="0">
+                <a:solidFill>
+                  <a:srgbClr val="555555"/>
+                </a:solidFill>
+                <a:latin typeface="Arial"/>
+              </a:rPr>
+              <a:t>All inbound / first Bundesliga seasons. Minutes + per-90 outcomes by position and source league.</a:t>
+            </a:r>
+          </a:p>
+          <a:p>
+            <a:r>
+              <a:rPr sz="800" b="0">
+                <a:solidFill>
+                  <a:srgbClr val="555555"/>
+                </a:solidFill>
+                <a:latin typeface="Arial"/>
+              </a:rPr>
+              <a:t/>
+            </a:r>
+          </a:p>
+          <a:p>
+            <a:r>
+              <a:rPr sz="1400" b="1">
+                <a:solidFill>
+                  <a:srgbClr val="1C1C1C"/>
+                </a:solidFill>
+                <a:latin typeface="Arial"/>
+              </a:rPr>
+              <a:t>Tier 2 — Deep portability → pizza</a:t>
+            </a:r>
+          </a:p>
+          <a:p>
+            <a:r>
+              <a:rPr sz="1200" b="0">
+                <a:solidFill>
+                  <a:srgbClr val="555555"/>
+                </a:solidFill>
+                <a:latin typeface="Arial"/>
+              </a:rPr>
+              <a:t>Paired prior→Y1 seasons: stability on all stats → redundancy → scout-card pizzas.</a:t>
+            </a:r>
+          </a:p>
+          <a:p>
+            <a:r>
+              <a:rPr sz="800" b="0">
+                <a:solidFill>
+                  <a:srgbClr val="555555"/>
+                </a:solidFill>
+                <a:latin typeface="Arial"/>
+              </a:rPr>
+              <a:t/>
+            </a:r>
+          </a:p>
+          <a:p>
+            <a:r>
+              <a:rPr sz="1400" b="1">
+                <a:solidFill>
+                  <a:srgbClr val="1C1C1C"/>
+                </a:solidFill>
+                <a:latin typeface="Arial"/>
+              </a:rPr>
+              <a:t>Data sources (separate idea):</a:t>
+            </a:r>
+          </a:p>
+          <a:p>
+            <a:r>
+              <a:rPr sz="1200" b="0">
+                <a:solidFill>
+                  <a:srgbClr val="555555"/>
+                </a:solidFill>
+                <a:latin typeface="Arial"/>
+              </a:rPr>
+              <a:t>• FBref = primary scale layer for Tier 1 + Tier 2 (season per-90). Not frozen yet.</a:t>
+            </a:r>
+          </a:p>
+          <a:p>
+            <a:r>
+              <a:rPr sz="1200" b="0">
+                <a:solidFill>
+                  <a:srgbClr val="555555"/>
+                </a:solidFill>
+                <a:latin typeface="Arial"/>
+              </a:rPr>
+              <a:t>• StatsBomb Open Data = live event-level deep dive on a smaller overlap (N=60 done).</a:t>
             </a:r>
           </a:p>
         </p:txBody>
@@ -3711,19 +3822,129 @@
           <a:noFill/>
         </p:spPr>
         <p:txBody>
-          <a:bodyPr wrap="none">
+          <a:bodyPr wrap="square">
             <a:spAutoFit/>
           </a:bodyPr>
           <a:lstStyle/>
           <a:p>
             <a:r>
-              <a:rPr sz="1400" b="0">
-                <a:solidFill>
-                  <a:srgbClr val="555555"/>
+              <a:rPr sz="1600" b="1">
+                <a:solidFill>
+                  <a:srgbClr val="1C1C1C"/>
                 </a:solidFill>
                 <a:latin typeface="Arial"/>
               </a:rPr>
-              <a:t>Honest N ≥ 500 on FBref · deeper event dive on StatsBomb open data</a:t>
+              <a:t>Tiers = sample scope (how big / how deep) — NOT “FBref vs StatsBomb”</a:t>
+            </a:r>
+          </a:p>
+          <a:p>
+            <a:r>
+              <a:rPr sz="1000" b="0">
+                <a:solidFill>
+                  <a:srgbClr val="555555"/>
+                </a:solidFill>
+                <a:latin typeface="Arial"/>
+              </a:rPr>
+              <a:t/>
+            </a:r>
+          </a:p>
+          <a:p>
+            <a:r>
+              <a:rPr sz="1400" b="1">
+                <a:solidFill>
+                  <a:srgbClr val="1C1C1C"/>
+                </a:solidFill>
+                <a:latin typeface="Arial"/>
+              </a:rPr>
+              <a:t>Tier 1 — Wide outcomes (target N ≥ 500)</a:t>
+            </a:r>
+          </a:p>
+          <a:p>
+            <a:r>
+              <a:rPr sz="1200" b="0">
+                <a:solidFill>
+                  <a:srgbClr val="555555"/>
+                </a:solidFill>
+                <a:latin typeface="Arial"/>
+              </a:rPr>
+              <a:t>All inbound / first Bundesliga seasons. Minutes + per-90 outcomes by position and source league.</a:t>
+            </a:r>
+          </a:p>
+          <a:p>
+            <a:r>
+              <a:rPr sz="800" b="0">
+                <a:solidFill>
+                  <a:srgbClr val="555555"/>
+                </a:solidFill>
+                <a:latin typeface="Arial"/>
+              </a:rPr>
+              <a:t/>
+            </a:r>
+          </a:p>
+          <a:p>
+            <a:r>
+              <a:rPr sz="1400" b="1">
+                <a:solidFill>
+                  <a:srgbClr val="1C1C1C"/>
+                </a:solidFill>
+                <a:latin typeface="Arial"/>
+              </a:rPr>
+              <a:t>Tier 2 — Deep portability → pizza</a:t>
+            </a:r>
+          </a:p>
+          <a:p>
+            <a:r>
+              <a:rPr sz="1200" b="0">
+                <a:solidFill>
+                  <a:srgbClr val="555555"/>
+                </a:solidFill>
+                <a:latin typeface="Arial"/>
+              </a:rPr>
+              <a:t>Paired prior→Y1 seasons: stability on all stats → redundancy → scout-card pizzas.</a:t>
+            </a:r>
+          </a:p>
+          <a:p>
+            <a:r>
+              <a:rPr sz="800" b="0">
+                <a:solidFill>
+                  <a:srgbClr val="555555"/>
+                </a:solidFill>
+                <a:latin typeface="Arial"/>
+              </a:rPr>
+              <a:t/>
+            </a:r>
+          </a:p>
+          <a:p>
+            <a:r>
+              <a:rPr sz="1400" b="1">
+                <a:solidFill>
+                  <a:srgbClr val="1C1C1C"/>
+                </a:solidFill>
+                <a:latin typeface="Arial"/>
+              </a:rPr>
+              <a:t>Data sources (separate idea):</a:t>
+            </a:r>
+          </a:p>
+          <a:p>
+            <a:r>
+              <a:rPr sz="1200" b="0">
+                <a:solidFill>
+                  <a:srgbClr val="555555"/>
+                </a:solidFill>
+                <a:latin typeface="Arial"/>
+              </a:rPr>
+              <a:t>• FBref = primary scale layer for Tier 1 + Tier 2 (season per-90). Not frozen yet.</a:t>
+            </a:r>
+          </a:p>
+          <a:p>
+            <a:r>
+              <a:rPr sz="1200" b="0">
+                <a:solidFill>
+                  <a:srgbClr val="555555"/>
+                </a:solidFill>
+                <a:latin typeface="Arial"/>
+              </a:rPr>
+              <a:t>• StatsBomb Open Data = live event-level deep dive on a smaller overlap (N=60 done).</a:t>
             </a:r>
           </a:p>
         </p:txBody>
@@ -3796,13 +4017,13 @@
           <a:lstStyle/>
           <a:p>
             <a:r>
-              <a:rPr sz="1400" b="1">
-                <a:solidFill>
-                  <a:srgbClr val="3D5A80"/>
+              <a:rPr sz="1300" b="1">
+                <a:solidFill>
+                  <a:srgbClr val="1C1C1C"/>
                 </a:solidFill>
                 <a:latin typeface="Arial"/>
               </a:rPr>
-              <a:t>Tier 1 — Wide (headline N ≥ 500)</a:t>
+              <a:t>Remember: Tier 1 / Tier 2 describe the study design.</a:t>
             </a:r>
           </a:p>
           <a:p>
@@ -3813,7 +4034,18 @@
                 </a:solidFill>
                 <a:latin typeface="Arial"/>
               </a:rPr>
-              <a:t>All inbound / first Bundesliga seasons over a multi-year window. Outcomes: minutes share, attack &amp; defend per-90 by position and source league. Answers who succeeds after arrival.</a:t>
+              <a:t/>
+            </a:r>
+          </a:p>
+          <a:p>
+            <a:r>
+              <a:rPr sz="1300" b="0">
+                <a:solidFill>
+                  <a:srgbClr val="555555"/>
+                </a:solidFill>
+                <a:latin typeface="Arial"/>
+              </a:rPr>
+              <a:t>FBref / StatsBomb describe which dataset feeds that design.</a:t>
             </a:r>
           </a:p>
         </p:txBody>
@@ -6032,19 +6264,30 @@
           <a:noFill/>
         </p:spPr>
         <p:txBody>
-          <a:bodyPr wrap="none">
+          <a:bodyPr wrap="square">
             <a:spAutoFit/>
           </a:bodyPr>
           <a:lstStyle/>
           <a:p>
             <a:r>
-              <a:rPr sz="2800" b="1">
+              <a:rPr sz="1400" b="1">
                 <a:solidFill>
                   <a:srgbClr val="1C1C1C"/>
                 </a:solidFill>
-                <a:latin typeface="Georgia"/>
+                <a:latin typeface="Arial"/>
               </a:rPr>
-              <a:t>Example player profile (mock)</a:t>
+              <a:t>Example: Eric Dier (Central Defender)</a:t>
+            </a:r>
+          </a:p>
+          <a:p>
+            <a:r>
+              <a:rPr sz="1200" b="0">
+                <a:solidFill>
+                  <a:srgbClr val="555555"/>
+                </a:solidFill>
+                <a:latin typeface="Arial"/>
+              </a:rPr>
+              <a:t>StatsBomb shortlist pizza · percentiles vs Bundesliga peers</a:t>
             </a:r>
           </a:p>
         </p:txBody>
@@ -6083,30 +6326,6 @@
           </a:p>
         </p:txBody>
       </p:sp>
-      <p:pic>
-        <p:nvPicPr>
-          <p:cNvPr id="6" name="Picture 5" descr="mock_pizza_bundesliga.png"/>
-          <p:cNvPicPr>
-            <a:picLocks noChangeAspect="1"/>
-          </p:cNvPicPr>
-          <p:nvPr/>
-        </p:nvPicPr>
-        <p:blipFill>
-          <a:blip r:embed="rId2"/>
-          <a:stretch>
-            <a:fillRect/>
-          </a:stretch>
-        </p:blipFill>
-        <p:spPr>
-          <a:xfrm>
-            <a:off x="457200" y="1325880"/>
-            <a:ext cx="7589520" cy="5059680"/>
-          </a:xfrm>
-          <a:prstGeom prst="rect">
-            <a:avLst/>
-          </a:prstGeom>
-        </p:spPr>
-      </p:pic>
       <p:sp>
         <p:nvSpPr>
           <p:cNvPr id="7" name="Rounded Rectangle 6"/>
@@ -6177,11 +6396,11 @@
             <a:r>
               <a:rPr sz="1400" b="1">
                 <a:solidFill>
-                  <a:srgbClr val="3D5A80"/>
+                  <a:srgbClr val="1C1C1C"/>
                 </a:solidFill>
                 <a:latin typeface="Arial"/>
               </a:rPr>
-              <a:t>How to read</a:t>
+              <a:t>How to read (percentiles — not raw rates)</a:t>
             </a:r>
           </a:p>
           <a:p>
@@ -6192,15 +6411,79 @@
                 </a:solidFill>
                 <a:latin typeface="Arial"/>
               </a:rPr>
-              <a:t>Filled wedges = Year-1 Bundesliga percentiles.
-Dashed arc = avg peer at position.
-Solid arc = top peer.
-Only metrics that transferred well (stable) and are non-redundant appear on the pizza.
-Dropdown HTML explorer sorts players by position.</a:t>
-            </a:r>
-          </a:p>
-        </p:txBody>
-      </p:sp>
+              <a:t/>
+            </a:r>
+          </a:p>
+          <a:p>
+            <a:r>
+              <a:rPr sz="1200" b="0">
+                <a:solidFill>
+                  <a:srgbClr val="555555"/>
+                </a:solidFill>
+                <a:latin typeface="Arial"/>
+              </a:rPr>
+              <a:t>Wedge length = Year-1 Bundesliga percentile vs peers at the position.</a:t>
+            </a:r>
+          </a:p>
+          <a:p>
+            <a:r>
+              <a:rPr sz="1200" b="0">
+                <a:solidFill>
+                  <a:srgbClr val="555555"/>
+                </a:solidFill>
+                <a:latin typeface="Arial"/>
+              </a:rPr>
+              <a:t>Center = 0th %ile · Outer rim = 100th %ile (best vs peers).</a:t>
+            </a:r>
+          </a:p>
+          <a:p>
+            <a:r>
+              <a:rPr sz="1200" b="0">
+                <a:solidFill>
+                  <a:srgbClr val="555555"/>
+                </a:solidFill>
+                <a:latin typeface="Arial"/>
+              </a:rPr>
+              <a:t>Dashed arc ≈ average peer (~50th). Solid arc ≈ top peer (~90th).</a:t>
+            </a:r>
+          </a:p>
+          <a:p>
+            <a:r>
+              <a:rPr sz="1200" b="0">
+                <a:solidFill>
+                  <a:srgbClr val="555555"/>
+                </a:solidFill>
+                <a:latin typeface="Arial"/>
+              </a:rPr>
+              <a:t>Only traits that passed stability + redundancy appear on the pizza.</a:t>
+            </a:r>
+          </a:p>
+        </p:txBody>
+      </p:sp>
+      <p:pic>
+        <p:nvPicPr>
+          <p:cNvPr id="9" name="Picture 8" descr="mock_pizza_bundesliga.png"/>
+          <p:cNvPicPr>
+            <a:picLocks noChangeAspect="1"/>
+          </p:cNvPicPr>
+          <p:nvPr/>
+        </p:nvPicPr>
+        <p:blipFill>
+          <a:blip r:embed="rId3"/>
+          <a:stretch>
+            <a:fillRect/>
+          </a:stretch>
+        </p:blipFill>
+        <p:spPr>
+          <a:xfrm>
+            <a:off x="365760" y="1051560"/>
+            <a:ext cx="4754733" cy="5029200"/>
+          </a:xfrm>
+          <a:prstGeom prst="rect">
+            <a:avLst/>
+          </a:prstGeom>
+        </p:spPr>
+      </p:pic>
     </p:spTree>
   </p:cSld>
   <p:clrMapOvr>
@@ -6210,6 +6493,859 @@
 </file>
 
 <file path=ppt/slides/slide6.xml><?xml version="1.0" encoding="utf-8"?>
+<p:sld xmlns:a="http://schemas.openxmlformats.org/drawingml/2006/main" xmlns:p="http://schemas.openxmlformats.org/presentationml/2006/main" xmlns:r="http://schemas.openxmlformats.org/officeDocument/2006/relationships">
+  <p:cSld>
+    <p:spTree>
+      <p:nvGrpSpPr>
+        <p:cNvPr id="1" name=""/>
+        <p:cNvGrpSpPr/>
+        <p:nvPr/>
+      </p:nvGrpSpPr>
+      <p:grpSpPr/>
+      <p:sp>
+        <p:nvSpPr>
+          <p:cNvPr id="2" name="Rectangle 1"/>
+          <p:cNvSpPr/>
+          <p:nvPr/>
+        </p:nvSpPr>
+        <p:spPr>
+          <a:xfrm>
+            <a:off x="0" y="0"/>
+            <a:ext cx="12191695" cy="6858000"/>
+          </a:xfrm>
+          <a:prstGeom prst="rect">
+            <a:avLst/>
+          </a:prstGeom>
+          <a:solidFill>
+            <a:srgbClr val="F4F5F7"/>
+          </a:solidFill>
+          <a:ln>
+            <a:noFill/>
+          </a:ln>
+        </p:spPr>
+        <p:style>
+          <a:lnRef idx="1">
+            <a:schemeClr val="accent1"/>
+          </a:lnRef>
+          <a:fillRef idx="3">
+            <a:schemeClr val="accent1"/>
+          </a:fillRef>
+          <a:effectRef idx="2">
+            <a:schemeClr val="accent1"/>
+          </a:effectRef>
+          <a:fontRef idx="minor">
+            <a:schemeClr val="lt1"/>
+          </a:fontRef>
+        </p:style>
+        <p:txBody>
+          <a:bodyPr rtlCol="0" anchor="ctr"/>
+          <a:lstStyle/>
+          <a:p>
+            <a:pPr algn="ctr"/>
+          </a:p>
+        </p:txBody>
+      </p:sp>
+      <p:sp>
+        <p:nvSpPr>
+          <p:cNvPr id="3" name="Rectangle 2"/>
+          <p:cNvSpPr/>
+          <p:nvPr/>
+        </p:nvSpPr>
+        <p:spPr>
+          <a:xfrm>
+            <a:off x="0" y="0"/>
+            <a:ext cx="137160" cy="6858000"/>
+          </a:xfrm>
+          <a:prstGeom prst="rect">
+            <a:avLst/>
+          </a:prstGeom>
+          <a:solidFill>
+            <a:srgbClr val="3D5A80"/>
+          </a:solidFill>
+          <a:ln>
+            <a:noFill/>
+          </a:ln>
+        </p:spPr>
+        <p:style>
+          <a:lnRef idx="1">
+            <a:schemeClr val="accent1"/>
+          </a:lnRef>
+          <a:fillRef idx="3">
+            <a:schemeClr val="accent1"/>
+          </a:fillRef>
+          <a:effectRef idx="2">
+            <a:schemeClr val="accent1"/>
+          </a:effectRef>
+          <a:fontRef idx="minor">
+            <a:schemeClr val="lt1"/>
+          </a:fontRef>
+        </p:style>
+        <p:txBody>
+          <a:bodyPr rtlCol="0" anchor="ctr"/>
+          <a:lstStyle/>
+          <a:p>
+            <a:pPr algn="ctr"/>
+          </a:p>
+        </p:txBody>
+      </p:sp>
+      <p:sp>
+        <p:nvSpPr>
+          <p:cNvPr id="4" name="TextBox 3"/>
+          <p:cNvSpPr txBox="1"/>
+          <p:nvPr/>
+        </p:nvSpPr>
+        <p:spPr>
+          <a:xfrm>
+            <a:off x="502920" y="292608"/>
+            <a:ext cx="11155680" cy="457200"/>
+          </a:xfrm>
+          <a:prstGeom prst="rect">
+            <a:avLst/>
+          </a:prstGeom>
+          <a:noFill/>
+        </p:spPr>
+        <p:txBody>
+          <a:bodyPr wrap="square">
+            <a:spAutoFit/>
+          </a:bodyPr>
+          <a:lstStyle/>
+          <a:p>
+            <a:r>
+              <a:rPr sz="2400" b="1">
+                <a:solidFill>
+                  <a:srgbClr val="1C1C1C"/>
+                </a:solidFill>
+                <a:latin typeface="Georgia"/>
+              </a:rPr>
+              <a:t>Step 2 — redundancy picks (keep the more stable metric)</a:t>
+            </a:r>
+          </a:p>
+        </p:txBody>
+      </p:sp>
+      <p:sp>
+        <p:nvSpPr>
+          <p:cNvPr id="5" name="TextBox 4"/>
+          <p:cNvSpPr txBox="1"/>
+          <p:nvPr/>
+        </p:nvSpPr>
+        <p:spPr>
+          <a:xfrm>
+            <a:off x="502920" y="804672"/>
+            <a:ext cx="11155680" cy="411480"/>
+          </a:xfrm>
+          <a:prstGeom prst="rect">
+            <a:avLst/>
+          </a:prstGeom>
+          <a:noFill/>
+        </p:spPr>
+        <p:txBody>
+          <a:bodyPr wrap="square">
+            <a:spAutoFit/>
+          </a:bodyPr>
+          <a:lstStyle/>
+          <a:p>
+            <a:r>
+              <a:rPr sz="1300" b="0">
+                <a:solidFill>
+                  <a:srgbClr val="555555"/>
+                </a:solidFill>
+                <a:latin typeface="Arial"/>
+              </a:rPr>
+              <a:t>Among stability passers (r ≥ 0.41), resolve |r| ≥ 0.70 clusters by keeping the trait with higher prior→Bundesliga Y1 stability.</a:t>
+            </a:r>
+          </a:p>
+        </p:txBody>
+      </p:sp>
+      <p:graphicFrame>
+        <p:nvGraphicFramePr>
+          <p:cNvPr id="6" name="Table 5"/>
+          <p:cNvGraphicFramePr>
+            <a:graphicFrameLocks noGrp="1"/>
+          </p:cNvGraphicFramePr>
+          <p:nvPr/>
+        </p:nvGraphicFramePr>
+        <p:xfrm>
+          <a:off x="502920" y="1325880"/>
+          <a:ext cx="11155680" cy="1828800"/>
+        </p:xfrm>
+        <a:graphic>
+          <a:graphicData uri="http://schemas.openxmlformats.org/drawingml/2006/table">
+            <a:tbl>
+              <a:tblPr firstRow="1" bandRow="1">
+                <a:tableStyleId>{5C22544A-7EE6-4342-B048-85BDC9FD1C3A}</a:tableStyleId>
+              </a:tblPr>
+              <a:tblGrid>
+                <a:gridCol w="1645920"/>
+                <a:gridCol w="731520"/>
+                <a:gridCol w="3291840"/>
+                <a:gridCol w="1371600"/>
+                <a:gridCol w="4114800"/>
+              </a:tblGrid>
+              <a:tr h="457200">
+                <a:tc>
+                  <a:txBody>
+                    <a:bodyPr/>
+                    <a:lstStyle/>
+                    <a:p>
+                      <a:r>
+                        <a:rPr sz="1100" b="1">
+                          <a:solidFill>
+                            <a:srgbClr val="FFFFFF"/>
+                          </a:solidFill>
+                          <a:latin typeface="Arial"/>
+                        </a:rPr>
+                        <a:t>Cluster</a:t>
+                      </a:r>
+                    </a:p>
+                  </a:txBody>
+                  <a:tcPr>
+                    <a:solidFill>
+                      <a:srgbClr val="1C1C1C"/>
+                    </a:solidFill>
+                  </a:tcPr>
+                </a:tc>
+                <a:tc>
+                  <a:txBody>
+                    <a:bodyPr/>
+                    <a:lstStyle/>
+                    <a:p>
+                      <a:r>
+                        <a:rPr sz="1100" b="1">
+                          <a:solidFill>
+                            <a:srgbClr val="FFFFFF"/>
+                          </a:solidFill>
+                          <a:latin typeface="Arial"/>
+                        </a:rPr>
+                        <a:t>|r|</a:t>
+                      </a:r>
+                    </a:p>
+                  </a:txBody>
+                  <a:tcPr>
+                    <a:solidFill>
+                      <a:srgbClr val="1C1C1C"/>
+                    </a:solidFill>
+                  </a:tcPr>
+                </a:tc>
+                <a:tc>
+                  <a:txBody>
+                    <a:bodyPr/>
+                    <a:lstStyle/>
+                    <a:p>
+                      <a:r>
+                        <a:rPr sz="1100" b="1">
+                          <a:solidFill>
+                            <a:srgbClr val="FFFFFF"/>
+                          </a:solidFill>
+                          <a:latin typeface="Arial"/>
+                        </a:rPr>
+                        <a:t>Kept (more stable)</a:t>
+                      </a:r>
+                    </a:p>
+                  </a:txBody>
+                  <a:tcPr>
+                    <a:solidFill>
+                      <a:srgbClr val="1C1C1C"/>
+                    </a:solidFill>
+                  </a:tcPr>
+                </a:tc>
+                <a:tc>
+                  <a:txBody>
+                    <a:bodyPr/>
+                    <a:lstStyle/>
+                    <a:p>
+                      <a:r>
+                        <a:rPr sz="1100" b="1">
+                          <a:solidFill>
+                            <a:srgbClr val="FFFFFF"/>
+                          </a:solidFill>
+                          <a:latin typeface="Arial"/>
+                        </a:rPr>
+                        <a:t>Stability r</a:t>
+                      </a:r>
+                    </a:p>
+                  </a:txBody>
+                  <a:tcPr>
+                    <a:solidFill>
+                      <a:srgbClr val="1C1C1C"/>
+                    </a:solidFill>
+                  </a:tcPr>
+                </a:tc>
+                <a:tc>
+                  <a:txBody>
+                    <a:bodyPr/>
+                    <a:lstStyle/>
+                    <a:p>
+                      <a:r>
+                        <a:rPr sz="1100" b="1">
+                          <a:solidFill>
+                            <a:srgbClr val="FFFFFF"/>
+                          </a:solidFill>
+                          <a:latin typeface="Arial"/>
+                        </a:rPr>
+                        <a:t>Dropped</a:t>
+                      </a:r>
+                    </a:p>
+                  </a:txBody>
+                  <a:tcPr>
+                    <a:solidFill>
+                      <a:srgbClr val="1C1C1C"/>
+                    </a:solidFill>
+                  </a:tcPr>
+                </a:tc>
+              </a:tr>
+              <a:tr h="457200">
+                <a:tc>
+                  <a:txBody>
+                    <a:bodyPr/>
+                    <a:lstStyle/>
+                    <a:p>
+                      <a:r>
+                        <a:rPr sz="1100" b="1">
+                          <a:solidFill>
+                            <a:srgbClr val="1C1C1C"/>
+                          </a:solidFill>
+                          <a:latin typeface="Arial"/>
+                        </a:rPr>
+                        <a:t>PAS ↔ CRY</a:t>
+                      </a:r>
+                    </a:p>
+                  </a:txBody>
+                  <a:tcPr>
+                    <a:solidFill>
+                      <a:srgbClr val="F0FAF4"/>
+                    </a:solidFill>
+                  </a:tcPr>
+                </a:tc>
+                <a:tc>
+                  <a:txBody>
+                    <a:bodyPr/>
+                    <a:lstStyle/>
+                    <a:p>
+                      <a:r>
+                        <a:rPr sz="1100" b="0">
+                          <a:solidFill>
+                            <a:srgbClr val="1C1C1C"/>
+                          </a:solidFill>
+                          <a:latin typeface="Arial"/>
+                        </a:rPr>
+                        <a:t>0.93</a:t>
+                      </a:r>
+                    </a:p>
+                  </a:txBody>
+                  <a:tcPr>
+                    <a:solidFill>
+                      <a:srgbClr val="F0FAF4"/>
+                    </a:solidFill>
+                  </a:tcPr>
+                </a:tc>
+                <a:tc>
+                  <a:txBody>
+                    <a:bodyPr/>
+                    <a:lstStyle/>
+                    <a:p>
+                      <a:r>
+                        <a:rPr sz="1100" b="1">
+                          <a:solidFill>
+                            <a:srgbClr val="1C1C1C"/>
+                          </a:solidFill>
+                          <a:latin typeface="Arial"/>
+                        </a:rPr>
+                        <a:t>PAS — Pass volume</a:t>
+                      </a:r>
+                    </a:p>
+                  </a:txBody>
+                  <a:tcPr>
+                    <a:solidFill>
+                      <a:srgbClr val="F0FAF4"/>
+                    </a:solidFill>
+                  </a:tcPr>
+                </a:tc>
+                <a:tc>
+                  <a:txBody>
+                    <a:bodyPr/>
+                    <a:lstStyle/>
+                    <a:p>
+                      <a:r>
+                        <a:rPr sz="1100" b="1">
+                          <a:solidFill>
+                            <a:srgbClr val="1C1C1C"/>
+                          </a:solidFill>
+                          <a:latin typeface="Arial"/>
+                        </a:rPr>
+                        <a:t>0.532</a:t>
+                      </a:r>
+                    </a:p>
+                  </a:txBody>
+                  <a:tcPr>
+                    <a:solidFill>
+                      <a:srgbClr val="F0FAF4"/>
+                    </a:solidFill>
+                  </a:tcPr>
+                </a:tc>
+                <a:tc>
+                  <a:txBody>
+                    <a:bodyPr/>
+                    <a:lstStyle/>
+                    <a:p>
+                      <a:r>
+                        <a:rPr sz="1100" b="0">
+                          <a:solidFill>
+                            <a:srgbClr val="1C1C1C"/>
+                          </a:solidFill>
+                          <a:latin typeface="Arial"/>
+                        </a:rPr>
+                        <a:t>CRY — Carries (r=0.413)</a:t>
+                      </a:r>
+                    </a:p>
+                  </a:txBody>
+                  <a:tcPr>
+                    <a:solidFill>
+                      <a:srgbClr val="F0FAF4"/>
+                    </a:solidFill>
+                  </a:tcPr>
+                </a:tc>
+              </a:tr>
+              <a:tr h="457200">
+                <a:tc>
+                  <a:txBody>
+                    <a:bodyPr/>
+                    <a:lstStyle/>
+                    <a:p>
+                      <a:r>
+                        <a:rPr sz="1100" b="1">
+                          <a:solidFill>
+                            <a:srgbClr val="1C1C1C"/>
+                          </a:solidFill>
+                          <a:latin typeface="Arial"/>
+                        </a:rPr>
+                        <a:t>XG ↔ SH</a:t>
+                      </a:r>
+                    </a:p>
+                  </a:txBody>
+                  <a:tcPr>
+                    <a:solidFill>
+                      <a:srgbClr val="F0FAF4"/>
+                    </a:solidFill>
+                  </a:tcPr>
+                </a:tc>
+                <a:tc>
+                  <a:txBody>
+                    <a:bodyPr/>
+                    <a:lstStyle/>
+                    <a:p>
+                      <a:r>
+                        <a:rPr sz="1100" b="0">
+                          <a:solidFill>
+                            <a:srgbClr val="1C1C1C"/>
+                          </a:solidFill>
+                          <a:latin typeface="Arial"/>
+                        </a:rPr>
+                        <a:t>0.86</a:t>
+                      </a:r>
+                    </a:p>
+                  </a:txBody>
+                  <a:tcPr>
+                    <a:solidFill>
+                      <a:srgbClr val="F0FAF4"/>
+                    </a:solidFill>
+                  </a:tcPr>
+                </a:tc>
+                <a:tc>
+                  <a:txBody>
+                    <a:bodyPr/>
+                    <a:lstStyle/>
+                    <a:p>
+                      <a:r>
+                        <a:rPr sz="1100" b="1">
+                          <a:solidFill>
+                            <a:srgbClr val="1C1C1C"/>
+                          </a:solidFill>
+                          <a:latin typeface="Arial"/>
+                        </a:rPr>
+                        <a:t>XG — Non-pen xG</a:t>
+                      </a:r>
+                    </a:p>
+                  </a:txBody>
+                  <a:tcPr>
+                    <a:solidFill>
+                      <a:srgbClr val="F0FAF4"/>
+                    </a:solidFill>
+                  </a:tcPr>
+                </a:tc>
+                <a:tc>
+                  <a:txBody>
+                    <a:bodyPr/>
+                    <a:lstStyle/>
+                    <a:p>
+                      <a:r>
+                        <a:rPr sz="1100" b="1">
+                          <a:solidFill>
+                            <a:srgbClr val="1C1C1C"/>
+                          </a:solidFill>
+                          <a:latin typeface="Arial"/>
+                        </a:rPr>
+                        <a:t>0.483</a:t>
+                      </a:r>
+                    </a:p>
+                  </a:txBody>
+                  <a:tcPr>
+                    <a:solidFill>
+                      <a:srgbClr val="F0FAF4"/>
+                    </a:solidFill>
+                  </a:tcPr>
+                </a:tc>
+                <a:tc>
+                  <a:txBody>
+                    <a:bodyPr/>
+                    <a:lstStyle/>
+                    <a:p>
+                      <a:r>
+                        <a:rPr sz="1100" b="0">
+                          <a:solidFill>
+                            <a:srgbClr val="1C1C1C"/>
+                          </a:solidFill>
+                          <a:latin typeface="Arial"/>
+                        </a:rPr>
+                        <a:t>SH — Shots (r=0.447)</a:t>
+                      </a:r>
+                    </a:p>
+                  </a:txBody>
+                  <a:tcPr>
+                    <a:solidFill>
+                      <a:srgbClr val="F0FAF4"/>
+                    </a:solidFill>
+                  </a:tcPr>
+                </a:tc>
+              </a:tr>
+              <a:tr h="457200">
+                <a:tc>
+                  <a:txBody>
+                    <a:bodyPr/>
+                    <a:lstStyle/>
+                    <a:p>
+                      <a:r>
+                        <a:rPr sz="1100" b="1">
+                          <a:solidFill>
+                            <a:srgbClr val="1C1C1C"/>
+                          </a:solidFill>
+                          <a:latin typeface="Arial"/>
+                        </a:rPr>
+                        <a:t>PPC ↔ PAS</a:t>
+                      </a:r>
+                    </a:p>
+                  </a:txBody>
+                  <a:tcPr>
+                    <a:solidFill>
+                      <a:srgbClr val="F0FAF4"/>
+                    </a:solidFill>
+                  </a:tcPr>
+                </a:tc>
+                <a:tc>
+                  <a:txBody>
+                    <a:bodyPr/>
+                    <a:lstStyle/>
+                    <a:p>
+                      <a:r>
+                        <a:rPr sz="1100" b="0">
+                          <a:solidFill>
+                            <a:srgbClr val="1C1C1C"/>
+                          </a:solidFill>
+                          <a:latin typeface="Arial"/>
+                        </a:rPr>
+                        <a:t>0.79</a:t>
+                      </a:r>
+                    </a:p>
+                  </a:txBody>
+                  <a:tcPr>
+                    <a:solidFill>
+                      <a:srgbClr val="F0FAF4"/>
+                    </a:solidFill>
+                  </a:tcPr>
+                </a:tc>
+                <a:tc>
+                  <a:txBody>
+                    <a:bodyPr/>
+                    <a:lstStyle/>
+                    <a:p>
+                      <a:r>
+                        <a:rPr sz="1100" b="1">
+                          <a:solidFill>
+                            <a:srgbClr val="1C1C1C"/>
+                          </a:solidFill>
+                          <a:latin typeface="Arial"/>
+                        </a:rPr>
+                        <a:t>PPC — Progressive passes</a:t>
+                      </a:r>
+                    </a:p>
+                  </a:txBody>
+                  <a:tcPr>
+                    <a:solidFill>
+                      <a:srgbClr val="F0FAF4"/>
+                    </a:solidFill>
+                  </a:tcPr>
+                </a:tc>
+                <a:tc>
+                  <a:txBody>
+                    <a:bodyPr/>
+                    <a:lstStyle/>
+                    <a:p>
+                      <a:r>
+                        <a:rPr sz="1100" b="1">
+                          <a:solidFill>
+                            <a:srgbClr val="1C1C1C"/>
+                          </a:solidFill>
+                          <a:latin typeface="Arial"/>
+                        </a:rPr>
+                        <a:t>0.720</a:t>
+                      </a:r>
+                    </a:p>
+                  </a:txBody>
+                  <a:tcPr>
+                    <a:solidFill>
+                      <a:srgbClr val="F0FAF4"/>
+                    </a:solidFill>
+                  </a:tcPr>
+                </a:tc>
+                <a:tc>
+                  <a:txBody>
+                    <a:bodyPr/>
+                    <a:lstStyle/>
+                    <a:p>
+                      <a:r>
+                        <a:rPr sz="1100" b="0">
+                          <a:solidFill>
+                            <a:srgbClr val="1C1C1C"/>
+                          </a:solidFill>
+                          <a:latin typeface="Arial"/>
+                        </a:rPr>
+                        <a:t>PAS — Pass volume (r=0.532)</a:t>
+                      </a:r>
+                    </a:p>
+                  </a:txBody>
+                  <a:tcPr>
+                    <a:solidFill>
+                      <a:srgbClr val="F0FAF4"/>
+                    </a:solidFill>
+                  </a:tcPr>
+                </a:tc>
+              </a:tr>
+            </a:tbl>
+          </a:graphicData>
+        </a:graphic>
+      </p:graphicFrame>
+      <p:sp>
+        <p:nvSpPr>
+          <p:cNvPr id="7" name="TextBox 6"/>
+          <p:cNvSpPr txBox="1"/>
+          <p:nvPr/>
+        </p:nvSpPr>
+        <p:spPr>
+          <a:xfrm>
+            <a:off x="502920" y="3337560"/>
+            <a:ext cx="11155680" cy="320040"/>
+          </a:xfrm>
+          <a:prstGeom prst="rect">
+            <a:avLst/>
+          </a:prstGeom>
+          <a:noFill/>
+        </p:spPr>
+        <p:txBody>
+          <a:bodyPr wrap="square">
+            <a:spAutoFit/>
+          </a:bodyPr>
+          <a:lstStyle/>
+          <a:p>
+            <a:r>
+              <a:rPr sz="1300" b="1">
+                <a:solidFill>
+                  <a:srgbClr val="1C1C1C"/>
+                </a:solidFill>
+                <a:latin typeface="Arial"/>
+              </a:rPr>
+              <a:t>Rule: when two portable metrics largely measure the same thing, keep the one that travels better.</a:t>
+            </a:r>
+          </a:p>
+        </p:txBody>
+      </p:sp>
+      <p:sp>
+        <p:nvSpPr>
+          <p:cNvPr id="8" name="TextBox 7"/>
+          <p:cNvSpPr txBox="1"/>
+          <p:nvPr/>
+        </p:nvSpPr>
+        <p:spPr>
+          <a:xfrm>
+            <a:off x="502920" y="3749039"/>
+            <a:ext cx="11155680" cy="320040"/>
+          </a:xfrm>
+          <a:prstGeom prst="rect">
+            <a:avLst/>
+          </a:prstGeom>
+          <a:noFill/>
+        </p:spPr>
+        <p:txBody>
+          <a:bodyPr wrap="square">
+            <a:spAutoFit/>
+          </a:bodyPr>
+          <a:lstStyle/>
+          <a:p>
+            <a:r>
+              <a:rPr sz="1300" b="0">
+                <a:solidFill>
+                  <a:srgbClr val="1C1C1C"/>
+                </a:solidFill>
+                <a:latin typeface="Arial"/>
+              </a:rPr>
+              <a:t>StatsBomb final shortlist (9): DIS · PPC · PRS · PAS · TAC · CLR · XG · DRB · PATT</a:t>
+            </a:r>
+          </a:p>
+        </p:txBody>
+      </p:sp>
+      <p:sp>
+        <p:nvSpPr>
+          <p:cNvPr id="9" name="TextBox 8"/>
+          <p:cNvSpPr txBox="1"/>
+          <p:nvPr/>
+        </p:nvSpPr>
+        <p:spPr>
+          <a:xfrm>
+            <a:off x="502920" y="4114800"/>
+            <a:ext cx="11155680" cy="365760"/>
+          </a:xfrm>
+          <a:prstGeom prst="rect">
+            <a:avLst/>
+          </a:prstGeom>
+          <a:noFill/>
+        </p:spPr>
+        <p:txBody>
+          <a:bodyPr wrap="square">
+            <a:spAutoFit/>
+          </a:bodyPr>
+          <a:lstStyle/>
+          <a:p>
+            <a:r>
+              <a:rPr sz="1300" b="0">
+                <a:solidFill>
+                  <a:srgbClr val="555555"/>
+                </a:solidFill>
+                <a:latin typeface="Arial"/>
+              </a:rPr>
+              <a:t>FBref planned picks (same rule via SB analogues): PrgP over Passes · Carries over PrgC · npxG over Shots</a:t>
+            </a:r>
+          </a:p>
+        </p:txBody>
+      </p:sp>
+      <p:sp>
+        <p:nvSpPr>
+          <p:cNvPr id="10" name="TextBox 9"/>
+          <p:cNvSpPr txBox="1"/>
+          <p:nvPr/>
+        </p:nvSpPr>
+        <p:spPr>
+          <a:xfrm>
+            <a:off x="502920" y="4572000"/>
+            <a:ext cx="11155680" cy="320040"/>
+          </a:xfrm>
+          <a:prstGeom prst="rect">
+            <a:avLst/>
+          </a:prstGeom>
+          <a:noFill/>
+        </p:spPr>
+        <p:txBody>
+          <a:bodyPr wrap="square">
+            <a:spAutoFit/>
+          </a:bodyPr>
+          <a:lstStyle/>
+          <a:p>
+            <a:r>
+              <a:rPr sz="1200" b="0">
+                <a:solidFill>
+                  <a:srgbClr val="555555"/>
+                </a:solidFill>
+                <a:latin typeface="Arial"/>
+              </a:rPr>
+              <a:t>FBref shortlist (8): PrgP · Carries · npxG · SCA · Tackles · Interceptions · Aerials won · Att-pen touches</a:t>
+            </a:r>
+          </a:p>
+        </p:txBody>
+      </p:sp>
+      <p:sp>
+        <p:nvSpPr>
+          <p:cNvPr id="11" name="TextBox 10"/>
+          <p:cNvSpPr txBox="1"/>
+          <p:nvPr/>
+        </p:nvSpPr>
+        <p:spPr>
+          <a:xfrm>
+            <a:off x="502920" y="5074920"/>
+            <a:ext cx="11155680" cy="411480"/>
+          </a:xfrm>
+          <a:prstGeom prst="rect">
+            <a:avLst/>
+          </a:prstGeom>
+          <a:noFill/>
+        </p:spPr>
+        <p:txBody>
+          <a:bodyPr wrap="square">
+            <a:spAutoFit/>
+          </a:bodyPr>
+          <a:lstStyle/>
+          <a:p>
+            <a:r>
+              <a:rPr sz="1200" b="0">
+                <a:solidFill>
+                  <a:srgbClr val="555555"/>
+                </a:solidFill>
+                <a:latin typeface="Arial"/>
+              </a:rPr>
+              <a:t>Dropped from StatsBomb scout card: CRY (vs PAS), SH (vs XG); PAS contested vs PPC but retained from the PAS↔CRY keep.</a:t>
+            </a:r>
+          </a:p>
+        </p:txBody>
+      </p:sp>
+      <p:sp>
+        <p:nvSpPr>
+          <p:cNvPr id="12" name="TextBox 11"/>
+          <p:cNvSpPr txBox="1"/>
+          <p:nvPr/>
+        </p:nvSpPr>
+        <p:spPr>
+          <a:xfrm>
+            <a:off x="502920" y="5623560"/>
+            <a:ext cx="11155680" cy="320040"/>
+          </a:xfrm>
+          <a:prstGeom prst="rect">
+            <a:avLst/>
+          </a:prstGeom>
+          <a:noFill/>
+        </p:spPr>
+        <p:txBody>
+          <a:bodyPr wrap="square">
+            <a:spAutoFit/>
+          </a:bodyPr>
+          <a:lstStyle/>
+          <a:p>
+            <a:r>
+              <a:rPr sz="1100" b="0">
+                <a:solidFill>
+                  <a:srgbClr val="555555"/>
+                </a:solidFill>
+                <a:latin typeface="Arial"/>
+              </a:rPr>
+              <a:t>Source: Step 2 Decision Tool PDF · stability gate r ≥ 0.41 · redundancy |r| ≥ 0.70 · cohort N=60</a:t>
+            </a:r>
+          </a:p>
+        </p:txBody>
+      </p:sp>
+    </p:spTree>
+  </p:cSld>
+  <p:clrMapOvr>
+    <a:masterClrMapping/>
+  </p:clrMapOvr>
+</p:sld>
+</file>
+
+<file path=ppt/slides/slide7.xml><?xml version="1.0" encoding="utf-8"?>
 <p:sld xmlns:a="http://schemas.openxmlformats.org/drawingml/2006/main" xmlns:p="http://schemas.openxmlformats.org/presentationml/2006/main" xmlns:r="http://schemas.openxmlformats.org/officeDocument/2006/relationships">
   <p:cSld>
     <p:spTree>
@@ -6475,7 +7611,7 @@
 </p:sld>
 </file>
 
-<file path=ppt/slides/slide7.xml><?xml version="1.0" encoding="utf-8"?>
+<file path=ppt/slides/slide8.xml><?xml version="1.0" encoding="utf-8"?>
 <p:sld xmlns:a="http://schemas.openxmlformats.org/drawingml/2006/main" xmlns:p="http://schemas.openxmlformats.org/presentationml/2006/main" xmlns:r="http://schemas.openxmlformats.org/officeDocument/2006/relationships">
   <p:cSld>
     <p:spTree>
@@ -6823,7 +7959,7 @@
 </p:sld>
 </file>
 
-<file path=ppt/slides/slide8.xml><?xml version="1.0" encoding="utf-8"?>
+<file path=ppt/slides/slide9.xml><?xml version="1.0" encoding="utf-8"?>
 <p:sld xmlns:a="http://schemas.openxmlformats.org/drawingml/2006/main" xmlns:p="http://schemas.openxmlformats.org/presentationml/2006/main" xmlns:r="http://schemas.openxmlformats.org/officeDocument/2006/relationships">
   <p:cSld>
     <p:spTree>
@@ -6936,7 +8072,7 @@
           <a:noFill/>
         </p:spPr>
         <p:txBody>
-          <a:bodyPr wrap="square">
+          <a:bodyPr wrap="none">
             <a:spAutoFit/>
           </a:bodyPr>
           <a:lstStyle/>
@@ -6948,7 +8084,7 @@
                 </a:solidFill>
                 <a:latin typeface="Georgia"/>
               </a:rPr>
-              <a:t>Step 2 — redundancy picks (keep the more stable metric)</a:t>
+              <a:t>FBref stability — status &amp; planned gate</a:t>
             </a:r>
           </a:p>
         </p:txBody>
@@ -6961,8 +8097,8 @@
         </p:nvSpPr>
         <p:spPr>
           <a:xfrm>
-            <a:off x="502920" y="804672"/>
-            <a:ext cx="11155680" cy="411480"/>
+            <a:off x="502920" y="822960"/>
+            <a:ext cx="11155680" cy="640080"/>
           </a:xfrm>
           <a:prstGeom prst="rect">
             <a:avLst/>
@@ -6982,7 +8118,18 @@
                 </a:solidFill>
                 <a:latin typeface="Arial"/>
               </a:rPr>
-              <a:t>Among stability passers (r ≥ 0.41), resolve |r| ≥ 0.70 clusters by keeping the trait with higher prior→Bundesliga Y1 stability.</a:t>
+              <a:t>FBref Tier 2 stability is not run yet (need paired prior→BL Y1 seasons at scale, target N≥500).</a:t>
+            </a:r>
+          </a:p>
+          <a:p>
+            <a:r>
+              <a:rPr sz="1300" b="0">
+                <a:solidFill>
+                  <a:srgbClr val="555555"/>
+                </a:solidFill>
+                <a:latin typeface="Arial"/>
+              </a:rPr>
+              <a:t>Same gate planned as StatsBomb deep dive: keep stats with prior→Y1 Pearson r ≥ ~0.40, then redundancy.</a:t>
             </a:r>
           </a:p>
         </p:txBody>
@@ -6996,8 +8143,8 @@
           <p:nvPr/>
         </p:nvGraphicFramePr>
         <p:xfrm>
-          <a:off x="502920" y="1325880"/>
-          <a:ext cx="11155680" cy="1828800"/>
+          <a:off x="502920" y="1600200"/>
+          <a:ext cx="11155680" cy="4169664"/>
         </p:xfrm>
         <a:graphic>
           <a:graphicData uri="http://schemas.openxmlformats.org/drawingml/2006/table">
@@ -7006,13 +8153,13 @@
                 <a:tableStyleId>{5C22544A-7EE6-4342-B048-85BDC9FD1C3A}</a:tableStyleId>
               </a:tblPr>
               <a:tblGrid>
+                <a:gridCol w="1005840"/>
+                <a:gridCol w="3108960"/>
+                <a:gridCol w="1463040"/>
                 <a:gridCol w="1645920"/>
-                <a:gridCol w="731520"/>
-                <a:gridCol w="3291840"/>
-                <a:gridCol w="1371600"/>
-                <a:gridCol w="4114800"/>
+                <a:gridCol w="3931920"/>
               </a:tblGrid>
-              <a:tr h="457200">
+              <a:tr h="347472">
                 <a:tc>
                   <a:txBody>
                     <a:bodyPr/>
@@ -7025,7 +8172,7 @@
                           </a:solidFill>
                           <a:latin typeface="Arial"/>
                         </a:rPr>
-                        <a:t>Cluster</a:t>
+                        <a:t>Abbrev</a:t>
                       </a:r>
                     </a:p>
                   </a:txBody>
@@ -7047,7 +8194,7 @@
                           </a:solidFill>
                           <a:latin typeface="Arial"/>
                         </a:rPr>
-                        <a:t>|r|</a:t>
+                        <a:t>FBref metric (planned)</a:t>
                       </a:r>
                     </a:p>
                   </a:txBody>
@@ -7069,7 +8216,7 @@
                           </a:solidFill>
                           <a:latin typeface="Arial"/>
                         </a:rPr>
-                        <a:t>Kept (more stable)</a:t>
+                        <a:t>Category</a:t>
                       </a:r>
                     </a:p>
                   </a:txBody>
@@ -7091,7 +8238,7 @@
                           </a:solidFill>
                           <a:latin typeface="Arial"/>
                         </a:rPr>
-                        <a:t>Stability r</a:t>
+                        <a:t>Step 2 status</a:t>
                       </a:r>
                     </a:p>
                   </a:txBody>
@@ -7113,7 +8260,7 @@
                           </a:solidFill>
                           <a:latin typeface="Arial"/>
                         </a:rPr>
-                        <a:t>Dropped</a:t>
+                        <a:t>Note</a:t>
                       </a:r>
                     </a:p>
                   </a:txBody>
@@ -7124,7 +8271,7 @@
                   </a:tcPr>
                 </a:tc>
               </a:tr>
-              <a:tr h="457200">
+              <a:tr h="347472">
                 <a:tc>
                   <a:txBody>
                     <a:bodyPr/>
@@ -7137,16 +8284,106 @@
                           </a:solidFill>
                           <a:latin typeface="Arial"/>
                         </a:rPr>
-                        <a:t>PAS ↔ CRY</a:t>
-                      </a:r>
-                    </a:p>
-                  </a:txBody>
-                  <a:tcPr>
-                    <a:solidFill>
-                      <a:srgbClr val="F0FAF4"/>
-                    </a:solidFill>
-                  </a:tcPr>
-                </a:tc>
+                        <a:t>PrgP</a:t>
+                      </a:r>
+                    </a:p>
+                  </a:txBody>
+                  <a:tcPr>
+                    <a:solidFill>
+                      <a:srgbClr val="F0FAF4"/>
+                    </a:solidFill>
+                  </a:tcPr>
+                </a:tc>
+                <a:tc>
+                  <a:txBody>
+                    <a:bodyPr/>
+                    <a:lstStyle/>
+                    <a:p>
+                      <a:r>
+                        <a:rPr sz="1100" b="1">
+                          <a:solidFill>
+                            <a:srgbClr val="1C1C1C"/>
+                          </a:solidFill>
+                          <a:latin typeface="Arial"/>
+                        </a:rPr>
+                        <a:t>Progressive passes</a:t>
+                      </a:r>
+                    </a:p>
+                  </a:txBody>
+                  <a:tcPr>
+                    <a:solidFill>
+                      <a:srgbClr val="F0FAF4"/>
+                    </a:solidFill>
+                  </a:tcPr>
+                </a:tc>
+                <a:tc>
+                  <a:txBody>
+                    <a:bodyPr/>
+                    <a:lstStyle/>
+                    <a:p>
+                      <a:r>
+                        <a:rPr sz="1100" b="1">
+                          <a:solidFill>
+                            <a:srgbClr val="1C1C1C"/>
+                          </a:solidFill>
+                          <a:latin typeface="Arial"/>
+                        </a:rPr>
+                        <a:t>Passing</a:t>
+                      </a:r>
+                    </a:p>
+                  </a:txBody>
+                  <a:tcPr>
+                    <a:solidFill>
+                      <a:srgbClr val="F0FAF4"/>
+                    </a:solidFill>
+                  </a:tcPr>
+                </a:tc>
+                <a:tc>
+                  <a:txBody>
+                    <a:bodyPr/>
+                    <a:lstStyle/>
+                    <a:p>
+                      <a:r>
+                        <a:rPr sz="1100" b="1">
+                          <a:solidFill>
+                            <a:srgbClr val="1C1C1C"/>
+                          </a:solidFill>
+                          <a:latin typeface="Arial"/>
+                        </a:rPr>
+                        <a:t>Planned keep</a:t>
+                      </a:r>
+                    </a:p>
+                  </a:txBody>
+                  <a:tcPr>
+                    <a:solidFill>
+                      <a:srgbClr val="F0FAF4"/>
+                    </a:solidFill>
+                  </a:tcPr>
+                </a:tc>
+                <a:tc>
+                  <a:txBody>
+                    <a:bodyPr/>
+                    <a:lstStyle/>
+                    <a:p>
+                      <a:r>
+                        <a:rPr sz="1100" b="1">
+                          <a:solidFill>
+                            <a:srgbClr val="1C1C1C"/>
+                          </a:solidFill>
+                          <a:latin typeface="Arial"/>
+                        </a:rPr>
+                        <a:t>vs Passes (cluster)</a:t>
+                      </a:r>
+                    </a:p>
+                  </a:txBody>
+                  <a:tcPr>
+                    <a:solidFill>
+                      <a:srgbClr val="F0FAF4"/>
+                    </a:solidFill>
+                  </a:tcPr>
+                </a:tc>
+              </a:tr>
+              <a:tr h="347472">
                 <a:tc>
                   <a:txBody>
                     <a:bodyPr/>
@@ -7159,16 +8396,106 @@
                           </a:solidFill>
                           <a:latin typeface="Arial"/>
                         </a:rPr>
-                        <a:t>0.93</a:t>
-                      </a:r>
-                    </a:p>
-                  </a:txBody>
-                  <a:tcPr>
-                    <a:solidFill>
-                      <a:srgbClr val="F0FAF4"/>
-                    </a:solidFill>
-                  </a:tcPr>
-                </a:tc>
+                        <a:t>Pass</a:t>
+                      </a:r>
+                    </a:p>
+                  </a:txBody>
+                  <a:tcPr>
+                    <a:solidFill>
+                      <a:srgbClr val="F5F5F5"/>
+                    </a:solidFill>
+                  </a:tcPr>
+                </a:tc>
+                <a:tc>
+                  <a:txBody>
+                    <a:bodyPr/>
+                    <a:lstStyle/>
+                    <a:p>
+                      <a:r>
+                        <a:rPr sz="1100" b="0">
+                          <a:solidFill>
+                            <a:srgbClr val="1C1C1C"/>
+                          </a:solidFill>
+                          <a:latin typeface="Arial"/>
+                        </a:rPr>
+                        <a:t>Passes</a:t>
+                      </a:r>
+                    </a:p>
+                  </a:txBody>
+                  <a:tcPr>
+                    <a:solidFill>
+                      <a:srgbClr val="F5F5F5"/>
+                    </a:solidFill>
+                  </a:tcPr>
+                </a:tc>
+                <a:tc>
+                  <a:txBody>
+                    <a:bodyPr/>
+                    <a:lstStyle/>
+                    <a:p>
+                      <a:r>
+                        <a:rPr sz="1100" b="0">
+                          <a:solidFill>
+                            <a:srgbClr val="1C1C1C"/>
+                          </a:solidFill>
+                          <a:latin typeface="Arial"/>
+                        </a:rPr>
+                        <a:t>Passing</a:t>
+                      </a:r>
+                    </a:p>
+                  </a:txBody>
+                  <a:tcPr>
+                    <a:solidFill>
+                      <a:srgbClr val="F5F5F5"/>
+                    </a:solidFill>
+                  </a:tcPr>
+                </a:tc>
+                <a:tc>
+                  <a:txBody>
+                    <a:bodyPr/>
+                    <a:lstStyle/>
+                    <a:p>
+                      <a:r>
+                        <a:rPr sz="1100" b="0">
+                          <a:solidFill>
+                            <a:srgbClr val="1C1C1C"/>
+                          </a:solidFill>
+                          <a:latin typeface="Arial"/>
+                        </a:rPr>
+                        <a:t>Planned drop</a:t>
+                      </a:r>
+                    </a:p>
+                  </a:txBody>
+                  <a:tcPr>
+                    <a:solidFill>
+                      <a:srgbClr val="F5F5F5"/>
+                    </a:solidFill>
+                  </a:tcPr>
+                </a:tc>
+                <a:tc>
+                  <a:txBody>
+                    <a:bodyPr/>
+                    <a:lstStyle/>
+                    <a:p>
+                      <a:r>
+                        <a:rPr sz="1100" b="0">
+                          <a:solidFill>
+                            <a:srgbClr val="1C1C1C"/>
+                          </a:solidFill>
+                          <a:latin typeface="Arial"/>
+                        </a:rPr>
+                        <a:t>less stable analogue</a:t>
+                      </a:r>
+                    </a:p>
+                  </a:txBody>
+                  <a:tcPr>
+                    <a:solidFill>
+                      <a:srgbClr val="F5F5F5"/>
+                    </a:solidFill>
+                  </a:tcPr>
+                </a:tc>
+              </a:tr>
+              <a:tr h="347472">
                 <a:tc>
                   <a:txBody>
                     <a:bodyPr/>
@@ -7181,7 +8508,7 @@
                           </a:solidFill>
                           <a:latin typeface="Arial"/>
                         </a:rPr>
-                        <a:t>PAS — Pass volume</a:t>
+                        <a:t>Carr</a:t>
                       </a:r>
                     </a:p>
                   </a:txBody>
@@ -7203,16 +8530,84 @@
                           </a:solidFill>
                           <a:latin typeface="Arial"/>
                         </a:rPr>
-                        <a:t>0.532</a:t>
-                      </a:r>
-                    </a:p>
-                  </a:txBody>
-                  <a:tcPr>
-                    <a:solidFill>
-                      <a:srgbClr val="F0FAF4"/>
-                    </a:solidFill>
-                  </a:tcPr>
-                </a:tc>
+                        <a:t>Carries</a:t>
+                      </a:r>
+                    </a:p>
+                  </a:txBody>
+                  <a:tcPr>
+                    <a:solidFill>
+                      <a:srgbClr val="F0FAF4"/>
+                    </a:solidFill>
+                  </a:tcPr>
+                </a:tc>
+                <a:tc>
+                  <a:txBody>
+                    <a:bodyPr/>
+                    <a:lstStyle/>
+                    <a:p>
+                      <a:r>
+                        <a:rPr sz="1100" b="1">
+                          <a:solidFill>
+                            <a:srgbClr val="1C1C1C"/>
+                          </a:solidFill>
+                          <a:latin typeface="Arial"/>
+                        </a:rPr>
+                        <a:t>Carrying</a:t>
+                      </a:r>
+                    </a:p>
+                  </a:txBody>
+                  <a:tcPr>
+                    <a:solidFill>
+                      <a:srgbClr val="F0FAF4"/>
+                    </a:solidFill>
+                  </a:tcPr>
+                </a:tc>
+                <a:tc>
+                  <a:txBody>
+                    <a:bodyPr/>
+                    <a:lstStyle/>
+                    <a:p>
+                      <a:r>
+                        <a:rPr sz="1100" b="1">
+                          <a:solidFill>
+                            <a:srgbClr val="1C1C1C"/>
+                          </a:solidFill>
+                          <a:latin typeface="Arial"/>
+                        </a:rPr>
+                        <a:t>Planned keep</a:t>
+                      </a:r>
+                    </a:p>
+                  </a:txBody>
+                  <a:tcPr>
+                    <a:solidFill>
+                      <a:srgbClr val="F0FAF4"/>
+                    </a:solidFill>
+                  </a:tcPr>
+                </a:tc>
+                <a:tc>
+                  <a:txBody>
+                    <a:bodyPr/>
+                    <a:lstStyle/>
+                    <a:p>
+                      <a:r>
+                        <a:rPr sz="1100" b="1">
+                          <a:solidFill>
+                            <a:srgbClr val="1C1C1C"/>
+                          </a:solidFill>
+                          <a:latin typeface="Arial"/>
+                        </a:rPr>
+                        <a:t>vs PrgC (cluster)</a:t>
+                      </a:r>
+                    </a:p>
+                  </a:txBody>
+                  <a:tcPr>
+                    <a:solidFill>
+                      <a:srgbClr val="F0FAF4"/>
+                    </a:solidFill>
+                  </a:tcPr>
+                </a:tc>
+              </a:tr>
+              <a:tr h="347472">
                 <a:tc>
                   <a:txBody>
                     <a:bodyPr/>
@@ -7225,18 +8620,106 @@
                           </a:solidFill>
                           <a:latin typeface="Arial"/>
                         </a:rPr>
-                        <a:t>CRY — Carries (r=0.413)</a:t>
-                      </a:r>
-                    </a:p>
-                  </a:txBody>
-                  <a:tcPr>
-                    <a:solidFill>
-                      <a:srgbClr val="F0FAF4"/>
+                        <a:t>PrgC</a:t>
+                      </a:r>
+                    </a:p>
+                  </a:txBody>
+                  <a:tcPr>
+                    <a:solidFill>
+                      <a:srgbClr val="F5F5F5"/>
+                    </a:solidFill>
+                  </a:tcPr>
+                </a:tc>
+                <a:tc>
+                  <a:txBody>
+                    <a:bodyPr/>
+                    <a:lstStyle/>
+                    <a:p>
+                      <a:r>
+                        <a:rPr sz="1100" b="0">
+                          <a:solidFill>
+                            <a:srgbClr val="1C1C1C"/>
+                          </a:solidFill>
+                          <a:latin typeface="Arial"/>
+                        </a:rPr>
+                        <a:t>Progressive carries</a:t>
+                      </a:r>
+                    </a:p>
+                  </a:txBody>
+                  <a:tcPr>
+                    <a:solidFill>
+                      <a:srgbClr val="F5F5F5"/>
+                    </a:solidFill>
+                  </a:tcPr>
+                </a:tc>
+                <a:tc>
+                  <a:txBody>
+                    <a:bodyPr/>
+                    <a:lstStyle/>
+                    <a:p>
+                      <a:r>
+                        <a:rPr sz="1100" b="0">
+                          <a:solidFill>
+                            <a:srgbClr val="1C1C1C"/>
+                          </a:solidFill>
+                          <a:latin typeface="Arial"/>
+                        </a:rPr>
+                        <a:t>Carrying</a:t>
+                      </a:r>
+                    </a:p>
+                  </a:txBody>
+                  <a:tcPr>
+                    <a:solidFill>
+                      <a:srgbClr val="F5F5F5"/>
+                    </a:solidFill>
+                  </a:tcPr>
+                </a:tc>
+                <a:tc>
+                  <a:txBody>
+                    <a:bodyPr/>
+                    <a:lstStyle/>
+                    <a:p>
+                      <a:r>
+                        <a:rPr sz="1100" b="0">
+                          <a:solidFill>
+                            <a:srgbClr val="1C1C1C"/>
+                          </a:solidFill>
+                          <a:latin typeface="Arial"/>
+                        </a:rPr>
+                        <a:t>Planned drop</a:t>
+                      </a:r>
+                    </a:p>
+                  </a:txBody>
+                  <a:tcPr>
+                    <a:solidFill>
+                      <a:srgbClr val="F5F5F5"/>
+                    </a:solidFill>
+                  </a:tcPr>
+                </a:tc>
+                <a:tc>
+                  <a:txBody>
+                    <a:bodyPr/>
+                    <a:lstStyle/>
+                    <a:p>
+                      <a:r>
+                        <a:rPr sz="1100" b="0">
+                          <a:solidFill>
+                            <a:srgbClr val="1C1C1C"/>
+                          </a:solidFill>
+                          <a:latin typeface="Arial"/>
+                        </a:rPr>
+                        <a:t>SB analogue failed r≥0.40</a:t>
+                      </a:r>
+                    </a:p>
+                  </a:txBody>
+                  <a:tcPr>
+                    <a:solidFill>
+                      <a:srgbClr val="F5F5F5"/>
                     </a:solidFill>
                   </a:tcPr>
                 </a:tc>
               </a:tr>
-              <a:tr h="457200">
+              <a:tr h="347472">
                 <a:tc>
                   <a:txBody>
                     <a:bodyPr/>
@@ -7249,16 +8732,106 @@
                           </a:solidFill>
                           <a:latin typeface="Arial"/>
                         </a:rPr>
-                        <a:t>XG ↔ SH</a:t>
-                      </a:r>
-                    </a:p>
-                  </a:txBody>
-                  <a:tcPr>
-                    <a:solidFill>
-                      <a:srgbClr val="F0FAF4"/>
-                    </a:solidFill>
-                  </a:tcPr>
-                </a:tc>
+                        <a:t>npxG</a:t>
+                      </a:r>
+                    </a:p>
+                  </a:txBody>
+                  <a:tcPr>
+                    <a:solidFill>
+                      <a:srgbClr val="F0FAF4"/>
+                    </a:solidFill>
+                  </a:tcPr>
+                </a:tc>
+                <a:tc>
+                  <a:txBody>
+                    <a:bodyPr/>
+                    <a:lstStyle/>
+                    <a:p>
+                      <a:r>
+                        <a:rPr sz="1100" b="1">
+                          <a:solidFill>
+                            <a:srgbClr val="1C1C1C"/>
+                          </a:solidFill>
+                          <a:latin typeface="Arial"/>
+                        </a:rPr>
+                        <a:t>Non-pen xG</a:t>
+                      </a:r>
+                    </a:p>
+                  </a:txBody>
+                  <a:tcPr>
+                    <a:solidFill>
+                      <a:srgbClr val="F0FAF4"/>
+                    </a:solidFill>
+                  </a:tcPr>
+                </a:tc>
+                <a:tc>
+                  <a:txBody>
+                    <a:bodyPr/>
+                    <a:lstStyle/>
+                    <a:p>
+                      <a:r>
+                        <a:rPr sz="1100" b="1">
+                          <a:solidFill>
+                            <a:srgbClr val="1C1C1C"/>
+                          </a:solidFill>
+                          <a:latin typeface="Arial"/>
+                        </a:rPr>
+                        <a:t>Attacking</a:t>
+                      </a:r>
+                    </a:p>
+                  </a:txBody>
+                  <a:tcPr>
+                    <a:solidFill>
+                      <a:srgbClr val="F0FAF4"/>
+                    </a:solidFill>
+                  </a:tcPr>
+                </a:tc>
+                <a:tc>
+                  <a:txBody>
+                    <a:bodyPr/>
+                    <a:lstStyle/>
+                    <a:p>
+                      <a:r>
+                        <a:rPr sz="1100" b="1">
+                          <a:solidFill>
+                            <a:srgbClr val="1C1C1C"/>
+                          </a:solidFill>
+                          <a:latin typeface="Arial"/>
+                        </a:rPr>
+                        <a:t>Planned keep</a:t>
+                      </a:r>
+                    </a:p>
+                  </a:txBody>
+                  <a:tcPr>
+                    <a:solidFill>
+                      <a:srgbClr val="F0FAF4"/>
+                    </a:solidFill>
+                  </a:tcPr>
+                </a:tc>
+                <a:tc>
+                  <a:txBody>
+                    <a:bodyPr/>
+                    <a:lstStyle/>
+                    <a:p>
+                      <a:r>
+                        <a:rPr sz="1100" b="1">
+                          <a:solidFill>
+                            <a:srgbClr val="1C1C1C"/>
+                          </a:solidFill>
+                          <a:latin typeface="Arial"/>
+                        </a:rPr>
+                        <a:t>vs Shots (cluster)</a:t>
+                      </a:r>
+                    </a:p>
+                  </a:txBody>
+                  <a:tcPr>
+                    <a:solidFill>
+                      <a:srgbClr val="F0FAF4"/>
+                    </a:solidFill>
+                  </a:tcPr>
+                </a:tc>
+              </a:tr>
+              <a:tr h="347472">
                 <a:tc>
                   <a:txBody>
                     <a:bodyPr/>
@@ -7271,16 +8844,106 @@
                           </a:solidFill>
                           <a:latin typeface="Arial"/>
                         </a:rPr>
-                        <a:t>0.86</a:t>
-                      </a:r>
-                    </a:p>
-                  </a:txBody>
-                  <a:tcPr>
-                    <a:solidFill>
-                      <a:srgbClr val="F0FAF4"/>
-                    </a:solidFill>
-                  </a:tcPr>
-                </a:tc>
+                        <a:t>Sh</a:t>
+                      </a:r>
+                    </a:p>
+                  </a:txBody>
+                  <a:tcPr>
+                    <a:solidFill>
+                      <a:srgbClr val="F5F5F5"/>
+                    </a:solidFill>
+                  </a:tcPr>
+                </a:tc>
+                <a:tc>
+                  <a:txBody>
+                    <a:bodyPr/>
+                    <a:lstStyle/>
+                    <a:p>
+                      <a:r>
+                        <a:rPr sz="1100" b="0">
+                          <a:solidFill>
+                            <a:srgbClr val="1C1C1C"/>
+                          </a:solidFill>
+                          <a:latin typeface="Arial"/>
+                        </a:rPr>
+                        <a:t>Shots</a:t>
+                      </a:r>
+                    </a:p>
+                  </a:txBody>
+                  <a:tcPr>
+                    <a:solidFill>
+                      <a:srgbClr val="F5F5F5"/>
+                    </a:solidFill>
+                  </a:tcPr>
+                </a:tc>
+                <a:tc>
+                  <a:txBody>
+                    <a:bodyPr/>
+                    <a:lstStyle/>
+                    <a:p>
+                      <a:r>
+                        <a:rPr sz="1100" b="0">
+                          <a:solidFill>
+                            <a:srgbClr val="1C1C1C"/>
+                          </a:solidFill>
+                          <a:latin typeface="Arial"/>
+                        </a:rPr>
+                        <a:t>Attacking</a:t>
+                      </a:r>
+                    </a:p>
+                  </a:txBody>
+                  <a:tcPr>
+                    <a:solidFill>
+                      <a:srgbClr val="F5F5F5"/>
+                    </a:solidFill>
+                  </a:tcPr>
+                </a:tc>
+                <a:tc>
+                  <a:txBody>
+                    <a:bodyPr/>
+                    <a:lstStyle/>
+                    <a:p>
+                      <a:r>
+                        <a:rPr sz="1100" b="0">
+                          <a:solidFill>
+                            <a:srgbClr val="1C1C1C"/>
+                          </a:solidFill>
+                          <a:latin typeface="Arial"/>
+                        </a:rPr>
+                        <a:t>Planned drop</a:t>
+                      </a:r>
+                    </a:p>
+                  </a:txBody>
+                  <a:tcPr>
+                    <a:solidFill>
+                      <a:srgbClr val="F5F5F5"/>
+                    </a:solidFill>
+                  </a:tcPr>
+                </a:tc>
+                <a:tc>
+                  <a:txBody>
+                    <a:bodyPr/>
+                    <a:lstStyle/>
+                    <a:p>
+                      <a:r>
+                        <a:rPr sz="1100" b="0">
+                          <a:solidFill>
+                            <a:srgbClr val="1C1C1C"/>
+                          </a:solidFill>
+                          <a:latin typeface="Arial"/>
+                        </a:rPr>
+                        <a:t>less stable analogue</a:t>
+                      </a:r>
+                    </a:p>
+                  </a:txBody>
+                  <a:tcPr>
+                    <a:solidFill>
+                      <a:srgbClr val="F5F5F5"/>
+                    </a:solidFill>
+                  </a:tcPr>
+                </a:tc>
+              </a:tr>
+              <a:tr h="347472">
                 <a:tc>
                   <a:txBody>
                     <a:bodyPr/>
@@ -7293,7 +8956,7 @@
                           </a:solidFill>
                           <a:latin typeface="Arial"/>
                         </a:rPr>
-                        <a:t>XG — Non-pen xG</a:t>
+                        <a:t>SCA</a:t>
                       </a:r>
                     </a:p>
                   </a:txBody>
@@ -7315,29 +8978,73 @@
                           </a:solidFill>
                           <a:latin typeface="Arial"/>
                         </a:rPr>
-                        <a:t>0.483</a:t>
-                      </a:r>
-                    </a:p>
-                  </a:txBody>
-                  <a:tcPr>
-                    <a:solidFill>
-                      <a:srgbClr val="F0FAF4"/>
-                    </a:solidFill>
-                  </a:tcPr>
-                </a:tc>
-                <a:tc>
-                  <a:txBody>
-                    <a:bodyPr/>
-                    <a:lstStyle/>
-                    <a:p>
-                      <a:r>
-                        <a:rPr sz="1100" b="0">
-                          <a:solidFill>
-                            <a:srgbClr val="1C1C1C"/>
-                          </a:solidFill>
-                          <a:latin typeface="Arial"/>
-                        </a:rPr>
-                        <a:t>SH — Shots (r=0.447)</a:t>
+                        <a:t>Shot-creating actions</a:t>
+                      </a:r>
+                    </a:p>
+                  </a:txBody>
+                  <a:tcPr>
+                    <a:solidFill>
+                      <a:srgbClr val="F0FAF4"/>
+                    </a:solidFill>
+                  </a:tcPr>
+                </a:tc>
+                <a:tc>
+                  <a:txBody>
+                    <a:bodyPr/>
+                    <a:lstStyle/>
+                    <a:p>
+                      <a:r>
+                        <a:rPr sz="1100" b="1">
+                          <a:solidFill>
+                            <a:srgbClr val="1C1C1C"/>
+                          </a:solidFill>
+                          <a:latin typeface="Arial"/>
+                        </a:rPr>
+                        <a:t>Attacking</a:t>
+                      </a:r>
+                    </a:p>
+                  </a:txBody>
+                  <a:tcPr>
+                    <a:solidFill>
+                      <a:srgbClr val="F0FAF4"/>
+                    </a:solidFill>
+                  </a:tcPr>
+                </a:tc>
+                <a:tc>
+                  <a:txBody>
+                    <a:bodyPr/>
+                    <a:lstStyle/>
+                    <a:p>
+                      <a:r>
+                        <a:rPr sz="1100" b="1">
+                          <a:solidFill>
+                            <a:srgbClr val="1C1C1C"/>
+                          </a:solidFill>
+                          <a:latin typeface="Arial"/>
+                        </a:rPr>
+                        <a:t>Singleton</a:t>
+                      </a:r>
+                    </a:p>
+                  </a:txBody>
+                  <a:tcPr>
+                    <a:solidFill>
+                      <a:srgbClr val="F0FAF4"/>
+                    </a:solidFill>
+                  </a:tcPr>
+                </a:tc>
+                <a:tc>
+                  <a:txBody>
+                    <a:bodyPr/>
+                    <a:lstStyle/>
+                    <a:p>
+                      <a:r>
+                        <a:rPr sz="1100" b="1">
+                          <a:solidFill>
+                            <a:srgbClr val="1C1C1C"/>
+                          </a:solidFill>
+                          <a:latin typeface="Arial"/>
+                        </a:rPr>
+                        <a:t>no high overlap</a:t>
                       </a:r>
                     </a:p>
                   </a:txBody>
@@ -7348,7 +9055,7 @@
                   </a:tcPr>
                 </a:tc>
               </a:tr>
-              <a:tr h="457200">
+              <a:tr h="347472">
                 <a:tc>
                   <a:txBody>
                     <a:bodyPr/>
@@ -7361,29 +9068,7 @@
                           </a:solidFill>
                           <a:latin typeface="Arial"/>
                         </a:rPr>
-                        <a:t>PPC ↔ PAS</a:t>
-                      </a:r>
-                    </a:p>
-                  </a:txBody>
-                  <a:tcPr>
-                    <a:solidFill>
-                      <a:srgbClr val="F0FAF4"/>
-                    </a:solidFill>
-                  </a:tcPr>
-                </a:tc>
-                <a:tc>
-                  <a:txBody>
-                    <a:bodyPr/>
-                    <a:lstStyle/>
-                    <a:p>
-                      <a:r>
-                        <a:rPr sz="1100" b="0">
-                          <a:solidFill>
-                            <a:srgbClr val="1C1C1C"/>
-                          </a:solidFill>
-                          <a:latin typeface="Arial"/>
-                        </a:rPr>
-                        <a:t>0.79</a:t>
+                        <a:t>Tkl</a:t>
                       </a:r>
                     </a:p>
                   </a:txBody>
@@ -7405,7 +9090,7 @@
                           </a:solidFill>
                           <a:latin typeface="Arial"/>
                         </a:rPr>
-                        <a:t>PPC — Progressive passes</a:t>
+                        <a:t>Tackles</a:t>
                       </a:r>
                     </a:p>
                   </a:txBody>
@@ -7427,29 +9112,387 @@
                           </a:solidFill>
                           <a:latin typeface="Arial"/>
                         </a:rPr>
-                        <a:t>0.720</a:t>
-                      </a:r>
-                    </a:p>
-                  </a:txBody>
-                  <a:tcPr>
-                    <a:solidFill>
-                      <a:srgbClr val="F0FAF4"/>
-                    </a:solidFill>
-                  </a:tcPr>
-                </a:tc>
-                <a:tc>
-                  <a:txBody>
-                    <a:bodyPr/>
-                    <a:lstStyle/>
-                    <a:p>
-                      <a:r>
-                        <a:rPr sz="1100" b="0">
-                          <a:solidFill>
-                            <a:srgbClr val="1C1C1C"/>
-                          </a:solidFill>
-                          <a:latin typeface="Arial"/>
-                        </a:rPr>
-                        <a:t>PAS — Pass volume (r=0.532)</a:t>
+                        <a:t>Defending</a:t>
+                      </a:r>
+                    </a:p>
+                  </a:txBody>
+                  <a:tcPr>
+                    <a:solidFill>
+                      <a:srgbClr val="F0FAF4"/>
+                    </a:solidFill>
+                  </a:tcPr>
+                </a:tc>
+                <a:tc>
+                  <a:txBody>
+                    <a:bodyPr/>
+                    <a:lstStyle/>
+                    <a:p>
+                      <a:r>
+                        <a:rPr sz="1100" b="1">
+                          <a:solidFill>
+                            <a:srgbClr val="1C1C1C"/>
+                          </a:solidFill>
+                          <a:latin typeface="Arial"/>
+                        </a:rPr>
+                        <a:t>Singleton</a:t>
+                      </a:r>
+                    </a:p>
+                  </a:txBody>
+                  <a:tcPr>
+                    <a:solidFill>
+                      <a:srgbClr val="F0FAF4"/>
+                    </a:solidFill>
+                  </a:tcPr>
+                </a:tc>
+                <a:tc>
+                  <a:txBody>
+                    <a:bodyPr/>
+                    <a:lstStyle/>
+                    <a:p>
+                      <a:r>
+                        <a:rPr sz="1100" b="1">
+                          <a:solidFill>
+                            <a:srgbClr val="1C1C1C"/>
+                          </a:solidFill>
+                          <a:latin typeface="Arial"/>
+                        </a:rPr>
+                        <a:t>no high overlap</a:t>
+                      </a:r>
+                    </a:p>
+                  </a:txBody>
+                  <a:tcPr>
+                    <a:solidFill>
+                      <a:srgbClr val="F0FAF4"/>
+                    </a:solidFill>
+                  </a:tcPr>
+                </a:tc>
+              </a:tr>
+              <a:tr h="347472">
+                <a:tc>
+                  <a:txBody>
+                    <a:bodyPr/>
+                    <a:lstStyle/>
+                    <a:p>
+                      <a:r>
+                        <a:rPr sz="1100" b="1">
+                          <a:solidFill>
+                            <a:srgbClr val="1C1C1C"/>
+                          </a:solidFill>
+                          <a:latin typeface="Arial"/>
+                        </a:rPr>
+                        <a:t>Int</a:t>
+                      </a:r>
+                    </a:p>
+                  </a:txBody>
+                  <a:tcPr>
+                    <a:solidFill>
+                      <a:srgbClr val="F0FAF4"/>
+                    </a:solidFill>
+                  </a:tcPr>
+                </a:tc>
+                <a:tc>
+                  <a:txBody>
+                    <a:bodyPr/>
+                    <a:lstStyle/>
+                    <a:p>
+                      <a:r>
+                        <a:rPr sz="1100" b="1">
+                          <a:solidFill>
+                            <a:srgbClr val="1C1C1C"/>
+                          </a:solidFill>
+                          <a:latin typeface="Arial"/>
+                        </a:rPr>
+                        <a:t>Interceptions</a:t>
+                      </a:r>
+                    </a:p>
+                  </a:txBody>
+                  <a:tcPr>
+                    <a:solidFill>
+                      <a:srgbClr val="F0FAF4"/>
+                    </a:solidFill>
+                  </a:tcPr>
+                </a:tc>
+                <a:tc>
+                  <a:txBody>
+                    <a:bodyPr/>
+                    <a:lstStyle/>
+                    <a:p>
+                      <a:r>
+                        <a:rPr sz="1100" b="1">
+                          <a:solidFill>
+                            <a:srgbClr val="1C1C1C"/>
+                          </a:solidFill>
+                          <a:latin typeface="Arial"/>
+                        </a:rPr>
+                        <a:t>Defending</a:t>
+                      </a:r>
+                    </a:p>
+                  </a:txBody>
+                  <a:tcPr>
+                    <a:solidFill>
+                      <a:srgbClr val="F0FAF4"/>
+                    </a:solidFill>
+                  </a:tcPr>
+                </a:tc>
+                <a:tc>
+                  <a:txBody>
+                    <a:bodyPr/>
+                    <a:lstStyle/>
+                    <a:p>
+                      <a:r>
+                        <a:rPr sz="1100" b="1">
+                          <a:solidFill>
+                            <a:srgbClr val="1C1C1C"/>
+                          </a:solidFill>
+                          <a:latin typeface="Arial"/>
+                        </a:rPr>
+                        <a:t>Singleton</a:t>
+                      </a:r>
+                    </a:p>
+                  </a:txBody>
+                  <a:tcPr>
+                    <a:solidFill>
+                      <a:srgbClr val="F0FAF4"/>
+                    </a:solidFill>
+                  </a:tcPr>
+                </a:tc>
+                <a:tc>
+                  <a:txBody>
+                    <a:bodyPr/>
+                    <a:lstStyle/>
+                    <a:p>
+                      <a:r>
+                        <a:rPr sz="1100" b="1">
+                          <a:solidFill>
+                            <a:srgbClr val="1C1C1C"/>
+                          </a:solidFill>
+                          <a:latin typeface="Arial"/>
+                        </a:rPr>
+                        <a:t>no high overlap</a:t>
+                      </a:r>
+                    </a:p>
+                  </a:txBody>
+                  <a:tcPr>
+                    <a:solidFill>
+                      <a:srgbClr val="F0FAF4"/>
+                    </a:solidFill>
+                  </a:tcPr>
+                </a:tc>
+              </a:tr>
+              <a:tr h="347472">
+                <a:tc>
+                  <a:txBody>
+                    <a:bodyPr/>
+                    <a:lstStyle/>
+                    <a:p>
+                      <a:r>
+                        <a:rPr sz="1100" b="1">
+                          <a:solidFill>
+                            <a:srgbClr val="1C1C1C"/>
+                          </a:solidFill>
+                          <a:latin typeface="Arial"/>
+                        </a:rPr>
+                        <a:t>Aer</a:t>
+                      </a:r>
+                    </a:p>
+                  </a:txBody>
+                  <a:tcPr>
+                    <a:solidFill>
+                      <a:srgbClr val="F0FAF4"/>
+                    </a:solidFill>
+                  </a:tcPr>
+                </a:tc>
+                <a:tc>
+                  <a:txBody>
+                    <a:bodyPr/>
+                    <a:lstStyle/>
+                    <a:p>
+                      <a:r>
+                        <a:rPr sz="1100" b="1">
+                          <a:solidFill>
+                            <a:srgbClr val="1C1C1C"/>
+                          </a:solidFill>
+                          <a:latin typeface="Arial"/>
+                        </a:rPr>
+                        <a:t>Aerials won</a:t>
+                      </a:r>
+                    </a:p>
+                  </a:txBody>
+                  <a:tcPr>
+                    <a:solidFill>
+                      <a:srgbClr val="F0FAF4"/>
+                    </a:solidFill>
+                  </a:tcPr>
+                </a:tc>
+                <a:tc>
+                  <a:txBody>
+                    <a:bodyPr/>
+                    <a:lstStyle/>
+                    <a:p>
+                      <a:r>
+                        <a:rPr sz="1100" b="1">
+                          <a:solidFill>
+                            <a:srgbClr val="1C1C1C"/>
+                          </a:solidFill>
+                          <a:latin typeface="Arial"/>
+                        </a:rPr>
+                        <a:t>Defending</a:t>
+                      </a:r>
+                    </a:p>
+                  </a:txBody>
+                  <a:tcPr>
+                    <a:solidFill>
+                      <a:srgbClr val="F0FAF4"/>
+                    </a:solidFill>
+                  </a:tcPr>
+                </a:tc>
+                <a:tc>
+                  <a:txBody>
+                    <a:bodyPr/>
+                    <a:lstStyle/>
+                    <a:p>
+                      <a:r>
+                        <a:rPr sz="1100" b="1">
+                          <a:solidFill>
+                            <a:srgbClr val="1C1C1C"/>
+                          </a:solidFill>
+                          <a:latin typeface="Arial"/>
+                        </a:rPr>
+                        <a:t>Singleton</a:t>
+                      </a:r>
+                    </a:p>
+                  </a:txBody>
+                  <a:tcPr>
+                    <a:solidFill>
+                      <a:srgbClr val="F0FAF4"/>
+                    </a:solidFill>
+                  </a:tcPr>
+                </a:tc>
+                <a:tc>
+                  <a:txBody>
+                    <a:bodyPr/>
+                    <a:lstStyle/>
+                    <a:p>
+                      <a:r>
+                        <a:rPr sz="1100" b="1">
+                          <a:solidFill>
+                            <a:srgbClr val="1C1C1C"/>
+                          </a:solidFill>
+                          <a:latin typeface="Arial"/>
+                        </a:rPr>
+                        <a:t>no high overlap</a:t>
+                      </a:r>
+                    </a:p>
+                  </a:txBody>
+                  <a:tcPr>
+                    <a:solidFill>
+                      <a:srgbClr val="F0FAF4"/>
+                    </a:solidFill>
+                  </a:tcPr>
+                </a:tc>
+              </a:tr>
+              <a:tr h="347472">
+                <a:tc>
+                  <a:txBody>
+                    <a:bodyPr/>
+                    <a:lstStyle/>
+                    <a:p>
+                      <a:r>
+                        <a:rPr sz="1100" b="1">
+                          <a:solidFill>
+                            <a:srgbClr val="1C1C1C"/>
+                          </a:solidFill>
+                          <a:latin typeface="Arial"/>
+                        </a:rPr>
+                        <a:t>AttPen</a:t>
+                      </a:r>
+                    </a:p>
+                  </a:txBody>
+                  <a:tcPr>
+                    <a:solidFill>
+                      <a:srgbClr val="F0FAF4"/>
+                    </a:solidFill>
+                  </a:tcPr>
+                </a:tc>
+                <a:tc>
+                  <a:txBody>
+                    <a:bodyPr/>
+                    <a:lstStyle/>
+                    <a:p>
+                      <a:r>
+                        <a:rPr sz="1100" b="1">
+                          <a:solidFill>
+                            <a:srgbClr val="1C1C1C"/>
+                          </a:solidFill>
+                          <a:latin typeface="Arial"/>
+                        </a:rPr>
+                        <a:t>Touches in att. pen</a:t>
+                      </a:r>
+                    </a:p>
+                  </a:txBody>
+                  <a:tcPr>
+                    <a:solidFill>
+                      <a:srgbClr val="F0FAF4"/>
+                    </a:solidFill>
+                  </a:tcPr>
+                </a:tc>
+                <a:tc>
+                  <a:txBody>
+                    <a:bodyPr/>
+                    <a:lstStyle/>
+                    <a:p>
+                      <a:r>
+                        <a:rPr sz="1100" b="1">
+                          <a:solidFill>
+                            <a:srgbClr val="1C1C1C"/>
+                          </a:solidFill>
+                          <a:latin typeface="Arial"/>
+                        </a:rPr>
+                        <a:t>Attacking</a:t>
+                      </a:r>
+                    </a:p>
+                  </a:txBody>
+                  <a:tcPr>
+                    <a:solidFill>
+                      <a:srgbClr val="F0FAF4"/>
+                    </a:solidFill>
+                  </a:tcPr>
+                </a:tc>
+                <a:tc>
+                  <a:txBody>
+                    <a:bodyPr/>
+                    <a:lstStyle/>
+                    <a:p>
+                      <a:r>
+                        <a:rPr sz="1100" b="1">
+                          <a:solidFill>
+                            <a:srgbClr val="1C1C1C"/>
+                          </a:solidFill>
+                          <a:latin typeface="Arial"/>
+                        </a:rPr>
+                        <a:t>Singleton</a:t>
+                      </a:r>
+                    </a:p>
+                  </a:txBody>
+                  <a:tcPr>
+                    <a:solidFill>
+                      <a:srgbClr val="F0FAF4"/>
+                    </a:solidFill>
+                  </a:tcPr>
+                </a:tc>
+                <a:tc>
+                  <a:txBody>
+                    <a:bodyPr/>
+                    <a:lstStyle/>
+                    <a:p>
+                      <a:r>
+                        <a:rPr sz="1100" b="1">
+                          <a:solidFill>
+                            <a:srgbClr val="1C1C1C"/>
+                          </a:solidFill>
+                          <a:latin typeface="Arial"/>
+                        </a:rPr>
+                        <a:t>no high overlap</a:t>
                       </a:r>
                     </a:p>
                   </a:txBody>
@@ -7472,8 +9515,8 @@
         </p:nvSpPr>
         <p:spPr>
           <a:xfrm>
-            <a:off x="502920" y="3337560"/>
-            <a:ext cx="11155680" cy="320040"/>
+            <a:off x="502920" y="5989320"/>
+            <a:ext cx="11155680" cy="548640"/>
           </a:xfrm>
           <a:prstGeom prst="rect">
             <a:avLst/>
@@ -7487,183 +9530,24 @@
           <a:lstStyle/>
           <a:p>
             <a:r>
-              <a:rPr sz="1300" b="1">
-                <a:solidFill>
-                  <a:srgbClr val="1C1C1C"/>
+              <a:rPr sz="1200" b="0">
+                <a:solidFill>
+                  <a:srgbClr val="8A5A00"/>
                 </a:solidFill>
                 <a:latin typeface="Arial"/>
               </a:rPr>
-              <a:t>Rule: when two portable metrics largely measure the same thing, keep the one that travels better.</a:t>
-            </a:r>
-          </a:p>
-        </p:txBody>
-      </p:sp>
-      <p:sp>
-        <p:nvSpPr>
-          <p:cNvPr id="8" name="TextBox 7"/>
-          <p:cNvSpPr txBox="1"/>
-          <p:nvPr/>
-        </p:nvSpPr>
-        <p:spPr>
-          <a:xfrm>
-            <a:off x="502920" y="3749039"/>
-            <a:ext cx="11155680" cy="320040"/>
-          </a:xfrm>
-          <a:prstGeom prst="rect">
-            <a:avLst/>
-          </a:prstGeom>
-          <a:noFill/>
-        </p:spPr>
-        <p:txBody>
-          <a:bodyPr wrap="square">
-            <a:spAutoFit/>
-          </a:bodyPr>
-          <a:lstStyle/>
-          <a:p>
-            <a:r>
-              <a:rPr sz="1300" b="0">
-                <a:solidFill>
-                  <a:srgbClr val="1C1C1C"/>
+              <a:t>When FBref freeze lands: replace this table with real prior→Y1 stability r’s (same layout as the StatsBomb stability slide).</a:t>
+            </a:r>
+          </a:p>
+          <a:p>
+            <a:r>
+              <a:rPr sz="1200" b="0">
+                <a:solidFill>
+                  <a:srgbClr val="555555"/>
                 </a:solidFill>
                 <a:latin typeface="Arial"/>
               </a:rPr>
-              <a:t>StatsBomb final shortlist (9): DIS · PPC · PRS · PAS · TAC · CLR · XG · DRB · PATT</a:t>
-            </a:r>
-          </a:p>
-        </p:txBody>
-      </p:sp>
-      <p:sp>
-        <p:nvSpPr>
-          <p:cNvPr id="9" name="TextBox 8"/>
-          <p:cNvSpPr txBox="1"/>
-          <p:nvPr/>
-        </p:nvSpPr>
-        <p:spPr>
-          <a:xfrm>
-            <a:off x="502920" y="4114800"/>
-            <a:ext cx="11155680" cy="365760"/>
-          </a:xfrm>
-          <a:prstGeom prst="rect">
-            <a:avLst/>
-          </a:prstGeom>
-          <a:noFill/>
-        </p:spPr>
-        <p:txBody>
-          <a:bodyPr wrap="square">
-            <a:spAutoFit/>
-          </a:bodyPr>
-          <a:lstStyle/>
-          <a:p>
-            <a:r>
-              <a:rPr sz="1300" b="0">
-                <a:solidFill>
-                  <a:srgbClr val="555555"/>
-                </a:solidFill>
-                <a:latin typeface="Arial"/>
-              </a:rPr>
-              <a:t>FBref planned picks (same rule via SB analogues): PrgP over Passes · Carries over PrgC · npxG over Shots</a:t>
-            </a:r>
-          </a:p>
-        </p:txBody>
-      </p:sp>
-      <p:sp>
-        <p:nvSpPr>
-          <p:cNvPr id="10" name="TextBox 9"/>
-          <p:cNvSpPr txBox="1"/>
-          <p:nvPr/>
-        </p:nvSpPr>
-        <p:spPr>
-          <a:xfrm>
-            <a:off x="502920" y="4572000"/>
-            <a:ext cx="11155680" cy="320040"/>
-          </a:xfrm>
-          <a:prstGeom prst="rect">
-            <a:avLst/>
-          </a:prstGeom>
-          <a:noFill/>
-        </p:spPr>
-        <p:txBody>
-          <a:bodyPr wrap="square">
-            <a:spAutoFit/>
-          </a:bodyPr>
-          <a:lstStyle/>
-          <a:p>
-            <a:r>
-              <a:rPr sz="1200" b="0">
-                <a:solidFill>
-                  <a:srgbClr val="555555"/>
-                </a:solidFill>
-                <a:latin typeface="Arial"/>
-              </a:rPr>
-              <a:t>FBref shortlist (8): PrgP · Carries · npxG · SCA · Tackles · Interceptions · Aerials won · Att-pen touches</a:t>
-            </a:r>
-          </a:p>
-        </p:txBody>
-      </p:sp>
-      <p:sp>
-        <p:nvSpPr>
-          <p:cNvPr id="11" name="TextBox 10"/>
-          <p:cNvSpPr txBox="1"/>
-          <p:nvPr/>
-        </p:nvSpPr>
-        <p:spPr>
-          <a:xfrm>
-            <a:off x="502920" y="5074920"/>
-            <a:ext cx="11155680" cy="411480"/>
-          </a:xfrm>
-          <a:prstGeom prst="rect">
-            <a:avLst/>
-          </a:prstGeom>
-          <a:noFill/>
-        </p:spPr>
-        <p:txBody>
-          <a:bodyPr wrap="square">
-            <a:spAutoFit/>
-          </a:bodyPr>
-          <a:lstStyle/>
-          <a:p>
-            <a:r>
-              <a:rPr sz="1200" b="0">
-                <a:solidFill>
-                  <a:srgbClr val="555555"/>
-                </a:solidFill>
-                <a:latin typeface="Arial"/>
-              </a:rPr>
-              <a:t>Dropped from StatsBomb scout card: CRY (vs PAS), SH (vs XG); PAS contested vs PPC but retained from the PAS↔CRY keep.</a:t>
-            </a:r>
-          </a:p>
-        </p:txBody>
-      </p:sp>
-      <p:sp>
-        <p:nvSpPr>
-          <p:cNvPr id="12" name="TextBox 11"/>
-          <p:cNvSpPr txBox="1"/>
-          <p:nvPr/>
-        </p:nvSpPr>
-        <p:spPr>
-          <a:xfrm>
-            <a:off x="502920" y="5623560"/>
-            <a:ext cx="11155680" cy="320040"/>
-          </a:xfrm>
-          <a:prstGeom prst="rect">
-            <a:avLst/>
-          </a:prstGeom>
-          <a:noFill/>
-        </p:spPr>
-        <p:txBody>
-          <a:bodyPr wrap="square">
-            <a:spAutoFit/>
-          </a:bodyPr>
-          <a:lstStyle/>
-          <a:p>
-            <a:r>
-              <a:rPr sz="1100" b="0">
-                <a:solidFill>
-                  <a:srgbClr val="555555"/>
-                </a:solidFill>
-                <a:latin typeface="Arial"/>
-              </a:rPr>
-              <a:t>Source: Step 2 Decision Tool PDF · stability gate r ≥ 0.41 · redundancy |r| ≥ 0.70 · cohort N=60</a:t>
+              <a:t>Until then: StatsBomb N=60 is the live stability evidence; FBref picks above are Step-2 plans guided by SB analogues.</a:t>
             </a:r>
           </a:p>
         </p:txBody>

</xml_diff>

<commit_message>
Clean leftover Tier wording on sample-design slide.
</commit_message>
<xml_diff>
--- a/bundesliga_transfer_traits.pptx
+++ b/bundesliga_transfer_traits.pptx
@@ -4118,13 +4118,13 @@
           <a:lstStyle/>
           <a:p>
             <a:r>
-              <a:rPr sz="1400" b="1">
-                <a:solidFill>
-                  <a:srgbClr val="3D5A80"/>
+              <a:rPr sz="1300" b="1">
+                <a:solidFill>
+                  <a:srgbClr val="555555"/>
                 </a:solidFill>
                 <a:latin typeface="Arial"/>
               </a:rPr>
-              <a:t>Tier 2 — Deep (portability → pizza)</a:t>
+              <a:t>Live now: StatsBomb deep dive (N=60). Next: FBref freeze for Tier 1 + Tier 2 at scale.</a:t>
             </a:r>
           </a:p>
           <a:p>
@@ -4135,7 +4135,7 @@
                 </a:solidFill>
                 <a:latin typeface="Arial"/>
               </a:rPr>
-              <a:t>Paired prior→Y1 seasons. 1) Stability on ALL stats. 2) Redundancy (|r|≥0.70). 3) Pizza charts from kept traits. StatsBomb ~94–120 for event-level check.</a:t>
+              <a:t/>
             </a:r>
           </a:p>
         </p:txBody>
@@ -6161,6 +6161,1607 @@
 </file>
 
 <file path=ppt/slides/slide5.xml><?xml version="1.0" encoding="utf-8"?>
+<p:sld xmlns:a="http://schemas.openxmlformats.org/drawingml/2006/main" xmlns:p="http://schemas.openxmlformats.org/presentationml/2006/main" xmlns:r="http://schemas.openxmlformats.org/officeDocument/2006/relationships">
+  <p:cSld>
+    <p:spTree>
+      <p:nvGrpSpPr>
+        <p:cNvPr id="1" name=""/>
+        <p:cNvGrpSpPr/>
+        <p:nvPr/>
+      </p:nvGrpSpPr>
+      <p:grpSpPr/>
+      <p:sp>
+        <p:nvSpPr>
+          <p:cNvPr id="2" name="Rectangle 1"/>
+          <p:cNvSpPr/>
+          <p:nvPr/>
+        </p:nvSpPr>
+        <p:spPr>
+          <a:xfrm>
+            <a:off x="0" y="0"/>
+            <a:ext cx="12191695" cy="6858000"/>
+          </a:xfrm>
+          <a:prstGeom prst="rect">
+            <a:avLst/>
+          </a:prstGeom>
+          <a:solidFill>
+            <a:srgbClr val="F4F5F7"/>
+          </a:solidFill>
+          <a:ln>
+            <a:noFill/>
+          </a:ln>
+        </p:spPr>
+        <p:style>
+          <a:lnRef idx="1">
+            <a:schemeClr val="accent1"/>
+          </a:lnRef>
+          <a:fillRef idx="3">
+            <a:schemeClr val="accent1"/>
+          </a:fillRef>
+          <a:effectRef idx="2">
+            <a:schemeClr val="accent1"/>
+          </a:effectRef>
+          <a:fontRef idx="minor">
+            <a:schemeClr val="lt1"/>
+          </a:fontRef>
+        </p:style>
+        <p:txBody>
+          <a:bodyPr rtlCol="0" anchor="ctr"/>
+          <a:lstStyle/>
+          <a:p>
+            <a:pPr algn="ctr"/>
+          </a:p>
+        </p:txBody>
+      </p:sp>
+      <p:sp>
+        <p:nvSpPr>
+          <p:cNvPr id="3" name="Rectangle 2"/>
+          <p:cNvSpPr/>
+          <p:nvPr/>
+        </p:nvSpPr>
+        <p:spPr>
+          <a:xfrm>
+            <a:off x="0" y="0"/>
+            <a:ext cx="137160" cy="6858000"/>
+          </a:xfrm>
+          <a:prstGeom prst="rect">
+            <a:avLst/>
+          </a:prstGeom>
+          <a:solidFill>
+            <a:srgbClr val="3D5A80"/>
+          </a:solidFill>
+          <a:ln>
+            <a:noFill/>
+          </a:ln>
+        </p:spPr>
+        <p:style>
+          <a:lnRef idx="1">
+            <a:schemeClr val="accent1"/>
+          </a:lnRef>
+          <a:fillRef idx="3">
+            <a:schemeClr val="accent1"/>
+          </a:fillRef>
+          <a:effectRef idx="2">
+            <a:schemeClr val="accent1"/>
+          </a:effectRef>
+          <a:fontRef idx="minor">
+            <a:schemeClr val="lt1"/>
+          </a:fontRef>
+        </p:style>
+        <p:txBody>
+          <a:bodyPr rtlCol="0" anchor="ctr"/>
+          <a:lstStyle/>
+          <a:p>
+            <a:pPr algn="ctr"/>
+          </a:p>
+        </p:txBody>
+      </p:sp>
+      <p:sp>
+        <p:nvSpPr>
+          <p:cNvPr id="4" name="TextBox 3"/>
+          <p:cNvSpPr txBox="1"/>
+          <p:nvPr/>
+        </p:nvSpPr>
+        <p:spPr>
+          <a:xfrm>
+            <a:off x="502920" y="292608"/>
+            <a:ext cx="11155680" cy="457200"/>
+          </a:xfrm>
+          <a:prstGeom prst="rect">
+            <a:avLst/>
+          </a:prstGeom>
+          <a:noFill/>
+        </p:spPr>
+        <p:txBody>
+          <a:bodyPr wrap="none">
+            <a:spAutoFit/>
+          </a:bodyPr>
+          <a:lstStyle/>
+          <a:p>
+            <a:r>
+              <a:rPr sz="2400" b="1">
+                <a:solidFill>
+                  <a:srgbClr val="1C1C1C"/>
+                </a:solidFill>
+                <a:latin typeface="Georgia"/>
+              </a:rPr>
+              <a:t>FBref stability — status &amp; planned gate</a:t>
+            </a:r>
+          </a:p>
+        </p:txBody>
+      </p:sp>
+      <p:sp>
+        <p:nvSpPr>
+          <p:cNvPr id="5" name="TextBox 4"/>
+          <p:cNvSpPr txBox="1"/>
+          <p:nvPr/>
+        </p:nvSpPr>
+        <p:spPr>
+          <a:xfrm>
+            <a:off x="502920" y="822960"/>
+            <a:ext cx="11155680" cy="640080"/>
+          </a:xfrm>
+          <a:prstGeom prst="rect">
+            <a:avLst/>
+          </a:prstGeom>
+          <a:noFill/>
+        </p:spPr>
+        <p:txBody>
+          <a:bodyPr wrap="square">
+            <a:spAutoFit/>
+          </a:bodyPr>
+          <a:lstStyle/>
+          <a:p>
+            <a:r>
+              <a:rPr sz="1300" b="0">
+                <a:solidFill>
+                  <a:srgbClr val="555555"/>
+                </a:solidFill>
+                <a:latin typeface="Arial"/>
+              </a:rPr>
+              <a:t>FBref Tier 2 stability is not run yet (need paired prior→BL Y1 seasons at scale, target N≥500).</a:t>
+            </a:r>
+          </a:p>
+          <a:p>
+            <a:r>
+              <a:rPr sz="1300" b="0">
+                <a:solidFill>
+                  <a:srgbClr val="555555"/>
+                </a:solidFill>
+                <a:latin typeface="Arial"/>
+              </a:rPr>
+              <a:t>Same gate planned as StatsBomb deep dive: keep stats with prior→Y1 Pearson r ≥ ~0.40, then redundancy.</a:t>
+            </a:r>
+          </a:p>
+        </p:txBody>
+      </p:sp>
+      <p:graphicFrame>
+        <p:nvGraphicFramePr>
+          <p:cNvPr id="6" name="Table 5"/>
+          <p:cNvGraphicFramePr>
+            <a:graphicFrameLocks noGrp="1"/>
+          </p:cNvGraphicFramePr>
+          <p:nvPr/>
+        </p:nvGraphicFramePr>
+        <p:xfrm>
+          <a:off x="502920" y="1600200"/>
+          <a:ext cx="11155680" cy="4169664"/>
+        </p:xfrm>
+        <a:graphic>
+          <a:graphicData uri="http://schemas.openxmlformats.org/drawingml/2006/table">
+            <a:tbl>
+              <a:tblPr firstRow="1" bandRow="1">
+                <a:tableStyleId>{5C22544A-7EE6-4342-B048-85BDC9FD1C3A}</a:tableStyleId>
+              </a:tblPr>
+              <a:tblGrid>
+                <a:gridCol w="1005840"/>
+                <a:gridCol w="3108960"/>
+                <a:gridCol w="1463040"/>
+                <a:gridCol w="1645920"/>
+                <a:gridCol w="3931920"/>
+              </a:tblGrid>
+              <a:tr h="347472">
+                <a:tc>
+                  <a:txBody>
+                    <a:bodyPr/>
+                    <a:lstStyle/>
+                    <a:p>
+                      <a:r>
+                        <a:rPr sz="1100" b="1">
+                          <a:solidFill>
+                            <a:srgbClr val="FFFFFF"/>
+                          </a:solidFill>
+                          <a:latin typeface="Arial"/>
+                        </a:rPr>
+                        <a:t>Abbrev</a:t>
+                      </a:r>
+                    </a:p>
+                  </a:txBody>
+                  <a:tcPr>
+                    <a:solidFill>
+                      <a:srgbClr val="1C1C1C"/>
+                    </a:solidFill>
+                  </a:tcPr>
+                </a:tc>
+                <a:tc>
+                  <a:txBody>
+                    <a:bodyPr/>
+                    <a:lstStyle/>
+                    <a:p>
+                      <a:r>
+                        <a:rPr sz="1100" b="1">
+                          <a:solidFill>
+                            <a:srgbClr val="FFFFFF"/>
+                          </a:solidFill>
+                          <a:latin typeface="Arial"/>
+                        </a:rPr>
+                        <a:t>FBref metric (planned)</a:t>
+                      </a:r>
+                    </a:p>
+                  </a:txBody>
+                  <a:tcPr>
+                    <a:solidFill>
+                      <a:srgbClr val="1C1C1C"/>
+                    </a:solidFill>
+                  </a:tcPr>
+                </a:tc>
+                <a:tc>
+                  <a:txBody>
+                    <a:bodyPr/>
+                    <a:lstStyle/>
+                    <a:p>
+                      <a:r>
+                        <a:rPr sz="1100" b="1">
+                          <a:solidFill>
+                            <a:srgbClr val="FFFFFF"/>
+                          </a:solidFill>
+                          <a:latin typeface="Arial"/>
+                        </a:rPr>
+                        <a:t>Category</a:t>
+                      </a:r>
+                    </a:p>
+                  </a:txBody>
+                  <a:tcPr>
+                    <a:solidFill>
+                      <a:srgbClr val="1C1C1C"/>
+                    </a:solidFill>
+                  </a:tcPr>
+                </a:tc>
+                <a:tc>
+                  <a:txBody>
+                    <a:bodyPr/>
+                    <a:lstStyle/>
+                    <a:p>
+                      <a:r>
+                        <a:rPr sz="1100" b="1">
+                          <a:solidFill>
+                            <a:srgbClr val="FFFFFF"/>
+                          </a:solidFill>
+                          <a:latin typeface="Arial"/>
+                        </a:rPr>
+                        <a:t>Step 2 status</a:t>
+                      </a:r>
+                    </a:p>
+                  </a:txBody>
+                  <a:tcPr>
+                    <a:solidFill>
+                      <a:srgbClr val="1C1C1C"/>
+                    </a:solidFill>
+                  </a:tcPr>
+                </a:tc>
+                <a:tc>
+                  <a:txBody>
+                    <a:bodyPr/>
+                    <a:lstStyle/>
+                    <a:p>
+                      <a:r>
+                        <a:rPr sz="1100" b="1">
+                          <a:solidFill>
+                            <a:srgbClr val="FFFFFF"/>
+                          </a:solidFill>
+                          <a:latin typeface="Arial"/>
+                        </a:rPr>
+                        <a:t>Note</a:t>
+                      </a:r>
+                    </a:p>
+                  </a:txBody>
+                  <a:tcPr>
+                    <a:solidFill>
+                      <a:srgbClr val="1C1C1C"/>
+                    </a:solidFill>
+                  </a:tcPr>
+                </a:tc>
+              </a:tr>
+              <a:tr h="347472">
+                <a:tc>
+                  <a:txBody>
+                    <a:bodyPr/>
+                    <a:lstStyle/>
+                    <a:p>
+                      <a:r>
+                        <a:rPr sz="1100" b="1">
+                          <a:solidFill>
+                            <a:srgbClr val="1C1C1C"/>
+                          </a:solidFill>
+                          <a:latin typeface="Arial"/>
+                        </a:rPr>
+                        <a:t>PrgP</a:t>
+                      </a:r>
+                    </a:p>
+                  </a:txBody>
+                  <a:tcPr>
+                    <a:solidFill>
+                      <a:srgbClr val="F0FAF4"/>
+                    </a:solidFill>
+                  </a:tcPr>
+                </a:tc>
+                <a:tc>
+                  <a:txBody>
+                    <a:bodyPr/>
+                    <a:lstStyle/>
+                    <a:p>
+                      <a:r>
+                        <a:rPr sz="1100" b="1">
+                          <a:solidFill>
+                            <a:srgbClr val="1C1C1C"/>
+                          </a:solidFill>
+                          <a:latin typeface="Arial"/>
+                        </a:rPr>
+                        <a:t>Progressive passes</a:t>
+                      </a:r>
+                    </a:p>
+                  </a:txBody>
+                  <a:tcPr>
+                    <a:solidFill>
+                      <a:srgbClr val="F0FAF4"/>
+                    </a:solidFill>
+                  </a:tcPr>
+                </a:tc>
+                <a:tc>
+                  <a:txBody>
+                    <a:bodyPr/>
+                    <a:lstStyle/>
+                    <a:p>
+                      <a:r>
+                        <a:rPr sz="1100" b="1">
+                          <a:solidFill>
+                            <a:srgbClr val="1C1C1C"/>
+                          </a:solidFill>
+                          <a:latin typeface="Arial"/>
+                        </a:rPr>
+                        <a:t>Passing</a:t>
+                      </a:r>
+                    </a:p>
+                  </a:txBody>
+                  <a:tcPr>
+                    <a:solidFill>
+                      <a:srgbClr val="F0FAF4"/>
+                    </a:solidFill>
+                  </a:tcPr>
+                </a:tc>
+                <a:tc>
+                  <a:txBody>
+                    <a:bodyPr/>
+                    <a:lstStyle/>
+                    <a:p>
+                      <a:r>
+                        <a:rPr sz="1100" b="1">
+                          <a:solidFill>
+                            <a:srgbClr val="1C1C1C"/>
+                          </a:solidFill>
+                          <a:latin typeface="Arial"/>
+                        </a:rPr>
+                        <a:t>Planned keep</a:t>
+                      </a:r>
+                    </a:p>
+                  </a:txBody>
+                  <a:tcPr>
+                    <a:solidFill>
+                      <a:srgbClr val="F0FAF4"/>
+                    </a:solidFill>
+                  </a:tcPr>
+                </a:tc>
+                <a:tc>
+                  <a:txBody>
+                    <a:bodyPr/>
+                    <a:lstStyle/>
+                    <a:p>
+                      <a:r>
+                        <a:rPr sz="1100" b="1">
+                          <a:solidFill>
+                            <a:srgbClr val="1C1C1C"/>
+                          </a:solidFill>
+                          <a:latin typeface="Arial"/>
+                        </a:rPr>
+                        <a:t>vs Passes (cluster)</a:t>
+                      </a:r>
+                    </a:p>
+                  </a:txBody>
+                  <a:tcPr>
+                    <a:solidFill>
+                      <a:srgbClr val="F0FAF4"/>
+                    </a:solidFill>
+                  </a:tcPr>
+                </a:tc>
+              </a:tr>
+              <a:tr h="347472">
+                <a:tc>
+                  <a:txBody>
+                    <a:bodyPr/>
+                    <a:lstStyle/>
+                    <a:p>
+                      <a:r>
+                        <a:rPr sz="1100" b="0">
+                          <a:solidFill>
+                            <a:srgbClr val="1C1C1C"/>
+                          </a:solidFill>
+                          <a:latin typeface="Arial"/>
+                        </a:rPr>
+                        <a:t>Pass</a:t>
+                      </a:r>
+                    </a:p>
+                  </a:txBody>
+                  <a:tcPr>
+                    <a:solidFill>
+                      <a:srgbClr val="F5F5F5"/>
+                    </a:solidFill>
+                  </a:tcPr>
+                </a:tc>
+                <a:tc>
+                  <a:txBody>
+                    <a:bodyPr/>
+                    <a:lstStyle/>
+                    <a:p>
+                      <a:r>
+                        <a:rPr sz="1100" b="0">
+                          <a:solidFill>
+                            <a:srgbClr val="1C1C1C"/>
+                          </a:solidFill>
+                          <a:latin typeface="Arial"/>
+                        </a:rPr>
+                        <a:t>Passes</a:t>
+                      </a:r>
+                    </a:p>
+                  </a:txBody>
+                  <a:tcPr>
+                    <a:solidFill>
+                      <a:srgbClr val="F5F5F5"/>
+                    </a:solidFill>
+                  </a:tcPr>
+                </a:tc>
+                <a:tc>
+                  <a:txBody>
+                    <a:bodyPr/>
+                    <a:lstStyle/>
+                    <a:p>
+                      <a:r>
+                        <a:rPr sz="1100" b="0">
+                          <a:solidFill>
+                            <a:srgbClr val="1C1C1C"/>
+                          </a:solidFill>
+                          <a:latin typeface="Arial"/>
+                        </a:rPr>
+                        <a:t>Passing</a:t>
+                      </a:r>
+                    </a:p>
+                  </a:txBody>
+                  <a:tcPr>
+                    <a:solidFill>
+                      <a:srgbClr val="F5F5F5"/>
+                    </a:solidFill>
+                  </a:tcPr>
+                </a:tc>
+                <a:tc>
+                  <a:txBody>
+                    <a:bodyPr/>
+                    <a:lstStyle/>
+                    <a:p>
+                      <a:r>
+                        <a:rPr sz="1100" b="0">
+                          <a:solidFill>
+                            <a:srgbClr val="1C1C1C"/>
+                          </a:solidFill>
+                          <a:latin typeface="Arial"/>
+                        </a:rPr>
+                        <a:t>Planned drop</a:t>
+                      </a:r>
+                    </a:p>
+                  </a:txBody>
+                  <a:tcPr>
+                    <a:solidFill>
+                      <a:srgbClr val="F5F5F5"/>
+                    </a:solidFill>
+                  </a:tcPr>
+                </a:tc>
+                <a:tc>
+                  <a:txBody>
+                    <a:bodyPr/>
+                    <a:lstStyle/>
+                    <a:p>
+                      <a:r>
+                        <a:rPr sz="1100" b="0">
+                          <a:solidFill>
+                            <a:srgbClr val="1C1C1C"/>
+                          </a:solidFill>
+                          <a:latin typeface="Arial"/>
+                        </a:rPr>
+                        <a:t>less stable analogue</a:t>
+                      </a:r>
+                    </a:p>
+                  </a:txBody>
+                  <a:tcPr>
+                    <a:solidFill>
+                      <a:srgbClr val="F5F5F5"/>
+                    </a:solidFill>
+                  </a:tcPr>
+                </a:tc>
+              </a:tr>
+              <a:tr h="347472">
+                <a:tc>
+                  <a:txBody>
+                    <a:bodyPr/>
+                    <a:lstStyle/>
+                    <a:p>
+                      <a:r>
+                        <a:rPr sz="1100" b="1">
+                          <a:solidFill>
+                            <a:srgbClr val="1C1C1C"/>
+                          </a:solidFill>
+                          <a:latin typeface="Arial"/>
+                        </a:rPr>
+                        <a:t>Carr</a:t>
+                      </a:r>
+                    </a:p>
+                  </a:txBody>
+                  <a:tcPr>
+                    <a:solidFill>
+                      <a:srgbClr val="F0FAF4"/>
+                    </a:solidFill>
+                  </a:tcPr>
+                </a:tc>
+                <a:tc>
+                  <a:txBody>
+                    <a:bodyPr/>
+                    <a:lstStyle/>
+                    <a:p>
+                      <a:r>
+                        <a:rPr sz="1100" b="1">
+                          <a:solidFill>
+                            <a:srgbClr val="1C1C1C"/>
+                          </a:solidFill>
+                          <a:latin typeface="Arial"/>
+                        </a:rPr>
+                        <a:t>Carries</a:t>
+                      </a:r>
+                    </a:p>
+                  </a:txBody>
+                  <a:tcPr>
+                    <a:solidFill>
+                      <a:srgbClr val="F0FAF4"/>
+                    </a:solidFill>
+                  </a:tcPr>
+                </a:tc>
+                <a:tc>
+                  <a:txBody>
+                    <a:bodyPr/>
+                    <a:lstStyle/>
+                    <a:p>
+                      <a:r>
+                        <a:rPr sz="1100" b="1">
+                          <a:solidFill>
+                            <a:srgbClr val="1C1C1C"/>
+                          </a:solidFill>
+                          <a:latin typeface="Arial"/>
+                        </a:rPr>
+                        <a:t>Carrying</a:t>
+                      </a:r>
+                    </a:p>
+                  </a:txBody>
+                  <a:tcPr>
+                    <a:solidFill>
+                      <a:srgbClr val="F0FAF4"/>
+                    </a:solidFill>
+                  </a:tcPr>
+                </a:tc>
+                <a:tc>
+                  <a:txBody>
+                    <a:bodyPr/>
+                    <a:lstStyle/>
+                    <a:p>
+                      <a:r>
+                        <a:rPr sz="1100" b="1">
+                          <a:solidFill>
+                            <a:srgbClr val="1C1C1C"/>
+                          </a:solidFill>
+                          <a:latin typeface="Arial"/>
+                        </a:rPr>
+                        <a:t>Planned keep</a:t>
+                      </a:r>
+                    </a:p>
+                  </a:txBody>
+                  <a:tcPr>
+                    <a:solidFill>
+                      <a:srgbClr val="F0FAF4"/>
+                    </a:solidFill>
+                  </a:tcPr>
+                </a:tc>
+                <a:tc>
+                  <a:txBody>
+                    <a:bodyPr/>
+                    <a:lstStyle/>
+                    <a:p>
+                      <a:r>
+                        <a:rPr sz="1100" b="1">
+                          <a:solidFill>
+                            <a:srgbClr val="1C1C1C"/>
+                          </a:solidFill>
+                          <a:latin typeface="Arial"/>
+                        </a:rPr>
+                        <a:t>vs PrgC (cluster)</a:t>
+                      </a:r>
+                    </a:p>
+                  </a:txBody>
+                  <a:tcPr>
+                    <a:solidFill>
+                      <a:srgbClr val="F0FAF4"/>
+                    </a:solidFill>
+                  </a:tcPr>
+                </a:tc>
+              </a:tr>
+              <a:tr h="347472">
+                <a:tc>
+                  <a:txBody>
+                    <a:bodyPr/>
+                    <a:lstStyle/>
+                    <a:p>
+                      <a:r>
+                        <a:rPr sz="1100" b="0">
+                          <a:solidFill>
+                            <a:srgbClr val="1C1C1C"/>
+                          </a:solidFill>
+                          <a:latin typeface="Arial"/>
+                        </a:rPr>
+                        <a:t>PrgC</a:t>
+                      </a:r>
+                    </a:p>
+                  </a:txBody>
+                  <a:tcPr>
+                    <a:solidFill>
+                      <a:srgbClr val="F5F5F5"/>
+                    </a:solidFill>
+                  </a:tcPr>
+                </a:tc>
+                <a:tc>
+                  <a:txBody>
+                    <a:bodyPr/>
+                    <a:lstStyle/>
+                    <a:p>
+                      <a:r>
+                        <a:rPr sz="1100" b="0">
+                          <a:solidFill>
+                            <a:srgbClr val="1C1C1C"/>
+                          </a:solidFill>
+                          <a:latin typeface="Arial"/>
+                        </a:rPr>
+                        <a:t>Progressive carries</a:t>
+                      </a:r>
+                    </a:p>
+                  </a:txBody>
+                  <a:tcPr>
+                    <a:solidFill>
+                      <a:srgbClr val="F5F5F5"/>
+                    </a:solidFill>
+                  </a:tcPr>
+                </a:tc>
+                <a:tc>
+                  <a:txBody>
+                    <a:bodyPr/>
+                    <a:lstStyle/>
+                    <a:p>
+                      <a:r>
+                        <a:rPr sz="1100" b="0">
+                          <a:solidFill>
+                            <a:srgbClr val="1C1C1C"/>
+                          </a:solidFill>
+                          <a:latin typeface="Arial"/>
+                        </a:rPr>
+                        <a:t>Carrying</a:t>
+                      </a:r>
+                    </a:p>
+                  </a:txBody>
+                  <a:tcPr>
+                    <a:solidFill>
+                      <a:srgbClr val="F5F5F5"/>
+                    </a:solidFill>
+                  </a:tcPr>
+                </a:tc>
+                <a:tc>
+                  <a:txBody>
+                    <a:bodyPr/>
+                    <a:lstStyle/>
+                    <a:p>
+                      <a:r>
+                        <a:rPr sz="1100" b="0">
+                          <a:solidFill>
+                            <a:srgbClr val="1C1C1C"/>
+                          </a:solidFill>
+                          <a:latin typeface="Arial"/>
+                        </a:rPr>
+                        <a:t>Planned drop</a:t>
+                      </a:r>
+                    </a:p>
+                  </a:txBody>
+                  <a:tcPr>
+                    <a:solidFill>
+                      <a:srgbClr val="F5F5F5"/>
+                    </a:solidFill>
+                  </a:tcPr>
+                </a:tc>
+                <a:tc>
+                  <a:txBody>
+                    <a:bodyPr/>
+                    <a:lstStyle/>
+                    <a:p>
+                      <a:r>
+                        <a:rPr sz="1100" b="0">
+                          <a:solidFill>
+                            <a:srgbClr val="1C1C1C"/>
+                          </a:solidFill>
+                          <a:latin typeface="Arial"/>
+                        </a:rPr>
+                        <a:t>SB analogue failed r≥0.40</a:t>
+                      </a:r>
+                    </a:p>
+                  </a:txBody>
+                  <a:tcPr>
+                    <a:solidFill>
+                      <a:srgbClr val="F5F5F5"/>
+                    </a:solidFill>
+                  </a:tcPr>
+                </a:tc>
+              </a:tr>
+              <a:tr h="347472">
+                <a:tc>
+                  <a:txBody>
+                    <a:bodyPr/>
+                    <a:lstStyle/>
+                    <a:p>
+                      <a:r>
+                        <a:rPr sz="1100" b="1">
+                          <a:solidFill>
+                            <a:srgbClr val="1C1C1C"/>
+                          </a:solidFill>
+                          <a:latin typeface="Arial"/>
+                        </a:rPr>
+                        <a:t>npxG</a:t>
+                      </a:r>
+                    </a:p>
+                  </a:txBody>
+                  <a:tcPr>
+                    <a:solidFill>
+                      <a:srgbClr val="F0FAF4"/>
+                    </a:solidFill>
+                  </a:tcPr>
+                </a:tc>
+                <a:tc>
+                  <a:txBody>
+                    <a:bodyPr/>
+                    <a:lstStyle/>
+                    <a:p>
+                      <a:r>
+                        <a:rPr sz="1100" b="1">
+                          <a:solidFill>
+                            <a:srgbClr val="1C1C1C"/>
+                          </a:solidFill>
+                          <a:latin typeface="Arial"/>
+                        </a:rPr>
+                        <a:t>Non-pen xG</a:t>
+                      </a:r>
+                    </a:p>
+                  </a:txBody>
+                  <a:tcPr>
+                    <a:solidFill>
+                      <a:srgbClr val="F0FAF4"/>
+                    </a:solidFill>
+                  </a:tcPr>
+                </a:tc>
+                <a:tc>
+                  <a:txBody>
+                    <a:bodyPr/>
+                    <a:lstStyle/>
+                    <a:p>
+                      <a:r>
+                        <a:rPr sz="1100" b="1">
+                          <a:solidFill>
+                            <a:srgbClr val="1C1C1C"/>
+                          </a:solidFill>
+                          <a:latin typeface="Arial"/>
+                        </a:rPr>
+                        <a:t>Attacking</a:t>
+                      </a:r>
+                    </a:p>
+                  </a:txBody>
+                  <a:tcPr>
+                    <a:solidFill>
+                      <a:srgbClr val="F0FAF4"/>
+                    </a:solidFill>
+                  </a:tcPr>
+                </a:tc>
+                <a:tc>
+                  <a:txBody>
+                    <a:bodyPr/>
+                    <a:lstStyle/>
+                    <a:p>
+                      <a:r>
+                        <a:rPr sz="1100" b="1">
+                          <a:solidFill>
+                            <a:srgbClr val="1C1C1C"/>
+                          </a:solidFill>
+                          <a:latin typeface="Arial"/>
+                        </a:rPr>
+                        <a:t>Planned keep</a:t>
+                      </a:r>
+                    </a:p>
+                  </a:txBody>
+                  <a:tcPr>
+                    <a:solidFill>
+                      <a:srgbClr val="F0FAF4"/>
+                    </a:solidFill>
+                  </a:tcPr>
+                </a:tc>
+                <a:tc>
+                  <a:txBody>
+                    <a:bodyPr/>
+                    <a:lstStyle/>
+                    <a:p>
+                      <a:r>
+                        <a:rPr sz="1100" b="1">
+                          <a:solidFill>
+                            <a:srgbClr val="1C1C1C"/>
+                          </a:solidFill>
+                          <a:latin typeface="Arial"/>
+                        </a:rPr>
+                        <a:t>vs Shots (cluster)</a:t>
+                      </a:r>
+                    </a:p>
+                  </a:txBody>
+                  <a:tcPr>
+                    <a:solidFill>
+                      <a:srgbClr val="F0FAF4"/>
+                    </a:solidFill>
+                  </a:tcPr>
+                </a:tc>
+              </a:tr>
+              <a:tr h="347472">
+                <a:tc>
+                  <a:txBody>
+                    <a:bodyPr/>
+                    <a:lstStyle/>
+                    <a:p>
+                      <a:r>
+                        <a:rPr sz="1100" b="0">
+                          <a:solidFill>
+                            <a:srgbClr val="1C1C1C"/>
+                          </a:solidFill>
+                          <a:latin typeface="Arial"/>
+                        </a:rPr>
+                        <a:t>Sh</a:t>
+                      </a:r>
+                    </a:p>
+                  </a:txBody>
+                  <a:tcPr>
+                    <a:solidFill>
+                      <a:srgbClr val="F5F5F5"/>
+                    </a:solidFill>
+                  </a:tcPr>
+                </a:tc>
+                <a:tc>
+                  <a:txBody>
+                    <a:bodyPr/>
+                    <a:lstStyle/>
+                    <a:p>
+                      <a:r>
+                        <a:rPr sz="1100" b="0">
+                          <a:solidFill>
+                            <a:srgbClr val="1C1C1C"/>
+                          </a:solidFill>
+                          <a:latin typeface="Arial"/>
+                        </a:rPr>
+                        <a:t>Shots</a:t>
+                      </a:r>
+                    </a:p>
+                  </a:txBody>
+                  <a:tcPr>
+                    <a:solidFill>
+                      <a:srgbClr val="F5F5F5"/>
+                    </a:solidFill>
+                  </a:tcPr>
+                </a:tc>
+                <a:tc>
+                  <a:txBody>
+                    <a:bodyPr/>
+                    <a:lstStyle/>
+                    <a:p>
+                      <a:r>
+                        <a:rPr sz="1100" b="0">
+                          <a:solidFill>
+                            <a:srgbClr val="1C1C1C"/>
+                          </a:solidFill>
+                          <a:latin typeface="Arial"/>
+                        </a:rPr>
+                        <a:t>Attacking</a:t>
+                      </a:r>
+                    </a:p>
+                  </a:txBody>
+                  <a:tcPr>
+                    <a:solidFill>
+                      <a:srgbClr val="F5F5F5"/>
+                    </a:solidFill>
+                  </a:tcPr>
+                </a:tc>
+                <a:tc>
+                  <a:txBody>
+                    <a:bodyPr/>
+                    <a:lstStyle/>
+                    <a:p>
+                      <a:r>
+                        <a:rPr sz="1100" b="0">
+                          <a:solidFill>
+                            <a:srgbClr val="1C1C1C"/>
+                          </a:solidFill>
+                          <a:latin typeface="Arial"/>
+                        </a:rPr>
+                        <a:t>Planned drop</a:t>
+                      </a:r>
+                    </a:p>
+                  </a:txBody>
+                  <a:tcPr>
+                    <a:solidFill>
+                      <a:srgbClr val="F5F5F5"/>
+                    </a:solidFill>
+                  </a:tcPr>
+                </a:tc>
+                <a:tc>
+                  <a:txBody>
+                    <a:bodyPr/>
+                    <a:lstStyle/>
+                    <a:p>
+                      <a:r>
+                        <a:rPr sz="1100" b="0">
+                          <a:solidFill>
+                            <a:srgbClr val="1C1C1C"/>
+                          </a:solidFill>
+                          <a:latin typeface="Arial"/>
+                        </a:rPr>
+                        <a:t>less stable analogue</a:t>
+                      </a:r>
+                    </a:p>
+                  </a:txBody>
+                  <a:tcPr>
+                    <a:solidFill>
+                      <a:srgbClr val="F5F5F5"/>
+                    </a:solidFill>
+                  </a:tcPr>
+                </a:tc>
+              </a:tr>
+              <a:tr h="347472">
+                <a:tc>
+                  <a:txBody>
+                    <a:bodyPr/>
+                    <a:lstStyle/>
+                    <a:p>
+                      <a:r>
+                        <a:rPr sz="1100" b="1">
+                          <a:solidFill>
+                            <a:srgbClr val="1C1C1C"/>
+                          </a:solidFill>
+                          <a:latin typeface="Arial"/>
+                        </a:rPr>
+                        <a:t>SCA</a:t>
+                      </a:r>
+                    </a:p>
+                  </a:txBody>
+                  <a:tcPr>
+                    <a:solidFill>
+                      <a:srgbClr val="F0FAF4"/>
+                    </a:solidFill>
+                  </a:tcPr>
+                </a:tc>
+                <a:tc>
+                  <a:txBody>
+                    <a:bodyPr/>
+                    <a:lstStyle/>
+                    <a:p>
+                      <a:r>
+                        <a:rPr sz="1100" b="1">
+                          <a:solidFill>
+                            <a:srgbClr val="1C1C1C"/>
+                          </a:solidFill>
+                          <a:latin typeface="Arial"/>
+                        </a:rPr>
+                        <a:t>Shot-creating actions</a:t>
+                      </a:r>
+                    </a:p>
+                  </a:txBody>
+                  <a:tcPr>
+                    <a:solidFill>
+                      <a:srgbClr val="F0FAF4"/>
+                    </a:solidFill>
+                  </a:tcPr>
+                </a:tc>
+                <a:tc>
+                  <a:txBody>
+                    <a:bodyPr/>
+                    <a:lstStyle/>
+                    <a:p>
+                      <a:r>
+                        <a:rPr sz="1100" b="1">
+                          <a:solidFill>
+                            <a:srgbClr val="1C1C1C"/>
+                          </a:solidFill>
+                          <a:latin typeface="Arial"/>
+                        </a:rPr>
+                        <a:t>Attacking</a:t>
+                      </a:r>
+                    </a:p>
+                  </a:txBody>
+                  <a:tcPr>
+                    <a:solidFill>
+                      <a:srgbClr val="F0FAF4"/>
+                    </a:solidFill>
+                  </a:tcPr>
+                </a:tc>
+                <a:tc>
+                  <a:txBody>
+                    <a:bodyPr/>
+                    <a:lstStyle/>
+                    <a:p>
+                      <a:r>
+                        <a:rPr sz="1100" b="1">
+                          <a:solidFill>
+                            <a:srgbClr val="1C1C1C"/>
+                          </a:solidFill>
+                          <a:latin typeface="Arial"/>
+                        </a:rPr>
+                        <a:t>Singleton</a:t>
+                      </a:r>
+                    </a:p>
+                  </a:txBody>
+                  <a:tcPr>
+                    <a:solidFill>
+                      <a:srgbClr val="F0FAF4"/>
+                    </a:solidFill>
+                  </a:tcPr>
+                </a:tc>
+                <a:tc>
+                  <a:txBody>
+                    <a:bodyPr/>
+                    <a:lstStyle/>
+                    <a:p>
+                      <a:r>
+                        <a:rPr sz="1100" b="1">
+                          <a:solidFill>
+                            <a:srgbClr val="1C1C1C"/>
+                          </a:solidFill>
+                          <a:latin typeface="Arial"/>
+                        </a:rPr>
+                        <a:t>no high overlap</a:t>
+                      </a:r>
+                    </a:p>
+                  </a:txBody>
+                  <a:tcPr>
+                    <a:solidFill>
+                      <a:srgbClr val="F0FAF4"/>
+                    </a:solidFill>
+                  </a:tcPr>
+                </a:tc>
+              </a:tr>
+              <a:tr h="347472">
+                <a:tc>
+                  <a:txBody>
+                    <a:bodyPr/>
+                    <a:lstStyle/>
+                    <a:p>
+                      <a:r>
+                        <a:rPr sz="1100" b="1">
+                          <a:solidFill>
+                            <a:srgbClr val="1C1C1C"/>
+                          </a:solidFill>
+                          <a:latin typeface="Arial"/>
+                        </a:rPr>
+                        <a:t>Tkl</a:t>
+                      </a:r>
+                    </a:p>
+                  </a:txBody>
+                  <a:tcPr>
+                    <a:solidFill>
+                      <a:srgbClr val="F0FAF4"/>
+                    </a:solidFill>
+                  </a:tcPr>
+                </a:tc>
+                <a:tc>
+                  <a:txBody>
+                    <a:bodyPr/>
+                    <a:lstStyle/>
+                    <a:p>
+                      <a:r>
+                        <a:rPr sz="1100" b="1">
+                          <a:solidFill>
+                            <a:srgbClr val="1C1C1C"/>
+                          </a:solidFill>
+                          <a:latin typeface="Arial"/>
+                        </a:rPr>
+                        <a:t>Tackles</a:t>
+                      </a:r>
+                    </a:p>
+                  </a:txBody>
+                  <a:tcPr>
+                    <a:solidFill>
+                      <a:srgbClr val="F0FAF4"/>
+                    </a:solidFill>
+                  </a:tcPr>
+                </a:tc>
+                <a:tc>
+                  <a:txBody>
+                    <a:bodyPr/>
+                    <a:lstStyle/>
+                    <a:p>
+                      <a:r>
+                        <a:rPr sz="1100" b="1">
+                          <a:solidFill>
+                            <a:srgbClr val="1C1C1C"/>
+                          </a:solidFill>
+                          <a:latin typeface="Arial"/>
+                        </a:rPr>
+                        <a:t>Defending</a:t>
+                      </a:r>
+                    </a:p>
+                  </a:txBody>
+                  <a:tcPr>
+                    <a:solidFill>
+                      <a:srgbClr val="F0FAF4"/>
+                    </a:solidFill>
+                  </a:tcPr>
+                </a:tc>
+                <a:tc>
+                  <a:txBody>
+                    <a:bodyPr/>
+                    <a:lstStyle/>
+                    <a:p>
+                      <a:r>
+                        <a:rPr sz="1100" b="1">
+                          <a:solidFill>
+                            <a:srgbClr val="1C1C1C"/>
+                          </a:solidFill>
+                          <a:latin typeface="Arial"/>
+                        </a:rPr>
+                        <a:t>Singleton</a:t>
+                      </a:r>
+                    </a:p>
+                  </a:txBody>
+                  <a:tcPr>
+                    <a:solidFill>
+                      <a:srgbClr val="F0FAF4"/>
+                    </a:solidFill>
+                  </a:tcPr>
+                </a:tc>
+                <a:tc>
+                  <a:txBody>
+                    <a:bodyPr/>
+                    <a:lstStyle/>
+                    <a:p>
+                      <a:r>
+                        <a:rPr sz="1100" b="1">
+                          <a:solidFill>
+                            <a:srgbClr val="1C1C1C"/>
+                          </a:solidFill>
+                          <a:latin typeface="Arial"/>
+                        </a:rPr>
+                        <a:t>no high overlap</a:t>
+                      </a:r>
+                    </a:p>
+                  </a:txBody>
+                  <a:tcPr>
+                    <a:solidFill>
+                      <a:srgbClr val="F0FAF4"/>
+                    </a:solidFill>
+                  </a:tcPr>
+                </a:tc>
+              </a:tr>
+              <a:tr h="347472">
+                <a:tc>
+                  <a:txBody>
+                    <a:bodyPr/>
+                    <a:lstStyle/>
+                    <a:p>
+                      <a:r>
+                        <a:rPr sz="1100" b="1">
+                          <a:solidFill>
+                            <a:srgbClr val="1C1C1C"/>
+                          </a:solidFill>
+                          <a:latin typeface="Arial"/>
+                        </a:rPr>
+                        <a:t>Int</a:t>
+                      </a:r>
+                    </a:p>
+                  </a:txBody>
+                  <a:tcPr>
+                    <a:solidFill>
+                      <a:srgbClr val="F0FAF4"/>
+                    </a:solidFill>
+                  </a:tcPr>
+                </a:tc>
+                <a:tc>
+                  <a:txBody>
+                    <a:bodyPr/>
+                    <a:lstStyle/>
+                    <a:p>
+                      <a:r>
+                        <a:rPr sz="1100" b="1">
+                          <a:solidFill>
+                            <a:srgbClr val="1C1C1C"/>
+                          </a:solidFill>
+                          <a:latin typeface="Arial"/>
+                        </a:rPr>
+                        <a:t>Interceptions</a:t>
+                      </a:r>
+                    </a:p>
+                  </a:txBody>
+                  <a:tcPr>
+                    <a:solidFill>
+                      <a:srgbClr val="F0FAF4"/>
+                    </a:solidFill>
+                  </a:tcPr>
+                </a:tc>
+                <a:tc>
+                  <a:txBody>
+                    <a:bodyPr/>
+                    <a:lstStyle/>
+                    <a:p>
+                      <a:r>
+                        <a:rPr sz="1100" b="1">
+                          <a:solidFill>
+                            <a:srgbClr val="1C1C1C"/>
+                          </a:solidFill>
+                          <a:latin typeface="Arial"/>
+                        </a:rPr>
+                        <a:t>Defending</a:t>
+                      </a:r>
+                    </a:p>
+                  </a:txBody>
+                  <a:tcPr>
+                    <a:solidFill>
+                      <a:srgbClr val="F0FAF4"/>
+                    </a:solidFill>
+                  </a:tcPr>
+                </a:tc>
+                <a:tc>
+                  <a:txBody>
+                    <a:bodyPr/>
+                    <a:lstStyle/>
+                    <a:p>
+                      <a:r>
+                        <a:rPr sz="1100" b="1">
+                          <a:solidFill>
+                            <a:srgbClr val="1C1C1C"/>
+                          </a:solidFill>
+                          <a:latin typeface="Arial"/>
+                        </a:rPr>
+                        <a:t>Singleton</a:t>
+                      </a:r>
+                    </a:p>
+                  </a:txBody>
+                  <a:tcPr>
+                    <a:solidFill>
+                      <a:srgbClr val="F0FAF4"/>
+                    </a:solidFill>
+                  </a:tcPr>
+                </a:tc>
+                <a:tc>
+                  <a:txBody>
+                    <a:bodyPr/>
+                    <a:lstStyle/>
+                    <a:p>
+                      <a:r>
+                        <a:rPr sz="1100" b="1">
+                          <a:solidFill>
+                            <a:srgbClr val="1C1C1C"/>
+                          </a:solidFill>
+                          <a:latin typeface="Arial"/>
+                        </a:rPr>
+                        <a:t>no high overlap</a:t>
+                      </a:r>
+                    </a:p>
+                  </a:txBody>
+                  <a:tcPr>
+                    <a:solidFill>
+                      <a:srgbClr val="F0FAF4"/>
+                    </a:solidFill>
+                  </a:tcPr>
+                </a:tc>
+              </a:tr>
+              <a:tr h="347472">
+                <a:tc>
+                  <a:txBody>
+                    <a:bodyPr/>
+                    <a:lstStyle/>
+                    <a:p>
+                      <a:r>
+                        <a:rPr sz="1100" b="1">
+                          <a:solidFill>
+                            <a:srgbClr val="1C1C1C"/>
+                          </a:solidFill>
+                          <a:latin typeface="Arial"/>
+                        </a:rPr>
+                        <a:t>Aer</a:t>
+                      </a:r>
+                    </a:p>
+                  </a:txBody>
+                  <a:tcPr>
+                    <a:solidFill>
+                      <a:srgbClr val="F0FAF4"/>
+                    </a:solidFill>
+                  </a:tcPr>
+                </a:tc>
+                <a:tc>
+                  <a:txBody>
+                    <a:bodyPr/>
+                    <a:lstStyle/>
+                    <a:p>
+                      <a:r>
+                        <a:rPr sz="1100" b="1">
+                          <a:solidFill>
+                            <a:srgbClr val="1C1C1C"/>
+                          </a:solidFill>
+                          <a:latin typeface="Arial"/>
+                        </a:rPr>
+                        <a:t>Aerials won</a:t>
+                      </a:r>
+                    </a:p>
+                  </a:txBody>
+                  <a:tcPr>
+                    <a:solidFill>
+                      <a:srgbClr val="F0FAF4"/>
+                    </a:solidFill>
+                  </a:tcPr>
+                </a:tc>
+                <a:tc>
+                  <a:txBody>
+                    <a:bodyPr/>
+                    <a:lstStyle/>
+                    <a:p>
+                      <a:r>
+                        <a:rPr sz="1100" b="1">
+                          <a:solidFill>
+                            <a:srgbClr val="1C1C1C"/>
+                          </a:solidFill>
+                          <a:latin typeface="Arial"/>
+                        </a:rPr>
+                        <a:t>Defending</a:t>
+                      </a:r>
+                    </a:p>
+                  </a:txBody>
+                  <a:tcPr>
+                    <a:solidFill>
+                      <a:srgbClr val="F0FAF4"/>
+                    </a:solidFill>
+                  </a:tcPr>
+                </a:tc>
+                <a:tc>
+                  <a:txBody>
+                    <a:bodyPr/>
+                    <a:lstStyle/>
+                    <a:p>
+                      <a:r>
+                        <a:rPr sz="1100" b="1">
+                          <a:solidFill>
+                            <a:srgbClr val="1C1C1C"/>
+                          </a:solidFill>
+                          <a:latin typeface="Arial"/>
+                        </a:rPr>
+                        <a:t>Singleton</a:t>
+                      </a:r>
+                    </a:p>
+                  </a:txBody>
+                  <a:tcPr>
+                    <a:solidFill>
+                      <a:srgbClr val="F0FAF4"/>
+                    </a:solidFill>
+                  </a:tcPr>
+                </a:tc>
+                <a:tc>
+                  <a:txBody>
+                    <a:bodyPr/>
+                    <a:lstStyle/>
+                    <a:p>
+                      <a:r>
+                        <a:rPr sz="1100" b="1">
+                          <a:solidFill>
+                            <a:srgbClr val="1C1C1C"/>
+                          </a:solidFill>
+                          <a:latin typeface="Arial"/>
+                        </a:rPr>
+                        <a:t>no high overlap</a:t>
+                      </a:r>
+                    </a:p>
+                  </a:txBody>
+                  <a:tcPr>
+                    <a:solidFill>
+                      <a:srgbClr val="F0FAF4"/>
+                    </a:solidFill>
+                  </a:tcPr>
+                </a:tc>
+              </a:tr>
+              <a:tr h="347472">
+                <a:tc>
+                  <a:txBody>
+                    <a:bodyPr/>
+                    <a:lstStyle/>
+                    <a:p>
+                      <a:r>
+                        <a:rPr sz="1100" b="1">
+                          <a:solidFill>
+                            <a:srgbClr val="1C1C1C"/>
+                          </a:solidFill>
+                          <a:latin typeface="Arial"/>
+                        </a:rPr>
+                        <a:t>AttPen</a:t>
+                      </a:r>
+                    </a:p>
+                  </a:txBody>
+                  <a:tcPr>
+                    <a:solidFill>
+                      <a:srgbClr val="F0FAF4"/>
+                    </a:solidFill>
+                  </a:tcPr>
+                </a:tc>
+                <a:tc>
+                  <a:txBody>
+                    <a:bodyPr/>
+                    <a:lstStyle/>
+                    <a:p>
+                      <a:r>
+                        <a:rPr sz="1100" b="1">
+                          <a:solidFill>
+                            <a:srgbClr val="1C1C1C"/>
+                          </a:solidFill>
+                          <a:latin typeface="Arial"/>
+                        </a:rPr>
+                        <a:t>Touches in att. pen</a:t>
+                      </a:r>
+                    </a:p>
+                  </a:txBody>
+                  <a:tcPr>
+                    <a:solidFill>
+                      <a:srgbClr val="F0FAF4"/>
+                    </a:solidFill>
+                  </a:tcPr>
+                </a:tc>
+                <a:tc>
+                  <a:txBody>
+                    <a:bodyPr/>
+                    <a:lstStyle/>
+                    <a:p>
+                      <a:r>
+                        <a:rPr sz="1100" b="1">
+                          <a:solidFill>
+                            <a:srgbClr val="1C1C1C"/>
+                          </a:solidFill>
+                          <a:latin typeface="Arial"/>
+                        </a:rPr>
+                        <a:t>Attacking</a:t>
+                      </a:r>
+                    </a:p>
+                  </a:txBody>
+                  <a:tcPr>
+                    <a:solidFill>
+                      <a:srgbClr val="F0FAF4"/>
+                    </a:solidFill>
+                  </a:tcPr>
+                </a:tc>
+                <a:tc>
+                  <a:txBody>
+                    <a:bodyPr/>
+                    <a:lstStyle/>
+                    <a:p>
+                      <a:r>
+                        <a:rPr sz="1100" b="1">
+                          <a:solidFill>
+                            <a:srgbClr val="1C1C1C"/>
+                          </a:solidFill>
+                          <a:latin typeface="Arial"/>
+                        </a:rPr>
+                        <a:t>Singleton</a:t>
+                      </a:r>
+                    </a:p>
+                  </a:txBody>
+                  <a:tcPr>
+                    <a:solidFill>
+                      <a:srgbClr val="F0FAF4"/>
+                    </a:solidFill>
+                  </a:tcPr>
+                </a:tc>
+                <a:tc>
+                  <a:txBody>
+                    <a:bodyPr/>
+                    <a:lstStyle/>
+                    <a:p>
+                      <a:r>
+                        <a:rPr sz="1100" b="1">
+                          <a:solidFill>
+                            <a:srgbClr val="1C1C1C"/>
+                          </a:solidFill>
+                          <a:latin typeface="Arial"/>
+                        </a:rPr>
+                        <a:t>no high overlap</a:t>
+                      </a:r>
+                    </a:p>
+                  </a:txBody>
+                  <a:tcPr>
+                    <a:solidFill>
+                      <a:srgbClr val="F0FAF4"/>
+                    </a:solidFill>
+                  </a:tcPr>
+                </a:tc>
+              </a:tr>
+            </a:tbl>
+          </a:graphicData>
+        </a:graphic>
+      </p:graphicFrame>
+      <p:sp>
+        <p:nvSpPr>
+          <p:cNvPr id="7" name="TextBox 6"/>
+          <p:cNvSpPr txBox="1"/>
+          <p:nvPr/>
+        </p:nvSpPr>
+        <p:spPr>
+          <a:xfrm>
+            <a:off x="502920" y="5989320"/>
+            <a:ext cx="11155680" cy="548640"/>
+          </a:xfrm>
+          <a:prstGeom prst="rect">
+            <a:avLst/>
+          </a:prstGeom>
+          <a:noFill/>
+        </p:spPr>
+        <p:txBody>
+          <a:bodyPr wrap="square">
+            <a:spAutoFit/>
+          </a:bodyPr>
+          <a:lstStyle/>
+          <a:p>
+            <a:r>
+              <a:rPr sz="1200" b="0">
+                <a:solidFill>
+                  <a:srgbClr val="8A5A00"/>
+                </a:solidFill>
+                <a:latin typeface="Arial"/>
+              </a:rPr>
+              <a:t>When FBref freeze lands: replace this table with real prior→Y1 stability r’s (same layout as the StatsBomb stability slide).</a:t>
+            </a:r>
+          </a:p>
+          <a:p>
+            <a:r>
+              <a:rPr sz="1200" b="0">
+                <a:solidFill>
+                  <a:srgbClr val="555555"/>
+                </a:solidFill>
+                <a:latin typeface="Arial"/>
+              </a:rPr>
+              <a:t>Until then: StatsBomb N=60 is the live stability evidence; FBref picks above are Step-2 plans guided by SB analogues.</a:t>
+            </a:r>
+          </a:p>
+        </p:txBody>
+      </p:sp>
+    </p:spTree>
+  </p:cSld>
+  <p:clrMapOvr>
+    <a:masterClrMapping/>
+  </p:clrMapOvr>
+</p:sld>
+</file>
+
+<file path=ppt/slides/slide6.xml><?xml version="1.0" encoding="utf-8"?>
 <p:sld xmlns:a="http://schemas.openxmlformats.org/drawingml/2006/main" xmlns:p="http://schemas.openxmlformats.org/presentationml/2006/main" xmlns:r="http://schemas.openxmlformats.org/officeDocument/2006/relationships">
   <p:cSld>
     <p:spTree>
@@ -6492,7 +8093,7 @@
 </p:sld>
 </file>
 
-<file path=ppt/slides/slide6.xml><?xml version="1.0" encoding="utf-8"?>
+<file path=ppt/slides/slide7.xml><?xml version="1.0" encoding="utf-8"?>
 <p:sld xmlns:a="http://schemas.openxmlformats.org/drawingml/2006/main" xmlns:p="http://schemas.openxmlformats.org/presentationml/2006/main" xmlns:r="http://schemas.openxmlformats.org/officeDocument/2006/relationships">
   <p:cSld>
     <p:spTree>
@@ -7345,7 +8946,7 @@
 </p:sld>
 </file>
 
-<file path=ppt/slides/slide7.xml><?xml version="1.0" encoding="utf-8"?>
+<file path=ppt/slides/slide8.xml><?xml version="1.0" encoding="utf-8"?>
 <p:sld xmlns:a="http://schemas.openxmlformats.org/drawingml/2006/main" xmlns:p="http://schemas.openxmlformats.org/presentationml/2006/main" xmlns:r="http://schemas.openxmlformats.org/officeDocument/2006/relationships">
   <p:cSld>
     <p:spTree>
@@ -7611,7 +9212,7 @@
 </p:sld>
 </file>
 
-<file path=ppt/slides/slide8.xml><?xml version="1.0" encoding="utf-8"?>
+<file path=ppt/slides/slide9.xml><?xml version="1.0" encoding="utf-8"?>
 <p:sld xmlns:a="http://schemas.openxmlformats.org/drawingml/2006/main" xmlns:p="http://schemas.openxmlformats.org/presentationml/2006/main" xmlns:r="http://schemas.openxmlformats.org/officeDocument/2006/relationships">
   <p:cSld>
     <p:spTree>
@@ -7947,1607 +9548,6 @@
               <a:t>interactive_player_explorer.html — dropdown by position + pizza
 cohort_data.json — open-data stress-test cohort
 projectproposal.txt — editable source for the Word doc</a:t>
-            </a:r>
-          </a:p>
-        </p:txBody>
-      </p:sp>
-    </p:spTree>
-  </p:cSld>
-  <p:clrMapOvr>
-    <a:masterClrMapping/>
-  </p:clrMapOvr>
-</p:sld>
-</file>
-
-<file path=ppt/slides/slide9.xml><?xml version="1.0" encoding="utf-8"?>
-<p:sld xmlns:a="http://schemas.openxmlformats.org/drawingml/2006/main" xmlns:p="http://schemas.openxmlformats.org/presentationml/2006/main" xmlns:r="http://schemas.openxmlformats.org/officeDocument/2006/relationships">
-  <p:cSld>
-    <p:spTree>
-      <p:nvGrpSpPr>
-        <p:cNvPr id="1" name=""/>
-        <p:cNvGrpSpPr/>
-        <p:nvPr/>
-      </p:nvGrpSpPr>
-      <p:grpSpPr/>
-      <p:sp>
-        <p:nvSpPr>
-          <p:cNvPr id="2" name="Rectangle 1"/>
-          <p:cNvSpPr/>
-          <p:nvPr/>
-        </p:nvSpPr>
-        <p:spPr>
-          <a:xfrm>
-            <a:off x="0" y="0"/>
-            <a:ext cx="12191695" cy="6858000"/>
-          </a:xfrm>
-          <a:prstGeom prst="rect">
-            <a:avLst/>
-          </a:prstGeom>
-          <a:solidFill>
-            <a:srgbClr val="F4F5F7"/>
-          </a:solidFill>
-          <a:ln>
-            <a:noFill/>
-          </a:ln>
-        </p:spPr>
-        <p:style>
-          <a:lnRef idx="1">
-            <a:schemeClr val="accent1"/>
-          </a:lnRef>
-          <a:fillRef idx="3">
-            <a:schemeClr val="accent1"/>
-          </a:fillRef>
-          <a:effectRef idx="2">
-            <a:schemeClr val="accent1"/>
-          </a:effectRef>
-          <a:fontRef idx="minor">
-            <a:schemeClr val="lt1"/>
-          </a:fontRef>
-        </p:style>
-        <p:txBody>
-          <a:bodyPr rtlCol="0" anchor="ctr"/>
-          <a:lstStyle/>
-          <a:p>
-            <a:pPr algn="ctr"/>
-          </a:p>
-        </p:txBody>
-      </p:sp>
-      <p:sp>
-        <p:nvSpPr>
-          <p:cNvPr id="3" name="Rectangle 2"/>
-          <p:cNvSpPr/>
-          <p:nvPr/>
-        </p:nvSpPr>
-        <p:spPr>
-          <a:xfrm>
-            <a:off x="0" y="0"/>
-            <a:ext cx="137160" cy="6858000"/>
-          </a:xfrm>
-          <a:prstGeom prst="rect">
-            <a:avLst/>
-          </a:prstGeom>
-          <a:solidFill>
-            <a:srgbClr val="3D5A80"/>
-          </a:solidFill>
-          <a:ln>
-            <a:noFill/>
-          </a:ln>
-        </p:spPr>
-        <p:style>
-          <a:lnRef idx="1">
-            <a:schemeClr val="accent1"/>
-          </a:lnRef>
-          <a:fillRef idx="3">
-            <a:schemeClr val="accent1"/>
-          </a:fillRef>
-          <a:effectRef idx="2">
-            <a:schemeClr val="accent1"/>
-          </a:effectRef>
-          <a:fontRef idx="minor">
-            <a:schemeClr val="lt1"/>
-          </a:fontRef>
-        </p:style>
-        <p:txBody>
-          <a:bodyPr rtlCol="0" anchor="ctr"/>
-          <a:lstStyle/>
-          <a:p>
-            <a:pPr algn="ctr"/>
-          </a:p>
-        </p:txBody>
-      </p:sp>
-      <p:sp>
-        <p:nvSpPr>
-          <p:cNvPr id="4" name="TextBox 3"/>
-          <p:cNvSpPr txBox="1"/>
-          <p:nvPr/>
-        </p:nvSpPr>
-        <p:spPr>
-          <a:xfrm>
-            <a:off x="502920" y="292608"/>
-            <a:ext cx="11155680" cy="457200"/>
-          </a:xfrm>
-          <a:prstGeom prst="rect">
-            <a:avLst/>
-          </a:prstGeom>
-          <a:noFill/>
-        </p:spPr>
-        <p:txBody>
-          <a:bodyPr wrap="none">
-            <a:spAutoFit/>
-          </a:bodyPr>
-          <a:lstStyle/>
-          <a:p>
-            <a:r>
-              <a:rPr sz="2400" b="1">
-                <a:solidFill>
-                  <a:srgbClr val="1C1C1C"/>
-                </a:solidFill>
-                <a:latin typeface="Georgia"/>
-              </a:rPr>
-              <a:t>FBref stability — status &amp; planned gate</a:t>
-            </a:r>
-          </a:p>
-        </p:txBody>
-      </p:sp>
-      <p:sp>
-        <p:nvSpPr>
-          <p:cNvPr id="5" name="TextBox 4"/>
-          <p:cNvSpPr txBox="1"/>
-          <p:nvPr/>
-        </p:nvSpPr>
-        <p:spPr>
-          <a:xfrm>
-            <a:off x="502920" y="822960"/>
-            <a:ext cx="11155680" cy="640080"/>
-          </a:xfrm>
-          <a:prstGeom prst="rect">
-            <a:avLst/>
-          </a:prstGeom>
-          <a:noFill/>
-        </p:spPr>
-        <p:txBody>
-          <a:bodyPr wrap="square">
-            <a:spAutoFit/>
-          </a:bodyPr>
-          <a:lstStyle/>
-          <a:p>
-            <a:r>
-              <a:rPr sz="1300" b="0">
-                <a:solidFill>
-                  <a:srgbClr val="555555"/>
-                </a:solidFill>
-                <a:latin typeface="Arial"/>
-              </a:rPr>
-              <a:t>FBref Tier 2 stability is not run yet (need paired prior→BL Y1 seasons at scale, target N≥500).</a:t>
-            </a:r>
-          </a:p>
-          <a:p>
-            <a:r>
-              <a:rPr sz="1300" b="0">
-                <a:solidFill>
-                  <a:srgbClr val="555555"/>
-                </a:solidFill>
-                <a:latin typeface="Arial"/>
-              </a:rPr>
-              <a:t>Same gate planned as StatsBomb deep dive: keep stats with prior→Y1 Pearson r ≥ ~0.40, then redundancy.</a:t>
-            </a:r>
-          </a:p>
-        </p:txBody>
-      </p:sp>
-      <p:graphicFrame>
-        <p:nvGraphicFramePr>
-          <p:cNvPr id="6" name="Table 5"/>
-          <p:cNvGraphicFramePr>
-            <a:graphicFrameLocks noGrp="1"/>
-          </p:cNvGraphicFramePr>
-          <p:nvPr/>
-        </p:nvGraphicFramePr>
-        <p:xfrm>
-          <a:off x="502920" y="1600200"/>
-          <a:ext cx="11155680" cy="4169664"/>
-        </p:xfrm>
-        <a:graphic>
-          <a:graphicData uri="http://schemas.openxmlformats.org/drawingml/2006/table">
-            <a:tbl>
-              <a:tblPr firstRow="1" bandRow="1">
-                <a:tableStyleId>{5C22544A-7EE6-4342-B048-85BDC9FD1C3A}</a:tableStyleId>
-              </a:tblPr>
-              <a:tblGrid>
-                <a:gridCol w="1005840"/>
-                <a:gridCol w="3108960"/>
-                <a:gridCol w="1463040"/>
-                <a:gridCol w="1645920"/>
-                <a:gridCol w="3931920"/>
-              </a:tblGrid>
-              <a:tr h="347472">
-                <a:tc>
-                  <a:txBody>
-                    <a:bodyPr/>
-                    <a:lstStyle/>
-                    <a:p>
-                      <a:r>
-                        <a:rPr sz="1100" b="1">
-                          <a:solidFill>
-                            <a:srgbClr val="FFFFFF"/>
-                          </a:solidFill>
-                          <a:latin typeface="Arial"/>
-                        </a:rPr>
-                        <a:t>Abbrev</a:t>
-                      </a:r>
-                    </a:p>
-                  </a:txBody>
-                  <a:tcPr>
-                    <a:solidFill>
-                      <a:srgbClr val="1C1C1C"/>
-                    </a:solidFill>
-                  </a:tcPr>
-                </a:tc>
-                <a:tc>
-                  <a:txBody>
-                    <a:bodyPr/>
-                    <a:lstStyle/>
-                    <a:p>
-                      <a:r>
-                        <a:rPr sz="1100" b="1">
-                          <a:solidFill>
-                            <a:srgbClr val="FFFFFF"/>
-                          </a:solidFill>
-                          <a:latin typeface="Arial"/>
-                        </a:rPr>
-                        <a:t>FBref metric (planned)</a:t>
-                      </a:r>
-                    </a:p>
-                  </a:txBody>
-                  <a:tcPr>
-                    <a:solidFill>
-                      <a:srgbClr val="1C1C1C"/>
-                    </a:solidFill>
-                  </a:tcPr>
-                </a:tc>
-                <a:tc>
-                  <a:txBody>
-                    <a:bodyPr/>
-                    <a:lstStyle/>
-                    <a:p>
-                      <a:r>
-                        <a:rPr sz="1100" b="1">
-                          <a:solidFill>
-                            <a:srgbClr val="FFFFFF"/>
-                          </a:solidFill>
-                          <a:latin typeface="Arial"/>
-                        </a:rPr>
-                        <a:t>Category</a:t>
-                      </a:r>
-                    </a:p>
-                  </a:txBody>
-                  <a:tcPr>
-                    <a:solidFill>
-                      <a:srgbClr val="1C1C1C"/>
-                    </a:solidFill>
-                  </a:tcPr>
-                </a:tc>
-                <a:tc>
-                  <a:txBody>
-                    <a:bodyPr/>
-                    <a:lstStyle/>
-                    <a:p>
-                      <a:r>
-                        <a:rPr sz="1100" b="1">
-                          <a:solidFill>
-                            <a:srgbClr val="FFFFFF"/>
-                          </a:solidFill>
-                          <a:latin typeface="Arial"/>
-                        </a:rPr>
-                        <a:t>Step 2 status</a:t>
-                      </a:r>
-                    </a:p>
-                  </a:txBody>
-                  <a:tcPr>
-                    <a:solidFill>
-                      <a:srgbClr val="1C1C1C"/>
-                    </a:solidFill>
-                  </a:tcPr>
-                </a:tc>
-                <a:tc>
-                  <a:txBody>
-                    <a:bodyPr/>
-                    <a:lstStyle/>
-                    <a:p>
-                      <a:r>
-                        <a:rPr sz="1100" b="1">
-                          <a:solidFill>
-                            <a:srgbClr val="FFFFFF"/>
-                          </a:solidFill>
-                          <a:latin typeface="Arial"/>
-                        </a:rPr>
-                        <a:t>Note</a:t>
-                      </a:r>
-                    </a:p>
-                  </a:txBody>
-                  <a:tcPr>
-                    <a:solidFill>
-                      <a:srgbClr val="1C1C1C"/>
-                    </a:solidFill>
-                  </a:tcPr>
-                </a:tc>
-              </a:tr>
-              <a:tr h="347472">
-                <a:tc>
-                  <a:txBody>
-                    <a:bodyPr/>
-                    <a:lstStyle/>
-                    <a:p>
-                      <a:r>
-                        <a:rPr sz="1100" b="1">
-                          <a:solidFill>
-                            <a:srgbClr val="1C1C1C"/>
-                          </a:solidFill>
-                          <a:latin typeface="Arial"/>
-                        </a:rPr>
-                        <a:t>PrgP</a:t>
-                      </a:r>
-                    </a:p>
-                  </a:txBody>
-                  <a:tcPr>
-                    <a:solidFill>
-                      <a:srgbClr val="F0FAF4"/>
-                    </a:solidFill>
-                  </a:tcPr>
-                </a:tc>
-                <a:tc>
-                  <a:txBody>
-                    <a:bodyPr/>
-                    <a:lstStyle/>
-                    <a:p>
-                      <a:r>
-                        <a:rPr sz="1100" b="1">
-                          <a:solidFill>
-                            <a:srgbClr val="1C1C1C"/>
-                          </a:solidFill>
-                          <a:latin typeface="Arial"/>
-                        </a:rPr>
-                        <a:t>Progressive passes</a:t>
-                      </a:r>
-                    </a:p>
-                  </a:txBody>
-                  <a:tcPr>
-                    <a:solidFill>
-                      <a:srgbClr val="F0FAF4"/>
-                    </a:solidFill>
-                  </a:tcPr>
-                </a:tc>
-                <a:tc>
-                  <a:txBody>
-                    <a:bodyPr/>
-                    <a:lstStyle/>
-                    <a:p>
-                      <a:r>
-                        <a:rPr sz="1100" b="1">
-                          <a:solidFill>
-                            <a:srgbClr val="1C1C1C"/>
-                          </a:solidFill>
-                          <a:latin typeface="Arial"/>
-                        </a:rPr>
-                        <a:t>Passing</a:t>
-                      </a:r>
-                    </a:p>
-                  </a:txBody>
-                  <a:tcPr>
-                    <a:solidFill>
-                      <a:srgbClr val="F0FAF4"/>
-                    </a:solidFill>
-                  </a:tcPr>
-                </a:tc>
-                <a:tc>
-                  <a:txBody>
-                    <a:bodyPr/>
-                    <a:lstStyle/>
-                    <a:p>
-                      <a:r>
-                        <a:rPr sz="1100" b="1">
-                          <a:solidFill>
-                            <a:srgbClr val="1C1C1C"/>
-                          </a:solidFill>
-                          <a:latin typeface="Arial"/>
-                        </a:rPr>
-                        <a:t>Planned keep</a:t>
-                      </a:r>
-                    </a:p>
-                  </a:txBody>
-                  <a:tcPr>
-                    <a:solidFill>
-                      <a:srgbClr val="F0FAF4"/>
-                    </a:solidFill>
-                  </a:tcPr>
-                </a:tc>
-                <a:tc>
-                  <a:txBody>
-                    <a:bodyPr/>
-                    <a:lstStyle/>
-                    <a:p>
-                      <a:r>
-                        <a:rPr sz="1100" b="1">
-                          <a:solidFill>
-                            <a:srgbClr val="1C1C1C"/>
-                          </a:solidFill>
-                          <a:latin typeface="Arial"/>
-                        </a:rPr>
-                        <a:t>vs Passes (cluster)</a:t>
-                      </a:r>
-                    </a:p>
-                  </a:txBody>
-                  <a:tcPr>
-                    <a:solidFill>
-                      <a:srgbClr val="F0FAF4"/>
-                    </a:solidFill>
-                  </a:tcPr>
-                </a:tc>
-              </a:tr>
-              <a:tr h="347472">
-                <a:tc>
-                  <a:txBody>
-                    <a:bodyPr/>
-                    <a:lstStyle/>
-                    <a:p>
-                      <a:r>
-                        <a:rPr sz="1100" b="0">
-                          <a:solidFill>
-                            <a:srgbClr val="1C1C1C"/>
-                          </a:solidFill>
-                          <a:latin typeface="Arial"/>
-                        </a:rPr>
-                        <a:t>Pass</a:t>
-                      </a:r>
-                    </a:p>
-                  </a:txBody>
-                  <a:tcPr>
-                    <a:solidFill>
-                      <a:srgbClr val="F5F5F5"/>
-                    </a:solidFill>
-                  </a:tcPr>
-                </a:tc>
-                <a:tc>
-                  <a:txBody>
-                    <a:bodyPr/>
-                    <a:lstStyle/>
-                    <a:p>
-                      <a:r>
-                        <a:rPr sz="1100" b="0">
-                          <a:solidFill>
-                            <a:srgbClr val="1C1C1C"/>
-                          </a:solidFill>
-                          <a:latin typeface="Arial"/>
-                        </a:rPr>
-                        <a:t>Passes</a:t>
-                      </a:r>
-                    </a:p>
-                  </a:txBody>
-                  <a:tcPr>
-                    <a:solidFill>
-                      <a:srgbClr val="F5F5F5"/>
-                    </a:solidFill>
-                  </a:tcPr>
-                </a:tc>
-                <a:tc>
-                  <a:txBody>
-                    <a:bodyPr/>
-                    <a:lstStyle/>
-                    <a:p>
-                      <a:r>
-                        <a:rPr sz="1100" b="0">
-                          <a:solidFill>
-                            <a:srgbClr val="1C1C1C"/>
-                          </a:solidFill>
-                          <a:latin typeface="Arial"/>
-                        </a:rPr>
-                        <a:t>Passing</a:t>
-                      </a:r>
-                    </a:p>
-                  </a:txBody>
-                  <a:tcPr>
-                    <a:solidFill>
-                      <a:srgbClr val="F5F5F5"/>
-                    </a:solidFill>
-                  </a:tcPr>
-                </a:tc>
-                <a:tc>
-                  <a:txBody>
-                    <a:bodyPr/>
-                    <a:lstStyle/>
-                    <a:p>
-                      <a:r>
-                        <a:rPr sz="1100" b="0">
-                          <a:solidFill>
-                            <a:srgbClr val="1C1C1C"/>
-                          </a:solidFill>
-                          <a:latin typeface="Arial"/>
-                        </a:rPr>
-                        <a:t>Planned drop</a:t>
-                      </a:r>
-                    </a:p>
-                  </a:txBody>
-                  <a:tcPr>
-                    <a:solidFill>
-                      <a:srgbClr val="F5F5F5"/>
-                    </a:solidFill>
-                  </a:tcPr>
-                </a:tc>
-                <a:tc>
-                  <a:txBody>
-                    <a:bodyPr/>
-                    <a:lstStyle/>
-                    <a:p>
-                      <a:r>
-                        <a:rPr sz="1100" b="0">
-                          <a:solidFill>
-                            <a:srgbClr val="1C1C1C"/>
-                          </a:solidFill>
-                          <a:latin typeface="Arial"/>
-                        </a:rPr>
-                        <a:t>less stable analogue</a:t>
-                      </a:r>
-                    </a:p>
-                  </a:txBody>
-                  <a:tcPr>
-                    <a:solidFill>
-                      <a:srgbClr val="F5F5F5"/>
-                    </a:solidFill>
-                  </a:tcPr>
-                </a:tc>
-              </a:tr>
-              <a:tr h="347472">
-                <a:tc>
-                  <a:txBody>
-                    <a:bodyPr/>
-                    <a:lstStyle/>
-                    <a:p>
-                      <a:r>
-                        <a:rPr sz="1100" b="1">
-                          <a:solidFill>
-                            <a:srgbClr val="1C1C1C"/>
-                          </a:solidFill>
-                          <a:latin typeface="Arial"/>
-                        </a:rPr>
-                        <a:t>Carr</a:t>
-                      </a:r>
-                    </a:p>
-                  </a:txBody>
-                  <a:tcPr>
-                    <a:solidFill>
-                      <a:srgbClr val="F0FAF4"/>
-                    </a:solidFill>
-                  </a:tcPr>
-                </a:tc>
-                <a:tc>
-                  <a:txBody>
-                    <a:bodyPr/>
-                    <a:lstStyle/>
-                    <a:p>
-                      <a:r>
-                        <a:rPr sz="1100" b="1">
-                          <a:solidFill>
-                            <a:srgbClr val="1C1C1C"/>
-                          </a:solidFill>
-                          <a:latin typeface="Arial"/>
-                        </a:rPr>
-                        <a:t>Carries</a:t>
-                      </a:r>
-                    </a:p>
-                  </a:txBody>
-                  <a:tcPr>
-                    <a:solidFill>
-                      <a:srgbClr val="F0FAF4"/>
-                    </a:solidFill>
-                  </a:tcPr>
-                </a:tc>
-                <a:tc>
-                  <a:txBody>
-                    <a:bodyPr/>
-                    <a:lstStyle/>
-                    <a:p>
-                      <a:r>
-                        <a:rPr sz="1100" b="1">
-                          <a:solidFill>
-                            <a:srgbClr val="1C1C1C"/>
-                          </a:solidFill>
-                          <a:latin typeface="Arial"/>
-                        </a:rPr>
-                        <a:t>Carrying</a:t>
-                      </a:r>
-                    </a:p>
-                  </a:txBody>
-                  <a:tcPr>
-                    <a:solidFill>
-                      <a:srgbClr val="F0FAF4"/>
-                    </a:solidFill>
-                  </a:tcPr>
-                </a:tc>
-                <a:tc>
-                  <a:txBody>
-                    <a:bodyPr/>
-                    <a:lstStyle/>
-                    <a:p>
-                      <a:r>
-                        <a:rPr sz="1100" b="1">
-                          <a:solidFill>
-                            <a:srgbClr val="1C1C1C"/>
-                          </a:solidFill>
-                          <a:latin typeface="Arial"/>
-                        </a:rPr>
-                        <a:t>Planned keep</a:t>
-                      </a:r>
-                    </a:p>
-                  </a:txBody>
-                  <a:tcPr>
-                    <a:solidFill>
-                      <a:srgbClr val="F0FAF4"/>
-                    </a:solidFill>
-                  </a:tcPr>
-                </a:tc>
-                <a:tc>
-                  <a:txBody>
-                    <a:bodyPr/>
-                    <a:lstStyle/>
-                    <a:p>
-                      <a:r>
-                        <a:rPr sz="1100" b="1">
-                          <a:solidFill>
-                            <a:srgbClr val="1C1C1C"/>
-                          </a:solidFill>
-                          <a:latin typeface="Arial"/>
-                        </a:rPr>
-                        <a:t>vs PrgC (cluster)</a:t>
-                      </a:r>
-                    </a:p>
-                  </a:txBody>
-                  <a:tcPr>
-                    <a:solidFill>
-                      <a:srgbClr val="F0FAF4"/>
-                    </a:solidFill>
-                  </a:tcPr>
-                </a:tc>
-              </a:tr>
-              <a:tr h="347472">
-                <a:tc>
-                  <a:txBody>
-                    <a:bodyPr/>
-                    <a:lstStyle/>
-                    <a:p>
-                      <a:r>
-                        <a:rPr sz="1100" b="0">
-                          <a:solidFill>
-                            <a:srgbClr val="1C1C1C"/>
-                          </a:solidFill>
-                          <a:latin typeface="Arial"/>
-                        </a:rPr>
-                        <a:t>PrgC</a:t>
-                      </a:r>
-                    </a:p>
-                  </a:txBody>
-                  <a:tcPr>
-                    <a:solidFill>
-                      <a:srgbClr val="F5F5F5"/>
-                    </a:solidFill>
-                  </a:tcPr>
-                </a:tc>
-                <a:tc>
-                  <a:txBody>
-                    <a:bodyPr/>
-                    <a:lstStyle/>
-                    <a:p>
-                      <a:r>
-                        <a:rPr sz="1100" b="0">
-                          <a:solidFill>
-                            <a:srgbClr val="1C1C1C"/>
-                          </a:solidFill>
-                          <a:latin typeface="Arial"/>
-                        </a:rPr>
-                        <a:t>Progressive carries</a:t>
-                      </a:r>
-                    </a:p>
-                  </a:txBody>
-                  <a:tcPr>
-                    <a:solidFill>
-                      <a:srgbClr val="F5F5F5"/>
-                    </a:solidFill>
-                  </a:tcPr>
-                </a:tc>
-                <a:tc>
-                  <a:txBody>
-                    <a:bodyPr/>
-                    <a:lstStyle/>
-                    <a:p>
-                      <a:r>
-                        <a:rPr sz="1100" b="0">
-                          <a:solidFill>
-                            <a:srgbClr val="1C1C1C"/>
-                          </a:solidFill>
-                          <a:latin typeface="Arial"/>
-                        </a:rPr>
-                        <a:t>Carrying</a:t>
-                      </a:r>
-                    </a:p>
-                  </a:txBody>
-                  <a:tcPr>
-                    <a:solidFill>
-                      <a:srgbClr val="F5F5F5"/>
-                    </a:solidFill>
-                  </a:tcPr>
-                </a:tc>
-                <a:tc>
-                  <a:txBody>
-                    <a:bodyPr/>
-                    <a:lstStyle/>
-                    <a:p>
-                      <a:r>
-                        <a:rPr sz="1100" b="0">
-                          <a:solidFill>
-                            <a:srgbClr val="1C1C1C"/>
-                          </a:solidFill>
-                          <a:latin typeface="Arial"/>
-                        </a:rPr>
-                        <a:t>Planned drop</a:t>
-                      </a:r>
-                    </a:p>
-                  </a:txBody>
-                  <a:tcPr>
-                    <a:solidFill>
-                      <a:srgbClr val="F5F5F5"/>
-                    </a:solidFill>
-                  </a:tcPr>
-                </a:tc>
-                <a:tc>
-                  <a:txBody>
-                    <a:bodyPr/>
-                    <a:lstStyle/>
-                    <a:p>
-                      <a:r>
-                        <a:rPr sz="1100" b="0">
-                          <a:solidFill>
-                            <a:srgbClr val="1C1C1C"/>
-                          </a:solidFill>
-                          <a:latin typeface="Arial"/>
-                        </a:rPr>
-                        <a:t>SB analogue failed r≥0.40</a:t>
-                      </a:r>
-                    </a:p>
-                  </a:txBody>
-                  <a:tcPr>
-                    <a:solidFill>
-                      <a:srgbClr val="F5F5F5"/>
-                    </a:solidFill>
-                  </a:tcPr>
-                </a:tc>
-              </a:tr>
-              <a:tr h="347472">
-                <a:tc>
-                  <a:txBody>
-                    <a:bodyPr/>
-                    <a:lstStyle/>
-                    <a:p>
-                      <a:r>
-                        <a:rPr sz="1100" b="1">
-                          <a:solidFill>
-                            <a:srgbClr val="1C1C1C"/>
-                          </a:solidFill>
-                          <a:latin typeface="Arial"/>
-                        </a:rPr>
-                        <a:t>npxG</a:t>
-                      </a:r>
-                    </a:p>
-                  </a:txBody>
-                  <a:tcPr>
-                    <a:solidFill>
-                      <a:srgbClr val="F0FAF4"/>
-                    </a:solidFill>
-                  </a:tcPr>
-                </a:tc>
-                <a:tc>
-                  <a:txBody>
-                    <a:bodyPr/>
-                    <a:lstStyle/>
-                    <a:p>
-                      <a:r>
-                        <a:rPr sz="1100" b="1">
-                          <a:solidFill>
-                            <a:srgbClr val="1C1C1C"/>
-                          </a:solidFill>
-                          <a:latin typeface="Arial"/>
-                        </a:rPr>
-                        <a:t>Non-pen xG</a:t>
-                      </a:r>
-                    </a:p>
-                  </a:txBody>
-                  <a:tcPr>
-                    <a:solidFill>
-                      <a:srgbClr val="F0FAF4"/>
-                    </a:solidFill>
-                  </a:tcPr>
-                </a:tc>
-                <a:tc>
-                  <a:txBody>
-                    <a:bodyPr/>
-                    <a:lstStyle/>
-                    <a:p>
-                      <a:r>
-                        <a:rPr sz="1100" b="1">
-                          <a:solidFill>
-                            <a:srgbClr val="1C1C1C"/>
-                          </a:solidFill>
-                          <a:latin typeface="Arial"/>
-                        </a:rPr>
-                        <a:t>Attacking</a:t>
-                      </a:r>
-                    </a:p>
-                  </a:txBody>
-                  <a:tcPr>
-                    <a:solidFill>
-                      <a:srgbClr val="F0FAF4"/>
-                    </a:solidFill>
-                  </a:tcPr>
-                </a:tc>
-                <a:tc>
-                  <a:txBody>
-                    <a:bodyPr/>
-                    <a:lstStyle/>
-                    <a:p>
-                      <a:r>
-                        <a:rPr sz="1100" b="1">
-                          <a:solidFill>
-                            <a:srgbClr val="1C1C1C"/>
-                          </a:solidFill>
-                          <a:latin typeface="Arial"/>
-                        </a:rPr>
-                        <a:t>Planned keep</a:t>
-                      </a:r>
-                    </a:p>
-                  </a:txBody>
-                  <a:tcPr>
-                    <a:solidFill>
-                      <a:srgbClr val="F0FAF4"/>
-                    </a:solidFill>
-                  </a:tcPr>
-                </a:tc>
-                <a:tc>
-                  <a:txBody>
-                    <a:bodyPr/>
-                    <a:lstStyle/>
-                    <a:p>
-                      <a:r>
-                        <a:rPr sz="1100" b="1">
-                          <a:solidFill>
-                            <a:srgbClr val="1C1C1C"/>
-                          </a:solidFill>
-                          <a:latin typeface="Arial"/>
-                        </a:rPr>
-                        <a:t>vs Shots (cluster)</a:t>
-                      </a:r>
-                    </a:p>
-                  </a:txBody>
-                  <a:tcPr>
-                    <a:solidFill>
-                      <a:srgbClr val="F0FAF4"/>
-                    </a:solidFill>
-                  </a:tcPr>
-                </a:tc>
-              </a:tr>
-              <a:tr h="347472">
-                <a:tc>
-                  <a:txBody>
-                    <a:bodyPr/>
-                    <a:lstStyle/>
-                    <a:p>
-                      <a:r>
-                        <a:rPr sz="1100" b="0">
-                          <a:solidFill>
-                            <a:srgbClr val="1C1C1C"/>
-                          </a:solidFill>
-                          <a:latin typeface="Arial"/>
-                        </a:rPr>
-                        <a:t>Sh</a:t>
-                      </a:r>
-                    </a:p>
-                  </a:txBody>
-                  <a:tcPr>
-                    <a:solidFill>
-                      <a:srgbClr val="F5F5F5"/>
-                    </a:solidFill>
-                  </a:tcPr>
-                </a:tc>
-                <a:tc>
-                  <a:txBody>
-                    <a:bodyPr/>
-                    <a:lstStyle/>
-                    <a:p>
-                      <a:r>
-                        <a:rPr sz="1100" b="0">
-                          <a:solidFill>
-                            <a:srgbClr val="1C1C1C"/>
-                          </a:solidFill>
-                          <a:latin typeface="Arial"/>
-                        </a:rPr>
-                        <a:t>Shots</a:t>
-                      </a:r>
-                    </a:p>
-                  </a:txBody>
-                  <a:tcPr>
-                    <a:solidFill>
-                      <a:srgbClr val="F5F5F5"/>
-                    </a:solidFill>
-                  </a:tcPr>
-                </a:tc>
-                <a:tc>
-                  <a:txBody>
-                    <a:bodyPr/>
-                    <a:lstStyle/>
-                    <a:p>
-                      <a:r>
-                        <a:rPr sz="1100" b="0">
-                          <a:solidFill>
-                            <a:srgbClr val="1C1C1C"/>
-                          </a:solidFill>
-                          <a:latin typeface="Arial"/>
-                        </a:rPr>
-                        <a:t>Attacking</a:t>
-                      </a:r>
-                    </a:p>
-                  </a:txBody>
-                  <a:tcPr>
-                    <a:solidFill>
-                      <a:srgbClr val="F5F5F5"/>
-                    </a:solidFill>
-                  </a:tcPr>
-                </a:tc>
-                <a:tc>
-                  <a:txBody>
-                    <a:bodyPr/>
-                    <a:lstStyle/>
-                    <a:p>
-                      <a:r>
-                        <a:rPr sz="1100" b="0">
-                          <a:solidFill>
-                            <a:srgbClr val="1C1C1C"/>
-                          </a:solidFill>
-                          <a:latin typeface="Arial"/>
-                        </a:rPr>
-                        <a:t>Planned drop</a:t>
-                      </a:r>
-                    </a:p>
-                  </a:txBody>
-                  <a:tcPr>
-                    <a:solidFill>
-                      <a:srgbClr val="F5F5F5"/>
-                    </a:solidFill>
-                  </a:tcPr>
-                </a:tc>
-                <a:tc>
-                  <a:txBody>
-                    <a:bodyPr/>
-                    <a:lstStyle/>
-                    <a:p>
-                      <a:r>
-                        <a:rPr sz="1100" b="0">
-                          <a:solidFill>
-                            <a:srgbClr val="1C1C1C"/>
-                          </a:solidFill>
-                          <a:latin typeface="Arial"/>
-                        </a:rPr>
-                        <a:t>less stable analogue</a:t>
-                      </a:r>
-                    </a:p>
-                  </a:txBody>
-                  <a:tcPr>
-                    <a:solidFill>
-                      <a:srgbClr val="F5F5F5"/>
-                    </a:solidFill>
-                  </a:tcPr>
-                </a:tc>
-              </a:tr>
-              <a:tr h="347472">
-                <a:tc>
-                  <a:txBody>
-                    <a:bodyPr/>
-                    <a:lstStyle/>
-                    <a:p>
-                      <a:r>
-                        <a:rPr sz="1100" b="1">
-                          <a:solidFill>
-                            <a:srgbClr val="1C1C1C"/>
-                          </a:solidFill>
-                          <a:latin typeface="Arial"/>
-                        </a:rPr>
-                        <a:t>SCA</a:t>
-                      </a:r>
-                    </a:p>
-                  </a:txBody>
-                  <a:tcPr>
-                    <a:solidFill>
-                      <a:srgbClr val="F0FAF4"/>
-                    </a:solidFill>
-                  </a:tcPr>
-                </a:tc>
-                <a:tc>
-                  <a:txBody>
-                    <a:bodyPr/>
-                    <a:lstStyle/>
-                    <a:p>
-                      <a:r>
-                        <a:rPr sz="1100" b="1">
-                          <a:solidFill>
-                            <a:srgbClr val="1C1C1C"/>
-                          </a:solidFill>
-                          <a:latin typeface="Arial"/>
-                        </a:rPr>
-                        <a:t>Shot-creating actions</a:t>
-                      </a:r>
-                    </a:p>
-                  </a:txBody>
-                  <a:tcPr>
-                    <a:solidFill>
-                      <a:srgbClr val="F0FAF4"/>
-                    </a:solidFill>
-                  </a:tcPr>
-                </a:tc>
-                <a:tc>
-                  <a:txBody>
-                    <a:bodyPr/>
-                    <a:lstStyle/>
-                    <a:p>
-                      <a:r>
-                        <a:rPr sz="1100" b="1">
-                          <a:solidFill>
-                            <a:srgbClr val="1C1C1C"/>
-                          </a:solidFill>
-                          <a:latin typeface="Arial"/>
-                        </a:rPr>
-                        <a:t>Attacking</a:t>
-                      </a:r>
-                    </a:p>
-                  </a:txBody>
-                  <a:tcPr>
-                    <a:solidFill>
-                      <a:srgbClr val="F0FAF4"/>
-                    </a:solidFill>
-                  </a:tcPr>
-                </a:tc>
-                <a:tc>
-                  <a:txBody>
-                    <a:bodyPr/>
-                    <a:lstStyle/>
-                    <a:p>
-                      <a:r>
-                        <a:rPr sz="1100" b="1">
-                          <a:solidFill>
-                            <a:srgbClr val="1C1C1C"/>
-                          </a:solidFill>
-                          <a:latin typeface="Arial"/>
-                        </a:rPr>
-                        <a:t>Singleton</a:t>
-                      </a:r>
-                    </a:p>
-                  </a:txBody>
-                  <a:tcPr>
-                    <a:solidFill>
-                      <a:srgbClr val="F0FAF4"/>
-                    </a:solidFill>
-                  </a:tcPr>
-                </a:tc>
-                <a:tc>
-                  <a:txBody>
-                    <a:bodyPr/>
-                    <a:lstStyle/>
-                    <a:p>
-                      <a:r>
-                        <a:rPr sz="1100" b="1">
-                          <a:solidFill>
-                            <a:srgbClr val="1C1C1C"/>
-                          </a:solidFill>
-                          <a:latin typeface="Arial"/>
-                        </a:rPr>
-                        <a:t>no high overlap</a:t>
-                      </a:r>
-                    </a:p>
-                  </a:txBody>
-                  <a:tcPr>
-                    <a:solidFill>
-                      <a:srgbClr val="F0FAF4"/>
-                    </a:solidFill>
-                  </a:tcPr>
-                </a:tc>
-              </a:tr>
-              <a:tr h="347472">
-                <a:tc>
-                  <a:txBody>
-                    <a:bodyPr/>
-                    <a:lstStyle/>
-                    <a:p>
-                      <a:r>
-                        <a:rPr sz="1100" b="1">
-                          <a:solidFill>
-                            <a:srgbClr val="1C1C1C"/>
-                          </a:solidFill>
-                          <a:latin typeface="Arial"/>
-                        </a:rPr>
-                        <a:t>Tkl</a:t>
-                      </a:r>
-                    </a:p>
-                  </a:txBody>
-                  <a:tcPr>
-                    <a:solidFill>
-                      <a:srgbClr val="F0FAF4"/>
-                    </a:solidFill>
-                  </a:tcPr>
-                </a:tc>
-                <a:tc>
-                  <a:txBody>
-                    <a:bodyPr/>
-                    <a:lstStyle/>
-                    <a:p>
-                      <a:r>
-                        <a:rPr sz="1100" b="1">
-                          <a:solidFill>
-                            <a:srgbClr val="1C1C1C"/>
-                          </a:solidFill>
-                          <a:latin typeface="Arial"/>
-                        </a:rPr>
-                        <a:t>Tackles</a:t>
-                      </a:r>
-                    </a:p>
-                  </a:txBody>
-                  <a:tcPr>
-                    <a:solidFill>
-                      <a:srgbClr val="F0FAF4"/>
-                    </a:solidFill>
-                  </a:tcPr>
-                </a:tc>
-                <a:tc>
-                  <a:txBody>
-                    <a:bodyPr/>
-                    <a:lstStyle/>
-                    <a:p>
-                      <a:r>
-                        <a:rPr sz="1100" b="1">
-                          <a:solidFill>
-                            <a:srgbClr val="1C1C1C"/>
-                          </a:solidFill>
-                          <a:latin typeface="Arial"/>
-                        </a:rPr>
-                        <a:t>Defending</a:t>
-                      </a:r>
-                    </a:p>
-                  </a:txBody>
-                  <a:tcPr>
-                    <a:solidFill>
-                      <a:srgbClr val="F0FAF4"/>
-                    </a:solidFill>
-                  </a:tcPr>
-                </a:tc>
-                <a:tc>
-                  <a:txBody>
-                    <a:bodyPr/>
-                    <a:lstStyle/>
-                    <a:p>
-                      <a:r>
-                        <a:rPr sz="1100" b="1">
-                          <a:solidFill>
-                            <a:srgbClr val="1C1C1C"/>
-                          </a:solidFill>
-                          <a:latin typeface="Arial"/>
-                        </a:rPr>
-                        <a:t>Singleton</a:t>
-                      </a:r>
-                    </a:p>
-                  </a:txBody>
-                  <a:tcPr>
-                    <a:solidFill>
-                      <a:srgbClr val="F0FAF4"/>
-                    </a:solidFill>
-                  </a:tcPr>
-                </a:tc>
-                <a:tc>
-                  <a:txBody>
-                    <a:bodyPr/>
-                    <a:lstStyle/>
-                    <a:p>
-                      <a:r>
-                        <a:rPr sz="1100" b="1">
-                          <a:solidFill>
-                            <a:srgbClr val="1C1C1C"/>
-                          </a:solidFill>
-                          <a:latin typeface="Arial"/>
-                        </a:rPr>
-                        <a:t>no high overlap</a:t>
-                      </a:r>
-                    </a:p>
-                  </a:txBody>
-                  <a:tcPr>
-                    <a:solidFill>
-                      <a:srgbClr val="F0FAF4"/>
-                    </a:solidFill>
-                  </a:tcPr>
-                </a:tc>
-              </a:tr>
-              <a:tr h="347472">
-                <a:tc>
-                  <a:txBody>
-                    <a:bodyPr/>
-                    <a:lstStyle/>
-                    <a:p>
-                      <a:r>
-                        <a:rPr sz="1100" b="1">
-                          <a:solidFill>
-                            <a:srgbClr val="1C1C1C"/>
-                          </a:solidFill>
-                          <a:latin typeface="Arial"/>
-                        </a:rPr>
-                        <a:t>Int</a:t>
-                      </a:r>
-                    </a:p>
-                  </a:txBody>
-                  <a:tcPr>
-                    <a:solidFill>
-                      <a:srgbClr val="F0FAF4"/>
-                    </a:solidFill>
-                  </a:tcPr>
-                </a:tc>
-                <a:tc>
-                  <a:txBody>
-                    <a:bodyPr/>
-                    <a:lstStyle/>
-                    <a:p>
-                      <a:r>
-                        <a:rPr sz="1100" b="1">
-                          <a:solidFill>
-                            <a:srgbClr val="1C1C1C"/>
-                          </a:solidFill>
-                          <a:latin typeface="Arial"/>
-                        </a:rPr>
-                        <a:t>Interceptions</a:t>
-                      </a:r>
-                    </a:p>
-                  </a:txBody>
-                  <a:tcPr>
-                    <a:solidFill>
-                      <a:srgbClr val="F0FAF4"/>
-                    </a:solidFill>
-                  </a:tcPr>
-                </a:tc>
-                <a:tc>
-                  <a:txBody>
-                    <a:bodyPr/>
-                    <a:lstStyle/>
-                    <a:p>
-                      <a:r>
-                        <a:rPr sz="1100" b="1">
-                          <a:solidFill>
-                            <a:srgbClr val="1C1C1C"/>
-                          </a:solidFill>
-                          <a:latin typeface="Arial"/>
-                        </a:rPr>
-                        <a:t>Defending</a:t>
-                      </a:r>
-                    </a:p>
-                  </a:txBody>
-                  <a:tcPr>
-                    <a:solidFill>
-                      <a:srgbClr val="F0FAF4"/>
-                    </a:solidFill>
-                  </a:tcPr>
-                </a:tc>
-                <a:tc>
-                  <a:txBody>
-                    <a:bodyPr/>
-                    <a:lstStyle/>
-                    <a:p>
-                      <a:r>
-                        <a:rPr sz="1100" b="1">
-                          <a:solidFill>
-                            <a:srgbClr val="1C1C1C"/>
-                          </a:solidFill>
-                          <a:latin typeface="Arial"/>
-                        </a:rPr>
-                        <a:t>Singleton</a:t>
-                      </a:r>
-                    </a:p>
-                  </a:txBody>
-                  <a:tcPr>
-                    <a:solidFill>
-                      <a:srgbClr val="F0FAF4"/>
-                    </a:solidFill>
-                  </a:tcPr>
-                </a:tc>
-                <a:tc>
-                  <a:txBody>
-                    <a:bodyPr/>
-                    <a:lstStyle/>
-                    <a:p>
-                      <a:r>
-                        <a:rPr sz="1100" b="1">
-                          <a:solidFill>
-                            <a:srgbClr val="1C1C1C"/>
-                          </a:solidFill>
-                          <a:latin typeface="Arial"/>
-                        </a:rPr>
-                        <a:t>no high overlap</a:t>
-                      </a:r>
-                    </a:p>
-                  </a:txBody>
-                  <a:tcPr>
-                    <a:solidFill>
-                      <a:srgbClr val="F0FAF4"/>
-                    </a:solidFill>
-                  </a:tcPr>
-                </a:tc>
-              </a:tr>
-              <a:tr h="347472">
-                <a:tc>
-                  <a:txBody>
-                    <a:bodyPr/>
-                    <a:lstStyle/>
-                    <a:p>
-                      <a:r>
-                        <a:rPr sz="1100" b="1">
-                          <a:solidFill>
-                            <a:srgbClr val="1C1C1C"/>
-                          </a:solidFill>
-                          <a:latin typeface="Arial"/>
-                        </a:rPr>
-                        <a:t>Aer</a:t>
-                      </a:r>
-                    </a:p>
-                  </a:txBody>
-                  <a:tcPr>
-                    <a:solidFill>
-                      <a:srgbClr val="F0FAF4"/>
-                    </a:solidFill>
-                  </a:tcPr>
-                </a:tc>
-                <a:tc>
-                  <a:txBody>
-                    <a:bodyPr/>
-                    <a:lstStyle/>
-                    <a:p>
-                      <a:r>
-                        <a:rPr sz="1100" b="1">
-                          <a:solidFill>
-                            <a:srgbClr val="1C1C1C"/>
-                          </a:solidFill>
-                          <a:latin typeface="Arial"/>
-                        </a:rPr>
-                        <a:t>Aerials won</a:t>
-                      </a:r>
-                    </a:p>
-                  </a:txBody>
-                  <a:tcPr>
-                    <a:solidFill>
-                      <a:srgbClr val="F0FAF4"/>
-                    </a:solidFill>
-                  </a:tcPr>
-                </a:tc>
-                <a:tc>
-                  <a:txBody>
-                    <a:bodyPr/>
-                    <a:lstStyle/>
-                    <a:p>
-                      <a:r>
-                        <a:rPr sz="1100" b="1">
-                          <a:solidFill>
-                            <a:srgbClr val="1C1C1C"/>
-                          </a:solidFill>
-                          <a:latin typeface="Arial"/>
-                        </a:rPr>
-                        <a:t>Defending</a:t>
-                      </a:r>
-                    </a:p>
-                  </a:txBody>
-                  <a:tcPr>
-                    <a:solidFill>
-                      <a:srgbClr val="F0FAF4"/>
-                    </a:solidFill>
-                  </a:tcPr>
-                </a:tc>
-                <a:tc>
-                  <a:txBody>
-                    <a:bodyPr/>
-                    <a:lstStyle/>
-                    <a:p>
-                      <a:r>
-                        <a:rPr sz="1100" b="1">
-                          <a:solidFill>
-                            <a:srgbClr val="1C1C1C"/>
-                          </a:solidFill>
-                          <a:latin typeface="Arial"/>
-                        </a:rPr>
-                        <a:t>Singleton</a:t>
-                      </a:r>
-                    </a:p>
-                  </a:txBody>
-                  <a:tcPr>
-                    <a:solidFill>
-                      <a:srgbClr val="F0FAF4"/>
-                    </a:solidFill>
-                  </a:tcPr>
-                </a:tc>
-                <a:tc>
-                  <a:txBody>
-                    <a:bodyPr/>
-                    <a:lstStyle/>
-                    <a:p>
-                      <a:r>
-                        <a:rPr sz="1100" b="1">
-                          <a:solidFill>
-                            <a:srgbClr val="1C1C1C"/>
-                          </a:solidFill>
-                          <a:latin typeface="Arial"/>
-                        </a:rPr>
-                        <a:t>no high overlap</a:t>
-                      </a:r>
-                    </a:p>
-                  </a:txBody>
-                  <a:tcPr>
-                    <a:solidFill>
-                      <a:srgbClr val="F0FAF4"/>
-                    </a:solidFill>
-                  </a:tcPr>
-                </a:tc>
-              </a:tr>
-              <a:tr h="347472">
-                <a:tc>
-                  <a:txBody>
-                    <a:bodyPr/>
-                    <a:lstStyle/>
-                    <a:p>
-                      <a:r>
-                        <a:rPr sz="1100" b="1">
-                          <a:solidFill>
-                            <a:srgbClr val="1C1C1C"/>
-                          </a:solidFill>
-                          <a:latin typeface="Arial"/>
-                        </a:rPr>
-                        <a:t>AttPen</a:t>
-                      </a:r>
-                    </a:p>
-                  </a:txBody>
-                  <a:tcPr>
-                    <a:solidFill>
-                      <a:srgbClr val="F0FAF4"/>
-                    </a:solidFill>
-                  </a:tcPr>
-                </a:tc>
-                <a:tc>
-                  <a:txBody>
-                    <a:bodyPr/>
-                    <a:lstStyle/>
-                    <a:p>
-                      <a:r>
-                        <a:rPr sz="1100" b="1">
-                          <a:solidFill>
-                            <a:srgbClr val="1C1C1C"/>
-                          </a:solidFill>
-                          <a:latin typeface="Arial"/>
-                        </a:rPr>
-                        <a:t>Touches in att. pen</a:t>
-                      </a:r>
-                    </a:p>
-                  </a:txBody>
-                  <a:tcPr>
-                    <a:solidFill>
-                      <a:srgbClr val="F0FAF4"/>
-                    </a:solidFill>
-                  </a:tcPr>
-                </a:tc>
-                <a:tc>
-                  <a:txBody>
-                    <a:bodyPr/>
-                    <a:lstStyle/>
-                    <a:p>
-                      <a:r>
-                        <a:rPr sz="1100" b="1">
-                          <a:solidFill>
-                            <a:srgbClr val="1C1C1C"/>
-                          </a:solidFill>
-                          <a:latin typeface="Arial"/>
-                        </a:rPr>
-                        <a:t>Attacking</a:t>
-                      </a:r>
-                    </a:p>
-                  </a:txBody>
-                  <a:tcPr>
-                    <a:solidFill>
-                      <a:srgbClr val="F0FAF4"/>
-                    </a:solidFill>
-                  </a:tcPr>
-                </a:tc>
-                <a:tc>
-                  <a:txBody>
-                    <a:bodyPr/>
-                    <a:lstStyle/>
-                    <a:p>
-                      <a:r>
-                        <a:rPr sz="1100" b="1">
-                          <a:solidFill>
-                            <a:srgbClr val="1C1C1C"/>
-                          </a:solidFill>
-                          <a:latin typeface="Arial"/>
-                        </a:rPr>
-                        <a:t>Singleton</a:t>
-                      </a:r>
-                    </a:p>
-                  </a:txBody>
-                  <a:tcPr>
-                    <a:solidFill>
-                      <a:srgbClr val="F0FAF4"/>
-                    </a:solidFill>
-                  </a:tcPr>
-                </a:tc>
-                <a:tc>
-                  <a:txBody>
-                    <a:bodyPr/>
-                    <a:lstStyle/>
-                    <a:p>
-                      <a:r>
-                        <a:rPr sz="1100" b="1">
-                          <a:solidFill>
-                            <a:srgbClr val="1C1C1C"/>
-                          </a:solidFill>
-                          <a:latin typeface="Arial"/>
-                        </a:rPr>
-                        <a:t>no high overlap</a:t>
-                      </a:r>
-                    </a:p>
-                  </a:txBody>
-                  <a:tcPr>
-                    <a:solidFill>
-                      <a:srgbClr val="F0FAF4"/>
-                    </a:solidFill>
-                  </a:tcPr>
-                </a:tc>
-              </a:tr>
-            </a:tbl>
-          </a:graphicData>
-        </a:graphic>
-      </p:graphicFrame>
-      <p:sp>
-        <p:nvSpPr>
-          <p:cNvPr id="7" name="TextBox 6"/>
-          <p:cNvSpPr txBox="1"/>
-          <p:nvPr/>
-        </p:nvSpPr>
-        <p:spPr>
-          <a:xfrm>
-            <a:off x="502920" y="5989320"/>
-            <a:ext cx="11155680" cy="548640"/>
-          </a:xfrm>
-          <a:prstGeom prst="rect">
-            <a:avLst/>
-          </a:prstGeom>
-          <a:noFill/>
-        </p:spPr>
-        <p:txBody>
-          <a:bodyPr wrap="square">
-            <a:spAutoFit/>
-          </a:bodyPr>
-          <a:lstStyle/>
-          <a:p>
-            <a:r>
-              <a:rPr sz="1200" b="0">
-                <a:solidFill>
-                  <a:srgbClr val="8A5A00"/>
-                </a:solidFill>
-                <a:latin typeface="Arial"/>
-              </a:rPr>
-              <a:t>When FBref freeze lands: replace this table with real prior→Y1 stability r’s (same layout as the StatsBomb stability slide).</a:t>
-            </a:r>
-          </a:p>
-          <a:p>
-            <a:r>
-              <a:rPr sz="1200" b="0">
-                <a:solidFill>
-                  <a:srgbClr val="555555"/>
-                </a:solidFill>
-                <a:latin typeface="Arial"/>
-              </a:rPr>
-              <a:t>Until then: StatsBomb N=60 is the live stability evidence; FBref picks above are Step-2 plans guided by SB analogues.</a:t>
             </a:r>
           </a:p>
         </p:txBody>

</xml_diff>

<commit_message>
Fix PPT: clear Tier 1/2 explanations, FBref stability table, labeled pizza percentiles.
</commit_message>
<xml_diff>
--- a/bundesliga_transfer_traits.pptx
+++ b/bundesliga_transfer_traits.pptx
@@ -5,11 +5,11 @@
     <p:sldMasterId id="2147483648" r:id="rId1"/>
   </p:sldMasterIdLst>
   <p:sldIdLst>
-    <p:sldId id="256" r:id="rId7"/>
     <p:sldId id="257" r:id="rId8"/>
     <p:sldId id="258" r:id="rId9"/>
     <p:sldId id="262" r:id="rId13"/>
     <p:sldId id="264" r:id="rId15"/>
+    <p:sldId id="256" r:id="rId7"/>
     <p:sldId id="259" r:id="rId10"/>
     <p:sldId id="263" r:id="rId14"/>
     <p:sldId id="260" r:id="rId11"/>
@@ -3111,7 +3111,7 @@
             <a:avLst/>
           </a:prstGeom>
           <a:solidFill>
-            <a:srgbClr val="FFFFFF"/>
+            <a:srgbClr val="F4F5F7"/>
           </a:solidFill>
           <a:ln>
             <a:noFill/>
@@ -3141,465 +3141,20 @@
       </p:sp>
       <p:sp>
         <p:nvSpPr>
-          <p:cNvPr id="3" name="TextBox 2"/>
-          <p:cNvSpPr txBox="1"/>
-          <p:nvPr/>
-        </p:nvSpPr>
-        <p:spPr>
-          <a:xfrm>
-            <a:off x="457200" y="228600"/>
-            <a:ext cx="10972800" cy="274320"/>
-          </a:xfrm>
-          <a:prstGeom prst="rect">
-            <a:avLst/>
-          </a:prstGeom>
-          <a:noFill/>
-        </p:spPr>
-        <p:txBody>
-          <a:bodyPr wrap="none">
-            <a:spAutoFit/>
-          </a:bodyPr>
-          <a:lstStyle/>
-          <a:p>
-            <a:r>
-              <a:rPr sz="1100" b="1">
-                <a:solidFill>
-                  <a:srgbClr val="3D5A80"/>
-                </a:solidFill>
-                <a:latin typeface="Arial"/>
-              </a:rPr>
-              <a:t>CAL BERKELEY · INDEPENDENT STUDY · TEMPLATE FROM NYRB PIZZA DECK</a:t>
-            </a:r>
-          </a:p>
-        </p:txBody>
-      </p:sp>
-      <p:sp>
-        <p:nvSpPr>
-          <p:cNvPr id="4" name="TextBox 3"/>
-          <p:cNvSpPr txBox="1"/>
-          <p:nvPr/>
-        </p:nvSpPr>
-        <p:spPr>
-          <a:xfrm>
-            <a:off x="457200" y="457200"/>
-            <a:ext cx="10972800" cy="548640"/>
-          </a:xfrm>
-          <a:prstGeom prst="rect">
-            <a:avLst/>
-          </a:prstGeom>
-          <a:noFill/>
-        </p:spPr>
-        <p:txBody>
-          <a:bodyPr wrap="none">
-            <a:spAutoFit/>
-          </a:bodyPr>
-          <a:lstStyle/>
-          <a:p>
-            <a:r>
-              <a:rPr sz="2800" b="1">
-                <a:solidFill>
-                  <a:srgbClr val="1C1C1C"/>
-                </a:solidFill>
-                <a:latin typeface="Georgia"/>
-              </a:rPr>
-              <a:t>Which traits travel into the Bundesliga?</a:t>
-            </a:r>
-          </a:p>
-        </p:txBody>
-      </p:sp>
-      <p:sp>
-        <p:nvSpPr>
-          <p:cNvPr id="5" name="TextBox 4"/>
-          <p:cNvSpPr txBox="1"/>
-          <p:nvPr/>
-        </p:nvSpPr>
-        <p:spPr>
-          <a:xfrm>
-            <a:off x="457200" y="960120"/>
-            <a:ext cx="10972800" cy="365760"/>
-          </a:xfrm>
-          <a:prstGeom prst="rect">
-            <a:avLst/>
-          </a:prstGeom>
-          <a:noFill/>
-        </p:spPr>
-        <p:txBody>
-          <a:bodyPr wrap="none">
-            <a:spAutoFit/>
-          </a:bodyPr>
-          <a:lstStyle/>
-          <a:p>
-            <a:r>
-              <a:rPr sz="1400" b="0">
-                <a:solidFill>
-                  <a:srgbClr val="555555"/>
-                </a:solidFill>
-                <a:latin typeface="Arial"/>
-              </a:rPr>
-              <a:t>Stability → redundancy → pizza charts · FBref primary · StatsBomb deep dive</a:t>
-            </a:r>
-          </a:p>
-        </p:txBody>
-      </p:sp>
-      <p:sp>
-        <p:nvSpPr>
-          <p:cNvPr id="6" name="Rounded Rectangle 5"/>
-          <p:cNvSpPr/>
-          <p:nvPr/>
-        </p:nvSpPr>
-        <p:spPr>
-          <a:xfrm>
-            <a:off x="457200" y="1645920"/>
-            <a:ext cx="3566160" cy="2011680"/>
-          </a:xfrm>
-          <a:prstGeom prst="roundRect">
-            <a:avLst/>
-          </a:prstGeom>
-          <a:solidFill>
-            <a:srgbClr val="F4F5F7"/>
-          </a:solidFill>
-          <a:ln>
-            <a:solidFill>
-              <a:srgbClr val="D0D4DB"/>
-            </a:solidFill>
-          </a:ln>
-        </p:spPr>
-        <p:style>
-          <a:lnRef idx="1">
-            <a:schemeClr val="accent1"/>
-          </a:lnRef>
-          <a:fillRef idx="3">
-            <a:schemeClr val="accent1"/>
-          </a:fillRef>
-          <a:effectRef idx="2">
-            <a:schemeClr val="accent1"/>
-          </a:effectRef>
-          <a:fontRef idx="minor">
-            <a:schemeClr val="lt1"/>
-          </a:fontRef>
-        </p:style>
-        <p:txBody>
-          <a:bodyPr rtlCol="0" anchor="ctr"/>
-          <a:lstStyle/>
-          <a:p>
-            <a:pPr algn="ctr"/>
-          </a:p>
-        </p:txBody>
-      </p:sp>
-      <p:sp>
-        <p:nvSpPr>
-          <p:cNvPr id="7" name="TextBox 6"/>
-          <p:cNvSpPr txBox="1"/>
-          <p:nvPr/>
-        </p:nvSpPr>
-        <p:spPr>
-          <a:xfrm>
-            <a:off x="594360" y="1783080"/>
-            <a:ext cx="3291840" cy="1737360"/>
-          </a:xfrm>
-          <a:prstGeom prst="rect">
-            <a:avLst/>
-          </a:prstGeom>
-          <a:noFill/>
-        </p:spPr>
-        <p:txBody>
-          <a:bodyPr wrap="square">
-            <a:spAutoFit/>
-          </a:bodyPr>
-          <a:lstStyle/>
-          <a:p>
-            <a:r>
-              <a:rPr sz="1400" b="1">
-                <a:solidFill>
-                  <a:srgbClr val="3D5A80"/>
-                </a:solidFill>
-                <a:latin typeface="Arial"/>
-              </a:rPr>
-              <a:t>Q1 — Portability</a:t>
-            </a:r>
-          </a:p>
-          <a:p>
-            <a:r>
-              <a:rPr sz="1200" b="0">
-                <a:solidFill>
-                  <a:srgbClr val="1C1C1C"/>
-                </a:solidFill>
-                <a:latin typeface="Arial"/>
-              </a:rPr>
-              <a:t>Which FBref per-90 stats stay consistent from the prior league into Bundesliga Year-1?</a:t>
-            </a:r>
-          </a:p>
-        </p:txBody>
-      </p:sp>
-      <p:sp>
-        <p:nvSpPr>
-          <p:cNvPr id="8" name="Rounded Rectangle 7"/>
-          <p:cNvSpPr/>
-          <p:nvPr/>
-        </p:nvSpPr>
-        <p:spPr>
-          <a:xfrm>
-            <a:off x="4297680" y="1645920"/>
-            <a:ext cx="3566160" cy="2011680"/>
-          </a:xfrm>
-          <a:prstGeom prst="roundRect">
-            <a:avLst/>
-          </a:prstGeom>
-          <a:solidFill>
-            <a:srgbClr val="F4F5F7"/>
-          </a:solidFill>
-          <a:ln>
-            <a:solidFill>
-              <a:srgbClr val="D0D4DB"/>
-            </a:solidFill>
-          </a:ln>
-        </p:spPr>
-        <p:style>
-          <a:lnRef idx="1">
-            <a:schemeClr val="accent1"/>
-          </a:lnRef>
-          <a:fillRef idx="3">
-            <a:schemeClr val="accent1"/>
-          </a:fillRef>
-          <a:effectRef idx="2">
-            <a:schemeClr val="accent1"/>
-          </a:effectRef>
-          <a:fontRef idx="minor">
-            <a:schemeClr val="lt1"/>
-          </a:fontRef>
-        </p:style>
-        <p:txBody>
-          <a:bodyPr rtlCol="0" anchor="ctr"/>
-          <a:lstStyle/>
-          <a:p>
-            <a:pPr algn="ctr"/>
-          </a:p>
-        </p:txBody>
-      </p:sp>
-      <p:sp>
-        <p:nvSpPr>
-          <p:cNvPr id="9" name="TextBox 8"/>
-          <p:cNvSpPr txBox="1"/>
-          <p:nvPr/>
-        </p:nvSpPr>
-        <p:spPr>
-          <a:xfrm>
-            <a:off x="4434840" y="1783080"/>
-            <a:ext cx="3291840" cy="1737360"/>
-          </a:xfrm>
-          <a:prstGeom prst="rect">
-            <a:avLst/>
-          </a:prstGeom>
-          <a:noFill/>
-        </p:spPr>
-        <p:txBody>
-          <a:bodyPr wrap="square">
-            <a:spAutoFit/>
-          </a:bodyPr>
-          <a:lstStyle/>
-          <a:p>
-            <a:r>
-              <a:rPr sz="1400" b="1">
-                <a:solidFill>
-                  <a:srgbClr val="3D5A80"/>
-                </a:solidFill>
-                <a:latin typeface="Arial"/>
-              </a:rPr>
-              <a:t>Q2 — Leagues</a:t>
-            </a:r>
-          </a:p>
-          <a:p>
-            <a:r>
-              <a:rPr sz="1200" b="0">
-                <a:solidFill>
-                  <a:srgbClr val="1C1C1C"/>
-                </a:solidFill>
-                <a:latin typeface="Arial"/>
-              </a:rPr>
-              <a:t>Which source leagues produce arrivals who perform effectively in Germany?</a:t>
-            </a:r>
-          </a:p>
-        </p:txBody>
-      </p:sp>
-      <p:sp>
-        <p:nvSpPr>
-          <p:cNvPr id="10" name="Rounded Rectangle 9"/>
-          <p:cNvSpPr/>
-          <p:nvPr/>
-        </p:nvSpPr>
-        <p:spPr>
-          <a:xfrm>
-            <a:off x="8138160" y="1645920"/>
-            <a:ext cx="3566160" cy="2011680"/>
-          </a:xfrm>
-          <a:prstGeom prst="roundRect">
-            <a:avLst/>
-          </a:prstGeom>
-          <a:solidFill>
-            <a:srgbClr val="F4F5F7"/>
-          </a:solidFill>
-          <a:ln>
-            <a:solidFill>
-              <a:srgbClr val="D0D4DB"/>
-            </a:solidFill>
-          </a:ln>
-        </p:spPr>
-        <p:style>
-          <a:lnRef idx="1">
-            <a:schemeClr val="accent1"/>
-          </a:lnRef>
-          <a:fillRef idx="3">
-            <a:schemeClr val="accent1"/>
-          </a:fillRef>
-          <a:effectRef idx="2">
-            <a:schemeClr val="accent1"/>
-          </a:effectRef>
-          <a:fontRef idx="minor">
-            <a:schemeClr val="lt1"/>
-          </a:fontRef>
-        </p:style>
-        <p:txBody>
-          <a:bodyPr rtlCol="0" anchor="ctr"/>
-          <a:lstStyle/>
-          <a:p>
-            <a:pPr algn="ctr"/>
-          </a:p>
-        </p:txBody>
-      </p:sp>
-      <p:sp>
-        <p:nvSpPr>
-          <p:cNvPr id="11" name="TextBox 10"/>
-          <p:cNvSpPr txBox="1"/>
-          <p:nvPr/>
-        </p:nvSpPr>
-        <p:spPr>
-          <a:xfrm>
-            <a:off x="8275320" y="1783080"/>
-            <a:ext cx="3291840" cy="1737360"/>
-          </a:xfrm>
-          <a:prstGeom prst="rect">
-            <a:avLst/>
-          </a:prstGeom>
-          <a:noFill/>
-        </p:spPr>
-        <p:txBody>
-          <a:bodyPr wrap="square">
-            <a:spAutoFit/>
-          </a:bodyPr>
-          <a:lstStyle/>
-          <a:p>
-            <a:r>
-              <a:rPr sz="1400" b="1">
-                <a:solidFill>
-                  <a:srgbClr val="3D5A80"/>
-                </a:solidFill>
-                <a:latin typeface="Arial"/>
-              </a:rPr>
-              <a:t>Q3 — Deliverable</a:t>
-            </a:r>
-          </a:p>
-          <a:p>
-            <a:r>
-              <a:rPr sz="1200" b="0">
-                <a:solidFill>
-                  <a:srgbClr val="1C1C1C"/>
-                </a:solidFill>
-                <a:latin typeface="Arial"/>
-              </a:rPr>
-              <a:t>A short non-redundant trait set + pizza profiles for scouts / Conrad.</a:t>
-            </a:r>
-          </a:p>
-        </p:txBody>
-      </p:sp>
-      <p:sp>
-        <p:nvSpPr>
-          <p:cNvPr id="12" name="TextBox 11"/>
-          <p:cNvSpPr txBox="1"/>
-          <p:nvPr/>
-        </p:nvSpPr>
-        <p:spPr>
-          <a:xfrm>
-            <a:off x="457200" y="4023360"/>
-            <a:ext cx="10972800" cy="4572000"/>
-          </a:xfrm>
-          <a:prstGeom prst="rect">
-            <a:avLst/>
-          </a:prstGeom>
-          <a:noFill/>
-        </p:spPr>
-        <p:txBody>
-          <a:bodyPr wrap="square">
-            <a:spAutoFit/>
-          </a:bodyPr>
-          <a:lstStyle/>
-          <a:p>
-            <a:pPr>
-              <a:spcAft>
-                <a:spcPts val="800"/>
-              </a:spcAft>
-            </a:pPr>
-            <a:r>
-              <a:rPr sz="1300" b="0">
-                <a:solidFill>
-                  <a:srgbClr val="1C1C1C"/>
-                </a:solidFill>
-                <a:latin typeface="Arial"/>
-              </a:rPr>
-              <a:t>Inbound cohort from FBref season records (first Bundesliga season / prior league ≠ Bundesliga).</a:t>
-            </a:r>
-          </a:p>
-          <a:p>
-            <a:pPr>
-              <a:spcAft>
-                <a:spcPts val="800"/>
-              </a:spcAft>
-            </a:pPr>
-            <a:r>
-              <a:rPr sz="1300" b="0">
-                <a:solidFill>
-                  <a:srgbClr val="1C1C1C"/>
-                </a:solidFill>
-                <a:latin typeface="Arial"/>
-              </a:rPr>
-              <a:t>Not Transfermarkt scrape · Not market-value model.</a:t>
-            </a:r>
-          </a:p>
-        </p:txBody>
-      </p:sp>
-    </p:spTree>
-  </p:cSld>
-  <p:clrMapOvr>
-    <a:masterClrMapping/>
-  </p:clrMapOvr>
-</p:sld>
-</file>
-
-<file path=ppt/slides/slide2.xml><?xml version="1.0" encoding="utf-8"?>
-<p:sld xmlns:a="http://schemas.openxmlformats.org/drawingml/2006/main" xmlns:p="http://schemas.openxmlformats.org/presentationml/2006/main" xmlns:r="http://schemas.openxmlformats.org/officeDocument/2006/relationships">
-  <p:cSld>
-    <p:spTree>
-      <p:nvGrpSpPr>
-        <p:cNvPr id="1" name=""/>
-        <p:cNvGrpSpPr/>
-        <p:nvPr/>
-      </p:nvGrpSpPr>
-      <p:grpSpPr/>
-      <p:sp>
-        <p:nvSpPr>
-          <p:cNvPr id="2" name="Rectangle 1"/>
+          <p:cNvPr id="3" name="Rectangle 2"/>
           <p:cNvSpPr/>
           <p:nvPr/>
         </p:nvSpPr>
         <p:spPr>
           <a:xfrm>
             <a:off x="0" y="0"/>
-            <a:ext cx="12191695" cy="6858000"/>
+            <a:ext cx="137160" cy="6858000"/>
           </a:xfrm>
           <a:prstGeom prst="rect">
             <a:avLst/>
           </a:prstGeom>
           <a:solidFill>
-            <a:srgbClr val="FFFFFF"/>
+            <a:srgbClr val="3D5A80"/>
           </a:solidFill>
           <a:ln>
             <a:noFill/>
@@ -3629,6 +3184,1510 @@
       </p:sp>
       <p:sp>
         <p:nvSpPr>
+          <p:cNvPr id="4" name="TextBox 3"/>
+          <p:cNvSpPr txBox="1"/>
+          <p:nvPr/>
+        </p:nvSpPr>
+        <p:spPr>
+          <a:xfrm>
+            <a:off x="502920" y="228600"/>
+            <a:ext cx="11155680" cy="411480"/>
+          </a:xfrm>
+          <a:prstGeom prst="rect">
+            <a:avLst/>
+          </a:prstGeom>
+          <a:noFill/>
+        </p:spPr>
+        <p:txBody>
+          <a:bodyPr wrap="square">
+            <a:spAutoFit/>
+          </a:bodyPr>
+          <a:lstStyle/>
+          <a:p>
+            <a:r>
+              <a:rPr sz="2200" b="1">
+                <a:solidFill>
+                  <a:srgbClr val="1C1C1C"/>
+                </a:solidFill>
+                <a:latin typeface="Georgia"/>
+              </a:rPr>
+              <a:t>FBref stability list (planned — Tier 2 not run yet)</a:t>
+            </a:r>
+          </a:p>
+        </p:txBody>
+      </p:sp>
+      <p:sp>
+        <p:nvSpPr>
+          <p:cNvPr id="5" name="TextBox 4"/>
+          <p:cNvSpPr txBox="1"/>
+          <p:nvPr/>
+        </p:nvSpPr>
+        <p:spPr>
+          <a:xfrm>
+            <a:off x="502920" y="685800"/>
+            <a:ext cx="11155680" cy="502920"/>
+          </a:xfrm>
+          <a:prstGeom prst="rect">
+            <a:avLst/>
+          </a:prstGeom>
+          <a:noFill/>
+        </p:spPr>
+        <p:txBody>
+          <a:bodyPr wrap="square">
+            <a:spAutoFit/>
+          </a:bodyPr>
+          <a:lstStyle/>
+          <a:p>
+            <a:r>
+              <a:rPr sz="1300" b="0">
+                <a:solidFill>
+                  <a:srgbClr val="555555"/>
+                </a:solidFill>
+                <a:latin typeface="Arial"/>
+              </a:rPr>
+              <a:t>Same idea as StatsBomb: prior league → Bundesliga Y1 correlation. Gate planned at r ≥ ~0.40, then redundancy.</a:t>
+            </a:r>
+          </a:p>
+          <a:p>
+            <a:r>
+              <a:rPr sz="1300" b="0">
+                <a:solidFill>
+                  <a:srgbClr val="555555"/>
+                </a:solidFill>
+                <a:latin typeface="Arial"/>
+              </a:rPr>
+              <a:t>No live FBref r’s yet (need N≥500 paired seasons). Table = your Step-2 planned keep/drop list.</a:t>
+            </a:r>
+          </a:p>
+        </p:txBody>
+      </p:sp>
+      <p:graphicFrame>
+        <p:nvGraphicFramePr>
+          <p:cNvPr id="6" name="Table 5"/>
+          <p:cNvGraphicFramePr>
+            <a:graphicFrameLocks noGrp="1"/>
+          </p:cNvGraphicFramePr>
+          <p:nvPr/>
+        </p:nvGraphicFramePr>
+        <p:xfrm>
+          <a:off x="411480" y="1325880"/>
+          <a:ext cx="11338560" cy="4169664"/>
+        </p:xfrm>
+        <a:graphic>
+          <a:graphicData uri="http://schemas.openxmlformats.org/drawingml/2006/table">
+            <a:tbl>
+              <a:tblPr firstRow="1" bandRow="1">
+                <a:tableStyleId>{5C22544A-7EE6-4342-B048-85BDC9FD1C3A}</a:tableStyleId>
+              </a:tblPr>
+              <a:tblGrid>
+                <a:gridCol w="914400"/>
+                <a:gridCol w="2743200"/>
+                <a:gridCol w="1371600"/>
+                <a:gridCol w="2011680"/>
+                <a:gridCol w="4297680"/>
+              </a:tblGrid>
+              <a:tr h="347472">
+                <a:tc>
+                  <a:txBody>
+                    <a:bodyPr/>
+                    <a:lstStyle/>
+                    <a:p>
+                      <a:r>
+                        <a:rPr sz="1100" b="1">
+                          <a:solidFill>
+                            <a:srgbClr val="FFFFFF"/>
+                          </a:solidFill>
+                          <a:latin typeface="Arial"/>
+                        </a:rPr>
+                        <a:t>Abbrev</a:t>
+                      </a:r>
+                    </a:p>
+                  </a:txBody>
+                  <a:tcPr>
+                    <a:solidFill>
+                      <a:srgbClr val="1C1C1C"/>
+                    </a:solidFill>
+                  </a:tcPr>
+                </a:tc>
+                <a:tc>
+                  <a:txBody>
+                    <a:bodyPr/>
+                    <a:lstStyle/>
+                    <a:p>
+                      <a:r>
+                        <a:rPr sz="1100" b="1">
+                          <a:solidFill>
+                            <a:srgbClr val="FFFFFF"/>
+                          </a:solidFill>
+                          <a:latin typeface="Arial"/>
+                        </a:rPr>
+                        <a:t>FBref metric</a:t>
+                      </a:r>
+                    </a:p>
+                  </a:txBody>
+                  <a:tcPr>
+                    <a:solidFill>
+                      <a:srgbClr val="1C1C1C"/>
+                    </a:solidFill>
+                  </a:tcPr>
+                </a:tc>
+                <a:tc>
+                  <a:txBody>
+                    <a:bodyPr/>
+                    <a:lstStyle/>
+                    <a:p>
+                      <a:r>
+                        <a:rPr sz="1100" b="1">
+                          <a:solidFill>
+                            <a:srgbClr val="FFFFFF"/>
+                          </a:solidFill>
+                          <a:latin typeface="Arial"/>
+                        </a:rPr>
+                        <a:t>Category</a:t>
+                      </a:r>
+                    </a:p>
+                  </a:txBody>
+                  <a:tcPr>
+                    <a:solidFill>
+                      <a:srgbClr val="1C1C1C"/>
+                    </a:solidFill>
+                  </a:tcPr>
+                </a:tc>
+                <a:tc>
+                  <a:txBody>
+                    <a:bodyPr/>
+                    <a:lstStyle/>
+                    <a:p>
+                      <a:r>
+                        <a:rPr sz="1100" b="1">
+                          <a:solidFill>
+                            <a:srgbClr val="FFFFFF"/>
+                          </a:solidFill>
+                          <a:latin typeface="Arial"/>
+                        </a:rPr>
+                        <a:t>Stability status</a:t>
+                      </a:r>
+                    </a:p>
+                  </a:txBody>
+                  <a:tcPr>
+                    <a:solidFill>
+                      <a:srgbClr val="1C1C1C"/>
+                    </a:solidFill>
+                  </a:tcPr>
+                </a:tc>
+                <a:tc>
+                  <a:txBody>
+                    <a:bodyPr/>
+                    <a:lstStyle/>
+                    <a:p>
+                      <a:r>
+                        <a:rPr sz="1100" b="1">
+                          <a:solidFill>
+                            <a:srgbClr val="FFFFFF"/>
+                          </a:solidFill>
+                          <a:latin typeface="Arial"/>
+                        </a:rPr>
+                        <a:t>Note</a:t>
+                      </a:r>
+                    </a:p>
+                  </a:txBody>
+                  <a:tcPr>
+                    <a:solidFill>
+                      <a:srgbClr val="1C1C1C"/>
+                    </a:solidFill>
+                  </a:tcPr>
+                </a:tc>
+              </a:tr>
+              <a:tr h="347472">
+                <a:tc>
+                  <a:txBody>
+                    <a:bodyPr/>
+                    <a:lstStyle/>
+                    <a:p>
+                      <a:r>
+                        <a:rPr sz="1100" b="1">
+                          <a:solidFill>
+                            <a:srgbClr val="1C1C1C"/>
+                          </a:solidFill>
+                          <a:latin typeface="Arial"/>
+                        </a:rPr>
+                        <a:t>PrgP</a:t>
+                      </a:r>
+                    </a:p>
+                  </a:txBody>
+                  <a:tcPr>
+                    <a:solidFill>
+                      <a:srgbClr val="F0FAF4"/>
+                    </a:solidFill>
+                  </a:tcPr>
+                </a:tc>
+                <a:tc>
+                  <a:txBody>
+                    <a:bodyPr/>
+                    <a:lstStyle/>
+                    <a:p>
+                      <a:r>
+                        <a:rPr sz="1100" b="1">
+                          <a:solidFill>
+                            <a:srgbClr val="1C1C1C"/>
+                          </a:solidFill>
+                          <a:latin typeface="Arial"/>
+                        </a:rPr>
+                        <a:t>Progressive passes</a:t>
+                      </a:r>
+                    </a:p>
+                  </a:txBody>
+                  <a:tcPr>
+                    <a:solidFill>
+                      <a:srgbClr val="F0FAF4"/>
+                    </a:solidFill>
+                  </a:tcPr>
+                </a:tc>
+                <a:tc>
+                  <a:txBody>
+                    <a:bodyPr/>
+                    <a:lstStyle/>
+                    <a:p>
+                      <a:r>
+                        <a:rPr sz="1100" b="1">
+                          <a:solidFill>
+                            <a:srgbClr val="1C1C1C"/>
+                          </a:solidFill>
+                          <a:latin typeface="Arial"/>
+                        </a:rPr>
+                        <a:t>Passing</a:t>
+                      </a:r>
+                    </a:p>
+                  </a:txBody>
+                  <a:tcPr>
+                    <a:solidFill>
+                      <a:srgbClr val="F0FAF4"/>
+                    </a:solidFill>
+                  </a:tcPr>
+                </a:tc>
+                <a:tc>
+                  <a:txBody>
+                    <a:bodyPr/>
+                    <a:lstStyle/>
+                    <a:p>
+                      <a:r>
+                        <a:rPr sz="1100" b="1">
+                          <a:solidFill>
+                            <a:srgbClr val="1C1C1C"/>
+                          </a:solidFill>
+                          <a:latin typeface="Arial"/>
+                        </a:rPr>
+                        <a:t>Planned PASS</a:t>
+                      </a:r>
+                    </a:p>
+                  </a:txBody>
+                  <a:tcPr>
+                    <a:solidFill>
+                      <a:srgbClr val="F0FAF4"/>
+                    </a:solidFill>
+                  </a:tcPr>
+                </a:tc>
+                <a:tc>
+                  <a:txBody>
+                    <a:bodyPr/>
+                    <a:lstStyle/>
+                    <a:p>
+                      <a:r>
+                        <a:rPr sz="1100" b="1">
+                          <a:solidFill>
+                            <a:srgbClr val="1C1C1C"/>
+                          </a:solidFill>
+                          <a:latin typeface="Arial"/>
+                        </a:rPr>
+                        <a:t>Keep over Passes (cluster)</a:t>
+                      </a:r>
+                    </a:p>
+                  </a:txBody>
+                  <a:tcPr>
+                    <a:solidFill>
+                      <a:srgbClr val="F0FAF4"/>
+                    </a:solidFill>
+                  </a:tcPr>
+                </a:tc>
+              </a:tr>
+              <a:tr h="347472">
+                <a:tc>
+                  <a:txBody>
+                    <a:bodyPr/>
+                    <a:lstStyle/>
+                    <a:p>
+                      <a:r>
+                        <a:rPr sz="1100" b="0">
+                          <a:solidFill>
+                            <a:srgbClr val="1C1C1C"/>
+                          </a:solidFill>
+                          <a:latin typeface="Arial"/>
+                        </a:rPr>
+                        <a:t>Pass</a:t>
+                      </a:r>
+                    </a:p>
+                  </a:txBody>
+                  <a:tcPr>
+                    <a:solidFill>
+                      <a:srgbClr val="F2F2F2"/>
+                    </a:solidFill>
+                  </a:tcPr>
+                </a:tc>
+                <a:tc>
+                  <a:txBody>
+                    <a:bodyPr/>
+                    <a:lstStyle/>
+                    <a:p>
+                      <a:r>
+                        <a:rPr sz="1100" b="0">
+                          <a:solidFill>
+                            <a:srgbClr val="1C1C1C"/>
+                          </a:solidFill>
+                          <a:latin typeface="Arial"/>
+                        </a:rPr>
+                        <a:t>Passes (volume)</a:t>
+                      </a:r>
+                    </a:p>
+                  </a:txBody>
+                  <a:tcPr>
+                    <a:solidFill>
+                      <a:srgbClr val="F2F2F2"/>
+                    </a:solidFill>
+                  </a:tcPr>
+                </a:tc>
+                <a:tc>
+                  <a:txBody>
+                    <a:bodyPr/>
+                    <a:lstStyle/>
+                    <a:p>
+                      <a:r>
+                        <a:rPr sz="1100" b="0">
+                          <a:solidFill>
+                            <a:srgbClr val="1C1C1C"/>
+                          </a:solidFill>
+                          <a:latin typeface="Arial"/>
+                        </a:rPr>
+                        <a:t>Passing</a:t>
+                      </a:r>
+                    </a:p>
+                  </a:txBody>
+                  <a:tcPr>
+                    <a:solidFill>
+                      <a:srgbClr val="F2F2F2"/>
+                    </a:solidFill>
+                  </a:tcPr>
+                </a:tc>
+                <a:tc>
+                  <a:txBody>
+                    <a:bodyPr/>
+                    <a:lstStyle/>
+                    <a:p>
+                      <a:r>
+                        <a:rPr sz="1100" b="0">
+                          <a:solidFill>
+                            <a:srgbClr val="1C1C1C"/>
+                          </a:solidFill>
+                          <a:latin typeface="Arial"/>
+                        </a:rPr>
+                        <a:t>Planned OUT</a:t>
+                      </a:r>
+                    </a:p>
+                  </a:txBody>
+                  <a:tcPr>
+                    <a:solidFill>
+                      <a:srgbClr val="F2F2F2"/>
+                    </a:solidFill>
+                  </a:tcPr>
+                </a:tc>
+                <a:tc>
+                  <a:txBody>
+                    <a:bodyPr/>
+                    <a:lstStyle/>
+                    <a:p>
+                      <a:r>
+                        <a:rPr sz="1100" b="0">
+                          <a:solidFill>
+                            <a:srgbClr val="1C1C1C"/>
+                          </a:solidFill>
+                          <a:latin typeface="Arial"/>
+                        </a:rPr>
+                        <a:t>Drop vs PrgP</a:t>
+                      </a:r>
+                    </a:p>
+                  </a:txBody>
+                  <a:tcPr>
+                    <a:solidFill>
+                      <a:srgbClr val="F2F2F2"/>
+                    </a:solidFill>
+                  </a:tcPr>
+                </a:tc>
+              </a:tr>
+              <a:tr h="347472">
+                <a:tc>
+                  <a:txBody>
+                    <a:bodyPr/>
+                    <a:lstStyle/>
+                    <a:p>
+                      <a:r>
+                        <a:rPr sz="1100" b="1">
+                          <a:solidFill>
+                            <a:srgbClr val="1C1C1C"/>
+                          </a:solidFill>
+                          <a:latin typeface="Arial"/>
+                        </a:rPr>
+                        <a:t>Carr</a:t>
+                      </a:r>
+                    </a:p>
+                  </a:txBody>
+                  <a:tcPr>
+                    <a:solidFill>
+                      <a:srgbClr val="F0FAF4"/>
+                    </a:solidFill>
+                  </a:tcPr>
+                </a:tc>
+                <a:tc>
+                  <a:txBody>
+                    <a:bodyPr/>
+                    <a:lstStyle/>
+                    <a:p>
+                      <a:r>
+                        <a:rPr sz="1100" b="1">
+                          <a:solidFill>
+                            <a:srgbClr val="1C1C1C"/>
+                          </a:solidFill>
+                          <a:latin typeface="Arial"/>
+                        </a:rPr>
+                        <a:t>Carries</a:t>
+                      </a:r>
+                    </a:p>
+                  </a:txBody>
+                  <a:tcPr>
+                    <a:solidFill>
+                      <a:srgbClr val="F0FAF4"/>
+                    </a:solidFill>
+                  </a:tcPr>
+                </a:tc>
+                <a:tc>
+                  <a:txBody>
+                    <a:bodyPr/>
+                    <a:lstStyle/>
+                    <a:p>
+                      <a:r>
+                        <a:rPr sz="1100" b="1">
+                          <a:solidFill>
+                            <a:srgbClr val="1C1C1C"/>
+                          </a:solidFill>
+                          <a:latin typeface="Arial"/>
+                        </a:rPr>
+                        <a:t>Carrying</a:t>
+                      </a:r>
+                    </a:p>
+                  </a:txBody>
+                  <a:tcPr>
+                    <a:solidFill>
+                      <a:srgbClr val="F0FAF4"/>
+                    </a:solidFill>
+                  </a:tcPr>
+                </a:tc>
+                <a:tc>
+                  <a:txBody>
+                    <a:bodyPr/>
+                    <a:lstStyle/>
+                    <a:p>
+                      <a:r>
+                        <a:rPr sz="1100" b="1">
+                          <a:solidFill>
+                            <a:srgbClr val="1C1C1C"/>
+                          </a:solidFill>
+                          <a:latin typeface="Arial"/>
+                        </a:rPr>
+                        <a:t>Planned PASS</a:t>
+                      </a:r>
+                    </a:p>
+                  </a:txBody>
+                  <a:tcPr>
+                    <a:solidFill>
+                      <a:srgbClr val="F0FAF4"/>
+                    </a:solidFill>
+                  </a:tcPr>
+                </a:tc>
+                <a:tc>
+                  <a:txBody>
+                    <a:bodyPr/>
+                    <a:lstStyle/>
+                    <a:p>
+                      <a:r>
+                        <a:rPr sz="1100" b="1">
+                          <a:solidFill>
+                            <a:srgbClr val="1C1C1C"/>
+                          </a:solidFill>
+                          <a:latin typeface="Arial"/>
+                        </a:rPr>
+                        <a:t>Keep over PrgC (cluster)</a:t>
+                      </a:r>
+                    </a:p>
+                  </a:txBody>
+                  <a:tcPr>
+                    <a:solidFill>
+                      <a:srgbClr val="F0FAF4"/>
+                    </a:solidFill>
+                  </a:tcPr>
+                </a:tc>
+              </a:tr>
+              <a:tr h="347472">
+                <a:tc>
+                  <a:txBody>
+                    <a:bodyPr/>
+                    <a:lstStyle/>
+                    <a:p>
+                      <a:r>
+                        <a:rPr sz="1100" b="0">
+                          <a:solidFill>
+                            <a:srgbClr val="1C1C1C"/>
+                          </a:solidFill>
+                          <a:latin typeface="Arial"/>
+                        </a:rPr>
+                        <a:t>PrgC</a:t>
+                      </a:r>
+                    </a:p>
+                  </a:txBody>
+                  <a:tcPr>
+                    <a:solidFill>
+                      <a:srgbClr val="F2F2F2"/>
+                    </a:solidFill>
+                  </a:tcPr>
+                </a:tc>
+                <a:tc>
+                  <a:txBody>
+                    <a:bodyPr/>
+                    <a:lstStyle/>
+                    <a:p>
+                      <a:r>
+                        <a:rPr sz="1100" b="0">
+                          <a:solidFill>
+                            <a:srgbClr val="1C1C1C"/>
+                          </a:solidFill>
+                          <a:latin typeface="Arial"/>
+                        </a:rPr>
+                        <a:t>Progressive carries</a:t>
+                      </a:r>
+                    </a:p>
+                  </a:txBody>
+                  <a:tcPr>
+                    <a:solidFill>
+                      <a:srgbClr val="F2F2F2"/>
+                    </a:solidFill>
+                  </a:tcPr>
+                </a:tc>
+                <a:tc>
+                  <a:txBody>
+                    <a:bodyPr/>
+                    <a:lstStyle/>
+                    <a:p>
+                      <a:r>
+                        <a:rPr sz="1100" b="0">
+                          <a:solidFill>
+                            <a:srgbClr val="1C1C1C"/>
+                          </a:solidFill>
+                          <a:latin typeface="Arial"/>
+                        </a:rPr>
+                        <a:t>Carrying</a:t>
+                      </a:r>
+                    </a:p>
+                  </a:txBody>
+                  <a:tcPr>
+                    <a:solidFill>
+                      <a:srgbClr val="F2F2F2"/>
+                    </a:solidFill>
+                  </a:tcPr>
+                </a:tc>
+                <a:tc>
+                  <a:txBody>
+                    <a:bodyPr/>
+                    <a:lstStyle/>
+                    <a:p>
+                      <a:r>
+                        <a:rPr sz="1100" b="0">
+                          <a:solidFill>
+                            <a:srgbClr val="1C1C1C"/>
+                          </a:solidFill>
+                          <a:latin typeface="Arial"/>
+                        </a:rPr>
+                        <a:t>Planned OUT</a:t>
+                      </a:r>
+                    </a:p>
+                  </a:txBody>
+                  <a:tcPr>
+                    <a:solidFill>
+                      <a:srgbClr val="F2F2F2"/>
+                    </a:solidFill>
+                  </a:tcPr>
+                </a:tc>
+                <a:tc>
+                  <a:txBody>
+                    <a:bodyPr/>
+                    <a:lstStyle/>
+                    <a:p>
+                      <a:r>
+                        <a:rPr sz="1100" b="0">
+                          <a:solidFill>
+                            <a:srgbClr val="1C1C1C"/>
+                          </a:solidFill>
+                          <a:latin typeface="Arial"/>
+                        </a:rPr>
+                        <a:t>Drop vs Carries</a:t>
+                      </a:r>
+                    </a:p>
+                  </a:txBody>
+                  <a:tcPr>
+                    <a:solidFill>
+                      <a:srgbClr val="F2F2F2"/>
+                    </a:solidFill>
+                  </a:tcPr>
+                </a:tc>
+              </a:tr>
+              <a:tr h="347472">
+                <a:tc>
+                  <a:txBody>
+                    <a:bodyPr/>
+                    <a:lstStyle/>
+                    <a:p>
+                      <a:r>
+                        <a:rPr sz="1100" b="1">
+                          <a:solidFill>
+                            <a:srgbClr val="1C1C1C"/>
+                          </a:solidFill>
+                          <a:latin typeface="Arial"/>
+                        </a:rPr>
+                        <a:t>npxG</a:t>
+                      </a:r>
+                    </a:p>
+                  </a:txBody>
+                  <a:tcPr>
+                    <a:solidFill>
+                      <a:srgbClr val="F0FAF4"/>
+                    </a:solidFill>
+                  </a:tcPr>
+                </a:tc>
+                <a:tc>
+                  <a:txBody>
+                    <a:bodyPr/>
+                    <a:lstStyle/>
+                    <a:p>
+                      <a:r>
+                        <a:rPr sz="1100" b="1">
+                          <a:solidFill>
+                            <a:srgbClr val="1C1C1C"/>
+                          </a:solidFill>
+                          <a:latin typeface="Arial"/>
+                        </a:rPr>
+                        <a:t>Non-pen xG</a:t>
+                      </a:r>
+                    </a:p>
+                  </a:txBody>
+                  <a:tcPr>
+                    <a:solidFill>
+                      <a:srgbClr val="F0FAF4"/>
+                    </a:solidFill>
+                  </a:tcPr>
+                </a:tc>
+                <a:tc>
+                  <a:txBody>
+                    <a:bodyPr/>
+                    <a:lstStyle/>
+                    <a:p>
+                      <a:r>
+                        <a:rPr sz="1100" b="1">
+                          <a:solidFill>
+                            <a:srgbClr val="1C1C1C"/>
+                          </a:solidFill>
+                          <a:latin typeface="Arial"/>
+                        </a:rPr>
+                        <a:t>Attacking</a:t>
+                      </a:r>
+                    </a:p>
+                  </a:txBody>
+                  <a:tcPr>
+                    <a:solidFill>
+                      <a:srgbClr val="F0FAF4"/>
+                    </a:solidFill>
+                  </a:tcPr>
+                </a:tc>
+                <a:tc>
+                  <a:txBody>
+                    <a:bodyPr/>
+                    <a:lstStyle/>
+                    <a:p>
+                      <a:r>
+                        <a:rPr sz="1100" b="1">
+                          <a:solidFill>
+                            <a:srgbClr val="1C1C1C"/>
+                          </a:solidFill>
+                          <a:latin typeface="Arial"/>
+                        </a:rPr>
+                        <a:t>Planned PASS</a:t>
+                      </a:r>
+                    </a:p>
+                  </a:txBody>
+                  <a:tcPr>
+                    <a:solidFill>
+                      <a:srgbClr val="F0FAF4"/>
+                    </a:solidFill>
+                  </a:tcPr>
+                </a:tc>
+                <a:tc>
+                  <a:txBody>
+                    <a:bodyPr/>
+                    <a:lstStyle/>
+                    <a:p>
+                      <a:r>
+                        <a:rPr sz="1100" b="1">
+                          <a:solidFill>
+                            <a:srgbClr val="1C1C1C"/>
+                          </a:solidFill>
+                          <a:latin typeface="Arial"/>
+                        </a:rPr>
+                        <a:t>Keep over Shots (cluster)</a:t>
+                      </a:r>
+                    </a:p>
+                  </a:txBody>
+                  <a:tcPr>
+                    <a:solidFill>
+                      <a:srgbClr val="F0FAF4"/>
+                    </a:solidFill>
+                  </a:tcPr>
+                </a:tc>
+              </a:tr>
+              <a:tr h="347472">
+                <a:tc>
+                  <a:txBody>
+                    <a:bodyPr/>
+                    <a:lstStyle/>
+                    <a:p>
+                      <a:r>
+                        <a:rPr sz="1100" b="0">
+                          <a:solidFill>
+                            <a:srgbClr val="1C1C1C"/>
+                          </a:solidFill>
+                          <a:latin typeface="Arial"/>
+                        </a:rPr>
+                        <a:t>Sh</a:t>
+                      </a:r>
+                    </a:p>
+                  </a:txBody>
+                  <a:tcPr>
+                    <a:solidFill>
+                      <a:srgbClr val="F2F2F2"/>
+                    </a:solidFill>
+                  </a:tcPr>
+                </a:tc>
+                <a:tc>
+                  <a:txBody>
+                    <a:bodyPr/>
+                    <a:lstStyle/>
+                    <a:p>
+                      <a:r>
+                        <a:rPr sz="1100" b="0">
+                          <a:solidFill>
+                            <a:srgbClr val="1C1C1C"/>
+                          </a:solidFill>
+                          <a:latin typeface="Arial"/>
+                        </a:rPr>
+                        <a:t>Shots</a:t>
+                      </a:r>
+                    </a:p>
+                  </a:txBody>
+                  <a:tcPr>
+                    <a:solidFill>
+                      <a:srgbClr val="F2F2F2"/>
+                    </a:solidFill>
+                  </a:tcPr>
+                </a:tc>
+                <a:tc>
+                  <a:txBody>
+                    <a:bodyPr/>
+                    <a:lstStyle/>
+                    <a:p>
+                      <a:r>
+                        <a:rPr sz="1100" b="0">
+                          <a:solidFill>
+                            <a:srgbClr val="1C1C1C"/>
+                          </a:solidFill>
+                          <a:latin typeface="Arial"/>
+                        </a:rPr>
+                        <a:t>Attacking</a:t>
+                      </a:r>
+                    </a:p>
+                  </a:txBody>
+                  <a:tcPr>
+                    <a:solidFill>
+                      <a:srgbClr val="F2F2F2"/>
+                    </a:solidFill>
+                  </a:tcPr>
+                </a:tc>
+                <a:tc>
+                  <a:txBody>
+                    <a:bodyPr/>
+                    <a:lstStyle/>
+                    <a:p>
+                      <a:r>
+                        <a:rPr sz="1100" b="0">
+                          <a:solidFill>
+                            <a:srgbClr val="1C1C1C"/>
+                          </a:solidFill>
+                          <a:latin typeface="Arial"/>
+                        </a:rPr>
+                        <a:t>Planned OUT</a:t>
+                      </a:r>
+                    </a:p>
+                  </a:txBody>
+                  <a:tcPr>
+                    <a:solidFill>
+                      <a:srgbClr val="F2F2F2"/>
+                    </a:solidFill>
+                  </a:tcPr>
+                </a:tc>
+                <a:tc>
+                  <a:txBody>
+                    <a:bodyPr/>
+                    <a:lstStyle/>
+                    <a:p>
+                      <a:r>
+                        <a:rPr sz="1100" b="0">
+                          <a:solidFill>
+                            <a:srgbClr val="1C1C1C"/>
+                          </a:solidFill>
+                          <a:latin typeface="Arial"/>
+                        </a:rPr>
+                        <a:t>Drop vs npxG</a:t>
+                      </a:r>
+                    </a:p>
+                  </a:txBody>
+                  <a:tcPr>
+                    <a:solidFill>
+                      <a:srgbClr val="F2F2F2"/>
+                    </a:solidFill>
+                  </a:tcPr>
+                </a:tc>
+              </a:tr>
+              <a:tr h="347472">
+                <a:tc>
+                  <a:txBody>
+                    <a:bodyPr/>
+                    <a:lstStyle/>
+                    <a:p>
+                      <a:r>
+                        <a:rPr sz="1100" b="1">
+                          <a:solidFill>
+                            <a:srgbClr val="1C1C1C"/>
+                          </a:solidFill>
+                          <a:latin typeface="Arial"/>
+                        </a:rPr>
+                        <a:t>SCA</a:t>
+                      </a:r>
+                    </a:p>
+                  </a:txBody>
+                  <a:tcPr>
+                    <a:solidFill>
+                      <a:srgbClr val="F0FAF4"/>
+                    </a:solidFill>
+                  </a:tcPr>
+                </a:tc>
+                <a:tc>
+                  <a:txBody>
+                    <a:bodyPr/>
+                    <a:lstStyle/>
+                    <a:p>
+                      <a:r>
+                        <a:rPr sz="1100" b="1">
+                          <a:solidFill>
+                            <a:srgbClr val="1C1C1C"/>
+                          </a:solidFill>
+                          <a:latin typeface="Arial"/>
+                        </a:rPr>
+                        <a:t>Shot-creating actions</a:t>
+                      </a:r>
+                    </a:p>
+                  </a:txBody>
+                  <a:tcPr>
+                    <a:solidFill>
+                      <a:srgbClr val="F0FAF4"/>
+                    </a:solidFill>
+                  </a:tcPr>
+                </a:tc>
+                <a:tc>
+                  <a:txBody>
+                    <a:bodyPr/>
+                    <a:lstStyle/>
+                    <a:p>
+                      <a:r>
+                        <a:rPr sz="1100" b="1">
+                          <a:solidFill>
+                            <a:srgbClr val="1C1C1C"/>
+                          </a:solidFill>
+                          <a:latin typeface="Arial"/>
+                        </a:rPr>
+                        <a:t>Attacking</a:t>
+                      </a:r>
+                    </a:p>
+                  </a:txBody>
+                  <a:tcPr>
+                    <a:solidFill>
+                      <a:srgbClr val="F0FAF4"/>
+                    </a:solidFill>
+                  </a:tcPr>
+                </a:tc>
+                <a:tc>
+                  <a:txBody>
+                    <a:bodyPr/>
+                    <a:lstStyle/>
+                    <a:p>
+                      <a:r>
+                        <a:rPr sz="1100" b="1">
+                          <a:solidFill>
+                            <a:srgbClr val="1C1C1C"/>
+                          </a:solidFill>
+                          <a:latin typeface="Arial"/>
+                        </a:rPr>
+                        <a:t>Planned PASS</a:t>
+                      </a:r>
+                    </a:p>
+                  </a:txBody>
+                  <a:tcPr>
+                    <a:solidFill>
+                      <a:srgbClr val="F0FAF4"/>
+                    </a:solidFill>
+                  </a:tcPr>
+                </a:tc>
+                <a:tc>
+                  <a:txBody>
+                    <a:bodyPr/>
+                    <a:lstStyle/>
+                    <a:p>
+                      <a:r>
+                        <a:rPr sz="1100" b="1">
+                          <a:solidFill>
+                            <a:srgbClr val="1C1C1C"/>
+                          </a:solidFill>
+                          <a:latin typeface="Arial"/>
+                        </a:rPr>
+                        <a:t>Singleton</a:t>
+                      </a:r>
+                    </a:p>
+                  </a:txBody>
+                  <a:tcPr>
+                    <a:solidFill>
+                      <a:srgbClr val="F0FAF4"/>
+                    </a:solidFill>
+                  </a:tcPr>
+                </a:tc>
+              </a:tr>
+              <a:tr h="347472">
+                <a:tc>
+                  <a:txBody>
+                    <a:bodyPr/>
+                    <a:lstStyle/>
+                    <a:p>
+                      <a:r>
+                        <a:rPr sz="1100" b="1">
+                          <a:solidFill>
+                            <a:srgbClr val="1C1C1C"/>
+                          </a:solidFill>
+                          <a:latin typeface="Arial"/>
+                        </a:rPr>
+                        <a:t>Tkl</a:t>
+                      </a:r>
+                    </a:p>
+                  </a:txBody>
+                  <a:tcPr>
+                    <a:solidFill>
+                      <a:srgbClr val="F0FAF4"/>
+                    </a:solidFill>
+                  </a:tcPr>
+                </a:tc>
+                <a:tc>
+                  <a:txBody>
+                    <a:bodyPr/>
+                    <a:lstStyle/>
+                    <a:p>
+                      <a:r>
+                        <a:rPr sz="1100" b="1">
+                          <a:solidFill>
+                            <a:srgbClr val="1C1C1C"/>
+                          </a:solidFill>
+                          <a:latin typeface="Arial"/>
+                        </a:rPr>
+                        <a:t>Tackles</a:t>
+                      </a:r>
+                    </a:p>
+                  </a:txBody>
+                  <a:tcPr>
+                    <a:solidFill>
+                      <a:srgbClr val="F0FAF4"/>
+                    </a:solidFill>
+                  </a:tcPr>
+                </a:tc>
+                <a:tc>
+                  <a:txBody>
+                    <a:bodyPr/>
+                    <a:lstStyle/>
+                    <a:p>
+                      <a:r>
+                        <a:rPr sz="1100" b="1">
+                          <a:solidFill>
+                            <a:srgbClr val="1C1C1C"/>
+                          </a:solidFill>
+                          <a:latin typeface="Arial"/>
+                        </a:rPr>
+                        <a:t>Defending</a:t>
+                      </a:r>
+                    </a:p>
+                  </a:txBody>
+                  <a:tcPr>
+                    <a:solidFill>
+                      <a:srgbClr val="F0FAF4"/>
+                    </a:solidFill>
+                  </a:tcPr>
+                </a:tc>
+                <a:tc>
+                  <a:txBody>
+                    <a:bodyPr/>
+                    <a:lstStyle/>
+                    <a:p>
+                      <a:r>
+                        <a:rPr sz="1100" b="1">
+                          <a:solidFill>
+                            <a:srgbClr val="1C1C1C"/>
+                          </a:solidFill>
+                          <a:latin typeface="Arial"/>
+                        </a:rPr>
+                        <a:t>Planned PASS</a:t>
+                      </a:r>
+                    </a:p>
+                  </a:txBody>
+                  <a:tcPr>
+                    <a:solidFill>
+                      <a:srgbClr val="F0FAF4"/>
+                    </a:solidFill>
+                  </a:tcPr>
+                </a:tc>
+                <a:tc>
+                  <a:txBody>
+                    <a:bodyPr/>
+                    <a:lstStyle/>
+                    <a:p>
+                      <a:r>
+                        <a:rPr sz="1100" b="1">
+                          <a:solidFill>
+                            <a:srgbClr val="1C1C1C"/>
+                          </a:solidFill>
+                          <a:latin typeface="Arial"/>
+                        </a:rPr>
+                        <a:t>Singleton</a:t>
+                      </a:r>
+                    </a:p>
+                  </a:txBody>
+                  <a:tcPr>
+                    <a:solidFill>
+                      <a:srgbClr val="F0FAF4"/>
+                    </a:solidFill>
+                  </a:tcPr>
+                </a:tc>
+              </a:tr>
+              <a:tr h="347472">
+                <a:tc>
+                  <a:txBody>
+                    <a:bodyPr/>
+                    <a:lstStyle/>
+                    <a:p>
+                      <a:r>
+                        <a:rPr sz="1100" b="1">
+                          <a:solidFill>
+                            <a:srgbClr val="1C1C1C"/>
+                          </a:solidFill>
+                          <a:latin typeface="Arial"/>
+                        </a:rPr>
+                        <a:t>Int</a:t>
+                      </a:r>
+                    </a:p>
+                  </a:txBody>
+                  <a:tcPr>
+                    <a:solidFill>
+                      <a:srgbClr val="F0FAF4"/>
+                    </a:solidFill>
+                  </a:tcPr>
+                </a:tc>
+                <a:tc>
+                  <a:txBody>
+                    <a:bodyPr/>
+                    <a:lstStyle/>
+                    <a:p>
+                      <a:r>
+                        <a:rPr sz="1100" b="1">
+                          <a:solidFill>
+                            <a:srgbClr val="1C1C1C"/>
+                          </a:solidFill>
+                          <a:latin typeface="Arial"/>
+                        </a:rPr>
+                        <a:t>Interceptions</a:t>
+                      </a:r>
+                    </a:p>
+                  </a:txBody>
+                  <a:tcPr>
+                    <a:solidFill>
+                      <a:srgbClr val="F0FAF4"/>
+                    </a:solidFill>
+                  </a:tcPr>
+                </a:tc>
+                <a:tc>
+                  <a:txBody>
+                    <a:bodyPr/>
+                    <a:lstStyle/>
+                    <a:p>
+                      <a:r>
+                        <a:rPr sz="1100" b="1">
+                          <a:solidFill>
+                            <a:srgbClr val="1C1C1C"/>
+                          </a:solidFill>
+                          <a:latin typeface="Arial"/>
+                        </a:rPr>
+                        <a:t>Defending</a:t>
+                      </a:r>
+                    </a:p>
+                  </a:txBody>
+                  <a:tcPr>
+                    <a:solidFill>
+                      <a:srgbClr val="F0FAF4"/>
+                    </a:solidFill>
+                  </a:tcPr>
+                </a:tc>
+                <a:tc>
+                  <a:txBody>
+                    <a:bodyPr/>
+                    <a:lstStyle/>
+                    <a:p>
+                      <a:r>
+                        <a:rPr sz="1100" b="1">
+                          <a:solidFill>
+                            <a:srgbClr val="1C1C1C"/>
+                          </a:solidFill>
+                          <a:latin typeface="Arial"/>
+                        </a:rPr>
+                        <a:t>Planned PASS</a:t>
+                      </a:r>
+                    </a:p>
+                  </a:txBody>
+                  <a:tcPr>
+                    <a:solidFill>
+                      <a:srgbClr val="F0FAF4"/>
+                    </a:solidFill>
+                  </a:tcPr>
+                </a:tc>
+                <a:tc>
+                  <a:txBody>
+                    <a:bodyPr/>
+                    <a:lstStyle/>
+                    <a:p>
+                      <a:r>
+                        <a:rPr sz="1100" b="1">
+                          <a:solidFill>
+                            <a:srgbClr val="1C1C1C"/>
+                          </a:solidFill>
+                          <a:latin typeface="Arial"/>
+                        </a:rPr>
+                        <a:t>Singleton</a:t>
+                      </a:r>
+                    </a:p>
+                  </a:txBody>
+                  <a:tcPr>
+                    <a:solidFill>
+                      <a:srgbClr val="F0FAF4"/>
+                    </a:solidFill>
+                  </a:tcPr>
+                </a:tc>
+              </a:tr>
+              <a:tr h="347472">
+                <a:tc>
+                  <a:txBody>
+                    <a:bodyPr/>
+                    <a:lstStyle/>
+                    <a:p>
+                      <a:r>
+                        <a:rPr sz="1100" b="1">
+                          <a:solidFill>
+                            <a:srgbClr val="1C1C1C"/>
+                          </a:solidFill>
+                          <a:latin typeface="Arial"/>
+                        </a:rPr>
+                        <a:t>Aer</a:t>
+                      </a:r>
+                    </a:p>
+                  </a:txBody>
+                  <a:tcPr>
+                    <a:solidFill>
+                      <a:srgbClr val="F0FAF4"/>
+                    </a:solidFill>
+                  </a:tcPr>
+                </a:tc>
+                <a:tc>
+                  <a:txBody>
+                    <a:bodyPr/>
+                    <a:lstStyle/>
+                    <a:p>
+                      <a:r>
+                        <a:rPr sz="1100" b="1">
+                          <a:solidFill>
+                            <a:srgbClr val="1C1C1C"/>
+                          </a:solidFill>
+                          <a:latin typeface="Arial"/>
+                        </a:rPr>
+                        <a:t>Aerials won</a:t>
+                      </a:r>
+                    </a:p>
+                  </a:txBody>
+                  <a:tcPr>
+                    <a:solidFill>
+                      <a:srgbClr val="F0FAF4"/>
+                    </a:solidFill>
+                  </a:tcPr>
+                </a:tc>
+                <a:tc>
+                  <a:txBody>
+                    <a:bodyPr/>
+                    <a:lstStyle/>
+                    <a:p>
+                      <a:r>
+                        <a:rPr sz="1100" b="1">
+                          <a:solidFill>
+                            <a:srgbClr val="1C1C1C"/>
+                          </a:solidFill>
+                          <a:latin typeface="Arial"/>
+                        </a:rPr>
+                        <a:t>Defending</a:t>
+                      </a:r>
+                    </a:p>
+                  </a:txBody>
+                  <a:tcPr>
+                    <a:solidFill>
+                      <a:srgbClr val="F0FAF4"/>
+                    </a:solidFill>
+                  </a:tcPr>
+                </a:tc>
+                <a:tc>
+                  <a:txBody>
+                    <a:bodyPr/>
+                    <a:lstStyle/>
+                    <a:p>
+                      <a:r>
+                        <a:rPr sz="1100" b="1">
+                          <a:solidFill>
+                            <a:srgbClr val="1C1C1C"/>
+                          </a:solidFill>
+                          <a:latin typeface="Arial"/>
+                        </a:rPr>
+                        <a:t>Planned PASS</a:t>
+                      </a:r>
+                    </a:p>
+                  </a:txBody>
+                  <a:tcPr>
+                    <a:solidFill>
+                      <a:srgbClr val="F0FAF4"/>
+                    </a:solidFill>
+                  </a:tcPr>
+                </a:tc>
+                <a:tc>
+                  <a:txBody>
+                    <a:bodyPr/>
+                    <a:lstStyle/>
+                    <a:p>
+                      <a:r>
+                        <a:rPr sz="1100" b="1">
+                          <a:solidFill>
+                            <a:srgbClr val="1C1C1C"/>
+                          </a:solidFill>
+                          <a:latin typeface="Arial"/>
+                        </a:rPr>
+                        <a:t>Singleton</a:t>
+                      </a:r>
+                    </a:p>
+                  </a:txBody>
+                  <a:tcPr>
+                    <a:solidFill>
+                      <a:srgbClr val="F0FAF4"/>
+                    </a:solidFill>
+                  </a:tcPr>
+                </a:tc>
+              </a:tr>
+              <a:tr h="347472">
+                <a:tc>
+                  <a:txBody>
+                    <a:bodyPr/>
+                    <a:lstStyle/>
+                    <a:p>
+                      <a:r>
+                        <a:rPr sz="1100" b="1">
+                          <a:solidFill>
+                            <a:srgbClr val="1C1C1C"/>
+                          </a:solidFill>
+                          <a:latin typeface="Arial"/>
+                        </a:rPr>
+                        <a:t>AttPen</a:t>
+                      </a:r>
+                    </a:p>
+                  </a:txBody>
+                  <a:tcPr>
+                    <a:solidFill>
+                      <a:srgbClr val="F0FAF4"/>
+                    </a:solidFill>
+                  </a:tcPr>
+                </a:tc>
+                <a:tc>
+                  <a:txBody>
+                    <a:bodyPr/>
+                    <a:lstStyle/>
+                    <a:p>
+                      <a:r>
+                        <a:rPr sz="1100" b="1">
+                          <a:solidFill>
+                            <a:srgbClr val="1C1C1C"/>
+                          </a:solidFill>
+                          <a:latin typeface="Arial"/>
+                        </a:rPr>
+                        <a:t>Touches in attacking pen</a:t>
+                      </a:r>
+                    </a:p>
+                  </a:txBody>
+                  <a:tcPr>
+                    <a:solidFill>
+                      <a:srgbClr val="F0FAF4"/>
+                    </a:solidFill>
+                  </a:tcPr>
+                </a:tc>
+                <a:tc>
+                  <a:txBody>
+                    <a:bodyPr/>
+                    <a:lstStyle/>
+                    <a:p>
+                      <a:r>
+                        <a:rPr sz="1100" b="1">
+                          <a:solidFill>
+                            <a:srgbClr val="1C1C1C"/>
+                          </a:solidFill>
+                          <a:latin typeface="Arial"/>
+                        </a:rPr>
+                        <a:t>Attacking</a:t>
+                      </a:r>
+                    </a:p>
+                  </a:txBody>
+                  <a:tcPr>
+                    <a:solidFill>
+                      <a:srgbClr val="F0FAF4"/>
+                    </a:solidFill>
+                  </a:tcPr>
+                </a:tc>
+                <a:tc>
+                  <a:txBody>
+                    <a:bodyPr/>
+                    <a:lstStyle/>
+                    <a:p>
+                      <a:r>
+                        <a:rPr sz="1100" b="1">
+                          <a:solidFill>
+                            <a:srgbClr val="1C1C1C"/>
+                          </a:solidFill>
+                          <a:latin typeface="Arial"/>
+                        </a:rPr>
+                        <a:t>Planned PASS</a:t>
+                      </a:r>
+                    </a:p>
+                  </a:txBody>
+                  <a:tcPr>
+                    <a:solidFill>
+                      <a:srgbClr val="F0FAF4"/>
+                    </a:solidFill>
+                  </a:tcPr>
+                </a:tc>
+                <a:tc>
+                  <a:txBody>
+                    <a:bodyPr/>
+                    <a:lstStyle/>
+                    <a:p>
+                      <a:r>
+                        <a:rPr sz="1100" b="1">
+                          <a:solidFill>
+                            <a:srgbClr val="1C1C1C"/>
+                          </a:solidFill>
+                          <a:latin typeface="Arial"/>
+                        </a:rPr>
+                        <a:t>Singleton</a:t>
+                      </a:r>
+                    </a:p>
+                  </a:txBody>
+                  <a:tcPr>
+                    <a:solidFill>
+                      <a:srgbClr val="F0FAF4"/>
+                    </a:solidFill>
+                  </a:tcPr>
+                </a:tc>
+              </a:tr>
+            </a:tbl>
+          </a:graphicData>
+        </a:graphic>
+      </p:graphicFrame>
+      <p:sp>
+        <p:nvSpPr>
+          <p:cNvPr id="7" name="TextBox 6"/>
+          <p:cNvSpPr txBox="1"/>
+          <p:nvPr/>
+        </p:nvSpPr>
+        <p:spPr>
+          <a:xfrm>
+            <a:off x="502920" y="6172200"/>
+            <a:ext cx="11155680" cy="365760"/>
+          </a:xfrm>
+          <a:prstGeom prst="rect">
+            <a:avLst/>
+          </a:prstGeom>
+          <a:noFill/>
+        </p:spPr>
+        <p:txBody>
+          <a:bodyPr wrap="square">
+            <a:spAutoFit/>
+          </a:bodyPr>
+          <a:lstStyle/>
+          <a:p>
+            <a:r>
+              <a:rPr sz="1100" b="0">
+                <a:solidFill>
+                  <a:srgbClr val="8A5A00"/>
+                </a:solidFill>
+                <a:latin typeface="Arial"/>
+              </a:rPr>
+              <a:t>When FBref is frozen: swap Planned PASS/OUT for real prior→Y1 stability r (mirror the StatsBomb stability slide).</a:t>
+            </a:r>
+          </a:p>
+        </p:txBody>
+      </p:sp>
+    </p:spTree>
+  </p:cSld>
+  <p:clrMapOvr>
+    <a:masterClrMapping/>
+  </p:clrMapOvr>
+</p:sld>
+</file>
+
+<file path=ppt/slides/slide2.xml><?xml version="1.0" encoding="utf-8"?>
+<p:sld xmlns:a="http://schemas.openxmlformats.org/drawingml/2006/main" xmlns:p="http://schemas.openxmlformats.org/presentationml/2006/main" xmlns:r="http://schemas.openxmlformats.org/officeDocument/2006/relationships">
+  <p:cSld>
+    <p:spTree>
+      <p:nvGrpSpPr>
+        <p:cNvPr id="1" name=""/>
+        <p:cNvGrpSpPr/>
+        <p:nvPr/>
+      </p:nvGrpSpPr>
+      <p:grpSpPr/>
+      <p:sp>
+        <p:nvSpPr>
           <p:cNvPr id="3" name="TextBox 2"/>
           <p:cNvSpPr txBox="1"/>
           <p:nvPr/>
@@ -3669,8 +4728,8 @@
         </p:nvSpPr>
         <p:spPr>
           <a:xfrm>
-            <a:off x="457200" y="457200"/>
-            <a:ext cx="10972800" cy="548640"/>
+            <a:off x="502920" y="822960"/>
+            <a:ext cx="11155680" cy="365760"/>
           </a:xfrm>
           <a:prstGeom prst="rect">
             <a:avLst/>
@@ -3690,29 +4749,197 @@
                 </a:solidFill>
                 <a:latin typeface="Arial"/>
               </a:rPr>
-              <a:t>Tiers = sample scope (how big / how deep) — NOT “FBref vs StatsBomb”</a:t>
-            </a:r>
-          </a:p>
-          <a:p>
-            <a:r>
-              <a:rPr sz="1000" b="0">
+              <a:t>What Tier 1 and Tier 2 mean (tiers ≠ FBref vs StatsBomb)</a:t>
+            </a:r>
+          </a:p>
+        </p:txBody>
+      </p:sp>
+      <p:sp>
+        <p:nvSpPr>
+          <p:cNvPr id="5" name="TextBox 4"/>
+          <p:cNvSpPr txBox="1"/>
+          <p:nvPr/>
+        </p:nvSpPr>
+        <p:spPr>
+          <a:xfrm>
+            <a:off x="502920" y="1234440"/>
+            <a:ext cx="11155680" cy="2194560"/>
+          </a:xfrm>
+          <a:prstGeom prst="rect">
+            <a:avLst/>
+          </a:prstGeom>
+          <a:noFill/>
+        </p:spPr>
+        <p:txBody>
+          <a:bodyPr wrap="square">
+            <a:spAutoFit/>
+          </a:bodyPr>
+          <a:lstStyle/>
+          <a:p>
+            <a:r>
+              <a:rPr sz="1500" b="1">
+                <a:solidFill>
+                  <a:srgbClr val="1C1C1C"/>
+                </a:solidFill>
+                <a:latin typeface="Arial"/>
+              </a:rPr>
+              <a:t>Tier 1 — WIDE sample</a:t>
+            </a:r>
+          </a:p>
+          <a:p>
+            <a:r>
+              <a:rPr sz="1300" b="0">
                 <a:solidFill>
                   <a:srgbClr val="555555"/>
                 </a:solidFill>
                 <a:latin typeface="Arial"/>
               </a:rPr>
-              <a:t/>
-            </a:r>
-          </a:p>
-          <a:p>
-            <a:r>
-              <a:rPr sz="1400" b="1">
+              <a:t>Wide = many inbound players, thin questions. Cover almost every first Bundesliga season over several years.</a:t>
+            </a:r>
+          </a:p>
+          <a:p>
+            <a:r>
+              <a:rPr sz="1300" b="0">
                 <a:solidFill>
                   <a:srgbClr val="1C1C1C"/>
                 </a:solidFill>
                 <a:latin typeface="Arial"/>
               </a:rPr>
-              <a:t>Tier 1 — Wide outcomes (target N ≥ 500)</a:t>
+              <a:t>Target: N ≥ 500 player-seasons on FBref.</a:t>
+            </a:r>
+          </a:p>
+          <a:p>
+            <a:r>
+              <a:rPr sz="1300" b="0">
+                <a:solidFill>
+                  <a:srgbClr val="555555"/>
+                </a:solidFill>
+                <a:latin typeface="Arial"/>
+              </a:rPr>
+              <a:t>500 outcomes of what? Each arrival’s Bundesliga Year-1 playing outcomes — minutes share, and attack/defend</a:t>
+            </a:r>
+          </a:p>
+          <a:p>
+            <a:r>
+              <a:rPr sz="1300" b="0">
+                <a:solidFill>
+                  <a:srgbClr val="555555"/>
+                </a:solidFill>
+                <a:latin typeface="Arial"/>
+              </a:rPr>
+              <a:t>per-90 — rolled up by position and prior (source) league. Answers: who gets on the pitch / produces in Germany.</a:t>
+            </a:r>
+          </a:p>
+        </p:txBody>
+      </p:sp>
+      <p:sp>
+        <p:nvSpPr>
+          <p:cNvPr id="6" name="TextBox 5"/>
+          <p:cNvSpPr txBox="1"/>
+          <p:nvPr/>
+        </p:nvSpPr>
+        <p:spPr>
+          <a:xfrm>
+            <a:off x="502920" y="3520440"/>
+            <a:ext cx="11155680" cy="2103120"/>
+          </a:xfrm>
+          <a:prstGeom prst="rect">
+            <a:avLst/>
+          </a:prstGeom>
+          <a:noFill/>
+        </p:spPr>
+        <p:txBody>
+          <a:bodyPr wrap="square">
+            <a:spAutoFit/>
+          </a:bodyPr>
+          <a:lstStyle/>
+          <a:p>
+            <a:r>
+              <a:rPr sz="1500" b="1">
+                <a:solidFill>
+                  <a:srgbClr val="1C1C1C"/>
+                </a:solidFill>
+                <a:latin typeface="Arial"/>
+              </a:rPr>
+              <a:t>Tier 2 — DEEP sample (stability → redundancy → pizza)</a:t>
+            </a:r>
+          </a:p>
+          <a:p>
+            <a:r>
+              <a:rPr sz="1300" b="0">
+                <a:solidFill>
+                  <a:srgbClr val="555555"/>
+                </a:solidFill>
+                <a:latin typeface="Arial"/>
+              </a:rPr>
+              <a:t>Deep = fewer players, richer trait questions. Only arrivals with prior-league stats AND Bundesliga Y1 stats.</a:t>
+            </a:r>
+          </a:p>
+          <a:p>
+            <a:r>
+              <a:rPr sz="1300" b="0">
+                <a:solidFill>
+                  <a:srgbClr val="555555"/>
+                </a:solidFill>
+                <a:latin typeface="Arial"/>
+              </a:rPr>
+              <a:t>Stability = does the same per-90 trait in the prior league predict the same trait in Bundesliga Y1? (Pearson r)</a:t>
+            </a:r>
+          </a:p>
+          <a:p>
+            <a:r>
+              <a:rPr sz="1300" b="0">
+                <a:solidFill>
+                  <a:srgbClr val="555555"/>
+                </a:solidFill>
+                <a:latin typeface="Arial"/>
+              </a:rPr>
+              <a:t>Then drop redundant copies (|r|≥0.70) and build pizzas from the kept shortlist.</a:t>
+            </a:r>
+          </a:p>
+          <a:p>
+            <a:r>
+              <a:rPr sz="1300" b="0">
+                <a:solidFill>
+                  <a:srgbClr val="1C1C1C"/>
+                </a:solidFill>
+                <a:latin typeface="Arial"/>
+              </a:rPr>
+              <a:t>FBref target: 500+ paired seasons. StatsBomb live check: N=60 open-data pairs (done).</a:t>
+            </a:r>
+          </a:p>
+        </p:txBody>
+      </p:sp>
+      <p:sp>
+        <p:nvSpPr>
+          <p:cNvPr id="7" name="TextBox 6"/>
+          <p:cNvSpPr txBox="1"/>
+          <p:nvPr/>
+        </p:nvSpPr>
+        <p:spPr>
+          <a:xfrm>
+            <a:off x="502920" y="5760720"/>
+            <a:ext cx="11155680" cy="731520"/>
+          </a:xfrm>
+          <a:prstGeom prst="rect">
+            <a:avLst/>
+          </a:prstGeom>
+          <a:noFill/>
+        </p:spPr>
+        <p:txBody>
+          <a:bodyPr wrap="square">
+            <a:spAutoFit/>
+          </a:bodyPr>
+          <a:lstStyle/>
+          <a:p>
+            <a:r>
+              <a:rPr sz="1300" b="1">
+                <a:solidFill>
+                  <a:srgbClr val="1C1C1C"/>
+                </a:solidFill>
+                <a:latin typeface="Arial"/>
+              </a:rPr>
+              <a:t>FBref / StatsBomb are data sources. Tier 1 / Tier 2 are how wide vs how deep you analyze.</a:t>
             </a:r>
           </a:p>
           <a:p>
@@ -3723,419 +4950,7 @@
                 </a:solidFill>
                 <a:latin typeface="Arial"/>
               </a:rPr>
-              <a:t>All inbound / first Bundesliga seasons. Minutes + per-90 outcomes by position and source league.</a:t>
-            </a:r>
-          </a:p>
-          <a:p>
-            <a:r>
-              <a:rPr sz="800" b="0">
-                <a:solidFill>
-                  <a:srgbClr val="555555"/>
-                </a:solidFill>
-                <a:latin typeface="Arial"/>
-              </a:rPr>
-              <a:t/>
-            </a:r>
-          </a:p>
-          <a:p>
-            <a:r>
-              <a:rPr sz="1400" b="1">
-                <a:solidFill>
-                  <a:srgbClr val="1C1C1C"/>
-                </a:solidFill>
-                <a:latin typeface="Arial"/>
-              </a:rPr>
-              <a:t>Tier 2 — Deep portability → pizza</a:t>
-            </a:r>
-          </a:p>
-          <a:p>
-            <a:r>
-              <a:rPr sz="1200" b="0">
-                <a:solidFill>
-                  <a:srgbClr val="555555"/>
-                </a:solidFill>
-                <a:latin typeface="Arial"/>
-              </a:rPr>
-              <a:t>Paired prior→Y1 seasons: stability on all stats → redundancy → scout-card pizzas.</a:t>
-            </a:r>
-          </a:p>
-          <a:p>
-            <a:r>
-              <a:rPr sz="800" b="0">
-                <a:solidFill>
-                  <a:srgbClr val="555555"/>
-                </a:solidFill>
-                <a:latin typeface="Arial"/>
-              </a:rPr>
-              <a:t/>
-            </a:r>
-          </a:p>
-          <a:p>
-            <a:r>
-              <a:rPr sz="1400" b="1">
-                <a:solidFill>
-                  <a:srgbClr val="1C1C1C"/>
-                </a:solidFill>
-                <a:latin typeface="Arial"/>
-              </a:rPr>
-              <a:t>Data sources (separate idea):</a:t>
-            </a:r>
-          </a:p>
-          <a:p>
-            <a:r>
-              <a:rPr sz="1200" b="0">
-                <a:solidFill>
-                  <a:srgbClr val="555555"/>
-                </a:solidFill>
-                <a:latin typeface="Arial"/>
-              </a:rPr>
-              <a:t>• FBref = primary scale layer for Tier 1 + Tier 2 (season per-90). Not frozen yet.</a:t>
-            </a:r>
-          </a:p>
-          <a:p>
-            <a:r>
-              <a:rPr sz="1200" b="0">
-                <a:solidFill>
-                  <a:srgbClr val="555555"/>
-                </a:solidFill>
-                <a:latin typeface="Arial"/>
-              </a:rPr>
-              <a:t>• StatsBomb Open Data = live event-level deep dive on a smaller overlap (N=60 done).</a:t>
-            </a:r>
-          </a:p>
-        </p:txBody>
-      </p:sp>
-      <p:sp>
-        <p:nvSpPr>
-          <p:cNvPr id="5" name="TextBox 4"/>
-          <p:cNvSpPr txBox="1"/>
-          <p:nvPr/>
-        </p:nvSpPr>
-        <p:spPr>
-          <a:xfrm>
-            <a:off x="457200" y="960120"/>
-            <a:ext cx="10972800" cy="365760"/>
-          </a:xfrm>
-          <a:prstGeom prst="rect">
-            <a:avLst/>
-          </a:prstGeom>
-          <a:noFill/>
-        </p:spPr>
-        <p:txBody>
-          <a:bodyPr wrap="square">
-            <a:spAutoFit/>
-          </a:bodyPr>
-          <a:lstStyle/>
-          <a:p>
-            <a:r>
-              <a:rPr sz="1600" b="1">
-                <a:solidFill>
-                  <a:srgbClr val="1C1C1C"/>
-                </a:solidFill>
-                <a:latin typeface="Arial"/>
-              </a:rPr>
-              <a:t>Tiers = sample scope (how big / how deep) — NOT “FBref vs StatsBomb”</a:t>
-            </a:r>
-          </a:p>
-          <a:p>
-            <a:r>
-              <a:rPr sz="1000" b="0">
-                <a:solidFill>
-                  <a:srgbClr val="555555"/>
-                </a:solidFill>
-                <a:latin typeface="Arial"/>
-              </a:rPr>
-              <a:t/>
-            </a:r>
-          </a:p>
-          <a:p>
-            <a:r>
-              <a:rPr sz="1400" b="1">
-                <a:solidFill>
-                  <a:srgbClr val="1C1C1C"/>
-                </a:solidFill>
-                <a:latin typeface="Arial"/>
-              </a:rPr>
-              <a:t>Tier 1 — Wide outcomes (target N ≥ 500)</a:t>
-            </a:r>
-          </a:p>
-          <a:p>
-            <a:r>
-              <a:rPr sz="1200" b="0">
-                <a:solidFill>
-                  <a:srgbClr val="555555"/>
-                </a:solidFill>
-                <a:latin typeface="Arial"/>
-              </a:rPr>
-              <a:t>All inbound / first Bundesliga seasons. Minutes + per-90 outcomes by position and source league.</a:t>
-            </a:r>
-          </a:p>
-          <a:p>
-            <a:r>
-              <a:rPr sz="800" b="0">
-                <a:solidFill>
-                  <a:srgbClr val="555555"/>
-                </a:solidFill>
-                <a:latin typeface="Arial"/>
-              </a:rPr>
-              <a:t/>
-            </a:r>
-          </a:p>
-          <a:p>
-            <a:r>
-              <a:rPr sz="1400" b="1">
-                <a:solidFill>
-                  <a:srgbClr val="1C1C1C"/>
-                </a:solidFill>
-                <a:latin typeface="Arial"/>
-              </a:rPr>
-              <a:t>Tier 2 — Deep portability → pizza</a:t>
-            </a:r>
-          </a:p>
-          <a:p>
-            <a:r>
-              <a:rPr sz="1200" b="0">
-                <a:solidFill>
-                  <a:srgbClr val="555555"/>
-                </a:solidFill>
-                <a:latin typeface="Arial"/>
-              </a:rPr>
-              <a:t>Paired prior→Y1 seasons: stability on all stats → redundancy → scout-card pizzas.</a:t>
-            </a:r>
-          </a:p>
-          <a:p>
-            <a:r>
-              <a:rPr sz="800" b="0">
-                <a:solidFill>
-                  <a:srgbClr val="555555"/>
-                </a:solidFill>
-                <a:latin typeface="Arial"/>
-              </a:rPr>
-              <a:t/>
-            </a:r>
-          </a:p>
-          <a:p>
-            <a:r>
-              <a:rPr sz="1400" b="1">
-                <a:solidFill>
-                  <a:srgbClr val="1C1C1C"/>
-                </a:solidFill>
-                <a:latin typeface="Arial"/>
-              </a:rPr>
-              <a:t>Data sources (separate idea):</a:t>
-            </a:r>
-          </a:p>
-          <a:p>
-            <a:r>
-              <a:rPr sz="1200" b="0">
-                <a:solidFill>
-                  <a:srgbClr val="555555"/>
-                </a:solidFill>
-                <a:latin typeface="Arial"/>
-              </a:rPr>
-              <a:t>• FBref = primary scale layer for Tier 1 + Tier 2 (season per-90). Not frozen yet.</a:t>
-            </a:r>
-          </a:p>
-          <a:p>
-            <a:r>
-              <a:rPr sz="1200" b="0">
-                <a:solidFill>
-                  <a:srgbClr val="555555"/>
-                </a:solidFill>
-                <a:latin typeface="Arial"/>
-              </a:rPr>
-              <a:t>• StatsBomb Open Data = live event-level deep dive on a smaller overlap (N=60 done).</a:t>
-            </a:r>
-          </a:p>
-        </p:txBody>
-      </p:sp>
-      <p:sp>
-        <p:nvSpPr>
-          <p:cNvPr id="6" name="Rounded Rectangle 5"/>
-          <p:cNvSpPr/>
-          <p:nvPr/>
-        </p:nvSpPr>
-        <p:spPr>
-          <a:xfrm>
-            <a:off x="457200" y="1554480"/>
-            <a:ext cx="5486400" cy="3200400"/>
-          </a:xfrm>
-          <a:prstGeom prst="roundRect">
-            <a:avLst/>
-          </a:prstGeom>
-          <a:solidFill>
-            <a:srgbClr val="F4F5F7"/>
-          </a:solidFill>
-          <a:ln>
-            <a:solidFill>
-              <a:srgbClr val="D0D4DB"/>
-            </a:solidFill>
-          </a:ln>
-        </p:spPr>
-        <p:style>
-          <a:lnRef idx="1">
-            <a:schemeClr val="accent1"/>
-          </a:lnRef>
-          <a:fillRef idx="3">
-            <a:schemeClr val="accent1"/>
-          </a:fillRef>
-          <a:effectRef idx="2">
-            <a:schemeClr val="accent1"/>
-          </a:effectRef>
-          <a:fontRef idx="minor">
-            <a:schemeClr val="lt1"/>
-          </a:fontRef>
-        </p:style>
-        <p:txBody>
-          <a:bodyPr rtlCol="0" anchor="ctr"/>
-          <a:lstStyle/>
-          <a:p>
-            <a:pPr algn="ctr"/>
-          </a:p>
-        </p:txBody>
-      </p:sp>
-      <p:sp>
-        <p:nvSpPr>
-          <p:cNvPr id="7" name="TextBox 6"/>
-          <p:cNvSpPr txBox="1"/>
-          <p:nvPr/>
-        </p:nvSpPr>
-        <p:spPr>
-          <a:xfrm>
-            <a:off x="594360" y="1691639"/>
-            <a:ext cx="5212080" cy="2926080"/>
-          </a:xfrm>
-          <a:prstGeom prst="rect">
-            <a:avLst/>
-          </a:prstGeom>
-          <a:noFill/>
-        </p:spPr>
-        <p:txBody>
-          <a:bodyPr wrap="square">
-            <a:spAutoFit/>
-          </a:bodyPr>
-          <a:lstStyle/>
-          <a:p>
-            <a:r>
-              <a:rPr sz="1300" b="1">
-                <a:solidFill>
-                  <a:srgbClr val="1C1C1C"/>
-                </a:solidFill>
-                <a:latin typeface="Arial"/>
-              </a:rPr>
-              <a:t>Remember: Tier 1 / Tier 2 describe the study design.</a:t>
-            </a:r>
-          </a:p>
-          <a:p>
-            <a:r>
-              <a:rPr sz="1200" b="0">
-                <a:solidFill>
-                  <a:srgbClr val="1C1C1C"/>
-                </a:solidFill>
-                <a:latin typeface="Arial"/>
-              </a:rPr>
-              <a:t/>
-            </a:r>
-          </a:p>
-          <a:p>
-            <a:r>
-              <a:rPr sz="1300" b="0">
-                <a:solidFill>
-                  <a:srgbClr val="555555"/>
-                </a:solidFill>
-                <a:latin typeface="Arial"/>
-              </a:rPr>
-              <a:t>FBref / StatsBomb describe which dataset feeds that design.</a:t>
-            </a:r>
-          </a:p>
-        </p:txBody>
-      </p:sp>
-      <p:sp>
-        <p:nvSpPr>
-          <p:cNvPr id="8" name="Rounded Rectangle 7"/>
-          <p:cNvSpPr/>
-          <p:nvPr/>
-        </p:nvSpPr>
-        <p:spPr>
-          <a:xfrm>
-            <a:off x="6217920" y="1554480"/>
-            <a:ext cx="5486400" cy="3200400"/>
-          </a:xfrm>
-          <a:prstGeom prst="roundRect">
-            <a:avLst/>
-          </a:prstGeom>
-          <a:solidFill>
-            <a:srgbClr val="F4F5F7"/>
-          </a:solidFill>
-          <a:ln>
-            <a:solidFill>
-              <a:srgbClr val="D0D4DB"/>
-            </a:solidFill>
-          </a:ln>
-        </p:spPr>
-        <p:style>
-          <a:lnRef idx="1">
-            <a:schemeClr val="accent1"/>
-          </a:lnRef>
-          <a:fillRef idx="3">
-            <a:schemeClr val="accent1"/>
-          </a:fillRef>
-          <a:effectRef idx="2">
-            <a:schemeClr val="accent1"/>
-          </a:effectRef>
-          <a:fontRef idx="minor">
-            <a:schemeClr val="lt1"/>
-          </a:fontRef>
-        </p:style>
-        <p:txBody>
-          <a:bodyPr rtlCol="0" anchor="ctr"/>
-          <a:lstStyle/>
-          <a:p>
-            <a:pPr algn="ctr"/>
-          </a:p>
-        </p:txBody>
-      </p:sp>
-      <p:sp>
-        <p:nvSpPr>
-          <p:cNvPr id="9" name="TextBox 8"/>
-          <p:cNvSpPr txBox="1"/>
-          <p:nvPr/>
-        </p:nvSpPr>
-        <p:spPr>
-          <a:xfrm>
-            <a:off x="6355080" y="1691639"/>
-            <a:ext cx="5212080" cy="2926080"/>
-          </a:xfrm>
-          <a:prstGeom prst="rect">
-            <a:avLst/>
-          </a:prstGeom>
-          <a:noFill/>
-        </p:spPr>
-        <p:txBody>
-          <a:bodyPr wrap="square">
-            <a:spAutoFit/>
-          </a:bodyPr>
-          <a:lstStyle/>
-          <a:p>
-            <a:r>
-              <a:rPr sz="1300" b="1">
-                <a:solidFill>
-                  <a:srgbClr val="555555"/>
-                </a:solidFill>
-                <a:latin typeface="Arial"/>
-              </a:rPr>
-              <a:t>Live now: StatsBomb deep dive (N=60). Next: FBref freeze for Tier 1 + Tier 2 at scale.</a:t>
-            </a:r>
-          </a:p>
-          <a:p>
-            <a:r>
-              <a:rPr sz="1200" b="0">
-                <a:solidFill>
-                  <a:srgbClr val="1C1C1C"/>
-                </a:solidFill>
-                <a:latin typeface="Arial"/>
-              </a:rPr>
-              <a:t/>
+              <a:t>FBref = scale layer for both tiers. StatsBomb = live event-level Tier-2 deep dive.</a:t>
             </a:r>
           </a:p>
         </p:txBody>
@@ -7888,7 +8703,51 @@
                 </a:solidFill>
                 <a:latin typeface="Arial"/>
               </a:rPr>
-              <a:t>StatsBomb shortlist pizza · percentiles vs Bundesliga peers</a:t>
+              <a:t/>
+            </a:r>
+          </a:p>
+          <a:p>
+            <a:r>
+              <a:rPr sz="1200" b="0">
+                <a:solidFill>
+                  <a:srgbClr val="555555"/>
+                </a:solidFill>
+                <a:latin typeface="Arial"/>
+              </a:rPr>
+              <a:t/>
+            </a:r>
+          </a:p>
+          <a:p>
+            <a:r>
+              <a:rPr sz="1200" b="0">
+                <a:solidFill>
+                  <a:srgbClr val="555555"/>
+                </a:solidFill>
+                <a:latin typeface="Arial"/>
+              </a:rPr>
+              <a:t/>
+            </a:r>
+          </a:p>
+          <a:p>
+            <a:r>
+              <a:rPr sz="1200" b="0">
+                <a:solidFill>
+                  <a:srgbClr val="555555"/>
+                </a:solidFill>
+                <a:latin typeface="Arial"/>
+              </a:rPr>
+              <a:t/>
+            </a:r>
+          </a:p>
+          <a:p>
+            <a:r>
+              <a:rPr sz="1200" b="0">
+                <a:solidFill>
+                  <a:srgbClr val="555555"/>
+                </a:solidFill>
+                <a:latin typeface="Arial"/>
+              </a:rPr>
+              <a:t>StatsBomb shortlist · rings marked 0%ile–100%ile</a:t>
             </a:r>
           </a:p>
         </p:txBody>
@@ -8001,7 +8860,7 @@
                 </a:solidFill>
                 <a:latin typeface="Arial"/>
               </a:rPr>
-              <a:t>How to read (percentiles — not raw rates)</a:t>
+              <a:t>How to read the ring numbers</a:t>
             </a:r>
           </a:p>
           <a:p>
@@ -8023,7 +8882,7 @@
                 </a:solidFill>
                 <a:latin typeface="Arial"/>
               </a:rPr>
-              <a:t>Wedge length = Year-1 Bundesliga percentile vs peers at the position.</a:t>
+              <a:t/>
             </a:r>
           </a:p>
           <a:p>
@@ -8034,7 +8893,7 @@
                 </a:solidFill>
                 <a:latin typeface="Arial"/>
               </a:rPr>
-              <a:t>Center = 0th %ile · Outer rim = 100th %ile (best vs peers).</a:t>
+              <a:t/>
             </a:r>
           </a:p>
           <a:p>
@@ -8045,7 +8904,7 @@
                 </a:solidFill>
                 <a:latin typeface="Arial"/>
               </a:rPr>
-              <a:t>Dashed arc ≈ average peer (~50th). Solid arc ≈ top peer (~90th).</a:t>
+              <a:t/>
             </a:r>
           </a:p>
           <a:p>
@@ -8056,7 +8915,40 @@
                 </a:solidFill>
                 <a:latin typeface="Arial"/>
               </a:rPr>
-              <a:t>Only traits that passed stability + redundancy appear on the pizza.</a:t>
+              <a:t/>
+            </a:r>
+          </a:p>
+          <a:p>
+            <a:r>
+              <a:rPr sz="1200" b="0">
+                <a:solidFill>
+                  <a:srgbClr val="555555"/>
+                </a:solidFill>
+                <a:latin typeface="Arial"/>
+              </a:rPr>
+              <a:t>0 / 25 / 50 / 75 / 100 = percentile vs Bundesliga peers (labeled %ile — not raw per-90).</a:t>
+            </a:r>
+          </a:p>
+          <a:p>
+            <a:r>
+              <a:rPr sz="1200" b="0">
+                <a:solidFill>
+                  <a:srgbClr val="555555"/>
+                </a:solidFill>
+                <a:latin typeface="Arial"/>
+              </a:rPr>
+              <a:t>Center = 0th %ile · rim = 100th %ile. Dashed ≈ 50th (avg). Solid ≈ ~90th (top).</a:t>
+            </a:r>
+          </a:p>
+          <a:p>
+            <a:r>
+              <a:rPr sz="1200" b="0">
+                <a:solidFill>
+                  <a:srgbClr val="555555"/>
+                </a:solidFill>
+                <a:latin typeface="Arial"/>
+              </a:rPr>
+              <a:t>Wedge length = this player’s Year-1 percentile on each kept trait.</a:t>
             </a:r>
           </a:p>
         </p:txBody>
@@ -8070,15 +8962,15 @@
           <p:nvPr/>
         </p:nvPicPr>
         <p:blipFill>
-          <a:blip r:embed="rId3"/>
+          <a:blip r:embed="rId4"/>
           <a:stretch>
             <a:fillRect/>
           </a:stretch>
         </p:blipFill>
         <p:spPr>
           <a:xfrm>
-            <a:off x="365760" y="1051560"/>
-            <a:ext cx="4754733" cy="5029200"/>
+            <a:off x="320040" y="960120"/>
+            <a:ext cx="4791937" cy="5120640"/>
           </a:xfrm>
           <a:prstGeom prst="rect">
             <a:avLst/>

</xml_diff>

<commit_message>
Restore original mock pizza; clarify FBref stability was not run.
</commit_message>
<xml_diff>
--- a/bundesliga_transfer_traits.pptx
+++ b/bundesliga_transfer_traits.pptx
@@ -5984,6 +5984,1607 @@
             <a:avLst/>
           </a:prstGeom>
           <a:solidFill>
+            <a:srgbClr val="F4F5F7"/>
+          </a:solidFill>
+          <a:ln>
+            <a:noFill/>
+          </a:ln>
+        </p:spPr>
+        <p:style>
+          <a:lnRef idx="1">
+            <a:schemeClr val="accent1"/>
+          </a:lnRef>
+          <a:fillRef idx="3">
+            <a:schemeClr val="accent1"/>
+          </a:fillRef>
+          <a:effectRef idx="2">
+            <a:schemeClr val="accent1"/>
+          </a:effectRef>
+          <a:fontRef idx="minor">
+            <a:schemeClr val="lt1"/>
+          </a:fontRef>
+        </p:style>
+        <p:txBody>
+          <a:bodyPr rtlCol="0" anchor="ctr"/>
+          <a:lstStyle/>
+          <a:p>
+            <a:pPr algn="ctr"/>
+          </a:p>
+        </p:txBody>
+      </p:sp>
+      <p:sp>
+        <p:nvSpPr>
+          <p:cNvPr id="3" name="Rectangle 2"/>
+          <p:cNvSpPr/>
+          <p:nvPr/>
+        </p:nvSpPr>
+        <p:spPr>
+          <a:xfrm>
+            <a:off x="0" y="0"/>
+            <a:ext cx="137160" cy="6858000"/>
+          </a:xfrm>
+          <a:prstGeom prst="rect">
+            <a:avLst/>
+          </a:prstGeom>
+          <a:solidFill>
+            <a:srgbClr val="3D5A80"/>
+          </a:solidFill>
+          <a:ln>
+            <a:noFill/>
+          </a:ln>
+        </p:spPr>
+        <p:style>
+          <a:lnRef idx="1">
+            <a:schemeClr val="accent1"/>
+          </a:lnRef>
+          <a:fillRef idx="3">
+            <a:schemeClr val="accent1"/>
+          </a:fillRef>
+          <a:effectRef idx="2">
+            <a:schemeClr val="accent1"/>
+          </a:effectRef>
+          <a:fontRef idx="minor">
+            <a:schemeClr val="lt1"/>
+          </a:fontRef>
+        </p:style>
+        <p:txBody>
+          <a:bodyPr rtlCol="0" anchor="ctr"/>
+          <a:lstStyle/>
+          <a:p>
+            <a:pPr algn="ctr"/>
+          </a:p>
+        </p:txBody>
+      </p:sp>
+      <p:sp>
+        <p:nvSpPr>
+          <p:cNvPr id="4" name="TextBox 3"/>
+          <p:cNvSpPr txBox="1"/>
+          <p:nvPr/>
+        </p:nvSpPr>
+        <p:spPr>
+          <a:xfrm>
+            <a:off x="502920" y="228600"/>
+            <a:ext cx="11155680" cy="411480"/>
+          </a:xfrm>
+          <a:prstGeom prst="rect">
+            <a:avLst/>
+          </a:prstGeom>
+          <a:noFill/>
+        </p:spPr>
+        <p:txBody>
+          <a:bodyPr wrap="square">
+            <a:spAutoFit/>
+          </a:bodyPr>
+          <a:lstStyle/>
+          <a:p>
+            <a:r>
+              <a:rPr sz="2200" b="1">
+                <a:solidFill>
+                  <a:srgbClr val="1C1C1C"/>
+                </a:solidFill>
+                <a:latin typeface="Georgia"/>
+              </a:rPr>
+              <a:t>FBref stability — NOT RUN YET (planned list only)</a:t>
+            </a:r>
+          </a:p>
+        </p:txBody>
+      </p:sp>
+      <p:sp>
+        <p:nvSpPr>
+          <p:cNvPr id="5" name="TextBox 4"/>
+          <p:cNvSpPr txBox="1"/>
+          <p:nvPr/>
+        </p:nvSpPr>
+        <p:spPr>
+          <a:xfrm>
+            <a:off x="502920" y="685800"/>
+            <a:ext cx="11155680" cy="502920"/>
+          </a:xfrm>
+          <a:prstGeom prst="rect">
+            <a:avLst/>
+          </a:prstGeom>
+          <a:noFill/>
+        </p:spPr>
+        <p:txBody>
+          <a:bodyPr wrap="square">
+            <a:spAutoFit/>
+          </a:bodyPr>
+          <a:lstStyle/>
+          <a:p>
+            <a:r>
+              <a:rPr sz="1300" b="1">
+                <a:solidFill>
+                  <a:srgbClr val="1C1C1C"/>
+                </a:solidFill>
+                <a:latin typeface="Arial"/>
+              </a:rPr>
+              <a:t>Only StatsBomb stability has been computed (N=60). FBref Tier 2 pairs are not frozen.</a:t>
+            </a:r>
+          </a:p>
+          <a:p>
+            <a:r>
+              <a:rPr sz="1300" b="0">
+                <a:solidFill>
+                  <a:srgbClr val="555555"/>
+                </a:solidFill>
+                <a:latin typeface="Arial"/>
+              </a:rPr>
+              <a:t/>
+            </a:r>
+          </a:p>
+          <a:p>
+            <a:r>
+              <a:rPr sz="1300" b="0">
+                <a:solidFill>
+                  <a:srgbClr val="555555"/>
+                </a:solidFill>
+                <a:latin typeface="Arial"/>
+              </a:rPr>
+              <a:t>Table below is your Step-2 plan for when FBref is run — not real FBref r values.</a:t>
+            </a:r>
+          </a:p>
+        </p:txBody>
+      </p:sp>
+      <p:graphicFrame>
+        <p:nvGraphicFramePr>
+          <p:cNvPr id="6" name="Table 5"/>
+          <p:cNvGraphicFramePr>
+            <a:graphicFrameLocks noGrp="1"/>
+          </p:cNvGraphicFramePr>
+          <p:nvPr/>
+        </p:nvGraphicFramePr>
+        <p:xfrm>
+          <a:off x="411480" y="1325880"/>
+          <a:ext cx="11338560" cy="4169664"/>
+        </p:xfrm>
+        <a:graphic>
+          <a:graphicData uri="http://schemas.openxmlformats.org/drawingml/2006/table">
+            <a:tbl>
+              <a:tblPr firstRow="1" bandRow="1">
+                <a:tableStyleId>{5C22544A-7EE6-4342-B048-85BDC9FD1C3A}</a:tableStyleId>
+              </a:tblPr>
+              <a:tblGrid>
+                <a:gridCol w="914400"/>
+                <a:gridCol w="2743200"/>
+                <a:gridCol w="1371600"/>
+                <a:gridCol w="2011680"/>
+                <a:gridCol w="4297680"/>
+              </a:tblGrid>
+              <a:tr h="347472">
+                <a:tc>
+                  <a:txBody>
+                    <a:bodyPr/>
+                    <a:lstStyle/>
+                    <a:p>
+                      <a:r>
+                        <a:rPr sz="1100" b="1">
+                          <a:solidFill>
+                            <a:srgbClr val="FFFFFF"/>
+                          </a:solidFill>
+                          <a:latin typeface="Arial"/>
+                        </a:rPr>
+                        <a:t>Abbrev</a:t>
+                      </a:r>
+                    </a:p>
+                  </a:txBody>
+                  <a:tcPr>
+                    <a:solidFill>
+                      <a:srgbClr val="1C1C1C"/>
+                    </a:solidFill>
+                  </a:tcPr>
+                </a:tc>
+                <a:tc>
+                  <a:txBody>
+                    <a:bodyPr/>
+                    <a:lstStyle/>
+                    <a:p>
+                      <a:r>
+                        <a:rPr sz="1100" b="1">
+                          <a:solidFill>
+                            <a:srgbClr val="FFFFFF"/>
+                          </a:solidFill>
+                          <a:latin typeface="Arial"/>
+                        </a:rPr>
+                        <a:t>FBref metric</a:t>
+                      </a:r>
+                    </a:p>
+                  </a:txBody>
+                  <a:tcPr>
+                    <a:solidFill>
+                      <a:srgbClr val="1C1C1C"/>
+                    </a:solidFill>
+                  </a:tcPr>
+                </a:tc>
+                <a:tc>
+                  <a:txBody>
+                    <a:bodyPr/>
+                    <a:lstStyle/>
+                    <a:p>
+                      <a:r>
+                        <a:rPr sz="1100" b="1">
+                          <a:solidFill>
+                            <a:srgbClr val="FFFFFF"/>
+                          </a:solidFill>
+                          <a:latin typeface="Arial"/>
+                        </a:rPr>
+                        <a:t>Category</a:t>
+                      </a:r>
+                    </a:p>
+                  </a:txBody>
+                  <a:tcPr>
+                    <a:solidFill>
+                      <a:srgbClr val="1C1C1C"/>
+                    </a:solidFill>
+                  </a:tcPr>
+                </a:tc>
+                <a:tc>
+                  <a:txBody>
+                    <a:bodyPr/>
+                    <a:lstStyle/>
+                    <a:p>
+                      <a:r>
+                        <a:rPr sz="1100" b="1">
+                          <a:solidFill>
+                            <a:srgbClr val="FFFFFF"/>
+                          </a:solidFill>
+                          <a:latin typeface="Arial"/>
+                        </a:rPr>
+                        <a:t>Stability status</a:t>
+                      </a:r>
+                    </a:p>
+                  </a:txBody>
+                  <a:tcPr>
+                    <a:solidFill>
+                      <a:srgbClr val="1C1C1C"/>
+                    </a:solidFill>
+                  </a:tcPr>
+                </a:tc>
+                <a:tc>
+                  <a:txBody>
+                    <a:bodyPr/>
+                    <a:lstStyle/>
+                    <a:p>
+                      <a:r>
+                        <a:rPr sz="1100" b="1">
+                          <a:solidFill>
+                            <a:srgbClr val="FFFFFF"/>
+                          </a:solidFill>
+                          <a:latin typeface="Arial"/>
+                        </a:rPr>
+                        <a:t>Note</a:t>
+                      </a:r>
+                    </a:p>
+                  </a:txBody>
+                  <a:tcPr>
+                    <a:solidFill>
+                      <a:srgbClr val="1C1C1C"/>
+                    </a:solidFill>
+                  </a:tcPr>
+                </a:tc>
+              </a:tr>
+              <a:tr h="347472">
+                <a:tc>
+                  <a:txBody>
+                    <a:bodyPr/>
+                    <a:lstStyle/>
+                    <a:p>
+                      <a:r>
+                        <a:rPr sz="1100" b="1">
+                          <a:solidFill>
+                            <a:srgbClr val="1C1C1C"/>
+                          </a:solidFill>
+                          <a:latin typeface="Arial"/>
+                        </a:rPr>
+                        <a:t>PrgP</a:t>
+                      </a:r>
+                    </a:p>
+                  </a:txBody>
+                  <a:tcPr>
+                    <a:solidFill>
+                      <a:srgbClr val="F0FAF4"/>
+                    </a:solidFill>
+                  </a:tcPr>
+                </a:tc>
+                <a:tc>
+                  <a:txBody>
+                    <a:bodyPr/>
+                    <a:lstStyle/>
+                    <a:p>
+                      <a:r>
+                        <a:rPr sz="1100" b="1">
+                          <a:solidFill>
+                            <a:srgbClr val="1C1C1C"/>
+                          </a:solidFill>
+                          <a:latin typeface="Arial"/>
+                        </a:rPr>
+                        <a:t>Progressive passes</a:t>
+                      </a:r>
+                    </a:p>
+                  </a:txBody>
+                  <a:tcPr>
+                    <a:solidFill>
+                      <a:srgbClr val="F0FAF4"/>
+                    </a:solidFill>
+                  </a:tcPr>
+                </a:tc>
+                <a:tc>
+                  <a:txBody>
+                    <a:bodyPr/>
+                    <a:lstStyle/>
+                    <a:p>
+                      <a:r>
+                        <a:rPr sz="1100" b="1">
+                          <a:solidFill>
+                            <a:srgbClr val="1C1C1C"/>
+                          </a:solidFill>
+                          <a:latin typeface="Arial"/>
+                        </a:rPr>
+                        <a:t>Passing</a:t>
+                      </a:r>
+                    </a:p>
+                  </a:txBody>
+                  <a:tcPr>
+                    <a:solidFill>
+                      <a:srgbClr val="F0FAF4"/>
+                    </a:solidFill>
+                  </a:tcPr>
+                </a:tc>
+                <a:tc>
+                  <a:txBody>
+                    <a:bodyPr/>
+                    <a:lstStyle/>
+                    <a:p>
+                      <a:r>
+                        <a:rPr sz="1100" b="1">
+                          <a:solidFill>
+                            <a:srgbClr val="1C1C1C"/>
+                          </a:solidFill>
+                          <a:latin typeface="Arial"/>
+                        </a:rPr>
+                        <a:t>Planned PASS</a:t>
+                      </a:r>
+                    </a:p>
+                  </a:txBody>
+                  <a:tcPr>
+                    <a:solidFill>
+                      <a:srgbClr val="F0FAF4"/>
+                    </a:solidFill>
+                  </a:tcPr>
+                </a:tc>
+                <a:tc>
+                  <a:txBody>
+                    <a:bodyPr/>
+                    <a:lstStyle/>
+                    <a:p>
+                      <a:r>
+                        <a:rPr sz="1100" b="1">
+                          <a:solidFill>
+                            <a:srgbClr val="1C1C1C"/>
+                          </a:solidFill>
+                          <a:latin typeface="Arial"/>
+                        </a:rPr>
+                        <a:t>Keep over Passes (cluster)</a:t>
+                      </a:r>
+                    </a:p>
+                  </a:txBody>
+                  <a:tcPr>
+                    <a:solidFill>
+                      <a:srgbClr val="F0FAF4"/>
+                    </a:solidFill>
+                  </a:tcPr>
+                </a:tc>
+              </a:tr>
+              <a:tr h="347472">
+                <a:tc>
+                  <a:txBody>
+                    <a:bodyPr/>
+                    <a:lstStyle/>
+                    <a:p>
+                      <a:r>
+                        <a:rPr sz="1100" b="0">
+                          <a:solidFill>
+                            <a:srgbClr val="1C1C1C"/>
+                          </a:solidFill>
+                          <a:latin typeface="Arial"/>
+                        </a:rPr>
+                        <a:t>Pass</a:t>
+                      </a:r>
+                    </a:p>
+                  </a:txBody>
+                  <a:tcPr>
+                    <a:solidFill>
+                      <a:srgbClr val="F2F2F2"/>
+                    </a:solidFill>
+                  </a:tcPr>
+                </a:tc>
+                <a:tc>
+                  <a:txBody>
+                    <a:bodyPr/>
+                    <a:lstStyle/>
+                    <a:p>
+                      <a:r>
+                        <a:rPr sz="1100" b="0">
+                          <a:solidFill>
+                            <a:srgbClr val="1C1C1C"/>
+                          </a:solidFill>
+                          <a:latin typeface="Arial"/>
+                        </a:rPr>
+                        <a:t>Passes (volume)</a:t>
+                      </a:r>
+                    </a:p>
+                  </a:txBody>
+                  <a:tcPr>
+                    <a:solidFill>
+                      <a:srgbClr val="F2F2F2"/>
+                    </a:solidFill>
+                  </a:tcPr>
+                </a:tc>
+                <a:tc>
+                  <a:txBody>
+                    <a:bodyPr/>
+                    <a:lstStyle/>
+                    <a:p>
+                      <a:r>
+                        <a:rPr sz="1100" b="0">
+                          <a:solidFill>
+                            <a:srgbClr val="1C1C1C"/>
+                          </a:solidFill>
+                          <a:latin typeface="Arial"/>
+                        </a:rPr>
+                        <a:t>Passing</a:t>
+                      </a:r>
+                    </a:p>
+                  </a:txBody>
+                  <a:tcPr>
+                    <a:solidFill>
+                      <a:srgbClr val="F2F2F2"/>
+                    </a:solidFill>
+                  </a:tcPr>
+                </a:tc>
+                <a:tc>
+                  <a:txBody>
+                    <a:bodyPr/>
+                    <a:lstStyle/>
+                    <a:p>
+                      <a:r>
+                        <a:rPr sz="1100" b="0">
+                          <a:solidFill>
+                            <a:srgbClr val="1C1C1C"/>
+                          </a:solidFill>
+                          <a:latin typeface="Arial"/>
+                        </a:rPr>
+                        <a:t>Planned OUT</a:t>
+                      </a:r>
+                    </a:p>
+                  </a:txBody>
+                  <a:tcPr>
+                    <a:solidFill>
+                      <a:srgbClr val="F2F2F2"/>
+                    </a:solidFill>
+                  </a:tcPr>
+                </a:tc>
+                <a:tc>
+                  <a:txBody>
+                    <a:bodyPr/>
+                    <a:lstStyle/>
+                    <a:p>
+                      <a:r>
+                        <a:rPr sz="1100" b="0">
+                          <a:solidFill>
+                            <a:srgbClr val="1C1C1C"/>
+                          </a:solidFill>
+                          <a:latin typeface="Arial"/>
+                        </a:rPr>
+                        <a:t>Drop vs PrgP</a:t>
+                      </a:r>
+                    </a:p>
+                  </a:txBody>
+                  <a:tcPr>
+                    <a:solidFill>
+                      <a:srgbClr val="F2F2F2"/>
+                    </a:solidFill>
+                  </a:tcPr>
+                </a:tc>
+              </a:tr>
+              <a:tr h="347472">
+                <a:tc>
+                  <a:txBody>
+                    <a:bodyPr/>
+                    <a:lstStyle/>
+                    <a:p>
+                      <a:r>
+                        <a:rPr sz="1100" b="1">
+                          <a:solidFill>
+                            <a:srgbClr val="1C1C1C"/>
+                          </a:solidFill>
+                          <a:latin typeface="Arial"/>
+                        </a:rPr>
+                        <a:t>Carr</a:t>
+                      </a:r>
+                    </a:p>
+                  </a:txBody>
+                  <a:tcPr>
+                    <a:solidFill>
+                      <a:srgbClr val="F0FAF4"/>
+                    </a:solidFill>
+                  </a:tcPr>
+                </a:tc>
+                <a:tc>
+                  <a:txBody>
+                    <a:bodyPr/>
+                    <a:lstStyle/>
+                    <a:p>
+                      <a:r>
+                        <a:rPr sz="1100" b="1">
+                          <a:solidFill>
+                            <a:srgbClr val="1C1C1C"/>
+                          </a:solidFill>
+                          <a:latin typeface="Arial"/>
+                        </a:rPr>
+                        <a:t>Carries</a:t>
+                      </a:r>
+                    </a:p>
+                  </a:txBody>
+                  <a:tcPr>
+                    <a:solidFill>
+                      <a:srgbClr val="F0FAF4"/>
+                    </a:solidFill>
+                  </a:tcPr>
+                </a:tc>
+                <a:tc>
+                  <a:txBody>
+                    <a:bodyPr/>
+                    <a:lstStyle/>
+                    <a:p>
+                      <a:r>
+                        <a:rPr sz="1100" b="1">
+                          <a:solidFill>
+                            <a:srgbClr val="1C1C1C"/>
+                          </a:solidFill>
+                          <a:latin typeface="Arial"/>
+                        </a:rPr>
+                        <a:t>Carrying</a:t>
+                      </a:r>
+                    </a:p>
+                  </a:txBody>
+                  <a:tcPr>
+                    <a:solidFill>
+                      <a:srgbClr val="F0FAF4"/>
+                    </a:solidFill>
+                  </a:tcPr>
+                </a:tc>
+                <a:tc>
+                  <a:txBody>
+                    <a:bodyPr/>
+                    <a:lstStyle/>
+                    <a:p>
+                      <a:r>
+                        <a:rPr sz="1100" b="1">
+                          <a:solidFill>
+                            <a:srgbClr val="1C1C1C"/>
+                          </a:solidFill>
+                          <a:latin typeface="Arial"/>
+                        </a:rPr>
+                        <a:t>Planned PASS</a:t>
+                      </a:r>
+                    </a:p>
+                  </a:txBody>
+                  <a:tcPr>
+                    <a:solidFill>
+                      <a:srgbClr val="F0FAF4"/>
+                    </a:solidFill>
+                  </a:tcPr>
+                </a:tc>
+                <a:tc>
+                  <a:txBody>
+                    <a:bodyPr/>
+                    <a:lstStyle/>
+                    <a:p>
+                      <a:r>
+                        <a:rPr sz="1100" b="1">
+                          <a:solidFill>
+                            <a:srgbClr val="1C1C1C"/>
+                          </a:solidFill>
+                          <a:latin typeface="Arial"/>
+                        </a:rPr>
+                        <a:t>Keep over PrgC (cluster)</a:t>
+                      </a:r>
+                    </a:p>
+                  </a:txBody>
+                  <a:tcPr>
+                    <a:solidFill>
+                      <a:srgbClr val="F0FAF4"/>
+                    </a:solidFill>
+                  </a:tcPr>
+                </a:tc>
+              </a:tr>
+              <a:tr h="347472">
+                <a:tc>
+                  <a:txBody>
+                    <a:bodyPr/>
+                    <a:lstStyle/>
+                    <a:p>
+                      <a:r>
+                        <a:rPr sz="1100" b="0">
+                          <a:solidFill>
+                            <a:srgbClr val="1C1C1C"/>
+                          </a:solidFill>
+                          <a:latin typeface="Arial"/>
+                        </a:rPr>
+                        <a:t>PrgC</a:t>
+                      </a:r>
+                    </a:p>
+                  </a:txBody>
+                  <a:tcPr>
+                    <a:solidFill>
+                      <a:srgbClr val="F2F2F2"/>
+                    </a:solidFill>
+                  </a:tcPr>
+                </a:tc>
+                <a:tc>
+                  <a:txBody>
+                    <a:bodyPr/>
+                    <a:lstStyle/>
+                    <a:p>
+                      <a:r>
+                        <a:rPr sz="1100" b="0">
+                          <a:solidFill>
+                            <a:srgbClr val="1C1C1C"/>
+                          </a:solidFill>
+                          <a:latin typeface="Arial"/>
+                        </a:rPr>
+                        <a:t>Progressive carries</a:t>
+                      </a:r>
+                    </a:p>
+                  </a:txBody>
+                  <a:tcPr>
+                    <a:solidFill>
+                      <a:srgbClr val="F2F2F2"/>
+                    </a:solidFill>
+                  </a:tcPr>
+                </a:tc>
+                <a:tc>
+                  <a:txBody>
+                    <a:bodyPr/>
+                    <a:lstStyle/>
+                    <a:p>
+                      <a:r>
+                        <a:rPr sz="1100" b="0">
+                          <a:solidFill>
+                            <a:srgbClr val="1C1C1C"/>
+                          </a:solidFill>
+                          <a:latin typeface="Arial"/>
+                        </a:rPr>
+                        <a:t>Carrying</a:t>
+                      </a:r>
+                    </a:p>
+                  </a:txBody>
+                  <a:tcPr>
+                    <a:solidFill>
+                      <a:srgbClr val="F2F2F2"/>
+                    </a:solidFill>
+                  </a:tcPr>
+                </a:tc>
+                <a:tc>
+                  <a:txBody>
+                    <a:bodyPr/>
+                    <a:lstStyle/>
+                    <a:p>
+                      <a:r>
+                        <a:rPr sz="1100" b="0">
+                          <a:solidFill>
+                            <a:srgbClr val="1C1C1C"/>
+                          </a:solidFill>
+                          <a:latin typeface="Arial"/>
+                        </a:rPr>
+                        <a:t>Planned OUT</a:t>
+                      </a:r>
+                    </a:p>
+                  </a:txBody>
+                  <a:tcPr>
+                    <a:solidFill>
+                      <a:srgbClr val="F2F2F2"/>
+                    </a:solidFill>
+                  </a:tcPr>
+                </a:tc>
+                <a:tc>
+                  <a:txBody>
+                    <a:bodyPr/>
+                    <a:lstStyle/>
+                    <a:p>
+                      <a:r>
+                        <a:rPr sz="1100" b="0">
+                          <a:solidFill>
+                            <a:srgbClr val="1C1C1C"/>
+                          </a:solidFill>
+                          <a:latin typeface="Arial"/>
+                        </a:rPr>
+                        <a:t>Drop vs Carries</a:t>
+                      </a:r>
+                    </a:p>
+                  </a:txBody>
+                  <a:tcPr>
+                    <a:solidFill>
+                      <a:srgbClr val="F2F2F2"/>
+                    </a:solidFill>
+                  </a:tcPr>
+                </a:tc>
+              </a:tr>
+              <a:tr h="347472">
+                <a:tc>
+                  <a:txBody>
+                    <a:bodyPr/>
+                    <a:lstStyle/>
+                    <a:p>
+                      <a:r>
+                        <a:rPr sz="1100" b="1">
+                          <a:solidFill>
+                            <a:srgbClr val="1C1C1C"/>
+                          </a:solidFill>
+                          <a:latin typeface="Arial"/>
+                        </a:rPr>
+                        <a:t>npxG</a:t>
+                      </a:r>
+                    </a:p>
+                  </a:txBody>
+                  <a:tcPr>
+                    <a:solidFill>
+                      <a:srgbClr val="F0FAF4"/>
+                    </a:solidFill>
+                  </a:tcPr>
+                </a:tc>
+                <a:tc>
+                  <a:txBody>
+                    <a:bodyPr/>
+                    <a:lstStyle/>
+                    <a:p>
+                      <a:r>
+                        <a:rPr sz="1100" b="1">
+                          <a:solidFill>
+                            <a:srgbClr val="1C1C1C"/>
+                          </a:solidFill>
+                          <a:latin typeface="Arial"/>
+                        </a:rPr>
+                        <a:t>Non-pen xG</a:t>
+                      </a:r>
+                    </a:p>
+                  </a:txBody>
+                  <a:tcPr>
+                    <a:solidFill>
+                      <a:srgbClr val="F0FAF4"/>
+                    </a:solidFill>
+                  </a:tcPr>
+                </a:tc>
+                <a:tc>
+                  <a:txBody>
+                    <a:bodyPr/>
+                    <a:lstStyle/>
+                    <a:p>
+                      <a:r>
+                        <a:rPr sz="1100" b="1">
+                          <a:solidFill>
+                            <a:srgbClr val="1C1C1C"/>
+                          </a:solidFill>
+                          <a:latin typeface="Arial"/>
+                        </a:rPr>
+                        <a:t>Attacking</a:t>
+                      </a:r>
+                    </a:p>
+                  </a:txBody>
+                  <a:tcPr>
+                    <a:solidFill>
+                      <a:srgbClr val="F0FAF4"/>
+                    </a:solidFill>
+                  </a:tcPr>
+                </a:tc>
+                <a:tc>
+                  <a:txBody>
+                    <a:bodyPr/>
+                    <a:lstStyle/>
+                    <a:p>
+                      <a:r>
+                        <a:rPr sz="1100" b="1">
+                          <a:solidFill>
+                            <a:srgbClr val="1C1C1C"/>
+                          </a:solidFill>
+                          <a:latin typeface="Arial"/>
+                        </a:rPr>
+                        <a:t>Planned PASS</a:t>
+                      </a:r>
+                    </a:p>
+                  </a:txBody>
+                  <a:tcPr>
+                    <a:solidFill>
+                      <a:srgbClr val="F0FAF4"/>
+                    </a:solidFill>
+                  </a:tcPr>
+                </a:tc>
+                <a:tc>
+                  <a:txBody>
+                    <a:bodyPr/>
+                    <a:lstStyle/>
+                    <a:p>
+                      <a:r>
+                        <a:rPr sz="1100" b="1">
+                          <a:solidFill>
+                            <a:srgbClr val="1C1C1C"/>
+                          </a:solidFill>
+                          <a:latin typeface="Arial"/>
+                        </a:rPr>
+                        <a:t>Keep over Shots (cluster)</a:t>
+                      </a:r>
+                    </a:p>
+                  </a:txBody>
+                  <a:tcPr>
+                    <a:solidFill>
+                      <a:srgbClr val="F0FAF4"/>
+                    </a:solidFill>
+                  </a:tcPr>
+                </a:tc>
+              </a:tr>
+              <a:tr h="347472">
+                <a:tc>
+                  <a:txBody>
+                    <a:bodyPr/>
+                    <a:lstStyle/>
+                    <a:p>
+                      <a:r>
+                        <a:rPr sz="1100" b="0">
+                          <a:solidFill>
+                            <a:srgbClr val="1C1C1C"/>
+                          </a:solidFill>
+                          <a:latin typeface="Arial"/>
+                        </a:rPr>
+                        <a:t>Sh</a:t>
+                      </a:r>
+                    </a:p>
+                  </a:txBody>
+                  <a:tcPr>
+                    <a:solidFill>
+                      <a:srgbClr val="F2F2F2"/>
+                    </a:solidFill>
+                  </a:tcPr>
+                </a:tc>
+                <a:tc>
+                  <a:txBody>
+                    <a:bodyPr/>
+                    <a:lstStyle/>
+                    <a:p>
+                      <a:r>
+                        <a:rPr sz="1100" b="0">
+                          <a:solidFill>
+                            <a:srgbClr val="1C1C1C"/>
+                          </a:solidFill>
+                          <a:latin typeface="Arial"/>
+                        </a:rPr>
+                        <a:t>Shots</a:t>
+                      </a:r>
+                    </a:p>
+                  </a:txBody>
+                  <a:tcPr>
+                    <a:solidFill>
+                      <a:srgbClr val="F2F2F2"/>
+                    </a:solidFill>
+                  </a:tcPr>
+                </a:tc>
+                <a:tc>
+                  <a:txBody>
+                    <a:bodyPr/>
+                    <a:lstStyle/>
+                    <a:p>
+                      <a:r>
+                        <a:rPr sz="1100" b="0">
+                          <a:solidFill>
+                            <a:srgbClr val="1C1C1C"/>
+                          </a:solidFill>
+                          <a:latin typeface="Arial"/>
+                        </a:rPr>
+                        <a:t>Attacking</a:t>
+                      </a:r>
+                    </a:p>
+                  </a:txBody>
+                  <a:tcPr>
+                    <a:solidFill>
+                      <a:srgbClr val="F2F2F2"/>
+                    </a:solidFill>
+                  </a:tcPr>
+                </a:tc>
+                <a:tc>
+                  <a:txBody>
+                    <a:bodyPr/>
+                    <a:lstStyle/>
+                    <a:p>
+                      <a:r>
+                        <a:rPr sz="1100" b="0">
+                          <a:solidFill>
+                            <a:srgbClr val="1C1C1C"/>
+                          </a:solidFill>
+                          <a:latin typeface="Arial"/>
+                        </a:rPr>
+                        <a:t>Planned OUT</a:t>
+                      </a:r>
+                    </a:p>
+                  </a:txBody>
+                  <a:tcPr>
+                    <a:solidFill>
+                      <a:srgbClr val="F2F2F2"/>
+                    </a:solidFill>
+                  </a:tcPr>
+                </a:tc>
+                <a:tc>
+                  <a:txBody>
+                    <a:bodyPr/>
+                    <a:lstStyle/>
+                    <a:p>
+                      <a:r>
+                        <a:rPr sz="1100" b="0">
+                          <a:solidFill>
+                            <a:srgbClr val="1C1C1C"/>
+                          </a:solidFill>
+                          <a:latin typeface="Arial"/>
+                        </a:rPr>
+                        <a:t>Drop vs npxG</a:t>
+                      </a:r>
+                    </a:p>
+                  </a:txBody>
+                  <a:tcPr>
+                    <a:solidFill>
+                      <a:srgbClr val="F2F2F2"/>
+                    </a:solidFill>
+                  </a:tcPr>
+                </a:tc>
+              </a:tr>
+              <a:tr h="347472">
+                <a:tc>
+                  <a:txBody>
+                    <a:bodyPr/>
+                    <a:lstStyle/>
+                    <a:p>
+                      <a:r>
+                        <a:rPr sz="1100" b="1">
+                          <a:solidFill>
+                            <a:srgbClr val="1C1C1C"/>
+                          </a:solidFill>
+                          <a:latin typeface="Arial"/>
+                        </a:rPr>
+                        <a:t>SCA</a:t>
+                      </a:r>
+                    </a:p>
+                  </a:txBody>
+                  <a:tcPr>
+                    <a:solidFill>
+                      <a:srgbClr val="F0FAF4"/>
+                    </a:solidFill>
+                  </a:tcPr>
+                </a:tc>
+                <a:tc>
+                  <a:txBody>
+                    <a:bodyPr/>
+                    <a:lstStyle/>
+                    <a:p>
+                      <a:r>
+                        <a:rPr sz="1100" b="1">
+                          <a:solidFill>
+                            <a:srgbClr val="1C1C1C"/>
+                          </a:solidFill>
+                          <a:latin typeface="Arial"/>
+                        </a:rPr>
+                        <a:t>Shot-creating actions</a:t>
+                      </a:r>
+                    </a:p>
+                  </a:txBody>
+                  <a:tcPr>
+                    <a:solidFill>
+                      <a:srgbClr val="F0FAF4"/>
+                    </a:solidFill>
+                  </a:tcPr>
+                </a:tc>
+                <a:tc>
+                  <a:txBody>
+                    <a:bodyPr/>
+                    <a:lstStyle/>
+                    <a:p>
+                      <a:r>
+                        <a:rPr sz="1100" b="1">
+                          <a:solidFill>
+                            <a:srgbClr val="1C1C1C"/>
+                          </a:solidFill>
+                          <a:latin typeface="Arial"/>
+                        </a:rPr>
+                        <a:t>Attacking</a:t>
+                      </a:r>
+                    </a:p>
+                  </a:txBody>
+                  <a:tcPr>
+                    <a:solidFill>
+                      <a:srgbClr val="F0FAF4"/>
+                    </a:solidFill>
+                  </a:tcPr>
+                </a:tc>
+                <a:tc>
+                  <a:txBody>
+                    <a:bodyPr/>
+                    <a:lstStyle/>
+                    <a:p>
+                      <a:r>
+                        <a:rPr sz="1100" b="1">
+                          <a:solidFill>
+                            <a:srgbClr val="1C1C1C"/>
+                          </a:solidFill>
+                          <a:latin typeface="Arial"/>
+                        </a:rPr>
+                        <a:t>Planned PASS</a:t>
+                      </a:r>
+                    </a:p>
+                  </a:txBody>
+                  <a:tcPr>
+                    <a:solidFill>
+                      <a:srgbClr val="F0FAF4"/>
+                    </a:solidFill>
+                  </a:tcPr>
+                </a:tc>
+                <a:tc>
+                  <a:txBody>
+                    <a:bodyPr/>
+                    <a:lstStyle/>
+                    <a:p>
+                      <a:r>
+                        <a:rPr sz="1100" b="1">
+                          <a:solidFill>
+                            <a:srgbClr val="1C1C1C"/>
+                          </a:solidFill>
+                          <a:latin typeface="Arial"/>
+                        </a:rPr>
+                        <a:t>Singleton</a:t>
+                      </a:r>
+                    </a:p>
+                  </a:txBody>
+                  <a:tcPr>
+                    <a:solidFill>
+                      <a:srgbClr val="F0FAF4"/>
+                    </a:solidFill>
+                  </a:tcPr>
+                </a:tc>
+              </a:tr>
+              <a:tr h="347472">
+                <a:tc>
+                  <a:txBody>
+                    <a:bodyPr/>
+                    <a:lstStyle/>
+                    <a:p>
+                      <a:r>
+                        <a:rPr sz="1100" b="1">
+                          <a:solidFill>
+                            <a:srgbClr val="1C1C1C"/>
+                          </a:solidFill>
+                          <a:latin typeface="Arial"/>
+                        </a:rPr>
+                        <a:t>Tkl</a:t>
+                      </a:r>
+                    </a:p>
+                  </a:txBody>
+                  <a:tcPr>
+                    <a:solidFill>
+                      <a:srgbClr val="F0FAF4"/>
+                    </a:solidFill>
+                  </a:tcPr>
+                </a:tc>
+                <a:tc>
+                  <a:txBody>
+                    <a:bodyPr/>
+                    <a:lstStyle/>
+                    <a:p>
+                      <a:r>
+                        <a:rPr sz="1100" b="1">
+                          <a:solidFill>
+                            <a:srgbClr val="1C1C1C"/>
+                          </a:solidFill>
+                          <a:latin typeface="Arial"/>
+                        </a:rPr>
+                        <a:t>Tackles</a:t>
+                      </a:r>
+                    </a:p>
+                  </a:txBody>
+                  <a:tcPr>
+                    <a:solidFill>
+                      <a:srgbClr val="F0FAF4"/>
+                    </a:solidFill>
+                  </a:tcPr>
+                </a:tc>
+                <a:tc>
+                  <a:txBody>
+                    <a:bodyPr/>
+                    <a:lstStyle/>
+                    <a:p>
+                      <a:r>
+                        <a:rPr sz="1100" b="1">
+                          <a:solidFill>
+                            <a:srgbClr val="1C1C1C"/>
+                          </a:solidFill>
+                          <a:latin typeface="Arial"/>
+                        </a:rPr>
+                        <a:t>Defending</a:t>
+                      </a:r>
+                    </a:p>
+                  </a:txBody>
+                  <a:tcPr>
+                    <a:solidFill>
+                      <a:srgbClr val="F0FAF4"/>
+                    </a:solidFill>
+                  </a:tcPr>
+                </a:tc>
+                <a:tc>
+                  <a:txBody>
+                    <a:bodyPr/>
+                    <a:lstStyle/>
+                    <a:p>
+                      <a:r>
+                        <a:rPr sz="1100" b="1">
+                          <a:solidFill>
+                            <a:srgbClr val="1C1C1C"/>
+                          </a:solidFill>
+                          <a:latin typeface="Arial"/>
+                        </a:rPr>
+                        <a:t>Planned PASS</a:t>
+                      </a:r>
+                    </a:p>
+                  </a:txBody>
+                  <a:tcPr>
+                    <a:solidFill>
+                      <a:srgbClr val="F0FAF4"/>
+                    </a:solidFill>
+                  </a:tcPr>
+                </a:tc>
+                <a:tc>
+                  <a:txBody>
+                    <a:bodyPr/>
+                    <a:lstStyle/>
+                    <a:p>
+                      <a:r>
+                        <a:rPr sz="1100" b="1">
+                          <a:solidFill>
+                            <a:srgbClr val="1C1C1C"/>
+                          </a:solidFill>
+                          <a:latin typeface="Arial"/>
+                        </a:rPr>
+                        <a:t>Singleton</a:t>
+                      </a:r>
+                    </a:p>
+                  </a:txBody>
+                  <a:tcPr>
+                    <a:solidFill>
+                      <a:srgbClr val="F0FAF4"/>
+                    </a:solidFill>
+                  </a:tcPr>
+                </a:tc>
+              </a:tr>
+              <a:tr h="347472">
+                <a:tc>
+                  <a:txBody>
+                    <a:bodyPr/>
+                    <a:lstStyle/>
+                    <a:p>
+                      <a:r>
+                        <a:rPr sz="1100" b="1">
+                          <a:solidFill>
+                            <a:srgbClr val="1C1C1C"/>
+                          </a:solidFill>
+                          <a:latin typeface="Arial"/>
+                        </a:rPr>
+                        <a:t>Int</a:t>
+                      </a:r>
+                    </a:p>
+                  </a:txBody>
+                  <a:tcPr>
+                    <a:solidFill>
+                      <a:srgbClr val="F0FAF4"/>
+                    </a:solidFill>
+                  </a:tcPr>
+                </a:tc>
+                <a:tc>
+                  <a:txBody>
+                    <a:bodyPr/>
+                    <a:lstStyle/>
+                    <a:p>
+                      <a:r>
+                        <a:rPr sz="1100" b="1">
+                          <a:solidFill>
+                            <a:srgbClr val="1C1C1C"/>
+                          </a:solidFill>
+                          <a:latin typeface="Arial"/>
+                        </a:rPr>
+                        <a:t>Interceptions</a:t>
+                      </a:r>
+                    </a:p>
+                  </a:txBody>
+                  <a:tcPr>
+                    <a:solidFill>
+                      <a:srgbClr val="F0FAF4"/>
+                    </a:solidFill>
+                  </a:tcPr>
+                </a:tc>
+                <a:tc>
+                  <a:txBody>
+                    <a:bodyPr/>
+                    <a:lstStyle/>
+                    <a:p>
+                      <a:r>
+                        <a:rPr sz="1100" b="1">
+                          <a:solidFill>
+                            <a:srgbClr val="1C1C1C"/>
+                          </a:solidFill>
+                          <a:latin typeface="Arial"/>
+                        </a:rPr>
+                        <a:t>Defending</a:t>
+                      </a:r>
+                    </a:p>
+                  </a:txBody>
+                  <a:tcPr>
+                    <a:solidFill>
+                      <a:srgbClr val="F0FAF4"/>
+                    </a:solidFill>
+                  </a:tcPr>
+                </a:tc>
+                <a:tc>
+                  <a:txBody>
+                    <a:bodyPr/>
+                    <a:lstStyle/>
+                    <a:p>
+                      <a:r>
+                        <a:rPr sz="1100" b="1">
+                          <a:solidFill>
+                            <a:srgbClr val="1C1C1C"/>
+                          </a:solidFill>
+                          <a:latin typeface="Arial"/>
+                        </a:rPr>
+                        <a:t>Planned PASS</a:t>
+                      </a:r>
+                    </a:p>
+                  </a:txBody>
+                  <a:tcPr>
+                    <a:solidFill>
+                      <a:srgbClr val="F0FAF4"/>
+                    </a:solidFill>
+                  </a:tcPr>
+                </a:tc>
+                <a:tc>
+                  <a:txBody>
+                    <a:bodyPr/>
+                    <a:lstStyle/>
+                    <a:p>
+                      <a:r>
+                        <a:rPr sz="1100" b="1">
+                          <a:solidFill>
+                            <a:srgbClr val="1C1C1C"/>
+                          </a:solidFill>
+                          <a:latin typeface="Arial"/>
+                        </a:rPr>
+                        <a:t>Singleton</a:t>
+                      </a:r>
+                    </a:p>
+                  </a:txBody>
+                  <a:tcPr>
+                    <a:solidFill>
+                      <a:srgbClr val="F0FAF4"/>
+                    </a:solidFill>
+                  </a:tcPr>
+                </a:tc>
+              </a:tr>
+              <a:tr h="347472">
+                <a:tc>
+                  <a:txBody>
+                    <a:bodyPr/>
+                    <a:lstStyle/>
+                    <a:p>
+                      <a:r>
+                        <a:rPr sz="1100" b="1">
+                          <a:solidFill>
+                            <a:srgbClr val="1C1C1C"/>
+                          </a:solidFill>
+                          <a:latin typeface="Arial"/>
+                        </a:rPr>
+                        <a:t>Aer</a:t>
+                      </a:r>
+                    </a:p>
+                  </a:txBody>
+                  <a:tcPr>
+                    <a:solidFill>
+                      <a:srgbClr val="F0FAF4"/>
+                    </a:solidFill>
+                  </a:tcPr>
+                </a:tc>
+                <a:tc>
+                  <a:txBody>
+                    <a:bodyPr/>
+                    <a:lstStyle/>
+                    <a:p>
+                      <a:r>
+                        <a:rPr sz="1100" b="1">
+                          <a:solidFill>
+                            <a:srgbClr val="1C1C1C"/>
+                          </a:solidFill>
+                          <a:latin typeface="Arial"/>
+                        </a:rPr>
+                        <a:t>Aerials won</a:t>
+                      </a:r>
+                    </a:p>
+                  </a:txBody>
+                  <a:tcPr>
+                    <a:solidFill>
+                      <a:srgbClr val="F0FAF4"/>
+                    </a:solidFill>
+                  </a:tcPr>
+                </a:tc>
+                <a:tc>
+                  <a:txBody>
+                    <a:bodyPr/>
+                    <a:lstStyle/>
+                    <a:p>
+                      <a:r>
+                        <a:rPr sz="1100" b="1">
+                          <a:solidFill>
+                            <a:srgbClr val="1C1C1C"/>
+                          </a:solidFill>
+                          <a:latin typeface="Arial"/>
+                        </a:rPr>
+                        <a:t>Defending</a:t>
+                      </a:r>
+                    </a:p>
+                  </a:txBody>
+                  <a:tcPr>
+                    <a:solidFill>
+                      <a:srgbClr val="F0FAF4"/>
+                    </a:solidFill>
+                  </a:tcPr>
+                </a:tc>
+                <a:tc>
+                  <a:txBody>
+                    <a:bodyPr/>
+                    <a:lstStyle/>
+                    <a:p>
+                      <a:r>
+                        <a:rPr sz="1100" b="1">
+                          <a:solidFill>
+                            <a:srgbClr val="1C1C1C"/>
+                          </a:solidFill>
+                          <a:latin typeface="Arial"/>
+                        </a:rPr>
+                        <a:t>Planned PASS</a:t>
+                      </a:r>
+                    </a:p>
+                  </a:txBody>
+                  <a:tcPr>
+                    <a:solidFill>
+                      <a:srgbClr val="F0FAF4"/>
+                    </a:solidFill>
+                  </a:tcPr>
+                </a:tc>
+                <a:tc>
+                  <a:txBody>
+                    <a:bodyPr/>
+                    <a:lstStyle/>
+                    <a:p>
+                      <a:r>
+                        <a:rPr sz="1100" b="1">
+                          <a:solidFill>
+                            <a:srgbClr val="1C1C1C"/>
+                          </a:solidFill>
+                          <a:latin typeface="Arial"/>
+                        </a:rPr>
+                        <a:t>Singleton</a:t>
+                      </a:r>
+                    </a:p>
+                  </a:txBody>
+                  <a:tcPr>
+                    <a:solidFill>
+                      <a:srgbClr val="F0FAF4"/>
+                    </a:solidFill>
+                  </a:tcPr>
+                </a:tc>
+              </a:tr>
+              <a:tr h="347472">
+                <a:tc>
+                  <a:txBody>
+                    <a:bodyPr/>
+                    <a:lstStyle/>
+                    <a:p>
+                      <a:r>
+                        <a:rPr sz="1100" b="1">
+                          <a:solidFill>
+                            <a:srgbClr val="1C1C1C"/>
+                          </a:solidFill>
+                          <a:latin typeface="Arial"/>
+                        </a:rPr>
+                        <a:t>AttPen</a:t>
+                      </a:r>
+                    </a:p>
+                  </a:txBody>
+                  <a:tcPr>
+                    <a:solidFill>
+                      <a:srgbClr val="F0FAF4"/>
+                    </a:solidFill>
+                  </a:tcPr>
+                </a:tc>
+                <a:tc>
+                  <a:txBody>
+                    <a:bodyPr/>
+                    <a:lstStyle/>
+                    <a:p>
+                      <a:r>
+                        <a:rPr sz="1100" b="1">
+                          <a:solidFill>
+                            <a:srgbClr val="1C1C1C"/>
+                          </a:solidFill>
+                          <a:latin typeface="Arial"/>
+                        </a:rPr>
+                        <a:t>Touches in attacking pen</a:t>
+                      </a:r>
+                    </a:p>
+                  </a:txBody>
+                  <a:tcPr>
+                    <a:solidFill>
+                      <a:srgbClr val="F0FAF4"/>
+                    </a:solidFill>
+                  </a:tcPr>
+                </a:tc>
+                <a:tc>
+                  <a:txBody>
+                    <a:bodyPr/>
+                    <a:lstStyle/>
+                    <a:p>
+                      <a:r>
+                        <a:rPr sz="1100" b="1">
+                          <a:solidFill>
+                            <a:srgbClr val="1C1C1C"/>
+                          </a:solidFill>
+                          <a:latin typeface="Arial"/>
+                        </a:rPr>
+                        <a:t>Attacking</a:t>
+                      </a:r>
+                    </a:p>
+                  </a:txBody>
+                  <a:tcPr>
+                    <a:solidFill>
+                      <a:srgbClr val="F0FAF4"/>
+                    </a:solidFill>
+                  </a:tcPr>
+                </a:tc>
+                <a:tc>
+                  <a:txBody>
+                    <a:bodyPr/>
+                    <a:lstStyle/>
+                    <a:p>
+                      <a:r>
+                        <a:rPr sz="1100" b="1">
+                          <a:solidFill>
+                            <a:srgbClr val="1C1C1C"/>
+                          </a:solidFill>
+                          <a:latin typeface="Arial"/>
+                        </a:rPr>
+                        <a:t>Planned PASS</a:t>
+                      </a:r>
+                    </a:p>
+                  </a:txBody>
+                  <a:tcPr>
+                    <a:solidFill>
+                      <a:srgbClr val="F0FAF4"/>
+                    </a:solidFill>
+                  </a:tcPr>
+                </a:tc>
+                <a:tc>
+                  <a:txBody>
+                    <a:bodyPr/>
+                    <a:lstStyle/>
+                    <a:p>
+                      <a:r>
+                        <a:rPr sz="1100" b="1">
+                          <a:solidFill>
+                            <a:srgbClr val="1C1C1C"/>
+                          </a:solidFill>
+                          <a:latin typeface="Arial"/>
+                        </a:rPr>
+                        <a:t>Singleton</a:t>
+                      </a:r>
+                    </a:p>
+                  </a:txBody>
+                  <a:tcPr>
+                    <a:solidFill>
+                      <a:srgbClr val="F0FAF4"/>
+                    </a:solidFill>
+                  </a:tcPr>
+                </a:tc>
+              </a:tr>
+            </a:tbl>
+          </a:graphicData>
+        </a:graphic>
+      </p:graphicFrame>
+      <p:sp>
+        <p:nvSpPr>
+          <p:cNvPr id="7" name="TextBox 6"/>
+          <p:cNvSpPr txBox="1"/>
+          <p:nvPr/>
+        </p:nvSpPr>
+        <p:spPr>
+          <a:xfrm>
+            <a:off x="502920" y="6172200"/>
+            <a:ext cx="11155680" cy="365760"/>
+          </a:xfrm>
+          <a:prstGeom prst="rect">
+            <a:avLst/>
+          </a:prstGeom>
+          <a:noFill/>
+        </p:spPr>
+        <p:txBody>
+          <a:bodyPr wrap="square">
+            <a:spAutoFit/>
+          </a:bodyPr>
+          <a:lstStyle/>
+          <a:p>
+            <a:r>
+              <a:rPr sz="1100" b="0">
+                <a:solidFill>
+                  <a:srgbClr val="8A5A00"/>
+                </a:solidFill>
+                <a:latin typeface="Arial"/>
+              </a:rPr>
+              <a:t>When FBref is frozen: replace Planned PASS/OUT with real prior→Y1 stability r (same layout as StatsBomb slide).</a:t>
+            </a:r>
+          </a:p>
+        </p:txBody>
+      </p:sp>
+    </p:spTree>
+  </p:cSld>
+  <p:clrMapOvr>
+    <a:masterClrMapping/>
+  </p:clrMapOvr>
+</p:sld>
+</file>
+
+<file path=ppt/slides/slide6.xml><?xml version="1.0" encoding="utf-8"?>
+<p:sld xmlns:a="http://schemas.openxmlformats.org/drawingml/2006/main" xmlns:p="http://schemas.openxmlformats.org/presentationml/2006/main" xmlns:r="http://schemas.openxmlformats.org/officeDocument/2006/relationships">
+  <p:cSld>
+    <p:spTree>
+      <p:nvGrpSpPr>
+        <p:cNvPr id="1" name=""/>
+        <p:cNvGrpSpPr/>
+        <p:nvPr/>
+      </p:nvGrpSpPr>
+      <p:grpSpPr/>
+      <p:sp>
+        <p:nvSpPr>
+          <p:cNvPr id="2" name="Rectangle 1"/>
+          <p:cNvSpPr/>
+          <p:nvPr/>
+        </p:nvSpPr>
+        <p:spPr>
+          <a:xfrm>
+            <a:off x="0" y="0"/>
+            <a:ext cx="12191695" cy="6858000"/>
+          </a:xfrm>
+          <a:prstGeom prst="rect">
+            <a:avLst/>
+          </a:prstGeom>
+          <a:solidFill>
             <a:srgbClr val="FFFFFF"/>
           </a:solidFill>
           <a:ln>
@@ -6075,7 +7676,7 @@
                 </a:solidFill>
                 <a:latin typeface="Arial"/>
               </a:rPr>
-              <a:t>Example: Eric Dier (Central Defender)</a:t>
+              <a:t>Example player profile</a:t>
             </a:r>
           </a:p>
           <a:p>
@@ -6086,7 +7687,18 @@
                 </a:solidFill>
                 <a:latin typeface="Arial"/>
               </a:rPr>
-              <a:t>StatsBomb shortlist · rings marked 0%ile–100%ile</a:t>
+              <a:t/>
+            </a:r>
+          </a:p>
+          <a:p>
+            <a:r>
+              <a:rPr sz="1200" b="0">
+                <a:solidFill>
+                  <a:srgbClr val="555555"/>
+                </a:solidFill>
+                <a:latin typeface="Arial"/>
+              </a:rPr>
+              <a:t>Built from traits that passed stability + redundancy</a:t>
             </a:r>
           </a:p>
         </p:txBody>
@@ -6199,7 +7811,7 @@
                 </a:solidFill>
                 <a:latin typeface="Arial"/>
               </a:rPr>
-              <a:t>How to read the ring numbers</a:t>
+              <a:t>How to read</a:t>
             </a:r>
           </a:p>
           <a:p>
@@ -6221,7 +7833,7 @@
                 </a:solidFill>
                 <a:latin typeface="Arial"/>
               </a:rPr>
-              <a:t>0 / 25 / 50 / 75 / 100 = percentile vs Bundesliga peers (labeled %ile — not raw per-90).</a:t>
+              <a:t/>
             </a:r>
           </a:p>
           <a:p>
@@ -6232,7 +7844,7 @@
                 </a:solidFill>
                 <a:latin typeface="Arial"/>
               </a:rPr>
-              <a:t>Center = 0th %ile · rim = 100th %ile. Dashed ≈ 50th (avg). Solid ≈ ~90th (top).</a:t>
+              <a:t/>
             </a:r>
           </a:p>
           <a:p>
@@ -6243,7 +7855,40 @@
                 </a:solidFill>
                 <a:latin typeface="Arial"/>
               </a:rPr>
-              <a:t>Wedge length = this player’s Year-1 percentile on each kept trait.</a:t>
+              <a:t/>
+            </a:r>
+          </a:p>
+          <a:p>
+            <a:r>
+              <a:rPr sz="1200" b="0">
+                <a:solidFill>
+                  <a:srgbClr val="555555"/>
+                </a:solidFill>
+                <a:latin typeface="Arial"/>
+              </a:rPr>
+              <a:t>Filled wedges = Year-1 Bundesliga percentiles vs peers.</a:t>
+            </a:r>
+          </a:p>
+          <a:p>
+            <a:r>
+              <a:rPr sz="1200" b="0">
+                <a:solidFill>
+                  <a:srgbClr val="555555"/>
+                </a:solidFill>
+                <a:latin typeface="Arial"/>
+              </a:rPr>
+              <a:t>Dashed arc = avg peer · Solid arc = top peer.</a:t>
+            </a:r>
+          </a:p>
+          <a:p>
+            <a:r>
+              <a:rPr sz="1200" b="0">
+                <a:solidFill>
+                  <a:srgbClr val="555555"/>
+                </a:solidFill>
+                <a:latin typeface="Arial"/>
+              </a:rPr>
+              <a:t>Only traits that passed stability + redundancy.</a:t>
             </a:r>
           </a:p>
         </p:txBody>
@@ -6257,15 +7902,15 @@
           <p:nvPr/>
         </p:nvPicPr>
         <p:blipFill>
-          <a:blip r:embed="rId3"/>
+          <a:blip r:embed="rId4"/>
           <a:stretch>
             <a:fillRect/>
           </a:stretch>
         </p:blipFill>
         <p:spPr>
           <a:xfrm>
-            <a:off x="320040" y="960120"/>
-            <a:ext cx="4791937" cy="5120640"/>
+            <a:off x="365760" y="1051560"/>
+            <a:ext cx="5536903" cy="4937760"/>
           </a:xfrm>
           <a:prstGeom prst="rect">
             <a:avLst/>
@@ -6280,7 +7925,7 @@
 </p:sld>
 </file>
 
-<file path=ppt/slides/slide6.xml><?xml version="1.0" encoding="utf-8"?>
+<file path=ppt/slides/slide7.xml><?xml version="1.0" encoding="utf-8"?>
 <p:sld xmlns:a="http://schemas.openxmlformats.org/drawingml/2006/main" xmlns:p="http://schemas.openxmlformats.org/presentationml/2006/main" xmlns:r="http://schemas.openxmlformats.org/officeDocument/2006/relationships">
   <p:cSld>
     <p:spTree>
@@ -7133,7 +8778,7 @@
 </p:sld>
 </file>
 
-<file path=ppt/slides/slide7.xml><?xml version="1.0" encoding="utf-8"?>
+<file path=ppt/slides/slide8.xml><?xml version="1.0" encoding="utf-8"?>
 <p:sld xmlns:a="http://schemas.openxmlformats.org/drawingml/2006/main" xmlns:p="http://schemas.openxmlformats.org/presentationml/2006/main" xmlns:r="http://schemas.openxmlformats.org/officeDocument/2006/relationships">
   <p:cSld>
     <p:spTree>
@@ -7399,7 +9044,7 @@
 </p:sld>
 </file>
 
-<file path=ppt/slides/slide8.xml><?xml version="1.0" encoding="utf-8"?>
+<file path=ppt/slides/slide9.xml><?xml version="1.0" encoding="utf-8"?>
 <p:sld xmlns:a="http://schemas.openxmlformats.org/drawingml/2006/main" xmlns:p="http://schemas.openxmlformats.org/presentationml/2006/main" xmlns:r="http://schemas.openxmlformats.org/officeDocument/2006/relationships">
   <p:cSld>
     <p:spTree>
@@ -7735,1596 +9380,6 @@
               <a:t>interactive_player_explorer.html — dropdown by position + pizza
 cohort_data.json — open-data stress-test cohort
 projectproposal.txt — editable source for the Word doc</a:t>
-            </a:r>
-          </a:p>
-        </p:txBody>
-      </p:sp>
-    </p:spTree>
-  </p:cSld>
-  <p:clrMapOvr>
-    <a:masterClrMapping/>
-  </p:clrMapOvr>
-</p:sld>
-</file>
-
-<file path=ppt/slides/slide9.xml><?xml version="1.0" encoding="utf-8"?>
-<p:sld xmlns:a="http://schemas.openxmlformats.org/drawingml/2006/main" xmlns:p="http://schemas.openxmlformats.org/presentationml/2006/main" xmlns:r="http://schemas.openxmlformats.org/officeDocument/2006/relationships">
-  <p:cSld>
-    <p:spTree>
-      <p:nvGrpSpPr>
-        <p:cNvPr id="1" name=""/>
-        <p:cNvGrpSpPr/>
-        <p:nvPr/>
-      </p:nvGrpSpPr>
-      <p:grpSpPr/>
-      <p:sp>
-        <p:nvSpPr>
-          <p:cNvPr id="2" name="Rectangle 1"/>
-          <p:cNvSpPr/>
-          <p:nvPr/>
-        </p:nvSpPr>
-        <p:spPr>
-          <a:xfrm>
-            <a:off x="0" y="0"/>
-            <a:ext cx="12191695" cy="6858000"/>
-          </a:xfrm>
-          <a:prstGeom prst="rect">
-            <a:avLst/>
-          </a:prstGeom>
-          <a:solidFill>
-            <a:srgbClr val="F4F5F7"/>
-          </a:solidFill>
-          <a:ln>
-            <a:noFill/>
-          </a:ln>
-        </p:spPr>
-        <p:style>
-          <a:lnRef idx="1">
-            <a:schemeClr val="accent1"/>
-          </a:lnRef>
-          <a:fillRef idx="3">
-            <a:schemeClr val="accent1"/>
-          </a:fillRef>
-          <a:effectRef idx="2">
-            <a:schemeClr val="accent1"/>
-          </a:effectRef>
-          <a:fontRef idx="minor">
-            <a:schemeClr val="lt1"/>
-          </a:fontRef>
-        </p:style>
-        <p:txBody>
-          <a:bodyPr rtlCol="0" anchor="ctr"/>
-          <a:lstStyle/>
-          <a:p>
-            <a:pPr algn="ctr"/>
-          </a:p>
-        </p:txBody>
-      </p:sp>
-      <p:sp>
-        <p:nvSpPr>
-          <p:cNvPr id="3" name="Rectangle 2"/>
-          <p:cNvSpPr/>
-          <p:nvPr/>
-        </p:nvSpPr>
-        <p:spPr>
-          <a:xfrm>
-            <a:off x="0" y="0"/>
-            <a:ext cx="137160" cy="6858000"/>
-          </a:xfrm>
-          <a:prstGeom prst="rect">
-            <a:avLst/>
-          </a:prstGeom>
-          <a:solidFill>
-            <a:srgbClr val="3D5A80"/>
-          </a:solidFill>
-          <a:ln>
-            <a:noFill/>
-          </a:ln>
-        </p:spPr>
-        <p:style>
-          <a:lnRef idx="1">
-            <a:schemeClr val="accent1"/>
-          </a:lnRef>
-          <a:fillRef idx="3">
-            <a:schemeClr val="accent1"/>
-          </a:fillRef>
-          <a:effectRef idx="2">
-            <a:schemeClr val="accent1"/>
-          </a:effectRef>
-          <a:fontRef idx="minor">
-            <a:schemeClr val="lt1"/>
-          </a:fontRef>
-        </p:style>
-        <p:txBody>
-          <a:bodyPr rtlCol="0" anchor="ctr"/>
-          <a:lstStyle/>
-          <a:p>
-            <a:pPr algn="ctr"/>
-          </a:p>
-        </p:txBody>
-      </p:sp>
-      <p:sp>
-        <p:nvSpPr>
-          <p:cNvPr id="4" name="TextBox 3"/>
-          <p:cNvSpPr txBox="1"/>
-          <p:nvPr/>
-        </p:nvSpPr>
-        <p:spPr>
-          <a:xfrm>
-            <a:off x="502920" y="228600"/>
-            <a:ext cx="11155680" cy="411480"/>
-          </a:xfrm>
-          <a:prstGeom prst="rect">
-            <a:avLst/>
-          </a:prstGeom>
-          <a:noFill/>
-        </p:spPr>
-        <p:txBody>
-          <a:bodyPr wrap="square">
-            <a:spAutoFit/>
-          </a:bodyPr>
-          <a:lstStyle/>
-          <a:p>
-            <a:r>
-              <a:rPr sz="2200" b="1">
-                <a:solidFill>
-                  <a:srgbClr val="1C1C1C"/>
-                </a:solidFill>
-                <a:latin typeface="Georgia"/>
-              </a:rPr>
-              <a:t>FBref stability list (planned — Tier 2 not run yet)</a:t>
-            </a:r>
-          </a:p>
-        </p:txBody>
-      </p:sp>
-      <p:sp>
-        <p:nvSpPr>
-          <p:cNvPr id="5" name="TextBox 4"/>
-          <p:cNvSpPr txBox="1"/>
-          <p:nvPr/>
-        </p:nvSpPr>
-        <p:spPr>
-          <a:xfrm>
-            <a:off x="502920" y="685800"/>
-            <a:ext cx="11155680" cy="502920"/>
-          </a:xfrm>
-          <a:prstGeom prst="rect">
-            <a:avLst/>
-          </a:prstGeom>
-          <a:noFill/>
-        </p:spPr>
-        <p:txBody>
-          <a:bodyPr wrap="square">
-            <a:spAutoFit/>
-          </a:bodyPr>
-          <a:lstStyle/>
-          <a:p>
-            <a:r>
-              <a:rPr sz="1300" b="0">
-                <a:solidFill>
-                  <a:srgbClr val="555555"/>
-                </a:solidFill>
-                <a:latin typeface="Arial"/>
-              </a:rPr>
-              <a:t>Same idea as StatsBomb: prior league → Bundesliga Y1 correlation. Planned gate r ≥ ~0.40, then redundancy.</a:t>
-            </a:r>
-          </a:p>
-          <a:p>
-            <a:r>
-              <a:rPr sz="1300" b="0">
-                <a:solidFill>
-                  <a:srgbClr val="555555"/>
-                </a:solidFill>
-                <a:latin typeface="Arial"/>
-              </a:rPr>
-              <a:t>No live FBref r’s yet (need N≥500 paired seasons). Table = Step-2 planned keep/drop list from your PDF.</a:t>
-            </a:r>
-          </a:p>
-        </p:txBody>
-      </p:sp>
-      <p:graphicFrame>
-        <p:nvGraphicFramePr>
-          <p:cNvPr id="6" name="Table 5"/>
-          <p:cNvGraphicFramePr>
-            <a:graphicFrameLocks noGrp="1"/>
-          </p:cNvGraphicFramePr>
-          <p:nvPr/>
-        </p:nvGraphicFramePr>
-        <p:xfrm>
-          <a:off x="411480" y="1325880"/>
-          <a:ext cx="11338560" cy="4169664"/>
-        </p:xfrm>
-        <a:graphic>
-          <a:graphicData uri="http://schemas.openxmlformats.org/drawingml/2006/table">
-            <a:tbl>
-              <a:tblPr firstRow="1" bandRow="1">
-                <a:tableStyleId>{5C22544A-7EE6-4342-B048-85BDC9FD1C3A}</a:tableStyleId>
-              </a:tblPr>
-              <a:tblGrid>
-                <a:gridCol w="914400"/>
-                <a:gridCol w="2743200"/>
-                <a:gridCol w="1371600"/>
-                <a:gridCol w="2011680"/>
-                <a:gridCol w="4297680"/>
-              </a:tblGrid>
-              <a:tr h="347472">
-                <a:tc>
-                  <a:txBody>
-                    <a:bodyPr/>
-                    <a:lstStyle/>
-                    <a:p>
-                      <a:r>
-                        <a:rPr sz="1100" b="1">
-                          <a:solidFill>
-                            <a:srgbClr val="FFFFFF"/>
-                          </a:solidFill>
-                          <a:latin typeface="Arial"/>
-                        </a:rPr>
-                        <a:t>Abbrev</a:t>
-                      </a:r>
-                    </a:p>
-                  </a:txBody>
-                  <a:tcPr>
-                    <a:solidFill>
-                      <a:srgbClr val="1C1C1C"/>
-                    </a:solidFill>
-                  </a:tcPr>
-                </a:tc>
-                <a:tc>
-                  <a:txBody>
-                    <a:bodyPr/>
-                    <a:lstStyle/>
-                    <a:p>
-                      <a:r>
-                        <a:rPr sz="1100" b="1">
-                          <a:solidFill>
-                            <a:srgbClr val="FFFFFF"/>
-                          </a:solidFill>
-                          <a:latin typeface="Arial"/>
-                        </a:rPr>
-                        <a:t>FBref metric</a:t>
-                      </a:r>
-                    </a:p>
-                  </a:txBody>
-                  <a:tcPr>
-                    <a:solidFill>
-                      <a:srgbClr val="1C1C1C"/>
-                    </a:solidFill>
-                  </a:tcPr>
-                </a:tc>
-                <a:tc>
-                  <a:txBody>
-                    <a:bodyPr/>
-                    <a:lstStyle/>
-                    <a:p>
-                      <a:r>
-                        <a:rPr sz="1100" b="1">
-                          <a:solidFill>
-                            <a:srgbClr val="FFFFFF"/>
-                          </a:solidFill>
-                          <a:latin typeface="Arial"/>
-                        </a:rPr>
-                        <a:t>Category</a:t>
-                      </a:r>
-                    </a:p>
-                  </a:txBody>
-                  <a:tcPr>
-                    <a:solidFill>
-                      <a:srgbClr val="1C1C1C"/>
-                    </a:solidFill>
-                  </a:tcPr>
-                </a:tc>
-                <a:tc>
-                  <a:txBody>
-                    <a:bodyPr/>
-                    <a:lstStyle/>
-                    <a:p>
-                      <a:r>
-                        <a:rPr sz="1100" b="1">
-                          <a:solidFill>
-                            <a:srgbClr val="FFFFFF"/>
-                          </a:solidFill>
-                          <a:latin typeface="Arial"/>
-                        </a:rPr>
-                        <a:t>Stability status</a:t>
-                      </a:r>
-                    </a:p>
-                  </a:txBody>
-                  <a:tcPr>
-                    <a:solidFill>
-                      <a:srgbClr val="1C1C1C"/>
-                    </a:solidFill>
-                  </a:tcPr>
-                </a:tc>
-                <a:tc>
-                  <a:txBody>
-                    <a:bodyPr/>
-                    <a:lstStyle/>
-                    <a:p>
-                      <a:r>
-                        <a:rPr sz="1100" b="1">
-                          <a:solidFill>
-                            <a:srgbClr val="FFFFFF"/>
-                          </a:solidFill>
-                          <a:latin typeface="Arial"/>
-                        </a:rPr>
-                        <a:t>Note</a:t>
-                      </a:r>
-                    </a:p>
-                  </a:txBody>
-                  <a:tcPr>
-                    <a:solidFill>
-                      <a:srgbClr val="1C1C1C"/>
-                    </a:solidFill>
-                  </a:tcPr>
-                </a:tc>
-              </a:tr>
-              <a:tr h="347472">
-                <a:tc>
-                  <a:txBody>
-                    <a:bodyPr/>
-                    <a:lstStyle/>
-                    <a:p>
-                      <a:r>
-                        <a:rPr sz="1100" b="1">
-                          <a:solidFill>
-                            <a:srgbClr val="1C1C1C"/>
-                          </a:solidFill>
-                          <a:latin typeface="Arial"/>
-                        </a:rPr>
-                        <a:t>PrgP</a:t>
-                      </a:r>
-                    </a:p>
-                  </a:txBody>
-                  <a:tcPr>
-                    <a:solidFill>
-                      <a:srgbClr val="F0FAF4"/>
-                    </a:solidFill>
-                  </a:tcPr>
-                </a:tc>
-                <a:tc>
-                  <a:txBody>
-                    <a:bodyPr/>
-                    <a:lstStyle/>
-                    <a:p>
-                      <a:r>
-                        <a:rPr sz="1100" b="1">
-                          <a:solidFill>
-                            <a:srgbClr val="1C1C1C"/>
-                          </a:solidFill>
-                          <a:latin typeface="Arial"/>
-                        </a:rPr>
-                        <a:t>Progressive passes</a:t>
-                      </a:r>
-                    </a:p>
-                  </a:txBody>
-                  <a:tcPr>
-                    <a:solidFill>
-                      <a:srgbClr val="F0FAF4"/>
-                    </a:solidFill>
-                  </a:tcPr>
-                </a:tc>
-                <a:tc>
-                  <a:txBody>
-                    <a:bodyPr/>
-                    <a:lstStyle/>
-                    <a:p>
-                      <a:r>
-                        <a:rPr sz="1100" b="1">
-                          <a:solidFill>
-                            <a:srgbClr val="1C1C1C"/>
-                          </a:solidFill>
-                          <a:latin typeface="Arial"/>
-                        </a:rPr>
-                        <a:t>Passing</a:t>
-                      </a:r>
-                    </a:p>
-                  </a:txBody>
-                  <a:tcPr>
-                    <a:solidFill>
-                      <a:srgbClr val="F0FAF4"/>
-                    </a:solidFill>
-                  </a:tcPr>
-                </a:tc>
-                <a:tc>
-                  <a:txBody>
-                    <a:bodyPr/>
-                    <a:lstStyle/>
-                    <a:p>
-                      <a:r>
-                        <a:rPr sz="1100" b="1">
-                          <a:solidFill>
-                            <a:srgbClr val="1C1C1C"/>
-                          </a:solidFill>
-                          <a:latin typeface="Arial"/>
-                        </a:rPr>
-                        <a:t>Planned PASS</a:t>
-                      </a:r>
-                    </a:p>
-                  </a:txBody>
-                  <a:tcPr>
-                    <a:solidFill>
-                      <a:srgbClr val="F0FAF4"/>
-                    </a:solidFill>
-                  </a:tcPr>
-                </a:tc>
-                <a:tc>
-                  <a:txBody>
-                    <a:bodyPr/>
-                    <a:lstStyle/>
-                    <a:p>
-                      <a:r>
-                        <a:rPr sz="1100" b="1">
-                          <a:solidFill>
-                            <a:srgbClr val="1C1C1C"/>
-                          </a:solidFill>
-                          <a:latin typeface="Arial"/>
-                        </a:rPr>
-                        <a:t>Keep over Passes (cluster)</a:t>
-                      </a:r>
-                    </a:p>
-                  </a:txBody>
-                  <a:tcPr>
-                    <a:solidFill>
-                      <a:srgbClr val="F0FAF4"/>
-                    </a:solidFill>
-                  </a:tcPr>
-                </a:tc>
-              </a:tr>
-              <a:tr h="347472">
-                <a:tc>
-                  <a:txBody>
-                    <a:bodyPr/>
-                    <a:lstStyle/>
-                    <a:p>
-                      <a:r>
-                        <a:rPr sz="1100" b="0">
-                          <a:solidFill>
-                            <a:srgbClr val="1C1C1C"/>
-                          </a:solidFill>
-                          <a:latin typeface="Arial"/>
-                        </a:rPr>
-                        <a:t>Pass</a:t>
-                      </a:r>
-                    </a:p>
-                  </a:txBody>
-                  <a:tcPr>
-                    <a:solidFill>
-                      <a:srgbClr val="F2F2F2"/>
-                    </a:solidFill>
-                  </a:tcPr>
-                </a:tc>
-                <a:tc>
-                  <a:txBody>
-                    <a:bodyPr/>
-                    <a:lstStyle/>
-                    <a:p>
-                      <a:r>
-                        <a:rPr sz="1100" b="0">
-                          <a:solidFill>
-                            <a:srgbClr val="1C1C1C"/>
-                          </a:solidFill>
-                          <a:latin typeface="Arial"/>
-                        </a:rPr>
-                        <a:t>Passes (volume)</a:t>
-                      </a:r>
-                    </a:p>
-                  </a:txBody>
-                  <a:tcPr>
-                    <a:solidFill>
-                      <a:srgbClr val="F2F2F2"/>
-                    </a:solidFill>
-                  </a:tcPr>
-                </a:tc>
-                <a:tc>
-                  <a:txBody>
-                    <a:bodyPr/>
-                    <a:lstStyle/>
-                    <a:p>
-                      <a:r>
-                        <a:rPr sz="1100" b="0">
-                          <a:solidFill>
-                            <a:srgbClr val="1C1C1C"/>
-                          </a:solidFill>
-                          <a:latin typeface="Arial"/>
-                        </a:rPr>
-                        <a:t>Passing</a:t>
-                      </a:r>
-                    </a:p>
-                  </a:txBody>
-                  <a:tcPr>
-                    <a:solidFill>
-                      <a:srgbClr val="F2F2F2"/>
-                    </a:solidFill>
-                  </a:tcPr>
-                </a:tc>
-                <a:tc>
-                  <a:txBody>
-                    <a:bodyPr/>
-                    <a:lstStyle/>
-                    <a:p>
-                      <a:r>
-                        <a:rPr sz="1100" b="0">
-                          <a:solidFill>
-                            <a:srgbClr val="1C1C1C"/>
-                          </a:solidFill>
-                          <a:latin typeface="Arial"/>
-                        </a:rPr>
-                        <a:t>Planned OUT</a:t>
-                      </a:r>
-                    </a:p>
-                  </a:txBody>
-                  <a:tcPr>
-                    <a:solidFill>
-                      <a:srgbClr val="F2F2F2"/>
-                    </a:solidFill>
-                  </a:tcPr>
-                </a:tc>
-                <a:tc>
-                  <a:txBody>
-                    <a:bodyPr/>
-                    <a:lstStyle/>
-                    <a:p>
-                      <a:r>
-                        <a:rPr sz="1100" b="0">
-                          <a:solidFill>
-                            <a:srgbClr val="1C1C1C"/>
-                          </a:solidFill>
-                          <a:latin typeface="Arial"/>
-                        </a:rPr>
-                        <a:t>Drop vs PrgP</a:t>
-                      </a:r>
-                    </a:p>
-                  </a:txBody>
-                  <a:tcPr>
-                    <a:solidFill>
-                      <a:srgbClr val="F2F2F2"/>
-                    </a:solidFill>
-                  </a:tcPr>
-                </a:tc>
-              </a:tr>
-              <a:tr h="347472">
-                <a:tc>
-                  <a:txBody>
-                    <a:bodyPr/>
-                    <a:lstStyle/>
-                    <a:p>
-                      <a:r>
-                        <a:rPr sz="1100" b="1">
-                          <a:solidFill>
-                            <a:srgbClr val="1C1C1C"/>
-                          </a:solidFill>
-                          <a:latin typeface="Arial"/>
-                        </a:rPr>
-                        <a:t>Carr</a:t>
-                      </a:r>
-                    </a:p>
-                  </a:txBody>
-                  <a:tcPr>
-                    <a:solidFill>
-                      <a:srgbClr val="F0FAF4"/>
-                    </a:solidFill>
-                  </a:tcPr>
-                </a:tc>
-                <a:tc>
-                  <a:txBody>
-                    <a:bodyPr/>
-                    <a:lstStyle/>
-                    <a:p>
-                      <a:r>
-                        <a:rPr sz="1100" b="1">
-                          <a:solidFill>
-                            <a:srgbClr val="1C1C1C"/>
-                          </a:solidFill>
-                          <a:latin typeface="Arial"/>
-                        </a:rPr>
-                        <a:t>Carries</a:t>
-                      </a:r>
-                    </a:p>
-                  </a:txBody>
-                  <a:tcPr>
-                    <a:solidFill>
-                      <a:srgbClr val="F0FAF4"/>
-                    </a:solidFill>
-                  </a:tcPr>
-                </a:tc>
-                <a:tc>
-                  <a:txBody>
-                    <a:bodyPr/>
-                    <a:lstStyle/>
-                    <a:p>
-                      <a:r>
-                        <a:rPr sz="1100" b="1">
-                          <a:solidFill>
-                            <a:srgbClr val="1C1C1C"/>
-                          </a:solidFill>
-                          <a:latin typeface="Arial"/>
-                        </a:rPr>
-                        <a:t>Carrying</a:t>
-                      </a:r>
-                    </a:p>
-                  </a:txBody>
-                  <a:tcPr>
-                    <a:solidFill>
-                      <a:srgbClr val="F0FAF4"/>
-                    </a:solidFill>
-                  </a:tcPr>
-                </a:tc>
-                <a:tc>
-                  <a:txBody>
-                    <a:bodyPr/>
-                    <a:lstStyle/>
-                    <a:p>
-                      <a:r>
-                        <a:rPr sz="1100" b="1">
-                          <a:solidFill>
-                            <a:srgbClr val="1C1C1C"/>
-                          </a:solidFill>
-                          <a:latin typeface="Arial"/>
-                        </a:rPr>
-                        <a:t>Planned PASS</a:t>
-                      </a:r>
-                    </a:p>
-                  </a:txBody>
-                  <a:tcPr>
-                    <a:solidFill>
-                      <a:srgbClr val="F0FAF4"/>
-                    </a:solidFill>
-                  </a:tcPr>
-                </a:tc>
-                <a:tc>
-                  <a:txBody>
-                    <a:bodyPr/>
-                    <a:lstStyle/>
-                    <a:p>
-                      <a:r>
-                        <a:rPr sz="1100" b="1">
-                          <a:solidFill>
-                            <a:srgbClr val="1C1C1C"/>
-                          </a:solidFill>
-                          <a:latin typeface="Arial"/>
-                        </a:rPr>
-                        <a:t>Keep over PrgC (cluster)</a:t>
-                      </a:r>
-                    </a:p>
-                  </a:txBody>
-                  <a:tcPr>
-                    <a:solidFill>
-                      <a:srgbClr val="F0FAF4"/>
-                    </a:solidFill>
-                  </a:tcPr>
-                </a:tc>
-              </a:tr>
-              <a:tr h="347472">
-                <a:tc>
-                  <a:txBody>
-                    <a:bodyPr/>
-                    <a:lstStyle/>
-                    <a:p>
-                      <a:r>
-                        <a:rPr sz="1100" b="0">
-                          <a:solidFill>
-                            <a:srgbClr val="1C1C1C"/>
-                          </a:solidFill>
-                          <a:latin typeface="Arial"/>
-                        </a:rPr>
-                        <a:t>PrgC</a:t>
-                      </a:r>
-                    </a:p>
-                  </a:txBody>
-                  <a:tcPr>
-                    <a:solidFill>
-                      <a:srgbClr val="F2F2F2"/>
-                    </a:solidFill>
-                  </a:tcPr>
-                </a:tc>
-                <a:tc>
-                  <a:txBody>
-                    <a:bodyPr/>
-                    <a:lstStyle/>
-                    <a:p>
-                      <a:r>
-                        <a:rPr sz="1100" b="0">
-                          <a:solidFill>
-                            <a:srgbClr val="1C1C1C"/>
-                          </a:solidFill>
-                          <a:latin typeface="Arial"/>
-                        </a:rPr>
-                        <a:t>Progressive carries</a:t>
-                      </a:r>
-                    </a:p>
-                  </a:txBody>
-                  <a:tcPr>
-                    <a:solidFill>
-                      <a:srgbClr val="F2F2F2"/>
-                    </a:solidFill>
-                  </a:tcPr>
-                </a:tc>
-                <a:tc>
-                  <a:txBody>
-                    <a:bodyPr/>
-                    <a:lstStyle/>
-                    <a:p>
-                      <a:r>
-                        <a:rPr sz="1100" b="0">
-                          <a:solidFill>
-                            <a:srgbClr val="1C1C1C"/>
-                          </a:solidFill>
-                          <a:latin typeface="Arial"/>
-                        </a:rPr>
-                        <a:t>Carrying</a:t>
-                      </a:r>
-                    </a:p>
-                  </a:txBody>
-                  <a:tcPr>
-                    <a:solidFill>
-                      <a:srgbClr val="F2F2F2"/>
-                    </a:solidFill>
-                  </a:tcPr>
-                </a:tc>
-                <a:tc>
-                  <a:txBody>
-                    <a:bodyPr/>
-                    <a:lstStyle/>
-                    <a:p>
-                      <a:r>
-                        <a:rPr sz="1100" b="0">
-                          <a:solidFill>
-                            <a:srgbClr val="1C1C1C"/>
-                          </a:solidFill>
-                          <a:latin typeface="Arial"/>
-                        </a:rPr>
-                        <a:t>Planned OUT</a:t>
-                      </a:r>
-                    </a:p>
-                  </a:txBody>
-                  <a:tcPr>
-                    <a:solidFill>
-                      <a:srgbClr val="F2F2F2"/>
-                    </a:solidFill>
-                  </a:tcPr>
-                </a:tc>
-                <a:tc>
-                  <a:txBody>
-                    <a:bodyPr/>
-                    <a:lstStyle/>
-                    <a:p>
-                      <a:r>
-                        <a:rPr sz="1100" b="0">
-                          <a:solidFill>
-                            <a:srgbClr val="1C1C1C"/>
-                          </a:solidFill>
-                          <a:latin typeface="Arial"/>
-                        </a:rPr>
-                        <a:t>Drop vs Carries</a:t>
-                      </a:r>
-                    </a:p>
-                  </a:txBody>
-                  <a:tcPr>
-                    <a:solidFill>
-                      <a:srgbClr val="F2F2F2"/>
-                    </a:solidFill>
-                  </a:tcPr>
-                </a:tc>
-              </a:tr>
-              <a:tr h="347472">
-                <a:tc>
-                  <a:txBody>
-                    <a:bodyPr/>
-                    <a:lstStyle/>
-                    <a:p>
-                      <a:r>
-                        <a:rPr sz="1100" b="1">
-                          <a:solidFill>
-                            <a:srgbClr val="1C1C1C"/>
-                          </a:solidFill>
-                          <a:latin typeface="Arial"/>
-                        </a:rPr>
-                        <a:t>npxG</a:t>
-                      </a:r>
-                    </a:p>
-                  </a:txBody>
-                  <a:tcPr>
-                    <a:solidFill>
-                      <a:srgbClr val="F0FAF4"/>
-                    </a:solidFill>
-                  </a:tcPr>
-                </a:tc>
-                <a:tc>
-                  <a:txBody>
-                    <a:bodyPr/>
-                    <a:lstStyle/>
-                    <a:p>
-                      <a:r>
-                        <a:rPr sz="1100" b="1">
-                          <a:solidFill>
-                            <a:srgbClr val="1C1C1C"/>
-                          </a:solidFill>
-                          <a:latin typeface="Arial"/>
-                        </a:rPr>
-                        <a:t>Non-pen xG</a:t>
-                      </a:r>
-                    </a:p>
-                  </a:txBody>
-                  <a:tcPr>
-                    <a:solidFill>
-                      <a:srgbClr val="F0FAF4"/>
-                    </a:solidFill>
-                  </a:tcPr>
-                </a:tc>
-                <a:tc>
-                  <a:txBody>
-                    <a:bodyPr/>
-                    <a:lstStyle/>
-                    <a:p>
-                      <a:r>
-                        <a:rPr sz="1100" b="1">
-                          <a:solidFill>
-                            <a:srgbClr val="1C1C1C"/>
-                          </a:solidFill>
-                          <a:latin typeface="Arial"/>
-                        </a:rPr>
-                        <a:t>Attacking</a:t>
-                      </a:r>
-                    </a:p>
-                  </a:txBody>
-                  <a:tcPr>
-                    <a:solidFill>
-                      <a:srgbClr val="F0FAF4"/>
-                    </a:solidFill>
-                  </a:tcPr>
-                </a:tc>
-                <a:tc>
-                  <a:txBody>
-                    <a:bodyPr/>
-                    <a:lstStyle/>
-                    <a:p>
-                      <a:r>
-                        <a:rPr sz="1100" b="1">
-                          <a:solidFill>
-                            <a:srgbClr val="1C1C1C"/>
-                          </a:solidFill>
-                          <a:latin typeface="Arial"/>
-                        </a:rPr>
-                        <a:t>Planned PASS</a:t>
-                      </a:r>
-                    </a:p>
-                  </a:txBody>
-                  <a:tcPr>
-                    <a:solidFill>
-                      <a:srgbClr val="F0FAF4"/>
-                    </a:solidFill>
-                  </a:tcPr>
-                </a:tc>
-                <a:tc>
-                  <a:txBody>
-                    <a:bodyPr/>
-                    <a:lstStyle/>
-                    <a:p>
-                      <a:r>
-                        <a:rPr sz="1100" b="1">
-                          <a:solidFill>
-                            <a:srgbClr val="1C1C1C"/>
-                          </a:solidFill>
-                          <a:latin typeface="Arial"/>
-                        </a:rPr>
-                        <a:t>Keep over Shots (cluster)</a:t>
-                      </a:r>
-                    </a:p>
-                  </a:txBody>
-                  <a:tcPr>
-                    <a:solidFill>
-                      <a:srgbClr val="F0FAF4"/>
-                    </a:solidFill>
-                  </a:tcPr>
-                </a:tc>
-              </a:tr>
-              <a:tr h="347472">
-                <a:tc>
-                  <a:txBody>
-                    <a:bodyPr/>
-                    <a:lstStyle/>
-                    <a:p>
-                      <a:r>
-                        <a:rPr sz="1100" b="0">
-                          <a:solidFill>
-                            <a:srgbClr val="1C1C1C"/>
-                          </a:solidFill>
-                          <a:latin typeface="Arial"/>
-                        </a:rPr>
-                        <a:t>Sh</a:t>
-                      </a:r>
-                    </a:p>
-                  </a:txBody>
-                  <a:tcPr>
-                    <a:solidFill>
-                      <a:srgbClr val="F2F2F2"/>
-                    </a:solidFill>
-                  </a:tcPr>
-                </a:tc>
-                <a:tc>
-                  <a:txBody>
-                    <a:bodyPr/>
-                    <a:lstStyle/>
-                    <a:p>
-                      <a:r>
-                        <a:rPr sz="1100" b="0">
-                          <a:solidFill>
-                            <a:srgbClr val="1C1C1C"/>
-                          </a:solidFill>
-                          <a:latin typeface="Arial"/>
-                        </a:rPr>
-                        <a:t>Shots</a:t>
-                      </a:r>
-                    </a:p>
-                  </a:txBody>
-                  <a:tcPr>
-                    <a:solidFill>
-                      <a:srgbClr val="F2F2F2"/>
-                    </a:solidFill>
-                  </a:tcPr>
-                </a:tc>
-                <a:tc>
-                  <a:txBody>
-                    <a:bodyPr/>
-                    <a:lstStyle/>
-                    <a:p>
-                      <a:r>
-                        <a:rPr sz="1100" b="0">
-                          <a:solidFill>
-                            <a:srgbClr val="1C1C1C"/>
-                          </a:solidFill>
-                          <a:latin typeface="Arial"/>
-                        </a:rPr>
-                        <a:t>Attacking</a:t>
-                      </a:r>
-                    </a:p>
-                  </a:txBody>
-                  <a:tcPr>
-                    <a:solidFill>
-                      <a:srgbClr val="F2F2F2"/>
-                    </a:solidFill>
-                  </a:tcPr>
-                </a:tc>
-                <a:tc>
-                  <a:txBody>
-                    <a:bodyPr/>
-                    <a:lstStyle/>
-                    <a:p>
-                      <a:r>
-                        <a:rPr sz="1100" b="0">
-                          <a:solidFill>
-                            <a:srgbClr val="1C1C1C"/>
-                          </a:solidFill>
-                          <a:latin typeface="Arial"/>
-                        </a:rPr>
-                        <a:t>Planned OUT</a:t>
-                      </a:r>
-                    </a:p>
-                  </a:txBody>
-                  <a:tcPr>
-                    <a:solidFill>
-                      <a:srgbClr val="F2F2F2"/>
-                    </a:solidFill>
-                  </a:tcPr>
-                </a:tc>
-                <a:tc>
-                  <a:txBody>
-                    <a:bodyPr/>
-                    <a:lstStyle/>
-                    <a:p>
-                      <a:r>
-                        <a:rPr sz="1100" b="0">
-                          <a:solidFill>
-                            <a:srgbClr val="1C1C1C"/>
-                          </a:solidFill>
-                          <a:latin typeface="Arial"/>
-                        </a:rPr>
-                        <a:t>Drop vs npxG</a:t>
-                      </a:r>
-                    </a:p>
-                  </a:txBody>
-                  <a:tcPr>
-                    <a:solidFill>
-                      <a:srgbClr val="F2F2F2"/>
-                    </a:solidFill>
-                  </a:tcPr>
-                </a:tc>
-              </a:tr>
-              <a:tr h="347472">
-                <a:tc>
-                  <a:txBody>
-                    <a:bodyPr/>
-                    <a:lstStyle/>
-                    <a:p>
-                      <a:r>
-                        <a:rPr sz="1100" b="1">
-                          <a:solidFill>
-                            <a:srgbClr val="1C1C1C"/>
-                          </a:solidFill>
-                          <a:latin typeface="Arial"/>
-                        </a:rPr>
-                        <a:t>SCA</a:t>
-                      </a:r>
-                    </a:p>
-                  </a:txBody>
-                  <a:tcPr>
-                    <a:solidFill>
-                      <a:srgbClr val="F0FAF4"/>
-                    </a:solidFill>
-                  </a:tcPr>
-                </a:tc>
-                <a:tc>
-                  <a:txBody>
-                    <a:bodyPr/>
-                    <a:lstStyle/>
-                    <a:p>
-                      <a:r>
-                        <a:rPr sz="1100" b="1">
-                          <a:solidFill>
-                            <a:srgbClr val="1C1C1C"/>
-                          </a:solidFill>
-                          <a:latin typeface="Arial"/>
-                        </a:rPr>
-                        <a:t>Shot-creating actions</a:t>
-                      </a:r>
-                    </a:p>
-                  </a:txBody>
-                  <a:tcPr>
-                    <a:solidFill>
-                      <a:srgbClr val="F0FAF4"/>
-                    </a:solidFill>
-                  </a:tcPr>
-                </a:tc>
-                <a:tc>
-                  <a:txBody>
-                    <a:bodyPr/>
-                    <a:lstStyle/>
-                    <a:p>
-                      <a:r>
-                        <a:rPr sz="1100" b="1">
-                          <a:solidFill>
-                            <a:srgbClr val="1C1C1C"/>
-                          </a:solidFill>
-                          <a:latin typeface="Arial"/>
-                        </a:rPr>
-                        <a:t>Attacking</a:t>
-                      </a:r>
-                    </a:p>
-                  </a:txBody>
-                  <a:tcPr>
-                    <a:solidFill>
-                      <a:srgbClr val="F0FAF4"/>
-                    </a:solidFill>
-                  </a:tcPr>
-                </a:tc>
-                <a:tc>
-                  <a:txBody>
-                    <a:bodyPr/>
-                    <a:lstStyle/>
-                    <a:p>
-                      <a:r>
-                        <a:rPr sz="1100" b="1">
-                          <a:solidFill>
-                            <a:srgbClr val="1C1C1C"/>
-                          </a:solidFill>
-                          <a:latin typeface="Arial"/>
-                        </a:rPr>
-                        <a:t>Planned PASS</a:t>
-                      </a:r>
-                    </a:p>
-                  </a:txBody>
-                  <a:tcPr>
-                    <a:solidFill>
-                      <a:srgbClr val="F0FAF4"/>
-                    </a:solidFill>
-                  </a:tcPr>
-                </a:tc>
-                <a:tc>
-                  <a:txBody>
-                    <a:bodyPr/>
-                    <a:lstStyle/>
-                    <a:p>
-                      <a:r>
-                        <a:rPr sz="1100" b="1">
-                          <a:solidFill>
-                            <a:srgbClr val="1C1C1C"/>
-                          </a:solidFill>
-                          <a:latin typeface="Arial"/>
-                        </a:rPr>
-                        <a:t>Singleton</a:t>
-                      </a:r>
-                    </a:p>
-                  </a:txBody>
-                  <a:tcPr>
-                    <a:solidFill>
-                      <a:srgbClr val="F0FAF4"/>
-                    </a:solidFill>
-                  </a:tcPr>
-                </a:tc>
-              </a:tr>
-              <a:tr h="347472">
-                <a:tc>
-                  <a:txBody>
-                    <a:bodyPr/>
-                    <a:lstStyle/>
-                    <a:p>
-                      <a:r>
-                        <a:rPr sz="1100" b="1">
-                          <a:solidFill>
-                            <a:srgbClr val="1C1C1C"/>
-                          </a:solidFill>
-                          <a:latin typeface="Arial"/>
-                        </a:rPr>
-                        <a:t>Tkl</a:t>
-                      </a:r>
-                    </a:p>
-                  </a:txBody>
-                  <a:tcPr>
-                    <a:solidFill>
-                      <a:srgbClr val="F0FAF4"/>
-                    </a:solidFill>
-                  </a:tcPr>
-                </a:tc>
-                <a:tc>
-                  <a:txBody>
-                    <a:bodyPr/>
-                    <a:lstStyle/>
-                    <a:p>
-                      <a:r>
-                        <a:rPr sz="1100" b="1">
-                          <a:solidFill>
-                            <a:srgbClr val="1C1C1C"/>
-                          </a:solidFill>
-                          <a:latin typeface="Arial"/>
-                        </a:rPr>
-                        <a:t>Tackles</a:t>
-                      </a:r>
-                    </a:p>
-                  </a:txBody>
-                  <a:tcPr>
-                    <a:solidFill>
-                      <a:srgbClr val="F0FAF4"/>
-                    </a:solidFill>
-                  </a:tcPr>
-                </a:tc>
-                <a:tc>
-                  <a:txBody>
-                    <a:bodyPr/>
-                    <a:lstStyle/>
-                    <a:p>
-                      <a:r>
-                        <a:rPr sz="1100" b="1">
-                          <a:solidFill>
-                            <a:srgbClr val="1C1C1C"/>
-                          </a:solidFill>
-                          <a:latin typeface="Arial"/>
-                        </a:rPr>
-                        <a:t>Defending</a:t>
-                      </a:r>
-                    </a:p>
-                  </a:txBody>
-                  <a:tcPr>
-                    <a:solidFill>
-                      <a:srgbClr val="F0FAF4"/>
-                    </a:solidFill>
-                  </a:tcPr>
-                </a:tc>
-                <a:tc>
-                  <a:txBody>
-                    <a:bodyPr/>
-                    <a:lstStyle/>
-                    <a:p>
-                      <a:r>
-                        <a:rPr sz="1100" b="1">
-                          <a:solidFill>
-                            <a:srgbClr val="1C1C1C"/>
-                          </a:solidFill>
-                          <a:latin typeface="Arial"/>
-                        </a:rPr>
-                        <a:t>Planned PASS</a:t>
-                      </a:r>
-                    </a:p>
-                  </a:txBody>
-                  <a:tcPr>
-                    <a:solidFill>
-                      <a:srgbClr val="F0FAF4"/>
-                    </a:solidFill>
-                  </a:tcPr>
-                </a:tc>
-                <a:tc>
-                  <a:txBody>
-                    <a:bodyPr/>
-                    <a:lstStyle/>
-                    <a:p>
-                      <a:r>
-                        <a:rPr sz="1100" b="1">
-                          <a:solidFill>
-                            <a:srgbClr val="1C1C1C"/>
-                          </a:solidFill>
-                          <a:latin typeface="Arial"/>
-                        </a:rPr>
-                        <a:t>Singleton</a:t>
-                      </a:r>
-                    </a:p>
-                  </a:txBody>
-                  <a:tcPr>
-                    <a:solidFill>
-                      <a:srgbClr val="F0FAF4"/>
-                    </a:solidFill>
-                  </a:tcPr>
-                </a:tc>
-              </a:tr>
-              <a:tr h="347472">
-                <a:tc>
-                  <a:txBody>
-                    <a:bodyPr/>
-                    <a:lstStyle/>
-                    <a:p>
-                      <a:r>
-                        <a:rPr sz="1100" b="1">
-                          <a:solidFill>
-                            <a:srgbClr val="1C1C1C"/>
-                          </a:solidFill>
-                          <a:latin typeface="Arial"/>
-                        </a:rPr>
-                        <a:t>Int</a:t>
-                      </a:r>
-                    </a:p>
-                  </a:txBody>
-                  <a:tcPr>
-                    <a:solidFill>
-                      <a:srgbClr val="F0FAF4"/>
-                    </a:solidFill>
-                  </a:tcPr>
-                </a:tc>
-                <a:tc>
-                  <a:txBody>
-                    <a:bodyPr/>
-                    <a:lstStyle/>
-                    <a:p>
-                      <a:r>
-                        <a:rPr sz="1100" b="1">
-                          <a:solidFill>
-                            <a:srgbClr val="1C1C1C"/>
-                          </a:solidFill>
-                          <a:latin typeface="Arial"/>
-                        </a:rPr>
-                        <a:t>Interceptions</a:t>
-                      </a:r>
-                    </a:p>
-                  </a:txBody>
-                  <a:tcPr>
-                    <a:solidFill>
-                      <a:srgbClr val="F0FAF4"/>
-                    </a:solidFill>
-                  </a:tcPr>
-                </a:tc>
-                <a:tc>
-                  <a:txBody>
-                    <a:bodyPr/>
-                    <a:lstStyle/>
-                    <a:p>
-                      <a:r>
-                        <a:rPr sz="1100" b="1">
-                          <a:solidFill>
-                            <a:srgbClr val="1C1C1C"/>
-                          </a:solidFill>
-                          <a:latin typeface="Arial"/>
-                        </a:rPr>
-                        <a:t>Defending</a:t>
-                      </a:r>
-                    </a:p>
-                  </a:txBody>
-                  <a:tcPr>
-                    <a:solidFill>
-                      <a:srgbClr val="F0FAF4"/>
-                    </a:solidFill>
-                  </a:tcPr>
-                </a:tc>
-                <a:tc>
-                  <a:txBody>
-                    <a:bodyPr/>
-                    <a:lstStyle/>
-                    <a:p>
-                      <a:r>
-                        <a:rPr sz="1100" b="1">
-                          <a:solidFill>
-                            <a:srgbClr val="1C1C1C"/>
-                          </a:solidFill>
-                          <a:latin typeface="Arial"/>
-                        </a:rPr>
-                        <a:t>Planned PASS</a:t>
-                      </a:r>
-                    </a:p>
-                  </a:txBody>
-                  <a:tcPr>
-                    <a:solidFill>
-                      <a:srgbClr val="F0FAF4"/>
-                    </a:solidFill>
-                  </a:tcPr>
-                </a:tc>
-                <a:tc>
-                  <a:txBody>
-                    <a:bodyPr/>
-                    <a:lstStyle/>
-                    <a:p>
-                      <a:r>
-                        <a:rPr sz="1100" b="1">
-                          <a:solidFill>
-                            <a:srgbClr val="1C1C1C"/>
-                          </a:solidFill>
-                          <a:latin typeface="Arial"/>
-                        </a:rPr>
-                        <a:t>Singleton</a:t>
-                      </a:r>
-                    </a:p>
-                  </a:txBody>
-                  <a:tcPr>
-                    <a:solidFill>
-                      <a:srgbClr val="F0FAF4"/>
-                    </a:solidFill>
-                  </a:tcPr>
-                </a:tc>
-              </a:tr>
-              <a:tr h="347472">
-                <a:tc>
-                  <a:txBody>
-                    <a:bodyPr/>
-                    <a:lstStyle/>
-                    <a:p>
-                      <a:r>
-                        <a:rPr sz="1100" b="1">
-                          <a:solidFill>
-                            <a:srgbClr val="1C1C1C"/>
-                          </a:solidFill>
-                          <a:latin typeface="Arial"/>
-                        </a:rPr>
-                        <a:t>Aer</a:t>
-                      </a:r>
-                    </a:p>
-                  </a:txBody>
-                  <a:tcPr>
-                    <a:solidFill>
-                      <a:srgbClr val="F0FAF4"/>
-                    </a:solidFill>
-                  </a:tcPr>
-                </a:tc>
-                <a:tc>
-                  <a:txBody>
-                    <a:bodyPr/>
-                    <a:lstStyle/>
-                    <a:p>
-                      <a:r>
-                        <a:rPr sz="1100" b="1">
-                          <a:solidFill>
-                            <a:srgbClr val="1C1C1C"/>
-                          </a:solidFill>
-                          <a:latin typeface="Arial"/>
-                        </a:rPr>
-                        <a:t>Aerials won</a:t>
-                      </a:r>
-                    </a:p>
-                  </a:txBody>
-                  <a:tcPr>
-                    <a:solidFill>
-                      <a:srgbClr val="F0FAF4"/>
-                    </a:solidFill>
-                  </a:tcPr>
-                </a:tc>
-                <a:tc>
-                  <a:txBody>
-                    <a:bodyPr/>
-                    <a:lstStyle/>
-                    <a:p>
-                      <a:r>
-                        <a:rPr sz="1100" b="1">
-                          <a:solidFill>
-                            <a:srgbClr val="1C1C1C"/>
-                          </a:solidFill>
-                          <a:latin typeface="Arial"/>
-                        </a:rPr>
-                        <a:t>Defending</a:t>
-                      </a:r>
-                    </a:p>
-                  </a:txBody>
-                  <a:tcPr>
-                    <a:solidFill>
-                      <a:srgbClr val="F0FAF4"/>
-                    </a:solidFill>
-                  </a:tcPr>
-                </a:tc>
-                <a:tc>
-                  <a:txBody>
-                    <a:bodyPr/>
-                    <a:lstStyle/>
-                    <a:p>
-                      <a:r>
-                        <a:rPr sz="1100" b="1">
-                          <a:solidFill>
-                            <a:srgbClr val="1C1C1C"/>
-                          </a:solidFill>
-                          <a:latin typeface="Arial"/>
-                        </a:rPr>
-                        <a:t>Planned PASS</a:t>
-                      </a:r>
-                    </a:p>
-                  </a:txBody>
-                  <a:tcPr>
-                    <a:solidFill>
-                      <a:srgbClr val="F0FAF4"/>
-                    </a:solidFill>
-                  </a:tcPr>
-                </a:tc>
-                <a:tc>
-                  <a:txBody>
-                    <a:bodyPr/>
-                    <a:lstStyle/>
-                    <a:p>
-                      <a:r>
-                        <a:rPr sz="1100" b="1">
-                          <a:solidFill>
-                            <a:srgbClr val="1C1C1C"/>
-                          </a:solidFill>
-                          <a:latin typeface="Arial"/>
-                        </a:rPr>
-                        <a:t>Singleton</a:t>
-                      </a:r>
-                    </a:p>
-                  </a:txBody>
-                  <a:tcPr>
-                    <a:solidFill>
-                      <a:srgbClr val="F0FAF4"/>
-                    </a:solidFill>
-                  </a:tcPr>
-                </a:tc>
-              </a:tr>
-              <a:tr h="347472">
-                <a:tc>
-                  <a:txBody>
-                    <a:bodyPr/>
-                    <a:lstStyle/>
-                    <a:p>
-                      <a:r>
-                        <a:rPr sz="1100" b="1">
-                          <a:solidFill>
-                            <a:srgbClr val="1C1C1C"/>
-                          </a:solidFill>
-                          <a:latin typeface="Arial"/>
-                        </a:rPr>
-                        <a:t>AttPen</a:t>
-                      </a:r>
-                    </a:p>
-                  </a:txBody>
-                  <a:tcPr>
-                    <a:solidFill>
-                      <a:srgbClr val="F0FAF4"/>
-                    </a:solidFill>
-                  </a:tcPr>
-                </a:tc>
-                <a:tc>
-                  <a:txBody>
-                    <a:bodyPr/>
-                    <a:lstStyle/>
-                    <a:p>
-                      <a:r>
-                        <a:rPr sz="1100" b="1">
-                          <a:solidFill>
-                            <a:srgbClr val="1C1C1C"/>
-                          </a:solidFill>
-                          <a:latin typeface="Arial"/>
-                        </a:rPr>
-                        <a:t>Touches in attacking pen</a:t>
-                      </a:r>
-                    </a:p>
-                  </a:txBody>
-                  <a:tcPr>
-                    <a:solidFill>
-                      <a:srgbClr val="F0FAF4"/>
-                    </a:solidFill>
-                  </a:tcPr>
-                </a:tc>
-                <a:tc>
-                  <a:txBody>
-                    <a:bodyPr/>
-                    <a:lstStyle/>
-                    <a:p>
-                      <a:r>
-                        <a:rPr sz="1100" b="1">
-                          <a:solidFill>
-                            <a:srgbClr val="1C1C1C"/>
-                          </a:solidFill>
-                          <a:latin typeface="Arial"/>
-                        </a:rPr>
-                        <a:t>Attacking</a:t>
-                      </a:r>
-                    </a:p>
-                  </a:txBody>
-                  <a:tcPr>
-                    <a:solidFill>
-                      <a:srgbClr val="F0FAF4"/>
-                    </a:solidFill>
-                  </a:tcPr>
-                </a:tc>
-                <a:tc>
-                  <a:txBody>
-                    <a:bodyPr/>
-                    <a:lstStyle/>
-                    <a:p>
-                      <a:r>
-                        <a:rPr sz="1100" b="1">
-                          <a:solidFill>
-                            <a:srgbClr val="1C1C1C"/>
-                          </a:solidFill>
-                          <a:latin typeface="Arial"/>
-                        </a:rPr>
-                        <a:t>Planned PASS</a:t>
-                      </a:r>
-                    </a:p>
-                  </a:txBody>
-                  <a:tcPr>
-                    <a:solidFill>
-                      <a:srgbClr val="F0FAF4"/>
-                    </a:solidFill>
-                  </a:tcPr>
-                </a:tc>
-                <a:tc>
-                  <a:txBody>
-                    <a:bodyPr/>
-                    <a:lstStyle/>
-                    <a:p>
-                      <a:r>
-                        <a:rPr sz="1100" b="1">
-                          <a:solidFill>
-                            <a:srgbClr val="1C1C1C"/>
-                          </a:solidFill>
-                          <a:latin typeface="Arial"/>
-                        </a:rPr>
-                        <a:t>Singleton</a:t>
-                      </a:r>
-                    </a:p>
-                  </a:txBody>
-                  <a:tcPr>
-                    <a:solidFill>
-                      <a:srgbClr val="F0FAF4"/>
-                    </a:solidFill>
-                  </a:tcPr>
-                </a:tc>
-              </a:tr>
-            </a:tbl>
-          </a:graphicData>
-        </a:graphic>
-      </p:graphicFrame>
-      <p:sp>
-        <p:nvSpPr>
-          <p:cNvPr id="7" name="TextBox 6"/>
-          <p:cNvSpPr txBox="1"/>
-          <p:nvPr/>
-        </p:nvSpPr>
-        <p:spPr>
-          <a:xfrm>
-            <a:off x="502920" y="6172200"/>
-            <a:ext cx="11155680" cy="365760"/>
-          </a:xfrm>
-          <a:prstGeom prst="rect">
-            <a:avLst/>
-          </a:prstGeom>
-          <a:noFill/>
-        </p:spPr>
-        <p:txBody>
-          <a:bodyPr wrap="square">
-            <a:spAutoFit/>
-          </a:bodyPr>
-          <a:lstStyle/>
-          <a:p>
-            <a:r>
-              <a:rPr sz="1100" b="0">
-                <a:solidFill>
-                  <a:srgbClr val="8A5A00"/>
-                </a:solidFill>
-                <a:latin typeface="Arial"/>
-              </a:rPr>
-              <a:t>When FBref is frozen: replace Planned PASS/OUT with real prior→Y1 stability r (same layout as StatsBomb slide).</a:t>
             </a:r>
           </a:p>
         </p:txBody>

</xml_diff>

<commit_message>
Run FBref Big-5 stability (N=117 pairs); update PPT and results.
Prior≥450 / Y1≥450 minutes; 71/103 metrics pass r≥0.40; redundancy auto shortlist written.
</commit_message>
<xml_diff>
--- a/bundesliga_transfer_traits.pptx
+++ b/bundesliga_transfer_traits.pptx
@@ -6063,8 +6063,8 @@
         </p:nvSpPr>
         <p:spPr>
           <a:xfrm>
-            <a:off x="502920" y="228600"/>
-            <a:ext cx="11155680" cy="411480"/>
+            <a:off x="457200" y="201168"/>
+            <a:ext cx="11247120" cy="411480"/>
           </a:xfrm>
           <a:prstGeom prst="rect">
             <a:avLst/>
@@ -6084,7 +6084,7 @@
                 </a:solidFill>
                 <a:latin typeface="Georgia"/>
               </a:rPr>
-              <a:t>FBref stability — NOT RUN YET (planned list only)</a:t>
+              <a:t>FBref stability — live results (Big 5 inbound)</a:t>
             </a:r>
           </a:p>
         </p:txBody>
@@ -6097,8 +6097,8 @@
         </p:nvSpPr>
         <p:spPr>
           <a:xfrm>
-            <a:off x="502920" y="685800"/>
-            <a:ext cx="11155680" cy="502920"/>
+            <a:off x="457200" y="640080"/>
+            <a:ext cx="11247120" cy="502920"/>
           </a:xfrm>
           <a:prstGeom prst="rect">
             <a:avLst/>
@@ -6112,35 +6112,24 @@
           <a:lstStyle/>
           <a:p>
             <a:r>
-              <a:rPr sz="1300" b="1">
+              <a:rPr sz="1200" b="0">
+                <a:solidFill>
+                  <a:srgbClr val="555555"/>
+                </a:solidFill>
+                <a:latin typeface="Arial"/>
+              </a:rPr>
+              <a:t>Paired N=117 · prior ≥450 min · BL Y1 ≥450 min · seasons end-years 2018–2025</a:t>
+            </a:r>
+          </a:p>
+          <a:p>
+            <a:r>
+              <a:rPr sz="1200" b="0">
                 <a:solidFill>
                   <a:srgbClr val="1C1C1C"/>
                 </a:solidFill>
                 <a:latin typeface="Arial"/>
               </a:rPr>
-              <a:t>Only StatsBomb stability has been computed (N=60). FBref Tier 2 pairs are not frozen.</a:t>
-            </a:r>
-          </a:p>
-          <a:p>
-            <a:r>
-              <a:rPr sz="1300" b="0">
-                <a:solidFill>
-                  <a:srgbClr val="555555"/>
-                </a:solidFill>
-                <a:latin typeface="Arial"/>
-              </a:rPr>
-              <a:t/>
-            </a:r>
-          </a:p>
-          <a:p>
-            <a:r>
-              <a:rPr sz="1300" b="0">
-                <a:solidFill>
-                  <a:srgbClr val="555555"/>
-                </a:solidFill>
-                <a:latin typeface="Arial"/>
-              </a:rPr>
-              <a:t>Table below is your Step-2 plan for when FBref is run — not real FBref r values.</a:t>
+              <a:t>Tested 103 metrics · 71 pass r≥0.40 · 35 pass r≥0.70 · 217 redundancy pairs · auto shortlist 22</a:t>
             </a:r>
           </a:p>
         </p:txBody>
@@ -6154,8 +6143,8 @@
           <p:nvPr/>
         </p:nvGraphicFramePr>
         <p:xfrm>
-          <a:off x="411480" y="1325880"/>
-          <a:ext cx="11338560" cy="4169664"/>
+          <a:off x="411480" y="1280160"/>
+          <a:ext cx="8961120" cy="4389120"/>
         </p:xfrm>
         <a:graphic>
           <a:graphicData uri="http://schemas.openxmlformats.org/drawingml/2006/table">
@@ -6164,20 +6153,20 @@
                 <a:tableStyleId>{5C22544A-7EE6-4342-B048-85BDC9FD1C3A}</a:tableStyleId>
               </a:tblPr>
               <a:tblGrid>
-                <a:gridCol w="914400"/>
-                <a:gridCol w="2743200"/>
+                <a:gridCol w="1005840"/>
+                <a:gridCol w="3840480"/>
+                <a:gridCol w="1463040"/>
                 <a:gridCol w="1371600"/>
-                <a:gridCol w="2011680"/>
-                <a:gridCol w="4297680"/>
+                <a:gridCol w="1280160"/>
               </a:tblGrid>
-              <a:tr h="347472">
-                <a:tc>
-                  <a:txBody>
-                    <a:bodyPr/>
-                    <a:lstStyle/>
-                    <a:p>
-                      <a:r>
-                        <a:rPr sz="1100" b="1">
+              <a:tr h="274320">
+                <a:tc>
+                  <a:txBody>
+                    <a:bodyPr/>
+                    <a:lstStyle/>
+                    <a:p>
+                      <a:r>
+                        <a:rPr sz="1000" b="1">
                           <a:solidFill>
                             <a:srgbClr val="FFFFFF"/>
                           </a:solidFill>
@@ -6199,13 +6188,13 @@
                     <a:lstStyle/>
                     <a:p>
                       <a:r>
-                        <a:rPr sz="1100" b="1">
+                        <a:rPr sz="1000" b="1">
                           <a:solidFill>
                             <a:srgbClr val="FFFFFF"/>
                           </a:solidFill>
                           <a:latin typeface="Arial"/>
                         </a:rPr>
-                        <a:t>FBref metric</a:t>
+                        <a:t>Metric</a:t>
                       </a:r>
                     </a:p>
                   </a:txBody>
@@ -6221,7 +6210,7 @@
                     <a:lstStyle/>
                     <a:p>
                       <a:r>
-                        <a:rPr sz="1100" b="1">
+                        <a:rPr sz="1000" b="1">
                           <a:solidFill>
                             <a:srgbClr val="FFFFFF"/>
                           </a:solidFill>
@@ -6243,13 +6232,13 @@
                     <a:lstStyle/>
                     <a:p>
                       <a:r>
-                        <a:rPr sz="1100" b="1">
+                        <a:rPr sz="1000" b="1">
                           <a:solidFill>
                             <a:srgbClr val="FFFFFF"/>
                           </a:solidFill>
                           <a:latin typeface="Arial"/>
                         </a:rPr>
-                        <a:t>Stability status</a:t>
+                        <a:t>Stability r</a:t>
                       </a:r>
                     </a:p>
                   </a:txBody>
@@ -6265,13 +6254,13 @@
                     <a:lstStyle/>
                     <a:p>
                       <a:r>
-                        <a:rPr sz="1100" b="1">
+                        <a:rPr sz="1000" b="1">
                           <a:solidFill>
                             <a:srgbClr val="FFFFFF"/>
                           </a:solidFill>
                           <a:latin typeface="Arial"/>
                         </a:rPr>
-                        <a:t>Note</a:t>
+                        <a:t>N</a:t>
                       </a:r>
                     </a:p>
                   </a:txBody>
@@ -6282,58 +6271,170 @@
                   </a:tcPr>
                 </a:tc>
               </a:tr>
-              <a:tr h="347472">
-                <a:tc>
-                  <a:txBody>
-                    <a:bodyPr/>
-                    <a:lstStyle/>
-                    <a:p>
-                      <a:r>
-                        <a:rPr sz="1100" b="1">
-                          <a:solidFill>
-                            <a:srgbClr val="1C1C1C"/>
-                          </a:solidFill>
-                          <a:latin typeface="Arial"/>
-                        </a:rPr>
-                        <a:t>PrgP</a:t>
-                      </a:r>
-                    </a:p>
-                  </a:txBody>
-                  <a:tcPr>
-                    <a:solidFill>
-                      <a:srgbClr val="F0FAF4"/>
-                    </a:solidFill>
-                  </a:tcPr>
-                </a:tc>
-                <a:tc>
-                  <a:txBody>
-                    <a:bodyPr/>
-                    <a:lstStyle/>
-                    <a:p>
-                      <a:r>
-                        <a:rPr sz="1100" b="1">
-                          <a:solidFill>
-                            <a:srgbClr val="1C1C1C"/>
-                          </a:solidFill>
-                          <a:latin typeface="Arial"/>
-                        </a:rPr>
-                        <a:t>Progressive passes</a:t>
-                      </a:r>
-                    </a:p>
-                  </a:txBody>
-                  <a:tcPr>
-                    <a:solidFill>
-                      <a:srgbClr val="F0FAF4"/>
-                    </a:solidFill>
-                  </a:tcPr>
-                </a:tc>
-                <a:tc>
-                  <a:txBody>
-                    <a:bodyPr/>
-                    <a:lstStyle/>
-                    <a:p>
-                      <a:r>
-                        <a:rPr sz="1100" b="1">
+              <a:tr h="274320">
+                <a:tc>
+                  <a:txBody>
+                    <a:bodyPr/>
+                    <a:lstStyle/>
+                    <a:p>
+                      <a:r>
+                        <a:rPr sz="1000" b="0">
+                          <a:solidFill>
+                            <a:srgbClr val="1C1C1C"/>
+                          </a:solidFill>
+                          <a:latin typeface="Arial"/>
+                        </a:rPr>
+                        <a:t>DEFPE</a:t>
+                      </a:r>
+                    </a:p>
+                  </a:txBody>
+                  <a:tcPr>
+                    <a:solidFill>
+                      <a:srgbClr val="F0FAF4"/>
+                    </a:solidFill>
+                  </a:tcPr>
+                </a:tc>
+                <a:tc>
+                  <a:txBody>
+                    <a:bodyPr/>
+                    <a:lstStyle/>
+                    <a:p>
+                      <a:r>
+                        <a:rPr sz="1000" b="0">
+                          <a:solidFill>
+                            <a:srgbClr val="1C1C1C"/>
+                          </a:solidFill>
+                          <a:latin typeface="Arial"/>
+                        </a:rPr>
+                        <a:t>Def Pen Touches</a:t>
+                      </a:r>
+                    </a:p>
+                  </a:txBody>
+                  <a:tcPr>
+                    <a:solidFill>
+                      <a:srgbClr val="F0FAF4"/>
+                    </a:solidFill>
+                  </a:tcPr>
+                </a:tc>
+                <a:tc>
+                  <a:txBody>
+                    <a:bodyPr/>
+                    <a:lstStyle/>
+                    <a:p>
+                      <a:r>
+                        <a:rPr sz="1000" b="0">
+                          <a:solidFill>
+                            <a:srgbClr val="1C1C1C"/>
+                          </a:solidFill>
+                          <a:latin typeface="Arial"/>
+                        </a:rPr>
+                        <a:t>Defending</a:t>
+                      </a:r>
+                    </a:p>
+                  </a:txBody>
+                  <a:tcPr>
+                    <a:solidFill>
+                      <a:srgbClr val="F0FAF4"/>
+                    </a:solidFill>
+                  </a:tcPr>
+                </a:tc>
+                <a:tc>
+                  <a:txBody>
+                    <a:bodyPr/>
+                    <a:lstStyle/>
+                    <a:p>
+                      <a:r>
+                        <a:rPr sz="1000" b="1">
+                          <a:solidFill>
+                            <a:srgbClr val="1C1C1C"/>
+                          </a:solidFill>
+                          <a:latin typeface="Arial"/>
+                        </a:rPr>
+                        <a:t>0.920</a:t>
+                      </a:r>
+                    </a:p>
+                  </a:txBody>
+                  <a:tcPr>
+                    <a:solidFill>
+                      <a:srgbClr val="F0FAF4"/>
+                    </a:solidFill>
+                  </a:tcPr>
+                </a:tc>
+                <a:tc>
+                  <a:txBody>
+                    <a:bodyPr/>
+                    <a:lstStyle/>
+                    <a:p>
+                      <a:r>
+                        <a:rPr sz="1000" b="0">
+                          <a:solidFill>
+                            <a:srgbClr val="1C1C1C"/>
+                          </a:solidFill>
+                          <a:latin typeface="Arial"/>
+                        </a:rPr>
+                        <a:t>114</a:t>
+                      </a:r>
+                    </a:p>
+                  </a:txBody>
+                  <a:tcPr>
+                    <a:solidFill>
+                      <a:srgbClr val="F0FAF4"/>
+                    </a:solidFill>
+                  </a:tcPr>
+                </a:tc>
+              </a:tr>
+              <a:tr h="274320">
+                <a:tc>
+                  <a:txBody>
+                    <a:bodyPr/>
+                    <a:lstStyle/>
+                    <a:p>
+                      <a:r>
+                        <a:rPr sz="1000" b="0">
+                          <a:solidFill>
+                            <a:srgbClr val="1C1C1C"/>
+                          </a:solidFill>
+                          <a:latin typeface="Arial"/>
+                        </a:rPr>
+                        <a:t>PRGC</a:t>
+                      </a:r>
+                    </a:p>
+                  </a:txBody>
+                  <a:tcPr>
+                    <a:solidFill>
+                      <a:srgbClr val="F0FAF4"/>
+                    </a:solidFill>
+                  </a:tcPr>
+                </a:tc>
+                <a:tc>
+                  <a:txBody>
+                    <a:bodyPr/>
+                    <a:lstStyle/>
+                    <a:p>
+                      <a:r>
+                        <a:rPr sz="1000" b="0">
+                          <a:solidFill>
+                            <a:srgbClr val="1C1C1C"/>
+                          </a:solidFill>
+                          <a:latin typeface="Arial"/>
+                        </a:rPr>
+                        <a:t>PrgC Progression</a:t>
+                      </a:r>
+                    </a:p>
+                  </a:txBody>
+                  <a:tcPr>
+                    <a:solidFill>
+                      <a:srgbClr val="F0FAF4"/>
+                    </a:solidFill>
+                  </a:tcPr>
+                </a:tc>
+                <a:tc>
+                  <a:txBody>
+                    <a:bodyPr/>
+                    <a:lstStyle/>
+                    <a:p>
+                      <a:r>
+                        <a:rPr sz="1000" b="0">
                           <a:solidFill>
                             <a:srgbClr val="1C1C1C"/>
                           </a:solidFill>
@@ -6355,35 +6456,35 @@
                     <a:lstStyle/>
                     <a:p>
                       <a:r>
-                        <a:rPr sz="1100" b="1">
-                          <a:solidFill>
-                            <a:srgbClr val="1C1C1C"/>
-                          </a:solidFill>
-                          <a:latin typeface="Arial"/>
-                        </a:rPr>
-                        <a:t>Planned PASS</a:t>
-                      </a:r>
-                    </a:p>
-                  </a:txBody>
-                  <a:tcPr>
-                    <a:solidFill>
-                      <a:srgbClr val="F0FAF4"/>
-                    </a:solidFill>
-                  </a:tcPr>
-                </a:tc>
-                <a:tc>
-                  <a:txBody>
-                    <a:bodyPr/>
-                    <a:lstStyle/>
-                    <a:p>
-                      <a:r>
-                        <a:rPr sz="1100" b="1">
-                          <a:solidFill>
-                            <a:srgbClr val="1C1C1C"/>
-                          </a:solidFill>
-                          <a:latin typeface="Arial"/>
-                        </a:rPr>
-                        <a:t>Keep over Passes (cluster)</a:t>
+                        <a:rPr sz="1000" b="1">
+                          <a:solidFill>
+                            <a:srgbClr val="1C1C1C"/>
+                          </a:solidFill>
+                          <a:latin typeface="Arial"/>
+                        </a:rPr>
+                        <a:t>0.891</a:t>
+                      </a:r>
+                    </a:p>
+                  </a:txBody>
+                  <a:tcPr>
+                    <a:solidFill>
+                      <a:srgbClr val="F0FAF4"/>
+                    </a:solidFill>
+                  </a:tcPr>
+                </a:tc>
+                <a:tc>
+                  <a:txBody>
+                    <a:bodyPr/>
+                    <a:lstStyle/>
+                    <a:p>
+                      <a:r>
+                        <a:rPr sz="1000" b="0">
+                          <a:solidFill>
+                            <a:srgbClr val="1C1C1C"/>
+                          </a:solidFill>
+                          <a:latin typeface="Arial"/>
+                        </a:rPr>
+                        <a:t>117</a:t>
                       </a:r>
                     </a:p>
                   </a:txBody>
@@ -6394,58 +6495,58 @@
                   </a:tcPr>
                 </a:tc>
               </a:tr>
-              <a:tr h="347472">
-                <a:tc>
-                  <a:txBody>
-                    <a:bodyPr/>
-                    <a:lstStyle/>
-                    <a:p>
-                      <a:r>
-                        <a:rPr sz="1100" b="0">
-                          <a:solidFill>
-                            <a:srgbClr val="1C1C1C"/>
-                          </a:solidFill>
-                          <a:latin typeface="Arial"/>
-                        </a:rPr>
-                        <a:t>Pass</a:t>
-                      </a:r>
-                    </a:p>
-                  </a:txBody>
-                  <a:tcPr>
-                    <a:solidFill>
-                      <a:srgbClr val="F2F2F2"/>
-                    </a:solidFill>
-                  </a:tcPr>
-                </a:tc>
-                <a:tc>
-                  <a:txBody>
-                    <a:bodyPr/>
-                    <a:lstStyle/>
-                    <a:p>
-                      <a:r>
-                        <a:rPr sz="1100" b="0">
-                          <a:solidFill>
-                            <a:srgbClr val="1C1C1C"/>
-                          </a:solidFill>
-                          <a:latin typeface="Arial"/>
-                        </a:rPr>
-                        <a:t>Passes (volume)</a:t>
-                      </a:r>
-                    </a:p>
-                  </a:txBody>
-                  <a:tcPr>
-                    <a:solidFill>
-                      <a:srgbClr val="F2F2F2"/>
-                    </a:solidFill>
-                  </a:tcPr>
-                </a:tc>
-                <a:tc>
-                  <a:txBody>
-                    <a:bodyPr/>
-                    <a:lstStyle/>
-                    <a:p>
-                      <a:r>
-                        <a:rPr sz="1100" b="0">
+              <a:tr h="274320">
+                <a:tc>
+                  <a:txBody>
+                    <a:bodyPr/>
+                    <a:lstStyle/>
+                    <a:p>
+                      <a:r>
+                        <a:rPr sz="1000" b="0">
+                          <a:solidFill>
+                            <a:srgbClr val="1C1C1C"/>
+                          </a:solidFill>
+                          <a:latin typeface="Arial"/>
+                        </a:rPr>
+                        <a:t>PRGDI</a:t>
+                      </a:r>
+                    </a:p>
+                  </a:txBody>
+                  <a:tcPr>
+                    <a:solidFill>
+                      <a:srgbClr val="F0FAF4"/>
+                    </a:solidFill>
+                  </a:tcPr>
+                </a:tc>
+                <a:tc>
+                  <a:txBody>
+                    <a:bodyPr/>
+                    <a:lstStyle/>
+                    <a:p>
+                      <a:r>
+                        <a:rPr sz="1000" b="0">
+                          <a:solidFill>
+                            <a:srgbClr val="1C1C1C"/>
+                          </a:solidFill>
+                          <a:latin typeface="Arial"/>
+                        </a:rPr>
+                        <a:t>PrgDist Total</a:t>
+                      </a:r>
+                    </a:p>
+                  </a:txBody>
+                  <a:tcPr>
+                    <a:solidFill>
+                      <a:srgbClr val="F0FAF4"/>
+                    </a:solidFill>
+                  </a:tcPr>
+                </a:tc>
+                <a:tc>
+                  <a:txBody>
+                    <a:bodyPr/>
+                    <a:lstStyle/>
+                    <a:p>
+                      <a:r>
+                        <a:rPr sz="1000" b="0">
                           <a:solidFill>
                             <a:srgbClr val="1C1C1C"/>
                           </a:solidFill>
@@ -6457,157 +6558,157 @@
                   </a:txBody>
                   <a:tcPr>
                     <a:solidFill>
-                      <a:srgbClr val="F2F2F2"/>
-                    </a:solidFill>
-                  </a:tcPr>
-                </a:tc>
-                <a:tc>
-                  <a:txBody>
-                    <a:bodyPr/>
-                    <a:lstStyle/>
-                    <a:p>
-                      <a:r>
-                        <a:rPr sz="1100" b="0">
-                          <a:solidFill>
-                            <a:srgbClr val="1C1C1C"/>
-                          </a:solidFill>
-                          <a:latin typeface="Arial"/>
-                        </a:rPr>
-                        <a:t>Planned OUT</a:t>
-                      </a:r>
-                    </a:p>
-                  </a:txBody>
-                  <a:tcPr>
-                    <a:solidFill>
-                      <a:srgbClr val="F2F2F2"/>
-                    </a:solidFill>
-                  </a:tcPr>
-                </a:tc>
-                <a:tc>
-                  <a:txBody>
-                    <a:bodyPr/>
-                    <a:lstStyle/>
-                    <a:p>
-                      <a:r>
-                        <a:rPr sz="1100" b="0">
-                          <a:solidFill>
-                            <a:srgbClr val="1C1C1C"/>
-                          </a:solidFill>
-                          <a:latin typeface="Arial"/>
-                        </a:rPr>
-                        <a:t>Drop vs PrgP</a:t>
-                      </a:r>
-                    </a:p>
-                  </a:txBody>
-                  <a:tcPr>
-                    <a:solidFill>
-                      <a:srgbClr val="F2F2F2"/>
+                      <a:srgbClr val="F0FAF4"/>
+                    </a:solidFill>
+                  </a:tcPr>
+                </a:tc>
+                <a:tc>
+                  <a:txBody>
+                    <a:bodyPr/>
+                    <a:lstStyle/>
+                    <a:p>
+                      <a:r>
+                        <a:rPr sz="1000" b="1">
+                          <a:solidFill>
+                            <a:srgbClr val="1C1C1C"/>
+                          </a:solidFill>
+                          <a:latin typeface="Arial"/>
+                        </a:rPr>
+                        <a:t>0.865</a:t>
+                      </a:r>
+                    </a:p>
+                  </a:txBody>
+                  <a:tcPr>
+                    <a:solidFill>
+                      <a:srgbClr val="F0FAF4"/>
+                    </a:solidFill>
+                  </a:tcPr>
+                </a:tc>
+                <a:tc>
+                  <a:txBody>
+                    <a:bodyPr/>
+                    <a:lstStyle/>
+                    <a:p>
+                      <a:r>
+                        <a:rPr sz="1000" b="0">
+                          <a:solidFill>
+                            <a:srgbClr val="1C1C1C"/>
+                          </a:solidFill>
+                          <a:latin typeface="Arial"/>
+                        </a:rPr>
+                        <a:t>117</a:t>
+                      </a:r>
+                    </a:p>
+                  </a:txBody>
+                  <a:tcPr>
+                    <a:solidFill>
+                      <a:srgbClr val="F0FAF4"/>
                     </a:solidFill>
                   </a:tcPr>
                 </a:tc>
               </a:tr>
-              <a:tr h="347472">
-                <a:tc>
-                  <a:txBody>
-                    <a:bodyPr/>
-                    <a:lstStyle/>
-                    <a:p>
-                      <a:r>
-                        <a:rPr sz="1100" b="1">
-                          <a:solidFill>
-                            <a:srgbClr val="1C1C1C"/>
-                          </a:solidFill>
-                          <a:latin typeface="Arial"/>
-                        </a:rPr>
-                        <a:t>Carr</a:t>
-                      </a:r>
-                    </a:p>
-                  </a:txBody>
-                  <a:tcPr>
-                    <a:solidFill>
-                      <a:srgbClr val="F0FAF4"/>
-                    </a:solidFill>
-                  </a:tcPr>
-                </a:tc>
-                <a:tc>
-                  <a:txBody>
-                    <a:bodyPr/>
-                    <a:lstStyle/>
-                    <a:p>
-                      <a:r>
-                        <a:rPr sz="1100" b="1">
-                          <a:solidFill>
-                            <a:srgbClr val="1C1C1C"/>
-                          </a:solidFill>
-                          <a:latin typeface="Arial"/>
-                        </a:rPr>
-                        <a:t>Carries</a:t>
-                      </a:r>
-                    </a:p>
-                  </a:txBody>
-                  <a:tcPr>
-                    <a:solidFill>
-                      <a:srgbClr val="F0FAF4"/>
-                    </a:solidFill>
-                  </a:tcPr>
-                </a:tc>
-                <a:tc>
-                  <a:txBody>
-                    <a:bodyPr/>
-                    <a:lstStyle/>
-                    <a:p>
-                      <a:r>
-                        <a:rPr sz="1100" b="1">
-                          <a:solidFill>
-                            <a:srgbClr val="1C1C1C"/>
-                          </a:solidFill>
-                          <a:latin typeface="Arial"/>
-                        </a:rPr>
-                        <a:t>Carrying</a:t>
-                      </a:r>
-                    </a:p>
-                  </a:txBody>
-                  <a:tcPr>
-                    <a:solidFill>
-                      <a:srgbClr val="F0FAF4"/>
-                    </a:solidFill>
-                  </a:tcPr>
-                </a:tc>
-                <a:tc>
-                  <a:txBody>
-                    <a:bodyPr/>
-                    <a:lstStyle/>
-                    <a:p>
-                      <a:r>
-                        <a:rPr sz="1100" b="1">
-                          <a:solidFill>
-                            <a:srgbClr val="1C1C1C"/>
-                          </a:solidFill>
-                          <a:latin typeface="Arial"/>
-                        </a:rPr>
-                        <a:t>Planned PASS</a:t>
-                      </a:r>
-                    </a:p>
-                  </a:txBody>
-                  <a:tcPr>
-                    <a:solidFill>
-                      <a:srgbClr val="F0FAF4"/>
-                    </a:solidFill>
-                  </a:tcPr>
-                </a:tc>
-                <a:tc>
-                  <a:txBody>
-                    <a:bodyPr/>
-                    <a:lstStyle/>
-                    <a:p>
-                      <a:r>
-                        <a:rPr sz="1100" b="1">
-                          <a:solidFill>
-                            <a:srgbClr val="1C1C1C"/>
-                          </a:solidFill>
-                          <a:latin typeface="Arial"/>
-                        </a:rPr>
-                        <a:t>Keep over PrgC (cluster)</a:t>
+              <a:tr h="274320">
+                <a:tc>
+                  <a:txBody>
+                    <a:bodyPr/>
+                    <a:lstStyle/>
+                    <a:p>
+                      <a:r>
+                        <a:rPr sz="1000" b="0">
+                          <a:solidFill>
+                            <a:srgbClr val="1C1C1C"/>
+                          </a:solidFill>
+                          <a:latin typeface="Arial"/>
+                        </a:rPr>
+                        <a:t>ATTLO</a:t>
+                      </a:r>
+                    </a:p>
+                  </a:txBody>
+                  <a:tcPr>
+                    <a:solidFill>
+                      <a:srgbClr val="F0FAF4"/>
+                    </a:solidFill>
+                  </a:tcPr>
+                </a:tc>
+                <a:tc>
+                  <a:txBody>
+                    <a:bodyPr/>
+                    <a:lstStyle/>
+                    <a:p>
+                      <a:r>
+                        <a:rPr sz="1000" b="0">
+                          <a:solidFill>
+                            <a:srgbClr val="1C1C1C"/>
+                          </a:solidFill>
+                          <a:latin typeface="Arial"/>
+                        </a:rPr>
+                        <a:t>Att Long</a:t>
+                      </a:r>
+                    </a:p>
+                  </a:txBody>
+                  <a:tcPr>
+                    <a:solidFill>
+                      <a:srgbClr val="F0FAF4"/>
+                    </a:solidFill>
+                  </a:tcPr>
+                </a:tc>
+                <a:tc>
+                  <a:txBody>
+                    <a:bodyPr/>
+                    <a:lstStyle/>
+                    <a:p>
+                      <a:r>
+                        <a:rPr sz="1000" b="0">
+                          <a:solidFill>
+                            <a:srgbClr val="1C1C1C"/>
+                          </a:solidFill>
+                          <a:latin typeface="Arial"/>
+                        </a:rPr>
+                        <a:t>Other</a:t>
+                      </a:r>
+                    </a:p>
+                  </a:txBody>
+                  <a:tcPr>
+                    <a:solidFill>
+                      <a:srgbClr val="F0FAF4"/>
+                    </a:solidFill>
+                  </a:tcPr>
+                </a:tc>
+                <a:tc>
+                  <a:txBody>
+                    <a:bodyPr/>
+                    <a:lstStyle/>
+                    <a:p>
+                      <a:r>
+                        <a:rPr sz="1000" b="1">
+                          <a:solidFill>
+                            <a:srgbClr val="1C1C1C"/>
+                          </a:solidFill>
+                          <a:latin typeface="Arial"/>
+                        </a:rPr>
+                        <a:t>0.851</a:t>
+                      </a:r>
+                    </a:p>
+                  </a:txBody>
+                  <a:tcPr>
+                    <a:solidFill>
+                      <a:srgbClr val="F0FAF4"/>
+                    </a:solidFill>
+                  </a:tcPr>
+                </a:tc>
+                <a:tc>
+                  <a:txBody>
+                    <a:bodyPr/>
+                    <a:lstStyle/>
+                    <a:p>
+                      <a:r>
+                        <a:rPr sz="1000" b="0">
+                          <a:solidFill>
+                            <a:srgbClr val="1C1C1C"/>
+                          </a:solidFill>
+                          <a:latin typeface="Arial"/>
+                        </a:rPr>
+                        <a:t>117</a:t>
                       </a:r>
                     </a:p>
                   </a:txBody>
@@ -6618,170 +6719,282 @@
                   </a:tcPr>
                 </a:tc>
               </a:tr>
-              <a:tr h="347472">
-                <a:tc>
-                  <a:txBody>
-                    <a:bodyPr/>
-                    <a:lstStyle/>
-                    <a:p>
-                      <a:r>
-                        <a:rPr sz="1100" b="0">
-                          <a:solidFill>
-                            <a:srgbClr val="1C1C1C"/>
-                          </a:solidFill>
-                          <a:latin typeface="Arial"/>
-                        </a:rPr>
-                        <a:t>PrgC</a:t>
-                      </a:r>
-                    </a:p>
-                  </a:txBody>
-                  <a:tcPr>
-                    <a:solidFill>
-                      <a:srgbClr val="F2F2F2"/>
-                    </a:solidFill>
-                  </a:tcPr>
-                </a:tc>
-                <a:tc>
-                  <a:txBody>
-                    <a:bodyPr/>
-                    <a:lstStyle/>
-                    <a:p>
-                      <a:r>
-                        <a:rPr sz="1100" b="0">
-                          <a:solidFill>
-                            <a:srgbClr val="1C1C1C"/>
-                          </a:solidFill>
-                          <a:latin typeface="Arial"/>
-                        </a:rPr>
-                        <a:t>Progressive carries</a:t>
-                      </a:r>
-                    </a:p>
-                  </a:txBody>
-                  <a:tcPr>
-                    <a:solidFill>
-                      <a:srgbClr val="F2F2F2"/>
-                    </a:solidFill>
-                  </a:tcPr>
-                </a:tc>
-                <a:tc>
-                  <a:txBody>
-                    <a:bodyPr/>
-                    <a:lstStyle/>
-                    <a:p>
-                      <a:r>
-                        <a:rPr sz="1100" b="0">
-                          <a:solidFill>
-                            <a:srgbClr val="1C1C1C"/>
-                          </a:solidFill>
-                          <a:latin typeface="Arial"/>
-                        </a:rPr>
-                        <a:t>Carrying</a:t>
-                      </a:r>
-                    </a:p>
-                  </a:txBody>
-                  <a:tcPr>
-                    <a:solidFill>
-                      <a:srgbClr val="F2F2F2"/>
-                    </a:solidFill>
-                  </a:tcPr>
-                </a:tc>
-                <a:tc>
-                  <a:txBody>
-                    <a:bodyPr/>
-                    <a:lstStyle/>
-                    <a:p>
-                      <a:r>
-                        <a:rPr sz="1100" b="0">
-                          <a:solidFill>
-                            <a:srgbClr val="1C1C1C"/>
-                          </a:solidFill>
-                          <a:latin typeface="Arial"/>
-                        </a:rPr>
-                        <a:t>Planned OUT</a:t>
-                      </a:r>
-                    </a:p>
-                  </a:txBody>
-                  <a:tcPr>
-                    <a:solidFill>
-                      <a:srgbClr val="F2F2F2"/>
-                    </a:solidFill>
-                  </a:tcPr>
-                </a:tc>
-                <a:tc>
-                  <a:txBody>
-                    <a:bodyPr/>
-                    <a:lstStyle/>
-                    <a:p>
-                      <a:r>
-                        <a:rPr sz="1100" b="0">
-                          <a:solidFill>
-                            <a:srgbClr val="1C1C1C"/>
-                          </a:solidFill>
-                          <a:latin typeface="Arial"/>
-                        </a:rPr>
-                        <a:t>Drop vs Carries</a:t>
-                      </a:r>
-                    </a:p>
-                  </a:txBody>
-                  <a:tcPr>
-                    <a:solidFill>
-                      <a:srgbClr val="F2F2F2"/>
+              <a:tr h="274320">
+                <a:tc>
+                  <a:txBody>
+                    <a:bodyPr/>
+                    <a:lstStyle/>
+                    <a:p>
+                      <a:r>
+                        <a:rPr sz="1000" b="0">
+                          <a:solidFill>
+                            <a:srgbClr val="1C1C1C"/>
+                          </a:solidFill>
+                          <a:latin typeface="Arial"/>
+                        </a:rPr>
+                        <a:t>XG</a:t>
+                      </a:r>
+                    </a:p>
+                  </a:txBody>
+                  <a:tcPr>
+                    <a:solidFill>
+                      <a:srgbClr val="F0FAF4"/>
+                    </a:solidFill>
+                  </a:tcPr>
+                </a:tc>
+                <a:tc>
+                  <a:txBody>
+                    <a:bodyPr/>
+                    <a:lstStyle/>
+                    <a:p>
+                      <a:r>
+                        <a:rPr sz="1000" b="0">
+                          <a:solidFill>
+                            <a:srgbClr val="1C1C1C"/>
+                          </a:solidFill>
+                          <a:latin typeface="Arial"/>
+                        </a:rPr>
+                        <a:t>xG Per</a:t>
+                      </a:r>
+                    </a:p>
+                  </a:txBody>
+                  <a:tcPr>
+                    <a:solidFill>
+                      <a:srgbClr val="F0FAF4"/>
+                    </a:solidFill>
+                  </a:tcPr>
+                </a:tc>
+                <a:tc>
+                  <a:txBody>
+                    <a:bodyPr/>
+                    <a:lstStyle/>
+                    <a:p>
+                      <a:r>
+                        <a:rPr sz="1000" b="0">
+                          <a:solidFill>
+                            <a:srgbClr val="1C1C1C"/>
+                          </a:solidFill>
+                          <a:latin typeface="Arial"/>
+                        </a:rPr>
+                        <a:t>Attacking</a:t>
+                      </a:r>
+                    </a:p>
+                  </a:txBody>
+                  <a:tcPr>
+                    <a:solidFill>
+                      <a:srgbClr val="F0FAF4"/>
+                    </a:solidFill>
+                  </a:tcPr>
+                </a:tc>
+                <a:tc>
+                  <a:txBody>
+                    <a:bodyPr/>
+                    <a:lstStyle/>
+                    <a:p>
+                      <a:r>
+                        <a:rPr sz="1000" b="1">
+                          <a:solidFill>
+                            <a:srgbClr val="1C1C1C"/>
+                          </a:solidFill>
+                          <a:latin typeface="Arial"/>
+                        </a:rPr>
+                        <a:t>0.849</a:t>
+                      </a:r>
+                    </a:p>
+                  </a:txBody>
+                  <a:tcPr>
+                    <a:solidFill>
+                      <a:srgbClr val="F0FAF4"/>
+                    </a:solidFill>
+                  </a:tcPr>
+                </a:tc>
+                <a:tc>
+                  <a:txBody>
+                    <a:bodyPr/>
+                    <a:lstStyle/>
+                    <a:p>
+                      <a:r>
+                        <a:rPr sz="1000" b="0">
+                          <a:solidFill>
+                            <a:srgbClr val="1C1C1C"/>
+                          </a:solidFill>
+                          <a:latin typeface="Arial"/>
+                        </a:rPr>
+                        <a:t>117</a:t>
+                      </a:r>
+                    </a:p>
+                  </a:txBody>
+                  <a:tcPr>
+                    <a:solidFill>
+                      <a:srgbClr val="F0FAF4"/>
                     </a:solidFill>
                   </a:tcPr>
                 </a:tc>
               </a:tr>
-              <a:tr h="347472">
-                <a:tc>
-                  <a:txBody>
-                    <a:bodyPr/>
-                    <a:lstStyle/>
-                    <a:p>
-                      <a:r>
-                        <a:rPr sz="1100" b="1">
-                          <a:solidFill>
-                            <a:srgbClr val="1C1C1C"/>
-                          </a:solidFill>
-                          <a:latin typeface="Arial"/>
-                        </a:rPr>
-                        <a:t>npxG</a:t>
-                      </a:r>
-                    </a:p>
-                  </a:txBody>
-                  <a:tcPr>
-                    <a:solidFill>
-                      <a:srgbClr val="F0FAF4"/>
-                    </a:solidFill>
-                  </a:tcPr>
-                </a:tc>
-                <a:tc>
-                  <a:txBody>
-                    <a:bodyPr/>
-                    <a:lstStyle/>
-                    <a:p>
-                      <a:r>
-                        <a:rPr sz="1100" b="1">
-                          <a:solidFill>
-                            <a:srgbClr val="1C1C1C"/>
-                          </a:solidFill>
-                          <a:latin typeface="Arial"/>
-                        </a:rPr>
-                        <a:t>Non-pen xG</a:t>
-                      </a:r>
-                    </a:p>
-                  </a:txBody>
-                  <a:tcPr>
-                    <a:solidFill>
-                      <a:srgbClr val="F0FAF4"/>
-                    </a:solidFill>
-                  </a:tcPr>
-                </a:tc>
-                <a:tc>
-                  <a:txBody>
-                    <a:bodyPr/>
-                    <a:lstStyle/>
-                    <a:p>
-                      <a:r>
-                        <a:rPr sz="1100" b="1">
+              <a:tr h="274320">
+                <a:tc>
+                  <a:txBody>
+                    <a:bodyPr/>
+                    <a:lstStyle/>
+                    <a:p>
+                      <a:r>
+                        <a:rPr sz="1000" b="0">
+                          <a:solidFill>
+                            <a:srgbClr val="1C1C1C"/>
+                          </a:solidFill>
+                          <a:latin typeface="Arial"/>
+                        </a:rPr>
+                        <a:t>PRGR</a:t>
+                      </a:r>
+                    </a:p>
+                  </a:txBody>
+                  <a:tcPr>
+                    <a:solidFill>
+                      <a:srgbClr val="F0FAF4"/>
+                    </a:solidFill>
+                  </a:tcPr>
+                </a:tc>
+                <a:tc>
+                  <a:txBody>
+                    <a:bodyPr/>
+                    <a:lstStyle/>
+                    <a:p>
+                      <a:r>
+                        <a:rPr sz="1000" b="0">
+                          <a:solidFill>
+                            <a:srgbClr val="1C1C1C"/>
+                          </a:solidFill>
+                          <a:latin typeface="Arial"/>
+                        </a:rPr>
+                        <a:t>PrgR Progression</a:t>
+                      </a:r>
+                    </a:p>
+                  </a:txBody>
+                  <a:tcPr>
+                    <a:solidFill>
+                      <a:srgbClr val="F0FAF4"/>
+                    </a:solidFill>
+                  </a:tcPr>
+                </a:tc>
+                <a:tc>
+                  <a:txBody>
+                    <a:bodyPr/>
+                    <a:lstStyle/>
+                    <a:p>
+                      <a:r>
+                        <a:rPr sz="1000" b="0">
+                          <a:solidFill>
+                            <a:srgbClr val="1C1C1C"/>
+                          </a:solidFill>
+                          <a:latin typeface="Arial"/>
+                        </a:rPr>
+                        <a:t>Passing</a:t>
+                      </a:r>
+                    </a:p>
+                  </a:txBody>
+                  <a:tcPr>
+                    <a:solidFill>
+                      <a:srgbClr val="F0FAF4"/>
+                    </a:solidFill>
+                  </a:tcPr>
+                </a:tc>
+                <a:tc>
+                  <a:txBody>
+                    <a:bodyPr/>
+                    <a:lstStyle/>
+                    <a:p>
+                      <a:r>
+                        <a:rPr sz="1000" b="1">
+                          <a:solidFill>
+                            <a:srgbClr val="1C1C1C"/>
+                          </a:solidFill>
+                          <a:latin typeface="Arial"/>
+                        </a:rPr>
+                        <a:t>0.843</a:t>
+                      </a:r>
+                    </a:p>
+                  </a:txBody>
+                  <a:tcPr>
+                    <a:solidFill>
+                      <a:srgbClr val="F0FAF4"/>
+                    </a:solidFill>
+                  </a:tcPr>
+                </a:tc>
+                <a:tc>
+                  <a:txBody>
+                    <a:bodyPr/>
+                    <a:lstStyle/>
+                    <a:p>
+                      <a:r>
+                        <a:rPr sz="1000" b="0">
+                          <a:solidFill>
+                            <a:srgbClr val="1C1C1C"/>
+                          </a:solidFill>
+                          <a:latin typeface="Arial"/>
+                        </a:rPr>
+                        <a:t>117</a:t>
+                      </a:r>
+                    </a:p>
+                  </a:txBody>
+                  <a:tcPr>
+                    <a:solidFill>
+                      <a:srgbClr val="F0FAF4"/>
+                    </a:solidFill>
+                  </a:tcPr>
+                </a:tc>
+              </a:tr>
+              <a:tr h="274320">
+                <a:tc>
+                  <a:txBody>
+                    <a:bodyPr/>
+                    <a:lstStyle/>
+                    <a:p>
+                      <a:r>
+                        <a:rPr sz="1000" b="0">
+                          <a:solidFill>
+                            <a:srgbClr val="1C1C1C"/>
+                          </a:solidFill>
+                          <a:latin typeface="Arial"/>
+                        </a:rPr>
+                        <a:t>SHPER</a:t>
+                      </a:r>
+                    </a:p>
+                  </a:txBody>
+                  <a:tcPr>
+                    <a:solidFill>
+                      <a:srgbClr val="F0FAF4"/>
+                    </a:solidFill>
+                  </a:tcPr>
+                </a:tc>
+                <a:tc>
+                  <a:txBody>
+                    <a:bodyPr/>
+                    <a:lstStyle/>
+                    <a:p>
+                      <a:r>
+                        <a:rPr sz="1000" b="0">
+                          <a:solidFill>
+                            <a:srgbClr val="1C1C1C"/>
+                          </a:solidFill>
+                          <a:latin typeface="Arial"/>
+                        </a:rPr>
+                        <a:t>Sh/90 Standard</a:t>
+                      </a:r>
+                    </a:p>
+                  </a:txBody>
+                  <a:tcPr>
+                    <a:solidFill>
+                      <a:srgbClr val="F0FAF4"/>
+                    </a:solidFill>
+                  </a:tcPr>
+                </a:tc>
+                <a:tc>
+                  <a:txBody>
+                    <a:bodyPr/>
+                    <a:lstStyle/>
+                    <a:p>
+                      <a:r>
+                        <a:rPr sz="1000" b="0">
                           <a:solidFill>
                             <a:srgbClr val="1C1C1C"/>
                           </a:solidFill>
@@ -6803,35 +7016,35 @@
                     <a:lstStyle/>
                     <a:p>
                       <a:r>
-                        <a:rPr sz="1100" b="1">
-                          <a:solidFill>
-                            <a:srgbClr val="1C1C1C"/>
-                          </a:solidFill>
-                          <a:latin typeface="Arial"/>
-                        </a:rPr>
-                        <a:t>Planned PASS</a:t>
-                      </a:r>
-                    </a:p>
-                  </a:txBody>
-                  <a:tcPr>
-                    <a:solidFill>
-                      <a:srgbClr val="F0FAF4"/>
-                    </a:solidFill>
-                  </a:tcPr>
-                </a:tc>
-                <a:tc>
-                  <a:txBody>
-                    <a:bodyPr/>
-                    <a:lstStyle/>
-                    <a:p>
-                      <a:r>
-                        <a:rPr sz="1100" b="1">
-                          <a:solidFill>
-                            <a:srgbClr val="1C1C1C"/>
-                          </a:solidFill>
-                          <a:latin typeface="Arial"/>
-                        </a:rPr>
-                        <a:t>Keep over Shots (cluster)</a:t>
+                        <a:rPr sz="1000" b="1">
+                          <a:solidFill>
+                            <a:srgbClr val="1C1C1C"/>
+                          </a:solidFill>
+                          <a:latin typeface="Arial"/>
+                        </a:rPr>
+                        <a:t>0.836</a:t>
+                      </a:r>
+                    </a:p>
+                  </a:txBody>
+                  <a:tcPr>
+                    <a:solidFill>
+                      <a:srgbClr val="F0FAF4"/>
+                    </a:solidFill>
+                  </a:tcPr>
+                </a:tc>
+                <a:tc>
+                  <a:txBody>
+                    <a:bodyPr/>
+                    <a:lstStyle/>
+                    <a:p>
+                      <a:r>
+                        <a:rPr sz="1000" b="0">
+                          <a:solidFill>
+                            <a:srgbClr val="1C1C1C"/>
+                          </a:solidFill>
+                          <a:latin typeface="Arial"/>
+                        </a:rPr>
+                        <a:t>117</a:t>
                       </a:r>
                     </a:p>
                   </a:txBody>
@@ -6842,58 +7055,170 @@
                   </a:tcPr>
                 </a:tc>
               </a:tr>
-              <a:tr h="347472">
-                <a:tc>
-                  <a:txBody>
-                    <a:bodyPr/>
-                    <a:lstStyle/>
-                    <a:p>
-                      <a:r>
-                        <a:rPr sz="1100" b="0">
-                          <a:solidFill>
-                            <a:srgbClr val="1C1C1C"/>
-                          </a:solidFill>
-                          <a:latin typeface="Arial"/>
-                        </a:rPr>
-                        <a:t>Sh</a:t>
-                      </a:r>
-                    </a:p>
-                  </a:txBody>
-                  <a:tcPr>
-                    <a:solidFill>
-                      <a:srgbClr val="F2F2F2"/>
-                    </a:solidFill>
-                  </a:tcPr>
-                </a:tc>
-                <a:tc>
-                  <a:txBody>
-                    <a:bodyPr/>
-                    <a:lstStyle/>
-                    <a:p>
-                      <a:r>
-                        <a:rPr sz="1100" b="0">
-                          <a:solidFill>
-                            <a:srgbClr val="1C1C1C"/>
-                          </a:solidFill>
-                          <a:latin typeface="Arial"/>
-                        </a:rPr>
-                        <a:t>Shots</a:t>
-                      </a:r>
-                    </a:p>
-                  </a:txBody>
-                  <a:tcPr>
-                    <a:solidFill>
-                      <a:srgbClr val="F2F2F2"/>
-                    </a:solidFill>
-                  </a:tcPr>
-                </a:tc>
-                <a:tc>
-                  <a:txBody>
-                    <a:bodyPr/>
-                    <a:lstStyle/>
-                    <a:p>
-                      <a:r>
-                        <a:rPr sz="1100" b="0">
+              <a:tr h="274320">
+                <a:tc>
+                  <a:txBody>
+                    <a:bodyPr/>
+                    <a:lstStyle/>
+                    <a:p>
+                      <a:r>
+                        <a:rPr sz="1000" b="0">
+                          <a:solidFill>
+                            <a:srgbClr val="1C1C1C"/>
+                          </a:solidFill>
+                          <a:latin typeface="Arial"/>
+                        </a:rPr>
+                        <a:t>XGPLU</a:t>
+                      </a:r>
+                    </a:p>
+                  </a:txBody>
+                  <a:tcPr>
+                    <a:solidFill>
+                      <a:srgbClr val="F0FAF4"/>
+                    </a:solidFill>
+                  </a:tcPr>
+                </a:tc>
+                <a:tc>
+                  <a:txBody>
+                    <a:bodyPr/>
+                    <a:lstStyle/>
+                    <a:p>
+                      <a:r>
+                        <a:rPr sz="1000" b="0">
+                          <a:solidFill>
+                            <a:srgbClr val="1C1C1C"/>
+                          </a:solidFill>
+                          <a:latin typeface="Arial"/>
+                        </a:rPr>
+                        <a:t>xG+xAG Per</a:t>
+                      </a:r>
+                    </a:p>
+                  </a:txBody>
+                  <a:tcPr>
+                    <a:solidFill>
+                      <a:srgbClr val="F0FAF4"/>
+                    </a:solidFill>
+                  </a:tcPr>
+                </a:tc>
+                <a:tc>
+                  <a:txBody>
+                    <a:bodyPr/>
+                    <a:lstStyle/>
+                    <a:p>
+                      <a:r>
+                        <a:rPr sz="1000" b="0">
+                          <a:solidFill>
+                            <a:srgbClr val="1C1C1C"/>
+                          </a:solidFill>
+                          <a:latin typeface="Arial"/>
+                        </a:rPr>
+                        <a:t>Passing</a:t>
+                      </a:r>
+                    </a:p>
+                  </a:txBody>
+                  <a:tcPr>
+                    <a:solidFill>
+                      <a:srgbClr val="F0FAF4"/>
+                    </a:solidFill>
+                  </a:tcPr>
+                </a:tc>
+                <a:tc>
+                  <a:txBody>
+                    <a:bodyPr/>
+                    <a:lstStyle/>
+                    <a:p>
+                      <a:r>
+                        <a:rPr sz="1000" b="1">
+                          <a:solidFill>
+                            <a:srgbClr val="1C1C1C"/>
+                          </a:solidFill>
+                          <a:latin typeface="Arial"/>
+                        </a:rPr>
+                        <a:t>0.833</a:t>
+                      </a:r>
+                    </a:p>
+                  </a:txBody>
+                  <a:tcPr>
+                    <a:solidFill>
+                      <a:srgbClr val="F0FAF4"/>
+                    </a:solidFill>
+                  </a:tcPr>
+                </a:tc>
+                <a:tc>
+                  <a:txBody>
+                    <a:bodyPr/>
+                    <a:lstStyle/>
+                    <a:p>
+                      <a:r>
+                        <a:rPr sz="1000" b="0">
+                          <a:solidFill>
+                            <a:srgbClr val="1C1C1C"/>
+                          </a:solidFill>
+                          <a:latin typeface="Arial"/>
+                        </a:rPr>
+                        <a:t>117</a:t>
+                      </a:r>
+                    </a:p>
+                  </a:txBody>
+                  <a:tcPr>
+                    <a:solidFill>
+                      <a:srgbClr val="F0FAF4"/>
+                    </a:solidFill>
+                  </a:tcPr>
+                </a:tc>
+              </a:tr>
+              <a:tr h="274320">
+                <a:tc>
+                  <a:txBody>
+                    <a:bodyPr/>
+                    <a:lstStyle/>
+                    <a:p>
+                      <a:r>
+                        <a:rPr sz="1000" b="0">
+                          <a:solidFill>
+                            <a:srgbClr val="1C1C1C"/>
+                          </a:solidFill>
+                          <a:latin typeface="Arial"/>
+                        </a:rPr>
+                        <a:t>NPXG</a:t>
+                      </a:r>
+                    </a:p>
+                  </a:txBody>
+                  <a:tcPr>
+                    <a:solidFill>
+                      <a:srgbClr val="F0FAF4"/>
+                    </a:solidFill>
+                  </a:tcPr>
+                </a:tc>
+                <a:tc>
+                  <a:txBody>
+                    <a:bodyPr/>
+                    <a:lstStyle/>
+                    <a:p>
+                      <a:r>
+                        <a:rPr sz="1000" b="0">
+                          <a:solidFill>
+                            <a:srgbClr val="1C1C1C"/>
+                          </a:solidFill>
+                          <a:latin typeface="Arial"/>
+                        </a:rPr>
+                        <a:t>npxG Per</a:t>
+                      </a:r>
+                    </a:p>
+                  </a:txBody>
+                  <a:tcPr>
+                    <a:solidFill>
+                      <a:srgbClr val="F0FAF4"/>
+                    </a:solidFill>
+                  </a:tcPr>
+                </a:tc>
+                <a:tc>
+                  <a:txBody>
+                    <a:bodyPr/>
+                    <a:lstStyle/>
+                    <a:p>
+                      <a:r>
+                        <a:rPr sz="1000" b="0">
                           <a:solidFill>
                             <a:srgbClr val="1C1C1C"/>
                           </a:solidFill>
@@ -6905,107 +7230,555 @@
                   </a:txBody>
                   <a:tcPr>
                     <a:solidFill>
-                      <a:srgbClr val="F2F2F2"/>
-                    </a:solidFill>
-                  </a:tcPr>
-                </a:tc>
-                <a:tc>
-                  <a:txBody>
-                    <a:bodyPr/>
-                    <a:lstStyle/>
-                    <a:p>
-                      <a:r>
-                        <a:rPr sz="1100" b="0">
-                          <a:solidFill>
-                            <a:srgbClr val="1C1C1C"/>
-                          </a:solidFill>
-                          <a:latin typeface="Arial"/>
-                        </a:rPr>
-                        <a:t>Planned OUT</a:t>
-                      </a:r>
-                    </a:p>
-                  </a:txBody>
-                  <a:tcPr>
-                    <a:solidFill>
-                      <a:srgbClr val="F2F2F2"/>
-                    </a:solidFill>
-                  </a:tcPr>
-                </a:tc>
-                <a:tc>
-                  <a:txBody>
-                    <a:bodyPr/>
-                    <a:lstStyle/>
-                    <a:p>
-                      <a:r>
-                        <a:rPr sz="1100" b="0">
-                          <a:solidFill>
-                            <a:srgbClr val="1C1C1C"/>
-                          </a:solidFill>
-                          <a:latin typeface="Arial"/>
-                        </a:rPr>
-                        <a:t>Drop vs npxG</a:t>
-                      </a:r>
-                    </a:p>
-                  </a:txBody>
-                  <a:tcPr>
-                    <a:solidFill>
-                      <a:srgbClr val="F2F2F2"/>
+                      <a:srgbClr val="F0FAF4"/>
+                    </a:solidFill>
+                  </a:tcPr>
+                </a:tc>
+                <a:tc>
+                  <a:txBody>
+                    <a:bodyPr/>
+                    <a:lstStyle/>
+                    <a:p>
+                      <a:r>
+                        <a:rPr sz="1000" b="1">
+                          <a:solidFill>
+                            <a:srgbClr val="1C1C1C"/>
+                          </a:solidFill>
+                          <a:latin typeface="Arial"/>
+                        </a:rPr>
+                        <a:t>0.831</a:t>
+                      </a:r>
+                    </a:p>
+                  </a:txBody>
+                  <a:tcPr>
+                    <a:solidFill>
+                      <a:srgbClr val="F0FAF4"/>
+                    </a:solidFill>
+                  </a:tcPr>
+                </a:tc>
+                <a:tc>
+                  <a:txBody>
+                    <a:bodyPr/>
+                    <a:lstStyle/>
+                    <a:p>
+                      <a:r>
+                        <a:rPr sz="1000" b="0">
+                          <a:solidFill>
+                            <a:srgbClr val="1C1C1C"/>
+                          </a:solidFill>
+                          <a:latin typeface="Arial"/>
+                        </a:rPr>
+                        <a:t>117</a:t>
+                      </a:r>
+                    </a:p>
+                  </a:txBody>
+                  <a:tcPr>
+                    <a:solidFill>
+                      <a:srgbClr val="F0FAF4"/>
                     </a:solidFill>
                   </a:tcPr>
                 </a:tc>
               </a:tr>
-              <a:tr h="347472">
-                <a:tc>
-                  <a:txBody>
-                    <a:bodyPr/>
-                    <a:lstStyle/>
-                    <a:p>
-                      <a:r>
-                        <a:rPr sz="1100" b="1">
-                          <a:solidFill>
-                            <a:srgbClr val="1C1C1C"/>
-                          </a:solidFill>
-                          <a:latin typeface="Arial"/>
-                        </a:rPr>
-                        <a:t>SCA</a:t>
-                      </a:r>
-                    </a:p>
-                  </a:txBody>
-                  <a:tcPr>
-                    <a:solidFill>
-                      <a:srgbClr val="F0FAF4"/>
-                    </a:solidFill>
-                  </a:tcPr>
-                </a:tc>
-                <a:tc>
-                  <a:txBody>
-                    <a:bodyPr/>
-                    <a:lstStyle/>
-                    <a:p>
-                      <a:r>
-                        <a:rPr sz="1100" b="1">
-                          <a:solidFill>
-                            <a:srgbClr val="1C1C1C"/>
-                          </a:solidFill>
-                          <a:latin typeface="Arial"/>
-                        </a:rPr>
-                        <a:t>Shot-creating actions</a:t>
-                      </a:r>
-                    </a:p>
-                  </a:txBody>
-                  <a:tcPr>
-                    <a:solidFill>
-                      <a:srgbClr val="F0FAF4"/>
-                    </a:solidFill>
-                  </a:tcPr>
-                </a:tc>
-                <a:tc>
-                  <a:txBody>
-                    <a:bodyPr/>
-                    <a:lstStyle/>
-                    <a:p>
-                      <a:r>
-                        <a:rPr sz="1100" b="1">
+              <a:tr h="274320">
+                <a:tc>
+                  <a:txBody>
+                    <a:bodyPr/>
+                    <a:lstStyle/>
+                    <a:p>
+                      <a:r>
+                        <a:rPr sz="1000" b="0">
+                          <a:solidFill>
+                            <a:srgbClr val="1C1C1C"/>
+                          </a:solidFill>
+                          <a:latin typeface="Arial"/>
+                        </a:rPr>
+                        <a:t>NPXGP</a:t>
+                      </a:r>
+                    </a:p>
+                  </a:txBody>
+                  <a:tcPr>
+                    <a:solidFill>
+                      <a:srgbClr val="F0FAF4"/>
+                    </a:solidFill>
+                  </a:tcPr>
+                </a:tc>
+                <a:tc>
+                  <a:txBody>
+                    <a:bodyPr/>
+                    <a:lstStyle/>
+                    <a:p>
+                      <a:r>
+                        <a:rPr sz="1000" b="0">
+                          <a:solidFill>
+                            <a:srgbClr val="1C1C1C"/>
+                          </a:solidFill>
+                          <a:latin typeface="Arial"/>
+                        </a:rPr>
+                        <a:t>npxG+xAG Per</a:t>
+                      </a:r>
+                    </a:p>
+                  </a:txBody>
+                  <a:tcPr>
+                    <a:solidFill>
+                      <a:srgbClr val="F0FAF4"/>
+                    </a:solidFill>
+                  </a:tcPr>
+                </a:tc>
+                <a:tc>
+                  <a:txBody>
+                    <a:bodyPr/>
+                    <a:lstStyle/>
+                    <a:p>
+                      <a:r>
+                        <a:rPr sz="1000" b="0">
+                          <a:solidFill>
+                            <a:srgbClr val="1C1C1C"/>
+                          </a:solidFill>
+                          <a:latin typeface="Arial"/>
+                        </a:rPr>
+                        <a:t>Passing</a:t>
+                      </a:r>
+                    </a:p>
+                  </a:txBody>
+                  <a:tcPr>
+                    <a:solidFill>
+                      <a:srgbClr val="F0FAF4"/>
+                    </a:solidFill>
+                  </a:tcPr>
+                </a:tc>
+                <a:tc>
+                  <a:txBody>
+                    <a:bodyPr/>
+                    <a:lstStyle/>
+                    <a:p>
+                      <a:r>
+                        <a:rPr sz="1000" b="1">
+                          <a:solidFill>
+                            <a:srgbClr val="1C1C1C"/>
+                          </a:solidFill>
+                          <a:latin typeface="Arial"/>
+                        </a:rPr>
+                        <a:t>0.821</a:t>
+                      </a:r>
+                    </a:p>
+                  </a:txBody>
+                  <a:tcPr>
+                    <a:solidFill>
+                      <a:srgbClr val="F0FAF4"/>
+                    </a:solidFill>
+                  </a:tcPr>
+                </a:tc>
+                <a:tc>
+                  <a:txBody>
+                    <a:bodyPr/>
+                    <a:lstStyle/>
+                    <a:p>
+                      <a:r>
+                        <a:rPr sz="1000" b="0">
+                          <a:solidFill>
+                            <a:srgbClr val="1C1C1C"/>
+                          </a:solidFill>
+                          <a:latin typeface="Arial"/>
+                        </a:rPr>
+                        <a:t>117</a:t>
+                      </a:r>
+                    </a:p>
+                  </a:txBody>
+                  <a:tcPr>
+                    <a:solidFill>
+                      <a:srgbClr val="F0FAF4"/>
+                    </a:solidFill>
+                  </a:tcPr>
+                </a:tc>
+              </a:tr>
+              <a:tr h="274320">
+                <a:tc>
+                  <a:txBody>
+                    <a:bodyPr/>
+                    <a:lstStyle/>
+                    <a:p>
+                      <a:r>
+                        <a:rPr sz="1000" b="0">
+                          <a:solidFill>
+                            <a:srgbClr val="1C1C1C"/>
+                          </a:solidFill>
+                          <a:latin typeface="Arial"/>
+                        </a:rPr>
+                        <a:t>CMPLO</a:t>
+                      </a:r>
+                    </a:p>
+                  </a:txBody>
+                  <a:tcPr>
+                    <a:solidFill>
+                      <a:srgbClr val="F0FAF4"/>
+                    </a:solidFill>
+                  </a:tcPr>
+                </a:tc>
+                <a:tc>
+                  <a:txBody>
+                    <a:bodyPr/>
+                    <a:lstStyle/>
+                    <a:p>
+                      <a:r>
+                        <a:rPr sz="1000" b="0">
+                          <a:solidFill>
+                            <a:srgbClr val="1C1C1C"/>
+                          </a:solidFill>
+                          <a:latin typeface="Arial"/>
+                        </a:rPr>
+                        <a:t>Cmp Long</a:t>
+                      </a:r>
+                    </a:p>
+                  </a:txBody>
+                  <a:tcPr>
+                    <a:solidFill>
+                      <a:srgbClr val="F0FAF4"/>
+                    </a:solidFill>
+                  </a:tcPr>
+                </a:tc>
+                <a:tc>
+                  <a:txBody>
+                    <a:bodyPr/>
+                    <a:lstStyle/>
+                    <a:p>
+                      <a:r>
+                        <a:rPr sz="1000" b="0">
+                          <a:solidFill>
+                            <a:srgbClr val="1C1C1C"/>
+                          </a:solidFill>
+                          <a:latin typeface="Arial"/>
+                        </a:rPr>
+                        <a:t>Passing</a:t>
+                      </a:r>
+                    </a:p>
+                  </a:txBody>
+                  <a:tcPr>
+                    <a:solidFill>
+                      <a:srgbClr val="F0FAF4"/>
+                    </a:solidFill>
+                  </a:tcPr>
+                </a:tc>
+                <a:tc>
+                  <a:txBody>
+                    <a:bodyPr/>
+                    <a:lstStyle/>
+                    <a:p>
+                      <a:r>
+                        <a:rPr sz="1000" b="1">
+                          <a:solidFill>
+                            <a:srgbClr val="1C1C1C"/>
+                          </a:solidFill>
+                          <a:latin typeface="Arial"/>
+                        </a:rPr>
+                        <a:t>0.812</a:t>
+                      </a:r>
+                    </a:p>
+                  </a:txBody>
+                  <a:tcPr>
+                    <a:solidFill>
+                      <a:srgbClr val="F0FAF4"/>
+                    </a:solidFill>
+                  </a:tcPr>
+                </a:tc>
+                <a:tc>
+                  <a:txBody>
+                    <a:bodyPr/>
+                    <a:lstStyle/>
+                    <a:p>
+                      <a:r>
+                        <a:rPr sz="1000" b="0">
+                          <a:solidFill>
+                            <a:srgbClr val="1C1C1C"/>
+                          </a:solidFill>
+                          <a:latin typeface="Arial"/>
+                        </a:rPr>
+                        <a:t>117</a:t>
+                      </a:r>
+                    </a:p>
+                  </a:txBody>
+                  <a:tcPr>
+                    <a:solidFill>
+                      <a:srgbClr val="F0FAF4"/>
+                    </a:solidFill>
+                  </a:tcPr>
+                </a:tc>
+              </a:tr>
+              <a:tr h="274320">
+                <a:tc>
+                  <a:txBody>
+                    <a:bodyPr/>
+                    <a:lstStyle/>
+                    <a:p>
+                      <a:r>
+                        <a:rPr sz="1000" b="0">
+                          <a:solidFill>
+                            <a:srgbClr val="1C1C1C"/>
+                          </a:solidFill>
+                          <a:latin typeface="Arial"/>
+                        </a:rPr>
+                        <a:t>TOTDI</a:t>
+                      </a:r>
+                    </a:p>
+                  </a:txBody>
+                  <a:tcPr>
+                    <a:solidFill>
+                      <a:srgbClr val="F0FAF4"/>
+                    </a:solidFill>
+                  </a:tcPr>
+                </a:tc>
+                <a:tc>
+                  <a:txBody>
+                    <a:bodyPr/>
+                    <a:lstStyle/>
+                    <a:p>
+                      <a:r>
+                        <a:rPr sz="1000" b="0">
+                          <a:solidFill>
+                            <a:srgbClr val="1C1C1C"/>
+                          </a:solidFill>
+                          <a:latin typeface="Arial"/>
+                        </a:rPr>
+                        <a:t>TotDist Total</a:t>
+                      </a:r>
+                    </a:p>
+                  </a:txBody>
+                  <a:tcPr>
+                    <a:solidFill>
+                      <a:srgbClr val="F0FAF4"/>
+                    </a:solidFill>
+                  </a:tcPr>
+                </a:tc>
+                <a:tc>
+                  <a:txBody>
+                    <a:bodyPr/>
+                    <a:lstStyle/>
+                    <a:p>
+                      <a:r>
+                        <a:rPr sz="1000" b="0">
+                          <a:solidFill>
+                            <a:srgbClr val="1C1C1C"/>
+                          </a:solidFill>
+                          <a:latin typeface="Arial"/>
+                        </a:rPr>
+                        <a:t>Passing</a:t>
+                      </a:r>
+                    </a:p>
+                  </a:txBody>
+                  <a:tcPr>
+                    <a:solidFill>
+                      <a:srgbClr val="F0FAF4"/>
+                    </a:solidFill>
+                  </a:tcPr>
+                </a:tc>
+                <a:tc>
+                  <a:txBody>
+                    <a:bodyPr/>
+                    <a:lstStyle/>
+                    <a:p>
+                      <a:r>
+                        <a:rPr sz="1000" b="1">
+                          <a:solidFill>
+                            <a:srgbClr val="1C1C1C"/>
+                          </a:solidFill>
+                          <a:latin typeface="Arial"/>
+                        </a:rPr>
+                        <a:t>0.797</a:t>
+                      </a:r>
+                    </a:p>
+                  </a:txBody>
+                  <a:tcPr>
+                    <a:solidFill>
+                      <a:srgbClr val="F0FAF4"/>
+                    </a:solidFill>
+                  </a:tcPr>
+                </a:tc>
+                <a:tc>
+                  <a:txBody>
+                    <a:bodyPr/>
+                    <a:lstStyle/>
+                    <a:p>
+                      <a:r>
+                        <a:rPr sz="1000" b="0">
+                          <a:solidFill>
+                            <a:srgbClr val="1C1C1C"/>
+                          </a:solidFill>
+                          <a:latin typeface="Arial"/>
+                        </a:rPr>
+                        <a:t>117</a:t>
+                      </a:r>
+                    </a:p>
+                  </a:txBody>
+                  <a:tcPr>
+                    <a:solidFill>
+                      <a:srgbClr val="F0FAF4"/>
+                    </a:solidFill>
+                  </a:tcPr>
+                </a:tc>
+              </a:tr>
+              <a:tr h="274320">
+                <a:tc>
+                  <a:txBody>
+                    <a:bodyPr/>
+                    <a:lstStyle/>
+                    <a:p>
+                      <a:r>
+                        <a:rPr sz="1000" b="0">
+                          <a:solidFill>
+                            <a:srgbClr val="1C1C1C"/>
+                          </a:solidFill>
+                          <a:latin typeface="Arial"/>
+                        </a:rPr>
+                        <a:t>DEF3R</a:t>
+                      </a:r>
+                    </a:p>
+                  </a:txBody>
+                  <a:tcPr>
+                    <a:solidFill>
+                      <a:srgbClr val="F0FAF4"/>
+                    </a:solidFill>
+                  </a:tcPr>
+                </a:tc>
+                <a:tc>
+                  <a:txBody>
+                    <a:bodyPr/>
+                    <a:lstStyle/>
+                    <a:p>
+                      <a:r>
+                        <a:rPr sz="1000" b="0">
+                          <a:solidFill>
+                            <a:srgbClr val="1C1C1C"/>
+                          </a:solidFill>
+                          <a:latin typeface="Arial"/>
+                        </a:rPr>
+                        <a:t>Def 3rd Touches</a:t>
+                      </a:r>
+                    </a:p>
+                  </a:txBody>
+                  <a:tcPr>
+                    <a:solidFill>
+                      <a:srgbClr val="F0FAF4"/>
+                    </a:solidFill>
+                  </a:tcPr>
+                </a:tc>
+                <a:tc>
+                  <a:txBody>
+                    <a:bodyPr/>
+                    <a:lstStyle/>
+                    <a:p>
+                      <a:r>
+                        <a:rPr sz="1000" b="0">
+                          <a:solidFill>
+                            <a:srgbClr val="1C1C1C"/>
+                          </a:solidFill>
+                          <a:latin typeface="Arial"/>
+                        </a:rPr>
+                        <a:t>Defending</a:t>
+                      </a:r>
+                    </a:p>
+                  </a:txBody>
+                  <a:tcPr>
+                    <a:solidFill>
+                      <a:srgbClr val="F0FAF4"/>
+                    </a:solidFill>
+                  </a:tcPr>
+                </a:tc>
+                <a:tc>
+                  <a:txBody>
+                    <a:bodyPr/>
+                    <a:lstStyle/>
+                    <a:p>
+                      <a:r>
+                        <a:rPr sz="1000" b="1">
+                          <a:solidFill>
+                            <a:srgbClr val="1C1C1C"/>
+                          </a:solidFill>
+                          <a:latin typeface="Arial"/>
+                        </a:rPr>
+                        <a:t>0.795</a:t>
+                      </a:r>
+                    </a:p>
+                  </a:txBody>
+                  <a:tcPr>
+                    <a:solidFill>
+                      <a:srgbClr val="F0FAF4"/>
+                    </a:solidFill>
+                  </a:tcPr>
+                </a:tc>
+                <a:tc>
+                  <a:txBody>
+                    <a:bodyPr/>
+                    <a:lstStyle/>
+                    <a:p>
+                      <a:r>
+                        <a:rPr sz="1000" b="0">
+                          <a:solidFill>
+                            <a:srgbClr val="1C1C1C"/>
+                          </a:solidFill>
+                          <a:latin typeface="Arial"/>
+                        </a:rPr>
+                        <a:t>114</a:t>
+                      </a:r>
+                    </a:p>
+                  </a:txBody>
+                  <a:tcPr>
+                    <a:solidFill>
+                      <a:srgbClr val="F0FAF4"/>
+                    </a:solidFill>
+                  </a:tcPr>
+                </a:tc>
+              </a:tr>
+              <a:tr h="274320">
+                <a:tc>
+                  <a:txBody>
+                    <a:bodyPr/>
+                    <a:lstStyle/>
+                    <a:p>
+                      <a:r>
+                        <a:rPr sz="1000" b="0">
+                          <a:solidFill>
+                            <a:srgbClr val="1C1C1C"/>
+                          </a:solidFill>
+                          <a:latin typeface="Arial"/>
+                        </a:rPr>
+                        <a:t>SOTPE</a:t>
+                      </a:r>
+                    </a:p>
+                  </a:txBody>
+                  <a:tcPr>
+                    <a:solidFill>
+                      <a:srgbClr val="F0FAF4"/>
+                    </a:solidFill>
+                  </a:tcPr>
+                </a:tc>
+                <a:tc>
+                  <a:txBody>
+                    <a:bodyPr/>
+                    <a:lstStyle/>
+                    <a:p>
+                      <a:r>
+                        <a:rPr sz="1000" b="0">
+                          <a:solidFill>
+                            <a:srgbClr val="1C1C1C"/>
+                          </a:solidFill>
+                          <a:latin typeface="Arial"/>
+                        </a:rPr>
+                        <a:t>SoT/90 Standard</a:t>
+                      </a:r>
+                    </a:p>
+                  </a:txBody>
+                  <a:tcPr>
+                    <a:solidFill>
+                      <a:srgbClr val="F0FAF4"/>
+                    </a:solidFill>
+                  </a:tcPr>
+                </a:tc>
+                <a:tc>
+                  <a:txBody>
+                    <a:bodyPr/>
+                    <a:lstStyle/>
+                    <a:p>
+                      <a:r>
+                        <a:rPr sz="1000" b="0">
                           <a:solidFill>
                             <a:srgbClr val="1C1C1C"/>
                           </a:solidFill>
@@ -7027,35 +7800,35 @@
                     <a:lstStyle/>
                     <a:p>
                       <a:r>
-                        <a:rPr sz="1100" b="1">
-                          <a:solidFill>
-                            <a:srgbClr val="1C1C1C"/>
-                          </a:solidFill>
-                          <a:latin typeface="Arial"/>
-                        </a:rPr>
-                        <a:t>Planned PASS</a:t>
-                      </a:r>
-                    </a:p>
-                  </a:txBody>
-                  <a:tcPr>
-                    <a:solidFill>
-                      <a:srgbClr val="F0FAF4"/>
-                    </a:solidFill>
-                  </a:tcPr>
-                </a:tc>
-                <a:tc>
-                  <a:txBody>
-                    <a:bodyPr/>
-                    <a:lstStyle/>
-                    <a:p>
-                      <a:r>
-                        <a:rPr sz="1100" b="1">
-                          <a:solidFill>
-                            <a:srgbClr val="1C1C1C"/>
-                          </a:solidFill>
-                          <a:latin typeface="Arial"/>
-                        </a:rPr>
-                        <a:t>Singleton</a:t>
+                        <a:rPr sz="1000" b="1">
+                          <a:solidFill>
+                            <a:srgbClr val="1C1C1C"/>
+                          </a:solidFill>
+                          <a:latin typeface="Arial"/>
+                        </a:rPr>
+                        <a:t>0.790</a:t>
+                      </a:r>
+                    </a:p>
+                  </a:txBody>
+                  <a:tcPr>
+                    <a:solidFill>
+                      <a:srgbClr val="F0FAF4"/>
+                    </a:solidFill>
+                  </a:tcPr>
+                </a:tc>
+                <a:tc>
+                  <a:txBody>
+                    <a:bodyPr/>
+                    <a:lstStyle/>
+                    <a:p>
+                      <a:r>
+                        <a:rPr sz="1000" b="0">
+                          <a:solidFill>
+                            <a:srgbClr val="1C1C1C"/>
+                          </a:solidFill>
+                          <a:latin typeface="Arial"/>
+                        </a:rPr>
+                        <a:t>117</a:t>
                       </a:r>
                     </a:p>
                   </a:txBody>
@@ -7066,444 +7839,108 @@
                   </a:tcPr>
                 </a:tc>
               </a:tr>
-              <a:tr h="347472">
-                <a:tc>
-                  <a:txBody>
-                    <a:bodyPr/>
-                    <a:lstStyle/>
-                    <a:p>
-                      <a:r>
-                        <a:rPr sz="1100" b="1">
-                          <a:solidFill>
-                            <a:srgbClr val="1C1C1C"/>
-                          </a:solidFill>
-                          <a:latin typeface="Arial"/>
-                        </a:rPr>
-                        <a:t>Tkl</a:t>
-                      </a:r>
-                    </a:p>
-                  </a:txBody>
-                  <a:tcPr>
-                    <a:solidFill>
-                      <a:srgbClr val="F0FAF4"/>
-                    </a:solidFill>
-                  </a:tcPr>
-                </a:tc>
-                <a:tc>
-                  <a:txBody>
-                    <a:bodyPr/>
-                    <a:lstStyle/>
-                    <a:p>
-                      <a:r>
-                        <a:rPr sz="1100" b="1">
-                          <a:solidFill>
-                            <a:srgbClr val="1C1C1C"/>
-                          </a:solidFill>
-                          <a:latin typeface="Arial"/>
-                        </a:rPr>
-                        <a:t>Tackles</a:t>
-                      </a:r>
-                    </a:p>
-                  </a:txBody>
-                  <a:tcPr>
-                    <a:solidFill>
-                      <a:srgbClr val="F0FAF4"/>
-                    </a:solidFill>
-                  </a:tcPr>
-                </a:tc>
-                <a:tc>
-                  <a:txBody>
-                    <a:bodyPr/>
-                    <a:lstStyle/>
-                    <a:p>
-                      <a:r>
-                        <a:rPr sz="1100" b="1">
-                          <a:solidFill>
-                            <a:srgbClr val="1C1C1C"/>
-                          </a:solidFill>
-                          <a:latin typeface="Arial"/>
-                        </a:rPr>
-                        <a:t>Defending</a:t>
-                      </a:r>
-                    </a:p>
-                  </a:txBody>
-                  <a:tcPr>
-                    <a:solidFill>
-                      <a:srgbClr val="F0FAF4"/>
-                    </a:solidFill>
-                  </a:tcPr>
-                </a:tc>
-                <a:tc>
-                  <a:txBody>
-                    <a:bodyPr/>
-                    <a:lstStyle/>
-                    <a:p>
-                      <a:r>
-                        <a:rPr sz="1100" b="1">
-                          <a:solidFill>
-                            <a:srgbClr val="1C1C1C"/>
-                          </a:solidFill>
-                          <a:latin typeface="Arial"/>
-                        </a:rPr>
-                        <a:t>Planned PASS</a:t>
-                      </a:r>
-                    </a:p>
-                  </a:txBody>
-                  <a:tcPr>
-                    <a:solidFill>
-                      <a:srgbClr val="F0FAF4"/>
-                    </a:solidFill>
-                  </a:tcPr>
-                </a:tc>
-                <a:tc>
-                  <a:txBody>
-                    <a:bodyPr/>
-                    <a:lstStyle/>
-                    <a:p>
-                      <a:r>
-                        <a:rPr sz="1100" b="1">
-                          <a:solidFill>
-                            <a:srgbClr val="1C1C1C"/>
-                          </a:solidFill>
-                          <a:latin typeface="Arial"/>
-                        </a:rPr>
-                        <a:t>Singleton</a:t>
-                      </a:r>
-                    </a:p>
-                  </a:txBody>
-                  <a:tcPr>
-                    <a:solidFill>
-                      <a:srgbClr val="F0FAF4"/>
-                    </a:solidFill>
-                  </a:tcPr>
-                </a:tc>
-              </a:tr>
-              <a:tr h="347472">
-                <a:tc>
-                  <a:txBody>
-                    <a:bodyPr/>
-                    <a:lstStyle/>
-                    <a:p>
-                      <a:r>
-                        <a:rPr sz="1100" b="1">
-                          <a:solidFill>
-                            <a:srgbClr val="1C1C1C"/>
-                          </a:solidFill>
-                          <a:latin typeface="Arial"/>
-                        </a:rPr>
-                        <a:t>Int</a:t>
-                      </a:r>
-                    </a:p>
-                  </a:txBody>
-                  <a:tcPr>
-                    <a:solidFill>
-                      <a:srgbClr val="F0FAF4"/>
-                    </a:solidFill>
-                  </a:tcPr>
-                </a:tc>
-                <a:tc>
-                  <a:txBody>
-                    <a:bodyPr/>
-                    <a:lstStyle/>
-                    <a:p>
-                      <a:r>
-                        <a:rPr sz="1100" b="1">
-                          <a:solidFill>
-                            <a:srgbClr val="1C1C1C"/>
-                          </a:solidFill>
-                          <a:latin typeface="Arial"/>
-                        </a:rPr>
-                        <a:t>Interceptions</a:t>
-                      </a:r>
-                    </a:p>
-                  </a:txBody>
-                  <a:tcPr>
-                    <a:solidFill>
-                      <a:srgbClr val="F0FAF4"/>
-                    </a:solidFill>
-                  </a:tcPr>
-                </a:tc>
-                <a:tc>
-                  <a:txBody>
-                    <a:bodyPr/>
-                    <a:lstStyle/>
-                    <a:p>
-                      <a:r>
-                        <a:rPr sz="1100" b="1">
-                          <a:solidFill>
-                            <a:srgbClr val="1C1C1C"/>
-                          </a:solidFill>
-                          <a:latin typeface="Arial"/>
-                        </a:rPr>
-                        <a:t>Defending</a:t>
-                      </a:r>
-                    </a:p>
-                  </a:txBody>
-                  <a:tcPr>
-                    <a:solidFill>
-                      <a:srgbClr val="F0FAF4"/>
-                    </a:solidFill>
-                  </a:tcPr>
-                </a:tc>
-                <a:tc>
-                  <a:txBody>
-                    <a:bodyPr/>
-                    <a:lstStyle/>
-                    <a:p>
-                      <a:r>
-                        <a:rPr sz="1100" b="1">
-                          <a:solidFill>
-                            <a:srgbClr val="1C1C1C"/>
-                          </a:solidFill>
-                          <a:latin typeface="Arial"/>
-                        </a:rPr>
-                        <a:t>Planned PASS</a:t>
-                      </a:r>
-                    </a:p>
-                  </a:txBody>
-                  <a:tcPr>
-                    <a:solidFill>
-                      <a:srgbClr val="F0FAF4"/>
-                    </a:solidFill>
-                  </a:tcPr>
-                </a:tc>
-                <a:tc>
-                  <a:txBody>
-                    <a:bodyPr/>
-                    <a:lstStyle/>
-                    <a:p>
-                      <a:r>
-                        <a:rPr sz="1100" b="1">
-                          <a:solidFill>
-                            <a:srgbClr val="1C1C1C"/>
-                          </a:solidFill>
-                          <a:latin typeface="Arial"/>
-                        </a:rPr>
-                        <a:t>Singleton</a:t>
-                      </a:r>
-                    </a:p>
-                  </a:txBody>
-                  <a:tcPr>
-                    <a:solidFill>
-                      <a:srgbClr val="F0FAF4"/>
-                    </a:solidFill>
-                  </a:tcPr>
-                </a:tc>
-              </a:tr>
-              <a:tr h="347472">
-                <a:tc>
-                  <a:txBody>
-                    <a:bodyPr/>
-                    <a:lstStyle/>
-                    <a:p>
-                      <a:r>
-                        <a:rPr sz="1100" b="1">
-                          <a:solidFill>
-                            <a:srgbClr val="1C1C1C"/>
-                          </a:solidFill>
-                          <a:latin typeface="Arial"/>
-                        </a:rPr>
-                        <a:t>Aer</a:t>
-                      </a:r>
-                    </a:p>
-                  </a:txBody>
-                  <a:tcPr>
-                    <a:solidFill>
-                      <a:srgbClr val="F0FAF4"/>
-                    </a:solidFill>
-                  </a:tcPr>
-                </a:tc>
-                <a:tc>
-                  <a:txBody>
-                    <a:bodyPr/>
-                    <a:lstStyle/>
-                    <a:p>
-                      <a:r>
-                        <a:rPr sz="1100" b="1">
-                          <a:solidFill>
-                            <a:srgbClr val="1C1C1C"/>
-                          </a:solidFill>
-                          <a:latin typeface="Arial"/>
-                        </a:rPr>
-                        <a:t>Aerials won</a:t>
-                      </a:r>
-                    </a:p>
-                  </a:txBody>
-                  <a:tcPr>
-                    <a:solidFill>
-                      <a:srgbClr val="F0FAF4"/>
-                    </a:solidFill>
-                  </a:tcPr>
-                </a:tc>
-                <a:tc>
-                  <a:txBody>
-                    <a:bodyPr/>
-                    <a:lstStyle/>
-                    <a:p>
-                      <a:r>
-                        <a:rPr sz="1100" b="1">
-                          <a:solidFill>
-                            <a:srgbClr val="1C1C1C"/>
-                          </a:solidFill>
-                          <a:latin typeface="Arial"/>
-                        </a:rPr>
-                        <a:t>Defending</a:t>
-                      </a:r>
-                    </a:p>
-                  </a:txBody>
-                  <a:tcPr>
-                    <a:solidFill>
-                      <a:srgbClr val="F0FAF4"/>
-                    </a:solidFill>
-                  </a:tcPr>
-                </a:tc>
-                <a:tc>
-                  <a:txBody>
-                    <a:bodyPr/>
-                    <a:lstStyle/>
-                    <a:p>
-                      <a:r>
-                        <a:rPr sz="1100" b="1">
-                          <a:solidFill>
-                            <a:srgbClr val="1C1C1C"/>
-                          </a:solidFill>
-                          <a:latin typeface="Arial"/>
-                        </a:rPr>
-                        <a:t>Planned PASS</a:t>
-                      </a:r>
-                    </a:p>
-                  </a:txBody>
-                  <a:tcPr>
-                    <a:solidFill>
-                      <a:srgbClr val="F0FAF4"/>
-                    </a:solidFill>
-                  </a:tcPr>
-                </a:tc>
-                <a:tc>
-                  <a:txBody>
-                    <a:bodyPr/>
-                    <a:lstStyle/>
-                    <a:p>
-                      <a:r>
-                        <a:rPr sz="1100" b="1">
-                          <a:solidFill>
-                            <a:srgbClr val="1C1C1C"/>
-                          </a:solidFill>
-                          <a:latin typeface="Arial"/>
-                        </a:rPr>
-                        <a:t>Singleton</a:t>
-                      </a:r>
-                    </a:p>
-                  </a:txBody>
-                  <a:tcPr>
-                    <a:solidFill>
-                      <a:srgbClr val="F0FAF4"/>
-                    </a:solidFill>
-                  </a:tcPr>
-                </a:tc>
-              </a:tr>
-              <a:tr h="347472">
-                <a:tc>
-                  <a:txBody>
-                    <a:bodyPr/>
-                    <a:lstStyle/>
-                    <a:p>
-                      <a:r>
-                        <a:rPr sz="1100" b="1">
-                          <a:solidFill>
-                            <a:srgbClr val="1C1C1C"/>
-                          </a:solidFill>
-                          <a:latin typeface="Arial"/>
-                        </a:rPr>
-                        <a:t>AttPen</a:t>
-                      </a:r>
-                    </a:p>
-                  </a:txBody>
-                  <a:tcPr>
-                    <a:solidFill>
-                      <a:srgbClr val="F0FAF4"/>
-                    </a:solidFill>
-                  </a:tcPr>
-                </a:tc>
-                <a:tc>
-                  <a:txBody>
-                    <a:bodyPr/>
-                    <a:lstStyle/>
-                    <a:p>
-                      <a:r>
-                        <a:rPr sz="1100" b="1">
-                          <a:solidFill>
-                            <a:srgbClr val="1C1C1C"/>
-                          </a:solidFill>
-                          <a:latin typeface="Arial"/>
-                        </a:rPr>
-                        <a:t>Touches in attacking pen</a:t>
-                      </a:r>
-                    </a:p>
-                  </a:txBody>
-                  <a:tcPr>
-                    <a:solidFill>
-                      <a:srgbClr val="F0FAF4"/>
-                    </a:solidFill>
-                  </a:tcPr>
-                </a:tc>
-                <a:tc>
-                  <a:txBody>
-                    <a:bodyPr/>
-                    <a:lstStyle/>
-                    <a:p>
-                      <a:r>
-                        <a:rPr sz="1100" b="1">
-                          <a:solidFill>
-                            <a:srgbClr val="1C1C1C"/>
-                          </a:solidFill>
-                          <a:latin typeface="Arial"/>
-                        </a:rPr>
-                        <a:t>Attacking</a:t>
-                      </a:r>
-                    </a:p>
-                  </a:txBody>
-                  <a:tcPr>
-                    <a:solidFill>
-                      <a:srgbClr val="F0FAF4"/>
-                    </a:solidFill>
-                  </a:tcPr>
-                </a:tc>
-                <a:tc>
-                  <a:txBody>
-                    <a:bodyPr/>
-                    <a:lstStyle/>
-                    <a:p>
-                      <a:r>
-                        <a:rPr sz="1100" b="1">
-                          <a:solidFill>
-                            <a:srgbClr val="1C1C1C"/>
-                          </a:solidFill>
-                          <a:latin typeface="Arial"/>
-                        </a:rPr>
-                        <a:t>Planned PASS</a:t>
-                      </a:r>
-                    </a:p>
-                  </a:txBody>
-                  <a:tcPr>
-                    <a:solidFill>
-                      <a:srgbClr val="F0FAF4"/>
-                    </a:solidFill>
-                  </a:tcPr>
-                </a:tc>
-                <a:tc>
-                  <a:txBody>
-                    <a:bodyPr/>
-                    <a:lstStyle/>
-                    <a:p>
-                      <a:r>
-                        <a:rPr sz="1100" b="1">
-                          <a:solidFill>
-                            <a:srgbClr val="1C1C1C"/>
-                          </a:solidFill>
-                          <a:latin typeface="Arial"/>
-                        </a:rPr>
-                        <a:t>Singleton</a:t>
+              <a:tr h="274320">
+                <a:tc>
+                  <a:txBody>
+                    <a:bodyPr/>
+                    <a:lstStyle/>
+                    <a:p>
+                      <a:r>
+                        <a:rPr sz="1000" b="0">
+                          <a:solidFill>
+                            <a:srgbClr val="1C1C1C"/>
+                          </a:solidFill>
+                          <a:latin typeface="Arial"/>
+                        </a:rPr>
+                        <a:t>ATTME</a:t>
+                      </a:r>
+                    </a:p>
+                  </a:txBody>
+                  <a:tcPr>
+                    <a:solidFill>
+                      <a:srgbClr val="F0FAF4"/>
+                    </a:solidFill>
+                  </a:tcPr>
+                </a:tc>
+                <a:tc>
+                  <a:txBody>
+                    <a:bodyPr/>
+                    <a:lstStyle/>
+                    <a:p>
+                      <a:r>
+                        <a:rPr sz="1000" b="0">
+                          <a:solidFill>
+                            <a:srgbClr val="1C1C1C"/>
+                          </a:solidFill>
+                          <a:latin typeface="Arial"/>
+                        </a:rPr>
+                        <a:t>Att Medium</a:t>
+                      </a:r>
+                    </a:p>
+                  </a:txBody>
+                  <a:tcPr>
+                    <a:solidFill>
+                      <a:srgbClr val="F0FAF4"/>
+                    </a:solidFill>
+                  </a:tcPr>
+                </a:tc>
+                <a:tc>
+                  <a:txBody>
+                    <a:bodyPr/>
+                    <a:lstStyle/>
+                    <a:p>
+                      <a:r>
+                        <a:rPr sz="1000" b="0">
+                          <a:solidFill>
+                            <a:srgbClr val="1C1C1C"/>
+                          </a:solidFill>
+                          <a:latin typeface="Arial"/>
+                        </a:rPr>
+                        <a:t>Other</a:t>
+                      </a:r>
+                    </a:p>
+                  </a:txBody>
+                  <a:tcPr>
+                    <a:solidFill>
+                      <a:srgbClr val="F0FAF4"/>
+                    </a:solidFill>
+                  </a:tcPr>
+                </a:tc>
+                <a:tc>
+                  <a:txBody>
+                    <a:bodyPr/>
+                    <a:lstStyle/>
+                    <a:p>
+                      <a:r>
+                        <a:rPr sz="1000" b="1">
+                          <a:solidFill>
+                            <a:srgbClr val="1C1C1C"/>
+                          </a:solidFill>
+                          <a:latin typeface="Arial"/>
+                        </a:rPr>
+                        <a:t>0.790</a:t>
+                      </a:r>
+                    </a:p>
+                  </a:txBody>
+                  <a:tcPr>
+                    <a:solidFill>
+                      <a:srgbClr val="F0FAF4"/>
+                    </a:solidFill>
+                  </a:tcPr>
+                </a:tc>
+                <a:tc>
+                  <a:txBody>
+                    <a:bodyPr/>
+                    <a:lstStyle/>
+                    <a:p>
+                      <a:r>
+                        <a:rPr sz="1000" b="0">
+                          <a:solidFill>
+                            <a:srgbClr val="1C1C1C"/>
+                          </a:solidFill>
+                          <a:latin typeface="Arial"/>
+                        </a:rPr>
+                        <a:t>117</a:t>
                       </a:r>
                     </a:p>
                   </a:txBody>
@@ -7526,8 +7963,8 @@
         </p:nvSpPr>
         <p:spPr>
           <a:xfrm>
-            <a:off x="502920" y="6172200"/>
-            <a:ext cx="11155680" cy="365760"/>
+            <a:off x="457200" y="5989320"/>
+            <a:ext cx="11247120" cy="594360"/>
           </a:xfrm>
           <a:prstGeom prst="rect">
             <a:avLst/>
@@ -7543,11 +7980,22 @@
             <a:r>
               <a:rPr sz="1100" b="0">
                 <a:solidFill>
-                  <a:srgbClr val="8A5A00"/>
+                  <a:srgbClr val="555555"/>
                 </a:solidFill>
                 <a:latin typeface="Arial"/>
               </a:rPr>
-              <a:t>When FBref is frozen: replace Planned PASS/OUT with real prior→Y1 stability r (same layout as StatsBomb slide).</a:t>
+              <a:t>Showing top 15 of 71 passers. Full table: results/fbref_stability_passed_r040.csv · Big 5 priors only (PL/La Liga/Serie A/Ligue 1→BL).</a:t>
+            </a:r>
+          </a:p>
+          <a:p>
+            <a:r>
+              <a:rPr sz="1100" b="0">
+                <a:solidFill>
+                  <a:srgbClr val="555555"/>
+                </a:solidFill>
+                <a:latin typeface="Arial"/>
+              </a:rPr>
+              <a:t>Auto shortlist after redundancy: 22 metrics (see fbref_redundancy_auto_shortlist_suggestion.csv).</a:t>
             </a:r>
           </a:p>
         </p:txBody>

</xml_diff>

<commit_message>
Polish PPT: refresh slide-9 rs, fix S10 title and S19 typos.
Co-authored-by: Cursor <cursoragent@cursor.com>
</commit_message>
<xml_diff>
--- a/bundesliga_transfer_traits.pptx
+++ b/bundesliga_transfer_traits.pptx
@@ -323,7 +323,7 @@
           <a:p>
             <a:fld id="{5BCAD085-E8A6-8845-BD4E-CB4CCA059FC4}" type="datetimeFigureOut">
               <a:rPr lang="en-US" smtClean="0"/>
-              <a:t>7/18/26</a:t>
+              <a:t>7/20/26</a:t>
             </a:fld>
             <a:endParaRPr lang="en-US"/>
           </a:p>
@@ -491,7 +491,7 @@
           <a:p>
             <a:fld id="{5BCAD085-E8A6-8845-BD4E-CB4CCA059FC4}" type="datetimeFigureOut">
               <a:rPr lang="en-US" smtClean="0"/>
-              <a:t>7/18/26</a:t>
+              <a:t>7/20/26</a:t>
             </a:fld>
             <a:endParaRPr lang="en-US"/>
           </a:p>
@@ -669,7 +669,7 @@
           <a:p>
             <a:fld id="{5BCAD085-E8A6-8845-BD4E-CB4CCA059FC4}" type="datetimeFigureOut">
               <a:rPr lang="en-US" smtClean="0"/>
-              <a:t>7/18/26</a:t>
+              <a:t>7/20/26</a:t>
             </a:fld>
             <a:endParaRPr lang="en-US"/>
           </a:p>
@@ -837,7 +837,7 @@
           <a:p>
             <a:fld id="{5BCAD085-E8A6-8845-BD4E-CB4CCA059FC4}" type="datetimeFigureOut">
               <a:rPr lang="en-US" smtClean="0"/>
-              <a:t>7/18/26</a:t>
+              <a:t>7/20/26</a:t>
             </a:fld>
             <a:endParaRPr lang="en-US"/>
           </a:p>
@@ -1082,7 +1082,7 @@
           <a:p>
             <a:fld id="{5BCAD085-E8A6-8845-BD4E-CB4CCA059FC4}" type="datetimeFigureOut">
               <a:rPr lang="en-US" smtClean="0"/>
-              <a:t>7/18/26</a:t>
+              <a:t>7/20/26</a:t>
             </a:fld>
             <a:endParaRPr lang="en-US"/>
           </a:p>
@@ -1367,7 +1367,7 @@
           <a:p>
             <a:fld id="{5BCAD085-E8A6-8845-BD4E-CB4CCA059FC4}" type="datetimeFigureOut">
               <a:rPr lang="en-US" smtClean="0"/>
-              <a:t>7/18/26</a:t>
+              <a:t>7/20/26</a:t>
             </a:fld>
             <a:endParaRPr lang="en-US"/>
           </a:p>
@@ -1786,7 +1786,7 @@
           <a:p>
             <a:fld id="{5BCAD085-E8A6-8845-BD4E-CB4CCA059FC4}" type="datetimeFigureOut">
               <a:rPr lang="en-US" smtClean="0"/>
-              <a:t>7/18/26</a:t>
+              <a:t>7/20/26</a:t>
             </a:fld>
             <a:endParaRPr lang="en-US"/>
           </a:p>
@@ -1903,7 +1903,7 @@
           <a:p>
             <a:fld id="{5BCAD085-E8A6-8845-BD4E-CB4CCA059FC4}" type="datetimeFigureOut">
               <a:rPr lang="en-US" smtClean="0"/>
-              <a:t>7/18/26</a:t>
+              <a:t>7/20/26</a:t>
             </a:fld>
             <a:endParaRPr lang="en-US"/>
           </a:p>
@@ -1998,7 +1998,7 @@
           <a:p>
             <a:fld id="{5BCAD085-E8A6-8845-BD4E-CB4CCA059FC4}" type="datetimeFigureOut">
               <a:rPr lang="en-US" smtClean="0"/>
-              <a:t>7/18/26</a:t>
+              <a:t>7/20/26</a:t>
             </a:fld>
             <a:endParaRPr lang="en-US"/>
           </a:p>
@@ -2273,7 +2273,7 @@
           <a:p>
             <a:fld id="{5BCAD085-E8A6-8845-BD4E-CB4CCA059FC4}" type="datetimeFigureOut">
               <a:rPr lang="en-US" smtClean="0"/>
-              <a:t>7/18/26</a:t>
+              <a:t>7/20/26</a:t>
             </a:fld>
             <a:endParaRPr lang="en-US"/>
           </a:p>
@@ -2525,7 +2525,7 @@
           <a:p>
             <a:fld id="{5BCAD085-E8A6-8845-BD4E-CB4CCA059FC4}" type="datetimeFigureOut">
               <a:rPr lang="en-US" smtClean="0"/>
-              <a:t>7/18/26</a:t>
+              <a:t>7/20/26</a:t>
             </a:fld>
             <a:endParaRPr lang="en-US"/>
           </a:p>
@@ -2736,7 +2736,7 @@
           <a:p>
             <a:fld id="{5BCAD085-E8A6-8845-BD4E-CB4CCA059FC4}" type="datetimeFigureOut">
               <a:rPr lang="en-US" smtClean="0"/>
-              <a:t>7/18/26</a:t>
+              <a:t>7/20/26</a:t>
             </a:fld>
             <a:endParaRPr lang="en-US"/>
           </a:p>
@@ -3119,7 +3119,7 @@
         </p:nvSpPr>
         <p:spPr>
           <a:xfrm>
-            <a:off x="0" y="320039"/>
+            <a:off x="0" y="0"/>
             <a:ext cx="12191695" cy="6858000"/>
           </a:xfrm>
           <a:prstGeom prst="rect">
@@ -3495,22 +3495,12 @@
           <a:p>
             <a:pPr algn="l"/>
             <a:r>
-              <a:rPr sz="1300" b="1" dirty="0">
-                <a:solidFill>
-                  <a:srgbClr val="3D5A80"/>
-                </a:solidFill>
-                <a:latin typeface="Calibri"/>
-              </a:rPr>
-              <a:t>OUTPUT  ·  SCOUT PIZZA</a:t>
-            </a:r>
-            <a:r>
-              <a:rPr lang="en-US" sz="1300" b="1" dirty="0">
-                <a:solidFill>
-                  <a:srgbClr val="3D5A80"/>
-                </a:solidFill>
-                <a:latin typeface="Calibri"/>
-              </a:rPr>
-              <a:t> CHART (Based on charts used by RBNY</a:t>
+              <a:rPr sz="2000" b="1">
+                <a:solidFill>
+                  <a:srgbClr val="222222"/>
+                </a:solidFill>
+              </a:rPr>
+              <a:t>OUTPUT · SCOUT PIZZA CHART (Based on charts used by RBNY)</a:t>
             </a:r>
             <a:endParaRPr sz="1300" b="1" dirty="0">
               <a:solidFill>
@@ -4749,7 +4739,7 @@
         <p:spPr>
           <a:xfrm>
             <a:off x="1600200" y="1463039"/>
-            <a:ext cx="9601200" cy="457200"/>
+            <a:ext cx="9601200" cy="338554"/>
           </a:xfrm>
           <a:prstGeom prst="rect">
             <a:avLst/>
@@ -4768,13 +4758,31 @@
               </a:spcAft>
             </a:pPr>
             <a:r>
-              <a:rPr sz="1400" b="0">
+              <a:rPr sz="1600" b="0" dirty="0">
                 <a:solidFill>
                   <a:srgbClr val="333333"/>
                 </a:solidFill>
                 <a:latin typeface="Calibri"/>
               </a:rPr>
-              <a:t>Open interactive_player_explorer.html in a browser.</a:t>
+              <a:t>Open </a:t>
+            </a:r>
+            <a:r>
+              <a:rPr sz="1600" b="0" dirty="0" err="1">
+                <a:solidFill>
+                  <a:srgbClr val="333333"/>
+                </a:solidFill>
+                <a:latin typeface="Calibri"/>
+              </a:rPr>
+              <a:t>interactive_player_explorer.html</a:t>
+            </a:r>
+            <a:r>
+              <a:rPr sz="1600" b="0" dirty="0">
+                <a:solidFill>
+                  <a:srgbClr val="333333"/>
+                </a:solidFill>
+                <a:latin typeface="Calibri"/>
+              </a:rPr>
+              <a:t> in a browser.</a:t>
             </a:r>
           </a:p>
         </p:txBody>
@@ -4912,8 +4920,8 @@
         </p:nvSpPr>
         <p:spPr>
           <a:xfrm>
-            <a:off x="1600200" y="2560320"/>
-            <a:ext cx="9601200" cy="457200"/>
+            <a:off x="1600200" y="2501705"/>
+            <a:ext cx="9601200" cy="623248"/>
           </a:xfrm>
           <a:prstGeom prst="rect">
             <a:avLst/>
@@ -4932,13 +4940,49 @@
               </a:spcAft>
             </a:pPr>
             <a:r>
-              <a:rPr sz="1400" b="0">
+              <a:rPr sz="1600" b="0" dirty="0">
                 <a:solidFill>
                   <a:srgbClr val="333333"/>
                 </a:solidFill>
                 <a:latin typeface="Calibri"/>
               </a:rPr>
-              <a:t>Switch StatsBomb (N=96 · 7 traits) ↔ FBref (N=329 · 32 traits).</a:t>
+              <a:t>Switch </a:t>
+            </a:r>
+            <a:r>
+              <a:rPr sz="1600" b="0" dirty="0" err="1">
+                <a:solidFill>
+                  <a:srgbClr val="333333"/>
+                </a:solidFill>
+                <a:latin typeface="Calibri"/>
+              </a:rPr>
+              <a:t>StatsBomb</a:t>
+            </a:r>
+            <a:r>
+              <a:rPr sz="1600" b="0" dirty="0">
+                <a:solidFill>
+                  <a:srgbClr val="333333"/>
+                </a:solidFill>
+                <a:latin typeface="Calibri"/>
+              </a:rPr>
+              <a:t> (N=96 · 7 traits) ↔ </a:t>
+            </a:r>
+            <a:r>
+              <a:rPr sz="1600" b="0" dirty="0" err="1">
+                <a:solidFill>
+                  <a:srgbClr val="333333"/>
+                </a:solidFill>
+                <a:latin typeface="Calibri"/>
+              </a:rPr>
+              <a:t>FBref</a:t>
+            </a:r>
+            <a:r>
+              <a:rPr sz="1600" b="0" dirty="0">
+                <a:solidFill>
+                  <a:srgbClr val="333333"/>
+                </a:solidFill>
+                <a:latin typeface="Calibri"/>
+              </a:rPr>
+              <a:t> (N=329 · 32 traits).</a:t>
             </a:r>
           </a:p>
           <a:p>
@@ -4948,7 +4992,7 @@
               </a:spcAft>
             </a:pPr>
             <a:r>
-              <a:rPr sz="1400" b="0">
+              <a:rPr sz="1600" b="0" dirty="0">
                 <a:solidFill>
                   <a:srgbClr val="333333"/>
                 </a:solidFill>
@@ -5108,7 +5152,7 @@
           <a:p>
             <a:pPr algn="l"/>
             <a:r>
-              <a:rPr sz="1600" b="0">
+              <a:rPr sz="1600" b="0" dirty="0">
                 <a:solidFill>
                   <a:srgbClr val="1C1C1C"/>
                 </a:solidFill>
@@ -5634,7 +5678,7 @@
           <a:lstStyle/>
           <a:p>
             <a:r>
-              <a:rPr sz="1400" b="1">
+              <a:rPr sz="1400" b="1" dirty="0" err="1">
                 <a:solidFill>
                   <a:srgbClr val="1C1C1C"/>
                 </a:solidFill>
@@ -5642,6 +5686,12 @@
               </a:rPr>
               <a:t>StatsBomb</a:t>
             </a:r>
+            <a:endParaRPr sz="1400" b="1" dirty="0">
+              <a:solidFill>
+                <a:srgbClr val="1C1C1C"/>
+              </a:solidFill>
+              <a:latin typeface="Georgia"/>
+            </a:endParaRPr>
           </a:p>
         </p:txBody>
       </p:sp>
@@ -5815,7 +5865,7 @@
         <p:spPr>
           <a:xfrm>
             <a:off x="4343400" y="2258568"/>
-            <a:ext cx="3291840" cy="274320"/>
+            <a:ext cx="3291840" cy="746358"/>
           </a:xfrm>
           <a:prstGeom prst="rect">
             <a:avLst/>
@@ -5834,24 +5884,24 @@
               </a:spcAft>
             </a:pPr>
             <a:r>
-              <a:rPr sz="1300" b="0" dirty="0" err="1">
+              <a:rPr sz="1400" b="1" dirty="0" err="1">
                 <a:solidFill>
                   <a:srgbClr val="333333"/>
                 </a:solidFill>
-                <a:latin typeface="Calibri"/>
+                <a:latin typeface="Georgia" panose="02040502050405020303" pitchFamily="18" charset="0"/>
               </a:rPr>
               <a:t>FBref</a:t>
             </a:r>
-            <a:endParaRPr sz="1600" b="1" dirty="0">
+            <a:endParaRPr sz="1400" b="1" dirty="0">
               <a:solidFill>
                 <a:srgbClr val="3D5A80"/>
               </a:solidFill>
-              <a:latin typeface="Calibri"/>
+              <a:latin typeface="Georgia" panose="02040502050405020303" pitchFamily="18" charset="0"/>
             </a:endParaRPr>
           </a:p>
           <a:p>
             <a:r>
-              <a:rPr sz="1300" b="0">
+              <a:rPr sz="1300" b="0" dirty="0">
                 <a:solidFill>
                   <a:srgbClr val="333333"/>
                 </a:solidFill>
@@ -5861,7 +5911,7 @@
           </a:p>
           <a:p>
             <a:r>
-              <a:rPr sz="1300" b="0">
+              <a:rPr sz="1300" b="0" dirty="0">
                 <a:solidFill>
                   <a:srgbClr val="333333"/>
                 </a:solidFill>
@@ -5970,7 +6020,7 @@
         <p:spPr>
           <a:xfrm>
             <a:off x="8092440" y="2258568"/>
-            <a:ext cx="3566160" cy="274320"/>
+            <a:ext cx="3566160" cy="307777"/>
           </a:xfrm>
           <a:prstGeom prst="rect">
             <a:avLst/>
@@ -5984,14 +6034,29 @@
           <a:lstStyle/>
           <a:p>
             <a:r>
-              <a:rPr sz="1400" b="1">
+              <a:rPr lang="en-US" sz="1400" b="1" dirty="0">
                 <a:solidFill>
                   <a:srgbClr val="1C1C1C"/>
                 </a:solidFill>
                 <a:latin typeface="Georgia"/>
               </a:rPr>
-              <a:t>Honest claim</a:t>
-            </a:r>
+              <a:t>Weak </a:t>
+            </a:r>
+            <a:r>
+              <a:rPr lang="en-US" sz="1400" b="1" dirty="0" err="1">
+                <a:solidFill>
+                  <a:srgbClr val="1C1C1C"/>
+                </a:solidFill>
+                <a:latin typeface="Georgia"/>
+              </a:rPr>
+              <a:t>Signalling</a:t>
+            </a:r>
+            <a:endParaRPr sz="1400" b="1" dirty="0">
+              <a:solidFill>
+                <a:srgbClr val="1C1C1C"/>
+              </a:solidFill>
+              <a:latin typeface="Georgia"/>
+            </a:endParaRPr>
           </a:p>
         </p:txBody>
       </p:sp>
@@ -6433,8 +6498,8 @@
         </p:nvSpPr>
         <p:spPr>
           <a:xfrm>
-            <a:off x="6355080" y="1417320"/>
-            <a:ext cx="5212080" cy="4114800"/>
+            <a:off x="7104183" y="1417320"/>
+            <a:ext cx="4193345" cy="3222674"/>
           </a:xfrm>
           <a:prstGeom prst="roundRect">
             <a:avLst/>
@@ -6768,14 +6833,11 @@
             </a:r>
           </a:p>
           <a:p>
-            <a:r>
-              <a:rPr sz="1200" b="0">
-                <a:solidFill>
-                  <a:srgbClr val="333333"/>
-                </a:solidFill>
-              </a:rPr>
-              <a:t/>
-            </a:r>
+            <a:endParaRPr sz="1200" b="0">
+              <a:solidFill>
+                <a:srgbClr val="333333"/>
+              </a:solidFill>
+            </a:endParaRPr>
           </a:p>
           <a:p>
             <a:r>
@@ -6858,7 +6920,7 @@
           <p:nvPr>
             <p:extLst>
               <p:ext uri="{D42A27DB-BD31-4B8C-83A1-F6EECF244321}">
-                <p14:modId xmlns:p14="http://schemas.microsoft.com/office/powerpoint/2010/main" val="3499797722"/>
+                <p14:modId xmlns:p14="http://schemas.microsoft.com/office/powerpoint/2010/main" val="1912777490"/>
               </p:ext>
             </p:extLst>
           </p:nvPr>
@@ -6913,7 +6975,7 @@
                       <a:r>
                         <a:rPr sz="1000" b="1">
                           <a:solidFill>
-                            <a:srgbClr val="333333"/>
+                            <a:schemeClr val="bg1"/>
                           </a:solidFill>
                         </a:rPr>
                         <a:t>Trait</a:t>
@@ -6942,7 +7004,7 @@
                       <a:r>
                         <a:rPr sz="1000" b="1">
                           <a:solidFill>
-                            <a:srgbClr val="333333"/>
+                            <a:schemeClr val="bg1"/>
                           </a:solidFill>
                         </a:rPr>
                         <a:t>ρ</a:t>
@@ -6969,9 +7031,9 @@
                         </a:defRPr>
                       </a:pPr>
                       <a:r>
-                        <a:rPr sz="1000" b="1">
-                          <a:solidFill>
-                            <a:srgbClr val="333333"/>
+                        <a:rPr sz="1000" b="1" dirty="0">
+                          <a:solidFill>
+                            <a:schemeClr val="bg1"/>
                           </a:solidFill>
                         </a:rPr>
                         <a:t>p</a:t>
@@ -7287,17 +7349,13 @@
                         </a:defRPr>
                       </a:pPr>
                       <a:r>
-                        <a:rPr dirty="0" sz="1000">
+                        <a:rPr sz="1000" dirty="0">
                           <a:solidFill>
                             <a:srgbClr val="333333"/>
                           </a:solidFill>
                         </a:rPr>
                         <a:t>DIS — Dispossessed (inv)</a:t>
                       </a:r>
-                      <a:r>
-                        <a:rPr lang="en-US" dirty="0"/>
-                        <a:t/>
-                      </a:r>
                       <a:endParaRPr dirty="0"/>
                     </a:p>
                   </a:txBody>
@@ -7321,7 +7379,7 @@
                         </a:defRPr>
                       </a:pPr>
                       <a:r>
-                        <a:rPr dirty="0" sz="1000">
+                        <a:rPr sz="1000" dirty="0">
                           <a:solidFill>
                             <a:srgbClr val="333333"/>
                           </a:solidFill>
@@ -7538,7 +7596,7 @@
                         </a:defRPr>
                       </a:pPr>
                       <a:r>
-                        <a:rPr dirty="0" sz="1000">
+                        <a:rPr sz="1000" dirty="0">
                           <a:solidFill>
                             <a:srgbClr val="333333"/>
                           </a:solidFill>
@@ -7610,13 +7668,20 @@
             </a:r>
           </a:p>
           <a:p>
+            <a:endParaRPr sz="1200" b="0">
+              <a:solidFill>
+                <a:srgbClr val="333333"/>
+              </a:solidFill>
+            </a:endParaRPr>
+          </a:p>
+          <a:p>
             <a:r>
               <a:rPr sz="1200" b="0">
                 <a:solidFill>
                   <a:srgbClr val="333333"/>
                 </a:solidFill>
               </a:rPr>
-              <a:t/>
+              <a:t>FINAL  ρ=+0.30  p=0.005 *</a:t>
             </a:r>
           </a:p>
           <a:p>
@@ -7626,7 +7691,7 @@
                   <a:srgbClr val="333333"/>
                 </a:solidFill>
               </a:rPr>
-              <a:t>FINAL  ρ=+0.30  p=0.005 *</a:t>
+              <a:t>SH  ρ=+0.27  p=0.011 *</a:t>
             </a:r>
           </a:p>
           <a:p>
@@ -7636,7 +7701,7 @@
                   <a:srgbClr val="333333"/>
                 </a:solidFill>
               </a:rPr>
-              <a:t>SH  ρ=+0.27  p=0.011 *</a:t>
+              <a:t>PRGDI  ρ=+0.24  p=0.025 *</a:t>
             </a:r>
           </a:p>
           <a:p>
@@ -7646,7 +7711,7 @@
                   <a:srgbClr val="333333"/>
                 </a:solidFill>
               </a:rPr>
-              <a:t>PRGDI  ρ=+0.24  p=0.025 *</a:t>
+              <a:t>TKLD  ρ=+0.23  p=0.030 *</a:t>
             </a:r>
           </a:p>
           <a:p>
@@ -7656,7 +7721,7 @@
                   <a:srgbClr val="333333"/>
                 </a:solidFill>
               </a:rPr>
-              <a:t>TKLD  ρ=+0.23  p=0.030 *</a:t>
+              <a:t>ATTLO  ρ=+0.22  p=0.036 *</a:t>
             </a:r>
           </a:p>
           <a:p>
@@ -7666,28 +7731,15 @@
                   <a:srgbClr val="333333"/>
                 </a:solidFill>
               </a:rPr>
-              <a:t>ATTLO  ρ=+0.22  p=0.036 *</a:t>
-            </a:r>
-          </a:p>
-          <a:p>
-            <a:r>
-              <a:rPr sz="1200" b="0">
-                <a:solidFill>
-                  <a:srgbClr val="333333"/>
-                </a:solidFill>
-              </a:rPr>
               <a:t>DEF3R  ρ=+0.22  p=0.039 *</a:t>
             </a:r>
           </a:p>
           <a:p>
-            <a:r>
-              <a:rPr sz="1200" b="0">
-                <a:solidFill>
-                  <a:srgbClr val="333333"/>
-                </a:solidFill>
-              </a:rPr>
-              <a:t/>
-            </a:r>
+            <a:endParaRPr sz="1200" b="0">
+              <a:solidFill>
+                <a:srgbClr val="333333"/>
+              </a:solidFill>
+            </a:endParaRPr>
           </a:p>
           <a:p>
             <a:r>
@@ -7710,7 +7762,7 @@
           <p:nvPr>
             <p:extLst>
               <p:ext uri="{D42A27DB-BD31-4B8C-83A1-F6EECF244321}">
-                <p14:modId xmlns:p14="http://schemas.microsoft.com/office/powerpoint/2010/main" val="2683717155"/>
+                <p14:modId xmlns:p14="http://schemas.microsoft.com/office/powerpoint/2010/main" val="4283249453"/>
               </p:ext>
             </p:extLst>
           </p:nvPr>
@@ -7765,7 +7817,7 @@
                       <a:r>
                         <a:rPr sz="1000" b="1">
                           <a:solidFill>
-                            <a:srgbClr val="333333"/>
+                            <a:schemeClr val="bg1"/>
                           </a:solidFill>
                         </a:rPr>
                         <a:t>Trait</a:t>
@@ -7794,7 +7846,7 @@
                       <a:r>
                         <a:rPr sz="1000" b="1">
                           <a:solidFill>
-                            <a:srgbClr val="333333"/>
+                            <a:schemeClr val="bg1"/>
                           </a:solidFill>
                         </a:rPr>
                         <a:t>ρ</a:t>
@@ -7821,9 +7873,9 @@
                         </a:defRPr>
                       </a:pPr>
                       <a:r>
-                        <a:rPr sz="1000" b="1">
-                          <a:solidFill>
-                            <a:srgbClr val="333333"/>
+                        <a:rPr sz="1000" b="1" dirty="0">
+                          <a:solidFill>
+                            <a:schemeClr val="bg1"/>
                           </a:solidFill>
                         </a:rPr>
                         <a:t>p</a:t>
@@ -8045,20 +8097,12 @@
                         </a:defRPr>
                       </a:pPr>
                       <a:r>
-                        <a:rPr dirty="0" sz="1000">
+                        <a:rPr sz="1000" dirty="0">
                           <a:solidFill>
                             <a:srgbClr val="333333"/>
                           </a:solidFill>
                         </a:rPr>
                         <a:t>PRGDI — PrgDist Total*</a:t>
-                      </a:r>
-                      <a:r>
-                        <a:rPr lang="en-US" dirty="0"/>
-                        <a:t/>
-                      </a:r>
-                      <a:r>
-                        <a:rPr dirty="0"/>
-                        <a:t/>
                       </a:r>
                     </a:p>
                   </a:txBody>
@@ -8729,14 +8773,14 @@
           <p:nvPr>
             <p:extLst>
               <p:ext uri="{D42A27DB-BD31-4B8C-83A1-F6EECF244321}">
-                <p14:modId xmlns:p14="http://schemas.microsoft.com/office/powerpoint/2010/main" val="2192350146"/>
+                <p14:modId xmlns:p14="http://schemas.microsoft.com/office/powerpoint/2010/main" val="3524262344"/>
               </p:ext>
             </p:extLst>
           </p:nvPr>
         </p:nvGraphicFramePr>
         <p:xfrm>
           <a:off x="411480" y="1179576"/>
-          <a:ext cx="5669280" cy="1554480"/>
+          <a:ext cx="5669280" cy="2292096"/>
         </p:xfrm>
         <a:graphic>
           <a:graphicData uri="http://schemas.openxmlformats.org/drawingml/2006/table">
@@ -8798,7 +8842,7 @@
                       <a:r>
                         <a:rPr sz="1000" b="1">
                           <a:solidFill>
-                            <a:srgbClr val="333333"/>
+                            <a:schemeClr val="bg1"/>
                           </a:solidFill>
                         </a:rPr>
                         <a:t>League</a:t>
@@ -8827,7 +8871,7 @@
                       <a:r>
                         <a:rPr sz="1000" b="1">
                           <a:solidFill>
-                            <a:srgbClr val="333333"/>
+                            <a:schemeClr val="bg1"/>
                           </a:solidFill>
                         </a:rPr>
                         <a:t>N</a:t>
@@ -8856,7 +8900,7 @@
                       <a:r>
                         <a:rPr sz="1000" b="1">
                           <a:solidFill>
-                            <a:srgbClr val="333333"/>
+                            <a:schemeClr val="bg1"/>
                           </a:solidFill>
                         </a:rPr>
                         <a:t>Mean Y1 min</a:t>
@@ -8885,7 +8929,7 @@
                       <a:r>
                         <a:rPr sz="1000" b="1">
                           <a:solidFill>
-                            <a:srgbClr val="333333"/>
+                            <a:schemeClr val="bg1"/>
                           </a:solidFill>
                         </a:rPr>
                         <a:t>Median Y1 min</a:t>
@@ -8912,9 +8956,9 @@
                         </a:defRPr>
                       </a:pPr>
                       <a:r>
-                        <a:rPr sz="1000" b="1">
-                          <a:solidFill>
-                            <a:srgbClr val="333333"/>
+                        <a:rPr sz="1000" b="1" dirty="0">
+                          <a:solidFill>
+                            <a:schemeClr val="bg1"/>
                           </a:solidFill>
                         </a:rPr>
                         <a:t>Trait score</a:t>
@@ -8948,7 +8992,7 @@
                         </a:defRPr>
                       </a:pPr>
                       <a:r>
-                        <a:rPr dirty="0" sz="1000" b="0">
+                        <a:rPr sz="1000" b="0" dirty="0">
                           <a:solidFill>
                             <a:srgbClr val="333333"/>
                           </a:solidFill>
@@ -9100,7 +9144,7 @@
                         </a:defRPr>
                       </a:pPr>
                       <a:r>
-                        <a:rPr dirty="0" sz="1000" b="0">
+                        <a:rPr sz="1000" b="0" dirty="0">
                           <a:solidFill>
                             <a:srgbClr val="333333"/>
                           </a:solidFill>
@@ -9404,7 +9448,7 @@
                         </a:defRPr>
                       </a:pPr>
                       <a:r>
-                        <a:rPr dirty="0" sz="1000" b="0">
+                        <a:rPr sz="1000" b="0" dirty="0">
                           <a:solidFill>
                             <a:srgbClr val="333333"/>
                           </a:solidFill>
@@ -9520,7 +9564,7 @@
                         </a:defRPr>
                       </a:pPr>
                       <a:r>
-                        <a:rPr dirty="0" sz="1000" b="0">
+                        <a:rPr sz="1000" b="0" dirty="0">
                           <a:solidFill>
                             <a:srgbClr val="333333"/>
                           </a:solidFill>
@@ -9556,7 +9600,7 @@
                         </a:defRPr>
                       </a:pPr>
                       <a:r>
-                        <a:rPr dirty="0" sz="1000" b="0">
+                        <a:rPr sz="1000" b="0" dirty="0">
                           <a:solidFill>
                             <a:srgbClr val="333333"/>
                           </a:solidFill>
@@ -9672,7 +9716,7 @@
                         </a:defRPr>
                       </a:pPr>
                       <a:r>
-                        <a:rPr dirty="0" sz="1000" b="0">
+                        <a:rPr sz="1000" b="0" dirty="0">
                           <a:solidFill>
                             <a:srgbClr val="333333"/>
                           </a:solidFill>
@@ -9689,7 +9733,7 @@
                 </a:tc>
                 <a:extLst>
                   <a:ext uri="{0D108BD9-81ED-4DB2-BD59-A6C34878D82A}">
-                    <a16:rowId xmlns:a16="http://schemas.microsoft.com/office/drawing/2014/main" val="10004"/>
+                    <a16:rowId xmlns:a16="http://schemas.microsoft.com/office/drawing/2014/main" val="1952154708"/>
                   </a:ext>
                 </a:extLst>
               </a:tr>
@@ -9708,7 +9752,7 @@
                         </a:defRPr>
                       </a:pPr>
                       <a:r>
-                        <a:rPr dirty="0" sz="1000" b="0">
+                        <a:rPr sz="1000" b="0" dirty="0">
                           <a:solidFill>
                             <a:srgbClr val="333333"/>
                           </a:solidFill>
@@ -9824,7 +9868,7 @@
                         </a:defRPr>
                       </a:pPr>
                       <a:r>
-                        <a:rPr dirty="0" sz="1000" b="0">
+                        <a:rPr sz="1000" b="0" dirty="0">
                           <a:solidFill>
                             <a:srgbClr val="333333"/>
                           </a:solidFill>
@@ -9841,7 +9885,7 @@
                 </a:tc>
                 <a:extLst>
                   <a:ext uri="{0D108BD9-81ED-4DB2-BD59-A6C34878D82A}">
-                    <a16:rowId xmlns:a16="http://schemas.microsoft.com/office/drawing/2014/main" val="10004"/>
+                    <a16:rowId xmlns:a16="http://schemas.microsoft.com/office/drawing/2014/main" val="256267834"/>
                   </a:ext>
                 </a:extLst>
               </a:tr>
@@ -9860,7 +9904,7 @@
                         </a:defRPr>
                       </a:pPr>
                       <a:r>
-                        <a:rPr dirty="0" sz="1000" b="0">
+                        <a:rPr sz="1000" b="0" dirty="0">
                           <a:solidFill>
                             <a:srgbClr val="333333"/>
                           </a:solidFill>
@@ -9976,7 +10020,7 @@
                         </a:defRPr>
                       </a:pPr>
                       <a:r>
-                        <a:rPr dirty="0" sz="1000" b="0">
+                        <a:rPr sz="1000" b="0" dirty="0">
                           <a:solidFill>
                             <a:srgbClr val="333333"/>
                           </a:solidFill>
@@ -9993,7 +10037,7 @@
                 </a:tc>
                 <a:extLst>
                   <a:ext uri="{0D108BD9-81ED-4DB2-BD59-A6C34878D82A}">
-                    <a16:rowId xmlns:a16="http://schemas.microsoft.com/office/drawing/2014/main" val="10004"/>
+                    <a16:rowId xmlns:a16="http://schemas.microsoft.com/office/drawing/2014/main" val="1344981553"/>
                   </a:ext>
                 </a:extLst>
               </a:tr>
@@ -10012,7 +10056,7 @@
                         </a:defRPr>
                       </a:pPr>
                       <a:r>
-                        <a:rPr dirty="0" sz="1000" b="0">
+                        <a:rPr sz="1000" b="0" dirty="0">
                           <a:solidFill>
                             <a:srgbClr val="333333"/>
                           </a:solidFill>
@@ -10128,7 +10172,7 @@
                         </a:defRPr>
                       </a:pPr>
                       <a:r>
-                        <a:rPr dirty="0" sz="1000" b="0">
+                        <a:rPr sz="1000" b="0" dirty="0">
                           <a:solidFill>
                             <a:srgbClr val="333333"/>
                           </a:solidFill>
@@ -10145,7 +10189,7 @@
                 </a:tc>
                 <a:extLst>
                   <a:ext uri="{0D108BD9-81ED-4DB2-BD59-A6C34878D82A}">
-                    <a16:rowId xmlns:a16="http://schemas.microsoft.com/office/drawing/2014/main" val="10004"/>
+                    <a16:rowId xmlns:a16="http://schemas.microsoft.com/office/drawing/2014/main" val="886173303"/>
                   </a:ext>
                 </a:extLst>
               </a:tr>
@@ -10159,11 +10203,17 @@
           <p:cNvGraphicFramePr>
             <a:graphicFrameLocks noGrp="1"/>
           </p:cNvGraphicFramePr>
-          <p:nvPr/>
+          <p:nvPr>
+            <p:extLst>
+              <p:ext uri="{D42A27DB-BD31-4B8C-83A1-F6EECF244321}">
+                <p14:modId xmlns:p14="http://schemas.microsoft.com/office/powerpoint/2010/main" val="4284551680"/>
+              </p:ext>
+            </p:extLst>
+          </p:nvPr>
         </p:nvGraphicFramePr>
         <p:xfrm>
           <a:off x="411480" y="3246120"/>
-          <a:ext cx="4846320" cy="1554480"/>
+          <a:ext cx="4846320" cy="1536192"/>
         </p:xfrm>
         <a:graphic>
           <a:graphicData uri="http://schemas.openxmlformats.org/drawingml/2006/table">
@@ -10218,7 +10268,7 @@
                       <a:r>
                         <a:rPr sz="1000" b="1">
                           <a:solidFill>
-                            <a:srgbClr val="333333"/>
+                            <a:schemeClr val="bg1"/>
                           </a:solidFill>
                         </a:rPr>
                         <a:t>League</a:t>
@@ -10247,7 +10297,7 @@
                       <a:r>
                         <a:rPr sz="1000" b="1">
                           <a:solidFill>
-                            <a:srgbClr val="333333"/>
+                            <a:schemeClr val="bg1"/>
                           </a:solidFill>
                         </a:rPr>
                         <a:t>N</a:t>
@@ -10276,7 +10326,7 @@
                       <a:r>
                         <a:rPr sz="1000" b="1">
                           <a:solidFill>
-                            <a:srgbClr val="333333"/>
+                            <a:schemeClr val="bg1"/>
                           </a:solidFill>
                         </a:rPr>
                         <a:t>Mean Y1 min</a:t>
@@ -10303,9 +10353,9 @@
                         </a:defRPr>
                       </a:pPr>
                       <a:r>
-                        <a:rPr sz="1000" b="1">
-                          <a:solidFill>
-                            <a:srgbClr val="333333"/>
+                        <a:rPr sz="1000" b="1" dirty="0">
+                          <a:solidFill>
+                            <a:schemeClr val="bg1"/>
                           </a:solidFill>
                         </a:rPr>
                         <a:t>Trait score</a:t>
@@ -10918,7 +10968,7 @@
                         </a:defRPr>
                       </a:pPr>
                       <a:r>
-                        <a:rPr sz="1000">
+                        <a:rPr sz="1000" dirty="0">
                           <a:solidFill>
                             <a:srgbClr val="333333"/>
                           </a:solidFill>
@@ -11382,7 +11432,7 @@
         <p:spPr>
           <a:xfrm>
             <a:off x="548640" y="914400"/>
-            <a:ext cx="10972800" cy="369332"/>
+            <a:ext cx="8046720" cy="646331"/>
           </a:xfrm>
           <a:prstGeom prst="rect">
             <a:avLst/>
@@ -11396,15 +11446,46 @@
           <a:lstStyle/>
           <a:p>
             <a:r>
-              <a:rPr sz="1200" b="0">
+              <a:rPr sz="1200" b="0" dirty="0">
                 <a:solidFill>
                   <a:srgbClr val="333333"/>
                 </a:solidFill>
               </a:rPr>
               <a:t>M1 R²=0.086 → M2 R²=0.215 when traits added · M3 holdout r=0.35 (exploratory)
-Left table = M1 league gaps · Right table = M2 trait effects · M3 = holdout r only (no third chart needed)</a:t>
-            </a:r>
-            <a:endParaRPr sz="1300" b="0" dirty="0">
+Left table = M1 league gaps · Right table = M2 trait effects · M3 = holdout r only</a:t>
+            </a:r>
+            <a:endParaRPr lang="en-US" sz="1200" b="0" dirty="0">
+              <a:solidFill>
+                <a:srgbClr val="333333"/>
+              </a:solidFill>
+            </a:endParaRPr>
+          </a:p>
+          <a:p>
+            <a:r>
+              <a:rPr lang="en-US" sz="1200" dirty="0">
+                <a:solidFill>
+                  <a:srgbClr val="333333"/>
+                </a:solidFill>
+              </a:rPr>
+              <a:t>M3</a:t>
+            </a:r>
+            <a:r>
+              <a:rPr lang="en-US" sz="1200" b="1" dirty="0">
+                <a:solidFill>
+                  <a:srgbClr val="333333"/>
+                </a:solidFill>
+              </a:rPr>
+              <a:t>: </a:t>
+            </a:r>
+            <a:r>
+              <a:rPr lang="en-US" sz="1200" b="1" dirty="0"/>
+              <a:t>r ≈ 0.35 </a:t>
+            </a:r>
+            <a:r>
+              <a:rPr lang="en-US" sz="1200" dirty="0"/>
+              <a:t>means: on the 20% of players left out, predicted Y1 minutes lined up with actual minutes only moderately</a:t>
+            </a:r>
+            <a:endParaRPr sz="1200" dirty="0">
               <a:solidFill>
                 <a:srgbClr val="555555"/>
               </a:solidFill>
@@ -11419,11 +11500,17 @@
           <p:cNvGraphicFramePr>
             <a:graphicFrameLocks noGrp="1"/>
           </p:cNvGraphicFramePr>
-          <p:nvPr/>
+          <p:nvPr>
+            <p:extLst>
+              <p:ext uri="{D42A27DB-BD31-4B8C-83A1-F6EECF244321}">
+                <p14:modId xmlns:p14="http://schemas.microsoft.com/office/powerpoint/2010/main" val="2603676595"/>
+              </p:ext>
+            </p:extLst>
+          </p:nvPr>
         </p:nvGraphicFramePr>
         <p:xfrm>
-          <a:off x="548640" y="1325880"/>
-          <a:ext cx="3657600" cy="1170432"/>
+          <a:off x="548640" y="1786128"/>
+          <a:ext cx="3657600" cy="1136904"/>
         </p:xfrm>
         <a:graphic>
           <a:graphicData uri="http://schemas.openxmlformats.org/drawingml/2006/table">
@@ -11454,7 +11541,7 @@
                   </a:extLst>
                 </a:gridCol>
               </a:tblGrid>
-              <a:tr h="292608">
+              <a:tr h="0">
                 <a:tc>
                   <a:txBody>
                     <a:bodyPr/>
@@ -11704,7 +11791,7 @@
                     <a:p>
                       <a:pPr algn="ctr"/>
                       <a:r>
-                        <a:rPr sz="1100" b="0">
+                        <a:rPr sz="1100" b="0" dirty="0">
                           <a:solidFill>
                             <a:srgbClr val="1C1C1C"/>
                           </a:solidFill>
@@ -11732,11 +11819,17 @@
           <p:cNvGraphicFramePr>
             <a:graphicFrameLocks noGrp="1"/>
           </p:cNvGraphicFramePr>
-          <p:nvPr/>
+          <p:nvPr>
+            <p:extLst>
+              <p:ext uri="{D42A27DB-BD31-4B8C-83A1-F6EECF244321}">
+                <p14:modId xmlns:p14="http://schemas.microsoft.com/office/powerpoint/2010/main" val="2913298479"/>
+              </p:ext>
+            </p:extLst>
+          </p:nvPr>
         </p:nvGraphicFramePr>
         <p:xfrm>
-          <a:off x="4663440" y="1325880"/>
-          <a:ext cx="3657600" cy="1755648"/>
+          <a:off x="4663440" y="1786128"/>
+          <a:ext cx="3657600" cy="1722120"/>
         </p:xfrm>
         <a:graphic>
           <a:graphicData uri="http://schemas.openxmlformats.org/drawingml/2006/table">
@@ -11767,7 +11860,7 @@
                   </a:extLst>
                 </a:gridCol>
               </a:tblGrid>
-              <a:tr h="292608">
+              <a:tr h="0">
                 <a:tc>
                   <a:txBody>
                     <a:bodyPr/>
@@ -12107,13 +12200,22 @@
                     <a:p>
                       <a:pPr algn="ctr"/>
                       <a:r>
-                        <a:rPr sz="1100" b="0">
+                        <a:rPr sz="1100" b="0" dirty="0" err="1">
                           <a:solidFill>
                             <a:srgbClr val="1C1C1C"/>
                           </a:solidFill>
                           <a:latin typeface="Arial"/>
                         </a:rPr>
-                        <a:t>xG Per</a:t>
+                        <a:t>xG</a:t>
+                      </a:r>
+                      <a:r>
+                        <a:rPr sz="1100" b="0" dirty="0">
+                          <a:solidFill>
+                            <a:srgbClr val="1C1C1C"/>
+                          </a:solidFill>
+                          <a:latin typeface="Arial"/>
+                        </a:rPr>
+                        <a:t> Per</a:t>
                       </a:r>
                     </a:p>
                   </a:txBody>
@@ -12126,7 +12228,7 @@
                     <a:p>
                       <a:pPr algn="ctr"/>
                       <a:r>
-                        <a:rPr sz="1100" b="0">
+                        <a:rPr sz="1100" b="0" dirty="0">
                           <a:solidFill>
                             <a:srgbClr val="1C1C1C"/>
                           </a:solidFill>
@@ -12145,7 +12247,7 @@
                     <a:p>
                       <a:pPr algn="ctr"/>
                       <a:r>
-                        <a:rPr sz="1100" b="0">
+                        <a:rPr sz="1100" b="0" dirty="0">
                           <a:solidFill>
                             <a:srgbClr val="1C1C1C"/>
                           </a:solidFill>
@@ -12224,14 +12326,11 @@
             </a:r>
           </a:p>
           <a:p>
-            <a:r>
-              <a:rPr sz="1200" b="0">
-                <a:solidFill>
-                  <a:srgbClr val="333333"/>
-                </a:solidFill>
-              </a:rPr>
-              <a:t/>
-            </a:r>
+            <a:endParaRPr sz="1200" b="0">
+              <a:solidFill>
+                <a:srgbClr val="333333"/>
+              </a:solidFill>
+            </a:endParaRPr>
           </a:p>
           <a:p>
             <a:r>
@@ -12313,50 +12412,6 @@
       </p:grpSpPr>
       <p:sp>
         <p:nvSpPr>
-          <p:cNvPr id="2" name="Rectangle 1"/>
-          <p:cNvSpPr/>
-          <p:nvPr/>
-        </p:nvSpPr>
-        <p:spPr>
-          <a:xfrm>
-            <a:off x="0" y="0"/>
-            <a:ext cx="12191695" cy="6858000"/>
-          </a:xfrm>
-          <a:prstGeom prst="rect">
-            <a:avLst/>
-          </a:prstGeom>
-          <a:solidFill>
-            <a:srgbClr val="F7F5F2"/>
-          </a:solidFill>
-          <a:ln>
-            <a:noFill/>
-          </a:ln>
-        </p:spPr>
-        <p:style>
-          <a:lnRef idx="1">
-            <a:schemeClr val="accent1"/>
-          </a:lnRef>
-          <a:fillRef idx="3">
-            <a:schemeClr val="accent1"/>
-          </a:fillRef>
-          <a:effectRef idx="2">
-            <a:schemeClr val="accent1"/>
-          </a:effectRef>
-          <a:fontRef idx="minor">
-            <a:schemeClr val="lt1"/>
-          </a:fontRef>
-        </p:style>
-        <p:txBody>
-          <a:bodyPr rtlCol="0" anchor="ctr"/>
-          <a:lstStyle/>
-          <a:p>
-            <a:pPr algn="ctr"/>
-            <a:endParaRPr/>
-          </a:p>
-        </p:txBody>
-      </p:sp>
-      <p:sp>
-        <p:nvSpPr>
           <p:cNvPr id="3" name="TextBox 2"/>
           <p:cNvSpPr txBox="1"/>
           <p:nvPr/>
@@ -12383,16 +12438,13 @@
               </a:spcAft>
             </a:pPr>
             <a:r>
-              <a:rPr sz="2600" b="1" dirty="0">
-                <a:solidFill>
-                  <a:srgbClr val="3D5A80"/>
-                </a:solidFill>
-                <a:latin typeface="Calibri"/>
+              <a:rPr sz="1400" b="0">
+                <a:solidFill>
+                  <a:srgbClr val="333333"/>
+                </a:solidFill>
               </a:rPr>
               <a:t>Why p-values stay modest</a:t>
             </a:r>
-          </a:p>
-          <a:p>
             <a:endParaRPr sz="2600" b="1" dirty="0">
               <a:solidFill>
                 <a:srgbClr val="3D5A80"/>
@@ -12402,251 +12454,103 @@
           </a:p>
           <a:p>
             <a:r>
-              <a:rPr sz="1600" b="0" dirty="0">
+              <a:rPr sz="1400" b="0">
                 <a:solidFill>
                   <a:srgbClr val="333333"/>
                 </a:solidFill>
               </a:rPr>
-              <a:t>• </a:t>
-            </a:r>
-            <a:r>
-              <a:rPr sz="1600" b="0" dirty="0" err="1">
+              <a:t/>
+            </a:r>
+          </a:p>
+          <a:p>
+            <a:r>
+              <a:rPr sz="1400" b="0">
                 <a:solidFill>
                   <a:srgbClr val="333333"/>
                 </a:solidFill>
               </a:rPr>
-              <a:t>StatsBomb</a:t>
-            </a:r>
-            <a:r>
-              <a:rPr sz="1600" b="0" dirty="0">
+              <a:t>• StatsBomb N=96 with messy open-data priors (World Cup / Euro / Champions League mix rather than clean league seasons — larger sample, less consistent prior context)</a:t>
+            </a:r>
+          </a:p>
+          <a:p>
+            <a:r>
+              <a:rPr sz="1400" b="0">
                 <a:solidFill>
                   <a:srgbClr val="333333"/>
                 </a:solidFill>
               </a:rPr>
-              <a:t> N=96 with messy open-data priors (</a:t>
-            </a:r>
-            <a:r>
-              <a:rPr lang="en-US" sz="1600" b="0" dirty="0">
+              <a:t>• FBref N=329 helps, but many advanced metrics only have ~90–100 complete pairs</a:t>
+            </a:r>
+          </a:p>
+          <a:p>
+            <a:r>
+              <a:rPr sz="1400" b="0">
                 <a:solidFill>
                   <a:srgbClr val="333333"/>
                 </a:solidFill>
               </a:rPr>
-              <a:t>World Cup</a:t>
-            </a:r>
-            <a:r>
-              <a:rPr sz="1600" b="0" dirty="0">
+              <a:t>• Multiple traits tested — treat Phase 2 as associative, not a forecast</a:t>
+            </a:r>
+          </a:p>
+          <a:p>
+            <a:r>
+              <a:rPr sz="1400" b="0">
                 <a:solidFill>
                   <a:srgbClr val="333333"/>
                 </a:solidFill>
               </a:rPr>
-              <a:t> / Euro</a:t>
-            </a:r>
-            <a:r>
-              <a:rPr lang="en-US" sz="1600" b="0" dirty="0">
+              <a:t/>
+            </a:r>
+          </a:p>
+          <a:p>
+            <a:r>
+              <a:rPr sz="1400" b="0">
                 <a:solidFill>
                   <a:srgbClr val="333333"/>
                 </a:solidFill>
               </a:rPr>
-              <a:t> tournament</a:t>
-            </a:r>
-            <a:r>
-              <a:rPr sz="1600" b="0" dirty="0">
+              <a:t>What hardened the sample</a:t>
+            </a:r>
+          </a:p>
+          <a:p>
+            <a:r>
+              <a:rPr sz="1400" b="0">
                 <a:solidFill>
                   <a:srgbClr val="333333"/>
                 </a:solidFill>
               </a:rPr>
-              <a:t> / </a:t>
-            </a:r>
-            <a:r>
-              <a:rPr lang="en-US" sz="1600" b="0" dirty="0">
+              <a:t/>
+            </a:r>
+          </a:p>
+          <a:p>
+            <a:r>
+              <a:rPr sz="1400" b="0">
                 <a:solidFill>
                   <a:srgbClr val="333333"/>
                 </a:solidFill>
               </a:rPr>
-              <a:t>Champions League</a:t>
-            </a:r>
-            <a:r>
-              <a:rPr sz="1600" b="0" dirty="0">
+              <a:t>• 19 leagues · first BL seasons 2021–2025 · prior/Y1 ≥300′ → N=329</a:t>
+            </a:r>
+          </a:p>
+          <a:p>
+            <a:r>
+              <a:rPr sz="1400" b="0">
                 <a:solidFill>
                   <a:srgbClr val="333333"/>
                 </a:solidFill>
               </a:rPr>
-              <a:t> mix</a:t>
-            </a:r>
-            <a:r>
-              <a:rPr lang="en-US" sz="1600" b="0" dirty="0">
+              <a:t>• Category stability gates + light redundancy (|r|≥0.95) → 32 traits</a:t>
+            </a:r>
+          </a:p>
+          <a:p>
+            <a:r>
+              <a:rPr sz="1400" b="0">
                 <a:solidFill>
                   <a:srgbClr val="333333"/>
                 </a:solidFill>
               </a:rPr>
-              <a:t> rather than stock ‘league-based’ data – this allows for a larger player sample, but less consistent league and opponent label for each event</a:t>
-            </a:r>
-            <a:r>
-              <a:rPr sz="1600" b="0" dirty="0">
-                <a:solidFill>
-                  <a:srgbClr val="333333"/>
-                </a:solidFill>
-              </a:rPr>
-              <a:t>)</a:t>
-            </a:r>
-          </a:p>
-          <a:p>
-            <a:r>
-              <a:rPr sz="1600" b="0" dirty="0">
-                <a:solidFill>
-                  <a:srgbClr val="333333"/>
-                </a:solidFill>
-              </a:rPr>
-              <a:t>• </a:t>
-            </a:r>
-            <a:r>
-              <a:rPr sz="1600" b="0" dirty="0" err="1">
-                <a:solidFill>
-                  <a:srgbClr val="333333"/>
-                </a:solidFill>
-              </a:rPr>
-              <a:t>FBref</a:t>
-            </a:r>
-            <a:r>
-              <a:rPr sz="1600" b="0" dirty="0">
-                <a:solidFill>
-                  <a:srgbClr val="333333"/>
-                </a:solidFill>
-              </a:rPr>
-              <a:t> N=329 helps, but many advanced metrics only have ~90–100 complete pairs</a:t>
-            </a:r>
-            <a:r>
-              <a:rPr lang="en-US" sz="1600" b="0" dirty="0">
-                <a:solidFill>
-                  <a:srgbClr val="333333"/>
-                </a:solidFill>
-              </a:rPr>
-              <a:t> based on the venue, game, minutes etc.</a:t>
-            </a:r>
-            <a:endParaRPr sz="1600" b="0" dirty="0">
-              <a:solidFill>
-                <a:srgbClr val="333333"/>
-              </a:solidFill>
-            </a:endParaRPr>
-          </a:p>
-          <a:p>
-            <a:r>
-              <a:rPr sz="1600" b="0" dirty="0">
-                <a:solidFill>
-                  <a:srgbClr val="333333"/>
-                </a:solidFill>
-              </a:rPr>
-              <a:t>• Multiple traits tested — treat Phase 2 as associative, not a forecast</a:t>
-            </a:r>
-          </a:p>
-          <a:p>
-            <a:endParaRPr sz="1600" b="0" dirty="0">
-              <a:solidFill>
-                <a:srgbClr val="333333"/>
-              </a:solidFill>
-            </a:endParaRPr>
-          </a:p>
-          <a:p>
-            <a:r>
-              <a:rPr sz="1800" b="1" dirty="0">
-                <a:solidFill>
-                  <a:srgbClr val="222222"/>
-                </a:solidFill>
-              </a:rPr>
-              <a:t>What hardened the sample</a:t>
-            </a:r>
-          </a:p>
-          <a:p>
-            <a:endParaRPr sz="1800" b="1" dirty="0">
-              <a:solidFill>
-                <a:srgbClr val="222222"/>
-              </a:solidFill>
-            </a:endParaRPr>
-          </a:p>
-          <a:p>
-            <a:r>
-              <a:rPr sz="1600" b="0" dirty="0">
-                <a:solidFill>
-                  <a:srgbClr val="333333"/>
-                </a:solidFill>
-              </a:rPr>
-              <a:t>• 19 leagues · first BL </a:t>
-            </a:r>
-            <a:r>
-              <a:rPr lang="en-US" sz="1600" b="0" dirty="0">
-                <a:solidFill>
-                  <a:srgbClr val="333333"/>
-                </a:solidFill>
-              </a:rPr>
-              <a:t>season played: withing range </a:t>
-            </a:r>
-            <a:r>
-              <a:rPr sz="1600" b="0" dirty="0">
-                <a:solidFill>
-                  <a:srgbClr val="333333"/>
-                </a:solidFill>
-              </a:rPr>
-              <a:t>2021</a:t>
-            </a:r>
-            <a:r>
-              <a:rPr lang="en-US" sz="1600" b="0" dirty="0">
-                <a:solidFill>
-                  <a:srgbClr val="333333"/>
-                </a:solidFill>
-              </a:rPr>
-              <a:t>-2025</a:t>
-            </a:r>
-            <a:r>
-              <a:rPr sz="1600" b="0" dirty="0">
-                <a:solidFill>
-                  <a:srgbClr val="333333"/>
-                </a:solidFill>
-              </a:rPr>
-              <a:t> · prior/Y1 ≥300′ → N=329</a:t>
-            </a:r>
-          </a:p>
-          <a:p>
-            <a:r>
-              <a:rPr sz="1600" b="0" dirty="0">
-                <a:solidFill>
-                  <a:srgbClr val="333333"/>
-                </a:solidFill>
-              </a:rPr>
-              <a:t>• Category stability gates + light redundancy (|r|≥0.95) → 32 traits</a:t>
-            </a:r>
-          </a:p>
-          <a:p>
-            <a:r>
-              <a:rPr sz="1600" b="0" dirty="0">
-                <a:solidFill>
-                  <a:srgbClr val="333333"/>
-                </a:solidFill>
-              </a:rPr>
-              <a:t>• </a:t>
-            </a:r>
-            <a:r>
-              <a:rPr sz="1600" b="0" dirty="0" err="1">
-                <a:solidFill>
-                  <a:srgbClr val="333333"/>
-                </a:solidFill>
-              </a:rPr>
-              <a:t>StatsBomb</a:t>
-            </a:r>
-            <a:r>
-              <a:rPr sz="1600" b="0" dirty="0">
-                <a:solidFill>
-                  <a:srgbClr val="333333"/>
-                </a:solidFill>
-              </a:rPr>
-              <a:t> kept as event deep dive (r≥0.40 · 7 traits), not league ranking</a:t>
-            </a:r>
-          </a:p>
-          <a:p>
-            <a:endParaRPr sz="1600" b="0" dirty="0">
-              <a:solidFill>
-                <a:srgbClr val="333333"/>
-              </a:solidFill>
-            </a:endParaRPr>
+              <a:t>• StatsBomb kept as event deep dive (r≥0.40 · 7 traits), not league ranking</a:t>
+            </a:r>
           </a:p>
         </p:txBody>
       </p:sp>
@@ -15498,7 +15402,7 @@
         <p:spPr>
           <a:xfrm>
             <a:off x="731520" y="3063240"/>
-            <a:ext cx="10698480" cy="502920"/>
+            <a:ext cx="10698480" cy="292388"/>
           </a:xfrm>
           <a:prstGeom prst="rect">
             <a:avLst/>
@@ -15517,13 +15421,13 @@
               </a:spcAft>
             </a:pPr>
             <a:r>
-              <a:rPr sz="1300" b="0">
+              <a:rPr sz="1300" b="0" dirty="0">
                 <a:solidFill>
                   <a:srgbClr val="333333"/>
                 </a:solidFill>
                 <a:latin typeface="Calibri"/>
               </a:rPr>
-              <a:t>Stability → Redundancy → Pizza/explorer → Success.</a:t>
+              <a:t>Stability → Redundancy → Pizza/explorer → Success</a:t>
             </a:r>
           </a:p>
         </p:txBody>
@@ -17565,7 +17469,7 @@
         </p:nvSpPr>
         <p:spPr>
           <a:xfrm>
-            <a:off x="0" y="0"/>
+            <a:off x="0" y="-16411"/>
             <a:ext cx="12191695" cy="6858000"/>
           </a:xfrm>
           <a:prstGeom prst="rect">
@@ -17609,7 +17513,7 @@
         </p:nvSpPr>
         <p:spPr>
           <a:xfrm>
-            <a:off x="411480" y="182880"/>
+            <a:off x="411480" y="300110"/>
             <a:ext cx="10972800" cy="292388"/>
           </a:xfrm>
           <a:prstGeom prst="rect">
@@ -17659,8 +17563,8 @@
         </p:nvSpPr>
         <p:spPr>
           <a:xfrm>
-            <a:off x="411480" y="438912"/>
-            <a:ext cx="10972800" cy="2262158"/>
+            <a:off x="411480" y="1118846"/>
+            <a:ext cx="3036279" cy="2569934"/>
           </a:xfrm>
           <a:prstGeom prst="rect">
             <a:avLst/>
@@ -17673,23 +17577,48 @@
           </a:bodyPr>
           <a:lstStyle/>
           <a:p>
-            <a:pPr algn="l">
+            <a:pPr marL="171450" indent="-171450" algn="l">
               <a:spcAft>
                 <a:spcPts val="300"/>
               </a:spcAft>
+              <a:buFont typeface="Arial" panose="020B0604020202020204" pitchFamily="34" charset="0"/>
+              <a:buChar char="•"/>
             </a:pPr>
             <a:r>
-              <a:rPr sz="1200" b="0">
+              <a:rPr sz="1200" b="0" dirty="0">
                 <a:solidFill>
                   <a:srgbClr val="333333"/>
                 </a:solidFill>
               </a:rPr>
               <a:t>Prior league → first Bundesliga Y1 (end-year ≥2021)</a:t>
             </a:r>
-          </a:p>
-          <a:p>
-            <a:r>
-              <a:rPr sz="1200" b="0">
+            <a:endParaRPr lang="en-US" sz="1200" b="0" dirty="0">
+              <a:solidFill>
+                <a:srgbClr val="333333"/>
+              </a:solidFill>
+            </a:endParaRPr>
+          </a:p>
+          <a:p>
+            <a:pPr marL="171450" indent="-171450" algn="l">
+              <a:spcAft>
+                <a:spcPts val="300"/>
+              </a:spcAft>
+              <a:buFont typeface="Arial" panose="020B0604020202020204" pitchFamily="34" charset="0"/>
+              <a:buChar char="•"/>
+            </a:pPr>
+            <a:endParaRPr sz="1200" b="0" dirty="0">
+              <a:solidFill>
+                <a:srgbClr val="333333"/>
+              </a:solidFill>
+            </a:endParaRPr>
+          </a:p>
+          <a:p>
+            <a:pPr marL="171450" indent="-171450">
+              <a:buFont typeface="Arial" panose="020B0604020202020204" pitchFamily="34" charset="0"/>
+              <a:buChar char="•"/>
+            </a:pPr>
+            <a:r>
+              <a:rPr sz="1200" b="0" dirty="0">
                 <a:solidFill>
                   <a:srgbClr val="333333"/>
                 </a:solidFill>
@@ -17698,68 +17627,90 @@
             </a:r>
           </a:p>
           <a:p>
-            <a:r>
-              <a:rPr sz="1200" b="0">
+            <a:pPr marL="171450" indent="-171450">
+              <a:buFont typeface="Arial" panose="020B0604020202020204" pitchFamily="34" charset="0"/>
+              <a:buChar char="•"/>
+            </a:pPr>
+            <a:endParaRPr sz="1200" b="0" dirty="0">
+              <a:solidFill>
+                <a:srgbClr val="333333"/>
+              </a:solidFill>
+            </a:endParaRPr>
+          </a:p>
+          <a:p>
+            <a:pPr marL="171450" indent="-171450">
+              <a:buFont typeface="Arial" panose="020B0604020202020204" pitchFamily="34" charset="0"/>
+              <a:buChar char="•"/>
+            </a:pPr>
+            <a:r>
+              <a:rPr sz="1200" b="0" dirty="0">
                 <a:solidFill>
                   <a:srgbClr val="333333"/>
                 </a:solidFill>
               </a:rPr>
-              <a:t/>
-            </a:r>
-          </a:p>
-          <a:p>
-            <a:r>
-              <a:rPr sz="1200" b="0">
+              <a:t>Category gates (not one global cut):</a:t>
+            </a:r>
+          </a:p>
+          <a:p>
+            <a:pPr marL="171450" indent="-171450">
+              <a:buFont typeface="Arial" panose="020B0604020202020204" pitchFamily="34" charset="0"/>
+              <a:buChar char="•"/>
+            </a:pPr>
+            <a:r>
+              <a:rPr sz="1200" b="0" dirty="0">
                 <a:solidFill>
                   <a:srgbClr val="333333"/>
                 </a:solidFill>
               </a:rPr>
-              <a:t>Category gates (not one global cut):</a:t>
-            </a:r>
-          </a:p>
-          <a:p>
-            <a:r>
-              <a:rPr sz="1200" b="0">
+              <a:t>Attacking / Passing / Other  ·  r ≥ 0.60</a:t>
+            </a:r>
+          </a:p>
+          <a:p>
+            <a:pPr marL="171450" indent="-171450">
+              <a:buFont typeface="Arial" panose="020B0604020202020204" pitchFamily="34" charset="0"/>
+              <a:buChar char="•"/>
+            </a:pPr>
+            <a:r>
+              <a:rPr sz="1200" b="0" dirty="0">
                 <a:solidFill>
                   <a:srgbClr val="333333"/>
                 </a:solidFill>
               </a:rPr>
-              <a:t>Attacking / Passing / Other  ·  r ≥ 0.60</a:t>
-            </a:r>
-          </a:p>
-          <a:p>
-            <a:r>
-              <a:rPr sz="1200" b="0">
+              <a:t>Defending / Carrying  ·  r ≥ 0.50</a:t>
+            </a:r>
+          </a:p>
+          <a:p>
+            <a:pPr marL="171450" indent="-171450">
+              <a:buFont typeface="Arial" panose="020B0604020202020204" pitchFamily="34" charset="0"/>
+              <a:buChar char="•"/>
+            </a:pPr>
+            <a:endParaRPr sz="1200" b="0" dirty="0">
+              <a:solidFill>
+                <a:srgbClr val="333333"/>
+              </a:solidFill>
+            </a:endParaRPr>
+          </a:p>
+          <a:p>
+            <a:pPr marL="171450" indent="-171450">
+              <a:buFont typeface="Arial" panose="020B0604020202020204" pitchFamily="34" charset="0"/>
+              <a:buChar char="•"/>
+            </a:pPr>
+            <a:r>
+              <a:rPr sz="1200" b="0" dirty="0">
                 <a:solidFill>
                   <a:srgbClr val="333333"/>
                 </a:solidFill>
               </a:rPr>
-              <a:t>Defending / Carrying  ·  r ≥ 0.50</a:t>
-            </a:r>
-          </a:p>
-          <a:p>
-            <a:r>
-              <a:rPr sz="1200" b="0">
-                <a:solidFill>
-                  <a:srgbClr val="333333"/>
-                </a:solidFill>
-              </a:rPr>
-              <a:t/>
-            </a:r>
-          </a:p>
-          <a:p>
-            <a:r>
-              <a:rPr sz="1200" b="0">
-                <a:solidFill>
-                  <a:srgbClr val="333333"/>
-                </a:solidFill>
-              </a:rPr>
               <a:t>43 metrics pass gates → redundancy next</a:t>
             </a:r>
           </a:p>
           <a:p>
-            <a:r>
-              <a:rPr sz="1200" b="0">
+            <a:pPr marL="171450" indent="-171450">
+              <a:buFont typeface="Arial" panose="020B0604020202020204" pitchFamily="34" charset="0"/>
+              <a:buChar char="•"/>
+            </a:pPr>
+            <a:r>
+              <a:rPr sz="1200" b="0" dirty="0">
                 <a:solidFill>
                   <a:srgbClr val="333333"/>
                 </a:solidFill>
@@ -17775,11 +17726,17 @@
           <p:cNvGraphicFramePr>
             <a:graphicFrameLocks noGrp="1"/>
           </p:cNvGraphicFramePr>
-          <p:nvPr/>
+          <p:nvPr>
+            <p:extLst>
+              <p:ext uri="{D42A27DB-BD31-4B8C-83A1-F6EECF244321}">
+                <p14:modId xmlns:p14="http://schemas.microsoft.com/office/powerpoint/2010/main" val="856127445"/>
+              </p:ext>
+            </p:extLst>
+          </p:nvPr>
         </p:nvGraphicFramePr>
         <p:xfrm>
-          <a:off x="411480" y="1188720"/>
-          <a:ext cx="8321040" cy="5440680"/>
+          <a:off x="3447759" y="658148"/>
+          <a:ext cx="8321040" cy="5120640"/>
         </p:xfrm>
         <a:graphic>
           <a:graphicData uri="http://schemas.openxmlformats.org/drawingml/2006/table">
@@ -17839,9 +17796,9 @@
                         </a:defRPr>
                       </a:pPr>
                       <a:r>
-                        <a:rPr sz="1000" b="1">
-                          <a:solidFill>
-                            <a:srgbClr val="333333"/>
+                        <a:rPr sz="1000" b="1" dirty="0">
+                          <a:solidFill>
+                            <a:schemeClr val="bg1"/>
                           </a:solidFill>
                         </a:rPr>
                         <a:t>Abbrev</a:t>
@@ -17868,9 +17825,9 @@
                         </a:defRPr>
                       </a:pPr>
                       <a:r>
-                        <a:rPr sz="1000" b="1">
-                          <a:solidFill>
-                            <a:srgbClr val="333333"/>
+                        <a:rPr sz="1000" b="1" dirty="0">
+                          <a:solidFill>
+                            <a:schemeClr val="bg1"/>
                           </a:solidFill>
                         </a:rPr>
                         <a:t>Metric</a:t>
@@ -17897,9 +17854,9 @@
                         </a:defRPr>
                       </a:pPr>
                       <a:r>
-                        <a:rPr sz="1000" b="1">
-                          <a:solidFill>
-                            <a:srgbClr val="333333"/>
+                        <a:rPr sz="1000" b="1" dirty="0">
+                          <a:solidFill>
+                            <a:schemeClr val="bg1"/>
                           </a:solidFill>
                         </a:rPr>
                         <a:t>Category</a:t>
@@ -17926,9 +17883,9 @@
                         </a:defRPr>
                       </a:pPr>
                       <a:r>
-                        <a:rPr sz="1000" b="1">
-                          <a:solidFill>
-                            <a:srgbClr val="333333"/>
+                        <a:rPr sz="1000" b="1" dirty="0">
+                          <a:solidFill>
+                            <a:schemeClr val="bg1"/>
                           </a:solidFill>
                         </a:rPr>
                         <a:t>r</a:t>
@@ -17955,9 +17912,9 @@
                         </a:defRPr>
                       </a:pPr>
                       <a:r>
-                        <a:rPr sz="1000" b="1">
-                          <a:solidFill>
-                            <a:srgbClr val="333333"/>
+                        <a:rPr sz="1000" b="1" dirty="0">
+                          <a:solidFill>
+                            <a:schemeClr val="bg1"/>
                           </a:solidFill>
                         </a:rPr>
                         <a:t>N</a:t>
@@ -18107,7 +18064,7 @@
                         </a:defRPr>
                       </a:pPr>
                       <a:r>
-                        <a:rPr sz="1000">
+                        <a:rPr sz="1000" dirty="0">
                           <a:solidFill>
                             <a:srgbClr val="333333"/>
                           </a:solidFill>
@@ -18259,7 +18216,7 @@
                         </a:defRPr>
                       </a:pPr>
                       <a:r>
-                        <a:rPr sz="1000">
+                        <a:rPr sz="1000" dirty="0">
                           <a:solidFill>
                             <a:srgbClr val="333333"/>
                           </a:solidFill>
@@ -20879,7 +20836,7 @@
                         </a:defRPr>
                       </a:pPr>
                       <a:r>
-                        <a:rPr dirty="0" sz="1000">
+                        <a:rPr sz="1000" dirty="0">
                           <a:solidFill>
                             <a:srgbClr val="333333"/>
                           </a:solidFill>
@@ -20995,7 +20952,7 @@
                         </a:defRPr>
                       </a:pPr>
                       <a:r>
-                        <a:rPr dirty="0" sz="1000">
+                        <a:rPr sz="1000" dirty="0">
                           <a:solidFill>
                             <a:srgbClr val="333333"/>
                           </a:solidFill>
@@ -21191,7 +21148,7 @@
               </a:spcAft>
             </a:pPr>
             <a:r>
-              <a:rPr sz="1100" b="0">
+              <a:rPr sz="1100" b="0" dirty="0">
                 <a:solidFill>
                   <a:srgbClr val="333333"/>
                 </a:solidFill>
@@ -21200,148 +21157,161 @@
             </a:r>
           </a:p>
           <a:p>
-            <a:r>
-              <a:rPr sz="1100" b="0">
+            <a:endParaRPr sz="1100" b="0" dirty="0">
+              <a:solidFill>
+                <a:srgbClr val="333333"/>
+              </a:solidFill>
+            </a:endParaRPr>
+          </a:p>
+          <a:p>
+            <a:r>
+              <a:rPr sz="1100" b="0" dirty="0">
                 <a:solidFill>
                   <a:srgbClr val="333333"/>
                 </a:solidFill>
               </a:rPr>
-              <a:t/>
-            </a:r>
-          </a:p>
-          <a:p>
-            <a:r>
-              <a:rPr sz="1100" b="0">
+              <a:t>✓  PPC  Progressive passes (~10m+ toward goal)  r=0.74</a:t>
+            </a:r>
+          </a:p>
+          <a:p>
+            <a:r>
+              <a:rPr sz="1100" b="0" dirty="0">
                 <a:solidFill>
                   <a:srgbClr val="333333"/>
                 </a:solidFill>
               </a:rPr>
-              <a:t>✓  PPC  Progressive passes (~10m+ toward goal)  r=0.74</a:t>
-            </a:r>
-          </a:p>
-          <a:p>
-            <a:r>
-              <a:rPr sz="1100" b="0">
+              <a:t>✓  DIS  Dispossessed (inverted)  r=0.59</a:t>
+            </a:r>
+          </a:p>
+          <a:p>
+            <a:r>
+              <a:rPr sz="1100" b="0" dirty="0">
                 <a:solidFill>
                   <a:srgbClr val="333333"/>
                 </a:solidFill>
               </a:rPr>
-              <a:t>✓  DIS  Dispossessed (inverted)  r=0.59</a:t>
-            </a:r>
-          </a:p>
-          <a:p>
-            <a:r>
-              <a:rPr sz="1100" b="0">
+              <a:t>✓  PRS  Pressures  r=0.51</a:t>
+            </a:r>
+          </a:p>
+          <a:p>
+            <a:r>
+              <a:rPr sz="1100" b="0" dirty="0">
                 <a:solidFill>
                   <a:srgbClr val="333333"/>
                 </a:solidFill>
               </a:rPr>
-              <a:t>✓  PRS  Pressures  r=0.51</a:t>
-            </a:r>
-          </a:p>
-          <a:p>
-            <a:r>
-              <a:rPr sz="1100" b="0">
+              <a:t>✓  PAS  Pass volume  r=0.49</a:t>
+            </a:r>
+          </a:p>
+          <a:p>
+            <a:r>
+              <a:rPr sz="1100" b="0" dirty="0">
                 <a:solidFill>
                   <a:srgbClr val="333333"/>
                 </a:solidFill>
               </a:rPr>
-              <a:t>✓  PAS  Pass volume  r=0.49</a:t>
-            </a:r>
-          </a:p>
-          <a:p>
-            <a:r>
-              <a:rPr sz="1100" b="0">
+              <a:t>✓  CLR  Clearances  r=0.47</a:t>
+            </a:r>
+          </a:p>
+          <a:p>
+            <a:r>
+              <a:rPr sz="1100" b="0" dirty="0">
                 <a:solidFill>
                   <a:srgbClr val="333333"/>
                 </a:solidFill>
               </a:rPr>
-              <a:t>✓  CLR  Clearances  r=0.47</a:t>
-            </a:r>
-          </a:p>
-          <a:p>
-            <a:r>
-              <a:rPr sz="1100" b="0">
+              <a:t>✓  DRB  Successful dribbles  r=0.46</a:t>
+            </a:r>
+          </a:p>
+          <a:p>
+            <a:r>
+              <a:rPr sz="1100" b="0" dirty="0">
                 <a:solidFill>
                   <a:srgbClr val="333333"/>
                 </a:solidFill>
               </a:rPr>
-              <a:t>✓  DRB  Successful dribbles  r=0.46</a:t>
-            </a:r>
-          </a:p>
-          <a:p>
-            <a:r>
-              <a:rPr sz="1100" b="0">
+              <a:t>✓  PATT  Passes into final third  r=0.42</a:t>
+            </a:r>
+          </a:p>
+          <a:p>
+            <a:r>
+              <a:rPr sz="1100" b="0" dirty="0">
                 <a:solidFill>
                   <a:srgbClr val="333333"/>
                 </a:solidFill>
               </a:rPr>
-              <a:t>✓  PATT  Passes into final third  r=0.42</a:t>
-            </a:r>
-          </a:p>
-          <a:p>
-            <a:r>
-              <a:rPr sz="1100" b="0">
+              <a:t>·  SH  Shots  r=0.40</a:t>
+            </a:r>
+          </a:p>
+          <a:p>
+            <a:r>
+              <a:rPr sz="1100" b="0" dirty="0">
                 <a:solidFill>
                   <a:srgbClr val="333333"/>
                 </a:solidFill>
               </a:rPr>
-              <a:t>·  SH  Shots  r=0.40</a:t>
-            </a:r>
-          </a:p>
-          <a:p>
-            <a:r>
-              <a:rPr sz="1100" b="0">
+              <a:t>·  CFGP  Progressive carries  r=0.38</a:t>
+            </a:r>
+          </a:p>
+          <a:p>
+            <a:r>
+              <a:rPr sz="1100" b="0" dirty="0">
                 <a:solidFill>
                   <a:srgbClr val="333333"/>
                 </a:solidFill>
               </a:rPr>
-              <a:t>·  CFGP  Progressive carries  r=0.38</a:t>
-            </a:r>
-          </a:p>
-          <a:p>
-            <a:r>
-              <a:rPr sz="1100" b="0">
+              <a:t>·  CRY  Carries  r=0.38</a:t>
+            </a:r>
+          </a:p>
+          <a:p>
+            <a:r>
+              <a:rPr sz="1100" b="0" dirty="0">
                 <a:solidFill>
                   <a:srgbClr val="333333"/>
                 </a:solidFill>
               </a:rPr>
-              <a:t>·  CRY  Carries  r=0.38</a:t>
-            </a:r>
-          </a:p>
-          <a:p>
-            <a:r>
-              <a:rPr sz="1100" b="0">
+              <a:t>·  TAC  Tackles  r=0.34</a:t>
+            </a:r>
+          </a:p>
+          <a:p>
+            <a:r>
+              <a:rPr sz="1100" b="0" dirty="0">
                 <a:solidFill>
                   <a:srgbClr val="333333"/>
                 </a:solidFill>
               </a:rPr>
-              <a:t>·  TAC  Tackles  r=0.34</a:t>
-            </a:r>
-          </a:p>
-          <a:p>
-            <a:r>
-              <a:rPr sz="1100" b="0">
+              <a:t>·  XG  Non-pen </a:t>
+            </a:r>
+            <a:r>
+              <a:rPr sz="1100" b="0" dirty="0" err="1">
                 <a:solidFill>
                   <a:srgbClr val="333333"/>
                 </a:solidFill>
               </a:rPr>
-              <a:t>·  XG  Non-pen xG  r=0.30</a:t>
-            </a:r>
-          </a:p>
-          <a:p>
-            <a:r>
-              <a:rPr sz="1100" b="0">
+              <a:t>xG</a:t>
+            </a:r>
+            <a:r>
+              <a:rPr sz="1100" b="0" dirty="0">
                 <a:solidFill>
                   <a:srgbClr val="333333"/>
                 </a:solidFill>
               </a:rPr>
+              <a:t>  r=0.30</a:t>
+            </a:r>
+          </a:p>
+          <a:p>
+            <a:r>
+              <a:rPr sz="1100" b="0" dirty="0">
+                <a:solidFill>
+                  <a:srgbClr val="333333"/>
+                </a:solidFill>
+              </a:rPr>
               <a:t>·  FLW  Fouls won  r=0.27</a:t>
             </a:r>
           </a:p>
           <a:p>
             <a:r>
-              <a:rPr sz="1100" b="0">
+              <a:rPr sz="1100" b="0" dirty="0">
                 <a:solidFill>
                   <a:srgbClr val="333333"/>
                 </a:solidFill>
@@ -21351,7 +21321,7 @@
           </a:p>
           <a:p>
             <a:r>
-              <a:rPr sz="1100" b="0">
+              <a:rPr sz="1100" b="0" dirty="0">
                 <a:solidFill>
                   <a:srgbClr val="333333"/>
                 </a:solidFill>
@@ -21361,7 +21331,7 @@
           </a:p>
           <a:p>
             <a:r>
-              <a:rPr sz="1100" b="0">
+              <a:rPr sz="1100" b="0" dirty="0">
                 <a:solidFill>
                   <a:srgbClr val="333333"/>
                 </a:solidFill>
@@ -21377,11 +21347,17 @@
           <p:cNvGraphicFramePr>
             <a:graphicFrameLocks noGrp="1"/>
           </p:cNvGraphicFramePr>
-          <p:nvPr/>
+          <p:nvPr>
+            <p:extLst>
+              <p:ext uri="{D42A27DB-BD31-4B8C-83A1-F6EECF244321}">
+                <p14:modId xmlns:p14="http://schemas.microsoft.com/office/powerpoint/2010/main" val="2041602011"/>
+              </p:ext>
+            </p:extLst>
+          </p:nvPr>
         </p:nvGraphicFramePr>
         <p:xfrm>
-          <a:off x="411480" y="1234440"/>
-          <a:ext cx="9144000" cy="4663440"/>
+          <a:off x="386862" y="1234440"/>
+          <a:ext cx="9168618" cy="4663440"/>
         </p:xfrm>
         <a:graphic>
           <a:graphicData uri="http://schemas.openxmlformats.org/drawingml/2006/table">
@@ -21390,7 +21366,7 @@
                 <a:tableStyleId>{5C22544A-7EE6-4342-B048-85BDC9FD1C3A}</a:tableStyleId>
               </a:tblPr>
               <a:tblGrid>
-                <a:gridCol w="1005840">
+                <a:gridCol w="1030458">
                   <a:extLst>
                     <a:ext uri="{9D8B030D-6E8A-4147-A177-3AD203B41FA5}">
                       <a16:colId xmlns:a16="http://schemas.microsoft.com/office/drawing/2014/main" val="20000"/>
@@ -21441,12 +21417,41 @@
                         </a:defRPr>
                       </a:pPr>
                       <a:r>
+                        <a:rPr sz="1000" b="1" dirty="0">
+                          <a:solidFill>
+                            <a:srgbClr val="333333"/>
+                          </a:solidFill>
+                        </a:rPr>
+                        <a:t>Abbrev</a:t>
+                      </a:r>
+                    </a:p>
+                  </a:txBody>
+                  <a:tcPr>
+                    <a:solidFill>
+                      <a:srgbClr val="1C1C1C"/>
+                    </a:solidFill>
+                  </a:tcPr>
+                </a:tc>
+                <a:tc>
+                  <a:txBody>
+                    <a:bodyPr/>
+                    <a:lstStyle/>
+                    <a:p>
+                      <a:pPr>
+                        <a:defRPr sz="1200" b="1">
+                          <a:solidFill>
+                            <a:srgbClr val="FFFFFF"/>
+                          </a:solidFill>
+                          <a:latin typeface="Calibri"/>
+                        </a:defRPr>
+                      </a:pPr>
+                      <a:r>
                         <a:rPr sz="1000" b="1">
                           <a:solidFill>
                             <a:srgbClr val="333333"/>
                           </a:solidFill>
                         </a:rPr>
-                        <a:t>Abbrev</a:t>
+                        <a:t>Metric</a:t>
                       </a:r>
                     </a:p>
                   </a:txBody>
@@ -21475,7 +21480,7 @@
                             <a:srgbClr val="333333"/>
                           </a:solidFill>
                         </a:rPr>
-                        <a:t>Metric</a:t>
+                        <a:t>Category</a:t>
                       </a:r>
                     </a:p>
                   </a:txBody>
@@ -21504,7 +21509,7 @@
                             <a:srgbClr val="333333"/>
                           </a:solidFill>
                         </a:rPr>
-                        <a:t>Category</a:t>
+                        <a:t>r</a:t>
                       </a:r>
                     </a:p>
                   </a:txBody>
@@ -21528,36 +21533,7 @@
                         </a:defRPr>
                       </a:pPr>
                       <a:r>
-                        <a:rPr sz="1000" b="1">
-                          <a:solidFill>
-                            <a:srgbClr val="333333"/>
-                          </a:solidFill>
-                        </a:rPr>
-                        <a:t>r</a:t>
-                      </a:r>
-                    </a:p>
-                  </a:txBody>
-                  <a:tcPr>
-                    <a:solidFill>
-                      <a:srgbClr val="1C1C1C"/>
-                    </a:solidFill>
-                  </a:tcPr>
-                </a:tc>
-                <a:tc>
-                  <a:txBody>
-                    <a:bodyPr/>
-                    <a:lstStyle/>
-                    <a:p>
-                      <a:pPr>
-                        <a:defRPr sz="1200" b="1">
-                          <a:solidFill>
-                            <a:srgbClr val="FFFFFF"/>
-                          </a:solidFill>
-                          <a:latin typeface="Calibri"/>
-                        </a:defRPr>
-                      </a:pPr>
-                      <a:r>
-                        <a:rPr sz="1000" b="1">
+                        <a:rPr sz="1000" b="1" dirty="0">
                           <a:solidFill>
                             <a:srgbClr val="333333"/>
                           </a:solidFill>
@@ -23989,7 +23965,7 @@
                         </a:defRPr>
                       </a:pPr>
                       <a:r>
-                        <a:rPr sz="1000">
+                        <a:rPr sz="1000" dirty="0">
                           <a:solidFill>
                             <a:srgbClr val="333333"/>
                           </a:solidFill>
@@ -24114,10 +24090,18 @@
           </a:fontRef>
         </p:style>
         <p:txBody>
-          <a:bodyPr rtlCol="0" anchor="ctr"/>
+          <a:bodyPr rtlCol="0" anchor="ctr" wrap="square"/>
           <a:lstStyle/>
           <a:p>
             <a:pPr algn="ctr"/>
+            <a:r>
+              <a:rPr sz="1100" b="0">
+                <a:solidFill>
+                  <a:srgbClr val="333333"/>
+                </a:solidFill>
+              </a:rPr>
+              <a:t>XG (0.80)  ·  SHPER (0.79)  ·  SOTPE (0.77)  ·  GLS (0.66)</a:t>
+            </a:r>
             <a:endParaRPr/>
           </a:p>
         </p:txBody>
@@ -24252,7 +24236,7 @@
         </p:nvSpPr>
         <p:spPr>
           <a:xfrm>
-            <a:off x="640080" y="1097280"/>
+            <a:off x="651803" y="1413801"/>
             <a:ext cx="4937760" cy="320040"/>
           </a:xfrm>
           <a:prstGeom prst="rect">
@@ -24441,7 +24425,7 @@
         </p:nvSpPr>
         <p:spPr>
           <a:xfrm>
-            <a:off x="640080" y="4963434"/>
+            <a:off x="651803" y="5279955"/>
             <a:ext cx="4937760" cy="640080"/>
           </a:xfrm>
           <a:prstGeom prst="rect">
@@ -24526,7 +24510,7 @@
         </p:nvSpPr>
         <p:spPr>
           <a:xfrm>
-            <a:off x="6309360" y="1097280"/>
+            <a:off x="6321083" y="1413801"/>
             <a:ext cx="5212080" cy="1405513"/>
           </a:xfrm>
           <a:prstGeom prst="rect">
@@ -24546,207 +24530,62 @@
               </a:spcAft>
             </a:pPr>
             <a:r>
-              <a:rPr sz="1600" b="1" dirty="0" err="1">
-                <a:solidFill>
-                  <a:srgbClr val="3D5A80"/>
-                </a:solidFill>
-                <a:latin typeface="Calibri"/>
-              </a:rPr>
-              <a:t>FBref</a:t>
-            </a:r>
-            <a:r>
-              <a:rPr sz="1600" b="1" dirty="0">
-                <a:solidFill>
-                  <a:srgbClr val="3D5A80"/>
-                </a:solidFill>
-                <a:latin typeface="Calibri"/>
-              </a:rPr>
-              <a:t>: 43 gated → 32 kept</a:t>
-            </a:r>
-          </a:p>
-          <a:p>
-            <a:pPr>
-              <a:spcAft>
-                <a:spcPts val="200"/>
-              </a:spcAft>
-            </a:pPr>
-            <a:r>
-              <a:rPr sz="1200" b="0" dirty="0">
-                <a:solidFill>
-                  <a:srgbClr val="555555"/>
-                </a:solidFill>
-                <a:latin typeface="Calibri"/>
+              <a:rPr sz="1200" b="0">
+                <a:solidFill>
+                  <a:srgbClr val="333333"/>
+                </a:solidFill>
+              </a:rPr>
+              <a:t>FBref: 43 gated → 32 kept</a:t>
+            </a:r>
+          </a:p>
+          <a:p>
+            <a:r>
+              <a:rPr sz="1200" b="0">
+                <a:solidFill>
+                  <a:srgbClr val="333333"/>
+                </a:solidFill>
               </a:rPr>
               <a:t>105 tested · category gates → 43 · |r|≥0.95 → 32</a:t>
             </a:r>
           </a:p>
           <a:p>
-            <a:pPr>
-              <a:spcAft>
-                <a:spcPts val="200"/>
-              </a:spcAft>
-            </a:pPr>
-            <a:r>
-              <a:rPr sz="1200" b="0" dirty="0">
-                <a:solidFill>
-                  <a:srgbClr val="555555"/>
-                </a:solidFill>
-                <a:latin typeface="Calibri"/>
+            <a:r>
+              <a:rPr sz="1200" b="0">
+                <a:solidFill>
+                  <a:srgbClr val="333333"/>
+                </a:solidFill>
               </a:rPr>
               <a:t>Pick order: stability → N → rate/contextual</a:t>
             </a:r>
           </a:p>
           <a:p>
-            <a:pPr>
-              <a:spcAft>
-                <a:spcPts val="200"/>
-              </a:spcAft>
-            </a:pPr>
-            <a:r>
-              <a:rPr sz="1200" b="0" dirty="0">
-                <a:solidFill>
-                  <a:srgbClr val="555555"/>
-                </a:solidFill>
-                <a:latin typeface="Calibri"/>
-              </a:rPr>
-              <a:t>Force-kept: </a:t>
-            </a:r>
-            <a:r>
-              <a:rPr sz="1200" b="0" dirty="0" err="1">
-                <a:solidFill>
-                  <a:srgbClr val="555555"/>
-                </a:solidFill>
-                <a:latin typeface="Calibri"/>
-              </a:rPr>
-              <a:t>SoT</a:t>
-            </a:r>
-            <a:r>
-              <a:rPr sz="1200" b="0" dirty="0">
-                <a:solidFill>
-                  <a:srgbClr val="555555"/>
-                </a:solidFill>
-                <a:latin typeface="Calibri"/>
-              </a:rPr>
-              <a:t>/90 · </a:t>
-            </a:r>
-            <a:r>
-              <a:rPr sz="1200" b="0" dirty="0" err="1">
-                <a:solidFill>
-                  <a:srgbClr val="555555"/>
-                </a:solidFill>
-                <a:latin typeface="Calibri"/>
-              </a:rPr>
-              <a:t>Gls</a:t>
-            </a:r>
-            <a:r>
-              <a:rPr sz="1200" b="0" dirty="0">
-                <a:solidFill>
-                  <a:srgbClr val="555555"/>
-                </a:solidFill>
-                <a:latin typeface="Calibri"/>
-              </a:rPr>
-              <a:t>/90 · </a:t>
-            </a:r>
-            <a:r>
-              <a:rPr sz="1200" b="0" dirty="0" err="1">
-                <a:solidFill>
-                  <a:srgbClr val="555555"/>
-                </a:solidFill>
-                <a:latin typeface="Calibri"/>
-              </a:rPr>
-              <a:t>Tkld</a:t>
-            </a:r>
-            <a:r>
-              <a:rPr sz="1200" b="0" dirty="0">
-                <a:solidFill>
-                  <a:srgbClr val="555555"/>
-                </a:solidFill>
-                <a:latin typeface="Calibri"/>
-              </a:rPr>
-              <a:t> Take · </a:t>
-            </a:r>
-            <a:r>
-              <a:rPr sz="1200" b="0" dirty="0" err="1">
-                <a:solidFill>
-                  <a:srgbClr val="555555"/>
-                </a:solidFill>
-                <a:latin typeface="Calibri"/>
-              </a:rPr>
-              <a:t>Att</a:t>
-            </a:r>
-            <a:r>
-              <a:rPr sz="1200" b="0" dirty="0">
-                <a:solidFill>
-                  <a:srgbClr val="555555"/>
-                </a:solidFill>
-                <a:latin typeface="Calibri"/>
-              </a:rPr>
-              <a:t> Total</a:t>
-            </a:r>
-          </a:p>
-          <a:p>
-            <a:pPr>
-              <a:spcAft>
-                <a:spcPts val="200"/>
-              </a:spcAft>
-            </a:pPr>
-            <a:endParaRPr sz="1200" b="0" dirty="0">
-              <a:solidFill>
-                <a:srgbClr val="555555"/>
-              </a:solidFill>
-              <a:latin typeface="Calibri"/>
-            </a:endParaRPr>
-          </a:p>
-          <a:p>
-            <a:pPr>
-              <a:spcAft>
-                <a:spcPts val="200"/>
-              </a:spcAft>
-            </a:pPr>
-            <a:r>
-              <a:rPr sz="1300" b="0" dirty="0">
+            <a:r>
+              <a:rPr sz="1200" b="0">
                 <a:solidFill>
                   <a:srgbClr val="333333"/>
                 </a:solidFill>
-                <a:latin typeface="Calibri"/>
-              </a:rPr>
-              <a:t>Top: Def Pen Touches (0.91) · </a:t>
-            </a:r>
-            <a:r>
-              <a:rPr sz="1300" b="0" dirty="0" err="1">
+              </a:rPr>
+              <a:t>Force-kept: SoT/90 · Gls/90 · Tkld Take · Att Total</a:t>
+            </a:r>
+          </a:p>
+          <a:p>
+            <a:r>
+              <a:rPr sz="1200" b="0">
                 <a:solidFill>
                   <a:srgbClr val="333333"/>
                 </a:solidFill>
-                <a:latin typeface="Calibri"/>
-              </a:rPr>
-              <a:t>PrgC</a:t>
-            </a:r>
-            <a:r>
-              <a:rPr sz="1300" b="0" dirty="0">
+              </a:rPr>
+              <a:t/>
+            </a:r>
+          </a:p>
+          <a:p>
+            <a:r>
+              <a:rPr sz="1200" b="0">
                 <a:solidFill>
                   <a:srgbClr val="333333"/>
                 </a:solidFill>
-                <a:latin typeface="Calibri"/>
-              </a:rPr>
-              <a:t> (0.81) · </a:t>
-            </a:r>
-            <a:r>
-              <a:rPr sz="1300" b="0" dirty="0" err="1">
-                <a:solidFill>
-                  <a:srgbClr val="333333"/>
-                </a:solidFill>
-                <a:latin typeface="Calibri"/>
-              </a:rPr>
-              <a:t>xG</a:t>
-            </a:r>
-            <a:r>
-              <a:rPr sz="1300" b="0" dirty="0">
-                <a:solidFill>
-                  <a:srgbClr val="333333"/>
-                </a:solidFill>
-                <a:latin typeface="Calibri"/>
-              </a:rPr>
-              <a:t> (0.80)</a:t>
+              </a:rPr>
+              <a:t>Top: DEFPE (0.91) · PRGC (0.81) · XG (0.80)</a:t>
             </a:r>
           </a:p>
         </p:txBody>
@@ -24759,7 +24598,7 @@
         </p:nvSpPr>
         <p:spPr>
           <a:xfrm>
-            <a:off x="6309360" y="1988820"/>
+            <a:off x="6321083" y="2305341"/>
             <a:ext cx="5212080" cy="237744"/>
           </a:xfrm>
           <a:prstGeom prst="rect">
@@ -24775,13 +24614,12 @@
           <a:p>
             <a:pPr algn="l"/>
             <a:r>
-              <a:rPr sz="1200" b="1">
-                <a:solidFill>
-                  <a:srgbClr val="3D5A80"/>
-                </a:solidFill>
-                <a:latin typeface="Calibri"/>
-              </a:rPr>
-              <a:t>Attacking (3)</a:t>
+              <a:rPr sz="1400" b="1">
+                <a:solidFill>
+                  <a:srgbClr val="222222"/>
+                </a:solidFill>
+              </a:rPr>
+              <a:t>Attacking (4)</a:t>
             </a:r>
           </a:p>
         </p:txBody>
@@ -24794,7 +24632,7 @@
         </p:nvSpPr>
         <p:spPr>
           <a:xfrm>
-            <a:off x="6309360" y="2494908"/>
+            <a:off x="6321083" y="2811429"/>
             <a:ext cx="5212080" cy="237744"/>
           </a:xfrm>
           <a:prstGeom prst="rect">
@@ -24810,13 +24648,12 @@
           <a:p>
             <a:pPr algn="l"/>
             <a:r>
-              <a:rPr sz="1200" b="1" dirty="0">
-                <a:solidFill>
-                  <a:srgbClr val="3D5A80"/>
-                </a:solidFill>
-                <a:latin typeface="Calibri"/>
-              </a:rPr>
-              <a:t>Passing (7)</a:t>
+              <a:rPr sz="1400" b="1">
+                <a:solidFill>
+                  <a:srgbClr val="222222"/>
+                </a:solidFill>
+              </a:rPr>
+              <a:t>Passing (13)</a:t>
             </a:r>
           </a:p>
         </p:txBody>
@@ -24829,7 +24666,7 @@
         </p:nvSpPr>
         <p:spPr>
           <a:xfrm>
-            <a:off x="6309360" y="2732652"/>
+            <a:off x="6321083" y="3049173"/>
             <a:ext cx="5212080" cy="384048"/>
           </a:xfrm>
           <a:prstGeom prst="rect">
@@ -24847,11 +24684,10 @@
             <a:r>
               <a:rPr sz="1100" b="0">
                 <a:solidFill>
-                  <a:srgbClr val="1C1C1C"/>
-                </a:solidFill>
-                <a:latin typeface="Calibri"/>
-              </a:rPr>
-              <a:t>PRGC (0.89)  ·  PRGDI (0.87)  ·  KP (0.76)  ·  FINAL (0.70)  ·  CMPPE (0.69)  ·  CRSPA (0.66)  ·  CRS (0.64)</a:t>
+                  <a:srgbClr val="333333"/>
+                </a:solidFill>
+              </a:rPr>
+              <a:t>PRGC (0.81)  ·  PRGDI (0.79)  ·  NPXGP (0.79)  ·  CMPME (0.73)  ·  TOTDI (0.72)  ·  PRGR (0.70)  ·  CRS (0.68)  ·  KP (0.65)  ·  CMPPE (0.64)  ·  XAG (0.64)  ·  FINAL (0.62)  ·  CMPPE (0.62)  ·  CMPPE (0.61)</a:t>
             </a:r>
           </a:p>
         </p:txBody>
@@ -24864,7 +24700,7 @@
         </p:nvSpPr>
         <p:spPr>
           <a:xfrm>
-            <a:off x="6309360" y="3171564"/>
+            <a:off x="6321083" y="3488085"/>
             <a:ext cx="5212080" cy="237744"/>
           </a:xfrm>
           <a:prstGeom prst="rect">
@@ -24880,13 +24716,12 @@
           <a:p>
             <a:pPr algn="l"/>
             <a:r>
-              <a:rPr sz="1200" b="1">
-                <a:solidFill>
-                  <a:srgbClr val="3D5A80"/>
-                </a:solidFill>
-                <a:latin typeface="Calibri"/>
-              </a:rPr>
-              <a:t>Carrying (4)</a:t>
+              <a:rPr sz="1400" b="1">
+                <a:solidFill>
+                  <a:srgbClr val="222222"/>
+                </a:solidFill>
+              </a:rPr>
+              <a:t>Carrying (5)</a:t>
             </a:r>
           </a:p>
         </p:txBody>
@@ -24899,7 +24734,7 @@
         </p:nvSpPr>
         <p:spPr>
           <a:xfrm>
-            <a:off x="6309360" y="3409308"/>
+            <a:off x="6321083" y="3725829"/>
             <a:ext cx="5212080" cy="384048"/>
           </a:xfrm>
           <a:prstGeom prst="rect">
@@ -24917,11 +24752,10 @@
             <a:r>
               <a:rPr sz="1100" b="0">
                 <a:solidFill>
-                  <a:srgbClr val="1C1C1C"/>
-                </a:solidFill>
-                <a:latin typeface="Calibri"/>
-              </a:rPr>
-              <a:t>PRGRR (0.77)  ·  ATT3R (0.73)  ·  SUCC (0.71)  ·  MIS (0.68)</a:t>
+                  <a:srgbClr val="333333"/>
+                </a:solidFill>
+              </a:rPr>
+              <a:t>PRGC (0.68)  ·  CPA (0.66)  ·  SUCC (0.65)  ·  PRGRR (0.60)  ·  ATT3R (0.54)</a:t>
             </a:r>
           </a:p>
         </p:txBody>
@@ -24934,7 +24768,7 @@
         </p:nvSpPr>
         <p:spPr>
           <a:xfrm>
-            <a:off x="6309360" y="3848220"/>
+            <a:off x="6321083" y="4164741"/>
             <a:ext cx="5212080" cy="237744"/>
           </a:xfrm>
           <a:prstGeom prst="rect">
@@ -24950,13 +24784,12 @@
           <a:p>
             <a:pPr algn="l"/>
             <a:r>
-              <a:rPr sz="1200" b="1">
-                <a:solidFill>
-                  <a:srgbClr val="3D5A80"/>
-                </a:solidFill>
-                <a:latin typeface="Calibri"/>
-              </a:rPr>
-              <a:t>Defending (11)</a:t>
+              <a:rPr sz="1400" b="1">
+                <a:solidFill>
+                  <a:srgbClr val="222222"/>
+                </a:solidFill>
+              </a:rPr>
+              <a:t>Defending (6)</a:t>
             </a:r>
           </a:p>
         </p:txBody>
@@ -24969,7 +24802,7 @@
         </p:nvSpPr>
         <p:spPr>
           <a:xfrm>
-            <a:off x="6309360" y="4085964"/>
+            <a:off x="6321083" y="4402485"/>
             <a:ext cx="5212080" cy="384048"/>
           </a:xfrm>
           <a:prstGeom prst="rect">
@@ -24987,11 +24820,10 @@
             <a:r>
               <a:rPr sz="1100" b="0">
                 <a:solidFill>
-                  <a:srgbClr val="1C1C1C"/>
-                </a:solidFill>
-                <a:latin typeface="Calibri"/>
-              </a:rPr>
-              <a:t>DEFPE (0.92)  ·  CLR (0.72)  ·  TKLD (0.71)  ·  WON (0.71)  ·  SH (0.69)  ·  INT (0.65)  ·  LOST (0.64)  ·  WONPE (0.57)  ·  DEF3R (0.54)  ·  TKLPE (0.51)  ·  RECOV (0.50)</a:t>
+                  <a:srgbClr val="333333"/>
+                </a:solidFill>
+              </a:rPr>
+              <a:t>DEFPE (0.91)  ·  DEF3R (0.79)  ·  SH (0.68)  ·  CLR (0.67)  ·  TKLD (0.59)  ·  INT (0.57)</a:t>
             </a:r>
           </a:p>
         </p:txBody>
@@ -25004,7 +24836,7 @@
         </p:nvSpPr>
         <p:spPr>
           <a:xfrm>
-            <a:off x="6309360" y="4524876"/>
+            <a:off x="6321083" y="4841397"/>
             <a:ext cx="5212080" cy="237744"/>
           </a:xfrm>
           <a:prstGeom prst="rect">
@@ -25020,13 +24852,12 @@
           <a:p>
             <a:pPr algn="l"/>
             <a:r>
-              <a:rPr sz="1200" b="1">
-                <a:solidFill>
-                  <a:srgbClr val="3D5A80"/>
-                </a:solidFill>
-                <a:latin typeface="Calibri"/>
-              </a:rPr>
-              <a:t>Other (1)</a:t>
+              <a:rPr sz="1400" b="1">
+                <a:solidFill>
+                  <a:srgbClr val="222222"/>
+                </a:solidFill>
+              </a:rPr>
+              <a:t>Other (4)</a:t>
             </a:r>
           </a:p>
         </p:txBody>
@@ -25039,7 +24870,7 @@
         </p:nvSpPr>
         <p:spPr>
           <a:xfrm>
-            <a:off x="6309360" y="4762620"/>
+            <a:off x="6321083" y="5079141"/>
             <a:ext cx="5212080" cy="384048"/>
           </a:xfrm>
           <a:prstGeom prst="rect">
@@ -25057,11 +24888,10 @@
             <a:r>
               <a:rPr sz="1100" b="0">
                 <a:solidFill>
-                  <a:srgbClr val="1C1C1C"/>
-                </a:solidFill>
-                <a:latin typeface="Calibri"/>
-              </a:rPr>
-              <a:t>FLD (0.59)</a:t>
+                  <a:srgbClr val="333333"/>
+                </a:solidFill>
+              </a:rPr>
+              <a:t>ATTLO (0.79)  ·  GPLUS (0.70)  ·  FK (0.70)  ·  ATT (0.65)</a:t>
             </a:r>
           </a:p>
         </p:txBody>

</xml_diff>

<commit_message>
Fix slide-9 category rs to match current shortlist values.
Co-authored-by: Cursor <cursoragent@cursor.com>
</commit_message>
<xml_diff>
--- a/bundesliga_transfer_traits.pptx
+++ b/bundesliga_transfer_traits.pptx
@@ -24095,12 +24095,12 @@
           <a:p>
             <a:pPr algn="ctr"/>
             <a:r>
-              <a:rPr sz="1100" b="0">
+              <a:rPr sz="1200" b="0">
                 <a:solidFill>
                   <a:srgbClr val="333333"/>
                 </a:solidFill>
               </a:rPr>
-              <a:t>XG (0.80)  ·  SHPER (0.79)  ·  SOTPE (0.77)  ·  GLS (0.66)</a:t>
+              <a:t/>
             </a:r>
             <a:endParaRPr/>
           </a:p>
@@ -24619,7 +24619,7 @@
                   <a:srgbClr val="222222"/>
                 </a:solidFill>
               </a:rPr>
-              <a:t>Attacking (4)</a:t>
+              <a:t>Attacking (3)</a:t>
             </a:r>
           </a:p>
         </p:txBody>
@@ -24653,7 +24653,7 @@
                   <a:srgbClr val="222222"/>
                 </a:solidFill>
               </a:rPr>
-              <a:t>Passing (13)</a:t>
+              <a:t>Passing (7)</a:t>
             </a:r>
           </a:p>
         </p:txBody>
@@ -24687,7 +24687,7 @@
                   <a:srgbClr val="333333"/>
                 </a:solidFill>
               </a:rPr>
-              <a:t>PRGC (0.81)  ·  PRGDI (0.79)  ·  NPXGP (0.79)  ·  CMPME (0.73)  ·  TOTDI (0.72)  ·  PRGR (0.70)  ·  CRS (0.68)  ·  KP (0.65)  ·  CMPPE (0.64)  ·  XAG (0.64)  ·  FINAL (0.62)  ·  CMPPE (0.62)  ·  CMPPE (0.61)</a:t>
+              <a:t>XG (0.80)  ·  GLS (0.66)  ·  ATTSH (0.56)</a:t>
             </a:r>
           </a:p>
         </p:txBody>
@@ -24721,7 +24721,7 @@
                   <a:srgbClr val="222222"/>
                 </a:solidFill>
               </a:rPr>
-              <a:t>Carrying (5)</a:t>
+              <a:t>Carrying (4)</a:t>
             </a:r>
           </a:p>
         </p:txBody>
@@ -24755,7 +24755,7 @@
                   <a:srgbClr val="333333"/>
                 </a:solidFill>
               </a:rPr>
-              <a:t>PRGC (0.68)  ·  CPA (0.66)  ·  SUCC (0.65)  ·  PRGRR (0.60)  ·  ATT3R (0.54)</a:t>
+              <a:t>PRGC (0.81)  ·  PRGDI (0.79)  ·  KP (0.65)  ·  FINAL (0.62)  ·  CMPPE (0.64)  ·  CRSPA (0.59)  ·  CRS (0.68)</a:t>
             </a:r>
           </a:p>
         </p:txBody>
@@ -24789,7 +24789,7 @@
                   <a:srgbClr val="222222"/>
                 </a:solidFill>
               </a:rPr>
-              <a:t>Defending (6)</a:t>
+              <a:t>Defending (11)</a:t>
             </a:r>
           </a:p>
         </p:txBody>
@@ -24823,7 +24823,7 @@
                   <a:srgbClr val="333333"/>
                 </a:solidFill>
               </a:rPr>
-              <a:t>DEFPE (0.91)  ·  DEF3R (0.79)  ·  SH (0.68)  ·  CLR (0.67)  ·  TKLD (0.59)  ·  INT (0.57)</a:t>
+              <a:t>PRGRR (0.60)  ·  ATT3R (0.54)  ·  SUCC (0.65)  ·  MIS (0.37)</a:t>
             </a:r>
           </a:p>
         </p:txBody>
@@ -24857,7 +24857,7 @@
                   <a:srgbClr val="222222"/>
                 </a:solidFill>
               </a:rPr>
-              <a:t>Other (4)</a:t>
+              <a:t>Other (1)</a:t>
             </a:r>
           </a:p>
         </p:txBody>
@@ -24891,7 +24891,7 @@
                   <a:srgbClr val="333333"/>
                 </a:solidFill>
               </a:rPr>
-              <a:t>ATTLO (0.79)  ·  GPLUS (0.70)  ·  FK (0.70)  ·  ATT (0.65)</a:t>
+              <a:t>DEFPE (0.91)  ·  CLR (0.67)  ·  TKLD (0.59)  ·  WON (0.42)  ·  SH (0.79)  ·  INT (0.57)  ·  LOST (0.42)  ·  WONPE (0.50)  ·  DEF3R (0.79)  ·  TKLPE (0.31)  ·  RECOV (0.40)</a:t>
             </a:r>
           </a:p>
         </p:txBody>

</xml_diff>

<commit_message>
Fix slide-9 FBref category chip layout and current rs.
Co-authored-by: Cursor <cursoragent@cursor.com>
</commit_message>
<xml_diff>
--- a/bundesliga_transfer_traits.pptx
+++ b/bundesliga_transfer_traits.pptx
@@ -24575,16 +24575,6 @@
                   <a:srgbClr val="333333"/>
                 </a:solidFill>
               </a:rPr>
-              <a:t/>
-            </a:r>
-          </a:p>
-          <a:p>
-            <a:r>
-              <a:rPr sz="1200" b="0">
-                <a:solidFill>
-                  <a:srgbClr val="333333"/>
-                </a:solidFill>
-              </a:rPr>
               <a:t>Top: DEFPE (0.91) · PRGC (0.81) · XG (0.80)</a:t>
             </a:r>
           </a:p>
@@ -24598,7 +24588,7 @@
         </p:nvSpPr>
         <p:spPr>
           <a:xfrm>
-            <a:off x="6321083" y="2305341"/>
+            <a:off x="6318504" y="2304288"/>
             <a:ext cx="5212080" cy="237744"/>
           </a:xfrm>
           <a:prstGeom prst="rect">
@@ -24614,7 +24604,7 @@
           <a:p>
             <a:pPr algn="l"/>
             <a:r>
-              <a:rPr sz="1400" b="1">
+              <a:rPr sz="1300" b="1">
                 <a:solidFill>
                   <a:srgbClr val="222222"/>
                 </a:solidFill>
@@ -24632,7 +24622,7 @@
         </p:nvSpPr>
         <p:spPr>
           <a:xfrm>
-            <a:off x="6321083" y="2811429"/>
+            <a:off x="6318504" y="2926080"/>
             <a:ext cx="5212080" cy="237744"/>
           </a:xfrm>
           <a:prstGeom prst="rect">
@@ -24648,7 +24638,7 @@
           <a:p>
             <a:pPr algn="l"/>
             <a:r>
-              <a:rPr sz="1400" b="1">
+              <a:rPr sz="1300" b="1">
                 <a:solidFill>
                   <a:srgbClr val="222222"/>
                 </a:solidFill>
@@ -24666,8 +24656,8 @@
         </p:nvSpPr>
         <p:spPr>
           <a:xfrm>
-            <a:off x="6321083" y="3049173"/>
-            <a:ext cx="5212080" cy="384048"/>
+            <a:off x="6318504" y="2542032"/>
+            <a:ext cx="5394960" cy="365760"/>
           </a:xfrm>
           <a:prstGeom prst="rect">
             <a:avLst/>
@@ -24700,7 +24690,7 @@
         </p:nvSpPr>
         <p:spPr>
           <a:xfrm>
-            <a:off x="6321083" y="3488085"/>
+            <a:off x="6318504" y="3611880"/>
             <a:ext cx="5212080" cy="237744"/>
           </a:xfrm>
           <a:prstGeom prst="rect">
@@ -24716,7 +24706,7 @@
           <a:p>
             <a:pPr algn="l"/>
             <a:r>
-              <a:rPr sz="1400" b="1">
+              <a:rPr sz="1300" b="1">
                 <a:solidFill>
                   <a:srgbClr val="222222"/>
                 </a:solidFill>
@@ -24734,8 +24724,8 @@
         </p:nvSpPr>
         <p:spPr>
           <a:xfrm>
-            <a:off x="6321083" y="3725829"/>
-            <a:ext cx="5212080" cy="384048"/>
+            <a:off x="6318504" y="3163824"/>
+            <a:ext cx="5394960" cy="365760"/>
           </a:xfrm>
           <a:prstGeom prst="rect">
             <a:avLst/>
@@ -24768,7 +24758,7 @@
         </p:nvSpPr>
         <p:spPr>
           <a:xfrm>
-            <a:off x="6321083" y="4164741"/>
+            <a:off x="6318504" y="4297680"/>
             <a:ext cx="5212080" cy="237744"/>
           </a:xfrm>
           <a:prstGeom prst="rect">
@@ -24784,7 +24774,7 @@
           <a:p>
             <a:pPr algn="l"/>
             <a:r>
-              <a:rPr sz="1400" b="1">
+              <a:rPr sz="1300" b="1">
                 <a:solidFill>
                   <a:srgbClr val="222222"/>
                 </a:solidFill>
@@ -24802,8 +24792,8 @@
         </p:nvSpPr>
         <p:spPr>
           <a:xfrm>
-            <a:off x="6321083" y="4402485"/>
-            <a:ext cx="5212080" cy="384048"/>
+            <a:off x="6318504" y="3849624"/>
+            <a:ext cx="5394960" cy="365760"/>
           </a:xfrm>
           <a:prstGeom prst="rect">
             <a:avLst/>
@@ -24836,7 +24826,7 @@
         </p:nvSpPr>
         <p:spPr>
           <a:xfrm>
-            <a:off x="6321083" y="4841397"/>
+            <a:off x="6318504" y="5074920"/>
             <a:ext cx="5212080" cy="237744"/>
           </a:xfrm>
           <a:prstGeom prst="rect">
@@ -24852,7 +24842,7 @@
           <a:p>
             <a:pPr algn="l"/>
             <a:r>
-              <a:rPr sz="1400" b="1">
+              <a:rPr sz="1300" b="1">
                 <a:solidFill>
                   <a:srgbClr val="222222"/>
                 </a:solidFill>
@@ -24870,8 +24860,8 @@
         </p:nvSpPr>
         <p:spPr>
           <a:xfrm>
-            <a:off x="6321083" y="5079141"/>
-            <a:ext cx="5212080" cy="384048"/>
+            <a:off x="6318504" y="4535424"/>
+            <a:ext cx="5394960" cy="502920"/>
           </a:xfrm>
           <a:prstGeom prst="rect">
             <a:avLst/>
@@ -24892,6 +24882,39 @@
                 </a:solidFill>
               </a:rPr>
               <a:t>DEFPE (0.91)  ·  CLR (0.67)  ·  TKLD (0.59)  ·  WON (0.42)  ·  SH (0.79)  ·  INT (0.57)  ·  LOST (0.42)  ·  WONPE (0.50)  ·  DEF3R (0.79)  ·  TKLPE (0.31)  ·  RECOV (0.40)</a:t>
+            </a:r>
+          </a:p>
+        </p:txBody>
+      </p:sp>
+      <p:sp>
+        <p:nvSpPr>
+          <p:cNvPr id="30" name="TextBox 29"/>
+          <p:cNvSpPr txBox="1"/>
+          <p:nvPr/>
+        </p:nvSpPr>
+        <p:spPr>
+          <a:xfrm>
+            <a:off x="6318504" y="5312664"/>
+            <a:ext cx="5394960" cy="365760"/>
+          </a:xfrm>
+          <a:prstGeom prst="rect">
+            <a:avLst/>
+          </a:prstGeom>
+          <a:noFill/>
+        </p:spPr>
+        <p:txBody>
+          <a:bodyPr wrap="square">
+            <a:spAutoFit/>
+          </a:bodyPr>
+          <a:lstStyle/>
+          <a:p>
+            <a:r>
+              <a:rPr sz="1100" b="0">
+                <a:solidFill>
+                  <a:srgbClr val="333333"/>
+                </a:solidFill>
+              </a:rPr>
+              <a:t>FLD (0.53)</a:t>
             </a:r>
           </a:p>
         </p:txBody>

</xml_diff>

<commit_message>
Clarify proposal and deck language for external readers.
Spell out the pipeline, metric floors, and league-relative scaling; add a glossary slide and keep absolute per-90 rates after peer scaling failed.

Co-authored-by: Cursor <cursoragent@cursor.com>
</commit_message>
<xml_diff>
--- a/bundesliga_transfer_traits.pptx
+++ b/bundesliga_transfer_traits.pptx
@@ -26,6 +26,7 @@
     <p:sldId id="280" r:id="rId20"/>
     <p:sldId id="278" r:id="rId21"/>
     <p:sldId id="277" r:id="rId22"/>
+    <p:sldId id="284" r:id="rId28"/>
     <p:sldId id="279" r:id="rId23"/>
   </p:sldIdLst>
   <p:sldSz cx="12192000" cy="6858000"/>
@@ -3679,50 +3680,62 @@
           <a:p>
             <a:pPr algn="l"/>
             <a:r>
-              <a:rPr sz="1300" b="0">
-                <a:solidFill>
-                  <a:srgbClr val="333333"/>
-                </a:solidFill>
-                <a:latin typeface="Georgia"/>
+              <a:rPr sz="1200" b="0">
+                <a:solidFill>
+                  <a:srgbClr val="333333"/>
+                </a:solidFill>
               </a:rPr>
               <a:t>How to read</a:t>
             </a:r>
           </a:p>
           <a:p>
             <a:r>
-              <a:rPr sz="1300" b="0">
-                <a:solidFill>
-                  <a:srgbClr val="333333"/>
-                </a:solidFill>
-              </a:rPr>
-              <a:t>Blue = BL Y1 · red dotted = prior · dashed = avg (50) · grey = top (90).</a:t>
-            </a:r>
-          </a:p>
-          <a:p>
-            <a:r>
-              <a:rPr sz="1300" b="0">
-                <a:solidFill>
-                  <a:srgbClr val="333333"/>
-                </a:solidFill>
-              </a:rPr>
-              <a:t>Percentiles 0–100 vs position peers.</a:t>
-            </a:r>
-          </a:p>
-          <a:p>
-            <a:endParaRPr sz="1300" b="0">
-              <a:solidFill>
-                <a:srgbClr val="333333"/>
-              </a:solidFill>
-            </a:endParaRPr>
-          </a:p>
-          <a:p>
-            <a:r>
-              <a:rPr sz="1300" b="0">
+              <a:rPr sz="1200" b="0">
+                <a:solidFill>
+                  <a:srgbClr val="333333"/>
+                </a:solidFill>
+              </a:rPr>
+              <a:t>Blue = Bundesliga Year-1 · red dotted = prior · dashed = 50th-percentile Bundesliga peer · grey = 90th-percentile Bundesliga peer.</a:t>
+            </a:r>
+          </a:p>
+          <a:p>
+            <a:r>
+              <a:rPr sz="1200" b="0">
+                <a:solidFill>
+                  <a:srgbClr val="333333"/>
+                </a:solidFill>
+              </a:rPr>
+              <a:t>Numbers are percentiles 0–100 vs position peers.</a:t>
+            </a:r>
+          </a:p>
+          <a:p>
+            <a:r>
+              <a:rPr sz="1200" b="0">
+                <a:solidFill>
+                  <a:srgbClr val="333333"/>
+                </a:solidFill>
+              </a:rPr>
+              <a:t/>
+            </a:r>
+          </a:p>
+          <a:p>
+            <a:r>
+              <a:rPr sz="1200" b="0">
                 <a:solidFill>
                   <a:srgbClr val="333333"/>
                 </a:solidFill>
               </a:rPr>
               <a:t>Explorer: StatsBomb N=96 · 7 traits · FBref N=329 · 32 traits.</a:t>
+            </a:r>
+          </a:p>
+          <a:p>
+            <a:r>
+              <a:rPr sz="1200" b="0">
+                <a:solidFill>
+                  <a:srgbClr val="333333"/>
+                </a:solidFill>
+              </a:rPr>
+              <a:t>Metric abbreviations: see Glossary slide (click codes on stability/success slides where linked).</a:t>
             </a:r>
           </a:p>
         </p:txBody>
@@ -5455,7 +5468,7 @@
                 </a:solidFill>
                 <a:latin typeface="Georgia"/>
               </a:rPr>
-              <a:t>Which prior traits &amp; leagues line up with BL Year-1 success?</a:t>
+              <a:t>Which prior traits &amp; leagues line up with Bundesliga Year-1 success?</a:t>
             </a:r>
           </a:p>
         </p:txBody>
@@ -6178,7 +6191,7 @@
                 </a:solidFill>
                 <a:latin typeface="Calibri"/>
               </a:rPr>
-              <a:t>Interpretation: positive </a:t>
+              <a:t>Interpretation: positive ρ = arriving with a higher prior percentile on that trait tends to coincide with more Bundesliga Year-1 minutes / higher trait score.</a:t>
             </a:r>
             <a:r>
               <a:rPr sz="1300" dirty="0" err="1">
@@ -6187,7 +6200,7 @@
                 </a:solidFill>
                 <a:latin typeface="Calibri"/>
               </a:rPr>
-              <a:t>ρ</a:t>
+              <a:t/>
             </a:r>
             <a:r>
               <a:rPr sz="1300" dirty="0">
@@ -6196,7 +6209,7 @@
                 </a:solidFill>
                 <a:latin typeface="Calibri"/>
               </a:rPr>
-              <a:t> = arriving with a higher prior percentile on that trait tends to coincide with more BL Y1 minutes / higher trait score.</a:t>
+              <a:t/>
             </a:r>
           </a:p>
           <a:p>
@@ -6775,13 +6788,13 @@
           <a:lstStyle/>
           <a:p>
             <a:r>
-              <a:rPr sz="1300" b="1">
+              <a:rPr sz="2000" b="1">
                 <a:solidFill>
                   <a:srgbClr val="3D5A80"/>
                 </a:solidFill>
                 <a:latin typeface="Calibri"/>
               </a:rPr>
-              <a:t>RESULTS  ·  TRAITS → BL SUCCESS</a:t>
+              <a:t>RESULTS  ·  TRAITS → BUNDESLIGA SUCCESS</a:t>
             </a:r>
           </a:p>
         </p:txBody>
@@ -7668,19 +7681,22 @@
             </a:r>
           </a:p>
           <a:p>
-            <a:endParaRPr sz="1200" b="0">
-              <a:solidFill>
-                <a:srgbClr val="333333"/>
-              </a:solidFill>
-            </a:endParaRPr>
-          </a:p>
-          <a:p>
             <a:r>
               <a:rPr sz="1200" b="0">
                 <a:solidFill>
                   <a:srgbClr val="333333"/>
                 </a:solidFill>
               </a:rPr>
+              <a:t/>
+            </a:r>
+          </a:p>
+          <a:p>
+            <a:r>
+              <a:rPr sz="1200" b="0">
+                <a:solidFill>
+                  <a:srgbClr val="333333"/>
+                </a:solidFill>
+              </a:rPr>
               <a:t>FINAL  ρ=+0.30  p=0.005 *</a:t>
             </a:r>
           </a:p>
@@ -7735,20 +7751,33 @@
             </a:r>
           </a:p>
           <a:p>
-            <a:endParaRPr sz="1200" b="0">
-              <a:solidFill>
-                <a:srgbClr val="333333"/>
-              </a:solidFill>
-            </a:endParaRPr>
-          </a:p>
-          <a:p>
             <a:r>
               <a:rPr sz="1200" b="0">
                 <a:solidFill>
                   <a:srgbClr val="333333"/>
                 </a:solidFill>
               </a:rPr>
+              <a:t/>
+            </a:r>
+          </a:p>
+          <a:p>
+            <a:r>
+              <a:rPr sz="1200" b="0">
+                <a:solidFill>
+                  <a:srgbClr val="333333"/>
+                </a:solidFill>
+              </a:rPr>
               <a:t>* p&lt;0.05  ·  Final Third, shot blocks, progressive distance lead.</a:t>
+            </a:r>
+          </a:p>
+          <a:p>
+            <a:r>
+              <a:rPr sz="1200" b="0">
+                <a:solidFill>
+                  <a:srgbClr val="333333"/>
+                </a:solidFill>
+              </a:rPr>
+              <a:t>Metric codes: see Glossary slide.</a:t>
             </a:r>
           </a:p>
         </p:txBody>
@@ -8627,6 +8656,41 @@
           </a:graphicData>
         </a:graphic>
       </p:graphicFrame>
+      <p:sp>
+        <p:nvSpPr>
+          <p:cNvPr id="9" name="TextBox 8">
+            <a:hlinkClick action="ppaction://hlinksldjump" r:id="rId2"/>
+          </p:cNvPr>
+          <p:cNvSpPr txBox="1"/>
+          <p:nvPr/>
+        </p:nvSpPr>
+        <p:spPr>
+          <a:xfrm>
+            <a:off x="9875520" y="137160"/>
+            <a:ext cx="2011680" cy="320040"/>
+          </a:xfrm>
+          <a:prstGeom prst="rect">
+            <a:avLst/>
+          </a:prstGeom>
+          <a:noFill/>
+        </p:spPr>
+        <p:txBody>
+          <a:bodyPr wrap="square">
+            <a:spAutoFit/>
+          </a:bodyPr>
+          <a:lstStyle/>
+          <a:p>
+            <a:r>
+              <a:rPr sz="1200" b="1">
+                <a:solidFill>
+                  <a:srgbClr val="3D5A80"/>
+                </a:solidFill>
+              </a:rPr>
+              <a:t>→ Glossary</a:t>
+            </a:r>
+          </a:p>
+        </p:txBody>
+      </p:sp>
     </p:spTree>
   </p:cSld>
   <p:clrMapOvr>
@@ -8719,13 +8783,13 @@
           <a:lstStyle/>
           <a:p>
             <a:r>
-              <a:rPr sz="1300" b="1">
+              <a:rPr sz="2000" b="1">
                 <a:solidFill>
                   <a:srgbClr val="3D5A80"/>
                 </a:solidFill>
                 <a:latin typeface="Calibri"/>
               </a:rPr>
-              <a:t>RESULTS  ·  FEEDER LEAGUES → BL SUCCESS</a:t>
+              <a:t>RESULTS  ·  FEEDER LEAGUES → BUNDESLIGA SUCCESS</a:t>
             </a:r>
           </a:p>
         </p:txBody>
@@ -11026,7 +11090,7 @@
                   <a:srgbClr val="555555"/>
                 </a:solidFill>
               </a:rPr>
-              <a:t>FBref N=329 (n≥8 shown). StatsBomb N=96 — intl priors are directional only.</a:t>
+              <a:t>FBref N=329 (n≥8 players per league shown). StatsBomb N=96 — international priors are directional only.</a:t>
             </a:r>
           </a:p>
           <a:p>
@@ -11169,31 +11233,12 @@
           <a:p>
             <a:pPr algn="l"/>
             <a:r>
-              <a:rPr b="0" dirty="0">
-                <a:solidFill>
-                  <a:srgbClr val="333333"/>
-                </a:solidFill>
-                <a:latin typeface="Georgia"/>
-              </a:rPr>
-              <a:t>Descriptive “best feeder</a:t>
-            </a:r>
-            <a:r>
-              <a:rPr lang="en-US" b="0" dirty="0">
-                <a:solidFill>
-                  <a:srgbClr val="333333"/>
-                </a:solidFill>
-                <a:latin typeface="Georgia"/>
-              </a:rPr>
-              <a:t> league</a:t>
-            </a:r>
-            <a:r>
-              <a:rPr b="0" dirty="0">
-                <a:solidFill>
-                  <a:srgbClr val="333333"/>
-                </a:solidFill>
-                <a:latin typeface="Georgia"/>
-              </a:rPr>
-              <a:t>” is not enough — OLS vs Serie A baseline.</a:t>
+              <a:rPr sz="1300" b="0">
+                <a:solidFill>
+                  <a:srgbClr val="333333"/>
+                </a:solidFill>
+              </a:rPr>
+              <a:t>Descriptive “best feeder league” averages are not enough — ordinary least squares (OLS) regression asks whether league gaps remain after controls.</a:t>
             </a:r>
           </a:p>
         </p:txBody>
@@ -11225,96 +11270,136 @@
           </a:bodyPr>
           <a:lstStyle/>
           <a:p>
-            <a:r>
-              <a:rPr lang="en-US" b="1" dirty="0"/>
-              <a:t>Model 1</a:t>
-            </a:r>
-            <a:r>
-              <a:rPr lang="en-US" dirty="0"/>
-              <a:t> — league only (with basic controls)</a:t>
-            </a:r>
             <a:br>
               <a:rPr lang="en-US" dirty="0"/>
             </a:br>
             <a:r>
-              <a:rPr lang="en-US" dirty="0"/>
-              <a:t>Predict Y1 minutes from:</a:t>
-            </a:r>
-          </a:p>
-          <a:p>
-            <a:r>
-              <a:rPr lang="en-US" dirty="0"/>
-              <a:t>prior league (PL / La Liga / Ligue 1 vs Serie A)</a:t>
-            </a:r>
-          </a:p>
-          <a:p>
-            <a:r>
-              <a:rPr lang="en-US" dirty="0"/>
-              <a:t>How many minutes they played before.</a:t>
-            </a:r>
-          </a:p>
-          <a:p>
-            <a:r>
-              <a:rPr lang="en-US" i="1" dirty="0"/>
-              <a:t>Question:</a:t>
-            </a:r>
-            <a:r>
-              <a:rPr lang="en-US" dirty="0"/>
-              <a:t> After that, does league still matter?</a:t>
-            </a:r>
-          </a:p>
-          <a:p>
-            <a:r>
-              <a:rPr lang="en-US" b="1" dirty="0"/>
-              <a:t>Model 2</a:t>
-            </a:r>
-            <a:r>
-              <a:rPr lang="en-US" dirty="0"/>
-              <a:t> — league + traits</a:t>
-            </a:r>
-            <a:br>
-              <a:rPr lang="en-US" dirty="0"/>
-            </a:br>
-            <a:r>
-              <a:rPr lang="en-US" dirty="0"/>
-              <a:t>Same as M1, plus prior trait percentiles (Final Third, box touches, etc.).</a:t>
-            </a:r>
-          </a:p>
-          <a:p>
-            <a:r>
-              <a:rPr lang="en-US" i="1" dirty="0"/>
-              <a:t>Question:</a:t>
-            </a:r>
-            <a:r>
-              <a:rPr lang="en-US" dirty="0"/>
-              <a:t> Once you know their prior profile, do league gaps shrink? </a:t>
-            </a:r>
-          </a:p>
-          <a:p>
-            <a:r>
-              <a:rPr lang="en-US" b="1" dirty="0"/>
-              <a:t>Model 3</a:t>
-            </a:r>
-            <a:r>
-              <a:rPr lang="en-US" dirty="0"/>
-              <a:t> — reality check</a:t>
-            </a:r>
-            <a:br>
-              <a:rPr lang="en-US" dirty="0"/>
-            </a:br>
-            <a:r>
-              <a:rPr lang="en-US" dirty="0"/>
-              <a:t>Fit on 80% of players, see if predictions match the other 20%.</a:t>
-            </a:r>
-          </a:p>
-          <a:p>
-            <a:r>
-              <a:rPr lang="en-US" i="1" dirty="0"/>
-              <a:t>Question:</a:t>
-            </a:r>
-            <a:r>
-              <a:rPr lang="en-US" dirty="0"/>
-              <a:t> Is this just memorizing the sample? </a:t>
+              <a:rPr sz="1200" b="0">
+                <a:solidFill>
+                  <a:srgbClr val="333333"/>
+                </a:solidFill>
+              </a:rPr>
+              <a:t>Model 1 — league only (with basic controls)</a:t>
+            </a:r>
+          </a:p>
+          <a:p>
+            <a:r>
+              <a:rPr sz="1200" b="0">
+                <a:solidFill>
+                  <a:srgbClr val="333333"/>
+                </a:solidFill>
+              </a:rPr>
+              <a:t>Predict Year-1 Bundesliga minutes from prior league (Premier League / La Liga / Ligue 1 vs Serie A baseline), prior minutes, and position.</a:t>
+            </a:r>
+          </a:p>
+          <a:p>
+            <a:r>
+              <a:rPr sz="1200" b="0">
+                <a:solidFill>
+                  <a:srgbClr val="333333"/>
+                </a:solidFill>
+              </a:rPr>
+              <a:t>Question: after that, does league still matter?</a:t>
+            </a:r>
+          </a:p>
+          <a:p>
+            <a:r>
+              <a:rPr sz="1200" b="0">
+                <a:solidFill>
+                  <a:srgbClr val="333333"/>
+                </a:solidFill>
+              </a:rPr>
+              <a:t/>
+            </a:r>
+          </a:p>
+          <a:p>
+            <a:r>
+              <a:rPr sz="1200" b="0">
+                <a:solidFill>
+                  <a:srgbClr val="333333"/>
+                </a:solidFill>
+              </a:rPr>
+              <a:t>Model 2 — league + traits</a:t>
+            </a:r>
+          </a:p>
+          <a:p>
+            <a:r>
+              <a:rPr sz="1200" b="0">
+                <a:solidFill>
+                  <a:srgbClr val="333333"/>
+                </a:solidFill>
+              </a:rPr>
+              <a:t>Same as Model 1, plus prior trait percentiles (e.g. Final Third, box touches).</a:t>
+            </a:r>
+          </a:p>
+          <a:p>
+            <a:r>
+              <a:rPr sz="1200" b="0">
+                <a:solidFill>
+                  <a:srgbClr val="333333"/>
+                </a:solidFill>
+              </a:rPr>
+              <a:t>Question: once you know the prior profile, do league gaps shrink?</a:t>
+            </a:r>
+          </a:p>
+          <a:p>
+            <a:r>
+              <a:rPr sz="1200" b="0">
+                <a:solidFill>
+                  <a:srgbClr val="333333"/>
+                </a:solidFill>
+              </a:rPr>
+              <a:t/>
+            </a:r>
+          </a:p>
+          <a:p>
+            <a:r>
+              <a:rPr sz="1200" b="0">
+                <a:solidFill>
+                  <a:srgbClr val="333333"/>
+                </a:solidFill>
+              </a:rPr>
+              <a:t>Model 3 — holdout check</a:t>
+            </a:r>
+          </a:p>
+          <a:p>
+            <a:r>
+              <a:rPr sz="1200" b="0">
+                <a:solidFill>
+                  <a:srgbClr val="333333"/>
+                </a:solidFill>
+              </a:rPr>
+              <a:t>Fit on 80% of players; see if predictions match the other 20%.</a:t>
+            </a:r>
+          </a:p>
+          <a:p>
+            <a:r>
+              <a:rPr sz="1200" b="0">
+                <a:solidFill>
+                  <a:srgbClr val="333333"/>
+                </a:solidFill>
+              </a:rPr>
+              <a:t>Question: is the fit just memorizing this sample?</a:t>
+            </a:r>
+          </a:p>
+          <a:p>
+            <a:r>
+              <a:rPr sz="1200" b="0">
+                <a:solidFill>
+                  <a:srgbClr val="333333"/>
+                </a:solidFill>
+              </a:rPr>
+              <a:t/>
+            </a:r>
+          </a:p>
+          <a:p>
+            <a:r>
+              <a:rPr sz="1200" b="0">
+                <a:solidFill>
+                  <a:srgbClr val="333333"/>
+                </a:solidFill>
+              </a:rPr>
+              <a:t>Serie A is the baseline league (lowest average Year-1 minutes among Big-5 feeders), so other leagues are estimated as “extra minutes vs Serie A.”</a:t>
             </a:r>
           </a:p>
         </p:txBody>
@@ -11446,13 +11531,12 @@
           <a:lstStyle/>
           <a:p>
             <a:r>
-              <a:rPr sz="1200" b="0" dirty="0">
-                <a:solidFill>
-                  <a:srgbClr val="333333"/>
-                </a:solidFill>
-              </a:rPr>
-              <a:t>M1 R²=0.086 → M2 R²=0.215 when traits added · M3 holdout r=0.35 (exploratory)
-Left table = M1 league gaps · Right table = M2 trait effects · M3 = holdout r only</a:t>
+              <a:rPr sz="1200" b="0">
+                <a:solidFill>
+                  <a:srgbClr val="333333"/>
+                </a:solidFill>
+              </a:rPr>
+              <a:t>Model 1 R²=0.086 → Model 2 R²=0.215 when traits added · Model 3 holdout correlation r=0.35 (exploratory)</a:t>
             </a:r>
             <a:endParaRPr lang="en-US" sz="1200" b="0" dirty="0">
               <a:solidFill>
@@ -11462,35 +11546,13 @@
           </a:p>
           <a:p>
             <a:r>
-              <a:rPr lang="en-US" sz="1200" dirty="0">
-                <a:solidFill>
-                  <a:srgbClr val="333333"/>
-                </a:solidFill>
-              </a:rPr>
-              <a:t>M3</a:t>
-            </a:r>
-            <a:r>
-              <a:rPr lang="en-US" sz="1200" b="1" dirty="0">
-                <a:solidFill>
-                  <a:srgbClr val="333333"/>
-                </a:solidFill>
-              </a:rPr>
-              <a:t>: </a:t>
-            </a:r>
-            <a:r>
-              <a:rPr lang="en-US" sz="1200" b="1" dirty="0"/>
-              <a:t>r ≈ 0.35 </a:t>
-            </a:r>
-            <a:r>
-              <a:rPr lang="en-US" sz="1200" dirty="0"/>
-              <a:t>means: on the 20% of players left out, predicted Y1 minutes lined up with actual minutes only moderately</a:t>
-            </a:r>
-            <a:endParaRPr sz="1200" dirty="0">
-              <a:solidFill>
-                <a:srgbClr val="555555"/>
-              </a:solidFill>
-              <a:latin typeface="Georgia"/>
-            </a:endParaRPr>
+              <a:rPr sz="1200" b="0">
+                <a:solidFill>
+                  <a:srgbClr val="333333"/>
+                </a:solidFill>
+              </a:rPr>
+              <a:t>Left table = Model 1 league gaps · Right table = Model 2 trait effects · Model 3 = holdout check only (no third chart)</a:t>
+            </a:r>
           </a:p>
         </p:txBody>
       </p:sp>
@@ -12302,7 +12364,7 @@
                   <a:srgbClr val="333333"/>
                 </a:solidFill>
               </a:rPr>
-              <a:t>Ligue 1 +163 min vs Serie A (p≈0.38) — not significant at N=117.</a:t>
+              <a:t>Ligue 1 about +163 minutes vs Serie A (p≈0.38) — not statistically significant at N=117.</a:t>
             </a:r>
           </a:p>
           <a:p>
@@ -12312,7 +12374,7 @@
                   <a:srgbClr val="333333"/>
                 </a:solidFill>
               </a:rPr>
-              <a:t>Traits raise R² (0.09 → 0.22). Profile &gt; league label.</a:t>
+              <a:t>Adding traits raises R² (0.09 → 0.22): prior profile matters more than league label.</a:t>
             </a:r>
           </a:p>
           <a:p>
@@ -12322,15 +12384,8 @@
                   <a:srgbClr val="333333"/>
                 </a:solidFill>
               </a:rPr>
-              <a:t>Takeaway: scout portable traits + minutes; league is a weak residual.</a:t>
-            </a:r>
-          </a:p>
-          <a:p>
-            <a:endParaRPr sz="1200" b="0">
-              <a:solidFill>
-                <a:srgbClr val="333333"/>
-              </a:solidFill>
-            </a:endParaRPr>
+              <a:t>Model 3 holdout r≈0.35 = moderate match on held-out players (not a strong forecast).</a:t>
+            </a:r>
           </a:p>
           <a:p>
             <a:r>
@@ -12339,7 +12394,27 @@
                   <a:srgbClr val="333333"/>
                 </a:solidFill>
               </a:rPr>
-              <a:t>Serie A = baseline (lowest mean Y1 minutes among Big-5 feeders).</a:t>
+              <a:t>Takeaway: scout portable traits + minutes; league is a weak residual signal.</a:t>
+            </a:r>
+          </a:p>
+          <a:p>
+            <a:r>
+              <a:rPr sz="1200" b="0">
+                <a:solidFill>
+                  <a:srgbClr val="333333"/>
+                </a:solidFill>
+              </a:rPr>
+              <a:t/>
+            </a:r>
+          </a:p>
+          <a:p>
+            <a:r>
+              <a:rPr sz="1200" b="0">
+                <a:solidFill>
+                  <a:srgbClr val="333333"/>
+                </a:solidFill>
+              </a:rPr>
+              <a:t>Serie A = baseline (lowest mean Year-1 minutes among Big-5 feeders).</a:t>
             </a:r>
           </a:p>
         </p:txBody>
@@ -12690,13 +12765,12 @@
               </a:spcAft>
             </a:pPr>
             <a:r>
-              <a:rPr sz="1300" b="0" dirty="0">
+              <a:rPr sz="1200" b="0">
                 <a:solidFill>
                   <a:srgbClr val="555555"/>
                 </a:solidFill>
-                <a:latin typeface="Calibri"/>
-              </a:rPr>
-              <a:t>Question → scrape → stability → thresholds → redundancy → explorer → significance</a:t>
+              </a:rPr>
+              <a:t>Research question → data scrape from FBref and StatsBomb → stability thresholds → redundancy thresholds → HTML player explorer → team-based significance findings</a:t>
             </a:r>
           </a:p>
         </p:txBody>
@@ -12781,87 +12855,22 @@
               </a:spcAft>
             </a:pPr>
             <a:r>
-              <a:rPr sz="1200" b="0" dirty="0">
-                <a:solidFill>
-                  <a:srgbClr val="333333"/>
-                </a:solidFill>
-                <a:latin typeface="Calibri"/>
+              <a:rPr sz="1200" b="0">
+                <a:solidFill>
+                  <a:srgbClr val="333333"/>
+                </a:solidFill>
               </a:rPr>
               <a:t>Question</a:t>
             </a:r>
           </a:p>
           <a:p>
             <a:r>
-              <a:rPr sz="1200" b="0" dirty="0">
-                <a:solidFill>
-                  <a:srgbClr val="333333"/>
-                </a:solidFill>
-              </a:rPr>
-              <a:t>Which traits travel into </a:t>
-            </a:r>
-            <a:r>
-              <a:rPr lang="en-US" sz="1200" dirty="0">
-                <a:solidFill>
-                  <a:srgbClr val="333333"/>
-                </a:solidFill>
-              </a:rPr>
-              <a:t>the German Bundesliga (BL) </a:t>
-            </a:r>
-            <a:r>
-              <a:rPr sz="1200" b="0" dirty="0">
-                <a:solidFill>
-                  <a:srgbClr val="333333"/>
-                </a:solidFill>
-              </a:rPr>
-              <a:t>— and which prior</a:t>
-            </a:r>
-            <a:r>
-              <a:rPr lang="en-US" sz="1200" b="0" dirty="0">
-                <a:solidFill>
-                  <a:srgbClr val="333333"/>
-                </a:solidFill>
-              </a:rPr>
-              <a:t> stats line </a:t>
-            </a:r>
-            <a:r>
-              <a:rPr sz="1200" b="0" dirty="0">
-                <a:solidFill>
-                  <a:srgbClr val="333333"/>
-                </a:solidFill>
-              </a:rPr>
-              <a:t>up with </a:t>
-            </a:r>
-            <a:r>
-              <a:rPr lang="en-US" sz="1200" dirty="0">
-                <a:solidFill>
-                  <a:srgbClr val="333333"/>
-                </a:solidFill>
-              </a:rPr>
-              <a:t>Year 1</a:t>
-            </a:r>
-            <a:r>
-              <a:rPr sz="1200" b="0" dirty="0">
-                <a:solidFill>
-                  <a:srgbClr val="333333"/>
-                </a:solidFill>
-              </a:rPr>
-              <a:t> </a:t>
-            </a:r>
-            <a:r>
-              <a:rPr lang="en-US" sz="1200" b="0" dirty="0">
-                <a:solidFill>
-                  <a:srgbClr val="333333"/>
-                </a:solidFill>
-              </a:rPr>
-              <a:t>(Y1) </a:t>
-            </a:r>
-            <a:r>
-              <a:rPr sz="1200" b="0" dirty="0">
-                <a:solidFill>
-                  <a:srgbClr val="333333"/>
-                </a:solidFill>
-              </a:rPr>
-              <a:t>minutes?</a:t>
+              <a:rPr sz="1200" b="0">
+                <a:solidFill>
+                  <a:srgbClr val="333333"/>
+                </a:solidFill>
+              </a:rPr>
+              <a:t>Which traits travel into the German Bundesliga — and which prior stats line up with Year-1 Bundesliga minutes?</a:t>
             </a:r>
           </a:p>
         </p:txBody>
@@ -12946,79 +12955,32 @@
               </a:spcAft>
             </a:pPr>
             <a:r>
-              <a:rPr sz="1200" b="0" dirty="0">
-                <a:solidFill>
-                  <a:srgbClr val="333333"/>
-                </a:solidFill>
-                <a:latin typeface="Calibri"/>
+              <a:rPr sz="1100" b="0">
+                <a:solidFill>
+                  <a:srgbClr val="333333"/>
+                </a:solidFill>
               </a:rPr>
               <a:t>Scrape two sources</a:t>
             </a:r>
           </a:p>
           <a:p>
             <a:r>
-              <a:rPr lang="en-US" sz="1200" b="0" dirty="0">
-                <a:solidFill>
-                  <a:srgbClr val="333333"/>
-                </a:solidFill>
-              </a:rPr>
-              <a:t>Football Reference (</a:t>
-            </a:r>
-            <a:r>
-              <a:rPr sz="1200" b="0" dirty="0" err="1">
-                <a:solidFill>
-                  <a:srgbClr val="333333"/>
-                </a:solidFill>
-              </a:rPr>
-              <a:t>F</a:t>
-            </a:r>
-            <a:r>
-              <a:rPr lang="en-US" sz="1200" b="0" dirty="0" err="1">
-                <a:solidFill>
-                  <a:srgbClr val="333333"/>
-                </a:solidFill>
-              </a:rPr>
-              <a:t>b</a:t>
-            </a:r>
-            <a:r>
-              <a:rPr sz="1200" b="0" dirty="0" err="1">
-                <a:solidFill>
-                  <a:srgbClr val="333333"/>
-                </a:solidFill>
-              </a:rPr>
-              <a:t>ref</a:t>
-            </a:r>
-            <a:r>
-              <a:rPr lang="en-US" sz="1200" b="0" dirty="0">
-                <a:solidFill>
-                  <a:srgbClr val="333333"/>
-                </a:solidFill>
-              </a:rPr>
-              <a:t>)</a:t>
-            </a:r>
-            <a:r>
-              <a:rPr sz="1200" b="0" dirty="0">
-                <a:solidFill>
-                  <a:srgbClr val="333333"/>
-                </a:solidFill>
-              </a:rPr>
-              <a:t>: 19 leagues, first BL ≥2021, ≥300′. </a:t>
-            </a:r>
-            <a:r>
-              <a:rPr sz="1200" b="0" dirty="0" err="1">
-                <a:solidFill>
-                  <a:srgbClr val="333333"/>
-                </a:solidFill>
-              </a:rPr>
-              <a:t>StatsBomb</a:t>
-            </a:r>
-            <a:r>
-              <a:rPr sz="1200" b="0" dirty="0">
-                <a:solidFill>
-                  <a:srgbClr val="333333"/>
-                </a:solidFill>
-              </a:rPr>
-              <a:t>: 17 comps; BL 2015/16 + 2023/24; ≥45′/≥30′.</a:t>
+              <a:rPr sz="1100" b="0">
+                <a:solidFill>
+                  <a:srgbClr val="333333"/>
+                </a:solidFill>
+              </a:rPr>
+              <a:t>Football Reference (FBref): 19 leagues; first Bundesliga season in 2021–2025; prior and Year-1 minutes ≥300′.</a:t>
+            </a:r>
+          </a:p>
+          <a:p>
+            <a:r>
+              <a:rPr sz="1100" b="0">
+                <a:solidFill>
+                  <a:srgbClr val="333333"/>
+                </a:solidFill>
+              </a:rPr>
+              <a:t>StatsBomb: 17 competitions; Bundesliga 2015/16 + 2023/24; prior ≥45′ / Year-1 ≥30′.</a:t>
             </a:r>
           </a:p>
         </p:txBody>
@@ -13103,39 +13065,22 @@
               </a:spcAft>
             </a:pPr>
             <a:r>
-              <a:rPr sz="1200" b="0" dirty="0">
-                <a:solidFill>
-                  <a:srgbClr val="333333"/>
-                </a:solidFill>
-                <a:latin typeface="Calibri"/>
+              <a:rPr sz="1200" b="0">
+                <a:solidFill>
+                  <a:srgbClr val="333333"/>
+                </a:solidFill>
               </a:rPr>
               <a:t>Stability</a:t>
             </a:r>
           </a:p>
           <a:p>
             <a:r>
-              <a:rPr sz="1200" b="0" dirty="0">
-                <a:solidFill>
-                  <a:srgbClr val="333333"/>
-                </a:solidFill>
-              </a:rPr>
-              <a:t>Correlate prior → BL Y1 per-90</a:t>
-            </a:r>
-            <a:r>
-              <a:rPr lang="en-US" sz="1200" b="0" dirty="0">
-                <a:solidFill>
-                  <a:srgbClr val="333333"/>
-                </a:solidFill>
-              </a:rPr>
-              <a:t> minutes</a:t>
-            </a:r>
-            <a:r>
-              <a:rPr sz="1200" b="0" dirty="0">
-                <a:solidFill>
-                  <a:srgbClr val="333333"/>
-                </a:solidFill>
-              </a:rPr>
-              <a:t>. Keep metrics that travel.</a:t>
+              <a:rPr sz="1200" b="0">
+                <a:solidFill>
+                  <a:srgbClr val="333333"/>
+                </a:solidFill>
+              </a:rPr>
+              <a:t>Correlate prior → Bundesliga Year-1 per-90 rates. Keep metrics that travel.</a:t>
             </a:r>
           </a:p>
         </p:txBody>
@@ -13220,79 +13165,22 @@
               </a:spcAft>
             </a:pPr>
             <a:r>
-              <a:rPr sz="1200" b="0" dirty="0">
-                <a:solidFill>
-                  <a:srgbClr val="333333"/>
-                </a:solidFill>
-                <a:latin typeface="Calibri"/>
+              <a:rPr sz="1100" b="0">
+                <a:solidFill>
+                  <a:srgbClr val="333333"/>
+                </a:solidFill>
               </a:rPr>
               <a:t>Choose thresholds</a:t>
             </a:r>
           </a:p>
           <a:p>
             <a:r>
-              <a:rPr sz="1200" b="0" dirty="0" err="1">
-                <a:solidFill>
-                  <a:srgbClr val="333333"/>
-                </a:solidFill>
-              </a:rPr>
-              <a:t>FBref</a:t>
-            </a:r>
-            <a:r>
-              <a:rPr sz="1200" b="0" dirty="0">
-                <a:solidFill>
-                  <a:srgbClr val="333333"/>
-                </a:solidFill>
-              </a:rPr>
-              <a:t> category gates → 43/105</a:t>
-            </a:r>
-            <a:r>
-              <a:rPr lang="en-US" sz="1200" b="0" dirty="0">
-                <a:solidFill>
-                  <a:srgbClr val="333333"/>
-                </a:solidFill>
-              </a:rPr>
-              <a:t> metrics</a:t>
-            </a:r>
-            <a:r>
-              <a:rPr sz="1200" b="0" dirty="0">
-                <a:solidFill>
-                  <a:srgbClr val="333333"/>
-                </a:solidFill>
-              </a:rPr>
-              <a:t>. </a:t>
-            </a:r>
-            <a:r>
-              <a:rPr sz="1200" b="0" dirty="0" err="1">
-                <a:solidFill>
-                  <a:srgbClr val="333333"/>
-                </a:solidFill>
-              </a:rPr>
-              <a:t>StatsBomb</a:t>
-            </a:r>
-            <a:r>
-              <a:rPr sz="1200" b="0" dirty="0">
-                <a:solidFill>
-                  <a:srgbClr val="333333"/>
-                </a:solidFill>
-              </a:rPr>
-              <a:t> r≥0.40 → 7/16</a:t>
-            </a:r>
-            <a:r>
-              <a:rPr lang="en-US" sz="1200" b="0" dirty="0">
-                <a:solidFill>
-                  <a:srgbClr val="333333"/>
-                </a:solidFill>
-              </a:rPr>
-              <a:t> metrics</a:t>
-            </a:r>
-            <a:r>
-              <a:rPr sz="1200" b="0" dirty="0">
-                <a:solidFill>
-                  <a:srgbClr val="333333"/>
-                </a:solidFill>
-              </a:rPr>
-              <a:t>.</a:t>
+              <a:rPr sz="1100" b="0">
+                <a:solidFill>
+                  <a:srgbClr val="333333"/>
+                </a:solidFill>
+              </a:rPr>
+              <a:t>FBref category gates → 43 of 105 metrics met the stability floor. StatsBomb Pearson r≥0.40 → 7 of 16.</a:t>
             </a:r>
           </a:p>
         </p:txBody>
@@ -13377,71 +13265,22 @@
               </a:spcAft>
             </a:pPr>
             <a:r>
-              <a:rPr sz="1200" b="0" dirty="0">
-                <a:solidFill>
-                  <a:srgbClr val="333333"/>
-                </a:solidFill>
-                <a:latin typeface="Calibri"/>
+              <a:rPr sz="1200" b="0">
+                <a:solidFill>
+                  <a:srgbClr val="333333"/>
+                </a:solidFill>
               </a:rPr>
               <a:t>Redundancy + context</a:t>
             </a:r>
           </a:p>
           <a:p>
             <a:r>
-              <a:rPr sz="1200" b="0" dirty="0">
-                <a:solidFill>
-                  <a:srgbClr val="333333"/>
-                </a:solidFill>
-              </a:rPr>
-              <a:t>Drop </a:t>
-            </a:r>
-            <a:r>
-              <a:rPr lang="en-US" sz="1200" b="0" dirty="0">
-                <a:solidFill>
-                  <a:srgbClr val="333333"/>
-                </a:solidFill>
-              </a:rPr>
-              <a:t>near-duplicates</a:t>
-            </a:r>
-            <a:r>
-              <a:rPr sz="1200" b="0" dirty="0">
-                <a:solidFill>
-                  <a:srgbClr val="333333"/>
-                </a:solidFill>
-              </a:rPr>
-              <a:t>.</a:t>
-            </a:r>
-            <a:r>
-              <a:rPr lang="en-US" sz="1200" b="0" dirty="0">
-                <a:solidFill>
-                  <a:srgbClr val="333333"/>
-                </a:solidFill>
-              </a:rPr>
-              <a:t> </a:t>
-            </a:r>
-            <a:r>
-              <a:rPr lang="en-US" sz="1200" b="0" dirty="0" err="1">
-                <a:solidFill>
-                  <a:srgbClr val="333333"/>
-                </a:solidFill>
-              </a:rPr>
-              <a:t>Fbref</a:t>
-            </a:r>
-            <a:r>
-              <a:rPr lang="en-US" sz="1200" b="0" dirty="0">
-                <a:solidFill>
-                  <a:srgbClr val="333333"/>
-                </a:solidFill>
-              </a:rPr>
-              <a:t> </a:t>
-            </a:r>
-            <a:r>
-              <a:rPr sz="1200" b="0" dirty="0">
-                <a:solidFill>
-                  <a:srgbClr val="333333"/>
-                </a:solidFill>
-              </a:rPr>
-              <a:t>43→32 · SB 7.</a:t>
+              <a:rPr sz="1200" b="0">
+                <a:solidFill>
+                  <a:srgbClr val="333333"/>
+                </a:solidFill>
+              </a:rPr>
+              <a:t>Drop near-duplicates. FBref 43→32 · StatsBomb keep 7.</a:t>
             </a:r>
           </a:p>
         </p:txBody>
@@ -13526,55 +13365,22 @@
               </a:spcAft>
             </a:pPr>
             <a:r>
-              <a:rPr sz="1200" b="0" dirty="0">
-                <a:solidFill>
-                  <a:srgbClr val="333333"/>
-                </a:solidFill>
-                <a:latin typeface="Calibri"/>
+              <a:rPr sz="1200" b="0">
+                <a:solidFill>
+                  <a:srgbClr val="333333"/>
+                </a:solidFill>
               </a:rPr>
               <a:t>Explorer &amp; graphics</a:t>
             </a:r>
           </a:p>
           <a:p>
             <a:r>
-              <a:rPr sz="1200" b="0" dirty="0">
-                <a:solidFill>
-                  <a:srgbClr val="333333"/>
-                </a:solidFill>
-              </a:rPr>
-              <a:t>Radars / pizzas on shortlist</a:t>
-            </a:r>
-            <a:r>
-              <a:rPr lang="en-US" sz="1200" b="0" dirty="0">
-                <a:solidFill>
-                  <a:srgbClr val="333333"/>
-                </a:solidFill>
-              </a:rPr>
-              <a:t> metrics</a:t>
-            </a:r>
-            <a:r>
-              <a:rPr sz="1200" b="0" dirty="0">
-                <a:solidFill>
-                  <a:srgbClr val="333333"/>
-                </a:solidFill>
-              </a:rPr>
-              <a:t> (</a:t>
-            </a:r>
-            <a:r>
-              <a:rPr sz="1200" b="0" dirty="0" err="1">
-                <a:solidFill>
-                  <a:srgbClr val="333333"/>
-                </a:solidFill>
-              </a:rPr>
-              <a:t>interactive_player_explorer.html</a:t>
-            </a:r>
-            <a:r>
-              <a:rPr sz="1200" b="0" dirty="0">
-                <a:solidFill>
-                  <a:srgbClr val="333333"/>
-                </a:solidFill>
-              </a:rPr>
-              <a:t>).</a:t>
+              <a:rPr sz="1200" b="0">
+                <a:solidFill>
+                  <a:srgbClr val="333333"/>
+                </a:solidFill>
+              </a:rPr>
+              <a:t>Radars / pizzas on shortlisted metrics (interactive_player_explorer.html).</a:t>
             </a:r>
           </a:p>
         </p:txBody>
@@ -13659,55 +13465,22 @@
               </a:spcAft>
             </a:pPr>
             <a:r>
-              <a:rPr sz="1200" b="0" dirty="0">
-                <a:solidFill>
-                  <a:srgbClr val="333333"/>
-                </a:solidFill>
-                <a:latin typeface="Calibri"/>
+              <a:rPr sz="1100" b="0">
+                <a:solidFill>
+                  <a:srgbClr val="333333"/>
+                </a:solidFill>
               </a:rPr>
               <a:t>Significance tests</a:t>
             </a:r>
           </a:p>
           <a:p>
             <a:r>
-              <a:rPr sz="1200" b="0" dirty="0">
-                <a:solidFill>
-                  <a:srgbClr val="333333"/>
-                </a:solidFill>
-              </a:rPr>
-              <a:t>Spearman: prior trait</a:t>
-            </a:r>
-            <a:r>
-              <a:rPr lang="en-US" sz="1200" b="0" dirty="0">
-                <a:solidFill>
-                  <a:srgbClr val="333333"/>
-                </a:solidFill>
-              </a:rPr>
-              <a:t> percentile</a:t>
-            </a:r>
-            <a:r>
-              <a:rPr sz="1200" b="0" dirty="0">
-                <a:solidFill>
-                  <a:srgbClr val="333333"/>
-                </a:solidFill>
-              </a:rPr>
-              <a:t> vs Y1 minutes; feeder</a:t>
-            </a:r>
-            <a:r>
-              <a:rPr lang="en-US" sz="1200" b="0" dirty="0">
-                <a:solidFill>
-                  <a:srgbClr val="333333"/>
-                </a:solidFill>
-              </a:rPr>
-              <a:t> league</a:t>
-            </a:r>
-            <a:r>
-              <a:rPr sz="1200" b="0" dirty="0">
-                <a:solidFill>
-                  <a:srgbClr val="333333"/>
-                </a:solidFill>
-              </a:rPr>
-              <a:t> summaries; exploratory OLS.</a:t>
+              <a:rPr sz="1100" b="0">
+                <a:solidFill>
+                  <a:srgbClr val="333333"/>
+                </a:solidFill>
+              </a:rPr>
+              <a:t>Spearman: prior trait percentile vs Year-1 Bundesliga minutes; feeder-league summaries; exploratory OLS.</a:t>
             </a:r>
           </a:p>
         </p:txBody>
@@ -13755,67 +13528,12 @@
               </a:spcAft>
             </a:pPr>
             <a:r>
-              <a:rPr lang="en-US" sz="1300" b="0" i="1" dirty="0">
-                <a:solidFill>
-                  <a:srgbClr val="555555"/>
-                </a:solidFill>
-                <a:latin typeface="Calibri"/>
-              </a:rPr>
-              <a:t>Compared to the project completed with Red Bull New York, </a:t>
-            </a:r>
-            <a:r>
-              <a:rPr lang="en-US" sz="1300" i="1" dirty="0">
-                <a:solidFill>
-                  <a:srgbClr val="555555"/>
-                </a:solidFill>
-                <a:latin typeface="Calibri"/>
-              </a:rPr>
-              <a:t>the project </a:t>
-            </a:r>
-            <a:r>
-              <a:rPr lang="en-US" sz="1300" b="0" i="1" dirty="0">
-                <a:solidFill>
-                  <a:srgbClr val="555555"/>
-                </a:solidFill>
-                <a:latin typeface="Calibri"/>
-              </a:rPr>
-              <a:t>defines the most portable traits for scouting leading to playing time in the Bundesliga year 1 post-transfer rather rather than</a:t>
-            </a:r>
-            <a:r>
-              <a:rPr sz="1300" b="0" i="1" dirty="0">
-                <a:solidFill>
-                  <a:srgbClr val="555555"/>
-                </a:solidFill>
-                <a:latin typeface="Calibri"/>
-              </a:rPr>
-              <a:t> </a:t>
-            </a:r>
-            <a:r>
-              <a:rPr sz="1300" b="0" i="1" dirty="0" err="1">
-                <a:solidFill>
-                  <a:srgbClr val="555555"/>
-                </a:solidFill>
-                <a:latin typeface="Calibri"/>
-              </a:rPr>
-              <a:t>Transfermarkt</a:t>
-            </a:r>
-            <a:r>
-              <a:rPr sz="1300" b="0" i="1" dirty="0">
-                <a:solidFill>
-                  <a:srgbClr val="555555"/>
-                </a:solidFill>
-                <a:latin typeface="Calibri"/>
-              </a:rPr>
-              <a:t> value</a:t>
-            </a:r>
-            <a:r>
-              <a:rPr lang="en-US" sz="1300" b="0" i="1" dirty="0">
-                <a:solidFill>
-                  <a:srgbClr val="555555"/>
-                </a:solidFill>
-                <a:latin typeface="Calibri"/>
-              </a:rPr>
-              <a:t>. Scouts and teams will be able to answer the questions: ‘Which traits do we scout in outside leagues to best predict playing time? Which leagues provide the most reliable statistics to best predict results in the BL?</a:t>
+              <a:rPr sz="1100" b="0">
+                <a:solidFill>
+                  <a:srgbClr val="333333"/>
+                </a:solidFill>
+              </a:rPr>
+              <a:t>Compared to the project completed with Red Bull New York, the project defines the most portable traits for scouting leading to playing time in the Bundesliga year 1 post-transfer rather than Transfermarkt value. Scouts and teams will be able to answer the questions: ‘Which traits do we scout in outside leagues to best predict playing time? Which leagues provide the most reliable statistics to best predict results in the Bundesliga?</a:t>
             </a:r>
             <a:endParaRPr sz="1300" b="0" i="1" dirty="0">
               <a:solidFill>
@@ -13878,13 +13596,12 @@
               </a:spcAft>
             </a:pPr>
             <a:r>
-              <a:rPr sz="2400" b="1" dirty="0">
-                <a:solidFill>
-                  <a:srgbClr val="3D5A80"/>
-                </a:solidFill>
-                <a:latin typeface="Calibri"/>
-              </a:rPr>
-              <a:t>CONCLUSION</a:t>
+              <a:rPr sz="1400" b="0">
+                <a:solidFill>
+                  <a:srgbClr val="333333"/>
+                </a:solidFill>
+              </a:rPr>
+              <a:t>• Portable shortlists: FBref 105 metrics tested → 43 met stability floor → 32 met redundancy floor · StatsBomb 16 metrics tested → 7 met stability floor (all 7 kept after redundancy)</a:t>
             </a:r>
             <a:endParaRPr lang="en-US" sz="2400" b="1" dirty="0">
               <a:solidFill>
@@ -13894,192 +13611,84 @@
             </a:endParaRPr>
           </a:p>
           <a:p>
-            <a:pPr>
-              <a:spcAft>
-                <a:spcPts val="300"/>
-              </a:spcAft>
-            </a:pPr>
-            <a:endParaRPr lang="en-US" sz="1600" dirty="0"/>
-          </a:p>
-          <a:p>
-            <a:r>
-              <a:rPr lang="en-US" sz="1600" dirty="0">
-                <a:solidFill>
-                  <a:srgbClr val="333333"/>
-                </a:solidFill>
-              </a:rPr>
-              <a:t>• Portable shortlists: </a:t>
-            </a:r>
-            <a:r>
-              <a:rPr lang="en-US" sz="1600" dirty="0" err="1">
-                <a:solidFill>
-                  <a:srgbClr val="333333"/>
-                </a:solidFill>
-              </a:rPr>
-              <a:t>FBref</a:t>
-            </a:r>
-            <a:r>
-              <a:rPr lang="en-US" sz="1600" dirty="0">
-                <a:solidFill>
-                  <a:srgbClr val="333333"/>
-                </a:solidFill>
-              </a:rPr>
-              <a:t> 105→43→32 · </a:t>
-            </a:r>
-            <a:r>
-              <a:rPr lang="en-US" sz="1600" dirty="0" err="1">
-                <a:solidFill>
-                  <a:srgbClr val="333333"/>
-                </a:solidFill>
-              </a:rPr>
-              <a:t>StatsBomb</a:t>
-            </a:r>
-            <a:r>
-              <a:rPr lang="en-US" sz="1600" dirty="0">
-                <a:solidFill>
-                  <a:srgbClr val="333333"/>
-                </a:solidFill>
-              </a:rPr>
-              <a:t> 16→7</a:t>
-            </a:r>
-            <a:endParaRPr lang="en-US" sz="1600" dirty="0"/>
-          </a:p>
-          <a:p>
-            <a:endParaRPr lang="en-US" sz="1600" dirty="0">
-              <a:solidFill>
-                <a:srgbClr val="333333"/>
-              </a:solidFill>
-            </a:endParaRPr>
-          </a:p>
-          <a:p>
-            <a:r>
-              <a:rPr lang="en-US" sz="1600" dirty="0">
-                <a:solidFill>
-                  <a:srgbClr val="333333"/>
-                </a:solidFill>
-              </a:rPr>
-              <a:t>• </a:t>
-            </a:r>
-            <a:r>
-              <a:rPr lang="en-US" sz="1600" dirty="0" err="1">
-                <a:solidFill>
-                  <a:srgbClr val="333333"/>
-                </a:solidFill>
-              </a:rPr>
-              <a:t>Fbref</a:t>
-            </a:r>
-            <a:r>
-              <a:rPr lang="en-US" sz="1600" dirty="0">
-                <a:solidFill>
-                  <a:srgbClr val="333333"/>
-                </a:solidFill>
-              </a:rPr>
-              <a:t> best/most-stable metrics: final-third passing, shot blocks, progressive distance, box defending ↔ more Y1 minutes (p&lt;0.05)</a:t>
-            </a:r>
-          </a:p>
-          <a:p>
-            <a:endParaRPr lang="en-US" sz="1600" dirty="0">
-              <a:solidFill>
-                <a:srgbClr val="333333"/>
-              </a:solidFill>
-            </a:endParaRPr>
-          </a:p>
-          <a:p>
-            <a:r>
-              <a:rPr lang="en-US" sz="1600" dirty="0">
-                <a:solidFill>
-                  <a:srgbClr val="333333"/>
-                </a:solidFill>
-              </a:rPr>
-              <a:t>• Feeder league gaps are modest; exploratory OLS (N=117) — traits matter more than the league label or league strength</a:t>
-            </a:r>
-          </a:p>
-          <a:p>
-            <a:endParaRPr lang="en-US" sz="1600" dirty="0">
-              <a:solidFill>
-                <a:srgbClr val="333333"/>
-              </a:solidFill>
-            </a:endParaRPr>
-          </a:p>
-          <a:p>
-            <a:r>
-              <a:rPr lang="en-US" sz="1600" dirty="0">
-                <a:solidFill>
-                  <a:srgbClr val="333333"/>
-                </a:solidFill>
-              </a:rPr>
-              <a:t>• Scout metrics that travel from league to league. Y1 minutes = open-data success proxy</a:t>
-            </a:r>
-          </a:p>
-          <a:p>
-            <a:endParaRPr lang="en-US" sz="1600" dirty="0">
-              <a:solidFill>
-                <a:srgbClr val="333333"/>
-              </a:solidFill>
-            </a:endParaRPr>
-          </a:p>
-          <a:p>
-            <a:r>
-              <a:rPr lang="en-US" sz="1600" dirty="0">
-                <a:solidFill>
-                  <a:srgbClr val="333333"/>
-                </a:solidFill>
-              </a:rPr>
-              <a:t>• Future project goals would be to test </a:t>
-            </a:r>
-            <a:r>
-              <a:rPr lang="el-GR" sz="1600" dirty="0">
-                <a:solidFill>
-                  <a:srgbClr val="333333"/>
-                </a:solidFill>
-              </a:rPr>
-              <a:t>Δ</a:t>
-            </a:r>
-            <a:r>
-              <a:rPr lang="en-US" sz="1600" dirty="0">
-                <a:solidFill>
-                  <a:srgbClr val="333333"/>
-                </a:solidFill>
-              </a:rPr>
-              <a:t> in</a:t>
-            </a:r>
-            <a:r>
-              <a:rPr lang="el-GR" sz="1600" dirty="0">
-                <a:solidFill>
-                  <a:srgbClr val="333333"/>
-                </a:solidFill>
-              </a:rPr>
-              <a:t> </a:t>
-            </a:r>
-            <a:r>
-              <a:rPr lang="en-US" sz="1600" dirty="0" err="1">
-                <a:solidFill>
-                  <a:srgbClr val="333333"/>
-                </a:solidFill>
-              </a:rPr>
-              <a:t>Transfermarkt</a:t>
-            </a:r>
-            <a:r>
-              <a:rPr lang="en-US" sz="1600" dirty="0">
-                <a:solidFill>
-                  <a:srgbClr val="333333"/>
-                </a:solidFill>
-              </a:rPr>
-              <a:t> market value (discussed in next slide) which is a main club outcome goal</a:t>
-            </a:r>
-          </a:p>
-          <a:p>
-            <a:pPr>
-              <a:spcAft>
-                <a:spcPts val="300"/>
-              </a:spcAft>
-            </a:pPr>
-            <a:endParaRPr sz="2400" b="1" dirty="0">
-              <a:solidFill>
-                <a:srgbClr val="3D5A80"/>
-              </a:solidFill>
-              <a:latin typeface="Calibri"/>
-            </a:endParaRPr>
+            <a:r>
+              <a:rPr sz="1400" b="0">
+                <a:solidFill>
+                  <a:srgbClr val="333333"/>
+                </a:solidFill>
+              </a:rPr>
+              <a:t/>
+            </a:r>
+          </a:p>
+          <a:p>
+            <a:r>
+              <a:rPr sz="1400" b="0">
+                <a:solidFill>
+                  <a:srgbClr val="333333"/>
+                </a:solidFill>
+              </a:rPr>
+              <a:t>• FBref traits most linked to Year-1 minutes (p&lt;0.05): final-third passing, shot blocks, progressive distance, box defending</a:t>
+            </a:r>
+          </a:p>
+          <a:p>
+            <a:r>
+              <a:rPr sz="1400" b="0">
+                <a:solidFill>
+                  <a:srgbClr val="333333"/>
+                </a:solidFill>
+              </a:rPr>
+              <a:t/>
+            </a:r>
+          </a:p>
+          <a:p>
+            <a:r>
+              <a:rPr sz="1400" b="0">
+                <a:solidFill>
+                  <a:srgbClr val="333333"/>
+                </a:solidFill>
+              </a:rPr>
+              <a:t>• Feeder-league gaps are modest; exploratory OLS (N=117) — traits matter more than league label</a:t>
+            </a:r>
+          </a:p>
+          <a:p>
+            <a:r>
+              <a:rPr sz="1400" b="0">
+                <a:solidFill>
+                  <a:srgbClr val="333333"/>
+                </a:solidFill>
+              </a:rPr>
+              <a:t/>
+            </a:r>
+          </a:p>
+          <a:p>
+            <a:r>
+              <a:rPr sz="1400" b="0">
+                <a:solidFill>
+                  <a:srgbClr val="333333"/>
+                </a:solidFill>
+              </a:rPr>
+              <a:t>• Scout metrics that travel league-to-league. Year-1 Bundesliga minutes = open-data success proxy</a:t>
+            </a:r>
+          </a:p>
+          <a:p>
+            <a:r>
+              <a:rPr sz="1400" b="0">
+                <a:solidFill>
+                  <a:srgbClr val="333333"/>
+                </a:solidFill>
+              </a:rPr>
+              <a:t/>
+            </a:r>
+          </a:p>
+          <a:p>
+            <a:r>
+              <a:rPr sz="1400" b="0">
+                <a:solidFill>
+                  <a:srgbClr val="333333"/>
+                </a:solidFill>
+              </a:rPr>
+              <a:t>• Future work: Δ Transfermarkt market value (next slide) as the club-grade outcome</a:t>
+            </a:r>
           </a:p>
         </p:txBody>
       </p:sp>
@@ -14253,218 +13862,52 @@
               </a:spcAft>
             </a:pPr>
             <a:r>
-              <a:rPr sz="1400" dirty="0">
-                <a:solidFill>
-                  <a:srgbClr val="1C1C1C"/>
-                </a:solidFill>
-                <a:latin typeface="Arial"/>
-              </a:rPr>
-              <a:t>Top indicator in a full club model: change in market value (</a:t>
-            </a:r>
-            <a:r>
-              <a:rPr sz="1400" dirty="0" err="1">
-                <a:solidFill>
-                  <a:srgbClr val="1C1C1C"/>
-                </a:solidFill>
-                <a:latin typeface="Arial"/>
-              </a:rPr>
-              <a:t>Δ</a:t>
-            </a:r>
-            <a:r>
-              <a:rPr sz="1400" dirty="0">
-                <a:solidFill>
-                  <a:srgbClr val="1C1C1C"/>
-                </a:solidFill>
-                <a:latin typeface="Arial"/>
-              </a:rPr>
-              <a:t> </a:t>
-            </a:r>
-            <a:r>
-              <a:rPr sz="1400" dirty="0" err="1">
-                <a:solidFill>
-                  <a:srgbClr val="1C1C1C"/>
-                </a:solidFill>
-                <a:latin typeface="Arial"/>
-              </a:rPr>
-              <a:t>Transfermarkt</a:t>
-            </a:r>
-            <a:r>
-              <a:rPr sz="1400" dirty="0">
-                <a:solidFill>
-                  <a:srgbClr val="1C1C1C"/>
-                </a:solidFill>
-                <a:latin typeface="Arial"/>
-              </a:rPr>
-              <a:t> M</a:t>
-            </a:r>
-            <a:r>
-              <a:rPr lang="en-US" sz="1400" dirty="0">
-                <a:solidFill>
-                  <a:srgbClr val="1C1C1C"/>
-                </a:solidFill>
-                <a:latin typeface="Arial"/>
-              </a:rPr>
-              <a:t>arket Value</a:t>
-            </a:r>
-            <a:r>
-              <a:rPr sz="1400" dirty="0">
-                <a:solidFill>
-                  <a:srgbClr val="1C1C1C"/>
-                </a:solidFill>
-                <a:latin typeface="Arial"/>
-              </a:rPr>
-              <a:t>)</a:t>
-            </a:r>
-          </a:p>
-          <a:p>
-            <a:pPr>
-              <a:spcAft>
-                <a:spcPts val="600"/>
-              </a:spcAft>
-            </a:pPr>
-            <a:r>
-              <a:rPr sz="1400" dirty="0">
-                <a:solidFill>
-                  <a:srgbClr val="1C1C1C"/>
-                </a:solidFill>
-                <a:latin typeface="Arial"/>
+              <a:rPr sz="1300" b="0">
+                <a:solidFill>
+                  <a:srgbClr val="333333"/>
+                </a:solidFill>
+              </a:rPr>
+              <a:t>Top indicator in a full club model: change in market value (Δ Transfermarkt market value)</a:t>
+            </a:r>
+          </a:p>
+          <a:p>
+            <a:r>
+              <a:rPr sz="1300" b="0">
+                <a:solidFill>
+                  <a:srgbClr val="333333"/>
+                </a:solidFill>
               </a:rPr>
               <a:t>Captures performance + hype + contract context in one outcome scouts care about</a:t>
             </a:r>
           </a:p>
           <a:p>
-            <a:pPr>
-              <a:spcAft>
-                <a:spcPts val="600"/>
-              </a:spcAft>
-            </a:pPr>
-            <a:r>
-              <a:rPr sz="1400" dirty="0">
-                <a:solidFill>
-                  <a:srgbClr val="1C1C1C"/>
-                </a:solidFill>
-                <a:latin typeface="Arial"/>
-              </a:rPr>
-              <a:t>NYRB Axis-3 used </a:t>
-            </a:r>
-            <a:r>
-              <a:rPr lang="en-US" sz="1400" dirty="0">
-                <a:solidFill>
-                  <a:srgbClr val="1C1C1C"/>
-                </a:solidFill>
-                <a:latin typeface="Arial"/>
-              </a:rPr>
-              <a:t>Market Value</a:t>
-            </a:r>
-            <a:r>
-              <a:rPr sz="1400" dirty="0">
-                <a:solidFill>
-                  <a:srgbClr val="1C1C1C"/>
-                </a:solidFill>
-                <a:latin typeface="Arial"/>
-              </a:rPr>
-              <a:t>; this project uses open data only — </a:t>
-            </a:r>
-            <a:r>
-              <a:rPr sz="1400" dirty="0" err="1">
-                <a:solidFill>
-                  <a:srgbClr val="1C1C1C"/>
-                </a:solidFill>
-                <a:latin typeface="Arial"/>
-              </a:rPr>
-              <a:t>Transfermarkt</a:t>
-            </a:r>
-            <a:r>
-              <a:rPr sz="1400" dirty="0">
-                <a:solidFill>
-                  <a:srgbClr val="1C1C1C"/>
-                </a:solidFill>
-                <a:latin typeface="Arial"/>
-              </a:rPr>
-              <a:t> </a:t>
-            </a:r>
-            <a:r>
-              <a:rPr lang="en-US" sz="1400" dirty="0">
-                <a:solidFill>
-                  <a:srgbClr val="1C1C1C"/>
-                </a:solidFill>
-                <a:latin typeface="Arial"/>
-              </a:rPr>
-              <a:t>disallows</a:t>
-            </a:r>
-            <a:r>
-              <a:rPr sz="1400" dirty="0">
-                <a:solidFill>
-                  <a:srgbClr val="1C1C1C"/>
-                </a:solidFill>
-                <a:latin typeface="Arial"/>
-              </a:rPr>
-              <a:t> </a:t>
-            </a:r>
-            <a:r>
-              <a:rPr lang="en-US" sz="1400" dirty="0">
-                <a:solidFill>
-                  <a:srgbClr val="1C1C1C"/>
-                </a:solidFill>
-                <a:latin typeface="Arial"/>
-              </a:rPr>
-              <a:t>scraping</a:t>
-            </a:r>
-            <a:endParaRPr sz="1400" dirty="0">
-              <a:solidFill>
-                <a:srgbClr val="1C1C1C"/>
-              </a:solidFill>
-              <a:latin typeface="Arial"/>
-            </a:endParaRPr>
-          </a:p>
-          <a:p>
-            <a:pPr>
-              <a:spcAft>
-                <a:spcPts val="600"/>
-              </a:spcAft>
-            </a:pPr>
-            <a:r>
-              <a:rPr sz="1400" dirty="0">
-                <a:solidFill>
-                  <a:srgbClr val="1C1C1C"/>
-                </a:solidFill>
-                <a:latin typeface="Arial"/>
-              </a:rPr>
-              <a:t>So we proxy success with Y1 minutes until a licensed MV feed is available</a:t>
-            </a:r>
-          </a:p>
-          <a:p>
-            <a:pPr>
-              <a:spcAft>
-                <a:spcPts val="600"/>
-              </a:spcAft>
-            </a:pPr>
-            <a:r>
-              <a:rPr sz="1400" dirty="0">
-                <a:solidFill>
-                  <a:srgbClr val="1C1C1C"/>
-                </a:solidFill>
-                <a:latin typeface="Arial"/>
-              </a:rPr>
-              <a:t>Natural extension: prior traits → </a:t>
-            </a:r>
-            <a:r>
-              <a:rPr sz="1400" dirty="0" err="1">
-                <a:solidFill>
-                  <a:srgbClr val="1C1C1C"/>
-                </a:solidFill>
-                <a:latin typeface="Arial"/>
-              </a:rPr>
-              <a:t>Δ</a:t>
-            </a:r>
-            <a:r>
-              <a:rPr sz="1400" dirty="0">
-                <a:solidFill>
-                  <a:srgbClr val="1C1C1C"/>
-                </a:solidFill>
-                <a:latin typeface="Arial"/>
-              </a:rPr>
-              <a:t> MV with holdout regression / ML</a:t>
+            <a:r>
+              <a:rPr sz="1300" b="0">
+                <a:solidFill>
+                  <a:srgbClr val="333333"/>
+                </a:solidFill>
+              </a:rPr>
+              <a:t>NYRB project Axis-3 testing of player value used market value rather than Year-1 minutes; this project uses open data only — Transfermarkt disallows scraping</a:t>
+            </a:r>
+          </a:p>
+          <a:p>
+            <a:r>
+              <a:rPr sz="1300" b="0">
+                <a:solidFill>
+                  <a:srgbClr val="333333"/>
+                </a:solidFill>
+              </a:rPr>
+              <a:t>So we proxy success with Year-1 Bundesliga minutes until a licensed market-value feed is available</a:t>
+            </a:r>
+          </a:p>
+          <a:p>
+            <a:r>
+              <a:rPr sz="1300" b="0">
+                <a:solidFill>
+                  <a:srgbClr val="333333"/>
+                </a:solidFill>
+              </a:rPr>
+              <a:t>Natural extension: prior traits → Δ market value with holdout regression / ML</a:t>
             </a:r>
           </a:p>
         </p:txBody>
@@ -14483,6 +13926,443 @@
 </file>
 
 <file path=ppt/slides/slide22.xml><?xml version="1.0" encoding="utf-8"?>
+<p:sld xmlns:a="http://schemas.openxmlformats.org/drawingml/2006/main" xmlns:p="http://schemas.openxmlformats.org/presentationml/2006/main" xmlns:r="http://schemas.openxmlformats.org/officeDocument/2006/relationships">
+  <p:cSld>
+    <p:spTree>
+      <p:nvGrpSpPr>
+        <p:cNvPr id="1" name=""/>
+        <p:cNvGrpSpPr/>
+        <p:nvPr/>
+      </p:nvGrpSpPr>
+      <p:grpSpPr/>
+      <p:sp>
+        <p:nvSpPr>
+          <p:cNvPr id="2" name="TextBox 1"/>
+          <p:cNvSpPr txBox="1"/>
+          <p:nvPr/>
+        </p:nvSpPr>
+        <p:spPr>
+          <a:xfrm>
+            <a:off x="457200" y="228600"/>
+            <a:ext cx="11155680" cy="457200"/>
+          </a:xfrm>
+          <a:prstGeom prst="rect">
+            <a:avLst/>
+          </a:prstGeom>
+          <a:noFill/>
+        </p:spPr>
+        <p:txBody>
+          <a:bodyPr wrap="square">
+            <a:spAutoFit/>
+          </a:bodyPr>
+          <a:lstStyle/>
+          <a:p>
+            <a:r>
+              <a:rPr sz="2200" b="1">
+                <a:solidFill>
+                  <a:srgbClr val="3D5A80"/>
+                </a:solidFill>
+              </a:rPr>
+              <a:t>GLOSSARY · METRIC ABBREVIATIONS</a:t>
+            </a:r>
+          </a:p>
+        </p:txBody>
+      </p:sp>
+      <p:sp>
+        <p:nvSpPr>
+          <p:cNvPr id="3" name="TextBox 2"/>
+          <p:cNvSpPr txBox="1"/>
+          <p:nvPr/>
+        </p:nvSpPr>
+        <p:spPr>
+          <a:xfrm>
+            <a:off x="457200" y="822960"/>
+            <a:ext cx="5486400" cy="5669280"/>
+          </a:xfrm>
+          <a:prstGeom prst="rect">
+            <a:avLst/>
+          </a:prstGeom>
+          <a:noFill/>
+        </p:spPr>
+        <p:txBody>
+          <a:bodyPr wrap="square">
+            <a:spAutoFit/>
+          </a:bodyPr>
+          <a:lstStyle/>
+          <a:p>
+            <a:r>
+              <a:rPr sz="1100" b="0">
+                <a:solidFill>
+                  <a:srgbClr val="333333"/>
+                </a:solidFill>
+              </a:rPr>
+              <a:t>FBref (examples)</a:t>
+            </a:r>
+          </a:p>
+          <a:p>
+            <a:r>
+              <a:rPr sz="1100" b="0">
+                <a:solidFill>
+                  <a:srgbClr val="333333"/>
+                </a:solidFill>
+              </a:rPr>
+              <a:t>DEFPE — Defensive penalty-area touches /90</a:t>
+            </a:r>
+          </a:p>
+          <a:p>
+            <a:r>
+              <a:rPr sz="1100" b="0">
+                <a:solidFill>
+                  <a:srgbClr val="333333"/>
+                </a:solidFill>
+              </a:rPr>
+              <a:t>DEF3R — Defensive-third touches /90</a:t>
+            </a:r>
+          </a:p>
+          <a:p>
+            <a:r>
+              <a:rPr sz="1100" b="0">
+                <a:solidFill>
+                  <a:srgbClr val="333333"/>
+                </a:solidFill>
+              </a:rPr>
+              <a:t>PRGC — Progressive carries /90</a:t>
+            </a:r>
+          </a:p>
+          <a:p>
+            <a:r>
+              <a:rPr sz="1100" b="0">
+                <a:solidFill>
+                  <a:srgbClr val="333333"/>
+                </a:solidFill>
+              </a:rPr>
+              <a:t>PRGDI — Progressive carry distance /90</a:t>
+            </a:r>
+          </a:p>
+          <a:p>
+            <a:r>
+              <a:rPr sz="1100" b="0">
+                <a:solidFill>
+                  <a:srgbClr val="333333"/>
+                </a:solidFill>
+              </a:rPr>
+              <a:t>PRGRR — Progressive receives /90</a:t>
+            </a:r>
+          </a:p>
+          <a:p>
+            <a:r>
+              <a:rPr sz="1100" b="0">
+                <a:solidFill>
+                  <a:srgbClr val="333333"/>
+                </a:solidFill>
+              </a:rPr>
+              <a:t>XG — Expected goals /90</a:t>
+            </a:r>
+          </a:p>
+          <a:p>
+            <a:r>
+              <a:rPr sz="1100" b="0">
+                <a:solidFill>
+                  <a:srgbClr val="333333"/>
+                </a:solidFill>
+              </a:rPr>
+              <a:t>GLS — Goals /90</a:t>
+            </a:r>
+          </a:p>
+          <a:p>
+            <a:r>
+              <a:rPr sz="1100" b="0">
+                <a:solidFill>
+                  <a:srgbClr val="333333"/>
+                </a:solidFill>
+              </a:rPr>
+              <a:t>SOTPE / ATTSH — Shots on target /90</a:t>
+            </a:r>
+          </a:p>
+          <a:p>
+            <a:r>
+              <a:rPr sz="1100" b="0">
+                <a:solidFill>
+                  <a:srgbClr val="333333"/>
+                </a:solidFill>
+              </a:rPr>
+              <a:t>FINAL — Passes into final third /90</a:t>
+            </a:r>
+          </a:p>
+          <a:p>
+            <a:r>
+              <a:rPr sz="1100" b="0">
+                <a:solidFill>
+                  <a:srgbClr val="333333"/>
+                </a:solidFill>
+              </a:rPr>
+              <a:t>KP — Key passes /90</a:t>
+            </a:r>
+          </a:p>
+          <a:p>
+            <a:r>
+              <a:rPr sz="1100" b="0">
+                <a:solidFill>
+                  <a:srgbClr val="333333"/>
+                </a:solidFill>
+              </a:rPr>
+              <a:t>SH — Shot blocks /90</a:t>
+            </a:r>
+          </a:p>
+          <a:p>
+            <a:r>
+              <a:rPr sz="1100" b="0">
+                <a:solidFill>
+                  <a:srgbClr val="333333"/>
+                </a:solidFill>
+              </a:rPr>
+              <a:t>TKLD — Tackled (take-ons) /90</a:t>
+            </a:r>
+          </a:p>
+          <a:p>
+            <a:r>
+              <a:rPr sz="1100" b="0">
+                <a:solidFill>
+                  <a:srgbClr val="333333"/>
+                </a:solidFill>
+              </a:rPr>
+              <a:t>CLR — Clearances /90</a:t>
+            </a:r>
+          </a:p>
+          <a:p>
+            <a:r>
+              <a:rPr sz="1100" b="0">
+                <a:solidFill>
+                  <a:srgbClr val="333333"/>
+                </a:solidFill>
+              </a:rPr>
+              <a:t>INT — Interceptions /90</a:t>
+            </a:r>
+          </a:p>
+          <a:p>
+            <a:r>
+              <a:rPr sz="1100" b="0">
+                <a:solidFill>
+                  <a:srgbClr val="333333"/>
+                </a:solidFill>
+              </a:rPr>
+              <a:t>ATTLO — Long pass attempts /90</a:t>
+            </a:r>
+          </a:p>
+          <a:p>
+            <a:r>
+              <a:rPr sz="1100" b="0">
+                <a:solidFill>
+                  <a:srgbClr val="333333"/>
+                </a:solidFill>
+              </a:rPr>
+              <a:t>FLD — Fouls drawn /90</a:t>
+            </a:r>
+          </a:p>
+        </p:txBody>
+      </p:sp>
+      <p:sp>
+        <p:nvSpPr>
+          <p:cNvPr id="4" name="TextBox 3"/>
+          <p:cNvSpPr txBox="1"/>
+          <p:nvPr/>
+        </p:nvSpPr>
+        <p:spPr>
+          <a:xfrm>
+            <a:off x="6126480" y="822960"/>
+            <a:ext cx="5486400" cy="5669280"/>
+          </a:xfrm>
+          <a:prstGeom prst="rect">
+            <a:avLst/>
+          </a:prstGeom>
+          <a:noFill/>
+        </p:spPr>
+        <p:txBody>
+          <a:bodyPr wrap="square">
+            <a:spAutoFit/>
+          </a:bodyPr>
+          <a:lstStyle/>
+          <a:p>
+            <a:r>
+              <a:rPr sz="1100" b="0">
+                <a:solidFill>
+                  <a:srgbClr val="333333"/>
+                </a:solidFill>
+              </a:rPr>
+              <a:t>StatsBomb</a:t>
+            </a:r>
+          </a:p>
+          <a:p>
+            <a:r>
+              <a:rPr sz="1100" b="0">
+                <a:solidFill>
+                  <a:srgbClr val="333333"/>
+                </a:solidFill>
+              </a:rPr>
+              <a:t>PPC — Progressive passes (~10m+ toward goal) /90</a:t>
+            </a:r>
+          </a:p>
+          <a:p>
+            <a:r>
+              <a:rPr sz="1100" b="0">
+                <a:solidFill>
+                  <a:srgbClr val="333333"/>
+                </a:solidFill>
+              </a:rPr>
+              <a:t>DIS — Dispossessed /90 (often inverted: fewer = better)</a:t>
+            </a:r>
+          </a:p>
+          <a:p>
+            <a:r>
+              <a:rPr sz="1100" b="0">
+                <a:solidFill>
+                  <a:srgbClr val="333333"/>
+                </a:solidFill>
+              </a:rPr>
+              <a:t>PRS — Pressures /90</a:t>
+            </a:r>
+          </a:p>
+          <a:p>
+            <a:r>
+              <a:rPr sz="1100" b="0">
+                <a:solidFill>
+                  <a:srgbClr val="333333"/>
+                </a:solidFill>
+              </a:rPr>
+              <a:t>PAS — Pass volume /90</a:t>
+            </a:r>
+          </a:p>
+          <a:p>
+            <a:r>
+              <a:rPr sz="1100" b="0">
+                <a:solidFill>
+                  <a:srgbClr val="333333"/>
+                </a:solidFill>
+              </a:rPr>
+              <a:t>CLR — Clearances /90</a:t>
+            </a:r>
+          </a:p>
+          <a:p>
+            <a:r>
+              <a:rPr sz="1100" b="0">
+                <a:solidFill>
+                  <a:srgbClr val="333333"/>
+                </a:solidFill>
+              </a:rPr>
+              <a:t>DRB — Successful dribbles /90</a:t>
+            </a:r>
+          </a:p>
+          <a:p>
+            <a:r>
+              <a:rPr sz="1100" b="0">
+                <a:solidFill>
+                  <a:srgbClr val="333333"/>
+                </a:solidFill>
+              </a:rPr>
+              <a:t>PATT — Passes into final third /90</a:t>
+            </a:r>
+          </a:p>
+          <a:p>
+            <a:r>
+              <a:rPr sz="1100" b="0">
+                <a:solidFill>
+                  <a:srgbClr val="333333"/>
+                </a:solidFill>
+              </a:rPr>
+              <a:t>SH — Shots /90</a:t>
+            </a:r>
+          </a:p>
+          <a:p>
+            <a:r>
+              <a:rPr sz="1100" b="0">
+                <a:solidFill>
+                  <a:srgbClr val="333333"/>
+                </a:solidFill>
+              </a:rPr>
+              <a:t>XG — Non-penalty expected goals /90</a:t>
+            </a:r>
+          </a:p>
+          <a:p>
+            <a:r>
+              <a:rPr sz="1100" b="0">
+                <a:solidFill>
+                  <a:srgbClr val="333333"/>
+                </a:solidFill>
+              </a:rPr>
+              <a:t/>
+            </a:r>
+          </a:p>
+          <a:p>
+            <a:r>
+              <a:rPr sz="1100" b="0">
+                <a:solidFill>
+                  <a:srgbClr val="333333"/>
+                </a:solidFill>
+              </a:rPr>
+              <a:t>Other terms</a:t>
+            </a:r>
+          </a:p>
+          <a:p>
+            <a:r>
+              <a:rPr sz="1100" b="0">
+                <a:solidFill>
+                  <a:srgbClr val="333333"/>
+                </a:solidFill>
+              </a:rPr>
+              <a:t>Pearson r — linear correlation (stability)</a:t>
+            </a:r>
+          </a:p>
+          <a:p>
+            <a:r>
+              <a:rPr sz="1100" b="0">
+                <a:solidFill>
+                  <a:srgbClr val="333333"/>
+                </a:solidFill>
+              </a:rPr>
+              <a:t>Spearman ρ — rank correlation (success vs minutes)</a:t>
+            </a:r>
+          </a:p>
+          <a:p>
+            <a:r>
+              <a:rPr sz="1100" b="0">
+                <a:solidFill>
+                  <a:srgbClr val="333333"/>
+                </a:solidFill>
+              </a:rPr>
+              <a:t>Y1 / Year-1 — first Bundesliga season</a:t>
+            </a:r>
+          </a:p>
+          <a:p>
+            <a:r>
+              <a:rPr sz="1100" b="0">
+                <a:solidFill>
+                  <a:srgbClr val="333333"/>
+                </a:solidFill>
+              </a:rPr>
+              <a:t>Feeder league — prior league before Bundesliga arrival</a:t>
+            </a:r>
+          </a:p>
+          <a:p>
+            <a:r>
+              <a:rPr sz="1100" b="0">
+                <a:solidFill>
+                  <a:srgbClr val="333333"/>
+                </a:solidFill>
+              </a:rPr>
+              <a:t>n≥8 — only show leagues with ≥8 players in the cell</a:t>
+            </a:r>
+          </a:p>
+        </p:txBody>
+      </p:sp>
+    </p:spTree>
+  </p:cSld>
+  <p:clrMapOvr>
+    <a:masterClrMapping/>
+  </p:clrMapOvr>
+</p:sld>
+</file>
+
+<file path=ppt/slides/slide23.xml><?xml version="1.0" encoding="utf-8"?>
 <p:sld xmlns:a="http://schemas.openxmlformats.org/drawingml/2006/main" xmlns:r="http://schemas.openxmlformats.org/officeDocument/2006/relationships" xmlns:p="http://schemas.openxmlformats.org/presentationml/2006/main">
   <p:cSld>
     <p:spTree>
@@ -14571,248 +14451,73 @@
               </a:spcAft>
             </a:pPr>
             <a:r>
-              <a:rPr lang="en-US" sz="2800" b="1" dirty="0">
-                <a:solidFill>
-                  <a:srgbClr val="3D5A80"/>
-                </a:solidFill>
-                <a:latin typeface="Arial" panose="020B0604020202020204" pitchFamily="34" charset="0"/>
-                <a:cs typeface="Arial" panose="020B0604020202020204" pitchFamily="34" charset="0"/>
-              </a:rPr>
-              <a:t>DELIVERABLES</a:t>
-            </a:r>
-          </a:p>
-          <a:p>
-            <a:pPr>
-              <a:spcAft>
-                <a:spcPts val="400"/>
-              </a:spcAft>
-            </a:pPr>
-            <a:endParaRPr sz="2400" b="0" dirty="0">
-              <a:latin typeface="Arial" panose="020B0604020202020204" pitchFamily="34" charset="0"/>
-              <a:cs typeface="Arial" panose="020B0604020202020204" pitchFamily="34" charset="0"/>
-            </a:endParaRPr>
-          </a:p>
-          <a:p>
-            <a:r>
-              <a:rPr sz="1600" b="0" dirty="0">
-                <a:latin typeface="Arial" panose="020B0604020202020204" pitchFamily="34" charset="0"/>
-                <a:cs typeface="Arial" panose="020B0604020202020204" pitchFamily="34" charset="0"/>
-              </a:rPr>
-              <a:t>1 · Cohort </a:t>
-            </a:r>
-            <a:r>
-              <a:rPr lang="en-US" sz="1600" b="0" dirty="0">
-                <a:latin typeface="Arial" panose="020B0604020202020204" pitchFamily="34" charset="0"/>
-                <a:cs typeface="Arial" panose="020B0604020202020204" pitchFamily="34" charset="0"/>
-              </a:rPr>
-              <a:t>of players </a:t>
-            </a:r>
-            <a:r>
-              <a:rPr sz="1600" b="0" dirty="0">
-                <a:latin typeface="Arial" panose="020B0604020202020204" pitchFamily="34" charset="0"/>
-                <a:cs typeface="Arial" panose="020B0604020202020204" pitchFamily="34" charset="0"/>
-              </a:rPr>
-              <a:t>(</a:t>
-            </a:r>
-            <a:r>
-              <a:rPr lang="en-US" sz="1600" b="0" dirty="0">
-                <a:latin typeface="Arial" panose="020B0604020202020204" pitchFamily="34" charset="0"/>
-                <a:cs typeface="Arial" panose="020B0604020202020204" pitchFamily="34" charset="0"/>
-              </a:rPr>
-              <a:t>with </a:t>
-            </a:r>
-            <a:r>
-              <a:rPr sz="1600" b="0" dirty="0">
-                <a:latin typeface="Arial" panose="020B0604020202020204" pitchFamily="34" charset="0"/>
-                <a:cs typeface="Arial" panose="020B0604020202020204" pitchFamily="34" charset="0"/>
-              </a:rPr>
-              <a:t>minute floors) · 2 · Stability · 3 · Redundancy · 4 · Explorer + success</a:t>
-            </a:r>
-          </a:p>
-          <a:p>
-            <a:endParaRPr sz="1600" b="0" dirty="0">
-              <a:latin typeface="Arial" panose="020B0604020202020204" pitchFamily="34" charset="0"/>
-              <a:cs typeface="Arial" panose="020B0604020202020204" pitchFamily="34" charset="0"/>
-            </a:endParaRPr>
-          </a:p>
-          <a:p>
-            <a:pPr algn="ctr"/>
-            <a:r>
-              <a:rPr lang="en-US" sz="1600" b="0" dirty="0">
-                <a:latin typeface="Arial" panose="020B0604020202020204" pitchFamily="34" charset="0"/>
-                <a:cs typeface="Arial" panose="020B0604020202020204" pitchFamily="34" charset="0"/>
-              </a:rPr>
-              <a:t>		Repo: </a:t>
-            </a:r>
-            <a:r>
-              <a:rPr sz="1600" b="1" i="1" dirty="0">
-                <a:latin typeface="Arial" panose="020B0604020202020204" pitchFamily="34" charset="0"/>
-                <a:cs typeface="Arial" panose="020B0604020202020204" pitchFamily="34" charset="0"/>
-              </a:rPr>
-              <a:t>Deck · </a:t>
-            </a:r>
-            <a:r>
-              <a:rPr lang="en-US" sz="1600" b="1" i="1">
-                <a:latin typeface="Arial" panose="020B0604020202020204" pitchFamily="34" charset="0"/>
-                <a:cs typeface="Arial" panose="020B0604020202020204" pitchFamily="34" charset="0"/>
-              </a:rPr>
-              <a:t>README.md </a:t>
-            </a:r>
-            <a:r>
-              <a:rPr lang="en-US" sz="1600" b="1" i="1" dirty="0">
-                <a:latin typeface="Arial" panose="020B0604020202020204" pitchFamily="34" charset="0"/>
-                <a:cs typeface="Arial" panose="020B0604020202020204" pitchFamily="34" charset="0"/>
-              </a:rPr>
-              <a:t>· </a:t>
-            </a:r>
-            <a:r>
-              <a:rPr sz="1600" b="1" i="1" dirty="0" err="1">
-                <a:latin typeface="Arial" panose="020B0604020202020204" pitchFamily="34" charset="0"/>
-                <a:cs typeface="Arial" panose="020B0604020202020204" pitchFamily="34" charset="0"/>
-              </a:rPr>
-              <a:t>interactive_player_explorer.html</a:t>
-            </a:r>
-            <a:r>
-              <a:rPr sz="1600" b="1" i="1" dirty="0">
-                <a:latin typeface="Arial" panose="020B0604020202020204" pitchFamily="34" charset="0"/>
-                <a:cs typeface="Arial" panose="020B0604020202020204" pitchFamily="34" charset="0"/>
-              </a:rPr>
-              <a:t> · </a:t>
-            </a:r>
-            <a:r>
-              <a:rPr sz="1600" b="1" i="1" dirty="0" err="1">
-                <a:latin typeface="Arial" panose="020B0604020202020204" pitchFamily="34" charset="0"/>
-                <a:cs typeface="Arial" panose="020B0604020202020204" pitchFamily="34" charset="0"/>
-              </a:rPr>
-              <a:t>stability_redundancy_inspector.html</a:t>
-            </a:r>
-            <a:endParaRPr sz="1600" b="1" i="1" dirty="0">
-              <a:latin typeface="Arial" panose="020B0604020202020204" pitchFamily="34" charset="0"/>
-              <a:cs typeface="Arial" panose="020B0604020202020204" pitchFamily="34" charset="0"/>
-            </a:endParaRPr>
-          </a:p>
-          <a:p>
-            <a:pPr algn="ctr"/>
-            <a:r>
-              <a:rPr sz="1600" b="1" i="1" dirty="0" err="1">
-                <a:latin typeface="Arial" panose="020B0604020202020204" pitchFamily="34" charset="0"/>
-                <a:cs typeface="Arial" panose="020B0604020202020204" pitchFamily="34" charset="0"/>
-              </a:rPr>
-              <a:t>projectproposal</a:t>
-            </a:r>
-            <a:r>
-              <a:rPr sz="1600" b="1" i="1" dirty="0">
-                <a:latin typeface="Arial" panose="020B0604020202020204" pitchFamily="34" charset="0"/>
-                <a:cs typeface="Arial" panose="020B0604020202020204" pitchFamily="34" charset="0"/>
-              </a:rPr>
-              <a:t> </a:t>
-            </a:r>
-          </a:p>
-          <a:p>
-            <a:endParaRPr sz="1600" b="0" dirty="0">
-              <a:highlight>
-                <a:srgbClr val="C0C0C0"/>
-              </a:highlight>
-              <a:latin typeface="Arial" panose="020B0604020202020204" pitchFamily="34" charset="0"/>
-              <a:cs typeface="Arial" panose="020B0604020202020204" pitchFamily="34" charset="0"/>
-            </a:endParaRPr>
-          </a:p>
-          <a:p>
-            <a:r>
-              <a:rPr lang="en-US" sz="1600" b="0" dirty="0">
-                <a:latin typeface="Arial" panose="020B0604020202020204" pitchFamily="34" charset="0"/>
-                <a:cs typeface="Arial" panose="020B0604020202020204" pitchFamily="34" charset="0"/>
-              </a:rPr>
-              <a:t>Stability </a:t>
-            </a:r>
-            <a:r>
-              <a:rPr sz="1600" b="0" dirty="0">
-                <a:latin typeface="Arial" panose="020B0604020202020204" pitchFamily="34" charset="0"/>
-                <a:cs typeface="Arial" panose="020B0604020202020204" pitchFamily="34" charset="0"/>
-              </a:rPr>
-              <a:t>Gates: </a:t>
-            </a:r>
-            <a:r>
-              <a:rPr sz="1600" b="0" dirty="0" err="1">
-                <a:latin typeface="Arial" panose="020B0604020202020204" pitchFamily="34" charset="0"/>
-                <a:cs typeface="Arial" panose="020B0604020202020204" pitchFamily="34" charset="0"/>
-              </a:rPr>
-              <a:t>FBref</a:t>
-            </a:r>
-            <a:r>
-              <a:rPr sz="1600" b="0" dirty="0">
-                <a:latin typeface="Arial" panose="020B0604020202020204" pitchFamily="34" charset="0"/>
-                <a:cs typeface="Arial" panose="020B0604020202020204" pitchFamily="34" charset="0"/>
-              </a:rPr>
-              <a:t> </a:t>
-            </a:r>
-            <a:r>
-              <a:rPr sz="1600" b="0" dirty="0" err="1">
-                <a:latin typeface="Arial" panose="020B0604020202020204" pitchFamily="34" charset="0"/>
-                <a:cs typeface="Arial" panose="020B0604020202020204" pitchFamily="34" charset="0"/>
-              </a:rPr>
-              <a:t>Att</a:t>
-            </a:r>
-            <a:r>
-              <a:rPr sz="1600" b="0" dirty="0">
-                <a:latin typeface="Arial" panose="020B0604020202020204" pitchFamily="34" charset="0"/>
-                <a:cs typeface="Arial" panose="020B0604020202020204" pitchFamily="34" charset="0"/>
-              </a:rPr>
-              <a:t>/Pass/Other ≥0.60 · Def/Carry</a:t>
-            </a:r>
-            <a:r>
-              <a:rPr lang="en-US" sz="1600" b="0" dirty="0">
-                <a:latin typeface="Arial" panose="020B0604020202020204" pitchFamily="34" charset="0"/>
-                <a:cs typeface="Arial" panose="020B0604020202020204" pitchFamily="34" charset="0"/>
-              </a:rPr>
-              <a:t> metrics</a:t>
-            </a:r>
-            <a:r>
-              <a:rPr sz="1600" b="0" dirty="0">
-                <a:latin typeface="Arial" panose="020B0604020202020204" pitchFamily="34" charset="0"/>
-                <a:cs typeface="Arial" panose="020B0604020202020204" pitchFamily="34" charset="0"/>
-              </a:rPr>
-              <a:t> ≥0.50 · SB r≥0.40 · shortlist</a:t>
-            </a:r>
-            <a:r>
-              <a:rPr lang="en-US" sz="1600" b="0" dirty="0">
-                <a:latin typeface="Arial" panose="020B0604020202020204" pitchFamily="34" charset="0"/>
-                <a:cs typeface="Arial" panose="020B0604020202020204" pitchFamily="34" charset="0"/>
-              </a:rPr>
-              <a:t> of metrics</a:t>
-            </a:r>
-            <a:r>
-              <a:rPr sz="1600" b="0" dirty="0">
-                <a:latin typeface="Arial" panose="020B0604020202020204" pitchFamily="34" charset="0"/>
-                <a:cs typeface="Arial" panose="020B0604020202020204" pitchFamily="34" charset="0"/>
-              </a:rPr>
-              <a:t> </a:t>
-            </a:r>
-            <a:r>
-              <a:rPr lang="en-US" sz="1600" b="0" dirty="0">
-                <a:latin typeface="Arial" panose="020B0604020202020204" pitchFamily="34" charset="0"/>
-                <a:cs typeface="Arial" panose="020B0604020202020204" pitchFamily="34" charset="0"/>
-              </a:rPr>
-              <a:t>(</a:t>
-            </a:r>
-            <a:r>
-              <a:rPr sz="1600" b="0" dirty="0">
-                <a:latin typeface="Arial" panose="020B0604020202020204" pitchFamily="34" charset="0"/>
-                <a:cs typeface="Arial" panose="020B0604020202020204" pitchFamily="34" charset="0"/>
-              </a:rPr>
-              <a:t>32 / 7</a:t>
-            </a:r>
-            <a:r>
-              <a:rPr lang="en-US" sz="1600" b="0" dirty="0">
-                <a:latin typeface="Arial" panose="020B0604020202020204" pitchFamily="34" charset="0"/>
-                <a:cs typeface="Arial" panose="020B0604020202020204" pitchFamily="34" charset="0"/>
-              </a:rPr>
-              <a:t>)</a:t>
-            </a:r>
-            <a:endParaRPr sz="1600" b="0" dirty="0">
-              <a:latin typeface="Arial" panose="020B0604020202020204" pitchFamily="34" charset="0"/>
-              <a:cs typeface="Arial" panose="020B0604020202020204" pitchFamily="34" charset="0"/>
-            </a:endParaRPr>
+              <a:rPr sz="1300" b="0">
+                <a:solidFill>
+                  <a:srgbClr val="333333"/>
+                </a:solidFill>
+              </a:rPr>
+              <a:t>Deliverables</a:t>
+            </a:r>
+          </a:p>
+          <a:p>
+            <a:r>
+              <a:rPr sz="1300" b="0">
+                <a:solidFill>
+                  <a:srgbClr val="333333"/>
+                </a:solidFill>
+              </a:rPr>
+              <a:t/>
+            </a:r>
+          </a:p>
+          <a:p>
+            <a:r>
+              <a:rPr sz="1300" b="0">
+                <a:solidFill>
+                  <a:srgbClr val="333333"/>
+                </a:solidFill>
+              </a:rPr>
+              <a:t>1 · Cohort (with minute floors) · 2 · Stability · 3 · Redundancy · 4 · Explorer + success</a:t>
+            </a:r>
+          </a:p>
+          <a:p>
+            <a:r>
+              <a:rPr sz="1300" b="0">
+                <a:solidFill>
+                  <a:srgbClr val="333333"/>
+                </a:solidFill>
+              </a:rPr>
+              <a:t/>
+            </a:r>
+          </a:p>
+          <a:p>
+            <a:r>
+              <a:rPr sz="1300" b="0">
+                <a:solidFill>
+                  <a:srgbClr val="333333"/>
+                </a:solidFill>
+              </a:rPr>
+              <a:t>Repo: deck · README.md · interactive_player_explorer.html · stability_redundancy_inspector.html · projectproposal</a:t>
+            </a:r>
+          </a:p>
+          <a:p>
+            <a:r>
+              <a:rPr sz="1300" b="0">
+                <a:solidFill>
+                  <a:srgbClr val="333333"/>
+                </a:solidFill>
+              </a:rPr>
+              <a:t/>
+            </a:r>
+          </a:p>
+          <a:p>
+            <a:r>
+              <a:rPr sz="1300" b="0">
+                <a:solidFill>
+                  <a:srgbClr val="333333"/>
+                </a:solidFill>
+              </a:rPr>
+              <a:t>Stability floors: FBref Attacking/Passing/Other Pearson r ≥ 0.60 · Defending/Carrying Pearson r ≥ 0.50 · StatsBomb Pearson r ≥ 0.40 · final shortlists 32 / 7</a:t>
+            </a:r>
           </a:p>
         </p:txBody>
       </p:sp>
@@ -15114,63 +14819,23 @@
               </a:spcAft>
             </a:pPr>
             <a:r>
-              <a:rPr sz="1400" b="0" dirty="0">
-                <a:solidFill>
-                  <a:srgbClr val="333333"/>
-                </a:solidFill>
-                <a:latin typeface="Calibri"/>
-              </a:rPr>
-              <a:t>When a player moves into </a:t>
-            </a:r>
-            <a:r>
-              <a:rPr lang="en-US" sz="1400" dirty="0">
-                <a:solidFill>
-                  <a:srgbClr val="333333"/>
-                </a:solidFill>
-                <a:latin typeface="Calibri"/>
-              </a:rPr>
-              <a:t>the top German league, the </a:t>
-            </a:r>
-            <a:r>
-              <a:rPr sz="1400" b="0" dirty="0">
-                <a:solidFill>
-                  <a:srgbClr val="333333"/>
-                </a:solidFill>
-                <a:latin typeface="Calibri"/>
-              </a:rPr>
-              <a:t>BL, which stats stay consistent — and which are league context?</a:t>
-            </a:r>
-            <a:r>
-              <a:rPr lang="en-US" sz="1400" b="0" dirty="0">
-                <a:solidFill>
-                  <a:srgbClr val="333333"/>
-                </a:solidFill>
-                <a:latin typeface="Calibri"/>
-              </a:rPr>
-              <a:t> </a:t>
-            </a:r>
-          </a:p>
-          <a:p>
-            <a:pPr>
-              <a:spcAft>
-                <a:spcPts val="500"/>
-              </a:spcAft>
-            </a:pPr>
-            <a:r>
-              <a:rPr lang="en-US" sz="1400" i="1" dirty="0">
-                <a:solidFill>
-                  <a:srgbClr val="333333"/>
-                </a:solidFill>
-                <a:latin typeface="Calibri"/>
-              </a:rPr>
-              <a:t>This applies only to player who entered the BL from a different league. AKA player transfers</a:t>
-            </a:r>
-            <a:endParaRPr sz="1400" b="0" i="1" dirty="0">
-              <a:solidFill>
-                <a:srgbClr val="333333"/>
-              </a:solidFill>
-              <a:latin typeface="Calibri"/>
-            </a:endParaRPr>
+              <a:rPr sz="1300" b="0">
+                <a:solidFill>
+                  <a:srgbClr val="333333"/>
+                </a:solidFill>
+              </a:rPr>
+              <a:t>When a player moves into the top German league, the Bundesliga, which stats stay consistent — and which are league context?</a:t>
+            </a:r>
+          </a:p>
+          <a:p>
+            <a:r>
+              <a:rPr sz="1300" b="0">
+                <a:solidFill>
+                  <a:srgbClr val="333333"/>
+                </a:solidFill>
+              </a:rPr>
+              <a:t>This applies only to players who entered the Bundesliga from a different league (transfers / promotions).</a:t>
+            </a:r>
           </a:p>
         </p:txBody>
       </p:sp>
@@ -15421,11 +15086,10 @@
               </a:spcAft>
             </a:pPr>
             <a:r>
-              <a:rPr sz="1300" b="0" dirty="0">
-                <a:solidFill>
-                  <a:srgbClr val="333333"/>
-                </a:solidFill>
-                <a:latin typeface="Calibri"/>
+              <a:rPr sz="1300" b="0">
+                <a:solidFill>
+                  <a:srgbClr val="333333"/>
+                </a:solidFill>
               </a:rPr>
               <a:t>Stability → Redundancy → Pizza/explorer → Success</a:t>
             </a:r>
@@ -15550,31 +15214,12 @@
               </a:spcAft>
             </a:pPr>
             <a:r>
-              <a:rPr sz="1300" b="0" dirty="0" err="1">
-                <a:solidFill>
-                  <a:srgbClr val="333333"/>
-                </a:solidFill>
-                <a:latin typeface="Calibri"/>
-              </a:rPr>
-              <a:t>FBref</a:t>
-            </a:r>
-            <a:r>
-              <a:rPr sz="1300" b="0" dirty="0">
-                <a:solidFill>
-                  <a:srgbClr val="333333"/>
-                </a:solidFill>
-                <a:latin typeface="Calibri"/>
-              </a:rPr>
-              <a:t> = scale</a:t>
-            </a:r>
-            <a:r>
-              <a:rPr lang="en-US" sz="1300" b="0" dirty="0">
-                <a:solidFill>
-                  <a:srgbClr val="333333"/>
-                </a:solidFill>
-                <a:latin typeface="Calibri"/>
-              </a:rPr>
-              <a:t>d metrics, larger sample</a:t>
+              <a:rPr sz="1100" b="0">
+                <a:solidFill>
+                  <a:srgbClr val="333333"/>
+                </a:solidFill>
+              </a:rPr>
+              <a:t>FBref = scaled metrics, larger sample</a:t>
             </a:r>
             <a:endParaRPr sz="1300" b="0" dirty="0">
               <a:solidFill>
@@ -15585,40 +15230,52 @@
           </a:p>
           <a:p>
             <a:r>
-              <a:rPr sz="1300" b="0" dirty="0">
-                <a:solidFill>
-                  <a:srgbClr val="333333"/>
-                </a:solidFill>
-              </a:rPr>
-              <a:t>19 leagues · BL ≥2021 · ≥300′</a:t>
-            </a:r>
-          </a:p>
-          <a:p>
-            <a:r>
-              <a:rPr sz="1300" b="0" dirty="0">
-                <a:solidFill>
-                  <a:srgbClr val="333333"/>
-                </a:solidFill>
-              </a:rPr>
-              <a:t>N=329 · 105→43→32</a:t>
-            </a:r>
-          </a:p>
-          <a:p>
-            <a:r>
-              <a:rPr sz="1300" b="0" dirty="0" err="1">
-                <a:solidFill>
-                  <a:srgbClr val="333333"/>
-                </a:solidFill>
-              </a:rPr>
-              <a:t>Att</a:t>
-            </a:r>
-            <a:r>
-              <a:rPr sz="1300" b="0" dirty="0">
-                <a:solidFill>
-                  <a:srgbClr val="333333"/>
-                </a:solidFill>
-              </a:rPr>
-              <a:t>/Pass/Other ≥0.60 · Def/Carry ≥0.50</a:t>
+              <a:rPr sz="1100" b="0">
+                <a:solidFill>
+                  <a:srgbClr val="333333"/>
+                </a:solidFill>
+              </a:rPr>
+              <a:t>19 leagues · first Bundesliga season 2021–2025 · ≥300′</a:t>
+            </a:r>
+          </a:p>
+          <a:p>
+            <a:r>
+              <a:rPr sz="1100" b="0">
+                <a:solidFill>
+                  <a:srgbClr val="333333"/>
+                </a:solidFill>
+              </a:rPr>
+              <a:t>N=329 pairs</a:t>
+            </a:r>
+          </a:p>
+          <a:p>
+            <a:r>
+              <a:rPr sz="1100" b="0">
+                <a:solidFill>
+                  <a:srgbClr val="333333"/>
+                </a:solidFill>
+              </a:rPr>
+              <a:t>105 metrics tested → 43 met stability floor → 32 met redundancy floor (final list)</a:t>
+            </a:r>
+          </a:p>
+          <a:p>
+            <a:r>
+              <a:rPr sz="1100" b="0">
+                <a:solidFill>
+                  <a:srgbClr val="333333"/>
+                </a:solidFill>
+              </a:rPr>
+              <a:t>Attacking/Passing/Other: Pearson stability ≥0.60</a:t>
+            </a:r>
+          </a:p>
+          <a:p>
+            <a:r>
+              <a:rPr sz="1100" b="0">
+                <a:solidFill>
+                  <a:srgbClr val="333333"/>
+                </a:solidFill>
+              </a:rPr>
+              <a:t>Defending/Carrying: Pearson stability ≥0.50 (lower floor to keep enough defensive volume)</a:t>
             </a:r>
           </a:p>
         </p:txBody>
@@ -15741,49 +15398,12 @@
               </a:spcAft>
             </a:pPr>
             <a:r>
-              <a:rPr sz="1300" b="0" dirty="0" err="1">
-                <a:solidFill>
-                  <a:srgbClr val="333333"/>
-                </a:solidFill>
-                <a:latin typeface="Calibri"/>
-              </a:rPr>
-              <a:t>StatsBomb</a:t>
-            </a:r>
-            <a:r>
-              <a:rPr sz="1300" b="0" dirty="0">
-                <a:solidFill>
-                  <a:srgbClr val="333333"/>
-                </a:solidFill>
-                <a:latin typeface="Calibri"/>
-              </a:rPr>
-              <a:t> = </a:t>
-            </a:r>
-            <a:r>
-              <a:rPr lang="en-US" sz="1300" b="0" dirty="0">
-                <a:solidFill>
-                  <a:srgbClr val="333333"/>
-                </a:solidFill>
-                <a:latin typeface="Calibri"/>
-              </a:rPr>
-              <a:t>metric </a:t>
-            </a:r>
-            <a:r>
-              <a:rPr sz="1300" b="0" dirty="0">
-                <a:solidFill>
-                  <a:srgbClr val="333333"/>
-                </a:solidFill>
-                <a:latin typeface="Calibri"/>
-              </a:rPr>
-              <a:t>depth</a:t>
-            </a:r>
-            <a:r>
-              <a:rPr lang="en-US" sz="1300" b="0" dirty="0">
-                <a:solidFill>
-                  <a:srgbClr val="333333"/>
-                </a:solidFill>
-                <a:latin typeface="Calibri"/>
-              </a:rPr>
-              <a:t>, smaller sample</a:t>
+              <a:rPr sz="1100" b="0">
+                <a:solidFill>
+                  <a:srgbClr val="333333"/>
+                </a:solidFill>
+              </a:rPr>
+              <a:t>StatsBomb = metric depth, smaller sample</a:t>
             </a:r>
             <a:endParaRPr sz="1300" b="0" dirty="0">
               <a:solidFill>
@@ -15794,32 +15414,32 @@
           </a:p>
           <a:p>
             <a:r>
-              <a:rPr sz="1300" b="0" dirty="0">
-                <a:solidFill>
-                  <a:srgbClr val="333333"/>
-                </a:solidFill>
-              </a:rPr>
-              <a:t>N=96 · ≥45′ / ≥30′</a:t>
-            </a:r>
-          </a:p>
-          <a:p>
-            <a:r>
-              <a:rPr sz="1300" b="0" dirty="0">
-                <a:solidFill>
-                  <a:srgbClr val="333333"/>
-                </a:solidFill>
-              </a:rPr>
-              <a:t>r≥0.40 → 7 · |r|≥0.85 keep all 7</a:t>
-            </a:r>
-          </a:p>
-          <a:p>
-            <a:r>
-              <a:rPr sz="1300" b="0" dirty="0">
-                <a:solidFill>
-                  <a:srgbClr val="333333"/>
-                </a:solidFill>
-              </a:rPr>
-              <a:t>Priors: 17 comps · BL 2015/16 + 2023/24</a:t>
+              <a:rPr sz="1100" b="0">
+                <a:solidFill>
+                  <a:srgbClr val="333333"/>
+                </a:solidFill>
+              </a:rPr>
+              <a:t>N=96 · prior ≥45′ / Year-1 ≥30′</a:t>
+            </a:r>
+          </a:p>
+          <a:p>
+            <a:r>
+              <a:rPr sz="1100" b="0">
+                <a:solidFill>
+                  <a:srgbClr val="333333"/>
+                </a:solidFill>
+              </a:rPr>
+              <a:t>Pearson r≥0.40 → 7 of 16 · Pearson |r|≥0.85 keep all 7</a:t>
+            </a:r>
+          </a:p>
+          <a:p>
+            <a:r>
+              <a:rPr sz="1100" b="0">
+                <a:solidFill>
+                  <a:srgbClr val="333333"/>
+                </a:solidFill>
+              </a:rPr>
+              <a:t>Priors: 17 competitions · Bundesliga 2015/16 + 2023/24</a:t>
             </a:r>
           </a:p>
         </p:txBody>
@@ -16037,7 +15657,7 @@
               </a:spcAft>
             </a:pPr>
             <a:r>
-              <a:rPr sz="1300" b="0" dirty="0">
+              <a:rPr sz="1200" b="0">
                 <a:solidFill>
                   <a:srgbClr val="333333"/>
                 </a:solidFill>
@@ -16046,34 +15666,33 @@
             </a:r>
           </a:p>
           <a:p>
-            <a:pPr>
-              <a:spcAft>
-                <a:spcPts val="400"/>
-              </a:spcAft>
-            </a:pPr>
-            <a:r>
-              <a:rPr sz="1200" b="0" dirty="0">
-                <a:solidFill>
-                  <a:srgbClr val="333333"/>
-                </a:solidFill>
-              </a:rPr>
-              <a:t>Pearson r = stability · Spearman </a:t>
-            </a:r>
-            <a:r>
-              <a:rPr sz="1200" b="0" dirty="0" err="1">
-                <a:solidFill>
-                  <a:srgbClr val="333333"/>
-                </a:solidFill>
-              </a:rPr>
-              <a:t>ρ</a:t>
-            </a:r>
-            <a:r>
-              <a:rPr sz="1200" b="0" dirty="0">
-                <a:solidFill>
-                  <a:srgbClr val="333333"/>
-                </a:solidFill>
-              </a:rPr>
-              <a:t> = success (rank-based; robust when Y1 minutes are skewed) · redundancy · percentiles</a:t>
+            <a:r>
+              <a:rPr sz="1200" b="0">
+                <a:solidFill>
+                  <a:srgbClr val="333333"/>
+                </a:solidFill>
+              </a:rPr>
+              <a:t>Pearson r = stability (does the prior ranking of a rate recur in Bundesliga Year-1?).</a:t>
+            </a:r>
+          </a:p>
+          <a:p>
+            <a:r>
+              <a:rPr sz="1200" b="0">
+                <a:solidFill>
+                  <a:srgbClr val="333333"/>
+                </a:solidFill>
+              </a:rPr>
+              <a:t>Spearman ρ = success (do higher prior trait ranks line up with more Year-1 minutes — rank-based, robust when minutes are skewed).</a:t>
+            </a:r>
+          </a:p>
+          <a:p>
+            <a:r>
+              <a:rPr sz="1200" b="0">
+                <a:solidFill>
+                  <a:srgbClr val="333333"/>
+                </a:solidFill>
+              </a:rPr>
+              <a:t>Then redundancy pruning and peer percentiles.</a:t>
             </a:r>
           </a:p>
         </p:txBody>
@@ -16244,7 +15863,7 @@
                   <a:srgbClr val="333333"/>
                 </a:solidFill>
               </a:rPr>
-              <a:t>Trait portability — prior ↔ BL Y1 stability r</a:t>
+              <a:t>Trait portability — prior ↔ Bundesliga Year-1 stability r</a:t>
             </a:r>
           </a:p>
           <a:p>
@@ -17001,116 +16620,93 @@
               </a:spcAft>
             </a:pPr>
             <a:r>
-              <a:rPr sz="1300" b="0" dirty="0">
-                <a:solidFill>
-                  <a:srgbClr val="333333"/>
-                </a:solidFill>
-                <a:latin typeface="Calibri"/>
+              <a:rPr sz="1200">
+                <a:solidFill>
+                  <a:srgbClr val="333333"/>
+                </a:solidFill>
               </a:rPr>
               <a:t>What we use</a:t>
             </a:r>
           </a:p>
           <a:p>
-            <a:endParaRPr sz="1300" b="0" dirty="0">
-              <a:solidFill>
-                <a:srgbClr val="333333"/>
-              </a:solidFill>
-              <a:latin typeface="Calibri"/>
-            </a:endParaRPr>
-          </a:p>
-          <a:p>
-            <a:r>
-              <a:rPr lang="en-US" sz="1300" b="0" dirty="0">
-                <a:solidFill>
-                  <a:srgbClr val="333333"/>
-                </a:solidFill>
-              </a:rPr>
-              <a:t>Outside league </a:t>
-            </a:r>
-            <a:r>
-              <a:rPr sz="1300" b="0" dirty="0">
-                <a:solidFill>
-                  <a:srgbClr val="333333"/>
-                </a:solidFill>
-              </a:rPr>
-              <a:t>tables + player-page fills</a:t>
-            </a:r>
-          </a:p>
-          <a:p>
-            <a:r>
-              <a:rPr sz="1300" b="0" dirty="0">
-                <a:solidFill>
-                  <a:srgbClr val="333333"/>
-                </a:solidFill>
-              </a:rPr>
-              <a:t>Analysis window: first BL end-years 2021–2025</a:t>
-            </a:r>
-          </a:p>
-          <a:p>
-            <a:r>
-              <a:rPr sz="1300" b="0" dirty="0">
-                <a:solidFill>
-                  <a:srgbClr val="333333"/>
-                </a:solidFill>
-              </a:rPr>
-              <a:t>Minutes: prior ≥300′ · Y1 ≥300′ → N=329 pairs · 19 leagues</a:t>
-            </a:r>
-          </a:p>
-          <a:p>
-            <a:endParaRPr sz="1300" b="0" dirty="0">
-              <a:solidFill>
-                <a:srgbClr val="333333"/>
-              </a:solidFill>
-            </a:endParaRPr>
-          </a:p>
-          <a:p>
-            <a:r>
-              <a:rPr sz="1300" b="0" dirty="0">
-                <a:solidFill>
-                  <a:srgbClr val="333333"/>
-                </a:solidFill>
-              </a:rPr>
-              <a:t>No league-relative scaling — it did not help rate→Y1 stability.</a:t>
-            </a:r>
-          </a:p>
-          <a:p>
-            <a:r>
-              <a:rPr sz="1300" b="0" dirty="0">
-                <a:solidFill>
-                  <a:srgbClr val="333333"/>
-                </a:solidFill>
-              </a:rPr>
-              <a:t>Absolute per-90 rates kept.</a:t>
-            </a:r>
-            <a:endParaRPr lang="en-US" sz="1300" b="0" dirty="0">
-              <a:solidFill>
-                <a:srgbClr val="333333"/>
-              </a:solidFill>
-            </a:endParaRPr>
-          </a:p>
-          <a:p>
-            <a:endParaRPr lang="en-US" sz="1300" dirty="0">
-              <a:solidFill>
-                <a:srgbClr val="333333"/>
-              </a:solidFill>
-            </a:endParaRPr>
-          </a:p>
-          <a:p>
-            <a:r>
-              <a:rPr lang="en-US" sz="1300" dirty="0">
+            <a:r>
+              <a:rPr sz="1200">
+                <a:solidFill>
+                  <a:srgbClr val="333333"/>
+                </a:solidFill>
+              </a:rPr>
+              <a:t/>
+            </a:r>
+          </a:p>
+          <a:p>
+            <a:r>
+              <a:rPr sz="1200">
+                <a:solidFill>
+                  <a:srgbClr val="333333"/>
+                </a:solidFill>
+              </a:rPr>
+              <a:t>Outside-league tables + player-page fills</a:t>
+            </a:r>
+          </a:p>
+          <a:p>
+            <a:r>
+              <a:rPr sz="1200">
+                <a:solidFill>
+                  <a:srgbClr val="333333"/>
+                </a:solidFill>
+              </a:rPr>
+              <a:t>Analysis window: first Bundesliga end-years 2021–2025</a:t>
+            </a:r>
+          </a:p>
+          <a:p>
+            <a:r>
+              <a:rPr sz="1200">
+                <a:solidFill>
+                  <a:srgbClr val="333333"/>
+                </a:solidFill>
+              </a:rPr>
+              <a:t>Minutes: prior ≥300′ · Year-1 ≥300′ → N=329 pairs · 19 leagues</a:t>
+            </a:r>
+          </a:p>
+          <a:p>
+            <a:r>
+              <a:rPr sz="1200">
+                <a:solidFill>
+                  <a:srgbClr val="333333"/>
+                </a:solidFill>
+              </a:rPr>
+              <a:t/>
+            </a:r>
+          </a:p>
+          <a:p>
+            <a:r>
+              <a:rPr sz="1200">
+                <a:solidFill>
+                  <a:srgbClr val="333333"/>
+                </a:solidFill>
+              </a:rPr>
+              <a:t>League-relative scaling tested and dropped: “how high vs peers in the same prior league” (z-score / percentile) did not improve prior→Year-1 stability, so we keep absolute per-90 rates.</a:t>
+            </a:r>
+          </a:p>
+          <a:p>
+            <a:r>
+              <a:rPr sz="1200">
+                <a:solidFill>
+                  <a:srgbClr val="333333"/>
+                </a:solidFill>
+              </a:rPr>
+              <a:t/>
+            </a:r>
+          </a:p>
+          <a:p>
+            <a:r>
+              <a:rPr sz="1200">
                 <a:solidFill>
                   <a:srgbClr val="333333"/>
                 </a:solidFill>
               </a:rPr>
               <a:t>Window · 2021–2025 · ≥300′ both sides · N=329</a:t>
             </a:r>
-          </a:p>
-          <a:p>
-            <a:endParaRPr sz="1300" b="0" dirty="0">
-              <a:solidFill>
-                <a:srgbClr val="333333"/>
-              </a:solidFill>
-            </a:endParaRPr>
           </a:p>
         </p:txBody>
       </p:sp>
@@ -17255,61 +16851,62 @@
               </a:spcAft>
             </a:pPr>
             <a:r>
-              <a:rPr sz="1300" b="0" dirty="0">
-                <a:solidFill>
-                  <a:srgbClr val="333333"/>
-                </a:solidFill>
-                <a:latin typeface="Calibri"/>
+              <a:rPr sz="1200" b="0">
+                <a:solidFill>
+                  <a:srgbClr val="333333"/>
+                </a:solidFill>
               </a:rPr>
               <a:t>What we use</a:t>
             </a:r>
           </a:p>
           <a:p>
-            <a:endParaRPr sz="1300" b="0" dirty="0">
-              <a:solidFill>
-                <a:srgbClr val="333333"/>
-              </a:solidFill>
-              <a:latin typeface="Calibri"/>
-            </a:endParaRPr>
-          </a:p>
-          <a:p>
-            <a:r>
-              <a:rPr sz="1300" b="0" dirty="0">
-                <a:solidFill>
-                  <a:srgbClr val="333333"/>
-                </a:solidFill>
-              </a:rPr>
-              <a:t>All male open comps as priors</a:t>
-            </a:r>
-          </a:p>
-          <a:p>
-            <a:r>
-              <a:rPr sz="1300" b="0" dirty="0">
-                <a:solidFill>
-                  <a:srgbClr val="333333"/>
-                </a:solidFill>
-              </a:rPr>
-              <a:t>BL open dumps: 2015/16 + 2023/24 only</a:t>
-            </a:r>
-          </a:p>
-          <a:p>
-            <a:r>
-              <a:rPr sz="1300" b="0" dirty="0">
-                <a:solidFill>
-                  <a:srgbClr val="333333"/>
-                </a:solidFill>
-              </a:rPr>
-              <a:t>N=96 · prior ≥45′ · Y1 ≥30′</a:t>
-            </a:r>
-          </a:p>
-          <a:p>
-            <a:r>
-              <a:rPr sz="1300" b="0" dirty="0">
-                <a:solidFill>
-                  <a:srgbClr val="333333"/>
-                </a:solidFill>
-              </a:rPr>
-              <a:t>r≥0.40 → 7 · |r|≥0.85 → keep all 7</a:t>
+            <a:r>
+              <a:rPr sz="1200" b="0">
+                <a:solidFill>
+                  <a:srgbClr val="333333"/>
+                </a:solidFill>
+              </a:rPr>
+              <a:t/>
+            </a:r>
+          </a:p>
+          <a:p>
+            <a:r>
+              <a:rPr sz="1200" b="0">
+                <a:solidFill>
+                  <a:srgbClr val="333333"/>
+                </a:solidFill>
+              </a:rPr>
+              <a:t>All male open competitions as priors</a:t>
+            </a:r>
+          </a:p>
+          <a:p>
+            <a:r>
+              <a:rPr sz="1200" b="0">
+                <a:solidFill>
+                  <a:srgbClr val="333333"/>
+                </a:solidFill>
+              </a:rPr>
+              <a:t>1. Bundesliga open dumps: 2015/16 + 2023/24 only</a:t>
+            </a:r>
+          </a:p>
+          <a:p>
+            <a:r>
+              <a:rPr sz="1200" b="0">
+                <a:solidFill>
+                  <a:srgbClr val="333333"/>
+                </a:solidFill>
+              </a:rPr>
+              <a:t>N=96 · prior ≥45′ · Year-1 ≥30′</a:t>
+            </a:r>
+          </a:p>
+          <a:p>
+            <a:r>
+              <a:rPr sz="1200" b="0">
+                <a:solidFill>
+                  <a:srgbClr val="333333"/>
+                </a:solidFill>
+              </a:rPr>
+              <a:t>Pearson r≥0.40 → 7 · Pearson |r|≥0.85 → keep all 7</a:t>
             </a:r>
           </a:p>
         </p:txBody>
@@ -17347,22 +16944,12 @@
               </a:spcAft>
             </a:pPr>
             <a:r>
-              <a:rPr sz="1300" b="0" dirty="0">
-                <a:solidFill>
-                  <a:srgbClr val="333333"/>
-                </a:solidFill>
-                <a:latin typeface="Calibri"/>
-              </a:rPr>
-              <a:t>vs </a:t>
-            </a:r>
-            <a:r>
-              <a:rPr sz="1300" b="0" dirty="0" err="1">
-                <a:solidFill>
-                  <a:srgbClr val="333333"/>
-                </a:solidFill>
-                <a:latin typeface="Calibri"/>
-              </a:rPr>
-              <a:t>FBref</a:t>
+              <a:rPr sz="1200">
+                <a:solidFill>
+                  <a:srgbClr val="333333"/>
+                </a:solidFill>
+              </a:rPr>
+              <a:t>vs FBref</a:t>
             </a:r>
             <a:endParaRPr sz="1300" b="0" dirty="0">
               <a:solidFill>
@@ -17373,7 +16960,7 @@
           </a:p>
           <a:p>
             <a:r>
-              <a:rPr sz="1300" b="0" dirty="0">
+              <a:rPr sz="1200">
                 <a:solidFill>
                   <a:srgbClr val="333333"/>
                 </a:solidFill>
@@ -17383,7 +16970,7 @@
           </a:p>
           <a:p>
             <a:r>
-              <a:rPr sz="1300" b="0" dirty="0">
+              <a:rPr sz="1200">
                 <a:solidFill>
                   <a:srgbClr val="333333"/>
                 </a:solidFill>
@@ -17392,46 +16979,23 @@
             </a:r>
           </a:p>
           <a:p>
-            <a:endParaRPr sz="1300" b="0" dirty="0">
-              <a:solidFill>
-                <a:srgbClr val="333333"/>
-              </a:solidFill>
-            </a:endParaRPr>
-          </a:p>
-          <a:p>
-            <a:r>
-              <a:rPr sz="1300" b="0" dirty="0">
-                <a:solidFill>
-                  <a:srgbClr val="333333"/>
-                </a:solidFill>
-              </a:rPr>
-              <a:t>No relative scaling: failed on </a:t>
-            </a:r>
-            <a:r>
-              <a:rPr sz="1300" b="0" dirty="0" err="1">
-                <a:solidFill>
-                  <a:srgbClr val="333333"/>
-                </a:solidFill>
-              </a:rPr>
-              <a:t>FBref</a:t>
-            </a:r>
-            <a:r>
-              <a:rPr sz="1300" b="0" dirty="0">
-                <a:solidFill>
-                  <a:srgbClr val="333333"/>
-                </a:solidFill>
-              </a:rPr>
-              <a:t>; SB priors are mixed</a:t>
-            </a:r>
-          </a:p>
-          <a:p>
-            <a:r>
-              <a:rPr sz="1300" b="0" dirty="0">
-                <a:solidFill>
-                  <a:srgbClr val="333333"/>
-                </a:solidFill>
-              </a:rPr>
-              <a:t>(WC / Euro / CL / leagues), so even less appropriate.</a:t>
+            <a:r>
+              <a:rPr sz="1200">
+                <a:solidFill>
+                  <a:srgbClr val="333333"/>
+                </a:solidFill>
+              </a:rPr>
+              <a:t/>
+            </a:r>
+          </a:p>
+          <a:p>
+            <a:r>
+              <a:rPr sz="1200">
+                <a:solidFill>
+                  <a:srgbClr val="333333"/>
+                </a:solidFill>
+              </a:rPr>
+              <a:t>No relative scaling: same peer-rank idea failed on FBref. StatsBomb priors mix FIFA World Cup, UEFA European Championship (Euro), UEFA Champions League, and other pro leagues, so within-league peer ranks are even less meaningful here.</a:t>
             </a:r>
           </a:p>
         </p:txBody>
@@ -17585,7 +17149,7 @@
               <a:buChar char="•"/>
             </a:pPr>
             <a:r>
-              <a:rPr sz="1200" b="0" dirty="0">
+              <a:rPr sz="1200" b="0">
                 <a:solidFill>
                   <a:srgbClr val="333333"/>
                 </a:solidFill>
@@ -17599,26 +17163,18 @@
             </a:endParaRPr>
           </a:p>
           <a:p>
-            <a:pPr marL="171450" indent="-171450" algn="l">
-              <a:spcAft>
-                <a:spcPts val="300"/>
-              </a:spcAft>
-              <a:buFont typeface="Arial" panose="020B0604020202020204" pitchFamily="34" charset="0"/>
-              <a:buChar char="•"/>
-            </a:pPr>
-            <a:endParaRPr sz="1200" b="0" dirty="0">
-              <a:solidFill>
-                <a:srgbClr val="333333"/>
-              </a:solidFill>
-            </a:endParaRPr>
-          </a:p>
-          <a:p>
-            <a:pPr marL="171450" indent="-171450">
-              <a:buFont typeface="Arial" panose="020B0604020202020204" pitchFamily="34" charset="0"/>
-              <a:buChar char="•"/>
-            </a:pPr>
-            <a:r>
-              <a:rPr sz="1200" b="0" dirty="0">
+            <a:r>
+              <a:rPr sz="1200" b="0">
+                <a:solidFill>
+                  <a:srgbClr val="333333"/>
+                </a:solidFill>
+              </a:rPr>
+              <a:t/>
+            </a:r>
+          </a:p>
+          <a:p>
+            <a:r>
+              <a:rPr sz="1200" b="0">
                 <a:solidFill>
                   <a:srgbClr val="333333"/>
                 </a:solidFill>
@@ -17627,23 +17183,18 @@
             </a:r>
           </a:p>
           <a:p>
-            <a:pPr marL="171450" indent="-171450">
-              <a:buFont typeface="Arial" panose="020B0604020202020204" pitchFamily="34" charset="0"/>
-              <a:buChar char="•"/>
-            </a:pPr>
-            <a:endParaRPr sz="1200" b="0" dirty="0">
-              <a:solidFill>
-                <a:srgbClr val="333333"/>
-              </a:solidFill>
-            </a:endParaRPr>
-          </a:p>
-          <a:p>
-            <a:pPr marL="171450" indent="-171450">
-              <a:buFont typeface="Arial" panose="020B0604020202020204" pitchFamily="34" charset="0"/>
-              <a:buChar char="•"/>
-            </a:pPr>
-            <a:r>
-              <a:rPr sz="1200" b="0" dirty="0">
+            <a:r>
+              <a:rPr sz="1200" b="0">
+                <a:solidFill>
+                  <a:srgbClr val="333333"/>
+                </a:solidFill>
+              </a:rPr>
+              <a:t/>
+            </a:r>
+          </a:p>
+          <a:p>
+            <a:r>
+              <a:rPr sz="1200" b="0">
                 <a:solidFill>
                   <a:srgbClr val="333333"/>
                 </a:solidFill>
@@ -17652,12 +17203,8 @@
             </a:r>
           </a:p>
           <a:p>
-            <a:pPr marL="171450" indent="-171450">
-              <a:buFont typeface="Arial" panose="020B0604020202020204" pitchFamily="34" charset="0"/>
-              <a:buChar char="•"/>
-            </a:pPr>
-            <a:r>
-              <a:rPr sz="1200" b="0" dirty="0">
+            <a:r>
+              <a:rPr sz="1200" b="0">
                 <a:solidFill>
                   <a:srgbClr val="333333"/>
                 </a:solidFill>
@@ -17666,12 +17213,8 @@
             </a:r>
           </a:p>
           <a:p>
-            <a:pPr marL="171450" indent="-171450">
-              <a:buFont typeface="Arial" panose="020B0604020202020204" pitchFamily="34" charset="0"/>
-              <a:buChar char="•"/>
-            </a:pPr>
-            <a:r>
-              <a:rPr sz="1200" b="0" dirty="0">
+            <a:r>
+              <a:rPr sz="1200" b="0">
                 <a:solidFill>
                   <a:srgbClr val="333333"/>
                 </a:solidFill>
@@ -17680,23 +17223,18 @@
             </a:r>
           </a:p>
           <a:p>
-            <a:pPr marL="171450" indent="-171450">
-              <a:buFont typeface="Arial" panose="020B0604020202020204" pitchFamily="34" charset="0"/>
-              <a:buChar char="•"/>
-            </a:pPr>
-            <a:endParaRPr sz="1200" b="0" dirty="0">
-              <a:solidFill>
-                <a:srgbClr val="333333"/>
-              </a:solidFill>
-            </a:endParaRPr>
-          </a:p>
-          <a:p>
-            <a:pPr marL="171450" indent="-171450">
-              <a:buFont typeface="Arial" panose="020B0604020202020204" pitchFamily="34" charset="0"/>
-              <a:buChar char="•"/>
-            </a:pPr>
-            <a:r>
-              <a:rPr sz="1200" b="0" dirty="0">
+            <a:r>
+              <a:rPr sz="1200" b="0">
+                <a:solidFill>
+                  <a:srgbClr val="333333"/>
+                </a:solidFill>
+              </a:rPr>
+              <a:t/>
+            </a:r>
+          </a:p>
+          <a:p>
+            <a:r>
+              <a:rPr sz="1200" b="0">
                 <a:solidFill>
                   <a:srgbClr val="333333"/>
                 </a:solidFill>
@@ -17705,17 +17243,33 @@
             </a:r>
           </a:p>
           <a:p>
-            <a:pPr marL="171450" indent="-171450">
-              <a:buFont typeface="Arial" panose="020B0604020202020204" pitchFamily="34" charset="0"/>
-              <a:buChar char="•"/>
-            </a:pPr>
-            <a:r>
-              <a:rPr sz="1200" b="0" dirty="0">
+            <a:r>
+              <a:rPr sz="1200" b="0">
                 <a:solidFill>
                   <a:srgbClr val="333333"/>
                 </a:solidFill>
               </a:rPr>
               <a:t>No league-relative scaling — absolute per-90 rates travel better.</a:t>
+            </a:r>
+          </a:p>
+          <a:p>
+            <a:r>
+              <a:rPr sz="1200" b="0">
+                <a:solidFill>
+                  <a:srgbClr val="333333"/>
+                </a:solidFill>
+              </a:rPr>
+              <a:t/>
+            </a:r>
+          </a:p>
+          <a:p>
+            <a:r>
+              <a:rPr sz="1200" b="0">
+                <a:solidFill>
+                  <a:srgbClr val="333333"/>
+                </a:solidFill>
+              </a:rPr>
+              <a:t>Metric codes: see Glossary slide.</a:t>
             </a:r>
           </a:p>
         </p:txBody>
@@ -20977,6 +20531,41 @@
           </a:graphicData>
         </a:graphic>
       </p:graphicFrame>
+      <p:sp>
+        <p:nvSpPr>
+          <p:cNvPr id="7" name="TextBox 6">
+            <a:hlinkClick action="ppaction://hlinksldjump" r:id="rId2"/>
+          </p:cNvPr>
+          <p:cNvSpPr txBox="1"/>
+          <p:nvPr/>
+        </p:nvSpPr>
+        <p:spPr>
+          <a:xfrm>
+            <a:off x="9875520" y="137160"/>
+            <a:ext cx="2011680" cy="320040"/>
+          </a:xfrm>
+          <a:prstGeom prst="rect">
+            <a:avLst/>
+          </a:prstGeom>
+          <a:noFill/>
+        </p:spPr>
+        <p:txBody>
+          <a:bodyPr wrap="square">
+            <a:spAutoFit/>
+          </a:bodyPr>
+          <a:lstStyle/>
+          <a:p>
+            <a:r>
+              <a:rPr sz="1200" b="1">
+                <a:solidFill>
+                  <a:srgbClr val="3D5A80"/>
+                </a:solidFill>
+              </a:rPr>
+              <a:t>→ Glossary</a:t>
+            </a:r>
+          </a:p>
+        </p:txBody>
+      </p:sp>
     </p:spTree>
   </p:cSld>
   <p:clrMapOvr>
@@ -24018,13 +23607,57 @@
               </a:spcAft>
             </a:pPr>
             <a:r>
-              <a:rPr sz="1300" b="0">
-                <a:solidFill>
-                  <a:srgbClr val="333333"/>
-                </a:solidFill>
-                <a:latin typeface="Calibri"/>
-              </a:rPr>
-              <a:t>Next: redundancy at |r|≥0.85 — only near-dupes cut; passes kept with progressive passes.</a:t>
+              <a:rPr sz="1200" b="0">
+                <a:solidFill>
+                  <a:srgbClr val="333333"/>
+                </a:solidFill>
+              </a:rPr>
+              <a:t>Next: redundancy at Pearson |r|≥0.85 — only near-dupes cut; passes kept with progressive passes.</a:t>
+            </a:r>
+          </a:p>
+          <a:p>
+            <a:r>
+              <a:rPr sz="1200" b="0">
+                <a:solidFill>
+                  <a:srgbClr val="333333"/>
+                </a:solidFill>
+              </a:rPr>
+              <a:t>Metric codes: see Glossary slide (PPC, DIS, PRS, …).</a:t>
+            </a:r>
+          </a:p>
+        </p:txBody>
+      </p:sp>
+      <p:sp>
+        <p:nvSpPr>
+          <p:cNvPr id="8" name="TextBox 7">
+            <a:hlinkClick action="ppaction://hlinksldjump" r:id="rId2"/>
+          </p:cNvPr>
+          <p:cNvSpPr txBox="1"/>
+          <p:nvPr/>
+        </p:nvSpPr>
+        <p:spPr>
+          <a:xfrm>
+            <a:off x="9875520" y="137160"/>
+            <a:ext cx="2011680" cy="320040"/>
+          </a:xfrm>
+          <a:prstGeom prst="rect">
+            <a:avLst/>
+          </a:prstGeom>
+          <a:noFill/>
+        </p:spPr>
+        <p:txBody>
+          <a:bodyPr wrap="square">
+            <a:spAutoFit/>
+          </a:bodyPr>
+          <a:lstStyle/>
+          <a:p>
+            <a:r>
+              <a:rPr sz="1200" b="1">
+                <a:solidFill>
+                  <a:srgbClr val="3D5A80"/>
+                </a:solidFill>
+              </a:rPr>
+              <a:t>→ Glossary</a:t>
             </a:r>
           </a:p>
         </p:txBody>

</xml_diff>

<commit_message>
Replace Y1 shorthand with Year 1 in Bundesliga across deliverables.
Makes the first-season outcome explicit in the proposal, README, deck, and explorer.

Co-authored-by: Cursor <cursoragent@cursor.com>
</commit_message>
<xml_diff>
--- a/bundesliga_transfer_traits.pptx
+++ b/bundesliga_transfer_traits.pptx
@@ -3695,7 +3695,7 @@
                   <a:srgbClr val="333333"/>
                 </a:solidFill>
               </a:rPr>
-              <a:t>Blue = Bundesliga Year-1 · red dotted = prior · dashed = 50th-percentile Bundesliga peer · grey = 90th-percentile Bundesliga peer.</a:t>
+              <a:t>Blue = Year 1 in Bundesliga · red dotted = prior · dashed = 50th-percentile Bundesliga peer · grey = 90th-percentile Bundesliga peer.</a:t>
             </a:r>
           </a:p>
           <a:p>
@@ -3911,7 +3911,7 @@
                 </a:solidFill>
                 <a:latin typeface="Calibri"/>
               </a:rPr>
-              <a:t>One number that answers: in Bundesliga Year-1, how strong is this player on the portable (shortlisted) traits — vs peers at their position?</a:t>
+              <a:t>One number that answers: in Year 1 in Bundesliga, how strong is this player on the portable (shortlisted) traits — vs peers at their position?</a:t>
             </a:r>
           </a:p>
         </p:txBody>
@@ -4247,7 +4247,7 @@
                 </a:solidFill>
                 <a:latin typeface="Calibri"/>
               </a:rPr>
-              <a:t>For each shortlist trait, take the player’s Bundesliga Y1 per-90 value.</a:t>
+              <a:t>For each shortlist trait, take the player’s Bundesliga Year 1 in Bundesliga per-90 value.</a:t>
             </a:r>
           </a:p>
           <a:p>
@@ -4442,7 +4442,7 @@
                 </a:solidFill>
                 <a:latin typeface="Calibri"/>
               </a:rPr>
-              <a:t>Stable-trait score = mean of those Y1 percentiles across the shortlist.</a:t>
+              <a:t>Stable-trait score = mean of those Year 1 in Bundesliga percentiles across the shortlist.</a:t>
             </a:r>
           </a:p>
           <a:p>
@@ -4474,7 +4474,7 @@
                 </a:solidFill>
                 <a:latin typeface="Calibri"/>
               </a:rPr>
-              <a:t>Higher = better Year-1 profile on traits that travel.</a:t>
+              <a:t>Higher = better Year 1 in Bundesliga profile on traits that travel.</a:t>
             </a:r>
           </a:p>
         </p:txBody>
@@ -5468,7 +5468,7 @@
                 </a:solidFill>
                 <a:latin typeface="Georgia"/>
               </a:rPr>
-              <a:t>Which prior traits &amp; leagues line up with Bundesliga Year-1 success?</a:t>
+              <a:t>Which prior traits &amp; leagues line up with Year 1 in Bundesliga success?</a:t>
             </a:r>
           </a:p>
         </p:txBody>
@@ -5554,7 +5554,8 @@
                 <a:latin typeface="Calibri"/>
               </a:rPr>
               <a:t>Phase 2: after shortlisting, test what lines up with BL success.
-Outcomes: Y1 minutes · Y1 min </a:t>
+Outcomes: Year 1 in Bundesliga minutes · Year 1 in Bundesliga min percentile · stable-trait score.
+Spearman ρ ranks players so we test “higher prior trait → more minutes” without a linear minutes scale; then feeder means + exploratory OLS.</a:t>
             </a:r>
             <a:r>
               <a:rPr lang="en-US" sz="1200" dirty="0">
@@ -5563,7 +5564,7 @@
                 </a:solidFill>
                 <a:latin typeface="Calibri"/>
               </a:rPr>
-              <a:t>percentile</a:t>
+              <a:t/>
             </a:r>
             <a:r>
               <a:rPr sz="1200" b="0" dirty="0">
@@ -5572,8 +5573,7 @@
                 </a:solidFill>
                 <a:latin typeface="Calibri"/>
               </a:rPr>
-              <a:t> · stable-trait score.
-Spearman ρ ranks players so we test “higher prior trait → more minutes” without a linear minutes scale; then feeder means + exploratory OLS.</a:t>
+              <a:t/>
             </a:r>
           </a:p>
         </p:txBody>
@@ -5929,7 +5929,7 @@
                   <a:srgbClr val="333333"/>
                 </a:solidFill>
               </a:rPr>
-              <a:t>Success = Y1 BL minutes</a:t>
+              <a:t>Success = Year 1 in Bundesliga minutes</a:t>
             </a:r>
           </a:p>
         </p:txBody>
@@ -6191,7 +6191,7 @@
                 </a:solidFill>
                 <a:latin typeface="Calibri"/>
               </a:rPr>
-              <a:t>Interpretation: positive ρ = arriving with a higher prior percentile on that trait tends to coincide with more Bundesliga Year-1 minutes / higher trait score.</a:t>
+              <a:t>Interpretation: positive ρ = arriving with a higher prior percentile on that trait tends to coincide with more Year 1 in Bundesliga minutes / higher trait score.</a:t>
             </a:r>
             <a:r>
               <a:rPr sz="1300" dirty="0" err="1">
@@ -6434,7 +6434,7 @@
                 </a:solidFill>
                 <a:latin typeface="Arial"/>
               </a:rPr>
-              <a:t>Primary success marker: Bundesliga minutes played in the player’s first BL season (Y1 minutes)</a:t>
+              <a:t>Primary success marker: Bundesliga minutes played in the player’s first BL season (Year 1 in Bundesliga minutes)</a:t>
             </a:r>
           </a:p>
           <a:p>
@@ -6466,7 +6466,7 @@
                 </a:solidFill>
                 <a:latin typeface="Arial"/>
               </a:rPr>
-              <a:t>Also reported: Y1 minutes percentile (rank in cohort) and stable-trait score (profile fit)</a:t>
+              <a:t>Also reported: Year 1 in Bundesliga minutes percentile (rank in cohort) and stable-trait score (profile fit)</a:t>
             </a:r>
           </a:p>
           <a:p>
@@ -6482,7 +6482,7 @@
                 </a:solidFill>
                 <a:latin typeface="Arial"/>
               </a:rPr>
-              <a:t>Trait &amp; league tests ask: which prior signals line up with more Y1 minutes?</a:t>
+              <a:t>Trait &amp; league tests ask: which prior signals line up with more Year 1 in Bundesliga minutes?</a:t>
             </a:r>
           </a:p>
           <a:p>
@@ -6498,7 +6498,7 @@
                 </a:solidFill>
                 <a:latin typeface="Arial"/>
               </a:rPr>
-              <a:t>Regression Δ Y1 min = estimated extra first-season minutes vs a reference league, holding controls</a:t>
+              <a:t>Regression Δ Year 1 in Bundesliga min = estimated extra first-season minutes vs a reference league, holding controls</a:t>
             </a:r>
           </a:p>
         </p:txBody>
@@ -6842,7 +6842,7 @@
                   <a:srgbClr val="333333"/>
                 </a:solidFill>
               </a:rPr>
-              <a:t>prior percentile → Y1 minutes</a:t>
+              <a:t>prior percentile → Year 1 in Bundesliga minutes</a:t>
             </a:r>
           </a:p>
           <a:p>
@@ -7677,7 +7677,7 @@
                   <a:srgbClr val="333333"/>
                 </a:solidFill>
               </a:rPr>
-              <a:t>prior %ile → Y1 minutes</a:t>
+              <a:t>prior %ile → Year 1 in Bundesliga minutes</a:t>
             </a:r>
           </a:p>
           <a:p>
@@ -8823,7 +8823,7 @@
                 </a:solidFill>
                 <a:latin typeface="Georgia"/>
               </a:rPr>
-              <a:t>Which source leagues produce the strongest Year-1 outcomes?</a:t>
+              <a:t>Which source leagues produce the strongest Year 1 in Bundesliga outcomes?</a:t>
             </a:r>
           </a:p>
         </p:txBody>
@@ -8967,7 +8967,7 @@
                             <a:schemeClr val="bg1"/>
                           </a:solidFill>
                         </a:rPr>
-                        <a:t>Mean Y1 min</a:t>
+                        <a:t>Mean Year 1 in Bundesliga min</a:t>
                       </a:r>
                     </a:p>
                   </a:txBody>
@@ -8996,7 +8996,7 @@
                             <a:schemeClr val="bg1"/>
                           </a:solidFill>
                         </a:rPr>
-                        <a:t>Median Y1 min</a:t>
+                        <a:t>Median Year 1 in Bundesliga min</a:t>
                       </a:r>
                     </a:p>
                   </a:txBody>
@@ -10393,7 +10393,7 @@
                             <a:schemeClr val="bg1"/>
                           </a:solidFill>
                         </a:rPr>
-                        <a:t>Mean Y1 min</a:t>
+                        <a:t>Mean Year 1 in Bundesliga min</a:t>
                       </a:r>
                     </a:p>
                   </a:txBody>
@@ -11289,7 +11289,7 @@
                   <a:srgbClr val="333333"/>
                 </a:solidFill>
               </a:rPr>
-              <a:t>Predict Year-1 Bundesliga minutes from prior league (Premier League / La Liga / Ligue 1 vs Serie A baseline), prior minutes, and position.</a:t>
+              <a:t>Predict Year 1 in Bundesliga minutes from prior league (Premier League / La Liga / Ligue 1 vs Serie A baseline), prior minutes, and position.</a:t>
             </a:r>
           </a:p>
           <a:p>
@@ -11399,7 +11399,7 @@
                   <a:srgbClr val="333333"/>
                 </a:solidFill>
               </a:rPr>
-              <a:t>Serie A is the baseline league (lowest average Year-1 minutes among Big-5 feeders), so other leagues are estimated as “extra minutes vs Serie A.”</a:t>
+              <a:t>Serie A is the baseline league (lowest average Year 1 in Bundesliga minutes among Big-5 feeders), so other leagues are estimated as “extra minutes vs Serie A.”</a:t>
             </a:r>
           </a:p>
         </p:txBody>
@@ -11640,7 +11640,7 @@
                           </a:solidFill>
                           <a:latin typeface="Arial"/>
                         </a:rPr>
-                        <a:t>Δ Y1 min</a:t>
+                        <a:t>Δ Year 1 in Bundesliga min</a:t>
                       </a:r>
                     </a:p>
                   </a:txBody>
@@ -11959,7 +11959,7 @@
                           </a:solidFill>
                           <a:latin typeface="Arial"/>
                         </a:rPr>
-                        <a:t>Δ Y1 min</a:t>
+                        <a:t>Δ Year 1 in Bundesliga min</a:t>
                       </a:r>
                     </a:p>
                   </a:txBody>
@@ -12414,7 +12414,7 @@
                   <a:srgbClr val="333333"/>
                 </a:solidFill>
               </a:rPr>
-              <a:t>Serie A = baseline (lowest mean Year-1 minutes among Big-5 feeders).</a:t>
+              <a:t>Serie A = baseline (lowest mean Year 1 in Bundesliga minutes among Big-5 feeders).</a:t>
             </a:r>
           </a:p>
         </p:txBody>
@@ -12604,7 +12604,7 @@
                   <a:srgbClr val="333333"/>
                 </a:solidFill>
               </a:rPr>
-              <a:t>• 19 leagues · first BL seasons 2021–2025 · prior/Y1 ≥300′ → N=329</a:t>
+              <a:t>• 19 leagues · first BL seasons 2021–2025 · prior / Year 1 in Bundesliga ≥300′ → N=329</a:t>
             </a:r>
           </a:p>
           <a:p>
@@ -12870,7 +12870,7 @@
                   <a:srgbClr val="333333"/>
                 </a:solidFill>
               </a:rPr>
-              <a:t>Which traits travel into the German Bundesliga — and which prior stats line up with Year-1 Bundesliga minutes?</a:t>
+              <a:t>Which traits travel into the German Bundesliga — and which prior stats line up with Year 1 in Bundesliga minutes?</a:t>
             </a:r>
           </a:p>
         </p:txBody>
@@ -12970,7 +12970,7 @@
                   <a:srgbClr val="333333"/>
                 </a:solidFill>
               </a:rPr>
-              <a:t>Football Reference (FBref): 19 leagues; first Bundesliga season in 2021–2025; prior and Year-1 minutes ≥300′.</a:t>
+              <a:t>Football Reference (FBref): 19 leagues; first Bundesliga season in 2021–2025; prior and Year 1 in Bundesliga minutes ≥300′.</a:t>
             </a:r>
           </a:p>
           <a:p>
@@ -12980,7 +12980,7 @@
                   <a:srgbClr val="333333"/>
                 </a:solidFill>
               </a:rPr>
-              <a:t>StatsBomb: 17 competitions; Bundesliga 2015/16 + 2023/24; prior ≥45′ / Year-1 ≥30′.</a:t>
+              <a:t>StatsBomb: 17 competitions; Bundesliga 2015/16 + 2023/24; prior ≥45′ / Year 1 in Bundesliga ≥30′.</a:t>
             </a:r>
           </a:p>
         </p:txBody>
@@ -13080,7 +13080,7 @@
                   <a:srgbClr val="333333"/>
                 </a:solidFill>
               </a:rPr>
-              <a:t>Correlate prior → Bundesliga Year-1 per-90 rates. Keep metrics that travel.</a:t>
+              <a:t>Correlate prior → Year 1 in Bundesliga per-90 rates. Keep metrics that travel.</a:t>
             </a:r>
           </a:p>
         </p:txBody>
@@ -13480,7 +13480,7 @@
                   <a:srgbClr val="333333"/>
                 </a:solidFill>
               </a:rPr>
-              <a:t>Spearman: prior trait percentile vs Year-1 Bundesliga minutes; feeder-league summaries; exploratory OLS.</a:t>
+              <a:t>Spearman: prior trait percentile vs Year 1 in Bundesliga minutes; feeder-league summaries; exploratory OLS.</a:t>
             </a:r>
           </a:p>
         </p:txBody>
@@ -13627,7 +13627,7 @@
                   <a:srgbClr val="333333"/>
                 </a:solidFill>
               </a:rPr>
-              <a:t>• FBref traits most linked to Year-1 minutes (p&lt;0.05): final-third passing, shot blocks, progressive distance, box defending</a:t>
+              <a:t>• FBref traits most linked to Year 1 in Bundesliga minutes (p&lt;0.05): final-third passing, shot blocks, progressive distance, box defending</a:t>
             </a:r>
           </a:p>
           <a:p>
@@ -13667,7 +13667,7 @@
                   <a:srgbClr val="333333"/>
                 </a:solidFill>
               </a:rPr>
-              <a:t>• Scout metrics that travel league-to-league. Year-1 Bundesliga minutes = open-data success proxy</a:t>
+              <a:t>• Scout metrics that travel league-to-league. Year 1 in Bundesliga minutes = open-data success proxy</a:t>
             </a:r>
           </a:p>
           <a:p>
@@ -13824,7 +13824,7 @@
                 </a:solidFill>
                 <a:latin typeface="Georgia"/>
               </a:rPr>
-              <a:t>What we would use instead of (or alongside) Y1 minutes.</a:t>
+              <a:t>What we would use instead of (or alongside) Year 1 in Bundesliga minutes.</a:t>
             </a:r>
           </a:p>
         </p:txBody>
@@ -13887,7 +13887,7 @@
                   <a:srgbClr val="333333"/>
                 </a:solidFill>
               </a:rPr>
-              <a:t>NYRB project Axis-3 testing of player value used market value rather than Year-1 minutes; this project uses open data only — Transfermarkt disallows scraping</a:t>
+              <a:t>NYRB project Axis-3 testing of player value used market value rather than Year 1 in Bundesliga minutes; this project uses open data only — Transfermarkt disallows scraping</a:t>
             </a:r>
           </a:p>
           <a:p>
@@ -13897,7 +13897,7 @@
                   <a:srgbClr val="333333"/>
                 </a:solidFill>
               </a:rPr>
-              <a:t>So we proxy success with Year-1 Bundesliga minutes until a licensed market-value feed is available</a:t>
+              <a:t>So we proxy success with Year 1 in Bundesliga minutes until a licensed market-value feed is available</a:t>
             </a:r>
           </a:p>
           <a:p>
@@ -14329,7 +14329,7 @@
                   <a:srgbClr val="333333"/>
                 </a:solidFill>
               </a:rPr>
-              <a:t>Y1 / Year-1 — first Bundesliga season</a:t>
+              <a:t>Year 1 in Bundesliga — first Bundesliga season</a:t>
             </a:r>
           </a:p>
           <a:p>
@@ -15419,7 +15419,7 @@
                   <a:srgbClr val="333333"/>
                 </a:solidFill>
               </a:rPr>
-              <a:t>N=96 · prior ≥45′ / Year-1 ≥30′</a:t>
+              <a:t>N=96 · prior ≥45′ / Year 1 in Bundesliga ≥30′</a:t>
             </a:r>
           </a:p>
           <a:p>
@@ -15672,7 +15672,7 @@
                   <a:srgbClr val="333333"/>
                 </a:solidFill>
               </a:rPr>
-              <a:t>Pearson r = stability (does the prior ranking of a rate recur in Bundesliga Year-1?).</a:t>
+              <a:t>Pearson r = stability (does the prior ranking of a rate recur in Year 1 in Bundesliga?).</a:t>
             </a:r>
           </a:p>
           <a:p>
@@ -15682,7 +15682,7 @@
                   <a:srgbClr val="333333"/>
                 </a:solidFill>
               </a:rPr>
-              <a:t>Spearman ρ = success (do higher prior trait ranks line up with more Year-1 minutes — rank-based, robust when minutes are skewed).</a:t>
+              <a:t>Spearman ρ = success (do higher prior trait ranks line up with more Year 1 in Bundesliga minutes — rank-based, robust when minutes are skewed).</a:t>
             </a:r>
           </a:p>
           <a:p>
@@ -15863,7 +15863,7 @@
                   <a:srgbClr val="333333"/>
                 </a:solidFill>
               </a:rPr>
-              <a:t>Trait portability — prior ↔ Bundesliga Year-1 stability r</a:t>
+              <a:t>Trait portability — prior ↔ Year 1 in Bundesliga stability r</a:t>
             </a:r>
           </a:p>
           <a:p>
@@ -15949,7 +15949,7 @@
                   <a:srgbClr val="333333"/>
                 </a:solidFill>
               </a:rPr>
-              <a:t>Y1 profile strength — stable-trait score</a:t>
+              <a:t>Year 1 in Bundesliga profile strength — stable-trait score</a:t>
             </a:r>
           </a:p>
         </p:txBody>
@@ -16665,7 +16665,7 @@
                   <a:srgbClr val="333333"/>
                 </a:solidFill>
               </a:rPr>
-              <a:t>Minutes: prior ≥300′ · Year-1 ≥300′ → N=329 pairs · 19 leagues</a:t>
+              <a:t>Minutes: prior ≥300′ · Year 1 in Bundesliga ≥300′ → N=329 pairs · 19 leagues</a:t>
             </a:r>
           </a:p>
           <a:p>
@@ -16685,7 +16685,7 @@
                   <a:srgbClr val="333333"/>
                 </a:solidFill>
               </a:rPr>
-              <a:t>League-relative scaling tested and dropped: “how high vs peers in the same prior league” (z-score / percentile) did not improve prior→Year-1 stability, so we keep absolute per-90 rates.</a:t>
+              <a:t>League-relative scaling tested and dropped: “how high vs peers in the same prior league” (z-score / percentile) did not improve prior→Year 1 in Bundesliga stability, so we keep absolute per-90 rates.</a:t>
             </a:r>
           </a:p>
           <a:p>
@@ -16896,7 +16896,7 @@
                   <a:srgbClr val="333333"/>
                 </a:solidFill>
               </a:rPr>
-              <a:t>N=96 · prior ≥45′ · Year-1 ≥30′</a:t>
+              <a:t>N=96 · prior ≥45′ · Year 1 in Bundesliga ≥30′</a:t>
             </a:r>
           </a:p>
           <a:p>
@@ -17154,7 +17154,7 @@
                   <a:srgbClr val="333333"/>
                 </a:solidFill>
               </a:rPr>
-              <a:t>Prior league → first Bundesliga Y1 (end-year ≥2021)</a:t>
+              <a:t>Prior league → first Bundesliga Year 1 in Bundesliga (end-year ≥2021)</a:t>
             </a:r>
             <a:endParaRPr lang="en-US" sz="1200" b="0" dirty="0">
               <a:solidFill>
@@ -20704,7 +20704,7 @@
                 </a:solidFill>
                 <a:latin typeface="Calibri"/>
               </a:rPr>
-              <a:t>Prior competition → Bundesliga Y1 · pass if r ≥ 0.40</a:t>
+              <a:t>Prior competition → Bundesliga Year 1 in Bundesliga · pass if r ≥ 0.40</a:t>
             </a:r>
           </a:p>
         </p:txBody>

</xml_diff>

<commit_message>
Polish explorer clarity and align closing-slide titles.
Spell out Bundesliga / Year 1 wording with metric hover definitions, and match Takeaways to the Why p-values title color.

Co-authored-by: Cursor <cursoragent@cursor.com>
</commit_message>
<xml_diff>
--- a/bundesliga_transfer_traits.pptx
+++ b/bundesliga_transfer_traits.pptx
@@ -26,8 +26,8 @@
     <p:sldId id="280" r:id="rId20"/>
     <p:sldId id="278" r:id="rId21"/>
     <p:sldId id="277" r:id="rId22"/>
-    <p:sldId id="284" r:id="rId28"/>
-    <p:sldId id="279" r:id="rId23"/>
+    <p:sldId id="284" r:id="rId23"/>
+    <p:sldId id="279" r:id="rId24"/>
   </p:sldIdLst>
   <p:sldSz cx="12192000" cy="6858000"/>
   <p:notesSz cx="6858000" cy="9144000"/>
@@ -324,7 +324,7 @@
           <a:p>
             <a:fld id="{5BCAD085-E8A6-8845-BD4E-CB4CCA059FC4}" type="datetimeFigureOut">
               <a:rPr lang="en-US" smtClean="0"/>
-              <a:t>7/20/26</a:t>
+              <a:t>7/22/26</a:t>
             </a:fld>
             <a:endParaRPr lang="en-US"/>
           </a:p>
@@ -492,7 +492,7 @@
           <a:p>
             <a:fld id="{5BCAD085-E8A6-8845-BD4E-CB4CCA059FC4}" type="datetimeFigureOut">
               <a:rPr lang="en-US" smtClean="0"/>
-              <a:t>7/20/26</a:t>
+              <a:t>7/22/26</a:t>
             </a:fld>
             <a:endParaRPr lang="en-US"/>
           </a:p>
@@ -670,7 +670,7 @@
           <a:p>
             <a:fld id="{5BCAD085-E8A6-8845-BD4E-CB4CCA059FC4}" type="datetimeFigureOut">
               <a:rPr lang="en-US" smtClean="0"/>
-              <a:t>7/20/26</a:t>
+              <a:t>7/22/26</a:t>
             </a:fld>
             <a:endParaRPr lang="en-US"/>
           </a:p>
@@ -838,7 +838,7 @@
           <a:p>
             <a:fld id="{5BCAD085-E8A6-8845-BD4E-CB4CCA059FC4}" type="datetimeFigureOut">
               <a:rPr lang="en-US" smtClean="0"/>
-              <a:t>7/20/26</a:t>
+              <a:t>7/22/26</a:t>
             </a:fld>
             <a:endParaRPr lang="en-US"/>
           </a:p>
@@ -1083,7 +1083,7 @@
           <a:p>
             <a:fld id="{5BCAD085-E8A6-8845-BD4E-CB4CCA059FC4}" type="datetimeFigureOut">
               <a:rPr lang="en-US" smtClean="0"/>
-              <a:t>7/20/26</a:t>
+              <a:t>7/22/26</a:t>
             </a:fld>
             <a:endParaRPr lang="en-US"/>
           </a:p>
@@ -1368,7 +1368,7 @@
           <a:p>
             <a:fld id="{5BCAD085-E8A6-8845-BD4E-CB4CCA059FC4}" type="datetimeFigureOut">
               <a:rPr lang="en-US" smtClean="0"/>
-              <a:t>7/20/26</a:t>
+              <a:t>7/22/26</a:t>
             </a:fld>
             <a:endParaRPr lang="en-US"/>
           </a:p>
@@ -1787,7 +1787,7 @@
           <a:p>
             <a:fld id="{5BCAD085-E8A6-8845-BD4E-CB4CCA059FC4}" type="datetimeFigureOut">
               <a:rPr lang="en-US" smtClean="0"/>
-              <a:t>7/20/26</a:t>
+              <a:t>7/22/26</a:t>
             </a:fld>
             <a:endParaRPr lang="en-US"/>
           </a:p>
@@ -1904,7 +1904,7 @@
           <a:p>
             <a:fld id="{5BCAD085-E8A6-8845-BD4E-CB4CCA059FC4}" type="datetimeFigureOut">
               <a:rPr lang="en-US" smtClean="0"/>
-              <a:t>7/20/26</a:t>
+              <a:t>7/22/26</a:t>
             </a:fld>
             <a:endParaRPr lang="en-US"/>
           </a:p>
@@ -1999,7 +1999,7 @@
           <a:p>
             <a:fld id="{5BCAD085-E8A6-8845-BD4E-CB4CCA059FC4}" type="datetimeFigureOut">
               <a:rPr lang="en-US" smtClean="0"/>
-              <a:t>7/20/26</a:t>
+              <a:t>7/22/26</a:t>
             </a:fld>
             <a:endParaRPr lang="en-US"/>
           </a:p>
@@ -2274,7 +2274,7 @@
           <a:p>
             <a:fld id="{5BCAD085-E8A6-8845-BD4E-CB4CCA059FC4}" type="datetimeFigureOut">
               <a:rPr lang="en-US" smtClean="0"/>
-              <a:t>7/20/26</a:t>
+              <a:t>7/22/26</a:t>
             </a:fld>
             <a:endParaRPr lang="en-US"/>
           </a:p>
@@ -2526,7 +2526,7 @@
           <a:p>
             <a:fld id="{5BCAD085-E8A6-8845-BD4E-CB4CCA059FC4}" type="datetimeFigureOut">
               <a:rPr lang="en-US" smtClean="0"/>
-              <a:t>7/20/26</a:t>
+              <a:t>7/22/26</a:t>
             </a:fld>
             <a:endParaRPr lang="en-US"/>
           </a:p>
@@ -2737,7 +2737,7 @@
           <a:p>
             <a:fld id="{5BCAD085-E8A6-8845-BD4E-CB4CCA059FC4}" type="datetimeFigureOut">
               <a:rPr lang="en-US" smtClean="0"/>
-              <a:t>7/20/26</a:t>
+              <a:t>7/22/26</a:t>
             </a:fld>
             <a:endParaRPr lang="en-US"/>
           </a:p>
@@ -3709,14 +3709,11 @@
             </a:r>
           </a:p>
           <a:p>
-            <a:r>
-              <a:rPr sz="1200" b="0">
-                <a:solidFill>
-                  <a:srgbClr val="333333"/>
-                </a:solidFill>
-              </a:rPr>
-              <a:t/>
-            </a:r>
+            <a:endParaRPr sz="1200" b="0">
+              <a:solidFill>
+                <a:srgbClr val="333333"/>
+              </a:solidFill>
+            </a:endParaRPr>
           </a:p>
           <a:p>
             <a:r>
@@ -5557,24 +5554,6 @@
 Outcomes: Year 1 in Bundesliga minutes · Year 1 in Bundesliga min percentile · stable-trait score.
 Spearman ρ ranks players so we test “higher prior trait → more minutes” without a linear minutes scale; then feeder means + exploratory OLS.</a:t>
             </a:r>
-            <a:r>
-              <a:rPr lang="en-US" sz="1200" dirty="0">
-                <a:solidFill>
-                  <a:srgbClr val="333333"/>
-                </a:solidFill>
-                <a:latin typeface="Calibri"/>
-              </a:rPr>
-              <a:t/>
-            </a:r>
-            <a:r>
-              <a:rPr sz="1200" b="0" dirty="0">
-                <a:solidFill>
-                  <a:srgbClr val="333333"/>
-                </a:solidFill>
-                <a:latin typeface="Calibri"/>
-              </a:rPr>
-              <a:t/>
-            </a:r>
           </a:p>
         </p:txBody>
       </p:sp>
@@ -6192,24 +6171,6 @@
                 <a:latin typeface="Calibri"/>
               </a:rPr>
               <a:t>Interpretation: positive ρ = arriving with a higher prior percentile on that trait tends to coincide with more Year 1 in Bundesliga minutes / higher trait score.</a:t>
-            </a:r>
-            <a:r>
-              <a:rPr sz="1300" dirty="0" err="1">
-                <a:solidFill>
-                  <a:srgbClr val="555555"/>
-                </a:solidFill>
-                <a:latin typeface="Calibri"/>
-              </a:rPr>
-              <a:t/>
-            </a:r>
-            <a:r>
-              <a:rPr sz="1300" dirty="0">
-                <a:solidFill>
-                  <a:srgbClr val="555555"/>
-                </a:solidFill>
-                <a:latin typeface="Calibri"/>
-              </a:rPr>
-              <a:t/>
             </a:r>
           </a:p>
           <a:p>
@@ -7681,13 +7642,20 @@
             </a:r>
           </a:p>
           <a:p>
+            <a:endParaRPr sz="1200" b="0">
+              <a:solidFill>
+                <a:srgbClr val="333333"/>
+              </a:solidFill>
+            </a:endParaRPr>
+          </a:p>
+          <a:p>
             <a:r>
               <a:rPr sz="1200" b="0">
                 <a:solidFill>
                   <a:srgbClr val="333333"/>
                 </a:solidFill>
               </a:rPr>
-              <a:t/>
+              <a:t>FINAL  ρ=+0.30  p=0.005 *</a:t>
             </a:r>
           </a:p>
           <a:p>
@@ -7697,7 +7665,7 @@
                   <a:srgbClr val="333333"/>
                 </a:solidFill>
               </a:rPr>
-              <a:t>FINAL  ρ=+0.30  p=0.005 *</a:t>
+              <a:t>SH  ρ=+0.27  p=0.011 *</a:t>
             </a:r>
           </a:p>
           <a:p>
@@ -7707,7 +7675,7 @@
                   <a:srgbClr val="333333"/>
                 </a:solidFill>
               </a:rPr>
-              <a:t>SH  ρ=+0.27  p=0.011 *</a:t>
+              <a:t>PRGDI  ρ=+0.24  p=0.025 *</a:t>
             </a:r>
           </a:p>
           <a:p>
@@ -7717,7 +7685,7 @@
                   <a:srgbClr val="333333"/>
                 </a:solidFill>
               </a:rPr>
-              <a:t>PRGDI  ρ=+0.24  p=0.025 *</a:t>
+              <a:t>TKLD  ρ=+0.23  p=0.030 *</a:t>
             </a:r>
           </a:p>
           <a:p>
@@ -7727,7 +7695,7 @@
                   <a:srgbClr val="333333"/>
                 </a:solidFill>
               </a:rPr>
-              <a:t>TKLD  ρ=+0.23  p=0.030 *</a:t>
+              <a:t>ATTLO  ρ=+0.22  p=0.036 *</a:t>
             </a:r>
           </a:p>
           <a:p>
@@ -7737,28 +7705,15 @@
                   <a:srgbClr val="333333"/>
                 </a:solidFill>
               </a:rPr>
-              <a:t>ATTLO  ρ=+0.22  p=0.036 *</a:t>
-            </a:r>
-          </a:p>
-          <a:p>
-            <a:r>
-              <a:rPr sz="1200" b="0">
-                <a:solidFill>
-                  <a:srgbClr val="333333"/>
-                </a:solidFill>
-              </a:rPr>
               <a:t>DEF3R  ρ=+0.22  p=0.039 *</a:t>
             </a:r>
           </a:p>
           <a:p>
-            <a:r>
-              <a:rPr sz="1200" b="0">
-                <a:solidFill>
-                  <a:srgbClr val="333333"/>
-                </a:solidFill>
-              </a:rPr>
-              <a:t/>
-            </a:r>
+            <a:endParaRPr sz="1200" b="0">
+              <a:solidFill>
+                <a:srgbClr val="333333"/>
+              </a:solidFill>
+            </a:endParaRPr>
           </a:p>
           <a:p>
             <a:r>
@@ -8659,7 +8614,7 @@
       <p:sp>
         <p:nvSpPr>
           <p:cNvPr id="9" name="TextBox 8">
-            <a:hlinkClick action="ppaction://hlinksldjump" r:id="rId2"/>
+            <a:hlinkClick r:id="rId2" action="ppaction://hlinksldjump"/>
           </p:cNvPr>
           <p:cNvSpPr txBox="1"/>
           <p:nvPr/>
@@ -8844,7 +8799,7 @@
         </p:nvGraphicFramePr>
         <p:xfrm>
           <a:off x="411480" y="1179576"/>
-          <a:ext cx="5669280" cy="2292096"/>
+          <a:ext cx="5669280" cy="2444496"/>
         </p:xfrm>
         <a:graphic>
           <a:graphicData uri="http://schemas.openxmlformats.org/drawingml/2006/table">
@@ -10270,14 +10225,14 @@
           <p:nvPr>
             <p:extLst>
               <p:ext uri="{D42A27DB-BD31-4B8C-83A1-F6EECF244321}">
-                <p14:modId xmlns:p14="http://schemas.microsoft.com/office/powerpoint/2010/main" val="4284551680"/>
+                <p14:modId xmlns:p14="http://schemas.microsoft.com/office/powerpoint/2010/main" val="1064765181"/>
               </p:ext>
             </p:extLst>
           </p:nvPr>
         </p:nvGraphicFramePr>
         <p:xfrm>
-          <a:off x="411480" y="3246120"/>
-          <a:ext cx="4846320" cy="1536192"/>
+          <a:off x="411480" y="3738486"/>
+          <a:ext cx="4846320" cy="1676400"/>
         </p:xfrm>
         <a:graphic>
           <a:graphicData uri="http://schemas.openxmlformats.org/drawingml/2006/table">
@@ -10330,7 +10285,7 @@
                         </a:defRPr>
                       </a:pPr>
                       <a:r>
-                        <a:rPr sz="1000" b="1">
+                        <a:rPr sz="1000" b="1" dirty="0">
                           <a:solidFill>
                             <a:schemeClr val="bg1"/>
                           </a:solidFill>
@@ -11065,7 +11020,7 @@
         </p:nvSpPr>
         <p:spPr>
           <a:xfrm>
-            <a:off x="411480" y="5029200"/>
+            <a:off x="411480" y="5521566"/>
             <a:ext cx="11155680" cy="743793"/>
           </a:xfrm>
           <a:prstGeom prst="rect">
@@ -11303,13 +11258,20 @@
             </a:r>
           </a:p>
           <a:p>
+            <a:endParaRPr sz="1200" b="0">
+              <a:solidFill>
+                <a:srgbClr val="333333"/>
+              </a:solidFill>
+            </a:endParaRPr>
+          </a:p>
+          <a:p>
             <a:r>
               <a:rPr sz="1200" b="0">
                 <a:solidFill>
                   <a:srgbClr val="333333"/>
                 </a:solidFill>
               </a:rPr>
-              <a:t/>
+              <a:t>Model 2 — league + traits</a:t>
             </a:r>
           </a:p>
           <a:p>
@@ -11319,7 +11281,7 @@
                   <a:srgbClr val="333333"/>
                 </a:solidFill>
               </a:rPr>
-              <a:t>Model 2 — league + traits</a:t>
+              <a:t>Same as Model 1, plus prior trait percentiles (e.g. Final Third, box touches).</a:t>
             </a:r>
           </a:p>
           <a:p>
@@ -11329,8 +11291,15 @@
                   <a:srgbClr val="333333"/>
                 </a:solidFill>
               </a:rPr>
-              <a:t>Same as Model 1, plus prior trait percentiles (e.g. Final Third, box touches).</a:t>
-            </a:r>
+              <a:t>Question: once you know the prior profile, do league gaps shrink?</a:t>
+            </a:r>
+          </a:p>
+          <a:p>
+            <a:endParaRPr sz="1200" b="0">
+              <a:solidFill>
+                <a:srgbClr val="333333"/>
+              </a:solidFill>
+            </a:endParaRPr>
           </a:p>
           <a:p>
             <a:r>
@@ -11339,7 +11308,7 @@
                   <a:srgbClr val="333333"/>
                 </a:solidFill>
               </a:rPr>
-              <a:t>Question: once you know the prior profile, do league gaps shrink?</a:t>
+              <a:t>Model 3 — holdout check</a:t>
             </a:r>
           </a:p>
           <a:p>
@@ -11349,7 +11318,7 @@
                   <a:srgbClr val="333333"/>
                 </a:solidFill>
               </a:rPr>
-              <a:t/>
+              <a:t>Fit on 80% of players; see if predictions match the other 20%.</a:t>
             </a:r>
           </a:p>
           <a:p>
@@ -11359,38 +11328,15 @@
                   <a:srgbClr val="333333"/>
                 </a:solidFill>
               </a:rPr>
-              <a:t>Model 3 — holdout check</a:t>
-            </a:r>
-          </a:p>
-          <a:p>
-            <a:r>
-              <a:rPr sz="1200" b="0">
-                <a:solidFill>
-                  <a:srgbClr val="333333"/>
-                </a:solidFill>
-              </a:rPr>
-              <a:t>Fit on 80% of players; see if predictions match the other 20%.</a:t>
-            </a:r>
-          </a:p>
-          <a:p>
-            <a:r>
-              <a:rPr sz="1200" b="0">
-                <a:solidFill>
-                  <a:srgbClr val="333333"/>
-                </a:solidFill>
-              </a:rPr>
               <a:t>Question: is the fit just memorizing this sample?</a:t>
             </a:r>
           </a:p>
           <a:p>
-            <a:r>
-              <a:rPr sz="1200" b="0">
-                <a:solidFill>
-                  <a:srgbClr val="333333"/>
-                </a:solidFill>
-              </a:rPr>
-              <a:t/>
-            </a:r>
+            <a:endParaRPr sz="1200" b="0">
+              <a:solidFill>
+                <a:srgbClr val="333333"/>
+              </a:solidFill>
+            </a:endParaRPr>
           </a:p>
           <a:p>
             <a:r>
@@ -11497,7 +11443,7 @@
           <a:p>
             <a:pPr algn="l"/>
             <a:r>
-              <a:rPr sz="2600" b="1">
+              <a:rPr sz="2600" b="1" dirty="0">
                 <a:solidFill>
                   <a:srgbClr val="3D5A80"/>
                 </a:solidFill>
@@ -11572,7 +11518,7 @@
         </p:nvGraphicFramePr>
         <p:xfrm>
           <a:off x="548640" y="1786128"/>
-          <a:ext cx="3657600" cy="1136904"/>
+          <a:ext cx="3657600" cy="1472184"/>
         </p:xfrm>
         <a:graphic>
           <a:graphicData uri="http://schemas.openxmlformats.org/drawingml/2006/table">
@@ -11891,7 +11837,7 @@
         </p:nvGraphicFramePr>
         <p:xfrm>
           <a:off x="4663440" y="1786128"/>
-          <a:ext cx="3657600" cy="1722120"/>
+          <a:ext cx="3657600" cy="2057400"/>
         </p:xfrm>
         <a:graphic>
           <a:graphicData uri="http://schemas.openxmlformats.org/drawingml/2006/table">
@@ -12398,14 +12344,11 @@
             </a:r>
           </a:p>
           <a:p>
-            <a:r>
-              <a:rPr sz="1200" b="0">
-                <a:solidFill>
-                  <a:srgbClr val="333333"/>
-                </a:solidFill>
-              </a:rPr>
-              <a:t/>
-            </a:r>
+            <a:endParaRPr sz="1200" b="0">
+              <a:solidFill>
+                <a:srgbClr val="333333"/>
+              </a:solidFill>
+            </a:endParaRPr>
           </a:p>
           <a:p>
             <a:r>
@@ -12487,6 +12430,56 @@
       </p:grpSpPr>
       <p:sp>
         <p:nvSpPr>
+          <p:cNvPr id="2" name="Rectangle 1">
+            <a:extLst>
+              <a:ext uri="{FF2B5EF4-FFF2-40B4-BE49-F238E27FC236}">
+                <a16:creationId xmlns:a16="http://schemas.microsoft.com/office/drawing/2014/main" id="{4BFDC249-A5FD-8DEF-D331-6AC779D7AD09}"/>
+              </a:ext>
+            </a:extLst>
+          </p:cNvPr>
+          <p:cNvSpPr/>
+          <p:nvPr/>
+        </p:nvSpPr>
+        <p:spPr>
+          <a:xfrm>
+            <a:off x="0" y="0"/>
+            <a:ext cx="12191695" cy="6858000"/>
+          </a:xfrm>
+          <a:prstGeom prst="rect">
+            <a:avLst/>
+          </a:prstGeom>
+          <a:solidFill>
+            <a:srgbClr val="F4F5F7"/>
+          </a:solidFill>
+          <a:ln>
+            <a:noFill/>
+          </a:ln>
+        </p:spPr>
+        <p:style>
+          <a:lnRef idx="1">
+            <a:schemeClr val="accent1"/>
+          </a:lnRef>
+          <a:fillRef idx="3">
+            <a:schemeClr val="accent1"/>
+          </a:fillRef>
+          <a:effectRef idx="2">
+            <a:schemeClr val="accent1"/>
+          </a:effectRef>
+          <a:fontRef idx="minor">
+            <a:schemeClr val="lt1"/>
+          </a:fontRef>
+        </p:style>
+        <p:txBody>
+          <a:bodyPr rtlCol="0" anchor="ctr"/>
+          <a:lstStyle/>
+          <a:p>
+            <a:pPr algn="ctr"/>
+            <a:endParaRPr/>
+          </a:p>
+        </p:txBody>
+      </p:sp>
+      <p:sp>
+        <p:nvSpPr>
           <p:cNvPr id="3" name="TextBox 2"/>
           <p:cNvSpPr txBox="1"/>
           <p:nvPr/>
@@ -12494,7 +12487,7 @@
         <p:spPr>
           <a:xfrm>
             <a:off x="548640" y="502920"/>
-            <a:ext cx="11064240" cy="3701013"/>
+            <a:ext cx="11064240" cy="3085460"/>
           </a:xfrm>
           <a:prstGeom prst="rect">
             <a:avLst/>
@@ -12513,13 +12506,22 @@
               </a:spcAft>
             </a:pPr>
             <a:r>
-              <a:rPr sz="1400" b="0">
-                <a:solidFill>
-                  <a:srgbClr val="333333"/>
-                </a:solidFill>
+              <a:rPr sz="2600" b="1" dirty="0">
+                <a:solidFill>
+                  <a:srgbClr val="3D5A80"/>
+                </a:solidFill>
+                <a:latin typeface="Georgia" panose="02040502050405020303" pitchFamily="18" charset="0"/>
               </a:rPr>
               <a:t>Why p-values stay modest</a:t>
             </a:r>
+            <a:endParaRPr sz="2600" b="1" dirty="0">
+              <a:solidFill>
+                <a:srgbClr val="3D5A80"/>
+              </a:solidFill>
+              <a:latin typeface="Georgia" panose="02040502050405020303" pitchFamily="18" charset="0"/>
+            </a:endParaRPr>
+          </a:p>
+          <a:p>
             <a:endParaRPr sz="2600" b="1" dirty="0">
               <a:solidFill>
                 <a:srgbClr val="3D5A80"/>
@@ -12529,37 +12531,59 @@
           </a:p>
           <a:p>
             <a:r>
-              <a:rPr sz="1400" b="0">
-                <a:solidFill>
-                  <a:srgbClr val="333333"/>
-                </a:solidFill>
-              </a:rPr>
-              <a:t/>
-            </a:r>
-          </a:p>
-          <a:p>
-            <a:r>
-              <a:rPr sz="1400" b="0">
-                <a:solidFill>
-                  <a:srgbClr val="333333"/>
-                </a:solidFill>
-              </a:rPr>
-              <a:t>• StatsBomb N=96 with messy open-data priors (World Cup / Euro / Champions League mix rather than clean league seasons — larger sample, less consistent prior context)</a:t>
-            </a:r>
-          </a:p>
-          <a:p>
-            <a:r>
-              <a:rPr sz="1400" b="0">
-                <a:solidFill>
-                  <a:srgbClr val="333333"/>
-                </a:solidFill>
-              </a:rPr>
-              <a:t>• FBref N=329 helps, but many advanced metrics only have ~90–100 complete pairs</a:t>
-            </a:r>
-          </a:p>
-          <a:p>
-            <a:r>
-              <a:rPr sz="1400" b="0">
+              <a:rPr sz="1400" b="0" dirty="0">
+                <a:solidFill>
+                  <a:srgbClr val="333333"/>
+                </a:solidFill>
+              </a:rPr>
+              <a:t>• </a:t>
+            </a:r>
+            <a:r>
+              <a:rPr sz="1400" b="0" dirty="0" err="1">
+                <a:solidFill>
+                  <a:srgbClr val="333333"/>
+                </a:solidFill>
+              </a:rPr>
+              <a:t>StatsBomb</a:t>
+            </a:r>
+            <a:r>
+              <a:rPr sz="1400" b="0" dirty="0">
+                <a:solidFill>
+                  <a:srgbClr val="333333"/>
+                </a:solidFill>
+              </a:rPr>
+              <a:t> N=96 with messy open-data priors (World Cup / Euro / Champions League mix rather than clean league seasons — larger sample, less consistent prior context)</a:t>
+            </a:r>
+          </a:p>
+          <a:p>
+            <a:r>
+              <a:rPr sz="1400" b="0" dirty="0">
+                <a:solidFill>
+                  <a:srgbClr val="333333"/>
+                </a:solidFill>
+              </a:rPr>
+              <a:t>• </a:t>
+            </a:r>
+            <a:r>
+              <a:rPr sz="1400" b="0" dirty="0" err="1">
+                <a:solidFill>
+                  <a:srgbClr val="333333"/>
+                </a:solidFill>
+              </a:rPr>
+              <a:t>FBref</a:t>
+            </a:r>
+            <a:r>
+              <a:rPr sz="1400" b="0" dirty="0">
+                <a:solidFill>
+                  <a:srgbClr val="333333"/>
+                </a:solidFill>
+              </a:rPr>
+              <a:t> N=329 helps, but many advanced metrics only have ~90–100 complete pairs</a:t>
+            </a:r>
+          </a:p>
+          <a:p>
+            <a:r>
+              <a:rPr sz="1400" b="0" dirty="0">
                 <a:solidFill>
                   <a:srgbClr val="333333"/>
                 </a:solidFill>
@@ -12568,18 +12592,15 @@
             </a:r>
           </a:p>
           <a:p>
-            <a:r>
-              <a:rPr sz="1400" b="0">
-                <a:solidFill>
-                  <a:srgbClr val="333333"/>
-                </a:solidFill>
-              </a:rPr>
-              <a:t/>
-            </a:r>
-          </a:p>
-          <a:p>
-            <a:r>
-              <a:rPr sz="1400" b="0">
+            <a:endParaRPr sz="1400" b="0" dirty="0">
+              <a:solidFill>
+                <a:srgbClr val="333333"/>
+              </a:solidFill>
+            </a:endParaRPr>
+          </a:p>
+          <a:p>
+            <a:r>
+              <a:rPr sz="1400" b="0" dirty="0">
                 <a:solidFill>
                   <a:srgbClr val="333333"/>
                 </a:solidFill>
@@ -12588,18 +12609,15 @@
             </a:r>
           </a:p>
           <a:p>
-            <a:r>
-              <a:rPr sz="1400" b="0">
-                <a:solidFill>
-                  <a:srgbClr val="333333"/>
-                </a:solidFill>
-              </a:rPr>
-              <a:t/>
-            </a:r>
-          </a:p>
-          <a:p>
-            <a:r>
-              <a:rPr sz="1400" b="0">
+            <a:endParaRPr sz="1400" b="0" dirty="0">
+              <a:solidFill>
+                <a:srgbClr val="333333"/>
+              </a:solidFill>
+            </a:endParaRPr>
+          </a:p>
+          <a:p>
+            <a:r>
+              <a:rPr sz="1400" b="0" dirty="0">
                 <a:solidFill>
                   <a:srgbClr val="333333"/>
                 </a:solidFill>
@@ -12609,7 +12627,7 @@
           </a:p>
           <a:p>
             <a:r>
-              <a:rPr sz="1400" b="0">
+              <a:rPr sz="1400" b="0" dirty="0">
                 <a:solidFill>
                   <a:srgbClr val="333333"/>
                 </a:solidFill>
@@ -12619,12 +12637,28 @@
           </a:p>
           <a:p>
             <a:r>
-              <a:rPr sz="1400" b="0">
-                <a:solidFill>
-                  <a:srgbClr val="333333"/>
-                </a:solidFill>
-              </a:rPr>
-              <a:t>• StatsBomb kept as event deep dive (r≥0.40 · 7 traits), not league ranking</a:t>
+              <a:rPr sz="1400" b="0" dirty="0">
+                <a:solidFill>
+                  <a:srgbClr val="333333"/>
+                </a:solidFill>
+              </a:rPr>
+              <a:t>• </a:t>
+            </a:r>
+            <a:r>
+              <a:rPr sz="1400" b="0" dirty="0" err="1">
+                <a:solidFill>
+                  <a:srgbClr val="333333"/>
+                </a:solidFill>
+              </a:rPr>
+              <a:t>StatsBomb</a:t>
+            </a:r>
+            <a:r>
+              <a:rPr sz="1400" b="0" dirty="0">
+                <a:solidFill>
+                  <a:srgbClr val="333333"/>
+                </a:solidFill>
+              </a:rPr>
+              <a:t> kept as event deep dive (r≥0.40 · 7 traits), not league ranking</a:t>
             </a:r>
           </a:p>
         </p:txBody>
@@ -12935,7 +12969,7 @@
         </p:nvSpPr>
         <p:spPr>
           <a:xfrm>
-            <a:off x="832104" y="1883664"/>
+            <a:off x="832104" y="1752147"/>
             <a:ext cx="5029200" cy="685800"/>
           </a:xfrm>
           <a:prstGeom prst="rect">
@@ -12955,7 +12989,7 @@
               </a:spcAft>
             </a:pPr>
             <a:r>
-              <a:rPr sz="1100" b="0">
+              <a:rPr sz="1100" b="0" dirty="0">
                 <a:solidFill>
                   <a:srgbClr val="333333"/>
                 </a:solidFill>
@@ -12965,22 +12999,46 @@
           </a:p>
           <a:p>
             <a:r>
-              <a:rPr sz="1100" b="0">
-                <a:solidFill>
-                  <a:srgbClr val="333333"/>
-                </a:solidFill>
-              </a:rPr>
-              <a:t>Football Reference (FBref): 19 leagues; first Bundesliga season in 2021–2025; prior and Year 1 in Bundesliga minutes ≥300′.</a:t>
-            </a:r>
-          </a:p>
-          <a:p>
-            <a:r>
-              <a:rPr sz="1100" b="0">
-                <a:solidFill>
-                  <a:srgbClr val="333333"/>
-                </a:solidFill>
-              </a:rPr>
-              <a:t>StatsBomb: 17 competitions; Bundesliga 2015/16 + 2023/24; prior ≥45′ / Year 1 in Bundesliga ≥30′.</a:t>
+              <a:rPr sz="1100" b="0" dirty="0">
+                <a:solidFill>
+                  <a:srgbClr val="333333"/>
+                </a:solidFill>
+              </a:rPr>
+              <a:t>Football Reference (</a:t>
+            </a:r>
+            <a:r>
+              <a:rPr sz="1100" b="0" dirty="0" err="1">
+                <a:solidFill>
+                  <a:srgbClr val="333333"/>
+                </a:solidFill>
+              </a:rPr>
+              <a:t>FBref</a:t>
+            </a:r>
+            <a:r>
+              <a:rPr sz="1100" b="0" dirty="0">
+                <a:solidFill>
+                  <a:srgbClr val="333333"/>
+                </a:solidFill>
+              </a:rPr>
+              <a:t>): 19 leagues; first Bundesliga season in 2021–2025; prior and Year 1 in Bundesliga minutes ≥300′.</a:t>
+            </a:r>
+          </a:p>
+          <a:p>
+            <a:r>
+              <a:rPr sz="1100" b="0" dirty="0" err="1">
+                <a:solidFill>
+                  <a:srgbClr val="333333"/>
+                </a:solidFill>
+              </a:rPr>
+              <a:t>StatsBomb</a:t>
+            </a:r>
+            <a:r>
+              <a:rPr sz="1100" b="0" dirty="0">
+                <a:solidFill>
+                  <a:srgbClr val="333333"/>
+                </a:solidFill>
+              </a:rPr>
+              <a:t>: 17 competitions; Bundesliga 2015/16 + 2023/24; prior ≥45′ / Year 1 in Bundesliga ≥30′.</a:t>
             </a:r>
           </a:p>
         </p:txBody>
@@ -12993,7 +13051,7 @@
         </p:nvSpPr>
         <p:spPr>
           <a:xfrm>
-            <a:off x="411480" y="2633472"/>
+            <a:off x="411480" y="2703810"/>
             <a:ext cx="329184" cy="329184"/>
           </a:xfrm>
           <a:prstGeom prst="ellipse">
@@ -13026,7 +13084,7 @@
           <a:p>
             <a:pPr algn="ctr"/>
             <a:r>
-              <a:rPr sz="1300" b="1">
+              <a:rPr sz="1300" b="1" dirty="0">
                 <a:solidFill>
                   <a:srgbClr val="FFFFFF"/>
                 </a:solidFill>
@@ -13045,7 +13103,7 @@
         </p:nvSpPr>
         <p:spPr>
           <a:xfrm>
-            <a:off x="832104" y="2596896"/>
+            <a:off x="832104" y="2708474"/>
             <a:ext cx="5029200" cy="487313"/>
           </a:xfrm>
           <a:prstGeom prst="rect">
@@ -13065,7 +13123,7 @@
               </a:spcAft>
             </a:pPr>
             <a:r>
-              <a:rPr sz="1200" b="0">
+              <a:rPr sz="1200" b="0" dirty="0">
                 <a:solidFill>
                   <a:srgbClr val="333333"/>
                 </a:solidFill>
@@ -13075,7 +13133,7 @@
           </a:p>
           <a:p>
             <a:r>
-              <a:rPr sz="1200" b="0">
+              <a:rPr sz="1200" b="0" dirty="0">
                 <a:solidFill>
                   <a:srgbClr val="333333"/>
                 </a:solidFill>
@@ -13570,156 +13628,13 @@
       </p:grpSpPr>
       <p:sp>
         <p:nvSpPr>
-          <p:cNvPr id="3" name="TextBox 2"/>
-          <p:cNvSpPr txBox="1"/>
-          <p:nvPr/>
-        </p:nvSpPr>
-        <p:spPr>
-          <a:xfrm>
-            <a:off x="747932" y="282526"/>
-            <a:ext cx="10972800" cy="3616375"/>
-          </a:xfrm>
-          <a:prstGeom prst="rect">
-            <a:avLst/>
-          </a:prstGeom>
-          <a:noFill/>
-        </p:spPr>
-        <p:txBody>
-          <a:bodyPr wrap="square">
-            <a:spAutoFit/>
-          </a:bodyPr>
-          <a:lstStyle/>
-          <a:p>
-            <a:pPr>
-              <a:spcAft>
-                <a:spcPts val="300"/>
-              </a:spcAft>
-            </a:pPr>
-            <a:r>
-              <a:rPr sz="1400" b="0">
-                <a:solidFill>
-                  <a:srgbClr val="333333"/>
-                </a:solidFill>
-              </a:rPr>
-              <a:t>• Portable shortlists: FBref 105 metrics tested → 43 met stability floor → 32 met redundancy floor · StatsBomb 16 metrics tested → 7 met stability floor (all 7 kept after redundancy)</a:t>
-            </a:r>
-            <a:endParaRPr lang="en-US" sz="2400" b="1" dirty="0">
-              <a:solidFill>
-                <a:srgbClr val="3D5A80"/>
-              </a:solidFill>
-              <a:latin typeface="Calibri"/>
-            </a:endParaRPr>
-          </a:p>
-          <a:p>
-            <a:r>
-              <a:rPr sz="1400" b="0">
-                <a:solidFill>
-                  <a:srgbClr val="333333"/>
-                </a:solidFill>
-              </a:rPr>
-              <a:t/>
-            </a:r>
-          </a:p>
-          <a:p>
-            <a:r>
-              <a:rPr sz="1400" b="0">
-                <a:solidFill>
-                  <a:srgbClr val="333333"/>
-                </a:solidFill>
-              </a:rPr>
-              <a:t>• FBref traits most linked to Year 1 in Bundesliga minutes (p&lt;0.05): final-third passing, shot blocks, progressive distance, box defending</a:t>
-            </a:r>
-          </a:p>
-          <a:p>
-            <a:r>
-              <a:rPr sz="1400" b="0">
-                <a:solidFill>
-                  <a:srgbClr val="333333"/>
-                </a:solidFill>
-              </a:rPr>
-              <a:t/>
-            </a:r>
-          </a:p>
-          <a:p>
-            <a:r>
-              <a:rPr sz="1400" b="0">
-                <a:solidFill>
-                  <a:srgbClr val="333333"/>
-                </a:solidFill>
-              </a:rPr>
-              <a:t>• Feeder-league gaps are modest; exploratory OLS (N=117) — traits matter more than league label</a:t>
-            </a:r>
-          </a:p>
-          <a:p>
-            <a:r>
-              <a:rPr sz="1400" b="0">
-                <a:solidFill>
-                  <a:srgbClr val="333333"/>
-                </a:solidFill>
-              </a:rPr>
-              <a:t/>
-            </a:r>
-          </a:p>
-          <a:p>
-            <a:r>
-              <a:rPr sz="1400" b="0">
-                <a:solidFill>
-                  <a:srgbClr val="333333"/>
-                </a:solidFill>
-              </a:rPr>
-              <a:t>• Scout metrics that travel league-to-league. Year 1 in Bundesliga minutes = open-data success proxy</a:t>
-            </a:r>
-          </a:p>
-          <a:p>
-            <a:r>
-              <a:rPr sz="1400" b="0">
-                <a:solidFill>
-                  <a:srgbClr val="333333"/>
-                </a:solidFill>
-              </a:rPr>
-              <a:t/>
-            </a:r>
-          </a:p>
-          <a:p>
-            <a:r>
-              <a:rPr sz="1400" b="0">
-                <a:solidFill>
-                  <a:srgbClr val="333333"/>
-                </a:solidFill>
-              </a:rPr>
-              <a:t>• Future work: Δ Transfermarkt market value (next slide) as the club-grade outcome</a:t>
-            </a:r>
-          </a:p>
-        </p:txBody>
-      </p:sp>
-    </p:spTree>
-  </p:cSld>
-  <p:clrMapOvr>
-    <a:masterClrMapping/>
-  </p:clrMapOvr>
-</p:sld>
-</file>
-
-<file path=ppt/slides/slide21.xml><?xml version="1.0" encoding="utf-8"?>
-<p:sld xmlns:a="http://schemas.openxmlformats.org/drawingml/2006/main" xmlns:r="http://schemas.openxmlformats.org/officeDocument/2006/relationships" xmlns:p="http://schemas.openxmlformats.org/presentationml/2006/main">
-  <p:cSld>
-    <p:spTree>
-      <p:nvGrpSpPr>
-        <p:cNvPr id="1" name=""/>
-        <p:cNvGrpSpPr/>
-        <p:nvPr/>
-      </p:nvGrpSpPr>
-      <p:grpSpPr>
-        <a:xfrm>
-          <a:off x="0" y="0"/>
-          <a:ext cx="0" cy="0"/>
-          <a:chOff x="0" y="0"/>
-          <a:chExt cx="0" cy="0"/>
-        </a:xfrm>
-      </p:grpSpPr>
-      <p:sp>
-        <p:nvSpPr>
-          <p:cNvPr id="2" name="Rectangle 1"/>
+          <p:cNvPr id="2" name="Rectangle 1">
+            <a:extLst>
+              <a:ext uri="{FF2B5EF4-FFF2-40B4-BE49-F238E27FC236}">
+                <a16:creationId xmlns:a16="http://schemas.microsoft.com/office/drawing/2014/main" id="{240DF8E9-F5CF-8327-48D0-70D97E7B353A}"/>
+              </a:ext>
+            </a:extLst>
+          </p:cNvPr>
           <p:cNvSpPr/>
           <p:nvPr/>
         </p:nvSpPr>
@@ -13769,8 +13684,8 @@
         </p:nvSpPr>
         <p:spPr>
           <a:xfrm>
-            <a:off x="548640" y="411480"/>
-            <a:ext cx="10972800" cy="594360"/>
+            <a:off x="747932" y="960120"/>
+            <a:ext cx="10972800" cy="4000000"/>
           </a:xfrm>
           <a:prstGeom prst="rect">
             <a:avLst/>
@@ -13783,14 +13698,93 @@
           </a:bodyPr>
           <a:lstStyle/>
           <a:p>
-            <a:r>
-              <a:rPr sz="2800" b="1" dirty="0">
-                <a:solidFill>
-                  <a:srgbClr val="3D5A80"/>
-                </a:solidFill>
-                <a:latin typeface="Georgia"/>
-              </a:rPr>
-              <a:t>IF WE HAD THE DATA  ·  TRANSFERMARKT VALUE</a:t>
+            <a:pPr>
+              <a:spcAft>
+                <a:spcPts val="300"/>
+              </a:spcAft>
+            </a:pPr>
+            <a:r>
+              <a:rPr sz="1400" b="0">
+                <a:solidFill>
+                  <a:srgbClr val="333333"/>
+                </a:solidFill>
+              </a:rPr>
+              <a:t>• Portable shortlists: FBref 105 metrics tested → 43 met stability floor → 32 met redundancy floor · StatsBomb 16 metrics tested → 7 met stability floor (all 7 kept after redundancy)</a:t>
+            </a:r>
+            <a:endParaRPr lang="en-US" sz="2400" b="1" dirty="0">
+              <a:solidFill>
+                <a:srgbClr val="3D5A80"/>
+              </a:solidFill>
+              <a:latin typeface="Calibri"/>
+            </a:endParaRPr>
+          </a:p>
+          <a:p>
+            <a:endParaRPr lang="en-US" sz="2400" b="1" dirty="0">
+              <a:solidFill>
+                <a:srgbClr val="3D5A80"/>
+              </a:solidFill>
+              <a:latin typeface="Calibri"/>
+            </a:endParaRPr>
+          </a:p>
+          <a:p>
+            <a:r>
+              <a:rPr sz="1400" b="0">
+                <a:solidFill>
+                  <a:srgbClr val="333333"/>
+                </a:solidFill>
+              </a:rPr>
+              <a:t>• FBref traits most linked to Year 1 in Bundesliga minutes (p&lt;0.05): final-third passing, shot blocks, progressive distance, box defending</a:t>
+            </a:r>
+          </a:p>
+          <a:p>
+            <a:endParaRPr sz="1400" b="0">
+              <a:solidFill>
+                <a:srgbClr val="333333"/>
+              </a:solidFill>
+            </a:endParaRPr>
+          </a:p>
+          <a:p>
+            <a:r>
+              <a:rPr sz="1400" b="0">
+                <a:solidFill>
+                  <a:srgbClr val="333333"/>
+                </a:solidFill>
+              </a:rPr>
+              <a:t>• Feeder-league gaps are modest; exploratory OLS (N=117) — traits matter more than league label</a:t>
+            </a:r>
+          </a:p>
+          <a:p>
+            <a:endParaRPr sz="1400" b="0">
+              <a:solidFill>
+                <a:srgbClr val="333333"/>
+              </a:solidFill>
+            </a:endParaRPr>
+          </a:p>
+          <a:p>
+            <a:r>
+              <a:rPr sz="1400" b="0">
+                <a:solidFill>
+                  <a:srgbClr val="333333"/>
+                </a:solidFill>
+              </a:rPr>
+              <a:t>• Scout metrics that travel league-to-league. Year 1 in Bundesliga minutes = open-data success proxy</a:t>
+            </a:r>
+          </a:p>
+          <a:p>
+            <a:endParaRPr sz="1400" b="0">
+              <a:solidFill>
+                <a:srgbClr val="333333"/>
+              </a:solidFill>
+            </a:endParaRPr>
+          </a:p>
+          <a:p>
+            <a:r>
+              <a:rPr sz="1400" b="0">
+                <a:solidFill>
+                  <a:srgbClr val="333333"/>
+                </a:solidFill>
+              </a:rPr>
+              <a:t>• Future work: Δ Transfermarkt market value (next slide) as the club-grade outcome</a:t>
             </a:r>
           </a:p>
         </p:txBody>
@@ -13803,8 +13797,8 @@
         </p:nvSpPr>
         <p:spPr>
           <a:xfrm>
-            <a:off x="548640" y="960120"/>
-            <a:ext cx="10972800" cy="411480"/>
+            <a:off x="548640" y="411480"/>
+            <a:ext cx="10972800" cy="548640"/>
           </a:xfrm>
           <a:prstGeom prst="rect">
             <a:avLst/>
@@ -13818,538 +13812,12 @@
           <a:lstStyle/>
           <a:p>
             <a:r>
-              <a:rPr sz="1500" b="0">
-                <a:solidFill>
-                  <a:srgbClr val="555555"/>
-                </a:solidFill>
-                <a:latin typeface="Georgia"/>
-              </a:rPr>
-              <a:t>What we would use instead of (or alongside) Year 1 in Bundesliga minutes.</a:t>
-            </a:r>
-          </a:p>
-        </p:txBody>
-      </p:sp>
-      <p:sp>
-        <p:nvSpPr>
-          <p:cNvPr id="5" name="TextBox 4"/>
-          <p:cNvSpPr txBox="1"/>
-          <p:nvPr/>
-        </p:nvSpPr>
-        <p:spPr>
-          <a:xfrm>
-            <a:off x="685800" y="1417320"/>
-            <a:ext cx="10652760" cy="1477328"/>
-          </a:xfrm>
-          <a:prstGeom prst="rect">
-            <a:avLst/>
-          </a:prstGeom>
-          <a:noFill/>
-          <a:ln w="19050">
-            <a:solidFill>
-              <a:srgbClr val="002060"/>
-            </a:solidFill>
-          </a:ln>
-        </p:spPr>
-        <p:txBody>
-          <a:bodyPr wrap="square">
-            <a:spAutoFit/>
-          </a:bodyPr>
-          <a:lstStyle/>
-          <a:p>
-            <a:pPr>
-              <a:spcAft>
-                <a:spcPts val="600"/>
-              </a:spcAft>
-            </a:pPr>
-            <a:r>
-              <a:rPr sz="1300" b="0">
-                <a:solidFill>
-                  <a:srgbClr val="333333"/>
-                </a:solidFill>
-              </a:rPr>
-              <a:t>Top indicator in a full club model: change in market value (Δ Transfermarkt market value)</a:t>
-            </a:r>
-          </a:p>
-          <a:p>
-            <a:r>
-              <a:rPr sz="1300" b="0">
-                <a:solidFill>
-                  <a:srgbClr val="333333"/>
-                </a:solidFill>
-              </a:rPr>
-              <a:t>Captures performance + hype + contract context in one outcome scouts care about</a:t>
-            </a:r>
-          </a:p>
-          <a:p>
-            <a:r>
-              <a:rPr sz="1300" b="0">
-                <a:solidFill>
-                  <a:srgbClr val="333333"/>
-                </a:solidFill>
-              </a:rPr>
-              <a:t>NYRB project Axis-3 testing of player value used market value rather than Year 1 in Bundesliga minutes; this project uses open data only — Transfermarkt disallows scraping</a:t>
-            </a:r>
-          </a:p>
-          <a:p>
-            <a:r>
-              <a:rPr sz="1300" b="0">
-                <a:solidFill>
-                  <a:srgbClr val="333333"/>
-                </a:solidFill>
-              </a:rPr>
-              <a:t>So we proxy success with Year 1 in Bundesliga minutes until a licensed market-value feed is available</a:t>
-            </a:r>
-          </a:p>
-          <a:p>
-            <a:r>
-              <a:rPr sz="1300" b="0">
-                <a:solidFill>
-                  <a:srgbClr val="333333"/>
-                </a:solidFill>
-              </a:rPr>
-              <a:t>Natural extension: prior traits → Δ market value with holdout regression / ML</a:t>
-            </a:r>
-          </a:p>
-        </p:txBody>
-      </p:sp>
-    </p:spTree>
-    <p:extLst>
-      <p:ext uri="{BB962C8B-B14F-4D97-AF65-F5344CB8AC3E}">
-        <p14:creationId xmlns:p14="http://schemas.microsoft.com/office/powerpoint/2010/main" val="797582397"/>
-      </p:ext>
-    </p:extLst>
-  </p:cSld>
-  <p:clrMapOvr>
-    <a:masterClrMapping/>
-  </p:clrMapOvr>
-</p:sld>
-</file>
-
-<file path=ppt/slides/slide22.xml><?xml version="1.0" encoding="utf-8"?>
-<p:sld xmlns:a="http://schemas.openxmlformats.org/drawingml/2006/main" xmlns:p="http://schemas.openxmlformats.org/presentationml/2006/main" xmlns:r="http://schemas.openxmlformats.org/officeDocument/2006/relationships">
-  <p:cSld>
-    <p:spTree>
-      <p:nvGrpSpPr>
-        <p:cNvPr id="1" name=""/>
-        <p:cNvGrpSpPr/>
-        <p:nvPr/>
-      </p:nvGrpSpPr>
-      <p:grpSpPr/>
-      <p:sp>
-        <p:nvSpPr>
-          <p:cNvPr id="2" name="TextBox 1"/>
-          <p:cNvSpPr txBox="1"/>
-          <p:nvPr/>
-        </p:nvSpPr>
-        <p:spPr>
-          <a:xfrm>
-            <a:off x="457200" y="228600"/>
-            <a:ext cx="11155680" cy="457200"/>
-          </a:xfrm>
-          <a:prstGeom prst="rect">
-            <a:avLst/>
-          </a:prstGeom>
-          <a:noFill/>
-        </p:spPr>
-        <p:txBody>
-          <a:bodyPr wrap="square">
-            <a:spAutoFit/>
-          </a:bodyPr>
-          <a:lstStyle/>
-          <a:p>
-            <a:r>
-              <a:rPr sz="2200" b="1">
+              <a:rPr sz="2600" b="1">
                 <a:solidFill>
                   <a:srgbClr val="3D5A80"/>
                 </a:solidFill>
               </a:rPr>
-              <a:t>GLOSSARY · METRIC ABBREVIATIONS</a:t>
-            </a:r>
-          </a:p>
-        </p:txBody>
-      </p:sp>
-      <p:sp>
-        <p:nvSpPr>
-          <p:cNvPr id="3" name="TextBox 2"/>
-          <p:cNvSpPr txBox="1"/>
-          <p:nvPr/>
-        </p:nvSpPr>
-        <p:spPr>
-          <a:xfrm>
-            <a:off x="457200" y="822960"/>
-            <a:ext cx="5486400" cy="5669280"/>
-          </a:xfrm>
-          <a:prstGeom prst="rect">
-            <a:avLst/>
-          </a:prstGeom>
-          <a:noFill/>
-        </p:spPr>
-        <p:txBody>
-          <a:bodyPr wrap="square">
-            <a:spAutoFit/>
-          </a:bodyPr>
-          <a:lstStyle/>
-          <a:p>
-            <a:r>
-              <a:rPr sz="1100" b="0">
-                <a:solidFill>
-                  <a:srgbClr val="333333"/>
-                </a:solidFill>
-              </a:rPr>
-              <a:t>FBref (examples)</a:t>
-            </a:r>
-          </a:p>
-          <a:p>
-            <a:r>
-              <a:rPr sz="1100" b="0">
-                <a:solidFill>
-                  <a:srgbClr val="333333"/>
-                </a:solidFill>
-              </a:rPr>
-              <a:t>DEFPE — Defensive penalty-area touches /90</a:t>
-            </a:r>
-          </a:p>
-          <a:p>
-            <a:r>
-              <a:rPr sz="1100" b="0">
-                <a:solidFill>
-                  <a:srgbClr val="333333"/>
-                </a:solidFill>
-              </a:rPr>
-              <a:t>DEF3R — Defensive-third touches /90</a:t>
-            </a:r>
-          </a:p>
-          <a:p>
-            <a:r>
-              <a:rPr sz="1100" b="0">
-                <a:solidFill>
-                  <a:srgbClr val="333333"/>
-                </a:solidFill>
-              </a:rPr>
-              <a:t>PRGC — Progressive carries /90</a:t>
-            </a:r>
-          </a:p>
-          <a:p>
-            <a:r>
-              <a:rPr sz="1100" b="0">
-                <a:solidFill>
-                  <a:srgbClr val="333333"/>
-                </a:solidFill>
-              </a:rPr>
-              <a:t>PRGDI — Progressive carry distance /90</a:t>
-            </a:r>
-          </a:p>
-          <a:p>
-            <a:r>
-              <a:rPr sz="1100" b="0">
-                <a:solidFill>
-                  <a:srgbClr val="333333"/>
-                </a:solidFill>
-              </a:rPr>
-              <a:t>PRGRR — Progressive receives /90</a:t>
-            </a:r>
-          </a:p>
-          <a:p>
-            <a:r>
-              <a:rPr sz="1100" b="0">
-                <a:solidFill>
-                  <a:srgbClr val="333333"/>
-                </a:solidFill>
-              </a:rPr>
-              <a:t>XG — Expected goals /90</a:t>
-            </a:r>
-          </a:p>
-          <a:p>
-            <a:r>
-              <a:rPr sz="1100" b="0">
-                <a:solidFill>
-                  <a:srgbClr val="333333"/>
-                </a:solidFill>
-              </a:rPr>
-              <a:t>GLS — Goals /90</a:t>
-            </a:r>
-          </a:p>
-          <a:p>
-            <a:r>
-              <a:rPr sz="1100" b="0">
-                <a:solidFill>
-                  <a:srgbClr val="333333"/>
-                </a:solidFill>
-              </a:rPr>
-              <a:t>SOTPE / ATTSH — Shots on target /90</a:t>
-            </a:r>
-          </a:p>
-          <a:p>
-            <a:r>
-              <a:rPr sz="1100" b="0">
-                <a:solidFill>
-                  <a:srgbClr val="333333"/>
-                </a:solidFill>
-              </a:rPr>
-              <a:t>FINAL — Passes into final third /90</a:t>
-            </a:r>
-          </a:p>
-          <a:p>
-            <a:r>
-              <a:rPr sz="1100" b="0">
-                <a:solidFill>
-                  <a:srgbClr val="333333"/>
-                </a:solidFill>
-              </a:rPr>
-              <a:t>KP — Key passes /90</a:t>
-            </a:r>
-          </a:p>
-          <a:p>
-            <a:r>
-              <a:rPr sz="1100" b="0">
-                <a:solidFill>
-                  <a:srgbClr val="333333"/>
-                </a:solidFill>
-              </a:rPr>
-              <a:t>SH — Shot blocks /90</a:t>
-            </a:r>
-          </a:p>
-          <a:p>
-            <a:r>
-              <a:rPr sz="1100" b="0">
-                <a:solidFill>
-                  <a:srgbClr val="333333"/>
-                </a:solidFill>
-              </a:rPr>
-              <a:t>TKLD — Tackled (take-ons) /90</a:t>
-            </a:r>
-          </a:p>
-          <a:p>
-            <a:r>
-              <a:rPr sz="1100" b="0">
-                <a:solidFill>
-                  <a:srgbClr val="333333"/>
-                </a:solidFill>
-              </a:rPr>
-              <a:t>CLR — Clearances /90</a:t>
-            </a:r>
-          </a:p>
-          <a:p>
-            <a:r>
-              <a:rPr sz="1100" b="0">
-                <a:solidFill>
-                  <a:srgbClr val="333333"/>
-                </a:solidFill>
-              </a:rPr>
-              <a:t>INT — Interceptions /90</a:t>
-            </a:r>
-          </a:p>
-          <a:p>
-            <a:r>
-              <a:rPr sz="1100" b="0">
-                <a:solidFill>
-                  <a:srgbClr val="333333"/>
-                </a:solidFill>
-              </a:rPr>
-              <a:t>ATTLO — Long pass attempts /90</a:t>
-            </a:r>
-          </a:p>
-          <a:p>
-            <a:r>
-              <a:rPr sz="1100" b="0">
-                <a:solidFill>
-                  <a:srgbClr val="333333"/>
-                </a:solidFill>
-              </a:rPr>
-              <a:t>FLD — Fouls drawn /90</a:t>
-            </a:r>
-          </a:p>
-        </p:txBody>
-      </p:sp>
-      <p:sp>
-        <p:nvSpPr>
-          <p:cNvPr id="4" name="TextBox 3"/>
-          <p:cNvSpPr txBox="1"/>
-          <p:nvPr/>
-        </p:nvSpPr>
-        <p:spPr>
-          <a:xfrm>
-            <a:off x="6126480" y="822960"/>
-            <a:ext cx="5486400" cy="5669280"/>
-          </a:xfrm>
-          <a:prstGeom prst="rect">
-            <a:avLst/>
-          </a:prstGeom>
-          <a:noFill/>
-        </p:spPr>
-        <p:txBody>
-          <a:bodyPr wrap="square">
-            <a:spAutoFit/>
-          </a:bodyPr>
-          <a:lstStyle/>
-          <a:p>
-            <a:r>
-              <a:rPr sz="1100" b="0">
-                <a:solidFill>
-                  <a:srgbClr val="333333"/>
-                </a:solidFill>
-              </a:rPr>
-              <a:t>StatsBomb</a:t>
-            </a:r>
-          </a:p>
-          <a:p>
-            <a:r>
-              <a:rPr sz="1100" b="0">
-                <a:solidFill>
-                  <a:srgbClr val="333333"/>
-                </a:solidFill>
-              </a:rPr>
-              <a:t>PPC — Progressive passes (~10m+ toward goal) /90</a:t>
-            </a:r>
-          </a:p>
-          <a:p>
-            <a:r>
-              <a:rPr sz="1100" b="0">
-                <a:solidFill>
-                  <a:srgbClr val="333333"/>
-                </a:solidFill>
-              </a:rPr>
-              <a:t>DIS — Dispossessed /90 (often inverted: fewer = better)</a:t>
-            </a:r>
-          </a:p>
-          <a:p>
-            <a:r>
-              <a:rPr sz="1100" b="0">
-                <a:solidFill>
-                  <a:srgbClr val="333333"/>
-                </a:solidFill>
-              </a:rPr>
-              <a:t>PRS — Pressures /90</a:t>
-            </a:r>
-          </a:p>
-          <a:p>
-            <a:r>
-              <a:rPr sz="1100" b="0">
-                <a:solidFill>
-                  <a:srgbClr val="333333"/>
-                </a:solidFill>
-              </a:rPr>
-              <a:t>PAS — Pass volume /90</a:t>
-            </a:r>
-          </a:p>
-          <a:p>
-            <a:r>
-              <a:rPr sz="1100" b="0">
-                <a:solidFill>
-                  <a:srgbClr val="333333"/>
-                </a:solidFill>
-              </a:rPr>
-              <a:t>CLR — Clearances /90</a:t>
-            </a:r>
-          </a:p>
-          <a:p>
-            <a:r>
-              <a:rPr sz="1100" b="0">
-                <a:solidFill>
-                  <a:srgbClr val="333333"/>
-                </a:solidFill>
-              </a:rPr>
-              <a:t>DRB — Successful dribbles /90</a:t>
-            </a:r>
-          </a:p>
-          <a:p>
-            <a:r>
-              <a:rPr sz="1100" b="0">
-                <a:solidFill>
-                  <a:srgbClr val="333333"/>
-                </a:solidFill>
-              </a:rPr>
-              <a:t>PATT — Passes into final third /90</a:t>
-            </a:r>
-          </a:p>
-          <a:p>
-            <a:r>
-              <a:rPr sz="1100" b="0">
-                <a:solidFill>
-                  <a:srgbClr val="333333"/>
-                </a:solidFill>
-              </a:rPr>
-              <a:t>SH — Shots /90</a:t>
-            </a:r>
-          </a:p>
-          <a:p>
-            <a:r>
-              <a:rPr sz="1100" b="0">
-                <a:solidFill>
-                  <a:srgbClr val="333333"/>
-                </a:solidFill>
-              </a:rPr>
-              <a:t>XG — Non-penalty expected goals /90</a:t>
-            </a:r>
-          </a:p>
-          <a:p>
-            <a:r>
-              <a:rPr sz="1100" b="0">
-                <a:solidFill>
-                  <a:srgbClr val="333333"/>
-                </a:solidFill>
-              </a:rPr>
-              <a:t/>
-            </a:r>
-          </a:p>
-          <a:p>
-            <a:r>
-              <a:rPr sz="1100" b="0">
-                <a:solidFill>
-                  <a:srgbClr val="333333"/>
-                </a:solidFill>
-              </a:rPr>
-              <a:t>Other terms</a:t>
-            </a:r>
-          </a:p>
-          <a:p>
-            <a:r>
-              <a:rPr sz="1100" b="0">
-                <a:solidFill>
-                  <a:srgbClr val="333333"/>
-                </a:solidFill>
-              </a:rPr>
-              <a:t>Pearson r — linear correlation (stability)</a:t>
-            </a:r>
-          </a:p>
-          <a:p>
-            <a:r>
-              <a:rPr sz="1100" b="0">
-                <a:solidFill>
-                  <a:srgbClr val="333333"/>
-                </a:solidFill>
-              </a:rPr>
-              <a:t>Spearman ρ — rank correlation (success vs minutes)</a:t>
-            </a:r>
-          </a:p>
-          <a:p>
-            <a:r>
-              <a:rPr sz="1100" b="0">
-                <a:solidFill>
-                  <a:srgbClr val="333333"/>
-                </a:solidFill>
-              </a:rPr>
-              <a:t>Year 1 in Bundesliga — first Bundesliga season</a:t>
-            </a:r>
-          </a:p>
-          <a:p>
-            <a:r>
-              <a:rPr sz="1100" b="0">
-                <a:solidFill>
-                  <a:srgbClr val="333333"/>
-                </a:solidFill>
-              </a:rPr>
-              <a:t>Feeder league — prior league before Bundesliga arrival</a:t>
-            </a:r>
-          </a:p>
-          <a:p>
-            <a:r>
-              <a:rPr sz="1100" b="0">
-                <a:solidFill>
-                  <a:srgbClr val="333333"/>
-                </a:solidFill>
-              </a:rPr>
-              <a:t>n≥8 — only show leagues with ≥8 players in the cell</a:t>
+              <a:t>TAKEAWAYS</a:t>
             </a:r>
           </a:p>
         </p:txBody>
@@ -14362,7 +13830,7 @@
 </p:sld>
 </file>
 
-<file path=ppt/slides/slide23.xml><?xml version="1.0" encoding="utf-8"?>
+<file path=ppt/slides/slide21.xml><?xml version="1.0" encoding="utf-8"?>
 <p:sld xmlns:a="http://schemas.openxmlformats.org/drawingml/2006/main" xmlns:r="http://schemas.openxmlformats.org/officeDocument/2006/relationships" xmlns:p="http://schemas.openxmlformats.org/presentationml/2006/main">
   <p:cSld>
     <p:spTree>
@@ -14432,7 +13900,7 @@
         <p:spPr>
           <a:xfrm>
             <a:off x="548640" y="411480"/>
-            <a:ext cx="10972800" cy="2472472"/>
+            <a:ext cx="10972800" cy="594360"/>
           </a:xfrm>
           <a:prstGeom prst="rect">
             <a:avLst/>
@@ -14445,33 +13913,697 @@
           </a:bodyPr>
           <a:lstStyle/>
           <a:p>
+            <a:r>
+              <a:rPr sz="2800" b="1" dirty="0">
+                <a:solidFill>
+                  <a:srgbClr val="3D5A80"/>
+                </a:solidFill>
+                <a:latin typeface="Georgia"/>
+              </a:rPr>
+              <a:t>IF WE HAD THE DATA  ·  TRANSFERMARKT VALUE</a:t>
+            </a:r>
+          </a:p>
+        </p:txBody>
+      </p:sp>
+      <p:sp>
+        <p:nvSpPr>
+          <p:cNvPr id="4" name="TextBox 3"/>
+          <p:cNvSpPr txBox="1"/>
+          <p:nvPr/>
+        </p:nvSpPr>
+        <p:spPr>
+          <a:xfrm>
+            <a:off x="548640" y="960120"/>
+            <a:ext cx="10972800" cy="411480"/>
+          </a:xfrm>
+          <a:prstGeom prst="rect">
+            <a:avLst/>
+          </a:prstGeom>
+          <a:noFill/>
+        </p:spPr>
+        <p:txBody>
+          <a:bodyPr wrap="square">
+            <a:spAutoFit/>
+          </a:bodyPr>
+          <a:lstStyle/>
+          <a:p>
+            <a:r>
+              <a:rPr sz="1500" b="0">
+                <a:solidFill>
+                  <a:srgbClr val="555555"/>
+                </a:solidFill>
+                <a:latin typeface="Georgia"/>
+              </a:rPr>
+              <a:t>What we would use instead of (or alongside) Year 1 in Bundesliga minutes.</a:t>
+            </a:r>
+          </a:p>
+        </p:txBody>
+      </p:sp>
+      <p:sp>
+        <p:nvSpPr>
+          <p:cNvPr id="5" name="TextBox 4"/>
+          <p:cNvSpPr txBox="1"/>
+          <p:nvPr/>
+        </p:nvSpPr>
+        <p:spPr>
+          <a:xfrm>
+            <a:off x="685800" y="1417320"/>
+            <a:ext cx="10652760" cy="1477328"/>
+          </a:xfrm>
+          <a:prstGeom prst="rect">
+            <a:avLst/>
+          </a:prstGeom>
+          <a:noFill/>
+          <a:ln w="19050">
+            <a:solidFill>
+              <a:srgbClr val="002060"/>
+            </a:solidFill>
+          </a:ln>
+        </p:spPr>
+        <p:txBody>
+          <a:bodyPr wrap="square">
+            <a:spAutoFit/>
+          </a:bodyPr>
+          <a:lstStyle/>
+          <a:p>
+            <a:pPr>
+              <a:spcAft>
+                <a:spcPts val="600"/>
+              </a:spcAft>
+            </a:pPr>
+            <a:r>
+              <a:rPr sz="1300" b="0">
+                <a:solidFill>
+                  <a:srgbClr val="333333"/>
+                </a:solidFill>
+              </a:rPr>
+              <a:t>Top indicator in a full club model: change in market value (Δ Transfermarkt market value)</a:t>
+            </a:r>
+          </a:p>
+          <a:p>
+            <a:r>
+              <a:rPr sz="1300" b="0">
+                <a:solidFill>
+                  <a:srgbClr val="333333"/>
+                </a:solidFill>
+              </a:rPr>
+              <a:t>Captures performance + hype + contract context in one outcome scouts care about</a:t>
+            </a:r>
+          </a:p>
+          <a:p>
+            <a:r>
+              <a:rPr sz="1300" b="0">
+                <a:solidFill>
+                  <a:srgbClr val="333333"/>
+                </a:solidFill>
+              </a:rPr>
+              <a:t>NYRB project Axis-3 testing of player value used market value rather than Year 1 in Bundesliga minutes; this project uses open data only — Transfermarkt disallows scraping</a:t>
+            </a:r>
+          </a:p>
+          <a:p>
+            <a:r>
+              <a:rPr sz="1300" b="0">
+                <a:solidFill>
+                  <a:srgbClr val="333333"/>
+                </a:solidFill>
+              </a:rPr>
+              <a:t>So we proxy success with Year 1 in Bundesliga minutes until a licensed market-value feed is available</a:t>
+            </a:r>
+          </a:p>
+          <a:p>
+            <a:r>
+              <a:rPr sz="1300" b="0">
+                <a:solidFill>
+                  <a:srgbClr val="333333"/>
+                </a:solidFill>
+              </a:rPr>
+              <a:t>Natural extension: prior traits → Δ market value with holdout regression / ML</a:t>
+            </a:r>
+          </a:p>
+        </p:txBody>
+      </p:sp>
+    </p:spTree>
+    <p:extLst>
+      <p:ext uri="{BB962C8B-B14F-4D97-AF65-F5344CB8AC3E}">
+        <p14:creationId xmlns:p14="http://schemas.microsoft.com/office/powerpoint/2010/main" val="797582397"/>
+      </p:ext>
+    </p:extLst>
+  </p:cSld>
+  <p:clrMapOvr>
+    <a:masterClrMapping/>
+  </p:clrMapOvr>
+</p:sld>
+</file>
+
+<file path=ppt/slides/slide22.xml><?xml version="1.0" encoding="utf-8"?>
+<p:sld xmlns:a="http://schemas.openxmlformats.org/drawingml/2006/main" xmlns:r="http://schemas.openxmlformats.org/officeDocument/2006/relationships" xmlns:p="http://schemas.openxmlformats.org/presentationml/2006/main">
+  <p:cSld>
+    <p:spTree>
+      <p:nvGrpSpPr>
+        <p:cNvPr id="1" name=""/>
+        <p:cNvGrpSpPr/>
+        <p:nvPr/>
+      </p:nvGrpSpPr>
+      <p:grpSpPr>
+        <a:xfrm>
+          <a:off x="0" y="0"/>
+          <a:ext cx="0" cy="0"/>
+          <a:chOff x="0" y="0"/>
+          <a:chExt cx="0" cy="0"/>
+        </a:xfrm>
+      </p:grpSpPr>
+      <p:sp>
+        <p:nvSpPr>
+          <p:cNvPr id="2" name="TextBox 1"/>
+          <p:cNvSpPr txBox="1"/>
+          <p:nvPr/>
+        </p:nvSpPr>
+        <p:spPr>
+          <a:xfrm>
+            <a:off x="457200" y="228600"/>
+            <a:ext cx="11155680" cy="457200"/>
+          </a:xfrm>
+          <a:prstGeom prst="rect">
+            <a:avLst/>
+          </a:prstGeom>
+          <a:noFill/>
+        </p:spPr>
+        <p:txBody>
+          <a:bodyPr wrap="square">
+            <a:spAutoFit/>
+          </a:bodyPr>
+          <a:lstStyle/>
+          <a:p>
+            <a:r>
+              <a:rPr sz="2200" b="1">
+                <a:solidFill>
+                  <a:srgbClr val="3D5A80"/>
+                </a:solidFill>
+              </a:rPr>
+              <a:t>GLOSSARY · METRIC ABBREVIATIONS</a:t>
+            </a:r>
+          </a:p>
+        </p:txBody>
+      </p:sp>
+      <p:sp>
+        <p:nvSpPr>
+          <p:cNvPr id="3" name="TextBox 2"/>
+          <p:cNvSpPr txBox="1"/>
+          <p:nvPr/>
+        </p:nvSpPr>
+        <p:spPr>
+          <a:xfrm>
+            <a:off x="457200" y="822960"/>
+            <a:ext cx="5486400" cy="5669280"/>
+          </a:xfrm>
+          <a:prstGeom prst="rect">
+            <a:avLst/>
+          </a:prstGeom>
+          <a:noFill/>
+        </p:spPr>
+        <p:txBody>
+          <a:bodyPr wrap="square">
+            <a:spAutoFit/>
+          </a:bodyPr>
+          <a:lstStyle/>
+          <a:p>
+            <a:r>
+              <a:rPr sz="1100" b="0">
+                <a:solidFill>
+                  <a:srgbClr val="333333"/>
+                </a:solidFill>
+              </a:rPr>
+              <a:t>FBref (examples)</a:t>
+            </a:r>
+          </a:p>
+          <a:p>
+            <a:r>
+              <a:rPr sz="1100" b="0">
+                <a:solidFill>
+                  <a:srgbClr val="333333"/>
+                </a:solidFill>
+              </a:rPr>
+              <a:t>DEFPE — Defensive penalty-area touches /90</a:t>
+            </a:r>
+          </a:p>
+          <a:p>
+            <a:r>
+              <a:rPr sz="1100" b="0">
+                <a:solidFill>
+                  <a:srgbClr val="333333"/>
+                </a:solidFill>
+              </a:rPr>
+              <a:t>DEF3R — Defensive-third touches /90</a:t>
+            </a:r>
+          </a:p>
+          <a:p>
+            <a:r>
+              <a:rPr sz="1100" b="0">
+                <a:solidFill>
+                  <a:srgbClr val="333333"/>
+                </a:solidFill>
+              </a:rPr>
+              <a:t>PRGC — Progressive carries /90</a:t>
+            </a:r>
+          </a:p>
+          <a:p>
+            <a:r>
+              <a:rPr sz="1100" b="0">
+                <a:solidFill>
+                  <a:srgbClr val="333333"/>
+                </a:solidFill>
+              </a:rPr>
+              <a:t>PRGDI — Progressive carry distance /90</a:t>
+            </a:r>
+          </a:p>
+          <a:p>
+            <a:r>
+              <a:rPr sz="1100" b="0">
+                <a:solidFill>
+                  <a:srgbClr val="333333"/>
+                </a:solidFill>
+              </a:rPr>
+              <a:t>PRGRR — Progressive receives /90</a:t>
+            </a:r>
+          </a:p>
+          <a:p>
+            <a:r>
+              <a:rPr sz="1100" b="0">
+                <a:solidFill>
+                  <a:srgbClr val="333333"/>
+                </a:solidFill>
+              </a:rPr>
+              <a:t>XG — Expected goals /90</a:t>
+            </a:r>
+          </a:p>
+          <a:p>
+            <a:r>
+              <a:rPr sz="1100" b="0">
+                <a:solidFill>
+                  <a:srgbClr val="333333"/>
+                </a:solidFill>
+              </a:rPr>
+              <a:t>GLS — Goals /90</a:t>
+            </a:r>
+          </a:p>
+          <a:p>
+            <a:r>
+              <a:rPr sz="1100" b="0">
+                <a:solidFill>
+                  <a:srgbClr val="333333"/>
+                </a:solidFill>
+              </a:rPr>
+              <a:t>SOTPE / ATTSH — Shots on target /90</a:t>
+            </a:r>
+          </a:p>
+          <a:p>
+            <a:r>
+              <a:rPr sz="1100" b="0">
+                <a:solidFill>
+                  <a:srgbClr val="333333"/>
+                </a:solidFill>
+              </a:rPr>
+              <a:t>FINAL — Passes into final third /90</a:t>
+            </a:r>
+          </a:p>
+          <a:p>
+            <a:r>
+              <a:rPr sz="1100" b="0">
+                <a:solidFill>
+                  <a:srgbClr val="333333"/>
+                </a:solidFill>
+              </a:rPr>
+              <a:t>KP — Key passes /90</a:t>
+            </a:r>
+          </a:p>
+          <a:p>
+            <a:r>
+              <a:rPr sz="1100" b="0">
+                <a:solidFill>
+                  <a:srgbClr val="333333"/>
+                </a:solidFill>
+              </a:rPr>
+              <a:t>SH — Shot blocks /90</a:t>
+            </a:r>
+          </a:p>
+          <a:p>
+            <a:r>
+              <a:rPr sz="1100" b="0">
+                <a:solidFill>
+                  <a:srgbClr val="333333"/>
+                </a:solidFill>
+              </a:rPr>
+              <a:t>TKLD — Tackled (take-ons) /90</a:t>
+            </a:r>
+          </a:p>
+          <a:p>
+            <a:r>
+              <a:rPr sz="1100" b="0">
+                <a:solidFill>
+                  <a:srgbClr val="333333"/>
+                </a:solidFill>
+              </a:rPr>
+              <a:t>CLR — Clearances /90</a:t>
+            </a:r>
+          </a:p>
+          <a:p>
+            <a:r>
+              <a:rPr sz="1100" b="0">
+                <a:solidFill>
+                  <a:srgbClr val="333333"/>
+                </a:solidFill>
+              </a:rPr>
+              <a:t>INT — Interceptions /90</a:t>
+            </a:r>
+          </a:p>
+          <a:p>
+            <a:r>
+              <a:rPr sz="1100" b="0">
+                <a:solidFill>
+                  <a:srgbClr val="333333"/>
+                </a:solidFill>
+              </a:rPr>
+              <a:t>ATTLO — Long pass attempts /90</a:t>
+            </a:r>
+          </a:p>
+          <a:p>
+            <a:r>
+              <a:rPr sz="1100" b="0">
+                <a:solidFill>
+                  <a:srgbClr val="333333"/>
+                </a:solidFill>
+              </a:rPr>
+              <a:t>FLD — Fouls drawn /90</a:t>
+            </a:r>
+          </a:p>
+        </p:txBody>
+      </p:sp>
+      <p:sp>
+        <p:nvSpPr>
+          <p:cNvPr id="4" name="TextBox 3"/>
+          <p:cNvSpPr txBox="1"/>
+          <p:nvPr/>
+        </p:nvSpPr>
+        <p:spPr>
+          <a:xfrm>
+            <a:off x="6126480" y="822960"/>
+            <a:ext cx="5486400" cy="5669280"/>
+          </a:xfrm>
+          <a:prstGeom prst="rect">
+            <a:avLst/>
+          </a:prstGeom>
+          <a:noFill/>
+        </p:spPr>
+        <p:txBody>
+          <a:bodyPr wrap="square">
+            <a:spAutoFit/>
+          </a:bodyPr>
+          <a:lstStyle/>
+          <a:p>
+            <a:r>
+              <a:rPr sz="1100" b="0">
+                <a:solidFill>
+                  <a:srgbClr val="333333"/>
+                </a:solidFill>
+              </a:rPr>
+              <a:t>StatsBomb</a:t>
+            </a:r>
+          </a:p>
+          <a:p>
+            <a:r>
+              <a:rPr sz="1100" b="0">
+                <a:solidFill>
+                  <a:srgbClr val="333333"/>
+                </a:solidFill>
+              </a:rPr>
+              <a:t>PPC — Progressive passes (~10m+ toward goal) /90</a:t>
+            </a:r>
+          </a:p>
+          <a:p>
+            <a:r>
+              <a:rPr sz="1100" b="0">
+                <a:solidFill>
+                  <a:srgbClr val="333333"/>
+                </a:solidFill>
+              </a:rPr>
+              <a:t>DIS — Dispossessed /90 (often inverted: fewer = better)</a:t>
+            </a:r>
+          </a:p>
+          <a:p>
+            <a:r>
+              <a:rPr sz="1100" b="0">
+                <a:solidFill>
+                  <a:srgbClr val="333333"/>
+                </a:solidFill>
+              </a:rPr>
+              <a:t>PRS — Pressures /90</a:t>
+            </a:r>
+          </a:p>
+          <a:p>
+            <a:r>
+              <a:rPr sz="1100" b="0">
+                <a:solidFill>
+                  <a:srgbClr val="333333"/>
+                </a:solidFill>
+              </a:rPr>
+              <a:t>PAS — Pass volume /90</a:t>
+            </a:r>
+          </a:p>
+          <a:p>
+            <a:r>
+              <a:rPr sz="1100" b="0">
+                <a:solidFill>
+                  <a:srgbClr val="333333"/>
+                </a:solidFill>
+              </a:rPr>
+              <a:t>CLR — Clearances /90</a:t>
+            </a:r>
+          </a:p>
+          <a:p>
+            <a:r>
+              <a:rPr sz="1100" b="0">
+                <a:solidFill>
+                  <a:srgbClr val="333333"/>
+                </a:solidFill>
+              </a:rPr>
+              <a:t>DRB — Successful dribbles /90</a:t>
+            </a:r>
+          </a:p>
+          <a:p>
+            <a:r>
+              <a:rPr sz="1100" b="0">
+                <a:solidFill>
+                  <a:srgbClr val="333333"/>
+                </a:solidFill>
+              </a:rPr>
+              <a:t>PATT — Passes into final third /90</a:t>
+            </a:r>
+          </a:p>
+          <a:p>
+            <a:r>
+              <a:rPr sz="1100" b="0">
+                <a:solidFill>
+                  <a:srgbClr val="333333"/>
+                </a:solidFill>
+              </a:rPr>
+              <a:t>SH — Shots /90</a:t>
+            </a:r>
+          </a:p>
+          <a:p>
+            <a:r>
+              <a:rPr sz="1100" b="0">
+                <a:solidFill>
+                  <a:srgbClr val="333333"/>
+                </a:solidFill>
+              </a:rPr>
+              <a:t>XG — Non-penalty expected goals /90</a:t>
+            </a:r>
+          </a:p>
+          <a:p>
+            <a:endParaRPr sz="1100" b="0">
+              <a:solidFill>
+                <a:srgbClr val="333333"/>
+              </a:solidFill>
+            </a:endParaRPr>
+          </a:p>
+          <a:p>
+            <a:r>
+              <a:rPr sz="1100" b="0">
+                <a:solidFill>
+                  <a:srgbClr val="333333"/>
+                </a:solidFill>
+              </a:rPr>
+              <a:t>Other terms</a:t>
+            </a:r>
+          </a:p>
+          <a:p>
+            <a:r>
+              <a:rPr sz="1100" b="0">
+                <a:solidFill>
+                  <a:srgbClr val="333333"/>
+                </a:solidFill>
+              </a:rPr>
+              <a:t>Pearson r — linear correlation (stability)</a:t>
+            </a:r>
+          </a:p>
+          <a:p>
+            <a:r>
+              <a:rPr sz="1100" b="0">
+                <a:solidFill>
+                  <a:srgbClr val="333333"/>
+                </a:solidFill>
+              </a:rPr>
+              <a:t>Spearman ρ — rank correlation (success vs minutes)</a:t>
+            </a:r>
+          </a:p>
+          <a:p>
+            <a:r>
+              <a:rPr sz="1100" b="0">
+                <a:solidFill>
+                  <a:srgbClr val="333333"/>
+                </a:solidFill>
+              </a:rPr>
+              <a:t>Year 1 in Bundesliga — first Bundesliga season</a:t>
+            </a:r>
+          </a:p>
+          <a:p>
+            <a:r>
+              <a:rPr sz="1100" b="0">
+                <a:solidFill>
+                  <a:srgbClr val="333333"/>
+                </a:solidFill>
+              </a:rPr>
+              <a:t>Feeder league — prior league before Bundesliga arrival</a:t>
+            </a:r>
+          </a:p>
+          <a:p>
+            <a:r>
+              <a:rPr sz="1100" b="0">
+                <a:solidFill>
+                  <a:srgbClr val="333333"/>
+                </a:solidFill>
+              </a:rPr>
+              <a:t>n≥8 — only show leagues with ≥8 players in the cell</a:t>
+            </a:r>
+          </a:p>
+        </p:txBody>
+      </p:sp>
+    </p:spTree>
+  </p:cSld>
+  <p:clrMapOvr>
+    <a:masterClrMapping/>
+  </p:clrMapOvr>
+</p:sld>
+</file>
+
+<file path=ppt/slides/slide23.xml><?xml version="1.0" encoding="utf-8"?>
+<p:sld xmlns:a="http://schemas.openxmlformats.org/drawingml/2006/main" xmlns:r="http://schemas.openxmlformats.org/officeDocument/2006/relationships" xmlns:p="http://schemas.openxmlformats.org/presentationml/2006/main">
+  <p:cSld>
+    <p:spTree>
+      <p:nvGrpSpPr>
+        <p:cNvPr id="1" name=""/>
+        <p:cNvGrpSpPr/>
+        <p:nvPr/>
+      </p:nvGrpSpPr>
+      <p:grpSpPr>
+        <a:xfrm>
+          <a:off x="0" y="0"/>
+          <a:ext cx="0" cy="0"/>
+          <a:chOff x="0" y="0"/>
+          <a:chExt cx="0" cy="0"/>
+        </a:xfrm>
+      </p:grpSpPr>
+      <p:sp>
+        <p:nvSpPr>
+          <p:cNvPr id="2" name="Rectangle 1"/>
+          <p:cNvSpPr/>
+          <p:nvPr/>
+        </p:nvSpPr>
+        <p:spPr>
+          <a:xfrm>
+            <a:off x="0" y="0"/>
+            <a:ext cx="12191695" cy="6858000"/>
+          </a:xfrm>
+          <a:prstGeom prst="rect">
+            <a:avLst/>
+          </a:prstGeom>
+          <a:solidFill>
+            <a:srgbClr val="F4F5F7"/>
+          </a:solidFill>
+          <a:ln>
+            <a:noFill/>
+          </a:ln>
+        </p:spPr>
+        <p:style>
+          <a:lnRef idx="1">
+            <a:schemeClr val="accent1"/>
+          </a:lnRef>
+          <a:fillRef idx="3">
+            <a:schemeClr val="accent1"/>
+          </a:fillRef>
+          <a:effectRef idx="2">
+            <a:schemeClr val="accent1"/>
+          </a:effectRef>
+          <a:fontRef idx="minor">
+            <a:schemeClr val="lt1"/>
+          </a:fontRef>
+        </p:style>
+        <p:txBody>
+          <a:bodyPr rtlCol="0" anchor="ctr"/>
+          <a:lstStyle/>
+          <a:p>
+            <a:pPr algn="ctr"/>
+            <a:endParaRPr/>
+          </a:p>
+        </p:txBody>
+      </p:sp>
+      <p:sp>
+        <p:nvSpPr>
+          <p:cNvPr id="3" name="TextBox 2"/>
+          <p:cNvSpPr txBox="1"/>
+          <p:nvPr/>
+        </p:nvSpPr>
+        <p:spPr>
+          <a:xfrm>
+            <a:off x="548640" y="411480"/>
+            <a:ext cx="10972800" cy="1744067"/>
+          </a:xfrm>
+          <a:prstGeom prst="rect">
+            <a:avLst/>
+          </a:prstGeom>
+          <a:noFill/>
+        </p:spPr>
+        <p:txBody>
+          <a:bodyPr wrap="square">
+            <a:spAutoFit/>
+          </a:bodyPr>
+          <a:lstStyle/>
+          <a:p>
             <a:pPr>
               <a:spcAft>
                 <a:spcPts val="400"/>
               </a:spcAft>
             </a:pPr>
             <a:r>
-              <a:rPr sz="1300" b="0">
-                <a:solidFill>
-                  <a:srgbClr val="333333"/>
-                </a:solidFill>
+              <a:rPr sz="2600" b="1" dirty="0">
+                <a:solidFill>
+                  <a:srgbClr val="333333"/>
+                </a:solidFill>
+                <a:latin typeface="Georgia" panose="02040502050405020303" pitchFamily="18" charset="0"/>
               </a:rPr>
               <a:t>Deliverables</a:t>
             </a:r>
           </a:p>
           <a:p>
-            <a:r>
-              <a:rPr sz="1300" b="0">
-                <a:solidFill>
-                  <a:srgbClr val="333333"/>
-                </a:solidFill>
-              </a:rPr>
-              <a:t/>
-            </a:r>
-          </a:p>
-          <a:p>
-            <a:r>
-              <a:rPr sz="1300" b="0">
+            <a:endParaRPr sz="1300" b="0" dirty="0">
+              <a:solidFill>
+                <a:srgbClr val="333333"/>
+              </a:solidFill>
+            </a:endParaRPr>
+          </a:p>
+          <a:p>
+            <a:r>
+              <a:rPr sz="1300" b="0" dirty="0">
                 <a:solidFill>
                   <a:srgbClr val="333333"/>
                 </a:solidFill>
@@ -14480,43 +14612,130 @@
             </a:r>
           </a:p>
           <a:p>
-            <a:r>
-              <a:rPr sz="1300" b="0">
-                <a:solidFill>
-                  <a:srgbClr val="333333"/>
-                </a:solidFill>
-              </a:rPr>
-              <a:t/>
-            </a:r>
-          </a:p>
-          <a:p>
-            <a:r>
-              <a:rPr sz="1300" b="0">
-                <a:solidFill>
-                  <a:srgbClr val="333333"/>
-                </a:solidFill>
-              </a:rPr>
-              <a:t>Repo: deck · README.md · interactive_player_explorer.html · stability_redundancy_inspector.html · projectproposal</a:t>
-            </a:r>
-          </a:p>
-          <a:p>
-            <a:r>
-              <a:rPr sz="1300" b="0">
-                <a:solidFill>
-                  <a:srgbClr val="333333"/>
-                </a:solidFill>
-              </a:rPr>
-              <a:t/>
-            </a:r>
-          </a:p>
-          <a:p>
-            <a:r>
-              <a:rPr sz="1300" b="0">
-                <a:solidFill>
-                  <a:srgbClr val="333333"/>
-                </a:solidFill>
-              </a:rPr>
-              <a:t>Stability floors: FBref Attacking/Passing/Other Pearson r ≥ 0.60 · Defending/Carrying Pearson r ≥ 0.50 · StatsBomb Pearson r ≥ 0.40 · final shortlists 32 / 7</a:t>
+            <a:endParaRPr sz="1300" b="0" dirty="0">
+              <a:solidFill>
+                <a:srgbClr val="333333"/>
+              </a:solidFill>
+            </a:endParaRPr>
+          </a:p>
+          <a:p>
+            <a:r>
+              <a:rPr sz="1300" b="0" dirty="0">
+                <a:solidFill>
+                  <a:srgbClr val="333333"/>
+                </a:solidFill>
+              </a:rPr>
+              <a:t>Repo: deck · </a:t>
+            </a:r>
+            <a:r>
+              <a:rPr sz="1300" b="0" dirty="0" err="1">
+                <a:solidFill>
+                  <a:srgbClr val="333333"/>
+                </a:solidFill>
+              </a:rPr>
+              <a:t>README.md</a:t>
+            </a:r>
+            <a:r>
+              <a:rPr sz="1300" b="0" dirty="0">
+                <a:solidFill>
+                  <a:srgbClr val="333333"/>
+                </a:solidFill>
+              </a:rPr>
+              <a:t> · </a:t>
+            </a:r>
+            <a:r>
+              <a:rPr sz="1300" b="0" dirty="0" err="1">
+                <a:solidFill>
+                  <a:srgbClr val="333333"/>
+                </a:solidFill>
+              </a:rPr>
+              <a:t>interactive_player_explorer.html</a:t>
+            </a:r>
+            <a:r>
+              <a:rPr sz="1300" b="0" dirty="0">
+                <a:solidFill>
+                  <a:srgbClr val="333333"/>
+                </a:solidFill>
+              </a:rPr>
+              <a:t> · </a:t>
+            </a:r>
+            <a:r>
+              <a:rPr sz="1300" b="0" dirty="0" err="1">
+                <a:solidFill>
+                  <a:srgbClr val="333333"/>
+                </a:solidFill>
+              </a:rPr>
+              <a:t>stability_redundancy_inspector.html</a:t>
+            </a:r>
+            <a:r>
+              <a:rPr sz="1300" b="0" dirty="0">
+                <a:solidFill>
+                  <a:srgbClr val="333333"/>
+                </a:solidFill>
+              </a:rPr>
+              <a:t> · </a:t>
+            </a:r>
+            <a:r>
+              <a:rPr sz="1300" b="0" dirty="0" err="1">
+                <a:solidFill>
+                  <a:srgbClr val="333333"/>
+                </a:solidFill>
+              </a:rPr>
+              <a:t>projectproposal</a:t>
+            </a:r>
+            <a:endParaRPr sz="1300" b="0" dirty="0">
+              <a:solidFill>
+                <a:srgbClr val="333333"/>
+              </a:solidFill>
+            </a:endParaRPr>
+          </a:p>
+          <a:p>
+            <a:endParaRPr sz="1300" b="0" dirty="0">
+              <a:solidFill>
+                <a:srgbClr val="333333"/>
+              </a:solidFill>
+            </a:endParaRPr>
+          </a:p>
+          <a:p>
+            <a:r>
+              <a:rPr sz="1300" b="0" dirty="0">
+                <a:solidFill>
+                  <a:srgbClr val="333333"/>
+                </a:solidFill>
+              </a:rPr>
+              <a:t>Stability floors: </a:t>
+            </a:r>
+            <a:r>
+              <a:rPr sz="1300" b="0" dirty="0" err="1">
+                <a:solidFill>
+                  <a:srgbClr val="333333"/>
+                </a:solidFill>
+              </a:rPr>
+              <a:t>FBref</a:t>
+            </a:r>
+            <a:r>
+              <a:rPr sz="1300" b="0" dirty="0">
+                <a:solidFill>
+                  <a:srgbClr val="333333"/>
+                </a:solidFill>
+              </a:rPr>
+              <a:t> Attacking/Passing/Other Pearson r ≥ 0.60 · Defending/Carrying Pearson r ≥ 0.50 · </a:t>
+            </a:r>
+            <a:r>
+              <a:rPr sz="1300" b="0" dirty="0" err="1">
+                <a:solidFill>
+                  <a:srgbClr val="333333"/>
+                </a:solidFill>
+              </a:rPr>
+              <a:t>StatsBomb</a:t>
+            </a:r>
+            <a:r>
+              <a:rPr sz="1300" b="0" dirty="0">
+                <a:solidFill>
+                  <a:srgbClr val="333333"/>
+                </a:solidFill>
+              </a:rPr>
+              <a:t> Pearson r ≥ 0.40 · final shortlists 32 / 7</a:t>
             </a:r>
           </a:p>
         </p:txBody>
@@ -15592,7 +15811,7 @@
         <p:spPr>
           <a:xfrm>
             <a:off x="457200" y="960120"/>
-            <a:ext cx="11247120" cy="868680"/>
+            <a:ext cx="11109960" cy="1190526"/>
           </a:xfrm>
           <a:prstGeom prst="roundRect">
             <a:avLst/>
@@ -15705,7 +15924,7 @@
         </p:nvSpPr>
         <p:spPr>
           <a:xfrm>
-            <a:off x="457200" y="2011680"/>
+            <a:off x="457200" y="2844014"/>
             <a:ext cx="3657600" cy="2331720"/>
           </a:xfrm>
           <a:prstGeom prst="roundRect">
@@ -15751,7 +15970,7 @@
         </p:nvSpPr>
         <p:spPr>
           <a:xfrm>
-            <a:off x="457200" y="2011680"/>
+            <a:off x="457200" y="2844014"/>
             <a:ext cx="73152" cy="2331720"/>
           </a:xfrm>
           <a:prstGeom prst="rect">
@@ -15795,7 +16014,7 @@
         </p:nvSpPr>
         <p:spPr>
           <a:xfrm>
-            <a:off x="640080" y="2121408"/>
+            <a:off x="640080" y="2953742"/>
             <a:ext cx="3337560" cy="338554"/>
           </a:xfrm>
           <a:prstGeom prst="rect">
@@ -15838,7 +16057,7 @@
         </p:nvSpPr>
         <p:spPr>
           <a:xfrm>
-            <a:off x="640080" y="2450592"/>
+            <a:off x="640080" y="3282926"/>
             <a:ext cx="3291840" cy="995144"/>
           </a:xfrm>
           <a:prstGeom prst="rect">
@@ -15962,7 +16181,7 @@
         </p:nvSpPr>
         <p:spPr>
           <a:xfrm>
-            <a:off x="4297680" y="2011680"/>
+            <a:off x="4297680" y="2844014"/>
             <a:ext cx="3657600" cy="2331720"/>
           </a:xfrm>
           <a:prstGeom prst="roundRect">
@@ -16008,7 +16227,7 @@
         </p:nvSpPr>
         <p:spPr>
           <a:xfrm>
-            <a:off x="4297680" y="2011680"/>
+            <a:off x="4297680" y="2844014"/>
             <a:ext cx="73152" cy="2331720"/>
           </a:xfrm>
           <a:prstGeom prst="rect">
@@ -16052,7 +16271,7 @@
         </p:nvSpPr>
         <p:spPr>
           <a:xfrm>
-            <a:off x="4480560" y="2121408"/>
+            <a:off x="4480560" y="2953742"/>
             <a:ext cx="3337560" cy="338554"/>
           </a:xfrm>
           <a:prstGeom prst="rect">
@@ -16095,7 +16314,7 @@
         </p:nvSpPr>
         <p:spPr>
           <a:xfrm>
-            <a:off x="4480560" y="2450592"/>
+            <a:off x="4480560" y="3282926"/>
             <a:ext cx="3291840" cy="1395254"/>
           </a:xfrm>
           <a:prstGeom prst="rect">
@@ -16195,7 +16414,7 @@
         </p:nvSpPr>
         <p:spPr>
           <a:xfrm>
-            <a:off x="8138160" y="2011680"/>
+            <a:off x="8138160" y="2844014"/>
             <a:ext cx="3566160" cy="2331720"/>
           </a:xfrm>
           <a:prstGeom prst="roundRect">
@@ -16241,7 +16460,7 @@
         </p:nvSpPr>
         <p:spPr>
           <a:xfrm>
-            <a:off x="8138160" y="2011680"/>
+            <a:off x="8138160" y="2844014"/>
             <a:ext cx="73152" cy="2331720"/>
           </a:xfrm>
           <a:prstGeom prst="rect">
@@ -16285,7 +16504,7 @@
         </p:nvSpPr>
         <p:spPr>
           <a:xfrm>
-            <a:off x="8321040" y="2121408"/>
+            <a:off x="8321040" y="2953742"/>
             <a:ext cx="3246120" cy="338554"/>
           </a:xfrm>
           <a:prstGeom prst="rect">
@@ -16328,7 +16547,7 @@
         </p:nvSpPr>
         <p:spPr>
           <a:xfrm>
-            <a:off x="8321040" y="2450592"/>
+            <a:off x="8321040" y="3282926"/>
             <a:ext cx="3200400" cy="1783079"/>
           </a:xfrm>
           <a:prstGeom prst="rect">
@@ -16629,13 +16848,20 @@
             </a:r>
           </a:p>
           <a:p>
+            <a:endParaRPr sz="1200">
+              <a:solidFill>
+                <a:srgbClr val="333333"/>
+              </a:solidFill>
+            </a:endParaRPr>
+          </a:p>
+          <a:p>
             <a:r>
               <a:rPr sz="1200">
                 <a:solidFill>
                   <a:srgbClr val="333333"/>
                 </a:solidFill>
               </a:rPr>
-              <a:t/>
+              <a:t>Outside-league tables + player-page fills</a:t>
             </a:r>
           </a:p>
           <a:p>
@@ -16645,7 +16871,7 @@
                   <a:srgbClr val="333333"/>
                 </a:solidFill>
               </a:rPr>
-              <a:t>Outside-league tables + player-page fills</a:t>
+              <a:t>Analysis window: first Bundesliga end-years 2021–2025</a:t>
             </a:r>
           </a:p>
           <a:p>
@@ -16655,8 +16881,15 @@
                   <a:srgbClr val="333333"/>
                 </a:solidFill>
               </a:rPr>
-              <a:t>Analysis window: first Bundesliga end-years 2021–2025</a:t>
-            </a:r>
+              <a:t>Minutes: prior ≥300′ · Year 1 in Bundesliga ≥300′ → N=329 pairs · 19 leagues</a:t>
+            </a:r>
+          </a:p>
+          <a:p>
+            <a:endParaRPr sz="1200">
+              <a:solidFill>
+                <a:srgbClr val="333333"/>
+              </a:solidFill>
+            </a:endParaRPr>
           </a:p>
           <a:p>
             <a:r>
@@ -16665,38 +16898,15 @@
                   <a:srgbClr val="333333"/>
                 </a:solidFill>
               </a:rPr>
-              <a:t>Minutes: prior ≥300′ · Year 1 in Bundesliga ≥300′ → N=329 pairs · 19 leagues</a:t>
-            </a:r>
-          </a:p>
-          <a:p>
-            <a:r>
-              <a:rPr sz="1200">
-                <a:solidFill>
-                  <a:srgbClr val="333333"/>
-                </a:solidFill>
-              </a:rPr>
-              <a:t/>
-            </a:r>
-          </a:p>
-          <a:p>
-            <a:r>
-              <a:rPr sz="1200">
-                <a:solidFill>
-                  <a:srgbClr val="333333"/>
-                </a:solidFill>
-              </a:rPr>
               <a:t>League-relative scaling tested and dropped: “how high vs peers in the same prior league” (z-score / percentile) did not improve prior→Year 1 in Bundesliga stability, so we keep absolute per-90 rates.</a:t>
             </a:r>
           </a:p>
           <a:p>
-            <a:r>
-              <a:rPr sz="1200">
-                <a:solidFill>
-                  <a:srgbClr val="333333"/>
-                </a:solidFill>
-              </a:rPr>
-              <a:t/>
-            </a:r>
+            <a:endParaRPr sz="1200">
+              <a:solidFill>
+                <a:srgbClr val="333333"/>
+              </a:solidFill>
+            </a:endParaRPr>
           </a:p>
           <a:p>
             <a:r>
@@ -16860,14 +17070,11 @@
             </a:r>
           </a:p>
           <a:p>
-            <a:r>
-              <a:rPr sz="1200" b="0">
-                <a:solidFill>
-                  <a:srgbClr val="333333"/>
-                </a:solidFill>
-              </a:rPr>
-              <a:t/>
-            </a:r>
+            <a:endParaRPr sz="1200" b="0">
+              <a:solidFill>
+                <a:srgbClr val="333333"/>
+              </a:solidFill>
+            </a:endParaRPr>
           </a:p>
           <a:p>
             <a:r>
@@ -16979,14 +17186,11 @@
             </a:r>
           </a:p>
           <a:p>
-            <a:r>
-              <a:rPr sz="1200">
-                <a:solidFill>
-                  <a:srgbClr val="333333"/>
-                </a:solidFill>
-              </a:rPr>
-              <a:t/>
-            </a:r>
+            <a:endParaRPr sz="1200">
+              <a:solidFill>
+                <a:srgbClr val="333333"/>
+              </a:solidFill>
+            </a:endParaRPr>
           </a:p>
           <a:p>
             <a:r>
@@ -17163,14 +17367,28 @@
             </a:endParaRPr>
           </a:p>
           <a:p>
+            <a:endParaRPr lang="en-US" sz="1200" b="0" dirty="0">
+              <a:solidFill>
+                <a:srgbClr val="333333"/>
+              </a:solidFill>
+            </a:endParaRPr>
+          </a:p>
+          <a:p>
             <a:r>
               <a:rPr sz="1200" b="0">
                 <a:solidFill>
                   <a:srgbClr val="333333"/>
                 </a:solidFill>
               </a:rPr>
-              <a:t/>
-            </a:r>
+              <a:t>Paired N=329 · 19 leagues · minutes ≥300′ both sides</a:t>
+            </a:r>
+          </a:p>
+          <a:p>
+            <a:endParaRPr sz="1200" b="0">
+              <a:solidFill>
+                <a:srgbClr val="333333"/>
+              </a:solidFill>
+            </a:endParaRPr>
           </a:p>
           <a:p>
             <a:r>
@@ -17179,7 +17397,7 @@
                   <a:srgbClr val="333333"/>
                 </a:solidFill>
               </a:rPr>
-              <a:t>Paired N=329 · 19 leagues · minutes ≥300′ both sides</a:t>
+              <a:t>Category gates (not one global cut):</a:t>
             </a:r>
           </a:p>
           <a:p>
@@ -17189,7 +17407,7 @@
                   <a:srgbClr val="333333"/>
                 </a:solidFill>
               </a:rPr>
-              <a:t/>
+              <a:t>Attacking / Passing / Other  ·  r ≥ 0.60</a:t>
             </a:r>
           </a:p>
           <a:p>
@@ -17199,8 +17417,15 @@
                   <a:srgbClr val="333333"/>
                 </a:solidFill>
               </a:rPr>
-              <a:t>Category gates (not one global cut):</a:t>
-            </a:r>
+              <a:t>Defending / Carrying  ·  r ≥ 0.50</a:t>
+            </a:r>
+          </a:p>
+          <a:p>
+            <a:endParaRPr sz="1200" b="0">
+              <a:solidFill>
+                <a:srgbClr val="333333"/>
+              </a:solidFill>
+            </a:endParaRPr>
           </a:p>
           <a:p>
             <a:r>
@@ -17209,7 +17434,7 @@
                   <a:srgbClr val="333333"/>
                 </a:solidFill>
               </a:rPr>
-              <a:t>Attacking / Passing / Other  ·  r ≥ 0.60</a:t>
+              <a:t>43 metrics pass gates → redundancy next</a:t>
             </a:r>
           </a:p>
           <a:p>
@@ -17219,48 +17444,15 @@
                   <a:srgbClr val="333333"/>
                 </a:solidFill>
               </a:rPr>
-              <a:t>Defending / Carrying  ·  r ≥ 0.50</a:t>
-            </a:r>
-          </a:p>
-          <a:p>
-            <a:r>
-              <a:rPr sz="1200" b="0">
-                <a:solidFill>
-                  <a:srgbClr val="333333"/>
-                </a:solidFill>
-              </a:rPr>
-              <a:t/>
-            </a:r>
-          </a:p>
-          <a:p>
-            <a:r>
-              <a:rPr sz="1200" b="0">
-                <a:solidFill>
-                  <a:srgbClr val="333333"/>
-                </a:solidFill>
-              </a:rPr>
-              <a:t>43 metrics pass gates → redundancy next</a:t>
-            </a:r>
-          </a:p>
-          <a:p>
-            <a:r>
-              <a:rPr sz="1200" b="0">
-                <a:solidFill>
-                  <a:srgbClr val="333333"/>
-                </a:solidFill>
-              </a:rPr>
               <a:t>No league-relative scaling — absolute per-90 rates travel better.</a:t>
             </a:r>
           </a:p>
           <a:p>
-            <a:r>
-              <a:rPr sz="1200" b="0">
-                <a:solidFill>
-                  <a:srgbClr val="333333"/>
-                </a:solidFill>
-              </a:rPr>
-              <a:t/>
-            </a:r>
+            <a:endParaRPr sz="1200" b="0">
+              <a:solidFill>
+                <a:srgbClr val="333333"/>
+              </a:solidFill>
+            </a:endParaRPr>
           </a:p>
           <a:p>
             <a:r>
@@ -20534,7 +20726,7 @@
       <p:sp>
         <p:nvSpPr>
           <p:cNvPr id="7" name="TextBox 6">
-            <a:hlinkClick action="ppaction://hlinksldjump" r:id="rId2"/>
+            <a:hlinkClick r:id="rId2" action="ppaction://hlinksldjump"/>
           </p:cNvPr>
           <p:cNvSpPr txBox="1"/>
           <p:nvPr/>
@@ -23630,7 +23822,7 @@
       <p:sp>
         <p:nvSpPr>
           <p:cNvPr id="8" name="TextBox 7">
-            <a:hlinkClick action="ppaction://hlinksldjump" r:id="rId2"/>
+            <a:hlinkClick r:id="rId2" action="ppaction://hlinksldjump"/>
           </p:cNvPr>
           <p:cNvSpPr txBox="1"/>
           <p:nvPr/>
@@ -23723,18 +23915,10 @@
           </a:fontRef>
         </p:style>
         <p:txBody>
-          <a:bodyPr rtlCol="0" anchor="ctr" wrap="square"/>
+          <a:bodyPr wrap="square" rtlCol="0" anchor="ctr"/>
           <a:lstStyle/>
           <a:p>
             <a:pPr algn="ctr"/>
-            <a:r>
-              <a:rPr sz="1200" b="0">
-                <a:solidFill>
-                  <a:srgbClr val="333333"/>
-                </a:solidFill>
-              </a:rPr>
-              <a:t/>
-            </a:r>
             <a:endParaRPr/>
           </a:p>
         </p:txBody>
@@ -24059,7 +24243,7 @@
         <p:spPr>
           <a:xfrm>
             <a:off x="651803" y="5279955"/>
-            <a:ext cx="4937760" cy="640080"/>
+            <a:ext cx="4937760" cy="461665"/>
           </a:xfrm>
           <a:prstGeom prst="rect">
             <a:avLst/>
@@ -24084,7 +24268,25 @@
                 </a:solidFill>
                 <a:latin typeface="Calibri"/>
               </a:rPr>
-              <a:t>SB: |r|≥0.85 — no cuts; passes kept with progressive passes.</a:t>
+              <a:t>SB: |r|≥0.85 — no cuts; passes kept with progressive passes</a:t>
+            </a:r>
+            <a:r>
+              <a:rPr lang="en-US" sz="1200" b="0" dirty="0">
+                <a:solidFill>
+                  <a:srgbClr val="333333"/>
+                </a:solidFill>
+                <a:latin typeface="Calibri"/>
+              </a:rPr>
+              <a:t> due to fundamental difference in definition</a:t>
+            </a:r>
+            <a:r>
+              <a:rPr sz="1200" b="0" dirty="0">
+                <a:solidFill>
+                  <a:srgbClr val="333333"/>
+                </a:solidFill>
+                <a:latin typeface="Calibri"/>
+              </a:rPr>
+              <a:t>.</a:t>
             </a:r>
           </a:p>
         </p:txBody>

</xml_diff>

<commit_message>
Make closing-slide titles match the deck title style.
Move Why p-values and Takeaways into standalone Georgia title boxes with the shared blue.

Co-authored-by: Cursor <cursoragent@cursor.com>
</commit_message>
<xml_diff>
--- a/bundesliga_transfer_traits.pptx
+++ b/bundesliga_transfer_traits.pptx
@@ -12486,8 +12486,8 @@
         </p:nvSpPr>
         <p:spPr>
           <a:xfrm>
-            <a:off x="548640" y="502920"/>
-            <a:ext cx="11064240" cy="3085460"/>
+            <a:off x="548640" y="960120"/>
+            <a:ext cx="11064240" cy="5200000"/>
           </a:xfrm>
           <a:prstGeom prst="rect">
             <a:avLst/>
@@ -12506,13 +12506,12 @@
               </a:spcAft>
             </a:pPr>
             <a:r>
-              <a:rPr sz="2600" b="1" dirty="0">
-                <a:solidFill>
-                  <a:srgbClr val="3D5A80"/>
-                </a:solidFill>
-                <a:latin typeface="Georgia" panose="02040502050405020303" pitchFamily="18" charset="0"/>
-              </a:rPr>
-              <a:t>Why p-values stay modest</a:t>
+              <a:rPr sz="1400" b="0">
+                <a:solidFill>
+                  <a:srgbClr val="333333"/>
+                </a:solidFill>
+              </a:rPr>
+              <a:t>• StatsBomb N=96 with messy open-data priors (World Cup / Euro / Champions League mix rather than clean league seasons — larger sample, less consistent prior context)</a:t>
             </a:r>
             <a:endParaRPr sz="2600" b="1" dirty="0">
               <a:solidFill>
@@ -12522,68 +12521,18 @@
             </a:endParaRPr>
           </a:p>
           <a:p>
-            <a:endParaRPr sz="2600" b="1" dirty="0">
-              <a:solidFill>
-                <a:srgbClr val="3D5A80"/>
-              </a:solidFill>
-              <a:latin typeface="Calibri"/>
-            </a:endParaRPr>
-          </a:p>
-          <a:p>
-            <a:r>
-              <a:rPr sz="1400" b="0" dirty="0">
-                <a:solidFill>
-                  <a:srgbClr val="333333"/>
-                </a:solidFill>
-              </a:rPr>
-              <a:t>• </a:t>
-            </a:r>
-            <a:r>
-              <a:rPr sz="1400" b="0" dirty="0" err="1">
-                <a:solidFill>
-                  <a:srgbClr val="333333"/>
-                </a:solidFill>
-              </a:rPr>
-              <a:t>StatsBomb</a:t>
-            </a:r>
-            <a:r>
-              <a:rPr sz="1400" b="0" dirty="0">
-                <a:solidFill>
-                  <a:srgbClr val="333333"/>
-                </a:solidFill>
-              </a:rPr>
-              <a:t> N=96 with messy open-data priors (World Cup / Euro / Champions League mix rather than clean league seasons — larger sample, less consistent prior context)</a:t>
-            </a:r>
-          </a:p>
-          <a:p>
-            <a:r>
-              <a:rPr sz="1400" b="0" dirty="0">
-                <a:solidFill>
-                  <a:srgbClr val="333333"/>
-                </a:solidFill>
-              </a:rPr>
-              <a:t>• </a:t>
-            </a:r>
-            <a:r>
-              <a:rPr sz="1400" b="0" dirty="0" err="1">
-                <a:solidFill>
-                  <a:srgbClr val="333333"/>
-                </a:solidFill>
-              </a:rPr>
-              <a:t>FBref</a:t>
-            </a:r>
-            <a:r>
-              <a:rPr sz="1400" b="0" dirty="0">
-                <a:solidFill>
-                  <a:srgbClr val="333333"/>
-                </a:solidFill>
-              </a:rPr>
-              <a:t> N=329 helps, but many advanced metrics only have ~90–100 complete pairs</a:t>
-            </a:r>
-          </a:p>
-          <a:p>
-            <a:r>
-              <a:rPr sz="1400" b="0" dirty="0">
+            <a:r>
+              <a:rPr sz="1400" b="0">
+                <a:solidFill>
+                  <a:srgbClr val="333333"/>
+                </a:solidFill>
+              </a:rPr>
+              <a:t>• FBref N=329 helps, but many advanced metrics only have ~90–100 complete pairs</a:t>
+            </a:r>
+          </a:p>
+          <a:p>
+            <a:r>
+              <a:rPr sz="1400" b="0">
                 <a:solidFill>
                   <a:srgbClr val="333333"/>
                 </a:solidFill>
@@ -12592,7 +12541,7 @@
             </a:r>
           </a:p>
           <a:p>
-            <a:endParaRPr sz="1400" b="0" dirty="0">
+            <a:endParaRPr sz="1400" b="0">
               <a:solidFill>
                 <a:srgbClr val="333333"/>
               </a:solidFill>
@@ -12600,7 +12549,7 @@
           </a:p>
           <a:p>
             <a:r>
-              <a:rPr sz="1400" b="0" dirty="0">
+              <a:rPr sz="1400" b="1">
                 <a:solidFill>
                   <a:srgbClr val="333333"/>
                 </a:solidFill>
@@ -12609,7 +12558,7 @@
             </a:r>
           </a:p>
           <a:p>
-            <a:endParaRPr sz="1400" b="0" dirty="0">
+            <a:endParaRPr sz="1400" b="1">
               <a:solidFill>
                 <a:srgbClr val="333333"/>
               </a:solidFill>
@@ -12617,7 +12566,7 @@
           </a:p>
           <a:p>
             <a:r>
-              <a:rPr sz="1400" b="0" dirty="0">
+              <a:rPr sz="1400" b="0">
                 <a:solidFill>
                   <a:srgbClr val="333333"/>
                 </a:solidFill>
@@ -12627,7 +12576,7 @@
           </a:p>
           <a:p>
             <a:r>
-              <a:rPr sz="1400" b="0" dirty="0">
+              <a:rPr sz="1400" b="0">
                 <a:solidFill>
                   <a:srgbClr val="333333"/>
                 </a:solidFill>
@@ -12637,28 +12586,46 @@
           </a:p>
           <a:p>
             <a:r>
-              <a:rPr sz="1400" b="0" dirty="0">
-                <a:solidFill>
-                  <a:srgbClr val="333333"/>
-                </a:solidFill>
-              </a:rPr>
-              <a:t>• </a:t>
-            </a:r>
-            <a:r>
-              <a:rPr sz="1400" b="0" dirty="0" err="1">
-                <a:solidFill>
-                  <a:srgbClr val="333333"/>
-                </a:solidFill>
-              </a:rPr>
-              <a:t>StatsBomb</a:t>
-            </a:r>
-            <a:r>
-              <a:rPr sz="1400" b="0" dirty="0">
-                <a:solidFill>
-                  <a:srgbClr val="333333"/>
-                </a:solidFill>
-              </a:rPr>
-              <a:t> kept as event deep dive (r≥0.40 · 7 traits), not league ranking</a:t>
+              <a:rPr sz="1400" b="0">
+                <a:solidFill>
+                  <a:srgbClr val="333333"/>
+                </a:solidFill>
+              </a:rPr>
+              <a:t>• StatsBomb kept as event deep dive (r≥0.40 · 7 traits), not league ranking</a:t>
+            </a:r>
+          </a:p>
+        </p:txBody>
+      </p:sp>
+      <p:sp>
+        <p:nvSpPr>
+          <p:cNvPr id="4" name="TextBox 3"/>
+          <p:cNvSpPr txBox="1"/>
+          <p:nvPr/>
+        </p:nvSpPr>
+        <p:spPr>
+          <a:xfrm>
+            <a:off x="548640" y="411480"/>
+            <a:ext cx="10972800" cy="548640"/>
+          </a:xfrm>
+          <a:prstGeom prst="rect">
+            <a:avLst/>
+          </a:prstGeom>
+          <a:noFill/>
+        </p:spPr>
+        <p:txBody>
+          <a:bodyPr wrap="none">
+            <a:spAutoFit/>
+          </a:bodyPr>
+          <a:lstStyle/>
+          <a:p>
+            <a:r>
+              <a:rPr sz="2600" b="1">
+                <a:solidFill>
+                  <a:srgbClr val="3D5A80"/>
+                </a:solidFill>
+                <a:latin typeface="Georgia"/>
+              </a:rPr>
+              <a:t>WHY P-VALUES STAY MODEST</a:t>
             </a:r>
           </a:p>
         </p:txBody>
@@ -13816,6 +13783,7 @@
                 <a:solidFill>
                   <a:srgbClr val="3D5A80"/>
                 </a:solidFill>
+                <a:latin typeface="Georgia"/>
               </a:rPr>
               <a:t>TAKEAWAYS</a:t>
             </a:r>

</xml_diff>

<commit_message>
Address professor deck comments for clarity and completeness.
Clarify success as Year 1 minutes, spell out regressions and selection bias, report unstable metrics, and cut repeated scaling jargon.

Co-authored-by: Cursor <cursoragent@cursor.com>
</commit_message>
<xml_diff>
--- a/bundesliga_transfer_traits.pptx
+++ b/bundesliga_transfer_traits.pptx
@@ -3863,13 +3863,52 @@
           <a:lstStyle/>
           <a:p>
             <a:r>
-              <a:rPr sz="2600" b="1">
-                <a:solidFill>
-                  <a:srgbClr val="1C1C1C"/>
-                </a:solidFill>
-                <a:latin typeface="Georgia"/>
+              <a:rPr sz="1300" b="0">
+                <a:solidFill>
+                  <a:srgbClr val="333333"/>
+                </a:solidFill>
               </a:rPr>
               <a:t>What “stable-trait score” means</a:t>
+            </a:r>
+          </a:p>
+          <a:p>
+            <a:r>
+              <a:rPr sz="1300" b="0">
+                <a:solidFill>
+                  <a:srgbClr val="333333"/>
+                </a:solidFill>
+              </a:rPr>
+              <a:t/>
+            </a:r>
+          </a:p>
+          <a:p>
+            <a:r>
+              <a:rPr sz="1300" b="0">
+                <a:solidFill>
+                  <a:srgbClr val="333333"/>
+                </a:solidFill>
+              </a:rPr>
+              <a:t>One number that answers: in Year 1 in Bundesliga, how strong is this player on the portable (shortlisted) traits — vs peers at their position?</a:t>
+            </a:r>
+          </a:p>
+          <a:p>
+            <a:r>
+              <a:rPr sz="1300" b="0">
+                <a:solidFill>
+                  <a:srgbClr val="333333"/>
+                </a:solidFill>
+              </a:rPr>
+              <a:t/>
+            </a:r>
+          </a:p>
+          <a:p>
+            <a:r>
+              <a:rPr sz="1300" b="0">
+                <a:solidFill>
+                  <a:srgbClr val="333333"/>
+                </a:solidFill>
+              </a:rPr>
+              <a:t>Phase 2 note: this is a secondary success outcome (alongside Year 1 minutes and minutes percentile) — a profile-fit score, not the primary playing-time marker.</a:t>
             </a:r>
           </a:p>
         </p:txBody>
@@ -5544,15 +5583,82 @@
               </a:spcAft>
             </a:pPr>
             <a:r>
-              <a:rPr sz="1200" b="0" dirty="0">
-                <a:solidFill>
-                  <a:srgbClr val="333333"/>
-                </a:solidFill>
-                <a:latin typeface="Calibri"/>
-              </a:rPr>
-              <a:t>Phase 2: after shortlisting, test what lines up with BL success.
-Outcomes: Year 1 in Bundesliga minutes · Year 1 in Bundesliga min percentile · stable-trait score.
-Spearman ρ ranks players so we test “higher prior trait → more minutes” without a linear minutes scale; then feeder means + exploratory OLS.</a:t>
+              <a:rPr sz="1200" b="0">
+                <a:solidFill>
+                  <a:srgbClr val="333333"/>
+                </a:solidFill>
+              </a:rPr>
+              <a:t>Phase 2: after shortlisting, test what lines up with Bundesliga success.</a:t>
+            </a:r>
+          </a:p>
+          <a:p>
+            <a:r>
+              <a:rPr sz="1200" b="0">
+                <a:solidFill>
+                  <a:srgbClr val="333333"/>
+                </a:solidFill>
+              </a:rPr>
+              <a:t>Primary success = Year 1 in Bundesliga minutes (more minutes = more playing time).</a:t>
+            </a:r>
+          </a:p>
+          <a:p>
+            <a:r>
+              <a:rPr sz="1200" b="0">
+                <a:solidFill>
+                  <a:srgbClr val="333333"/>
+                </a:solidFill>
+              </a:rPr>
+              <a:t>Also reported: Year 1 minutes percentile · stable-trait score (secondary).</a:t>
+            </a:r>
+          </a:p>
+          <a:p>
+            <a:r>
+              <a:rPr sz="1200" b="0">
+                <a:solidFill>
+                  <a:srgbClr val="333333"/>
+                </a:solidFill>
+              </a:rPr>
+              <a:t/>
+            </a:r>
+          </a:p>
+          <a:p>
+            <a:r>
+              <a:rPr sz="1200" b="0">
+                <a:solidFill>
+                  <a:srgbClr val="333333"/>
+                </a:solidFill>
+              </a:rPr>
+              <a:t>Spearman ρ: rank players on a prior trait, rank them on Year 1 minutes, correlate the ranks. It does not assume minutes rise linearly — only that higher prior trait ranks tend to coincide with more minutes.</a:t>
+            </a:r>
+          </a:p>
+          <a:p>
+            <a:r>
+              <a:rPr sz="1200" b="0">
+                <a:solidFill>
+                  <a:srgbClr val="333333"/>
+                </a:solidFill>
+              </a:rPr>
+              <a:t>Minutes always depend on competition for the XI, injuries, and manager choice — we treat this as an associative open-data proxy, not a causal “deserved minutes” metric.</a:t>
+            </a:r>
+          </a:p>
+          <a:p>
+            <a:r>
+              <a:rPr sz="1200" b="0">
+                <a:solidFill>
+                  <a:srgbClr val="333333"/>
+                </a:solidFill>
+              </a:rPr>
+              <a:t/>
+            </a:r>
+          </a:p>
+          <a:p>
+            <a:r>
+              <a:rPr sz="1200" b="0">
+                <a:solidFill>
+                  <a:srgbClr val="333333"/>
+                </a:solidFill>
+              </a:rPr>
+              <a:t>Then: feeder means + exploratory OLS.</a:t>
             </a:r>
           </a:p>
         </p:txBody>
@@ -6389,77 +6495,52 @@
               </a:spcAft>
             </a:pPr>
             <a:r>
-              <a:rPr sz="1400">
-                <a:solidFill>
-                  <a:srgbClr val="1C1C1C"/>
-                </a:solidFill>
-                <a:latin typeface="Arial"/>
-              </a:rPr>
-              <a:t>Primary success marker: Bundesliga minutes played in the player’s first BL season (Year 1 in Bundesliga minutes)</a:t>
-            </a:r>
-          </a:p>
-          <a:p>
-            <a:pPr>
-              <a:spcAft>
-                <a:spcPts val="600"/>
-              </a:spcAft>
-            </a:pPr>
-            <a:r>
-              <a:rPr sz="1400">
-                <a:solidFill>
-                  <a:srgbClr val="1C1C1C"/>
-                </a:solidFill>
-                <a:latin typeface="Arial"/>
-              </a:rPr>
-              <a:t>Interpretation: playing-time success — did the club trust and use the inbound player?</a:t>
-            </a:r>
-          </a:p>
-          <a:p>
-            <a:pPr>
-              <a:spcAft>
-                <a:spcPts val="600"/>
-              </a:spcAft>
-            </a:pPr>
-            <a:r>
-              <a:rPr sz="1400">
-                <a:solidFill>
-                  <a:srgbClr val="1C1C1C"/>
-                </a:solidFill>
-                <a:latin typeface="Arial"/>
-              </a:rPr>
-              <a:t>Also reported: Year 1 in Bundesliga minutes percentile (rank in cohort) and stable-trait score (profile fit)</a:t>
-            </a:r>
-          </a:p>
-          <a:p>
-            <a:pPr>
-              <a:spcAft>
-                <a:spcPts val="600"/>
-              </a:spcAft>
-            </a:pPr>
-            <a:r>
-              <a:rPr sz="1400">
-                <a:solidFill>
-                  <a:srgbClr val="1C1C1C"/>
-                </a:solidFill>
-                <a:latin typeface="Arial"/>
-              </a:rPr>
-              <a:t>Trait &amp; league tests ask: which prior signals line up with more Year 1 in Bundesliga minutes?</a:t>
-            </a:r>
-          </a:p>
-          <a:p>
-            <a:pPr>
-              <a:spcAft>
-                <a:spcPts val="600"/>
-              </a:spcAft>
-            </a:pPr>
-            <a:r>
-              <a:rPr sz="1400">
-                <a:solidFill>
-                  <a:srgbClr val="1C1C1C"/>
-                </a:solidFill>
-                <a:latin typeface="Arial"/>
-              </a:rPr>
-              <a:t>Regression Δ Year 1 in Bundesliga min = estimated extra first-season minutes vs a reference league, holding controls</a:t>
+              <a:rPr sz="1200" b="0">
+                <a:solidFill>
+                  <a:srgbClr val="333333"/>
+                </a:solidFill>
+              </a:rPr>
+              <a:t>Primary success marker: minutes played in the player’s first 1. Bundesliga season (“Year 1 in Bundesliga minutes”).</a:t>
+            </a:r>
+          </a:p>
+          <a:p>
+            <a:r>
+              <a:rPr sz="1200" b="0">
+                <a:solidFill>
+                  <a:srgbClr val="333333"/>
+                </a:solidFill>
+              </a:rPr>
+              <a:t>Plain English: did the club trust and use the inbound player (playing-time success)?</a:t>
+            </a:r>
+          </a:p>
+          <a:p>
+            <a:r>
+              <a:rPr sz="1200" b="0">
+                <a:solidFill>
+                  <a:srgbClr val="333333"/>
+                </a:solidFill>
+              </a:rPr>
+              <a:t>Also reported (secondary): Year 1 minutes percentile (rank in cohort) and stable-trait score (how strong the Year 1 profile looks on portable traits).</a:t>
+            </a:r>
+          </a:p>
+          <a:p>
+            <a:r>
+              <a:rPr sz="1200" b="0">
+                <a:solidFill>
+                  <a:srgbClr val="333333"/>
+                </a:solidFill>
+              </a:rPr>
+              <a:t>Trait &amp; league tests ask: which prior signals line up with more Year 1 minutes?</a:t>
+            </a:r>
+          </a:p>
+          <a:p>
+            <a:r>
+              <a:rPr sz="1200" b="0">
+                <a:solidFill>
+                  <a:srgbClr val="333333"/>
+                </a:solidFill>
+              </a:rPr>
+              <a:t>Regression Δ Year 1 minutes = estimated extra first-season minutes vs a reference league (Serie A), holding controls.</a:t>
             </a:r>
           </a:p>
         </p:txBody>
@@ -11040,9 +11121,9 @@
               </a:spcAft>
             </a:pPr>
             <a:r>
-              <a:rPr sz="1200" b="0">
-                <a:solidFill>
-                  <a:srgbClr val="555555"/>
+              <a:rPr sz="1100" b="0">
+                <a:solidFill>
+                  <a:srgbClr val="333333"/>
                 </a:solidFill>
               </a:rPr>
               <a:t>FBref N=329 (n≥8 players per league shown). StatsBomb N=96 — international priors are directional only.</a:t>
@@ -11050,9 +11131,19 @@
           </a:p>
           <a:p>
             <a:r>
-              <a:rPr sz="1200" b="0">
-                <a:solidFill>
-                  <a:srgbClr val="555555"/>
+              <a:rPr sz="1100" b="0">
+                <a:solidFill>
+                  <a:srgbClr val="333333"/>
+                </a:solidFill>
+              </a:rPr>
+              <a:t>Selection bias: these are players clubs already chose to sign from each feeder — not a random draw from that league. Means describe arrived cohorts, not “transfer from X causes minutes.”</a:t>
+            </a:r>
+          </a:p>
+          <a:p>
+            <a:r>
+              <a:rPr sz="1100" b="0">
+                <a:solidFill>
+                  <a:srgbClr val="333333"/>
                 </a:solidFill>
               </a:rPr>
               <a:t>Tables also in the explorer Success tab · README.md</a:t>
@@ -11244,7 +11335,7 @@
                   <a:srgbClr val="333333"/>
                 </a:solidFill>
               </a:rPr>
-              <a:t>Predict Year 1 in Bundesliga minutes from prior league (Premier League / La Liga / Ligue 1 vs Serie A baseline), prior minutes, and position.</a:t>
+              <a:t>Year 1 minutes = prior league (PL / La Liga / Ligue 1 vs Serie A baseline)</a:t>
             </a:r>
           </a:p>
           <a:p>
@@ -11254,23 +11345,36 @@
                   <a:srgbClr val="333333"/>
                 </a:solidFill>
               </a:rPr>
+              <a:t>                 + prior minutes + position</a:t>
+            </a:r>
+          </a:p>
+          <a:p>
+            <a:r>
+              <a:rPr sz="1200" b="0">
+                <a:solidFill>
+                  <a:srgbClr val="333333"/>
+                </a:solidFill>
+              </a:rPr>
               <a:t>Question: after that, does league still matter?</a:t>
             </a:r>
           </a:p>
           <a:p>
-            <a:endParaRPr sz="1200" b="0">
-              <a:solidFill>
-                <a:srgbClr val="333333"/>
-              </a:solidFill>
-            </a:endParaRPr>
-          </a:p>
-          <a:p>
             <a:r>
               <a:rPr sz="1200" b="0">
                 <a:solidFill>
                   <a:srgbClr val="333333"/>
                 </a:solidFill>
               </a:rPr>
+              <a:t/>
+            </a:r>
+          </a:p>
+          <a:p>
+            <a:r>
+              <a:rPr sz="1200" b="0">
+                <a:solidFill>
+                  <a:srgbClr val="333333"/>
+                </a:solidFill>
+              </a:rPr>
               <a:t>Model 2 — league + traits</a:t>
             </a:r>
           </a:p>
@@ -11281,7 +11385,7 @@
                   <a:srgbClr val="333333"/>
                 </a:solidFill>
               </a:rPr>
-              <a:t>Same as Model 1, plus prior trait percentiles (e.g. Final Third, box touches).</a:t>
+              <a:t>Year 1 minutes = Model 1 + prior trait percentiles</a:t>
             </a:r>
           </a:p>
           <a:p>
@@ -11291,23 +11395,36 @@
                   <a:srgbClr val="333333"/>
                 </a:solidFill>
               </a:rPr>
+              <a:t>                 (e.g. Final Third, Def Pen Touches, …)</a:t>
+            </a:r>
+          </a:p>
+          <a:p>
+            <a:r>
+              <a:rPr sz="1200" b="0">
+                <a:solidFill>
+                  <a:srgbClr val="333333"/>
+                </a:solidFill>
+              </a:rPr>
               <a:t>Question: once you know the prior profile, do league gaps shrink?</a:t>
             </a:r>
           </a:p>
           <a:p>
-            <a:endParaRPr sz="1200" b="0">
-              <a:solidFill>
-                <a:srgbClr val="333333"/>
-              </a:solidFill>
-            </a:endParaRPr>
-          </a:p>
-          <a:p>
             <a:r>
               <a:rPr sz="1200" b="0">
                 <a:solidFill>
                   <a:srgbClr val="333333"/>
                 </a:solidFill>
               </a:rPr>
+              <a:t/>
+            </a:r>
+          </a:p>
+          <a:p>
+            <a:r>
+              <a:rPr sz="1200" b="0">
+                <a:solidFill>
+                  <a:srgbClr val="333333"/>
+                </a:solidFill>
+              </a:rPr>
               <a:t>Model 3 — holdout check</a:t>
             </a:r>
           </a:p>
@@ -11318,7 +11435,7 @@
                   <a:srgbClr val="333333"/>
                 </a:solidFill>
               </a:rPr>
-              <a:t>Fit on 80% of players; see if predictions match the other 20%.</a:t>
+              <a:t>Fit Model 2 on 80% of players; correlate predicted vs actual Year 1 minutes on the other 20%.</a:t>
             </a:r>
           </a:p>
           <a:p>
@@ -11332,20 +11449,33 @@
             </a:r>
           </a:p>
           <a:p>
-            <a:endParaRPr sz="1200" b="0">
-              <a:solidFill>
-                <a:srgbClr val="333333"/>
-              </a:solidFill>
-            </a:endParaRPr>
-          </a:p>
-          <a:p>
             <a:r>
               <a:rPr sz="1200" b="0">
                 <a:solidFill>
                   <a:srgbClr val="333333"/>
                 </a:solidFill>
               </a:rPr>
-              <a:t>Serie A is the baseline league (lowest average Year 1 in Bundesliga minutes among Big-5 feeders), so other leagues are estimated as “extra minutes vs Serie A.”</a:t>
+              <a:t/>
+            </a:r>
+          </a:p>
+          <a:p>
+            <a:r>
+              <a:rPr sz="1200" b="0">
+                <a:solidFill>
+                  <a:srgbClr val="333333"/>
+                </a:solidFill>
+              </a:rPr>
+              <a:t>Serie A = baseline (lowest average Year 1 minutes among Big-5 feeders in this subset).</a:t>
+            </a:r>
+          </a:p>
+          <a:p>
+            <a:r>
+              <a:rPr sz="1200" b="0">
+                <a:solidFill>
+                  <a:srgbClr val="333333"/>
+                </a:solidFill>
+              </a:rPr>
+              <a:t>Big-5 FBref subset N=117. Associative / exploratory — not a validated forecast.</a:t>
             </a:r>
           </a:p>
         </p:txBody>
@@ -12310,7 +12440,7 @@
                   <a:srgbClr val="333333"/>
                 </a:solidFill>
               </a:rPr>
-              <a:t>Ligue 1 about +163 minutes vs Serie A (p≈0.38) — not statistically significant at N=117.</a:t>
+              <a:t>Does this make sense?</a:t>
             </a:r>
           </a:p>
           <a:p>
@@ -12320,6 +12450,26 @@
                   <a:srgbClr val="333333"/>
                 </a:solidFill>
               </a:rPr>
+              <a:t>Yes — Ligue 1’s +163 minutes vs Serie A looks large on the table but p≈0.38 (N=117): not statistically distinguishable from noise. Modest, non-significant league gaps are exactly what you’d expect if clubs already select carefully and league labels are weak once minutes/position are controlled.</a:t>
+            </a:r>
+          </a:p>
+          <a:p>
+            <a:r>
+              <a:rPr sz="1200" b="0">
+                <a:solidFill>
+                  <a:srgbClr val="333333"/>
+                </a:solidFill>
+              </a:rPr>
+              <a:t/>
+            </a:r>
+          </a:p>
+          <a:p>
+            <a:r>
+              <a:rPr sz="1200" b="0">
+                <a:solidFill>
+                  <a:srgbClr val="333333"/>
+                </a:solidFill>
+              </a:rPr>
               <a:t>Adding traits raises R² (0.09 → 0.22): prior profile matters more than league label.</a:t>
             </a:r>
           </a:p>
@@ -12340,15 +12490,8 @@
                   <a:srgbClr val="333333"/>
                 </a:solidFill>
               </a:rPr>
-              <a:t>Takeaway: scout portable traits + minutes; league is a weak residual signal.</a:t>
-            </a:r>
-          </a:p>
-          <a:p>
-            <a:endParaRPr sz="1200" b="0">
-              <a:solidFill>
-                <a:srgbClr val="333333"/>
-              </a:solidFill>
-            </a:endParaRPr>
+              <a:t>Takeaway: scout portable traits + Year 1 minutes; league is a weak residual signal.</a:t>
+            </a:r>
           </a:p>
           <a:p>
             <a:r>
@@ -12357,7 +12500,17 @@
                   <a:srgbClr val="333333"/>
                 </a:solidFill>
               </a:rPr>
-              <a:t>Serie A = baseline (lowest mean Year 1 in Bundesliga minutes among Big-5 feeders).</a:t>
+              <a:t/>
+            </a:r>
+          </a:p>
+          <a:p>
+            <a:r>
+              <a:rPr sz="1200" b="0">
+                <a:solidFill>
+                  <a:srgbClr val="333333"/>
+                </a:solidFill>
+              </a:rPr>
+              <a:t>Serie A = baseline (lowest mean Year 1 minutes among Big-5 feeders).</a:t>
             </a:r>
           </a:p>
         </p:txBody>
@@ -13090,7 +13243,7 @@
               </a:spcAft>
             </a:pPr>
             <a:r>
-              <a:rPr sz="1200" b="0" dirty="0">
+              <a:rPr sz="1200" b="0">
                 <a:solidFill>
                   <a:srgbClr val="333333"/>
                 </a:solidFill>
@@ -13100,12 +13253,12 @@
           </a:p>
           <a:p>
             <a:r>
-              <a:rPr sz="1200" b="0" dirty="0">
-                <a:solidFill>
-                  <a:srgbClr val="333333"/>
-                </a:solidFill>
-              </a:rPr>
-              <a:t>Correlate prior → Year 1 in Bundesliga per-90 rates. Keep metrics that travel.</a:t>
+              <a:rPr sz="1200" b="0">
+                <a:solidFill>
+                  <a:srgbClr val="333333"/>
+                </a:solidFill>
+              </a:rPr>
+              <a:t>Correlate prior → Year 1 in Bundesliga per-90 rates. Keep metrics that travel (clear the floor). Metrics that miss the floor are non-portable — reported as failed/unstable in the inspector, not on the scout shortlist.</a:t>
             </a:r>
           </a:p>
         </p:txBody>
@@ -15869,7 +16022,7 @@
                   <a:srgbClr val="333333"/>
                 </a:solidFill>
               </a:rPr>
-              <a:t>Spearman ρ = success (do higher prior trait ranks line up with more Year 1 in Bundesliga minutes — rank-based, robust when minutes are skewed).</a:t>
+              <a:t>Spearman ρ = success — yes: success means more Year 1 in Bundesliga minutes (playing time), not goals or market value. We ask whether higher prior trait ranks line up with more first-season minutes.</a:t>
             </a:r>
           </a:p>
           <a:p>
@@ -15879,7 +16032,7 @@
                   <a:srgbClr val="333333"/>
                 </a:solidFill>
               </a:rPr>
-              <a:t>Then redundancy pruning and peer percentiles.</a:t>
+              <a:t>Redundancy = drop near-duplicate metrics. Percentiles = rank vs Bundesliga position peers.</a:t>
             </a:r>
           </a:p>
         </p:txBody>
@@ -16807,7 +16960,7 @@
               </a:spcAft>
             </a:pPr>
             <a:r>
-              <a:rPr sz="1200">
+              <a:rPr sz="1200" b="0">
                 <a:solidFill>
                   <a:srgbClr val="333333"/>
                 </a:solidFill>
@@ -16816,15 +16969,18 @@
             </a:r>
           </a:p>
           <a:p>
-            <a:endParaRPr sz="1200">
-              <a:solidFill>
-                <a:srgbClr val="333333"/>
-              </a:solidFill>
-            </a:endParaRPr>
-          </a:p>
-          <a:p>
-            <a:r>
-              <a:rPr sz="1200">
+            <a:r>
+              <a:rPr sz="1200" b="0">
+                <a:solidFill>
+                  <a:srgbClr val="333333"/>
+                </a:solidFill>
+              </a:rPr>
+              <a:t/>
+            </a:r>
+          </a:p>
+          <a:p>
+            <a:r>
+              <a:rPr sz="1200" b="0">
                 <a:solidFill>
                   <a:srgbClr val="333333"/>
                 </a:solidFill>
@@ -16834,7 +16990,7 @@
           </a:p>
           <a:p>
             <a:r>
-              <a:rPr sz="1200">
+              <a:rPr sz="1200" b="0">
                 <a:solidFill>
                   <a:srgbClr val="333333"/>
                 </a:solidFill>
@@ -16844,7 +17000,7 @@
           </a:p>
           <a:p>
             <a:r>
-              <a:rPr sz="1200">
+              <a:rPr sz="1200" b="0">
                 <a:solidFill>
                   <a:srgbClr val="333333"/>
                 </a:solidFill>
@@ -16853,32 +17009,38 @@
             </a:r>
           </a:p>
           <a:p>
-            <a:endParaRPr sz="1200">
-              <a:solidFill>
-                <a:srgbClr val="333333"/>
-              </a:solidFill>
-            </a:endParaRPr>
-          </a:p>
-          <a:p>
-            <a:r>
-              <a:rPr sz="1200">
-                <a:solidFill>
-                  <a:srgbClr val="333333"/>
-                </a:solidFill>
-              </a:rPr>
-              <a:t>League-relative scaling tested and dropped: “how high vs peers in the same prior league” (z-score / percentile) did not improve prior→Year 1 in Bundesliga stability, so we keep absolute per-90 rates.</a:t>
-            </a:r>
-          </a:p>
-          <a:p>
-            <a:endParaRPr sz="1200">
-              <a:solidFill>
-                <a:srgbClr val="333333"/>
-              </a:solidFill>
-            </a:endParaRPr>
-          </a:p>
-          <a:p>
-            <a:r>
-              <a:rPr sz="1200">
+            <a:r>
+              <a:rPr sz="1200" b="0">
+                <a:solidFill>
+                  <a:srgbClr val="333333"/>
+                </a:solidFill>
+              </a:rPr>
+              <a:t/>
+            </a:r>
+          </a:p>
+          <a:p>
+            <a:r>
+              <a:rPr sz="1200" b="0">
+                <a:solidFill>
+                  <a:srgbClr val="333333"/>
+                </a:solidFill>
+              </a:rPr>
+              <a:t>League-relative scaling (mentioned once): we tried “how high vs peers in the same prior league” (z-score / percentile). It did not improve prior→Year 1 stability, so we keep absolute per-90 rates everywhere.</a:t>
+            </a:r>
+          </a:p>
+          <a:p>
+            <a:r>
+              <a:rPr sz="1200" b="0">
+                <a:solidFill>
+                  <a:srgbClr val="333333"/>
+                </a:solidFill>
+              </a:rPr>
+              <a:t/>
+            </a:r>
+          </a:p>
+          <a:p>
+            <a:r>
+              <a:rPr sz="1200" b="0">
                 <a:solidFill>
                   <a:srgbClr val="333333"/>
                 </a:solidFill>
@@ -17038,20 +17200,13 @@
             </a:r>
           </a:p>
           <a:p>
-            <a:endParaRPr sz="1200" b="0">
-              <a:solidFill>
-                <a:srgbClr val="333333"/>
-              </a:solidFill>
-            </a:endParaRPr>
-          </a:p>
-          <a:p>
             <a:r>
               <a:rPr sz="1200" b="0">
                 <a:solidFill>
                   <a:srgbClr val="333333"/>
                 </a:solidFill>
               </a:rPr>
-              <a:t>All male open competitions as priors</a:t>
+              <a:t/>
             </a:r>
           </a:p>
           <a:p>
@@ -17061,6 +17216,16 @@
                   <a:srgbClr val="333333"/>
                 </a:solidFill>
               </a:rPr>
+              <a:t>Priors = any StatsBomb open men’s competition the player played before Bundesliga (club leagues and internationals — World Cup, Euro, Champions League, etc.).</a:t>
+            </a:r>
+          </a:p>
+          <a:p>
+            <a:r>
+              <a:rPr sz="1200" b="0">
+                <a:solidFill>
+                  <a:srgbClr val="333333"/>
+                </a:solidFill>
+              </a:rPr>
               <a:t>1. Bundesliga open dumps: 2015/16 + 2023/24 only</a:t>
             </a:r>
           </a:p>
@@ -17082,6 +17247,26 @@
                 </a:solidFill>
               </a:rPr>
               <a:t>Pearson r≥0.40 → 7 · Pearson |r|≥0.85 → keep all 7</a:t>
+            </a:r>
+          </a:p>
+          <a:p>
+            <a:r>
+              <a:rPr sz="1200" b="0">
+                <a:solidFill>
+                  <a:srgbClr val="333333"/>
+                </a:solidFill>
+              </a:rPr>
+              <a:t/>
+            </a:r>
+          </a:p>
+          <a:p>
+            <a:r>
+              <a:rPr sz="1200" b="0">
+                <a:solidFill>
+                  <a:srgbClr val="333333"/>
+                </a:solidFill>
+              </a:rPr>
+              <a:t>Open-data thinness · two BL seasons · event check</a:t>
             </a:r>
           </a:p>
         </p:txBody>
@@ -17119,7 +17304,7 @@
               </a:spcAft>
             </a:pPr>
             <a:r>
-              <a:rPr sz="1200">
+              <a:rPr sz="1200" b="0">
                 <a:solidFill>
                   <a:srgbClr val="333333"/>
                 </a:solidFill>
@@ -17135,7 +17320,7 @@
           </a:p>
           <a:p>
             <a:r>
-              <a:rPr sz="1200">
+              <a:rPr sz="1200" b="0">
                 <a:solidFill>
                   <a:srgbClr val="333333"/>
                 </a:solidFill>
@@ -17145,29 +17330,22 @@
           </a:p>
           <a:p>
             <a:r>
-              <a:rPr sz="1200">
-                <a:solidFill>
-                  <a:srgbClr val="333333"/>
-                </a:solidFill>
-              </a:rPr>
-              <a:t>Event check on trait families — not league ranking.</a:t>
-            </a:r>
-          </a:p>
-          <a:p>
-            <a:endParaRPr sz="1200">
-              <a:solidFill>
-                <a:srgbClr val="333333"/>
-              </a:solidFill>
-            </a:endParaRPr>
-          </a:p>
-          <a:p>
-            <a:r>
-              <a:rPr sz="1200">
-                <a:solidFill>
-                  <a:srgbClr val="333333"/>
-                </a:solidFill>
-              </a:rPr>
-              <a:t>No relative scaling: same peer-rank idea failed on FBref. StatsBomb priors mix FIFA World Cup, UEFA European Championship (Euro), UEFA Champions League, and other pro leagues, so within-league peer ranks are even less meaningful here.</a:t>
+              <a:rPr sz="1200" b="0">
+                <a:solidFill>
+                  <a:srgbClr val="333333"/>
+                </a:solidFill>
+              </a:rPr>
+              <a:t>Event check on trait families — not a second league-ranking study.</a:t>
+            </a:r>
+          </a:p>
+          <a:p>
+            <a:r>
+              <a:rPr sz="1200" b="0">
+                <a:solidFill>
+                  <a:srgbClr val="333333"/>
+                </a:solidFill>
+              </a:rPr>
+              <a:t>Priors mix club + international competitions, so feeder tables here are directional only.</a:t>
             </a:r>
           </a:p>
         </p:txBody>
@@ -17326,7 +17504,7 @@
                   <a:srgbClr val="333333"/>
                 </a:solidFill>
               </a:rPr>
-              <a:t>Prior league → first Bundesliga Year 1 in Bundesliga (end-year ≥2021)</a:t>
+              <a:t>Prior league → first Bundesliga season (end-years 2021–2025)</a:t>
             </a:r>
             <a:endParaRPr lang="en-US" sz="1200" b="0" dirty="0">
               <a:solidFill>
@@ -17335,36 +17513,42 @@
             </a:endParaRPr>
           </a:p>
           <a:p>
-            <a:endParaRPr lang="en-US" sz="1200" b="0" dirty="0">
-              <a:solidFill>
-                <a:srgbClr val="333333"/>
-              </a:solidFill>
-            </a:endParaRPr>
-          </a:p>
-          <a:p>
             <a:r>
               <a:rPr sz="1200" b="0">
                 <a:solidFill>
                   <a:srgbClr val="333333"/>
                 </a:solidFill>
               </a:rPr>
+              <a:t/>
+            </a:r>
+          </a:p>
+          <a:p>
+            <a:r>
+              <a:rPr sz="1200" b="0">
+                <a:solidFill>
+                  <a:srgbClr val="333333"/>
+                </a:solidFill>
+              </a:rPr>
               <a:t>Paired N=329 · 19 leagues · minutes ≥300′ both sides</a:t>
             </a:r>
           </a:p>
           <a:p>
-            <a:endParaRPr sz="1200" b="0">
-              <a:solidFill>
-                <a:srgbClr val="333333"/>
-              </a:solidFill>
-            </a:endParaRPr>
-          </a:p>
-          <a:p>
             <a:r>
               <a:rPr sz="1200" b="0">
                 <a:solidFill>
                   <a:srgbClr val="333333"/>
                 </a:solidFill>
               </a:rPr>
+              <a:t/>
+            </a:r>
+          </a:p>
+          <a:p>
+            <a:r>
+              <a:rPr sz="1200" b="0">
+                <a:solidFill>
+                  <a:srgbClr val="333333"/>
+                </a:solidFill>
+              </a:rPr>
               <a:t>Category gates (not one global cut):</a:t>
             </a:r>
           </a:p>
@@ -17375,7 +17559,7 @@
                   <a:srgbClr val="333333"/>
                 </a:solidFill>
               </a:rPr>
-              <a:t>Attacking / Passing / Other  ·  r ≥ 0.60</a:t>
+              <a:t>Attacking / Passing / Other · Pearson r ≥ 0.60</a:t>
             </a:r>
           </a:p>
           <a:p>
@@ -17385,15 +17569,8 @@
                   <a:srgbClr val="333333"/>
                 </a:solidFill>
               </a:rPr>
-              <a:t>Defending / Carrying  ·  r ≥ 0.50</a:t>
-            </a:r>
-          </a:p>
-          <a:p>
-            <a:endParaRPr sz="1200" b="0">
-              <a:solidFill>
-                <a:srgbClr val="333333"/>
-              </a:solidFill>
-            </a:endParaRPr>
+              <a:t>Defending / Carrying · Pearson r ≥ 0.50</a:t>
+            </a:r>
           </a:p>
           <a:p>
             <a:r>
@@ -17402,7 +17579,7 @@
                   <a:srgbClr val="333333"/>
                 </a:solidFill>
               </a:rPr>
-              <a:t>43 metrics pass gates → redundancy next</a:t>
+              <a:t>43 of 105 metrics pass → redundancy next</a:t>
             </a:r>
           </a:p>
           <a:p>
@@ -17412,15 +17589,8 @@
                   <a:srgbClr val="333333"/>
                 </a:solidFill>
               </a:rPr>
-              <a:t>No league-relative scaling — absolute per-90 rates travel better.</a:t>
-            </a:r>
-          </a:p>
-          <a:p>
-            <a:endParaRPr sz="1200" b="0">
-              <a:solidFill>
-                <a:srgbClr val="333333"/>
-              </a:solidFill>
-            </a:endParaRPr>
+              <a:t/>
+            </a:r>
           </a:p>
           <a:p>
             <a:r>
@@ -17430,6 +17600,16 @@
                 </a:solidFill>
               </a:rPr>
               <a:t>Metric codes: see Glossary slide.</a:t>
+            </a:r>
+          </a:p>
+          <a:p>
+            <a:r>
+              <a:rPr sz="1200" b="0">
+                <a:solidFill>
+                  <a:srgbClr val="333333"/>
+                </a:solidFill>
+              </a:rPr>
+              <a:t>Unstable metrics (the other 62) miss the floor — non-portable; listed in the inspector.</a:t>
             </a:r>
           </a:p>
         </p:txBody>
@@ -23767,7 +23947,7 @@
               </a:spcAft>
             </a:pPr>
             <a:r>
-              <a:rPr sz="1200" b="0">
+              <a:rPr sz="1100" b="0">
                 <a:solidFill>
                   <a:srgbClr val="333333"/>
                 </a:solidFill>
@@ -23777,12 +23957,32 @@
           </a:p>
           <a:p>
             <a:r>
-              <a:rPr sz="1200" b="0">
+              <a:rPr sz="1100" b="0">
                 <a:solidFill>
                   <a:srgbClr val="333333"/>
                 </a:solidFill>
               </a:rPr>
               <a:t>Metric codes: see Glossary slide (PPC, DIS, PRS, …).</a:t>
+            </a:r>
+          </a:p>
+          <a:p>
+            <a:r>
+              <a:rPr sz="1100" b="0">
+                <a:solidFill>
+                  <a:srgbClr val="333333"/>
+                </a:solidFill>
+              </a:rPr>
+              <a:t/>
+            </a:r>
+          </a:p>
+          <a:p>
+            <a:r>
+              <a:rPr sz="1100" b="0">
+                <a:solidFill>
+                  <a:srgbClr val="333333"/>
+                </a:solidFill>
+              </a:rPr>
+              <a:t>Position changes: we use broad position groups for peer ranks. We do not model "CB became FB" as the main story — role switches can add noise to stability, but this project is about which rate traits travel, not which players changed position.</a:t>
             </a:r>
           </a:p>
         </p:txBody>
@@ -23950,13 +24150,12 @@
           <a:p>
             <a:pPr algn="l"/>
             <a:r>
-              <a:rPr lang="en-US" sz="2200" b="1" dirty="0">
-                <a:solidFill>
-                  <a:srgbClr val="1C1C1C"/>
-                </a:solidFill>
-                <a:latin typeface="Georgia"/>
-              </a:rPr>
-              <a:t>Collinearity-Style Metric Pruning </a:t>
+              <a:rPr sz="1800" b="1">
+                <a:solidFill>
+                  <a:srgbClr val="3D5A80"/>
+                </a:solidFill>
+              </a:rPr>
+              <a:t>Drop near-duplicate metrics</a:t>
             </a:r>
             <a:endParaRPr sz="2200" b="1" dirty="0">
               <a:solidFill>
@@ -23964,6 +24163,16 @@
               </a:solidFill>
               <a:latin typeface="Georgia"/>
             </a:endParaRPr>
+          </a:p>
+          <a:p>
+            <a:r>
+              <a:rPr sz="1200">
+                <a:solidFill>
+                  <a:srgbClr val="555555"/>
+                </a:solidFill>
+              </a:rPr>
+              <a:t>(metrics that move together — same information twice)</a:t>
+            </a:r>
           </a:p>
         </p:txBody>
       </p:sp>
@@ -24333,52 +24542,52 @@
               </a:spcAft>
             </a:pPr>
             <a:r>
-              <a:rPr sz="1200" b="0">
-                <a:solidFill>
-                  <a:srgbClr val="333333"/>
-                </a:solidFill>
-              </a:rPr>
-              <a:t>FBref: 43 gated → 32 kept</a:t>
-            </a:r>
-          </a:p>
-          <a:p>
-            <a:r>
-              <a:rPr sz="1200" b="0">
-                <a:solidFill>
-                  <a:srgbClr val="333333"/>
-                </a:solidFill>
-              </a:rPr>
-              <a:t>105 tested · category gates → 43 · |r|≥0.95 → 32</a:t>
-            </a:r>
-          </a:p>
-          <a:p>
-            <a:r>
-              <a:rPr sz="1200" b="0">
-                <a:solidFill>
-                  <a:srgbClr val="333333"/>
-                </a:solidFill>
-              </a:rPr>
-              <a:t>Pick order: stability → N → rate/contextual</a:t>
-            </a:r>
-          </a:p>
-          <a:p>
-            <a:r>
-              <a:rPr sz="1200" b="0">
-                <a:solidFill>
-                  <a:srgbClr val="333333"/>
-                </a:solidFill>
-              </a:rPr>
-              <a:t>Force-kept: SoT/90 · Gls/90 · Tkld Take · Att Total</a:t>
-            </a:r>
-          </a:p>
-          <a:p>
-            <a:r>
-              <a:rPr sz="1200" b="0">
-                <a:solidFill>
-                  <a:srgbClr val="333333"/>
-                </a:solidFill>
-              </a:rPr>
-              <a:t>Top: DEFPE (0.91) · PRGC (0.81) · XG (0.80)</a:t>
+              <a:rPr sz="1100" b="0">
+                <a:solidFill>
+                  <a:srgbClr val="333333"/>
+                </a:solidFill>
+              </a:rPr>
+              <a:t>FBref: 43 cleared stability → 32 kept</a:t>
+            </a:r>
+          </a:p>
+          <a:p>
+            <a:r>
+              <a:rPr sz="1100" b="0">
+                <a:solidFill>
+                  <a:srgbClr val="333333"/>
+                </a:solidFill>
+              </a:rPr>
+              <a:t>105 tested · category gates → 43 · Pearson |r|≥0.95 → drop near-duplicates → 32</a:t>
+            </a:r>
+          </a:p>
+          <a:p>
+            <a:r>
+              <a:rPr sz="1100" b="0">
+                <a:solidFill>
+                  <a:srgbClr val="333333"/>
+                </a:solidFill>
+              </a:rPr>
+              <a:t>Near-duplicate = two metrics that almost always move together (same information twice).</a:t>
+            </a:r>
+          </a:p>
+          <a:p>
+            <a:r>
+              <a:rPr sz="1100" b="0">
+                <a:solidFill>
+                  <a:srgbClr val="333333"/>
+                </a:solidFill>
+              </a:rPr>
+              <a:t>Pick order when choosing which to keep: higher stability → larger N → prefer rate/contextual</a:t>
+            </a:r>
+          </a:p>
+          <a:p>
+            <a:r>
+              <a:rPr sz="1100" b="0">
+                <a:solidFill>
+                  <a:srgbClr val="333333"/>
+                </a:solidFill>
+              </a:rPr>
+              <a:t>Top stability examples: DEFPE (0.91) · PRGC (0.81) · XG (0.80)</a:t>
             </a:r>
           </a:p>
         </p:txBody>

</xml_diff>

<commit_message>
Use full metric names on result slides.
Replace scout codes with plain-language labels so a non-soccer reader can follow the tables without the glossary.

Co-authored-by: Cursor <cursoragent@cursor.com>
</commit_message>
<xml_diff>
--- a/bundesliga_transfer_traits.pptx
+++ b/bundesliga_transfer_traits.pptx
@@ -6869,7 +6869,7 @@
               </a:spcAft>
             </a:pPr>
             <a:r>
-              <a:rPr sz="1200" b="0">
+              <a:rPr sz="1100">
                 <a:solidFill>
                   <a:srgbClr val="333333"/>
                 </a:solidFill>
@@ -6879,7 +6879,7 @@
           </a:p>
           <a:p>
             <a:r>
-              <a:rPr sz="1200" b="0">
+              <a:rPr sz="1100">
                 <a:solidFill>
                   <a:srgbClr val="333333"/>
                 </a:solidFill>
@@ -6888,80 +6888,83 @@
             </a:r>
           </a:p>
           <a:p>
-            <a:endParaRPr sz="1200" b="0">
-              <a:solidFill>
-                <a:srgbClr val="333333"/>
-              </a:solidFill>
-            </a:endParaRPr>
-          </a:p>
-          <a:p>
-            <a:r>
-              <a:rPr sz="1200" b="0">
-                <a:solidFill>
-                  <a:srgbClr val="333333"/>
-                </a:solidFill>
-              </a:rPr>
-              <a:t>PRS  ρ=-0.28  p=0.006</a:t>
-            </a:r>
-          </a:p>
-          <a:p>
-            <a:r>
-              <a:rPr sz="1200" b="0">
-                <a:solidFill>
-                  <a:srgbClr val="333333"/>
-                </a:solidFill>
-              </a:rPr>
-              <a:t>DRB  ρ=-0.17  p=0.090</a:t>
-            </a:r>
-          </a:p>
-          <a:p>
-            <a:r>
-              <a:rPr sz="1200" b="0">
-                <a:solidFill>
-                  <a:srgbClr val="333333"/>
-                </a:solidFill>
-              </a:rPr>
-              <a:t>PPC  ρ=+0.16  p=0.112</a:t>
-            </a:r>
-          </a:p>
-          <a:p>
-            <a:r>
-              <a:rPr sz="1200" b="0">
-                <a:solidFill>
-                  <a:srgbClr val="333333"/>
-                </a:solidFill>
-              </a:rPr>
-              <a:t>DIS  ρ=+0.14  p=0.185</a:t>
-            </a:r>
-          </a:p>
-          <a:p>
-            <a:r>
-              <a:rPr sz="1200" b="0">
-                <a:solidFill>
-                  <a:srgbClr val="333333"/>
-                </a:solidFill>
-              </a:rPr>
-              <a:t>PATT  ρ=-0.11  p=0.280</a:t>
-            </a:r>
-          </a:p>
-          <a:p>
-            <a:r>
-              <a:rPr sz="1200" b="0">
-                <a:solidFill>
-                  <a:srgbClr val="333333"/>
-                </a:solidFill>
-              </a:rPr>
-              <a:t>CLR  ρ=-0.07  p=0.473</a:t>
-            </a:r>
-          </a:p>
-          <a:p>
-            <a:r>
-              <a:rPr sz="1200" b="0">
-                <a:solidFill>
-                  <a:srgbClr val="333333"/>
-                </a:solidFill>
-              </a:rPr>
-              <a:t>PAS  ρ=+0.00  p=0.980</a:t>
+            <a:r>
+              <a:rPr sz="1100">
+                <a:solidFill>
+                  <a:srgbClr val="333333"/>
+                </a:solidFill>
+              </a:rPr>
+              <a:t/>
+            </a:r>
+          </a:p>
+          <a:p>
+            <a:r>
+              <a:rPr sz="1100">
+                <a:solidFill>
+                  <a:srgbClr val="333333"/>
+                </a:solidFill>
+              </a:rPr>
+              <a:t>Pressures  ρ=-0.28  p=0.006</a:t>
+            </a:r>
+          </a:p>
+          <a:p>
+            <a:r>
+              <a:rPr sz="1100">
+                <a:solidFill>
+                  <a:srgbClr val="333333"/>
+                </a:solidFill>
+              </a:rPr>
+              <a:t>Successful dribbles  ρ=-0.17  p=0.090</a:t>
+            </a:r>
+          </a:p>
+          <a:p>
+            <a:r>
+              <a:rPr sz="1100">
+                <a:solidFill>
+                  <a:srgbClr val="333333"/>
+                </a:solidFill>
+              </a:rPr>
+              <a:t>Progressive passes  ρ=+0.16  p=0.112</a:t>
+            </a:r>
+          </a:p>
+          <a:p>
+            <a:r>
+              <a:rPr sz="1100">
+                <a:solidFill>
+                  <a:srgbClr val="333333"/>
+                </a:solidFill>
+              </a:rPr>
+              <a:t>Dispossessed (inverted)  ρ=+0.14  p=0.185</a:t>
+            </a:r>
+          </a:p>
+          <a:p>
+            <a:r>
+              <a:rPr sz="1100">
+                <a:solidFill>
+                  <a:srgbClr val="333333"/>
+                </a:solidFill>
+              </a:rPr>
+              <a:t>Passes into final third  ρ=-0.11  p=0.280</a:t>
+            </a:r>
+          </a:p>
+          <a:p>
+            <a:r>
+              <a:rPr sz="1100">
+                <a:solidFill>
+                  <a:srgbClr val="333333"/>
+                </a:solidFill>
+              </a:rPr>
+              <a:t>Clearances  ρ=-0.07  p=0.473</a:t>
+            </a:r>
+          </a:p>
+          <a:p>
+            <a:r>
+              <a:rPr sz="1100">
+                <a:solidFill>
+                  <a:srgbClr val="333333"/>
+                </a:solidFill>
+              </a:rPr>
+              <a:t>Pass volume  ρ=+0.00  p=0.980</a:t>
             </a:r>
           </a:p>
         </p:txBody>
@@ -7113,21 +7116,8 @@
                     <a:bodyPr/>
                     <a:lstStyle/>
                     <a:p>
-                      <a:pPr>
-                        <a:defRPr sz="1000" b="0">
-                          <a:solidFill>
-                            <a:srgbClr val="1C1C1C"/>
-                          </a:solidFill>
-                          <a:latin typeface="Calibri"/>
-                        </a:defRPr>
-                      </a:pPr>
-                      <a:r>
-                        <a:rPr sz="1000">
-                          <a:solidFill>
-                            <a:srgbClr val="333333"/>
-                          </a:solidFill>
-                        </a:rPr>
-                        <a:t>PRS — Pressures</a:t>
+                      <a:r>
+                        <a:t>Pressures</a:t>
                       </a:r>
                     </a:p>
                   </a:txBody>
@@ -7207,21 +7197,8 @@
                     <a:bodyPr/>
                     <a:lstStyle/>
                     <a:p>
-                      <a:pPr>
-                        <a:defRPr sz="1000" b="0">
-                          <a:solidFill>
-                            <a:srgbClr val="1C1C1C"/>
-                          </a:solidFill>
-                          <a:latin typeface="Calibri"/>
-                        </a:defRPr>
-                      </a:pPr>
-                      <a:r>
-                        <a:rPr sz="1000">
-                          <a:solidFill>
-                            <a:srgbClr val="333333"/>
-                          </a:solidFill>
-                        </a:rPr>
-                        <a:t>DRB — Successful dribbles</a:t>
+                      <a:r>
+                        <a:t>Successful dribbles</a:t>
                       </a:r>
                     </a:p>
                   </a:txBody>
@@ -7301,21 +7278,8 @@
                     <a:bodyPr/>
                     <a:lstStyle/>
                     <a:p>
-                      <a:pPr>
-                        <a:defRPr sz="1000" b="0">
-                          <a:solidFill>
-                            <a:srgbClr val="1C1C1C"/>
-                          </a:solidFill>
-                          <a:latin typeface="Calibri"/>
-                        </a:defRPr>
-                      </a:pPr>
-                      <a:r>
-                        <a:rPr sz="1000">
-                          <a:solidFill>
-                            <a:srgbClr val="333333"/>
-                          </a:solidFill>
-                        </a:rPr>
-                        <a:t>PPC — Progressive passes</a:t>
+                      <a:r>
+                        <a:t>Progressive passes</a:t>
                       </a:r>
                     </a:p>
                   </a:txBody>
@@ -7395,23 +7359,9 @@
                     <a:bodyPr/>
                     <a:lstStyle/>
                     <a:p>
-                      <a:pPr>
-                        <a:defRPr sz="1000" b="0">
-                          <a:solidFill>
-                            <a:srgbClr val="1C1C1C"/>
-                          </a:solidFill>
-                          <a:latin typeface="Calibri"/>
-                        </a:defRPr>
-                      </a:pPr>
-                      <a:r>
-                        <a:rPr sz="1000" dirty="0">
-                          <a:solidFill>
-                            <a:srgbClr val="333333"/>
-                          </a:solidFill>
-                        </a:rPr>
-                        <a:t>DIS — Dispossessed (inv)</a:t>
-                      </a:r>
-                      <a:endParaRPr dirty="0"/>
+                      <a:r>
+                        <a:t>Dispossessed (inverted)</a:t>
+                      </a:r>
                     </a:p>
                   </a:txBody>
                   <a:tcPr>
@@ -7490,21 +7440,8 @@
                     <a:bodyPr/>
                     <a:lstStyle/>
                     <a:p>
-                      <a:pPr>
-                        <a:defRPr sz="1000" b="0">
-                          <a:solidFill>
-                            <a:srgbClr val="1C1C1C"/>
-                          </a:solidFill>
-                          <a:latin typeface="Calibri"/>
-                        </a:defRPr>
-                      </a:pPr>
-                      <a:r>
-                        <a:rPr sz="1000">
-                          <a:solidFill>
-                            <a:srgbClr val="333333"/>
-                          </a:solidFill>
-                        </a:rPr>
-                        <a:t>PATT — Passes into final third</a:t>
+                      <a:r>
+                        <a:t>Passes into final third</a:t>
                       </a:r>
                     </a:p>
                   </a:txBody>
@@ -7584,21 +7521,8 @@
                     <a:bodyPr/>
                     <a:lstStyle/>
                     <a:p>
-                      <a:pPr>
-                        <a:defRPr sz="1000" b="0">
-                          <a:solidFill>
-                            <a:srgbClr val="1C1C1C"/>
-                          </a:solidFill>
-                          <a:latin typeface="Calibri"/>
-                        </a:defRPr>
-                      </a:pPr>
-                      <a:r>
-                        <a:rPr sz="1000">
-                          <a:solidFill>
-                            <a:srgbClr val="333333"/>
-                          </a:solidFill>
-                        </a:rPr>
-                        <a:t>CLR — Clearances</a:t>
+                      <a:r>
+                        <a:t>Clearances</a:t>
                       </a:r>
                     </a:p>
                   </a:txBody>
@@ -7704,7 +7628,7 @@
               </a:spcAft>
             </a:pPr>
             <a:r>
-              <a:rPr sz="1200" b="0">
+              <a:rPr sz="1100">
                 <a:solidFill>
                   <a:srgbClr val="333333"/>
                 </a:solidFill>
@@ -7714,106 +7638,102 @@
           </a:p>
           <a:p>
             <a:r>
-              <a:rPr sz="1200" b="0">
-                <a:solidFill>
-                  <a:srgbClr val="333333"/>
-                </a:solidFill>
-              </a:rPr>
-              <a:t>prior %ile → Year 1 in Bundesliga minutes</a:t>
-            </a:r>
-          </a:p>
-          <a:p>
-            <a:endParaRPr sz="1200" b="0">
-              <a:solidFill>
-                <a:srgbClr val="333333"/>
-              </a:solidFill>
-            </a:endParaRPr>
-          </a:p>
-          <a:p>
-            <a:r>
-              <a:rPr sz="1200" b="0">
-                <a:solidFill>
-                  <a:srgbClr val="333333"/>
-                </a:solidFill>
-              </a:rPr>
-              <a:t>FINAL  ρ=+0.30  p=0.005 *</a:t>
-            </a:r>
-          </a:p>
-          <a:p>
-            <a:r>
-              <a:rPr sz="1200" b="0">
-                <a:solidFill>
-                  <a:srgbClr val="333333"/>
-                </a:solidFill>
-              </a:rPr>
-              <a:t>SH  ρ=+0.27  p=0.011 *</a:t>
-            </a:r>
-          </a:p>
-          <a:p>
-            <a:r>
-              <a:rPr sz="1200" b="0">
-                <a:solidFill>
-                  <a:srgbClr val="333333"/>
-                </a:solidFill>
-              </a:rPr>
-              <a:t>PRGDI  ρ=+0.24  p=0.025 *</a:t>
-            </a:r>
-          </a:p>
-          <a:p>
-            <a:r>
-              <a:rPr sz="1200" b="0">
-                <a:solidFill>
-                  <a:srgbClr val="333333"/>
-                </a:solidFill>
-              </a:rPr>
-              <a:t>TKLD  ρ=+0.23  p=0.030 *</a:t>
-            </a:r>
-          </a:p>
-          <a:p>
-            <a:r>
-              <a:rPr sz="1200" b="0">
-                <a:solidFill>
-                  <a:srgbClr val="333333"/>
-                </a:solidFill>
-              </a:rPr>
-              <a:t>ATTLO  ρ=+0.22  p=0.036 *</a:t>
-            </a:r>
-          </a:p>
-          <a:p>
-            <a:r>
-              <a:rPr sz="1200" b="0">
-                <a:solidFill>
-                  <a:srgbClr val="333333"/>
-                </a:solidFill>
-              </a:rPr>
-              <a:t>DEF3R  ρ=+0.22  p=0.039 *</a:t>
-            </a:r>
-          </a:p>
-          <a:p>
-            <a:endParaRPr sz="1200" b="0">
-              <a:solidFill>
-                <a:srgbClr val="333333"/>
-              </a:solidFill>
-            </a:endParaRPr>
-          </a:p>
-          <a:p>
-            <a:r>
-              <a:rPr sz="1200" b="0">
-                <a:solidFill>
-                  <a:srgbClr val="333333"/>
-                </a:solidFill>
-              </a:rPr>
-              <a:t>* p&lt;0.05  ·  Final Third, shot blocks, progressive distance lead.</a:t>
-            </a:r>
-          </a:p>
-          <a:p>
-            <a:r>
-              <a:rPr sz="1200" b="0">
-                <a:solidFill>
-                  <a:srgbClr val="333333"/>
-                </a:solidFill>
-              </a:rPr>
-              <a:t>Metric codes: see Glossary slide.</a:t>
+              <a:rPr sz="1100">
+                <a:solidFill>
+                  <a:srgbClr val="333333"/>
+                </a:solidFill>
+              </a:rPr>
+              <a:t>prior percentile → Year 1 in Bundesliga minutes</a:t>
+            </a:r>
+          </a:p>
+          <a:p>
+            <a:r>
+              <a:rPr sz="1100">
+                <a:solidFill>
+                  <a:srgbClr val="333333"/>
+                </a:solidFill>
+              </a:rPr>
+              <a:t/>
+            </a:r>
+          </a:p>
+          <a:p>
+            <a:r>
+              <a:rPr sz="1100">
+                <a:solidFill>
+                  <a:srgbClr val="333333"/>
+                </a:solidFill>
+              </a:rPr>
+              <a:t>Final-third passes  ρ=+0.30  p=0.005 *</a:t>
+            </a:r>
+          </a:p>
+          <a:p>
+            <a:r>
+              <a:rPr sz="1100">
+                <a:solidFill>
+                  <a:srgbClr val="333333"/>
+                </a:solidFill>
+              </a:rPr>
+              <a:t>Shot blocks  ρ=+0.27  p=0.011 *</a:t>
+            </a:r>
+          </a:p>
+          <a:p>
+            <a:r>
+              <a:rPr sz="1100">
+                <a:solidFill>
+                  <a:srgbClr val="333333"/>
+                </a:solidFill>
+              </a:rPr>
+              <a:t>Progressive carry distance  ρ=+0.24  p=0.025 *</a:t>
+            </a:r>
+          </a:p>
+          <a:p>
+            <a:r>
+              <a:rPr sz="1100">
+                <a:solidFill>
+                  <a:srgbClr val="333333"/>
+                </a:solidFill>
+              </a:rPr>
+              <a:t>Tackled take-ons  ρ=+0.23  p=0.030 *</a:t>
+            </a:r>
+          </a:p>
+          <a:p>
+            <a:r>
+              <a:rPr sz="1100">
+                <a:solidFill>
+                  <a:srgbClr val="333333"/>
+                </a:solidFill>
+              </a:rPr>
+              <a:t>Long pass attempts  ρ=+0.22  p=0.036 *</a:t>
+            </a:r>
+          </a:p>
+          <a:p>
+            <a:r>
+              <a:rPr sz="1100">
+                <a:solidFill>
+                  <a:srgbClr val="333333"/>
+                </a:solidFill>
+              </a:rPr>
+              <a:t>Defensive-third touches  ρ=+0.22  p=0.039 *</a:t>
+            </a:r>
+          </a:p>
+          <a:p>
+            <a:r>
+              <a:rPr sz="1100">
+                <a:solidFill>
+                  <a:srgbClr val="333333"/>
+                </a:solidFill>
+              </a:rPr>
+              <a:t/>
+            </a:r>
+          </a:p>
+          <a:p>
+            <a:r>
+              <a:rPr sz="1100">
+                <a:solidFill>
+                  <a:srgbClr val="333333"/>
+                </a:solidFill>
+              </a:rPr>
+              <a:t>* p&lt;0.05  ·  Final-third passes, shot blocks, progressive carry distance lead.</a:t>
             </a:r>
           </a:p>
         </p:txBody>
@@ -7965,21 +7885,8 @@
                     <a:bodyPr/>
                     <a:lstStyle/>
                     <a:p>
-                      <a:pPr>
-                        <a:defRPr sz="1000" b="0">
-                          <a:solidFill>
-                            <a:srgbClr val="1C1C1C"/>
-                          </a:solidFill>
-                          <a:latin typeface="Calibri"/>
-                        </a:defRPr>
-                      </a:pPr>
-                      <a:r>
-                        <a:rPr sz="1000">
-                          <a:solidFill>
-                            <a:srgbClr val="333333"/>
-                          </a:solidFill>
-                        </a:rPr>
-                        <a:t>FINAL — Final Third*</a:t>
+                      <a:r>
+                        <a:t>Final-third passes*</a:t>
                       </a:r>
                     </a:p>
                   </a:txBody>
@@ -8059,21 +7966,8 @@
                     <a:bodyPr/>
                     <a:lstStyle/>
                     <a:p>
-                      <a:pPr>
-                        <a:defRPr sz="1000" b="0">
-                          <a:solidFill>
-                            <a:srgbClr val="1C1C1C"/>
-                          </a:solidFill>
-                          <a:latin typeface="Calibri"/>
-                        </a:defRPr>
-                      </a:pPr>
-                      <a:r>
-                        <a:rPr sz="1000">
-                          <a:solidFill>
-                            <a:srgbClr val="333333"/>
-                          </a:solidFill>
-                        </a:rPr>
-                        <a:t>SH — Shot Blocks*</a:t>
+                      <a:r>
+                        <a:t>Shot blocks*</a:t>
                       </a:r>
                     </a:p>
                   </a:txBody>
@@ -8153,21 +8047,8 @@
                     <a:bodyPr/>
                     <a:lstStyle/>
                     <a:p>
-                      <a:pPr>
-                        <a:defRPr sz="1000" b="0">
-                          <a:solidFill>
-                            <a:srgbClr val="1C1C1C"/>
-                          </a:solidFill>
-                          <a:latin typeface="Calibri"/>
-                        </a:defRPr>
-                      </a:pPr>
-                      <a:r>
-                        <a:rPr sz="1000" dirty="0">
-                          <a:solidFill>
-                            <a:srgbClr val="333333"/>
-                          </a:solidFill>
-                        </a:rPr>
-                        <a:t>PRGDI — PrgDist Total*</a:t>
+                      <a:r>
+                        <a:t>Progressive carry distance*</a:t>
                       </a:r>
                     </a:p>
                   </a:txBody>
@@ -8247,21 +8128,8 @@
                     <a:bodyPr/>
                     <a:lstStyle/>
                     <a:p>
-                      <a:pPr>
-                        <a:defRPr sz="1000" b="0">
-                          <a:solidFill>
-                            <a:srgbClr val="1C1C1C"/>
-                          </a:solidFill>
-                          <a:latin typeface="Calibri"/>
-                        </a:defRPr>
-                      </a:pPr>
-                      <a:r>
-                        <a:rPr sz="1000">
-                          <a:solidFill>
-                            <a:srgbClr val="333333"/>
-                          </a:solidFill>
-                        </a:rPr>
-                        <a:t>TKLD — Tkld Take*</a:t>
+                      <a:r>
+                        <a:t>Tackled take-ons*</a:t>
                       </a:r>
                     </a:p>
                   </a:txBody>
@@ -8341,21 +8209,8 @@
                     <a:bodyPr/>
                     <a:lstStyle/>
                     <a:p>
-                      <a:pPr>
-                        <a:defRPr sz="1000" b="0">
-                          <a:solidFill>
-                            <a:srgbClr val="1C1C1C"/>
-                          </a:solidFill>
-                          <a:latin typeface="Calibri"/>
-                        </a:defRPr>
-                      </a:pPr>
-                      <a:r>
-                        <a:rPr sz="1000">
-                          <a:solidFill>
-                            <a:srgbClr val="333333"/>
-                          </a:solidFill>
-                        </a:rPr>
-                        <a:t>ATTLO — Att Long*</a:t>
+                      <a:r>
+                        <a:t>Long pass attempts*</a:t>
                       </a:r>
                     </a:p>
                   </a:txBody>
@@ -8435,21 +8290,8 @@
                     <a:bodyPr/>
                     <a:lstStyle/>
                     <a:p>
-                      <a:pPr>
-                        <a:defRPr sz="1000" b="0">
-                          <a:solidFill>
-                            <a:srgbClr val="1C1C1C"/>
-                          </a:solidFill>
-                          <a:latin typeface="Calibri"/>
-                        </a:defRPr>
-                      </a:pPr>
-                      <a:r>
-                        <a:rPr sz="1000">
-                          <a:solidFill>
-                            <a:srgbClr val="333333"/>
-                          </a:solidFill>
-                        </a:rPr>
-                        <a:t>DEF3R — Def 3rd Touches*</a:t>
+                      <a:r>
+                        <a:t>Defensive-third touches*</a:t>
                       </a:r>
                     </a:p>
                   </a:txBody>
@@ -8529,16 +8371,8 @@
                     <a:bodyPr/>
                     <a:lstStyle/>
                     <a:p>
-                      <a:pPr>
-                        <a:defRPr sz="1000" b="0">
-                          <a:solidFill>
-                            <a:srgbClr val="1C1C1C"/>
-                          </a:solidFill>
-                          <a:latin typeface="Calibri"/>
-                        </a:defRPr>
-                      </a:pPr>
-                      <a:r>
-                        <a:t>MIS — Mis Carries</a:t>
+                      <a:r>
+                        <a:t>Miscontrols (carries)</a:t>
                       </a:r>
                     </a:p>
                   </a:txBody>
@@ -8608,23 +8442,9 @@
                     <a:bodyPr/>
                     <a:lstStyle/>
                     <a:p>
-                      <a:pPr>
-                        <a:defRPr sz="1000" b="0">
-                          <a:solidFill>
-                            <a:srgbClr val="1C1C1C"/>
-                          </a:solidFill>
-                          <a:latin typeface="Calibri"/>
-                        </a:defRPr>
-                      </a:pPr>
-                      <a:r>
-                        <a:rPr dirty="0"/>
-                        <a:t>CLR — Cl</a:t>
-                      </a:r>
-                      <a:r>
-                        <a:rPr lang="en-US" dirty="0"/>
-                        <a:t>earances</a:t>
-                      </a:r>
-                      <a:endParaRPr dirty="0"/>
+                      <a:r>
+                        <a:t>Clearances</a:t>
+                      </a:r>
                     </a:p>
                   </a:txBody>
                   <a:tcPr>
@@ -12080,15 +11900,8 @@
                     <a:bodyPr/>
                     <a:lstStyle/>
                     <a:p>
-                      <a:pPr algn="ctr"/>
-                      <a:r>
-                        <a:rPr sz="1100" b="0">
-                          <a:solidFill>
-                            <a:srgbClr val="1C1C1C"/>
-                          </a:solidFill>
-                          <a:latin typeface="Arial"/>
-                        </a:rPr>
-                        <a:t>Lost Aerial*</a:t>
+                      <a:r>
+                        <a:t>Aerials lost (fewer = better)*</a:t>
                       </a:r>
                     </a:p>
                   </a:txBody>
@@ -12144,15 +11957,8 @@
                     <a:bodyPr/>
                     <a:lstStyle/>
                     <a:p>
-                      <a:pPr algn="ctr"/>
-                      <a:r>
-                        <a:rPr sz="1100" b="0">
-                          <a:solidFill>
-                            <a:srgbClr val="1C1C1C"/>
-                          </a:solidFill>
-                          <a:latin typeface="Arial"/>
-                        </a:rPr>
-                        <a:t>Final Third</a:t>
+                      <a:r>
+                        <a:t>Final-third passes</a:t>
                       </a:r>
                     </a:p>
                   </a:txBody>
@@ -12208,15 +12014,8 @@
                     <a:bodyPr/>
                     <a:lstStyle/>
                     <a:p>
-                      <a:pPr algn="ctr"/>
-                      <a:r>
-                        <a:rPr sz="1100" b="0">
-                          <a:solidFill>
-                            <a:srgbClr val="1C1C1C"/>
-                          </a:solidFill>
-                          <a:latin typeface="Arial"/>
-                        </a:rPr>
-                        <a:t>Def Pen Touches</a:t>
+                      <a:r>
+                        <a:t>Defensive penalty-area touches</a:t>
                       </a:r>
                     </a:p>
                   </a:txBody>
@@ -12272,15 +12071,8 @@
                     <a:bodyPr/>
                     <a:lstStyle/>
                     <a:p>
-                      <a:pPr algn="ctr"/>
-                      <a:r>
-                        <a:rPr sz="1100" b="0">
-                          <a:solidFill>
-                            <a:srgbClr val="1C1C1C"/>
-                          </a:solidFill>
-                          <a:latin typeface="Arial"/>
-                        </a:rPr>
-                        <a:t>PrgDist Total</a:t>
+                      <a:r>
+                        <a:t>Progressive carry distance</a:t>
                       </a:r>
                     </a:p>
                   </a:txBody>
@@ -12336,24 +12128,8 @@
                     <a:bodyPr/>
                     <a:lstStyle/>
                     <a:p>
-                      <a:pPr algn="ctr"/>
-                      <a:r>
-                        <a:rPr sz="1100" b="0" dirty="0" err="1">
-                          <a:solidFill>
-                            <a:srgbClr val="1C1C1C"/>
-                          </a:solidFill>
-                          <a:latin typeface="Arial"/>
-                        </a:rPr>
-                        <a:t>xG</a:t>
-                      </a:r>
-                      <a:r>
-                        <a:rPr sz="1100" b="0" dirty="0">
-                          <a:solidFill>
-                            <a:srgbClr val="1C1C1C"/>
-                          </a:solidFill>
-                          <a:latin typeface="Arial"/>
-                        </a:rPr>
-                        <a:t> Per</a:t>
+                      <a:r>
+                        <a:t>Expected goals (xG)</a:t>
                       </a:r>
                     </a:p>
                   </a:txBody>
@@ -17681,21 +17457,8 @@
                     <a:bodyPr/>
                     <a:lstStyle/>
                     <a:p>
-                      <a:pPr>
-                        <a:defRPr sz="1100" b="1">
-                          <a:solidFill>
-                            <a:srgbClr val="FFFFFF"/>
-                          </a:solidFill>
-                          <a:latin typeface="Calibri"/>
-                        </a:defRPr>
-                      </a:pPr>
-                      <a:r>
-                        <a:rPr sz="1000" b="1" dirty="0">
-                          <a:solidFill>
-                            <a:schemeClr val="bg1"/>
-                          </a:solidFill>
-                        </a:rPr>
-                        <a:t>Abbrev</a:t>
+                      <a:r>
+                        <a:t>Code</a:t>
                       </a:r>
                     </a:p>
                   </a:txBody>
@@ -17710,21 +17473,8 @@
                     <a:bodyPr/>
                     <a:lstStyle/>
                     <a:p>
-                      <a:pPr>
-                        <a:defRPr sz="1100" b="1">
-                          <a:solidFill>
-                            <a:srgbClr val="FFFFFF"/>
-                          </a:solidFill>
-                          <a:latin typeface="Calibri"/>
-                        </a:defRPr>
-                      </a:pPr>
-                      <a:r>
-                        <a:rPr sz="1000" b="1" dirty="0">
-                          <a:solidFill>
-                            <a:schemeClr val="bg1"/>
-                          </a:solidFill>
-                        </a:rPr>
-                        <a:t>Metric</a:t>
+                      <a:r>
+                        <a:t>Metric (full name)</a:t>
                       </a:r>
                     </a:p>
                   </a:txBody>
@@ -17862,21 +17612,8 @@
                     <a:bodyPr/>
                     <a:lstStyle/>
                     <a:p>
-                      <a:pPr>
-                        <a:defRPr sz="1100" b="0">
-                          <a:solidFill>
-                            <a:srgbClr val="1C1C1C"/>
-                          </a:solidFill>
-                          <a:latin typeface="Calibri"/>
-                        </a:defRPr>
-                      </a:pPr>
-                      <a:r>
-                        <a:rPr sz="1000">
-                          <a:solidFill>
-                            <a:srgbClr val="333333"/>
-                          </a:solidFill>
-                        </a:rPr>
-                        <a:t>Def Pen Touches</a:t>
+                      <a:r>
+                        <a:t>Defensive penalty-area touches</a:t>
                       </a:r>
                     </a:p>
                   </a:txBody>
@@ -18014,21 +17751,8 @@
                     <a:bodyPr/>
                     <a:lstStyle/>
                     <a:p>
-                      <a:pPr>
-                        <a:defRPr sz="1100" b="0">
-                          <a:solidFill>
-                            <a:srgbClr val="1C1C1C"/>
-                          </a:solidFill>
-                          <a:latin typeface="Calibri"/>
-                        </a:defRPr>
-                      </a:pPr>
-                      <a:r>
-                        <a:rPr sz="1000">
-                          <a:solidFill>
-                            <a:srgbClr val="333333"/>
-                          </a:solidFill>
-                        </a:rPr>
-                        <a:t>PrgC Progression</a:t>
+                      <a:r>
+                        <a:t>Progressive carries</a:t>
                       </a:r>
                     </a:p>
                   </a:txBody>
@@ -18166,21 +17890,8 @@
                     <a:bodyPr/>
                     <a:lstStyle/>
                     <a:p>
-                      <a:pPr>
-                        <a:defRPr sz="1100" b="0">
-                          <a:solidFill>
-                            <a:srgbClr val="1C1C1C"/>
-                          </a:solidFill>
-                          <a:latin typeface="Calibri"/>
-                        </a:defRPr>
-                      </a:pPr>
-                      <a:r>
-                        <a:rPr sz="1000">
-                          <a:solidFill>
-                            <a:srgbClr val="333333"/>
-                          </a:solidFill>
-                        </a:rPr>
-                        <a:t>xG Per</a:t>
+                      <a:r>
+                        <a:t>Expected goals (xG)</a:t>
                       </a:r>
                     </a:p>
                   </a:txBody>
@@ -18318,21 +18029,8 @@
                     <a:bodyPr/>
                     <a:lstStyle/>
                     <a:p>
-                      <a:pPr>
-                        <a:defRPr sz="1100" b="0">
-                          <a:solidFill>
-                            <a:srgbClr val="1C1C1C"/>
-                          </a:solidFill>
-                          <a:latin typeface="Calibri"/>
-                        </a:defRPr>
-                      </a:pPr>
-                      <a:r>
-                        <a:rPr sz="1000">
-                          <a:solidFill>
-                            <a:srgbClr val="333333"/>
-                          </a:solidFill>
-                        </a:rPr>
-                        <a:t>npxG Per</a:t>
+                      <a:r>
+                        <a:t>Non-penalty expected goals</a:t>
                       </a:r>
                     </a:p>
                   </a:txBody>
@@ -18470,21 +18168,8 @@
                     <a:bodyPr/>
                     <a:lstStyle/>
                     <a:p>
-                      <a:pPr>
-                        <a:defRPr sz="1100" b="0">
-                          <a:solidFill>
-                            <a:srgbClr val="1C1C1C"/>
-                          </a:solidFill>
-                          <a:latin typeface="Calibri"/>
-                        </a:defRPr>
-                      </a:pPr>
-                      <a:r>
-                        <a:rPr sz="1000">
-                          <a:solidFill>
-                            <a:srgbClr val="333333"/>
-                          </a:solidFill>
-                        </a:rPr>
-                        <a:t>Def 3rd Touches</a:t>
+                      <a:r>
+                        <a:t>Defensive-third touches</a:t>
                       </a:r>
                     </a:p>
                   </a:txBody>
@@ -18622,21 +18307,8 @@
                     <a:bodyPr/>
                     <a:lstStyle/>
                     <a:p>
-                      <a:pPr>
-                        <a:defRPr sz="1100" b="0">
-                          <a:solidFill>
-                            <a:srgbClr val="1C1C1C"/>
-                          </a:solidFill>
-                          <a:latin typeface="Calibri"/>
-                        </a:defRPr>
-                      </a:pPr>
-                      <a:r>
-                        <a:rPr sz="1000">
-                          <a:solidFill>
-                            <a:srgbClr val="333333"/>
-                          </a:solidFill>
-                        </a:rPr>
-                        <a:t>PrgDist Total</a:t>
+                      <a:r>
+                        <a:t>Progressive carry distance</a:t>
                       </a:r>
                     </a:p>
                   </a:txBody>
@@ -18774,21 +18446,8 @@
                     <a:bodyPr/>
                     <a:lstStyle/>
                     <a:p>
-                      <a:pPr>
-                        <a:defRPr sz="1100" b="0">
-                          <a:solidFill>
-                            <a:srgbClr val="1C1C1C"/>
-                          </a:solidFill>
-                          <a:latin typeface="Calibri"/>
-                        </a:defRPr>
-                      </a:pPr>
-                      <a:r>
-                        <a:rPr sz="1000">
-                          <a:solidFill>
-                            <a:srgbClr val="333333"/>
-                          </a:solidFill>
-                        </a:rPr>
-                        <a:t>Sh/90 Standard</a:t>
+                      <a:r>
+                        <a:t>Shots per 90</a:t>
                       </a:r>
                     </a:p>
                   </a:txBody>
@@ -18926,21 +18585,8 @@
                     <a:bodyPr/>
                     <a:lstStyle/>
                     <a:p>
-                      <a:pPr>
-                        <a:defRPr sz="1100" b="0">
-                          <a:solidFill>
-                            <a:srgbClr val="1C1C1C"/>
-                          </a:solidFill>
-                          <a:latin typeface="Calibri"/>
-                        </a:defRPr>
-                      </a:pPr>
-                      <a:r>
-                        <a:rPr sz="1000">
-                          <a:solidFill>
-                            <a:srgbClr val="333333"/>
-                          </a:solidFill>
-                        </a:rPr>
-                        <a:t>Sh Standard</a:t>
+                      <a:r>
+                        <a:t>Shot blocks</a:t>
                       </a:r>
                     </a:p>
                   </a:txBody>
@@ -19078,21 +18724,8 @@
                     <a:bodyPr/>
                     <a:lstStyle/>
                     <a:p>
-                      <a:pPr>
-                        <a:defRPr sz="1100" b="0">
-                          <a:solidFill>
-                            <a:srgbClr val="1C1C1C"/>
-                          </a:solidFill>
-                          <a:latin typeface="Calibri"/>
-                        </a:defRPr>
-                      </a:pPr>
-                      <a:r>
-                        <a:rPr sz="1000">
-                          <a:solidFill>
-                            <a:srgbClr val="333333"/>
-                          </a:solidFill>
-                        </a:rPr>
-                        <a:t>npxG+xAG Per</a:t>
+                      <a:r>
+                        <a:t>Non-pen xG + xAG</a:t>
                       </a:r>
                     </a:p>
                   </a:txBody>
@@ -19230,21 +18863,8 @@
                     <a:bodyPr/>
                     <a:lstStyle/>
                     <a:p>
-                      <a:pPr>
-                        <a:defRPr sz="1100" b="0">
-                          <a:solidFill>
-                            <a:srgbClr val="1C1C1C"/>
-                          </a:solidFill>
-                          <a:latin typeface="Calibri"/>
-                        </a:defRPr>
-                      </a:pPr>
-                      <a:r>
-                        <a:rPr sz="1000">
-                          <a:solidFill>
-                            <a:srgbClr val="333333"/>
-                          </a:solidFill>
-                        </a:rPr>
-                        <a:t>xG+xAG Per</a:t>
+                      <a:r>
+                        <a:t>xG + xAG</a:t>
                       </a:r>
                     </a:p>
                   </a:txBody>
@@ -19382,21 +19002,8 @@
                     <a:bodyPr/>
                     <a:lstStyle/>
                     <a:p>
-                      <a:pPr>
-                        <a:defRPr sz="1100" b="0">
-                          <a:solidFill>
-                            <a:srgbClr val="1C1C1C"/>
-                          </a:solidFill>
-                          <a:latin typeface="Calibri"/>
-                        </a:defRPr>
-                      </a:pPr>
-                      <a:r>
-                        <a:rPr sz="1000">
-                          <a:solidFill>
-                            <a:srgbClr val="333333"/>
-                          </a:solidFill>
-                        </a:rPr>
-                        <a:t>Att Long</a:t>
+                      <a:r>
+                        <a:t>Long pass attempts</a:t>
                       </a:r>
                     </a:p>
                   </a:txBody>
@@ -19534,21 +19141,8 @@
                     <a:bodyPr/>
                     <a:lstStyle/>
                     <a:p>
-                      <a:pPr>
-                        <a:defRPr sz="1100" b="0">
-                          <a:solidFill>
-                            <a:srgbClr val="1C1C1C"/>
-                          </a:solidFill>
-                          <a:latin typeface="Calibri"/>
-                        </a:defRPr>
-                      </a:pPr>
-                      <a:r>
-                        <a:rPr sz="1000">
-                          <a:solidFill>
-                            <a:srgbClr val="333333"/>
-                          </a:solidFill>
-                        </a:rPr>
-                        <a:t>SoT Standard</a:t>
+                      <a:r>
+                        <a:t>Shots on target</a:t>
                       </a:r>
                     </a:p>
                   </a:txBody>
@@ -19686,21 +19280,8 @@
                     <a:bodyPr/>
                     <a:lstStyle/>
                     <a:p>
-                      <a:pPr>
-                        <a:defRPr sz="1100" b="0">
-                          <a:solidFill>
-                            <a:srgbClr val="1C1C1C"/>
-                          </a:solidFill>
-                          <a:latin typeface="Calibri"/>
-                        </a:defRPr>
-                      </a:pPr>
-                      <a:r>
-                        <a:rPr sz="1000">
-                          <a:solidFill>
-                            <a:srgbClr val="333333"/>
-                          </a:solidFill>
-                        </a:rPr>
-                        <a:t>SoT/90 Standard</a:t>
+                      <a:r>
+                        <a:t>Shots on target per 90</a:t>
                       </a:r>
                     </a:p>
                   </a:txBody>
@@ -19838,21 +19419,8 @@
                     <a:bodyPr/>
                     <a:lstStyle/>
                     <a:p>
-                      <a:pPr>
-                        <a:defRPr sz="1100" b="0">
-                          <a:solidFill>
-                            <a:srgbClr val="1C1C1C"/>
-                          </a:solidFill>
-                          <a:latin typeface="Calibri"/>
-                        </a:defRPr>
-                      </a:pPr>
-                      <a:r>
-                        <a:rPr sz="1000">
-                          <a:solidFill>
-                            <a:srgbClr val="333333"/>
-                          </a:solidFill>
-                        </a:rPr>
-                        <a:t>Cmp Long</a:t>
+                      <a:r>
+                        <a:t>Long pass completions</a:t>
                       </a:r>
                     </a:p>
                   </a:txBody>
@@ -19990,21 +19558,8 @@
                     <a:bodyPr/>
                     <a:lstStyle/>
                     <a:p>
-                      <a:pPr>
-                        <a:defRPr sz="1100" b="0">
-                          <a:solidFill>
-                            <a:srgbClr val="1C1C1C"/>
-                          </a:solidFill>
-                          <a:latin typeface="Calibri"/>
-                        </a:defRPr>
-                      </a:pPr>
-                      <a:r>
-                        <a:rPr sz="1000">
-                          <a:solidFill>
-                            <a:srgbClr val="333333"/>
-                          </a:solidFill>
-                        </a:rPr>
-                        <a:t>Cmp Medium</a:t>
+                      <a:r>
+                        <a:t>Medium pass completions</a:t>
                       </a:r>
                     </a:p>
                   </a:txBody>
@@ -20142,21 +19697,8 @@
                     <a:bodyPr/>
                     <a:lstStyle/>
                     <a:p>
-                      <a:pPr>
-                        <a:defRPr sz="1100" b="0">
-                          <a:solidFill>
-                            <a:srgbClr val="1C1C1C"/>
-                          </a:solidFill>
-                          <a:latin typeface="Calibri"/>
-                        </a:defRPr>
-                      </a:pPr>
-                      <a:r>
-                        <a:rPr sz="1000">
-                          <a:solidFill>
-                            <a:srgbClr val="333333"/>
-                          </a:solidFill>
-                        </a:rPr>
-                        <a:t>Att Medium</a:t>
+                      <a:r>
+                        <a:t>Medium pass attempts</a:t>
                       </a:r>
                     </a:p>
                   </a:txBody>
@@ -20294,21 +19836,8 @@
                     <a:bodyPr/>
                     <a:lstStyle/>
                     <a:p>
-                      <a:pPr>
-                        <a:defRPr sz="1100" b="0">
-                          <a:solidFill>
-                            <a:srgbClr val="1C1C1C"/>
-                          </a:solidFill>
-                          <a:latin typeface="Calibri"/>
-                        </a:defRPr>
-                      </a:pPr>
-                      <a:r>
-                        <a:rPr sz="1000">
-                          <a:solidFill>
-                            <a:srgbClr val="333333"/>
-                          </a:solidFill>
-                        </a:rPr>
-                        <a:t>TotDist Total</a:t>
+                      <a:r>
+                        <a:t>Total pass distance</a:t>
                       </a:r>
                     </a:p>
                   </a:txBody>
@@ -20446,21 +19975,8 @@
                     <a:bodyPr/>
                     <a:lstStyle/>
                     <a:p>
-                      <a:pPr>
-                        <a:defRPr sz="1100" b="0">
-                          <a:solidFill>
-                            <a:srgbClr val="1C1C1C"/>
-                          </a:solidFill>
-                          <a:latin typeface="Calibri"/>
-                        </a:defRPr>
-                      </a:pPr>
-                      <a:r>
-                        <a:rPr sz="1000">
-                          <a:solidFill>
-                            <a:srgbClr val="333333"/>
-                          </a:solidFill>
-                        </a:rPr>
-                        <a:t>PrgR Progression</a:t>
+                      <a:r>
+                        <a:t>Progressive passes received (count)</a:t>
                       </a:r>
                     </a:p>
                   </a:txBody>
@@ -20598,21 +20114,8 @@
                     <a:bodyPr/>
                     <a:lstStyle/>
                     <a:p>
-                      <a:pPr>
-                        <a:defRPr sz="1100" b="0">
-                          <a:solidFill>
-                            <a:srgbClr val="1C1C1C"/>
-                          </a:solidFill>
-                          <a:latin typeface="Calibri"/>
-                        </a:defRPr>
-                      </a:pPr>
-                      <a:r>
-                        <a:rPr sz="1000">
-                          <a:solidFill>
-                            <a:srgbClr val="333333"/>
-                          </a:solidFill>
-                        </a:rPr>
-                        <a:t>G+A Per</a:t>
+                      <a:r>
+                        <a:t>Goals + assists</a:t>
                       </a:r>
                     </a:p>
                   </a:txBody>
@@ -20750,21 +20253,8 @@
                     <a:bodyPr/>
                     <a:lstStyle/>
                     <a:p>
-                      <a:pPr>
-                        <a:defRPr sz="1100" b="0">
-                          <a:solidFill>
-                            <a:srgbClr val="1C1C1C"/>
-                          </a:solidFill>
-                          <a:latin typeface="Calibri"/>
-                        </a:defRPr>
-                      </a:pPr>
-                      <a:r>
-                        <a:rPr sz="1000">
-                          <a:solidFill>
-                            <a:srgbClr val="333333"/>
-                          </a:solidFill>
-                        </a:rPr>
-                        <a:t>FK Standard</a:t>
+                      <a:r>
+                        <a:t>Free kicks</a:t>
                       </a:r>
                     </a:p>
                   </a:txBody>
@@ -21077,7 +20567,7 @@
               </a:spcAft>
             </a:pPr>
             <a:r>
-              <a:rPr sz="1100" b="0" dirty="0">
+              <a:rPr sz="1100">
                 <a:solidFill>
                   <a:srgbClr val="333333"/>
                 </a:solidFill>
@@ -21086,186 +20576,133 @@
             </a:r>
           </a:p>
           <a:p>
-            <a:endParaRPr sz="1100" b="0" dirty="0">
-              <a:solidFill>
-                <a:srgbClr val="333333"/>
-              </a:solidFill>
-            </a:endParaRPr>
-          </a:p>
-          <a:p>
-            <a:r>
-              <a:rPr sz="1100" b="0" dirty="0">
-                <a:solidFill>
-                  <a:srgbClr val="333333"/>
-                </a:solidFill>
-              </a:rPr>
-              <a:t>✓  PPC  Progressive passes (~10m+ toward goal)  r=0.74</a:t>
-            </a:r>
-          </a:p>
-          <a:p>
-            <a:r>
-              <a:rPr sz="1100" b="0" dirty="0">
-                <a:solidFill>
-                  <a:srgbClr val="333333"/>
-                </a:solidFill>
-              </a:rPr>
-              <a:t>✓  DIS  Dispossessed (inverted)  r=0.59</a:t>
-            </a:r>
-          </a:p>
-          <a:p>
-            <a:r>
-              <a:rPr sz="1100" b="0" dirty="0">
-                <a:solidFill>
-                  <a:srgbClr val="333333"/>
-                </a:solidFill>
-              </a:rPr>
-              <a:t>✓  PRS  Pressures  r=0.51</a:t>
-            </a:r>
-          </a:p>
-          <a:p>
-            <a:r>
-              <a:rPr sz="1100" b="0" dirty="0">
-                <a:solidFill>
-                  <a:srgbClr val="333333"/>
-                </a:solidFill>
-              </a:rPr>
-              <a:t>✓  PAS  Pass volume  r=0.49</a:t>
-            </a:r>
-          </a:p>
-          <a:p>
-            <a:r>
-              <a:rPr sz="1100" b="0" dirty="0">
-                <a:solidFill>
-                  <a:srgbClr val="333333"/>
-                </a:solidFill>
-              </a:rPr>
-              <a:t>✓  CLR  Clearances  r=0.47</a:t>
-            </a:r>
-          </a:p>
-          <a:p>
-            <a:r>
-              <a:rPr sz="1100" b="0" dirty="0">
-                <a:solidFill>
-                  <a:srgbClr val="333333"/>
-                </a:solidFill>
-              </a:rPr>
-              <a:t>✓  DRB  Successful dribbles  r=0.46</a:t>
-            </a:r>
-          </a:p>
-          <a:p>
-            <a:r>
-              <a:rPr sz="1100" b="0" dirty="0">
-                <a:solidFill>
-                  <a:srgbClr val="333333"/>
-                </a:solidFill>
-              </a:rPr>
-              <a:t>✓  PATT  Passes into final third  r=0.42</a:t>
-            </a:r>
-          </a:p>
-          <a:p>
-            <a:r>
-              <a:rPr sz="1100" b="0" dirty="0">
-                <a:solidFill>
-                  <a:srgbClr val="333333"/>
-                </a:solidFill>
-              </a:rPr>
-              <a:t>·  SH  Shots  r=0.40</a:t>
-            </a:r>
-          </a:p>
-          <a:p>
-            <a:r>
-              <a:rPr sz="1100" b="0" dirty="0">
-                <a:solidFill>
-                  <a:srgbClr val="333333"/>
-                </a:solidFill>
-              </a:rPr>
-              <a:t>·  CFGP  Progressive carries  r=0.38</a:t>
-            </a:r>
-          </a:p>
-          <a:p>
-            <a:r>
-              <a:rPr sz="1100" b="0" dirty="0">
-                <a:solidFill>
-                  <a:srgbClr val="333333"/>
-                </a:solidFill>
-              </a:rPr>
-              <a:t>·  CRY  Carries  r=0.38</a:t>
-            </a:r>
-          </a:p>
-          <a:p>
-            <a:r>
-              <a:rPr sz="1100" b="0" dirty="0">
-                <a:solidFill>
-                  <a:srgbClr val="333333"/>
-                </a:solidFill>
-              </a:rPr>
-              <a:t>·  TAC  Tackles  r=0.34</a:t>
-            </a:r>
-          </a:p>
-          <a:p>
-            <a:r>
-              <a:rPr sz="1100" b="0" dirty="0">
-                <a:solidFill>
-                  <a:srgbClr val="333333"/>
-                </a:solidFill>
-              </a:rPr>
-              <a:t>·  XG  Non-pen </a:t>
-            </a:r>
-            <a:r>
-              <a:rPr sz="1100" b="0" dirty="0" err="1">
-                <a:solidFill>
-                  <a:srgbClr val="333333"/>
-                </a:solidFill>
-              </a:rPr>
-              <a:t>xG</a:t>
-            </a:r>
-            <a:r>
-              <a:rPr sz="1100" b="0" dirty="0">
-                <a:solidFill>
-                  <a:srgbClr val="333333"/>
-                </a:solidFill>
-              </a:rPr>
-              <a:t>  r=0.30</a:t>
-            </a:r>
-          </a:p>
-          <a:p>
-            <a:r>
-              <a:rPr sz="1100" b="0" dirty="0">
-                <a:solidFill>
-                  <a:srgbClr val="333333"/>
-                </a:solidFill>
-              </a:rPr>
-              <a:t>·  FLW  Fouls won  r=0.27</a:t>
-            </a:r>
-          </a:p>
-          <a:p>
-            <a:r>
-              <a:rPr sz="1100" b="0" dirty="0">
-                <a:solidFill>
-                  <a:srgbClr val="333333"/>
-                </a:solidFill>
-              </a:rPr>
-              <a:t>·  INT  Interceptions  r=0.20</a:t>
-            </a:r>
-          </a:p>
-          <a:p>
-            <a:r>
-              <a:rPr sz="1100" b="0" dirty="0">
-                <a:solidFill>
-                  <a:srgbClr val="333333"/>
-                </a:solidFill>
-              </a:rPr>
-              <a:t>·  XA  Expected assists  r=0.13</a:t>
-            </a:r>
-          </a:p>
-          <a:p>
-            <a:r>
-              <a:rPr sz="1100" b="0" dirty="0">
-                <a:solidFill>
-                  <a:srgbClr val="333333"/>
-                </a:solidFill>
-              </a:rPr>
-              <a:t>·  AER  Aerials won  r=0.12</a:t>
+            <a:r>
+              <a:rPr sz="1100">
+                <a:solidFill>
+                  <a:srgbClr val="333333"/>
+                </a:solidFill>
+              </a:rPr>
+              <a:t/>
+            </a:r>
+          </a:p>
+          <a:p>
+            <a:r>
+              <a:rPr sz="1100">
+                <a:solidFill>
+                  <a:srgbClr val="333333"/>
+                </a:solidFill>
+              </a:rPr>
+              <a:t>✓  Progressive passes (~10m+ toward goal)  r=0.74</a:t>
+            </a:r>
+          </a:p>
+          <a:p>
+            <a:r>
+              <a:rPr sz="1100">
+                <a:solidFill>
+                  <a:srgbClr val="333333"/>
+                </a:solidFill>
+              </a:rPr>
+              <a:t>✓  Dispossessed (inverted)  r=0.59</a:t>
+            </a:r>
+          </a:p>
+          <a:p>
+            <a:r>
+              <a:rPr sz="1100">
+                <a:solidFill>
+                  <a:srgbClr val="333333"/>
+                </a:solidFill>
+              </a:rPr>
+              <a:t>✓  Pressures  r=0.51</a:t>
+            </a:r>
+          </a:p>
+          <a:p>
+            <a:r>
+              <a:rPr sz="1100">
+                <a:solidFill>
+                  <a:srgbClr val="333333"/>
+                </a:solidFill>
+              </a:rPr>
+              <a:t>✓  Pass volume  r=0.49</a:t>
+            </a:r>
+          </a:p>
+          <a:p>
+            <a:r>
+              <a:rPr sz="1100">
+                <a:solidFill>
+                  <a:srgbClr val="333333"/>
+                </a:solidFill>
+              </a:rPr>
+              <a:t>✓  Clearances  r=0.47</a:t>
+            </a:r>
+          </a:p>
+          <a:p>
+            <a:r>
+              <a:rPr sz="1100">
+                <a:solidFill>
+                  <a:srgbClr val="333333"/>
+                </a:solidFill>
+              </a:rPr>
+              <a:t>✓  Successful dribbles  r=0.46</a:t>
+            </a:r>
+          </a:p>
+          <a:p>
+            <a:r>
+              <a:rPr sz="1100">
+                <a:solidFill>
+                  <a:srgbClr val="333333"/>
+                </a:solidFill>
+              </a:rPr>
+              <a:t>✓  Passes into final third  r=0.42</a:t>
+            </a:r>
+          </a:p>
+          <a:p>
+            <a:r>
+              <a:rPr sz="1100">
+                <a:solidFill>
+                  <a:srgbClr val="333333"/>
+                </a:solidFill>
+              </a:rPr>
+              <a:t>·  Shots  r=0.40 (out)</a:t>
+            </a:r>
+          </a:p>
+          <a:p>
+            <a:r>
+              <a:rPr sz="1100">
+                <a:solidFill>
+                  <a:srgbClr val="333333"/>
+                </a:solidFill>
+              </a:rPr>
+              <a:t>·  Progressive carries  r=0.38 (out)</a:t>
+            </a:r>
+          </a:p>
+          <a:p>
+            <a:r>
+              <a:rPr sz="1100">
+                <a:solidFill>
+                  <a:srgbClr val="333333"/>
+                </a:solidFill>
+              </a:rPr>
+              <a:t>·  Carries  r=0.38 (out)</a:t>
+            </a:r>
+          </a:p>
+          <a:p>
+            <a:r>
+              <a:rPr sz="1100">
+                <a:solidFill>
+                  <a:srgbClr val="333333"/>
+                </a:solidFill>
+              </a:rPr>
+              <a:t>·  Tackles  r=0.34 · Non-pen xG  r=0.30 · Fouls won  r=0.27</a:t>
+            </a:r>
+          </a:p>
+          <a:p>
+            <a:r>
+              <a:rPr sz="1100">
+                <a:solidFill>
+                  <a:srgbClr val="333333"/>
+                </a:solidFill>
+              </a:rPr>
+              <a:t>·  Interceptions  r=0.20 · Expected assists  r=0.13 · Aerials won  r=0.12</a:t>
             </a:r>
           </a:p>
         </p:txBody>
@@ -21337,21 +20774,8 @@
                     <a:bodyPr/>
                     <a:lstStyle/>
                     <a:p>
-                      <a:pPr>
-                        <a:defRPr sz="1200" b="1">
-                          <a:solidFill>
-                            <a:srgbClr val="FFFFFF"/>
-                          </a:solidFill>
-                          <a:latin typeface="Calibri"/>
-                        </a:defRPr>
-                      </a:pPr>
-                      <a:r>
-                        <a:rPr sz="1000" b="1" dirty="0">
-                          <a:solidFill>
-                            <a:srgbClr val="333333"/>
-                          </a:solidFill>
-                        </a:rPr>
-                        <a:t>Abbrev</a:t>
+                      <a:r>
+                        <a:t>Code</a:t>
                       </a:r>
                     </a:p>
                   </a:txBody>
@@ -21366,21 +20790,8 @@
                     <a:bodyPr/>
                     <a:lstStyle/>
                     <a:p>
-                      <a:pPr>
-                        <a:defRPr sz="1200" b="1">
-                          <a:solidFill>
-                            <a:srgbClr val="FFFFFF"/>
-                          </a:solidFill>
-                          <a:latin typeface="Calibri"/>
-                        </a:defRPr>
-                      </a:pPr>
-                      <a:r>
-                        <a:rPr sz="1000" b="1">
-                          <a:solidFill>
-                            <a:srgbClr val="333333"/>
-                          </a:solidFill>
-                        </a:rPr>
-                        <a:t>Metric</a:t>
+                      <a:r>
+                        <a:t>Metric (full name)</a:t>
                       </a:r>
                     </a:p>
                   </a:txBody>
@@ -21518,20 +20929,7 @@
                     <a:bodyPr/>
                     <a:lstStyle/>
                     <a:p>
-                      <a:pPr>
-                        <a:defRPr sz="1200" b="0">
-                          <a:solidFill>
-                            <a:srgbClr val="1C1C1C"/>
-                          </a:solidFill>
-                          <a:latin typeface="Calibri"/>
-                        </a:defRPr>
-                      </a:pPr>
-                      <a:r>
-                        <a:rPr sz="1000">
-                          <a:solidFill>
-                            <a:srgbClr val="333333"/>
-                          </a:solidFill>
-                        </a:rPr>
+                      <a:r>
                         <a:t>Progressive passes</a:t>
                       </a:r>
                     </a:p>
@@ -21670,21 +21068,8 @@
                     <a:bodyPr/>
                     <a:lstStyle/>
                     <a:p>
-                      <a:pPr>
-                        <a:defRPr sz="1200" b="0">
-                          <a:solidFill>
-                            <a:srgbClr val="1C1C1C"/>
-                          </a:solidFill>
-                          <a:latin typeface="Calibri"/>
-                        </a:defRPr>
-                      </a:pPr>
-                      <a:r>
-                        <a:rPr sz="1000">
-                          <a:solidFill>
-                            <a:srgbClr val="333333"/>
-                          </a:solidFill>
-                        </a:rPr>
-                        <a:t>Dispossessed (inv)</a:t>
+                      <a:r>
+                        <a:t>Dispossessed (inverted)</a:t>
                       </a:r>
                     </a:p>
                   </a:txBody>
@@ -21822,20 +21207,7 @@
                     <a:bodyPr/>
                     <a:lstStyle/>
                     <a:p>
-                      <a:pPr>
-                        <a:defRPr sz="1200" b="0">
-                          <a:solidFill>
-                            <a:srgbClr val="1C1C1C"/>
-                          </a:solidFill>
-                          <a:latin typeface="Calibri"/>
-                        </a:defRPr>
-                      </a:pPr>
-                      <a:r>
-                        <a:rPr sz="1000">
-                          <a:solidFill>
-                            <a:srgbClr val="333333"/>
-                          </a:solidFill>
-                        </a:rPr>
+                      <a:r>
                         <a:t>Pressures</a:t>
                       </a:r>
                     </a:p>
@@ -21974,20 +21346,7 @@
                     <a:bodyPr/>
                     <a:lstStyle/>
                     <a:p>
-                      <a:pPr>
-                        <a:defRPr sz="1200" b="0">
-                          <a:solidFill>
-                            <a:srgbClr val="1C1C1C"/>
-                          </a:solidFill>
-                          <a:latin typeface="Calibri"/>
-                        </a:defRPr>
-                      </a:pPr>
-                      <a:r>
-                        <a:rPr sz="1000">
-                          <a:solidFill>
-                            <a:srgbClr val="333333"/>
-                          </a:solidFill>
-                        </a:rPr>
+                      <a:r>
                         <a:t>Pass volume</a:t>
                       </a:r>
                     </a:p>
@@ -22126,20 +21485,7 @@
                     <a:bodyPr/>
                     <a:lstStyle/>
                     <a:p>
-                      <a:pPr>
-                        <a:defRPr sz="1200" b="0">
-                          <a:solidFill>
-                            <a:srgbClr val="1C1C1C"/>
-                          </a:solidFill>
-                          <a:latin typeface="Calibri"/>
-                        </a:defRPr>
-                      </a:pPr>
-                      <a:r>
-                        <a:rPr sz="1000">
-                          <a:solidFill>
-                            <a:srgbClr val="333333"/>
-                          </a:solidFill>
-                        </a:rPr>
+                      <a:r>
                         <a:t>Clearances</a:t>
                       </a:r>
                     </a:p>
@@ -22278,20 +21624,7 @@
                     <a:bodyPr/>
                     <a:lstStyle/>
                     <a:p>
-                      <a:pPr>
-                        <a:defRPr sz="1200" b="0">
-                          <a:solidFill>
-                            <a:srgbClr val="1C1C1C"/>
-                          </a:solidFill>
-                          <a:latin typeface="Calibri"/>
-                        </a:defRPr>
-                      </a:pPr>
-                      <a:r>
-                        <a:rPr sz="1000">
-                          <a:solidFill>
-                            <a:srgbClr val="333333"/>
-                          </a:solidFill>
-                        </a:rPr>
+                      <a:r>
                         <a:t>Successful dribbles</a:t>
                       </a:r>
                     </a:p>
@@ -22430,20 +21763,7 @@
                     <a:bodyPr/>
                     <a:lstStyle/>
                     <a:p>
-                      <a:pPr>
-                        <a:defRPr sz="1200" b="0">
-                          <a:solidFill>
-                            <a:srgbClr val="1C1C1C"/>
-                          </a:solidFill>
-                          <a:latin typeface="Calibri"/>
-                        </a:defRPr>
-                      </a:pPr>
-                      <a:r>
-                        <a:rPr sz="1000">
-                          <a:solidFill>
-                            <a:srgbClr val="333333"/>
-                          </a:solidFill>
-                        </a:rPr>
+                      <a:r>
                         <a:t>Passes into final third</a:t>
                       </a:r>
                     </a:p>
@@ -22582,20 +21902,7 @@
                     <a:bodyPr/>
                     <a:lstStyle/>
                     <a:p>
-                      <a:pPr>
-                        <a:defRPr sz="1200" b="0">
-                          <a:solidFill>
-                            <a:srgbClr val="1C1C1C"/>
-                          </a:solidFill>
-                          <a:latin typeface="Calibri"/>
-                        </a:defRPr>
-                      </a:pPr>
-                      <a:r>
-                        <a:rPr sz="1000">
-                          <a:solidFill>
-                            <a:srgbClr val="333333"/>
-                          </a:solidFill>
-                        </a:rPr>
+                      <a:r>
                         <a:t>Shots</a:t>
                       </a:r>
                     </a:p>
@@ -22734,20 +22041,7 @@
                     <a:bodyPr/>
                     <a:lstStyle/>
                     <a:p>
-                      <a:pPr>
-                        <a:defRPr sz="1200" b="0">
-                          <a:solidFill>
-                            <a:srgbClr val="1C1C1C"/>
-                          </a:solidFill>
-                          <a:latin typeface="Calibri"/>
-                        </a:defRPr>
-                      </a:pPr>
-                      <a:r>
-                        <a:rPr sz="1000">
-                          <a:solidFill>
-                            <a:srgbClr val="333333"/>
-                          </a:solidFill>
-                        </a:rPr>
+                      <a:r>
                         <a:t>Progressive carries</a:t>
                       </a:r>
                     </a:p>
@@ -22886,20 +22180,7 @@
                     <a:bodyPr/>
                     <a:lstStyle/>
                     <a:p>
-                      <a:pPr>
-                        <a:defRPr sz="1200" b="0">
-                          <a:solidFill>
-                            <a:srgbClr val="1C1C1C"/>
-                          </a:solidFill>
-                          <a:latin typeface="Calibri"/>
-                        </a:defRPr>
-                      </a:pPr>
-                      <a:r>
-                        <a:rPr sz="1000">
-                          <a:solidFill>
-                            <a:srgbClr val="333333"/>
-                          </a:solidFill>
-                        </a:rPr>
+                      <a:r>
                         <a:t>Carries</a:t>
                       </a:r>
                     </a:p>
@@ -23038,20 +22319,7 @@
                     <a:bodyPr/>
                     <a:lstStyle/>
                     <a:p>
-                      <a:pPr>
-                        <a:defRPr sz="1200" b="0">
-                          <a:solidFill>
-                            <a:srgbClr val="1C1C1C"/>
-                          </a:solidFill>
-                          <a:latin typeface="Calibri"/>
-                        </a:defRPr>
-                      </a:pPr>
-                      <a:r>
-                        <a:rPr sz="1000">
-                          <a:solidFill>
-                            <a:srgbClr val="333333"/>
-                          </a:solidFill>
-                        </a:rPr>
+                      <a:r>
                         <a:t>Tackles</a:t>
                       </a:r>
                     </a:p>
@@ -23190,21 +22458,8 @@
                     <a:bodyPr/>
                     <a:lstStyle/>
                     <a:p>
-                      <a:pPr>
-                        <a:defRPr sz="1200" b="0">
-                          <a:solidFill>
-                            <a:srgbClr val="1C1C1C"/>
-                          </a:solidFill>
-                          <a:latin typeface="Calibri"/>
-                        </a:defRPr>
-                      </a:pPr>
-                      <a:r>
-                        <a:rPr sz="1000">
-                          <a:solidFill>
-                            <a:srgbClr val="333333"/>
-                          </a:solidFill>
-                        </a:rPr>
-                        <a:t>Non-pen xG</a:t>
+                      <a:r>
+                        <a:t>Non-penalty expected goals</a:t>
                       </a:r>
                     </a:p>
                   </a:txBody>
@@ -23342,20 +22597,7 @@
                     <a:bodyPr/>
                     <a:lstStyle/>
                     <a:p>
-                      <a:pPr>
-                        <a:defRPr sz="1200" b="0">
-                          <a:solidFill>
-                            <a:srgbClr val="1C1C1C"/>
-                          </a:solidFill>
-                          <a:latin typeface="Calibri"/>
-                        </a:defRPr>
-                      </a:pPr>
-                      <a:r>
-                        <a:rPr sz="1000">
-                          <a:solidFill>
-                            <a:srgbClr val="333333"/>
-                          </a:solidFill>
-                        </a:rPr>
+                      <a:r>
                         <a:t>Fouls won</a:t>
                       </a:r>
                     </a:p>
@@ -23494,20 +22736,7 @@
                     <a:bodyPr/>
                     <a:lstStyle/>
                     <a:p>
-                      <a:pPr>
-                        <a:defRPr sz="1200" b="0">
-                          <a:solidFill>
-                            <a:srgbClr val="1C1C1C"/>
-                          </a:solidFill>
-                          <a:latin typeface="Calibri"/>
-                        </a:defRPr>
-                      </a:pPr>
-                      <a:r>
-                        <a:rPr sz="1000">
-                          <a:solidFill>
-                            <a:srgbClr val="333333"/>
-                          </a:solidFill>
-                        </a:rPr>
+                      <a:r>
                         <a:t>Interceptions</a:t>
                       </a:r>
                     </a:p>
@@ -23646,20 +22875,7 @@
                     <a:bodyPr/>
                     <a:lstStyle/>
                     <a:p>
-                      <a:pPr>
-                        <a:defRPr sz="1200" b="0">
-                          <a:solidFill>
-                            <a:srgbClr val="1C1C1C"/>
-                          </a:solidFill>
-                          <a:latin typeface="Calibri"/>
-                        </a:defRPr>
-                      </a:pPr>
-                      <a:r>
-                        <a:rPr sz="1000">
-                          <a:solidFill>
-                            <a:srgbClr val="333333"/>
-                          </a:solidFill>
-                        </a:rPr>
+                      <a:r>
                         <a:t>Expected assists</a:t>
                       </a:r>
                     </a:p>
@@ -23798,20 +23014,7 @@
                     <a:bodyPr/>
                     <a:lstStyle/>
                     <a:p>
-                      <a:pPr>
-                        <a:defRPr sz="1200" b="0">
-                          <a:solidFill>
-                            <a:srgbClr val="1C1C1C"/>
-                          </a:solidFill>
-                          <a:latin typeface="Calibri"/>
-                        </a:defRPr>
-                      </a:pPr>
-                      <a:r>
-                        <a:rPr sz="1000">
-                          <a:solidFill>
-                            <a:srgbClr val="333333"/>
-                          </a:solidFill>
-                        </a:rPr>
+                      <a:r>
                         <a:t>Aerials won</a:t>
                       </a:r>
                     </a:p>
@@ -24250,163 +23453,102 @@
               </a:spcAft>
             </a:pPr>
             <a:r>
-              <a:rPr sz="1600" b="1" dirty="0" err="1">
-                <a:solidFill>
-                  <a:srgbClr val="3D5A80"/>
-                </a:solidFill>
-                <a:latin typeface="Calibri"/>
-              </a:rPr>
-              <a:t>StatsBomb</a:t>
-            </a:r>
-            <a:r>
-              <a:rPr sz="1600" b="1" dirty="0">
-                <a:solidFill>
-                  <a:srgbClr val="3D5A80"/>
-                </a:solidFill>
-                <a:latin typeface="Calibri"/>
-              </a:rPr>
-              <a:t> shortlist (7)</a:t>
-            </a:r>
-          </a:p>
-          <a:p>
-            <a:pPr>
-              <a:spcAft>
-                <a:spcPts val="300"/>
-              </a:spcAft>
-            </a:pPr>
-            <a:r>
-              <a:rPr sz="1200" b="0" dirty="0">
-                <a:solidFill>
-                  <a:srgbClr val="555555"/>
-                </a:solidFill>
-                <a:latin typeface="Calibri"/>
+              <a:rPr sz="1100">
+                <a:solidFill>
+                  <a:srgbClr val="333333"/>
+                </a:solidFill>
+              </a:rPr>
+              <a:t>StatsBomb shortlist (7)</a:t>
+            </a:r>
+          </a:p>
+          <a:p>
+            <a:r>
+              <a:rPr sz="1100">
+                <a:solidFill>
+                  <a:srgbClr val="333333"/>
+                </a:solidFill>
               </a:rPr>
               <a:t>Stability r≥0.40 · redundancy |r|≥0.85 (passes kept)</a:t>
             </a:r>
           </a:p>
           <a:p>
-            <a:pPr>
-              <a:spcAft>
-                <a:spcPts val="300"/>
-              </a:spcAft>
-            </a:pPr>
-            <a:endParaRPr sz="1200" b="0" dirty="0">
-              <a:solidFill>
-                <a:srgbClr val="555555"/>
-              </a:solidFill>
-              <a:latin typeface="Calibri"/>
-            </a:endParaRPr>
-          </a:p>
-          <a:p>
-            <a:pPr>
-              <a:spcAft>
-                <a:spcPts val="300"/>
-              </a:spcAft>
-            </a:pPr>
-            <a:r>
-              <a:rPr sz="1300" b="0" dirty="0">
-                <a:solidFill>
-                  <a:srgbClr val="333333"/>
-                </a:solidFill>
-                <a:latin typeface="Calibri"/>
-              </a:rPr>
-              <a:t>PPC  Progressive passes  r=0.74</a:t>
-            </a:r>
-          </a:p>
-          <a:p>
-            <a:pPr>
-              <a:spcAft>
-                <a:spcPts val="300"/>
-              </a:spcAft>
-            </a:pPr>
-            <a:r>
-              <a:rPr sz="1300" b="0" dirty="0">
-                <a:solidFill>
-                  <a:srgbClr val="333333"/>
-                </a:solidFill>
-                <a:latin typeface="Calibri"/>
-              </a:rPr>
-              <a:t>DIS  Dispossessed (inv)  r=0.59</a:t>
-            </a:r>
-          </a:p>
-          <a:p>
-            <a:pPr>
-              <a:spcAft>
-                <a:spcPts val="300"/>
-              </a:spcAft>
-            </a:pPr>
-            <a:r>
-              <a:rPr sz="1300" b="0" dirty="0">
-                <a:solidFill>
-                  <a:srgbClr val="333333"/>
-                </a:solidFill>
-                <a:latin typeface="Calibri"/>
-              </a:rPr>
-              <a:t>PRS  Pressures  r=0.51</a:t>
-            </a:r>
-          </a:p>
-          <a:p>
-            <a:pPr>
-              <a:spcAft>
-                <a:spcPts val="300"/>
-              </a:spcAft>
-            </a:pPr>
-            <a:r>
-              <a:rPr sz="1300" b="0" dirty="0">
-                <a:solidFill>
-                  <a:srgbClr val="333333"/>
-                </a:solidFill>
-                <a:latin typeface="Calibri"/>
-              </a:rPr>
-              <a:t>PAS  Pass volume  r=0.49</a:t>
-            </a:r>
-          </a:p>
-          <a:p>
-            <a:pPr>
-              <a:spcAft>
-                <a:spcPts val="300"/>
-              </a:spcAft>
-            </a:pPr>
-            <a:r>
-              <a:rPr sz="1300" b="0" dirty="0">
-                <a:solidFill>
-                  <a:srgbClr val="333333"/>
-                </a:solidFill>
-                <a:latin typeface="Calibri"/>
-              </a:rPr>
-              <a:t>CLR  Clearances  r=0.47</a:t>
-            </a:r>
-          </a:p>
-          <a:p>
-            <a:pPr>
-              <a:spcAft>
-                <a:spcPts val="300"/>
-              </a:spcAft>
-            </a:pPr>
-            <a:r>
-              <a:rPr sz="1300" b="0" dirty="0">
-                <a:solidFill>
-                  <a:srgbClr val="333333"/>
-                </a:solidFill>
-                <a:latin typeface="Calibri"/>
-              </a:rPr>
-              <a:t>DRB  Dribbles completed  r=0.46</a:t>
-            </a:r>
-          </a:p>
-          <a:p>
-            <a:pPr>
-              <a:spcAft>
-                <a:spcPts val="300"/>
-              </a:spcAft>
-            </a:pPr>
-            <a:r>
-              <a:rPr sz="1300" b="0" dirty="0">
-                <a:solidFill>
-                  <a:srgbClr val="333333"/>
-                </a:solidFill>
-                <a:latin typeface="Calibri"/>
-              </a:rPr>
-              <a:t>PATT  Passes into final third  r=0.42</a:t>
+            <a:r>
+              <a:rPr sz="1100">
+                <a:solidFill>
+                  <a:srgbClr val="333333"/>
+                </a:solidFill>
+              </a:rPr>
+              <a:t/>
+            </a:r>
+          </a:p>
+          <a:p>
+            <a:r>
+              <a:rPr sz="1100">
+                <a:solidFill>
+                  <a:srgbClr val="333333"/>
+                </a:solidFill>
+              </a:rPr>
+              <a:t>Progressive passes  r=0.74</a:t>
+            </a:r>
+          </a:p>
+          <a:p>
+            <a:r>
+              <a:rPr sz="1100">
+                <a:solidFill>
+                  <a:srgbClr val="333333"/>
+                </a:solidFill>
+              </a:rPr>
+              <a:t>Dispossessed (inverted)  r=0.59</a:t>
+            </a:r>
+          </a:p>
+          <a:p>
+            <a:r>
+              <a:rPr sz="1100">
+                <a:solidFill>
+                  <a:srgbClr val="333333"/>
+                </a:solidFill>
+              </a:rPr>
+              <a:t>Pressures  r=0.51</a:t>
+            </a:r>
+          </a:p>
+          <a:p>
+            <a:r>
+              <a:rPr sz="1100">
+                <a:solidFill>
+                  <a:srgbClr val="333333"/>
+                </a:solidFill>
+              </a:rPr>
+              <a:t>Pass volume  r=0.49</a:t>
+            </a:r>
+          </a:p>
+          <a:p>
+            <a:r>
+              <a:rPr sz="1100">
+                <a:solidFill>
+                  <a:srgbClr val="333333"/>
+                </a:solidFill>
+              </a:rPr>
+              <a:t>Clearances  r=0.47</a:t>
+            </a:r>
+          </a:p>
+          <a:p>
+            <a:r>
+              <a:rPr sz="1100">
+                <a:solidFill>
+                  <a:srgbClr val="333333"/>
+                </a:solidFill>
+              </a:rPr>
+              <a:t>Successful dribbles  r=0.46</a:t>
+            </a:r>
+          </a:p>
+          <a:p>
+            <a:r>
+              <a:rPr sz="1100">
+                <a:solidFill>
+                  <a:srgbClr val="333333"/>
+                </a:solidFill>
+              </a:rPr>
+              <a:t>Passes into final third  r=0.42</a:t>
             </a:r>
           </a:p>
         </p:txBody>
@@ -24542,7 +23684,7 @@
               </a:spcAft>
             </a:pPr>
             <a:r>
-              <a:rPr sz="1100" b="0">
+              <a:rPr sz="1100">
                 <a:solidFill>
                   <a:srgbClr val="333333"/>
                 </a:solidFill>
@@ -24552,7 +23694,7 @@
           </a:p>
           <a:p>
             <a:r>
-              <a:rPr sz="1100" b="0">
+              <a:rPr sz="1100">
                 <a:solidFill>
                   <a:srgbClr val="333333"/>
                 </a:solidFill>
@@ -24562,7 +23704,7 @@
           </a:p>
           <a:p>
             <a:r>
-              <a:rPr sz="1100" b="0">
+              <a:rPr sz="1100">
                 <a:solidFill>
                   <a:srgbClr val="333333"/>
                 </a:solidFill>
@@ -24572,7 +23714,7 @@
           </a:p>
           <a:p>
             <a:r>
-              <a:rPr sz="1100" b="0">
+              <a:rPr sz="1100">
                 <a:solidFill>
                   <a:srgbClr val="333333"/>
                 </a:solidFill>
@@ -24582,12 +23724,12 @@
           </a:p>
           <a:p>
             <a:r>
-              <a:rPr sz="1100" b="0">
-                <a:solidFill>
-                  <a:srgbClr val="333333"/>
-                </a:solidFill>
-              </a:rPr>
-              <a:t>Top stability examples: DEFPE (0.91) · PRGC (0.81) · XG (0.80)</a:t>
+              <a:rPr sz="1100">
+                <a:solidFill>
+                  <a:srgbClr val="333333"/>
+                </a:solidFill>
+              </a:rPr>
+              <a:t>Top stability examples: Defensive penalty-area touches (0.91) · Progressive carries (0.81) · Expected goals (0.80)</a:t>
             </a:r>
           </a:p>
         </p:txBody>
@@ -24684,12 +23826,12 @@
           <a:p>
             <a:pPr algn="l"/>
             <a:r>
-              <a:rPr sz="1100" b="0">
-                <a:solidFill>
-                  <a:srgbClr val="333333"/>
-                </a:solidFill>
-              </a:rPr>
-              <a:t>XG (0.80)  ·  GLS (0.66)  ·  ATTSH (0.56)</a:t>
+              <a:rPr sz="1000">
+                <a:solidFill>
+                  <a:srgbClr val="333333"/>
+                </a:solidFill>
+              </a:rPr>
+              <a:t>Expected goals (0.80) · Goals (0.66) · Shots on target (0.56)</a:t>
             </a:r>
           </a:p>
         </p:txBody>
@@ -24752,12 +23894,12 @@
           <a:p>
             <a:pPr algn="l"/>
             <a:r>
-              <a:rPr sz="1100" b="0">
-                <a:solidFill>
-                  <a:srgbClr val="333333"/>
-                </a:solidFill>
-              </a:rPr>
-              <a:t>PRGC (0.81)  ·  PRGDI (0.79)  ·  KP (0.65)  ·  FINAL (0.62)  ·  CMPPE (0.64)  ·  CRSPA (0.59)  ·  CRS (0.68)</a:t>
+              <a:rPr sz="900">
+                <a:solidFill>
+                  <a:srgbClr val="333333"/>
+                </a:solidFill>
+              </a:rPr>
+              <a:t>Progressive carries (0.81) · Progressive carry distance (0.79) · Key passes (0.65) · Final-third passes (0.62) · Medium completion % (0.64) · Crosses into box (0.59) · Crosses (0.68)</a:t>
             </a:r>
           </a:p>
         </p:txBody>
@@ -24820,12 +23962,12 @@
           <a:p>
             <a:pPr algn="l"/>
             <a:r>
-              <a:rPr sz="1100" b="0">
-                <a:solidFill>
-                  <a:srgbClr val="333333"/>
-                </a:solidFill>
-              </a:rPr>
-              <a:t>PRGRR (0.60)  ·  ATT3R (0.54)  ·  SUCC (0.65)  ·  MIS (0.37)</a:t>
+              <a:rPr sz="900">
+                <a:solidFill>
+                  <a:srgbClr val="333333"/>
+                </a:solidFill>
+              </a:rPr>
+              <a:t>Progressive receives (0.60) · Attacking-third touches (0.54) · Successful take-ons (0.65) · Miscontrols (0.37)</a:t>
             </a:r>
           </a:p>
         </p:txBody>
@@ -24888,12 +24030,12 @@
           <a:p>
             <a:pPr algn="l"/>
             <a:r>
-              <a:rPr sz="1100" b="0">
-                <a:solidFill>
-                  <a:srgbClr val="333333"/>
-                </a:solidFill>
-              </a:rPr>
-              <a:t>DEFPE (0.91)  ·  CLR (0.67)  ·  TKLD (0.59)  ·  WON (0.42)  ·  SH (0.79)  ·  INT (0.57)  ·  LOST (0.42)  ·  WONPE (0.50)  ·  DEF3R (0.79)  ·  TKLPE (0.31)  ·  RECOV (0.40)</a:t>
+              <a:rPr sz="900">
+                <a:solidFill>
+                  <a:srgbClr val="333333"/>
+                </a:solidFill>
+              </a:rPr>
+              <a:t>Defensive box touches (0.91) · Clearances (0.67) · Tackled take-ons (0.59) · Aerials won (0.42) · Shot blocks (0.79) · Interceptions (0.57) · Aerials lost (0.42) · Aerial win % (0.50) · Defensive-third touches (0.79) · Tackle % (0.31) · Recoveries (0.40)</a:t>
             </a:r>
           </a:p>
         </p:txBody>
@@ -24921,12 +24063,12 @@
           <a:lstStyle/>
           <a:p>
             <a:r>
-              <a:rPr sz="1100" b="0">
-                <a:solidFill>
-                  <a:srgbClr val="333333"/>
-                </a:solidFill>
-              </a:rPr>
-              <a:t>FLD (0.53)</a:t>
+              <a:rPr sz="1000">
+                <a:solidFill>
+                  <a:srgbClr val="333333"/>
+                </a:solidFill>
+              </a:rPr>
+              <a:t>Fouls drawn (0.53)</a:t>
             </a:r>
           </a:p>
         </p:txBody>

</xml_diff>

<commit_message>
Tighten presentation wording for a non-soccer reader.
Lead with Success=, define open data and Bundesliga once, and rewrite minutes, selection bias, and Ligue 1 takeaways without insider jargon.

Co-authored-by: Cursor <cursoragent@cursor.com>
</commit_message>
<xml_diff>
--- a/bundesliga_transfer_traits.pptx
+++ b/bundesliga_transfer_traits.pptx
@@ -3240,49 +3240,12 @@
           <a:p>
             <a:pPr algn="l"/>
             <a:r>
-              <a:rPr sz="2800" b="1" dirty="0">
-                <a:solidFill>
-                  <a:srgbClr val="222222"/>
-                </a:solidFill>
-                <a:latin typeface="Georgia"/>
-              </a:rPr>
-              <a:t>Which traits</a:t>
-            </a:r>
-            <a:r>
-              <a:rPr lang="en-US" sz="2800" b="1" dirty="0">
-                <a:solidFill>
-                  <a:srgbClr val="222222"/>
-                </a:solidFill>
-                <a:latin typeface="Georgia"/>
-              </a:rPr>
-              <a:t> most accurately </a:t>
-            </a:r>
-            <a:r>
-              <a:rPr sz="2800" b="1" dirty="0">
-                <a:solidFill>
-                  <a:srgbClr val="222222"/>
-                </a:solidFill>
-                <a:latin typeface="Georgia"/>
-              </a:rPr>
-              <a:t>travel into the Bundesliga</a:t>
-            </a:r>
-            <a:r>
-              <a:rPr lang="en-US" sz="2800" b="1" dirty="0">
-                <a:solidFill>
-                  <a:srgbClr val="222222"/>
-                </a:solidFill>
-                <a:latin typeface="Georgia"/>
-              </a:rPr>
-              <a:t> from other professional soccer leagues</a:t>
-            </a:r>
-            <a:r>
-              <a:rPr sz="2800" b="1" dirty="0">
-                <a:solidFill>
-                  <a:srgbClr val="222222"/>
-                </a:solidFill>
-                <a:latin typeface="Georgia"/>
-              </a:rPr>
-              <a:t>?</a:t>
+              <a:rPr sz="2000" b="1">
+                <a:solidFill>
+                  <a:srgbClr val="333333"/>
+                </a:solidFill>
+              </a:rPr>
+              <a:t>Which traits most accurately travel into the Bundesliga (Germany’s top men’s soccer league) from other professional soccer leagues?</a:t>
             </a:r>
           </a:p>
         </p:txBody>
@@ -5583,7 +5546,7 @@
               </a:spcAft>
             </a:pPr>
             <a:r>
-              <a:rPr sz="1200" b="0">
+              <a:rPr sz="1100">
                 <a:solidFill>
                   <a:srgbClr val="333333"/>
                 </a:solidFill>
@@ -5593,17 +5556,27 @@
           </a:p>
           <a:p>
             <a:r>
-              <a:rPr sz="1200" b="0">
-                <a:solidFill>
-                  <a:srgbClr val="333333"/>
-                </a:solidFill>
-              </a:rPr>
-              <a:t>Primary success = Year 1 in Bundesliga minutes (more minutes = more playing time).</a:t>
-            </a:r>
-          </a:p>
-          <a:p>
-            <a:r>
-              <a:rPr sz="1200" b="0">
+              <a:rPr sz="1100">
+                <a:solidFill>
+                  <a:srgbClr val="333333"/>
+                </a:solidFill>
+              </a:rPr>
+              <a:t/>
+            </a:r>
+          </a:p>
+          <a:p>
+            <a:r>
+              <a:rPr sz="1100">
+                <a:solidFill>
+                  <a:srgbClr val="333333"/>
+                </a:solidFill>
+              </a:rPr>
+              <a:t>Success = Year 1 in Bundesliga minutes (more minutes = more playing time).</a:t>
+            </a:r>
+          </a:p>
+          <a:p>
+            <a:r>
+              <a:rPr sz="1100">
                 <a:solidFill>
                   <a:srgbClr val="333333"/>
                 </a:solidFill>
@@ -5613,7 +5586,7 @@
           </a:p>
           <a:p>
             <a:r>
-              <a:rPr sz="1200" b="0">
+              <a:rPr sz="1100">
                 <a:solidFill>
                   <a:srgbClr val="333333"/>
                 </a:solidFill>
@@ -5623,27 +5596,17 @@
           </a:p>
           <a:p>
             <a:r>
-              <a:rPr sz="1200" b="0">
-                <a:solidFill>
-                  <a:srgbClr val="333333"/>
-                </a:solidFill>
-              </a:rPr>
-              <a:t>Spearman ρ: rank players on a prior trait, rank them on Year 1 minutes, correlate the ranks. It does not assume minutes rise linearly — only that higher prior trait ranks tend to coincide with more minutes.</a:t>
-            </a:r>
-          </a:p>
-          <a:p>
-            <a:r>
-              <a:rPr sz="1200" b="0">
-                <a:solidFill>
-                  <a:srgbClr val="333333"/>
-                </a:solidFill>
-              </a:rPr>
-              <a:t>Minutes always depend on competition for the XI, injuries, and manager choice — we treat this as an associative open-data proxy, not a causal “deserved minutes” metric.</a:t>
-            </a:r>
-          </a:p>
-          <a:p>
-            <a:r>
-              <a:rPr sz="1200" b="0">
+              <a:rPr sz="1100">
+                <a:solidFill>
+                  <a:srgbClr val="333333"/>
+                </a:solidFill>
+              </a:rPr>
+              <a:t>Spearman ρ: sort players from high to low on a prior trait, sort them from high to low on Year 1 minutes, and measure how often those two orderings agree. A positive link means players who ranked higher on that trait before the move also tended to play more in their first Bundesliga season.</a:t>
+            </a:r>
+          </a:p>
+          <a:p>
+            <a:r>
+              <a:rPr sz="1100">
                 <a:solidFill>
                   <a:srgbClr val="333333"/>
                 </a:solidFill>
@@ -5653,12 +5616,32 @@
           </a:p>
           <a:p>
             <a:r>
-              <a:rPr sz="1200" b="0">
-                <a:solidFill>
-                  <a:srgbClr val="333333"/>
-                </a:solidFill>
-              </a:rPr>
-              <a:t>Then: feeder means + exploratory OLS.</a:t>
+              <a:rPr sz="1100">
+                <a:solidFill>
+                  <a:srgbClr val="333333"/>
+                </a:solidFill>
+              </a:rPr>
+              <a:t>Playing time still depends on the roster, injuries, and coaching choices — we use minutes as an observable open-data stand-in for “the club gave this player a real role,” not as proof that the player deserved those minutes.</a:t>
+            </a:r>
+          </a:p>
+          <a:p>
+            <a:r>
+              <a:rPr sz="1100">
+                <a:solidFill>
+                  <a:srgbClr val="333333"/>
+                </a:solidFill>
+              </a:rPr>
+              <a:t/>
+            </a:r>
+          </a:p>
+          <a:p>
+            <a:r>
+              <a:rPr sz="1100">
+                <a:solidFill>
+                  <a:srgbClr val="333333"/>
+                </a:solidFill>
+              </a:rPr>
+              <a:t>Then: feeder-league averages + exploratory OLS.</a:t>
             </a:r>
           </a:p>
         </p:txBody>
@@ -6495,52 +6478,112 @@
               </a:spcAft>
             </a:pPr>
             <a:r>
-              <a:rPr sz="1200" b="0">
-                <a:solidFill>
-                  <a:srgbClr val="333333"/>
-                </a:solidFill>
-              </a:rPr>
-              <a:t>Primary success marker: minutes played in the player’s first 1. Bundesliga season (“Year 1 in Bundesliga minutes”).</a:t>
-            </a:r>
-          </a:p>
-          <a:p>
-            <a:r>
-              <a:rPr sz="1200" b="0">
-                <a:solidFill>
-                  <a:srgbClr val="333333"/>
-                </a:solidFill>
-              </a:rPr>
-              <a:t>Plain English: did the club trust and use the inbound player (playing-time success)?</a:t>
-            </a:r>
-          </a:p>
-          <a:p>
-            <a:r>
-              <a:rPr sz="1200" b="0">
-                <a:solidFill>
-                  <a:srgbClr val="333333"/>
-                </a:solidFill>
-              </a:rPr>
-              <a:t>Also reported (secondary): Year 1 minutes percentile (rank in cohort) and stable-trait score (how strong the Year 1 profile looks on portable traits).</a:t>
-            </a:r>
-          </a:p>
-          <a:p>
-            <a:r>
-              <a:rPr sz="1200" b="0">
-                <a:solidFill>
-                  <a:srgbClr val="333333"/>
-                </a:solidFill>
-              </a:rPr>
-              <a:t>Trait &amp; league tests ask: which prior signals line up with more Year 1 minutes?</a:t>
-            </a:r>
-          </a:p>
-          <a:p>
-            <a:r>
-              <a:rPr sz="1200" b="0">
-                <a:solidFill>
-                  <a:srgbClr val="333333"/>
-                </a:solidFill>
-              </a:rPr>
-              <a:t>Regression Δ Year 1 minutes = estimated extra first-season minutes vs a reference league (Serie A), holding controls.</a:t>
+              <a:rPr sz="1200">
+                <a:solidFill>
+                  <a:srgbClr val="333333"/>
+                </a:solidFill>
+              </a:rPr>
+              <a:t>Primary success marker: minutes played in the player’s first Bundesliga season (“Year 1 in Bundesliga minutes”).</a:t>
+            </a:r>
+          </a:p>
+          <a:p>
+            <a:r>
+              <a:rPr sz="1200">
+                <a:solidFill>
+                  <a:srgbClr val="333333"/>
+                </a:solidFill>
+              </a:rPr>
+              <a:t/>
+            </a:r>
+          </a:p>
+          <a:p>
+            <a:r>
+              <a:rPr sz="1200">
+                <a:solidFill>
+                  <a:srgbClr val="333333"/>
+                </a:solidFill>
+              </a:rPr>
+              <a:t>Success means the club gave the inbound player playing time — not goals scored and not market value.</a:t>
+            </a:r>
+          </a:p>
+          <a:p>
+            <a:r>
+              <a:rPr sz="1200">
+                <a:solidFill>
+                  <a:srgbClr val="333333"/>
+                </a:solidFill>
+              </a:rPr>
+              <a:t/>
+            </a:r>
+          </a:p>
+          <a:p>
+            <a:r>
+              <a:rPr sz="1200">
+                <a:solidFill>
+                  <a:srgbClr val="333333"/>
+                </a:solidFill>
+              </a:rPr>
+              <a:t>Also reported (secondary):</a:t>
+            </a:r>
+          </a:p>
+          <a:p>
+            <a:r>
+              <a:rPr sz="1200">
+                <a:solidFill>
+                  <a:srgbClr val="333333"/>
+                </a:solidFill>
+              </a:rPr>
+              <a:t>• Year 1 minutes percentile — where that player’s minutes rank among peers in the study</a:t>
+            </a:r>
+          </a:p>
+          <a:p>
+            <a:r>
+              <a:rPr sz="1200">
+                <a:solidFill>
+                  <a:srgbClr val="333333"/>
+                </a:solidFill>
+              </a:rPr>
+              <a:t>• Stable-trait score — how strong the Year 1 profile looks on the portable traits</a:t>
+            </a:r>
+          </a:p>
+          <a:p>
+            <a:r>
+              <a:rPr sz="1200">
+                <a:solidFill>
+                  <a:srgbClr val="333333"/>
+                </a:solidFill>
+              </a:rPr>
+              <a:t/>
+            </a:r>
+          </a:p>
+          <a:p>
+            <a:r>
+              <a:rPr sz="1200">
+                <a:solidFill>
+                  <a:srgbClr val="333333"/>
+                </a:solidFill>
+              </a:rPr>
+              <a:t>Trait and league tests ask: which prior signals line up with more Year 1 minutes?</a:t>
+            </a:r>
+          </a:p>
+          <a:p>
+            <a:r>
+              <a:rPr sz="1200">
+                <a:solidFill>
+                  <a:srgbClr val="333333"/>
+                </a:solidFill>
+              </a:rPr>
+              <a:t/>
+            </a:r>
+          </a:p>
+          <a:p>
+            <a:r>
+              <a:rPr sz="1200">
+                <a:solidFill>
+                  <a:srgbClr val="333333"/>
+                </a:solidFill>
+              </a:rPr>
+              <a:t>Regression Δ Year 1 minutes = estimated extra first-season minutes versus a reference league (Serie A), holding other controls fixed.</a:t>
             </a:r>
           </a:p>
         </p:txBody>
@@ -10941,27 +10984,47 @@
               </a:spcAft>
             </a:pPr>
             <a:r>
-              <a:rPr sz="1100" b="0">
-                <a:solidFill>
-                  <a:srgbClr val="333333"/>
-                </a:solidFill>
-              </a:rPr>
-              <a:t>FBref N=329 (n≥8 players per league shown). StatsBomb N=96 — international priors are directional only.</a:t>
-            </a:r>
-          </a:p>
-          <a:p>
-            <a:r>
-              <a:rPr sz="1100" b="0">
-                <a:solidFill>
-                  <a:srgbClr val="333333"/>
-                </a:solidFill>
-              </a:rPr>
-              <a:t>Selection bias: these are players clubs already chose to sign from each feeder — not a random draw from that league. Means describe arrived cohorts, not “transfer from X causes minutes.”</a:t>
-            </a:r>
-          </a:p>
-          <a:p>
-            <a:r>
-              <a:rPr sz="1100" b="0">
+              <a:rPr sz="1100">
+                <a:solidFill>
+                  <a:srgbClr val="333333"/>
+                </a:solidFill>
+              </a:rPr>
+              <a:t>FBref N=329 (only leagues with ≥8 players shown). StatsBomb N=96 — international priors are directional only.</a:t>
+            </a:r>
+          </a:p>
+          <a:p>
+            <a:r>
+              <a:rPr sz="1100">
+                <a:solidFill>
+                  <a:srgbClr val="333333"/>
+                </a:solidFill>
+              </a:rPr>
+              <a:t/>
+            </a:r>
+          </a:p>
+          <a:p>
+            <a:r>
+              <a:rPr sz="1100">
+                <a:solidFill>
+                  <a:srgbClr val="333333"/>
+                </a:solidFill>
+              </a:rPr>
+              <a:t>How to read these averages: each row is players who already moved from that competition into the Bundesliga. Clubs chose whom to sign, so this is not a random sample of everyone in that league. Higher average Year 1 minutes describe the arrivals we observe — they do not prove that “coming from league X causes more minutes.”</a:t>
+            </a:r>
+          </a:p>
+          <a:p>
+            <a:r>
+              <a:rPr sz="1100">
+                <a:solidFill>
+                  <a:srgbClr val="333333"/>
+                </a:solidFill>
+              </a:rPr>
+              <a:t/>
+            </a:r>
+          </a:p>
+          <a:p>
+            <a:r>
+              <a:rPr sz="1100">
                 <a:solidFill>
                   <a:srgbClr val="333333"/>
                 </a:solidFill>
@@ -12211,27 +12274,17 @@
               </a:spcAft>
             </a:pPr>
             <a:r>
-              <a:rPr sz="1200" b="0">
-                <a:solidFill>
-                  <a:srgbClr val="333333"/>
-                </a:solidFill>
-              </a:rPr>
-              <a:t>Does this make sense?</a:t>
-            </a:r>
-          </a:p>
-          <a:p>
-            <a:r>
-              <a:rPr sz="1200" b="0">
-                <a:solidFill>
-                  <a:srgbClr val="333333"/>
-                </a:solidFill>
-              </a:rPr>
-              <a:t>Yes — Ligue 1’s +163 minutes vs Serie A looks large on the table but p≈0.38 (N=117): not statistically distinguishable from noise. Modest, non-significant league gaps are exactly what you’d expect if clubs already select carefully and league labels are weak once minutes/position are controlled.</a:t>
-            </a:r>
-          </a:p>
-          <a:p>
-            <a:r>
-              <a:rPr sz="1200" b="0">
+              <a:rPr sz="1100">
+                <a:solidFill>
+                  <a:srgbClr val="333333"/>
+                </a:solidFill>
+              </a:rPr>
+              <a:t>Does the Ligue 1 result make sense?</a:t>
+            </a:r>
+          </a:p>
+          <a:p>
+            <a:r>
+              <a:rPr sz="1100">
                 <a:solidFill>
                   <a:srgbClr val="333333"/>
                 </a:solidFill>
@@ -12241,37 +12294,17 @@
           </a:p>
           <a:p>
             <a:r>
-              <a:rPr sz="1200" b="0">
-                <a:solidFill>
-                  <a:srgbClr val="333333"/>
-                </a:solidFill>
-              </a:rPr>
-              <a:t>Adding traits raises R² (0.09 → 0.22): prior profile matters more than league label.</a:t>
-            </a:r>
-          </a:p>
-          <a:p>
-            <a:r>
-              <a:rPr sz="1200" b="0">
-                <a:solidFill>
-                  <a:srgbClr val="333333"/>
-                </a:solidFill>
-              </a:rPr>
-              <a:t>Model 3 holdout r≈0.35 = moderate match on held-out players (not a strong forecast).</a:t>
-            </a:r>
-          </a:p>
-          <a:p>
-            <a:r>
-              <a:rPr sz="1200" b="0">
-                <a:solidFill>
-                  <a:srgbClr val="333333"/>
-                </a:solidFill>
-              </a:rPr>
-              <a:t>Takeaway: scout portable traits + Year 1 minutes; league is a weak residual signal.</a:t>
-            </a:r>
-          </a:p>
-          <a:p>
-            <a:r>
-              <a:rPr sz="1200" b="0">
+              <a:rPr sz="1100">
+                <a:solidFill>
+                  <a:srgbClr val="333333"/>
+                </a:solidFill>
+              </a:rPr>
+              <a:t>The table shows Ligue 1 arrivals with about +163 Year 1 minutes versus Serie A. That gap looks large, but p≈0.38 with N=117 — under usual standards it is not distinguishable from chance. In plain terms: we do not have clear evidence that Ligue 1 labels alone buy more first-season playing time once prior minutes and position are held fixed.</a:t>
+            </a:r>
+          </a:p>
+          <a:p>
+            <a:r>
+              <a:rPr sz="1100">
                 <a:solidFill>
                   <a:srgbClr val="333333"/>
                 </a:solidFill>
@@ -12281,12 +12314,52 @@
           </a:p>
           <a:p>
             <a:r>
-              <a:rPr sz="1200" b="0">
-                <a:solidFill>
-                  <a:srgbClr val="333333"/>
-                </a:solidFill>
-              </a:rPr>
-              <a:t>Serie A = baseline (lowest mean Year 1 minutes among Big-5 feeders).</a:t>
+              <a:rPr sz="1100">
+                <a:solidFill>
+                  <a:srgbClr val="333333"/>
+                </a:solidFill>
+              </a:rPr>
+              <a:t>What does look clearer: adding prior trait percentiles raises R² from about 0.09 to 0.22, so the player’s prior profile explains Year 1 minutes better than the league name. The holdout check (correlation ≈0.35) is only moderate — useful as exploration, not a strong forecast.</a:t>
+            </a:r>
+          </a:p>
+          <a:p>
+            <a:r>
+              <a:rPr sz="1100">
+                <a:solidFill>
+                  <a:srgbClr val="333333"/>
+                </a:solidFill>
+              </a:rPr>
+              <a:t/>
+            </a:r>
+          </a:p>
+          <a:p>
+            <a:r>
+              <a:rPr sz="1100">
+                <a:solidFill>
+                  <a:srgbClr val="333333"/>
+                </a:solidFill>
+              </a:rPr>
+              <a:t>Takeaway: prioritize portable traits and Year 1 minutes; treat feeder-league labels as a weak leftover signal.</a:t>
+            </a:r>
+          </a:p>
+          <a:p>
+            <a:r>
+              <a:rPr sz="1100">
+                <a:solidFill>
+                  <a:srgbClr val="333333"/>
+                </a:solidFill>
+              </a:rPr>
+              <a:t/>
+            </a:r>
+          </a:p>
+          <a:p>
+            <a:r>
+              <a:rPr sz="1100">
+                <a:solidFill>
+                  <a:srgbClr val="333333"/>
+                </a:solidFill>
+              </a:rPr>
+              <a:t>Serie A = baseline (lowest mean Year 1 minutes among Big-5 feeders in this subset).</a:t>
             </a:r>
           </a:p>
         </p:txBody>
@@ -12695,12 +12768,22 @@
               </a:spcAft>
             </a:pPr>
             <a:r>
-              <a:rPr sz="1200" b="0">
-                <a:solidFill>
-                  <a:srgbClr val="555555"/>
-                </a:solidFill>
-              </a:rPr>
-              <a:t>Research question → data scrape from FBref and StatsBomb → stability thresholds → redundancy thresholds → HTML player explorer → team-based significance findings</a:t>
+              <a:rPr sz="1200">
+                <a:solidFill>
+                  <a:srgbClr val="333333"/>
+                </a:solidFill>
+              </a:rPr>
+              <a:t>Question</a:t>
+            </a:r>
+          </a:p>
+          <a:p>
+            <a:r>
+              <a:rPr sz="1200">
+                <a:solidFill>
+                  <a:srgbClr val="333333"/>
+                </a:solidFill>
+              </a:rPr>
+              <a:t>Which traits travel into the Bundesliga (Germany’s top men’s soccer league) — and which prior stats line up with Year 1 in Bundesliga minutes?</a:t>
             </a:r>
           </a:p>
         </p:txBody>
@@ -15773,7 +15856,7 @@
               </a:spcAft>
             </a:pPr>
             <a:r>
-              <a:rPr sz="1200" b="0">
+              <a:rPr sz="1200">
                 <a:solidFill>
                   <a:srgbClr val="333333"/>
                 </a:solidFill>
@@ -15783,27 +15866,57 @@
           </a:p>
           <a:p>
             <a:r>
-              <a:rPr sz="1200" b="0">
-                <a:solidFill>
-                  <a:srgbClr val="333333"/>
-                </a:solidFill>
-              </a:rPr>
-              <a:t>Pearson r = stability (does the prior ranking of a rate recur in Year 1 in Bundesliga?).</a:t>
-            </a:r>
-          </a:p>
-          <a:p>
-            <a:r>
-              <a:rPr sz="1200" b="0">
-                <a:solidFill>
-                  <a:srgbClr val="333333"/>
-                </a:solidFill>
-              </a:rPr>
-              <a:t>Spearman ρ = success — yes: success means more Year 1 in Bundesliga minutes (playing time), not goals or market value. We ask whether higher prior trait ranks line up with more first-season minutes.</a:t>
-            </a:r>
-          </a:p>
-          <a:p>
-            <a:r>
-              <a:rPr sz="1200" b="0">
+              <a:rPr sz="1200">
+                <a:solidFill>
+                  <a:srgbClr val="333333"/>
+                </a:solidFill>
+              </a:rPr>
+              <a:t/>
+            </a:r>
+          </a:p>
+          <a:p>
+            <a:r>
+              <a:rPr sz="1200">
+                <a:solidFill>
+                  <a:srgbClr val="333333"/>
+                </a:solidFill>
+              </a:rPr>
+              <a:t>Pearson r = stability: does a player’s ranking on a rate in the prior league tend to show up again in Year 1 in the Bundesliga?</a:t>
+            </a:r>
+          </a:p>
+          <a:p>
+            <a:r>
+              <a:rPr sz="1200">
+                <a:solidFill>
+                  <a:srgbClr val="333333"/>
+                </a:solidFill>
+              </a:rPr>
+              <a:t/>
+            </a:r>
+          </a:p>
+          <a:p>
+            <a:r>
+              <a:rPr sz="1200">
+                <a:solidFill>
+                  <a:srgbClr val="333333"/>
+                </a:solidFill>
+              </a:rPr>
+              <a:t>Success = more minutes in Year 1 in the Bundesliga (playing time), not goals or market value. Spearman ρ asks whether higher prior trait ranks line up with more first-season minutes.</a:t>
+            </a:r>
+          </a:p>
+          <a:p>
+            <a:r>
+              <a:rPr sz="1200">
+                <a:solidFill>
+                  <a:srgbClr val="333333"/>
+                </a:solidFill>
+              </a:rPr>
+              <a:t/>
+            </a:r>
+          </a:p>
+          <a:p>
+            <a:r>
+              <a:rPr sz="1200">
                 <a:solidFill>
                   <a:srgbClr val="333333"/>
                 </a:solidFill>
@@ -16967,7 +17080,7 @@
               </a:spcAft>
             </a:pPr>
             <a:r>
-              <a:rPr sz="1200" b="0">
+              <a:rPr sz="1100">
                 <a:solidFill>
                   <a:srgbClr val="333333"/>
                 </a:solidFill>
@@ -16977,7 +17090,7 @@
           </a:p>
           <a:p>
             <a:r>
-              <a:rPr sz="1200" b="0">
+              <a:rPr sz="1100">
                 <a:solidFill>
                   <a:srgbClr val="333333"/>
                 </a:solidFill>
@@ -16987,27 +17100,27 @@
           </a:p>
           <a:p>
             <a:r>
-              <a:rPr sz="1200" b="0">
-                <a:solidFill>
-                  <a:srgbClr val="333333"/>
-                </a:solidFill>
-              </a:rPr>
-              <a:t>Priors = any StatsBomb open men’s competition the player played before Bundesliga (club leagues and internationals — World Cup, Euro, Champions League, etc.).</a:t>
-            </a:r>
-          </a:p>
-          <a:p>
-            <a:r>
-              <a:rPr sz="1200" b="0">
-                <a:solidFill>
-                  <a:srgbClr val="333333"/>
-                </a:solidFill>
-              </a:rPr>
-              <a:t>1. Bundesliga open dumps: 2015/16 + 2023/24 only</a:t>
-            </a:r>
-          </a:p>
-          <a:p>
-            <a:r>
-              <a:rPr sz="1200" b="0">
+              <a:rPr sz="1100">
+                <a:solidFill>
+                  <a:srgbClr val="333333"/>
+                </a:solidFill>
+              </a:rPr>
+              <a:t>“Open” means free public StatsBomb match files anyone can download — not a paid data feed. Priors come from those open men’s competitions the player appeared in before the Bundesliga (club leagues and tournaments such as the World Cup, European Championship, and Champions League).</a:t>
+            </a:r>
+          </a:p>
+          <a:p>
+            <a:r>
+              <a:rPr sz="1100">
+                <a:solidFill>
+                  <a:srgbClr val="333333"/>
+                </a:solidFill>
+              </a:rPr>
+              <a:t>Bundesliga open dumps available: 2015/16 + 2023/24 only</a:t>
+            </a:r>
+          </a:p>
+          <a:p>
+            <a:r>
+              <a:rPr sz="1100">
                 <a:solidFill>
                   <a:srgbClr val="333333"/>
                 </a:solidFill>
@@ -17017,7 +17130,7 @@
           </a:p>
           <a:p>
             <a:r>
-              <a:rPr sz="1200" b="0">
+              <a:rPr sz="1100">
                 <a:solidFill>
                   <a:srgbClr val="333333"/>
                 </a:solidFill>
@@ -17027,7 +17140,7 @@
           </a:p>
           <a:p>
             <a:r>
-              <a:rPr sz="1200" b="0">
+              <a:rPr sz="1100">
                 <a:solidFill>
                   <a:srgbClr val="333333"/>
                 </a:solidFill>
@@ -17037,12 +17150,12 @@
           </a:p>
           <a:p>
             <a:r>
-              <a:rPr sz="1200" b="0">
-                <a:solidFill>
-                  <a:srgbClr val="333333"/>
-                </a:solidFill>
-              </a:rPr>
-              <a:t>Open-data thinness · two BL seasons · event check</a:t>
+              <a:rPr sz="1100">
+                <a:solidFill>
+                  <a:srgbClr val="333333"/>
+                </a:solidFill>
+              </a:rPr>
+              <a:t>Open-data thinness · two Bundesliga seasons · event check</a:t>
             </a:r>
           </a:p>
         </p:txBody>

</xml_diff>

<commit_message>
Remove leftover German Bundesliga duplicate on steps slide.
Co-authored-by: Cursor <cursoragent@cursor.com>
</commit_message>
<xml_diff>
--- a/bundesliga_transfer_traits.pptx
+++ b/bundesliga_transfer_traits.pptx
@@ -12868,7 +12868,7 @@
               </a:spcAft>
             </a:pPr>
             <a:r>
-              <a:rPr sz="1200" b="0">
+              <a:rPr sz="1200">
                 <a:solidFill>
                   <a:srgbClr val="333333"/>
                 </a:solidFill>
@@ -12878,12 +12878,12 @@
           </a:p>
           <a:p>
             <a:r>
-              <a:rPr sz="1200" b="0">
-                <a:solidFill>
-                  <a:srgbClr val="333333"/>
-                </a:solidFill>
-              </a:rPr>
-              <a:t>Which traits travel into the German Bundesliga — and which prior stats line up with Year 1 in Bundesliga minutes?</a:t>
+              <a:rPr sz="1200">
+                <a:solidFill>
+                  <a:srgbClr val="333333"/>
+                </a:solidFill>
+              </a:rPr>
+              <a:t>Which traits travel into the Bundesliga (Germany’s top men’s soccer league) — and which prior stats line up with Year 1 in Bundesliga minutes?</a:t>
             </a:r>
           </a:p>
         </p:txBody>

</xml_diff>

<commit_message>
Add short causal vs descriptive read on feeder averages.
Clarify that relative league means describe arrivals, not that coming from league X causes more Year 1 minutes.

Co-authored-by: Cursor <cursoragent@cursor.com>
</commit_message>
<xml_diff>
--- a/bundesliga_transfer_traits.pptx
+++ b/bundesliga_transfer_traits.pptx
@@ -11009,7 +11009,27 @@
                   <a:srgbClr val="333333"/>
                 </a:solidFill>
               </a:rPr>
-              <a:t>How to read these averages: each row is players who already moved from that competition into the Bundesliga. Clubs chose whom to sign, so this is not a random sample of everyone in that league. Higher average Year 1 minutes describe the arrivals we observe — they do not prove that “coming from league X causes more minutes.”</a:t>
+              <a:t>How to read these averages: each row is players who already moved from that competition into the Bundesliga. Clubs chose whom to sign, so this is not a random sample of everyone in that league.</a:t>
+            </a:r>
+          </a:p>
+          <a:p>
+            <a:r>
+              <a:rPr sz="1100">
+                <a:solidFill>
+                  <a:srgbClr val="333333"/>
+                </a:solidFill>
+              </a:rPr>
+              <a:t/>
+            </a:r>
+          </a:p>
+          <a:p>
+            <a:r>
+              <a:rPr sz="1100">
+                <a:solidFill>
+                  <a:srgbClr val="333333"/>
+                </a:solidFill>
+              </a:rPr>
+              <a:t>Short version: relative feeder averages are a useful scouting description of arrivals. They are not a causal claim that “coming from league X causes more minutes” or proves that league produces better transferable talent — that would need separating the league label from who gets signed and where they land. (The exploratory OLS later holds prior minutes / position / traits fixed and finds league gaps are modest.)</a:t>
             </a:r>
           </a:p>
           <a:p>

</xml_diff>

<commit_message>
Clarify secondary outcomes and next steps on success slide.
Spell out minutes percentile, stable-trait score, feeder-league averages, and exploratory OLS in plain language.

Co-authored-by: Cursor <cursoragent@cursor.com>
</commit_message>
<xml_diff>
--- a/bundesliga_transfer_traits.pptx
+++ b/bundesliga_transfer_traits.pptx
@@ -324,7 +324,7 @@
           <a:p>
             <a:fld id="{5BCAD085-E8A6-8845-BD4E-CB4CCA059FC4}" type="datetimeFigureOut">
               <a:rPr lang="en-US" smtClean="0"/>
-              <a:t>7/22/26</a:t>
+              <a:t>8/4/26</a:t>
             </a:fld>
             <a:endParaRPr lang="en-US"/>
           </a:p>
@@ -492,7 +492,7 @@
           <a:p>
             <a:fld id="{5BCAD085-E8A6-8845-BD4E-CB4CCA059FC4}" type="datetimeFigureOut">
               <a:rPr lang="en-US" smtClean="0"/>
-              <a:t>7/22/26</a:t>
+              <a:t>8/4/26</a:t>
             </a:fld>
             <a:endParaRPr lang="en-US"/>
           </a:p>
@@ -670,7 +670,7 @@
           <a:p>
             <a:fld id="{5BCAD085-E8A6-8845-BD4E-CB4CCA059FC4}" type="datetimeFigureOut">
               <a:rPr lang="en-US" smtClean="0"/>
-              <a:t>7/22/26</a:t>
+              <a:t>8/4/26</a:t>
             </a:fld>
             <a:endParaRPr lang="en-US"/>
           </a:p>
@@ -838,7 +838,7 @@
           <a:p>
             <a:fld id="{5BCAD085-E8A6-8845-BD4E-CB4CCA059FC4}" type="datetimeFigureOut">
               <a:rPr lang="en-US" smtClean="0"/>
-              <a:t>7/22/26</a:t>
+              <a:t>8/4/26</a:t>
             </a:fld>
             <a:endParaRPr lang="en-US"/>
           </a:p>
@@ -1083,7 +1083,7 @@
           <a:p>
             <a:fld id="{5BCAD085-E8A6-8845-BD4E-CB4CCA059FC4}" type="datetimeFigureOut">
               <a:rPr lang="en-US" smtClean="0"/>
-              <a:t>7/22/26</a:t>
+              <a:t>8/4/26</a:t>
             </a:fld>
             <a:endParaRPr lang="en-US"/>
           </a:p>
@@ -1368,7 +1368,7 @@
           <a:p>
             <a:fld id="{5BCAD085-E8A6-8845-BD4E-CB4CCA059FC4}" type="datetimeFigureOut">
               <a:rPr lang="en-US" smtClean="0"/>
-              <a:t>7/22/26</a:t>
+              <a:t>8/4/26</a:t>
             </a:fld>
             <a:endParaRPr lang="en-US"/>
           </a:p>
@@ -1787,7 +1787,7 @@
           <a:p>
             <a:fld id="{5BCAD085-E8A6-8845-BD4E-CB4CCA059FC4}" type="datetimeFigureOut">
               <a:rPr lang="en-US" smtClean="0"/>
-              <a:t>7/22/26</a:t>
+              <a:t>8/4/26</a:t>
             </a:fld>
             <a:endParaRPr lang="en-US"/>
           </a:p>
@@ -1904,7 +1904,7 @@
           <a:p>
             <a:fld id="{5BCAD085-E8A6-8845-BD4E-CB4CCA059FC4}" type="datetimeFigureOut">
               <a:rPr lang="en-US" smtClean="0"/>
-              <a:t>7/22/26</a:t>
+              <a:t>8/4/26</a:t>
             </a:fld>
             <a:endParaRPr lang="en-US"/>
           </a:p>
@@ -1999,7 +1999,7 @@
           <a:p>
             <a:fld id="{5BCAD085-E8A6-8845-BD4E-CB4CCA059FC4}" type="datetimeFigureOut">
               <a:rPr lang="en-US" smtClean="0"/>
-              <a:t>7/22/26</a:t>
+              <a:t>8/4/26</a:t>
             </a:fld>
             <a:endParaRPr lang="en-US"/>
           </a:p>
@@ -2274,7 +2274,7 @@
           <a:p>
             <a:fld id="{5BCAD085-E8A6-8845-BD4E-CB4CCA059FC4}" type="datetimeFigureOut">
               <a:rPr lang="en-US" smtClean="0"/>
-              <a:t>7/22/26</a:t>
+              <a:t>8/4/26</a:t>
             </a:fld>
             <a:endParaRPr lang="en-US"/>
           </a:p>
@@ -2526,7 +2526,7 @@
           <a:p>
             <a:fld id="{5BCAD085-E8A6-8845-BD4E-CB4CCA059FC4}" type="datetimeFigureOut">
               <a:rPr lang="en-US" smtClean="0"/>
-              <a:t>7/22/26</a:t>
+              <a:t>8/4/26</a:t>
             </a:fld>
             <a:endParaRPr lang="en-US"/>
           </a:p>
@@ -2737,7 +2737,7 @@
           <a:p>
             <a:fld id="{5BCAD085-E8A6-8845-BD4E-CB4CCA059FC4}" type="datetimeFigureOut">
               <a:rPr lang="en-US" smtClean="0"/>
-              <a:t>7/22/26</a:t>
+              <a:t>8/4/26</a:t>
             </a:fld>
             <a:endParaRPr lang="en-US"/>
           </a:p>
@@ -3240,12 +3240,49 @@
           <a:p>
             <a:pPr algn="l"/>
             <a:r>
-              <a:rPr sz="2000" b="1">
-                <a:solidFill>
-                  <a:srgbClr val="333333"/>
-                </a:solidFill>
-              </a:rPr>
-              <a:t>Which traits most accurately travel into the Bundesliga (Germany’s top men’s soccer league) from other professional soccer leagues?</a:t>
+              <a:rPr sz="2800" b="1" dirty="0">
+                <a:solidFill>
+                  <a:srgbClr val="222222"/>
+                </a:solidFill>
+                <a:latin typeface="Georgia"/>
+              </a:rPr>
+              <a:t>Which traits</a:t>
+            </a:r>
+            <a:r>
+              <a:rPr lang="en-US" sz="2800" b="1" dirty="0">
+                <a:solidFill>
+                  <a:srgbClr val="222222"/>
+                </a:solidFill>
+                <a:latin typeface="Georgia"/>
+              </a:rPr>
+              <a:t> most accurately </a:t>
+            </a:r>
+            <a:r>
+              <a:rPr sz="2800" b="1" dirty="0">
+                <a:solidFill>
+                  <a:srgbClr val="222222"/>
+                </a:solidFill>
+                <a:latin typeface="Georgia"/>
+              </a:rPr>
+              <a:t>travel into the Bundesliga</a:t>
+            </a:r>
+            <a:r>
+              <a:rPr lang="en-US" sz="2800" b="1" dirty="0">
+                <a:solidFill>
+                  <a:srgbClr val="222222"/>
+                </a:solidFill>
+                <a:latin typeface="Georgia"/>
+              </a:rPr>
+              <a:t> from other professional soccer leagues</a:t>
+            </a:r>
+            <a:r>
+              <a:rPr sz="2800" b="1" dirty="0">
+                <a:solidFill>
+                  <a:srgbClr val="222222"/>
+                </a:solidFill>
+                <a:latin typeface="Georgia"/>
+              </a:rPr>
+              <a:t>?</a:t>
             </a:r>
           </a:p>
         </p:txBody>
@@ -3628,7 +3665,7 @@
         <p:spPr>
           <a:xfrm>
             <a:off x="6812280" y="1508760"/>
-            <a:ext cx="4663440" cy="320040"/>
+            <a:ext cx="4663440" cy="2123658"/>
           </a:xfrm>
           <a:prstGeom prst="rect">
             <a:avLst/>
@@ -3643,7 +3680,7 @@
           <a:p>
             <a:pPr algn="l"/>
             <a:r>
-              <a:rPr sz="1200" b="0">
+              <a:rPr sz="1200" b="0" dirty="0">
                 <a:solidFill>
                   <a:srgbClr val="333333"/>
                 </a:solidFill>
@@ -3653,26 +3690,14 @@
           </a:p>
           <a:p>
             <a:r>
-              <a:rPr sz="1200" b="0">
-                <a:solidFill>
-                  <a:srgbClr val="333333"/>
-                </a:solidFill>
-              </a:rPr>
-              <a:t>Blue = Year 1 in Bundesliga · red dotted = prior · dashed = 50th-percentile Bundesliga peer · grey = 90th-percentile Bundesliga peer.</a:t>
-            </a:r>
-          </a:p>
-          <a:p>
-            <a:r>
-              <a:rPr sz="1200" b="0">
-                <a:solidFill>
-                  <a:srgbClr val="333333"/>
-                </a:solidFill>
-              </a:rPr>
-              <a:t>Numbers are percentiles 0–100 vs position peers.</a:t>
-            </a:r>
-          </a:p>
-          <a:p>
-            <a:endParaRPr sz="1200" b="0">
+              <a:rPr sz="1200" b="0" dirty="0">
+                <a:solidFill>
+                  <a:srgbClr val="333333"/>
+                </a:solidFill>
+              </a:rPr>
+              <a:t>Blue = Year 1 in Bundesliga </a:t>
+            </a:r>
+            <a:endParaRPr lang="en-US" sz="1200" b="0" dirty="0">
               <a:solidFill>
                 <a:srgbClr val="333333"/>
               </a:solidFill>
@@ -3680,17 +3705,145 @@
           </a:p>
           <a:p>
             <a:r>
-              <a:rPr sz="1200" b="0">
-                <a:solidFill>
-                  <a:srgbClr val="333333"/>
-                </a:solidFill>
-              </a:rPr>
-              <a:t>Explorer: StatsBomb N=96 · 7 traits · FBref N=329 · 32 traits.</a:t>
-            </a:r>
-          </a:p>
-          <a:p>
-            <a:r>
-              <a:rPr sz="1200" b="0">
+              <a:rPr lang="en-US" sz="1200" dirty="0">
+                <a:solidFill>
+                  <a:srgbClr val="333333"/>
+                </a:solidFill>
+              </a:rPr>
+              <a:t>R</a:t>
+            </a:r>
+            <a:r>
+              <a:rPr sz="1200" b="0" dirty="0">
+                <a:solidFill>
+                  <a:srgbClr val="333333"/>
+                </a:solidFill>
+              </a:rPr>
+              <a:t>ed dotted = prior </a:t>
+            </a:r>
+            <a:r>
+              <a:rPr lang="en-US" sz="1200" b="0" dirty="0">
+                <a:solidFill>
+                  <a:srgbClr val="333333"/>
+                </a:solidFill>
+              </a:rPr>
+              <a:t>Season</a:t>
+            </a:r>
+          </a:p>
+          <a:p>
+            <a:r>
+              <a:rPr lang="en-US" sz="1200" dirty="0">
+                <a:solidFill>
+                  <a:srgbClr val="333333"/>
+                </a:solidFill>
+              </a:rPr>
+              <a:t>D</a:t>
+            </a:r>
+            <a:r>
+              <a:rPr sz="1200" b="0" dirty="0">
+                <a:solidFill>
+                  <a:srgbClr val="333333"/>
+                </a:solidFill>
+              </a:rPr>
+              <a:t>ashed = 50th-percentile Bundesliga peer </a:t>
+            </a:r>
+            <a:endParaRPr lang="en-US" sz="1200" dirty="0">
+              <a:solidFill>
+                <a:srgbClr val="333333"/>
+              </a:solidFill>
+            </a:endParaRPr>
+          </a:p>
+          <a:p>
+            <a:r>
+              <a:rPr lang="en-US" sz="1200" b="0" dirty="0">
+                <a:solidFill>
+                  <a:srgbClr val="333333"/>
+                </a:solidFill>
+              </a:rPr>
+              <a:t>G</a:t>
+            </a:r>
+            <a:r>
+              <a:rPr sz="1200" b="0" dirty="0">
+                <a:solidFill>
+                  <a:srgbClr val="333333"/>
+                </a:solidFill>
+              </a:rPr>
+              <a:t>rey = 90th-percentile Bundesliga peer</a:t>
+            </a:r>
+            <a:endParaRPr lang="en-US" sz="1200" b="0" dirty="0">
+              <a:solidFill>
+                <a:srgbClr val="333333"/>
+              </a:solidFill>
+            </a:endParaRPr>
+          </a:p>
+          <a:p>
+            <a:endParaRPr sz="1200" b="0" dirty="0">
+              <a:solidFill>
+                <a:srgbClr val="333333"/>
+              </a:solidFill>
+            </a:endParaRPr>
+          </a:p>
+          <a:p>
+            <a:r>
+              <a:rPr sz="1200" b="0" dirty="0">
+                <a:solidFill>
+                  <a:srgbClr val="333333"/>
+                </a:solidFill>
+              </a:rPr>
+              <a:t>Numbers are percentiles 0–100 vs position peers.</a:t>
+            </a:r>
+          </a:p>
+          <a:p>
+            <a:endParaRPr sz="1200" b="0" dirty="0">
+              <a:solidFill>
+                <a:srgbClr val="333333"/>
+              </a:solidFill>
+            </a:endParaRPr>
+          </a:p>
+          <a:p>
+            <a:r>
+              <a:rPr sz="1200" b="0" dirty="0">
+                <a:solidFill>
+                  <a:srgbClr val="333333"/>
+                </a:solidFill>
+              </a:rPr>
+              <a:t>Explorer: </a:t>
+            </a:r>
+            <a:r>
+              <a:rPr sz="1200" b="0" dirty="0" err="1">
+                <a:solidFill>
+                  <a:srgbClr val="333333"/>
+                </a:solidFill>
+              </a:rPr>
+              <a:t>StatsBomb</a:t>
+            </a:r>
+            <a:r>
+              <a:rPr sz="1200" b="0" dirty="0">
+                <a:solidFill>
+                  <a:srgbClr val="333333"/>
+                </a:solidFill>
+              </a:rPr>
+              <a:t> N=96 · 7 traits · </a:t>
+            </a:r>
+            <a:r>
+              <a:rPr sz="1200" b="0" dirty="0" err="1">
+                <a:solidFill>
+                  <a:srgbClr val="333333"/>
+                </a:solidFill>
+              </a:rPr>
+              <a:t>FBref</a:t>
+            </a:r>
+            <a:r>
+              <a:rPr sz="1200" b="0" dirty="0">
+                <a:solidFill>
+                  <a:srgbClr val="333333"/>
+                </a:solidFill>
+              </a:rPr>
+              <a:t> N=329 · 32 traits.</a:t>
+            </a:r>
+          </a:p>
+          <a:p>
+            <a:r>
+              <a:rPr sz="1200" b="0" dirty="0">
                 <a:solidFill>
                   <a:srgbClr val="333333"/>
                 </a:solidFill>
@@ -3835,34 +3988,28 @@
             </a:r>
           </a:p>
           <a:p>
+            <a:endParaRPr sz="1300" b="0">
+              <a:solidFill>
+                <a:srgbClr val="333333"/>
+              </a:solidFill>
+            </a:endParaRPr>
+          </a:p>
+          <a:p>
             <a:r>
               <a:rPr sz="1300" b="0">
                 <a:solidFill>
                   <a:srgbClr val="333333"/>
                 </a:solidFill>
               </a:rPr>
-              <a:t/>
-            </a:r>
-          </a:p>
-          <a:p>
-            <a:r>
-              <a:rPr sz="1300" b="0">
-                <a:solidFill>
-                  <a:srgbClr val="333333"/>
-                </a:solidFill>
-              </a:rPr>
               <a:t>One number that answers: in Year 1 in Bundesliga, how strong is this player on the portable (shortlisted) traits — vs peers at their position?</a:t>
             </a:r>
           </a:p>
           <a:p>
-            <a:r>
-              <a:rPr sz="1300" b="0">
-                <a:solidFill>
-                  <a:srgbClr val="333333"/>
-                </a:solidFill>
-              </a:rPr>
-              <a:t/>
-            </a:r>
+            <a:endParaRPr sz="1300" b="0">
+              <a:solidFill>
+                <a:srgbClr val="333333"/>
+              </a:solidFill>
+            </a:endParaRPr>
           </a:p>
           <a:p>
             <a:r>
@@ -5581,7 +5728,7 @@
                   <a:srgbClr val="333333"/>
                 </a:solidFill>
               </a:rPr>
-              <a:t>Also reported: Year 1 minutes percentile · stable-trait score (secondary).</a:t>
+              <a:t/>
             </a:r>
           </a:p>
           <a:p>
@@ -5591,6 +5738,36 @@
                   <a:srgbClr val="333333"/>
                 </a:solidFill>
               </a:rPr>
+              <a:t>We also show two supporting numbers (not the main success definition):</a:t>
+            </a:r>
+          </a:p>
+          <a:p>
+            <a:r>
+              <a:rPr sz="1100">
+                <a:solidFill>
+                  <a:srgbClr val="333333"/>
+                </a:solidFill>
+              </a:rPr>
+              <a:t>• Year 1 minutes percentile — where this player’s first-season minutes rank among other inbound players in the study (0–100).</a:t>
+            </a:r>
+          </a:p>
+          <a:p>
+            <a:r>
+              <a:rPr sz="1100">
+                <a:solidFill>
+                  <a:srgbClr val="333333"/>
+                </a:solidFill>
+              </a:rPr>
+              <a:t>• Stable-trait score — how strong their Year 1 profile looks on the portable traits we kept (average percentile vs position peers).</a:t>
+            </a:r>
+          </a:p>
+          <a:p>
+            <a:r>
+              <a:rPr sz="1100">
+                <a:solidFill>
+                  <a:srgbClr val="333333"/>
+                </a:solidFill>
+              </a:rPr>
               <a:t/>
             </a:r>
           </a:p>
@@ -5621,7 +5798,7 @@
                   <a:srgbClr val="333333"/>
                 </a:solidFill>
               </a:rPr>
-              <a:t>Playing time still depends on the roster, injuries, and coaching choices — we use minutes as an observable open-data stand-in for “the club gave this player a real role,” not as proof that the player deserved those minutes.</a:t>
+              <a:t>Playing time still depends on the roster, injuries, and coaching choices — we use minutes as an observable open-data stand-in for “the club gave this player a real role,” not as proof that the player should have gotten those minutes.</a:t>
             </a:r>
           </a:p>
           <a:p>
@@ -5641,7 +5818,7 @@
                   <a:srgbClr val="333333"/>
                 </a:solidFill>
               </a:rPr>
-              <a:t>Then: feeder-league averages + exploratory OLS.</a:t>
+              <a:t>Next steps on later slides: compare average Year 1 minutes by prior league (feeder-league averages), then run exploratory ordinary least squares (OLS) regression with controls.</a:t>
             </a:r>
           </a:p>
         </p:txBody>
@@ -6478,112 +6655,52 @@
               </a:spcAft>
             </a:pPr>
             <a:r>
-              <a:rPr sz="1200">
-                <a:solidFill>
-                  <a:srgbClr val="333333"/>
-                </a:solidFill>
-              </a:rPr>
-              <a:t>Primary success marker: minutes played in the player’s first Bundesliga season (“Year 1 in Bundesliga minutes”).</a:t>
-            </a:r>
-          </a:p>
-          <a:p>
-            <a:r>
-              <a:rPr sz="1200">
-                <a:solidFill>
-                  <a:srgbClr val="333333"/>
-                </a:solidFill>
-              </a:rPr>
-              <a:t/>
-            </a:r>
-          </a:p>
-          <a:p>
-            <a:r>
-              <a:rPr sz="1200">
-                <a:solidFill>
-                  <a:srgbClr val="333333"/>
-                </a:solidFill>
-              </a:rPr>
-              <a:t>Success means the club gave the inbound player playing time — not goals scored and not market value.</a:t>
-            </a:r>
-          </a:p>
-          <a:p>
-            <a:r>
-              <a:rPr sz="1200">
-                <a:solidFill>
-                  <a:srgbClr val="333333"/>
-                </a:solidFill>
-              </a:rPr>
-              <a:t/>
-            </a:r>
-          </a:p>
-          <a:p>
-            <a:r>
-              <a:rPr sz="1200">
-                <a:solidFill>
-                  <a:srgbClr val="333333"/>
-                </a:solidFill>
-              </a:rPr>
-              <a:t>Also reported (secondary):</a:t>
-            </a:r>
-          </a:p>
-          <a:p>
-            <a:r>
-              <a:rPr sz="1200">
-                <a:solidFill>
-                  <a:srgbClr val="333333"/>
-                </a:solidFill>
-              </a:rPr>
-              <a:t>• Year 1 minutes percentile — where that player’s minutes rank among peers in the study</a:t>
-            </a:r>
-          </a:p>
-          <a:p>
-            <a:r>
-              <a:rPr sz="1200">
-                <a:solidFill>
-                  <a:srgbClr val="333333"/>
-                </a:solidFill>
-              </a:rPr>
-              <a:t>• Stable-trait score — how strong the Year 1 profile looks on the portable traits</a:t>
-            </a:r>
-          </a:p>
-          <a:p>
-            <a:r>
-              <a:rPr sz="1200">
-                <a:solidFill>
-                  <a:srgbClr val="333333"/>
-                </a:solidFill>
-              </a:rPr>
-              <a:t/>
-            </a:r>
-          </a:p>
-          <a:p>
-            <a:r>
-              <a:rPr sz="1200">
-                <a:solidFill>
-                  <a:srgbClr val="333333"/>
-                </a:solidFill>
-              </a:rPr>
-              <a:t>Trait and league tests ask: which prior signals line up with more Year 1 minutes?</a:t>
-            </a:r>
-          </a:p>
-          <a:p>
-            <a:r>
-              <a:rPr sz="1200">
-                <a:solidFill>
-                  <a:srgbClr val="333333"/>
-                </a:solidFill>
-              </a:rPr>
-              <a:t/>
-            </a:r>
-          </a:p>
-          <a:p>
-            <a:r>
-              <a:rPr sz="1200">
-                <a:solidFill>
-                  <a:srgbClr val="333333"/>
-                </a:solidFill>
-              </a:rPr>
-              <a:t>Regression Δ Year 1 minutes = estimated extra first-season minutes versus a reference league (Serie A), holding other controls fixed.</a:t>
+              <a:rPr sz="1200" b="0">
+                <a:solidFill>
+                  <a:srgbClr val="333333"/>
+                </a:solidFill>
+              </a:rPr>
+              <a:t>Primary success marker: minutes played in the player’s first 1. Bundesliga season (“Year 1 in Bundesliga minutes”).</a:t>
+            </a:r>
+          </a:p>
+          <a:p>
+            <a:r>
+              <a:rPr sz="1200" b="0">
+                <a:solidFill>
+                  <a:srgbClr val="333333"/>
+                </a:solidFill>
+              </a:rPr>
+              <a:t>Plain English: did the club trust and use the inbound player (playing-time success)?</a:t>
+            </a:r>
+          </a:p>
+          <a:p>
+            <a:r>
+              <a:rPr sz="1200" b="0">
+                <a:solidFill>
+                  <a:srgbClr val="333333"/>
+                </a:solidFill>
+              </a:rPr>
+              <a:t>Also reported (secondary): Year 1 minutes percentile (rank in cohort) and stable-trait score (how strong the Year 1 profile looks on portable traits).</a:t>
+            </a:r>
+          </a:p>
+          <a:p>
+            <a:r>
+              <a:rPr sz="1200" b="0">
+                <a:solidFill>
+                  <a:srgbClr val="333333"/>
+                </a:solidFill>
+              </a:rPr>
+              <a:t>Trait &amp; league tests ask: which prior signals line up with more Year 1 minutes?</a:t>
+            </a:r>
+          </a:p>
+          <a:p>
+            <a:r>
+              <a:rPr sz="1200" b="0">
+                <a:solidFill>
+                  <a:srgbClr val="333333"/>
+                </a:solidFill>
+              </a:rPr>
+              <a:t>Regression Δ Year 1 minutes = estimated extra first-season minutes vs a reference league (Serie A), holding controls.</a:t>
             </a:r>
           </a:p>
         </p:txBody>
@@ -6912,7 +7029,7 @@
               </a:spcAft>
             </a:pPr>
             <a:r>
-              <a:rPr sz="1100">
+              <a:rPr sz="1200" b="0">
                 <a:solidFill>
                   <a:srgbClr val="333333"/>
                 </a:solidFill>
@@ -6922,7 +7039,7 @@
           </a:p>
           <a:p>
             <a:r>
-              <a:rPr sz="1100">
+              <a:rPr sz="1200" b="0">
                 <a:solidFill>
                   <a:srgbClr val="333333"/>
                 </a:solidFill>
@@ -6931,83 +7048,80 @@
             </a:r>
           </a:p>
           <a:p>
-            <a:r>
-              <a:rPr sz="1100">
-                <a:solidFill>
-                  <a:srgbClr val="333333"/>
-                </a:solidFill>
-              </a:rPr>
-              <a:t/>
-            </a:r>
-          </a:p>
-          <a:p>
-            <a:r>
-              <a:rPr sz="1100">
-                <a:solidFill>
-                  <a:srgbClr val="333333"/>
-                </a:solidFill>
-              </a:rPr>
-              <a:t>Pressures  ρ=-0.28  p=0.006</a:t>
-            </a:r>
-          </a:p>
-          <a:p>
-            <a:r>
-              <a:rPr sz="1100">
-                <a:solidFill>
-                  <a:srgbClr val="333333"/>
-                </a:solidFill>
-              </a:rPr>
-              <a:t>Successful dribbles  ρ=-0.17  p=0.090</a:t>
-            </a:r>
-          </a:p>
-          <a:p>
-            <a:r>
-              <a:rPr sz="1100">
-                <a:solidFill>
-                  <a:srgbClr val="333333"/>
-                </a:solidFill>
-              </a:rPr>
-              <a:t>Progressive passes  ρ=+0.16  p=0.112</a:t>
-            </a:r>
-          </a:p>
-          <a:p>
-            <a:r>
-              <a:rPr sz="1100">
-                <a:solidFill>
-                  <a:srgbClr val="333333"/>
-                </a:solidFill>
-              </a:rPr>
-              <a:t>Dispossessed (inverted)  ρ=+0.14  p=0.185</a:t>
-            </a:r>
-          </a:p>
-          <a:p>
-            <a:r>
-              <a:rPr sz="1100">
-                <a:solidFill>
-                  <a:srgbClr val="333333"/>
-                </a:solidFill>
-              </a:rPr>
-              <a:t>Passes into final third  ρ=-0.11  p=0.280</a:t>
-            </a:r>
-          </a:p>
-          <a:p>
-            <a:r>
-              <a:rPr sz="1100">
-                <a:solidFill>
-                  <a:srgbClr val="333333"/>
-                </a:solidFill>
-              </a:rPr>
-              <a:t>Clearances  ρ=-0.07  p=0.473</a:t>
-            </a:r>
-          </a:p>
-          <a:p>
-            <a:r>
-              <a:rPr sz="1100">
-                <a:solidFill>
-                  <a:srgbClr val="333333"/>
-                </a:solidFill>
-              </a:rPr>
-              <a:t>Pass volume  ρ=+0.00  p=0.980</a:t>
+            <a:endParaRPr sz="1200" b="0">
+              <a:solidFill>
+                <a:srgbClr val="333333"/>
+              </a:solidFill>
+            </a:endParaRPr>
+          </a:p>
+          <a:p>
+            <a:r>
+              <a:rPr sz="1200" b="0">
+                <a:solidFill>
+                  <a:srgbClr val="333333"/>
+                </a:solidFill>
+              </a:rPr>
+              <a:t>PRS  ρ=-0.28  p=0.006</a:t>
+            </a:r>
+          </a:p>
+          <a:p>
+            <a:r>
+              <a:rPr sz="1200" b="0">
+                <a:solidFill>
+                  <a:srgbClr val="333333"/>
+                </a:solidFill>
+              </a:rPr>
+              <a:t>DRB  ρ=-0.17  p=0.090</a:t>
+            </a:r>
+          </a:p>
+          <a:p>
+            <a:r>
+              <a:rPr sz="1200" b="0">
+                <a:solidFill>
+                  <a:srgbClr val="333333"/>
+                </a:solidFill>
+              </a:rPr>
+              <a:t>PPC  ρ=+0.16  p=0.112</a:t>
+            </a:r>
+          </a:p>
+          <a:p>
+            <a:r>
+              <a:rPr sz="1200" b="0">
+                <a:solidFill>
+                  <a:srgbClr val="333333"/>
+                </a:solidFill>
+              </a:rPr>
+              <a:t>DIS  ρ=+0.14  p=0.185</a:t>
+            </a:r>
+          </a:p>
+          <a:p>
+            <a:r>
+              <a:rPr sz="1200" b="0">
+                <a:solidFill>
+                  <a:srgbClr val="333333"/>
+                </a:solidFill>
+              </a:rPr>
+              <a:t>PATT  ρ=-0.11  p=0.280</a:t>
+            </a:r>
+          </a:p>
+          <a:p>
+            <a:r>
+              <a:rPr sz="1200" b="0">
+                <a:solidFill>
+                  <a:srgbClr val="333333"/>
+                </a:solidFill>
+              </a:rPr>
+              <a:t>CLR  ρ=-0.07  p=0.473</a:t>
+            </a:r>
+          </a:p>
+          <a:p>
+            <a:r>
+              <a:rPr sz="1200" b="0">
+                <a:solidFill>
+                  <a:srgbClr val="333333"/>
+                </a:solidFill>
+              </a:rPr>
+              <a:t>PAS  ρ=+0.00  p=0.980</a:t>
             </a:r>
           </a:p>
         </p:txBody>
@@ -7159,8 +7273,21 @@
                     <a:bodyPr/>
                     <a:lstStyle/>
                     <a:p>
-                      <a:r>
-                        <a:t>Pressures</a:t>
+                      <a:pPr>
+                        <a:defRPr sz="1000" b="0">
+                          <a:solidFill>
+                            <a:srgbClr val="1C1C1C"/>
+                          </a:solidFill>
+                          <a:latin typeface="Calibri"/>
+                        </a:defRPr>
+                      </a:pPr>
+                      <a:r>
+                        <a:rPr sz="1000">
+                          <a:solidFill>
+                            <a:srgbClr val="333333"/>
+                          </a:solidFill>
+                        </a:rPr>
+                        <a:t>PRS — Pressures</a:t>
                       </a:r>
                     </a:p>
                   </a:txBody>
@@ -7240,8 +7367,21 @@
                     <a:bodyPr/>
                     <a:lstStyle/>
                     <a:p>
-                      <a:r>
-                        <a:t>Successful dribbles</a:t>
+                      <a:pPr>
+                        <a:defRPr sz="1000" b="0">
+                          <a:solidFill>
+                            <a:srgbClr val="1C1C1C"/>
+                          </a:solidFill>
+                          <a:latin typeface="Calibri"/>
+                        </a:defRPr>
+                      </a:pPr>
+                      <a:r>
+                        <a:rPr sz="1000">
+                          <a:solidFill>
+                            <a:srgbClr val="333333"/>
+                          </a:solidFill>
+                        </a:rPr>
+                        <a:t>DRB — Successful dribbles</a:t>
                       </a:r>
                     </a:p>
                   </a:txBody>
@@ -7321,8 +7461,21 @@
                     <a:bodyPr/>
                     <a:lstStyle/>
                     <a:p>
-                      <a:r>
-                        <a:t>Progressive passes</a:t>
+                      <a:pPr>
+                        <a:defRPr sz="1000" b="0">
+                          <a:solidFill>
+                            <a:srgbClr val="1C1C1C"/>
+                          </a:solidFill>
+                          <a:latin typeface="Calibri"/>
+                        </a:defRPr>
+                      </a:pPr>
+                      <a:r>
+                        <a:rPr sz="1000">
+                          <a:solidFill>
+                            <a:srgbClr val="333333"/>
+                          </a:solidFill>
+                        </a:rPr>
+                        <a:t>PPC — Progressive passes</a:t>
                       </a:r>
                     </a:p>
                   </a:txBody>
@@ -7402,9 +7555,23 @@
                     <a:bodyPr/>
                     <a:lstStyle/>
                     <a:p>
-                      <a:r>
-                        <a:t>Dispossessed (inverted)</a:t>
-                      </a:r>
+                      <a:pPr>
+                        <a:defRPr sz="1000" b="0">
+                          <a:solidFill>
+                            <a:srgbClr val="1C1C1C"/>
+                          </a:solidFill>
+                          <a:latin typeface="Calibri"/>
+                        </a:defRPr>
+                      </a:pPr>
+                      <a:r>
+                        <a:rPr sz="1000" dirty="0">
+                          <a:solidFill>
+                            <a:srgbClr val="333333"/>
+                          </a:solidFill>
+                        </a:rPr>
+                        <a:t>DIS — Dispossessed (inv)</a:t>
+                      </a:r>
+                      <a:endParaRPr dirty="0"/>
                     </a:p>
                   </a:txBody>
                   <a:tcPr>
@@ -7483,8 +7650,21 @@
                     <a:bodyPr/>
                     <a:lstStyle/>
                     <a:p>
-                      <a:r>
-                        <a:t>Passes into final third</a:t>
+                      <a:pPr>
+                        <a:defRPr sz="1000" b="0">
+                          <a:solidFill>
+                            <a:srgbClr val="1C1C1C"/>
+                          </a:solidFill>
+                          <a:latin typeface="Calibri"/>
+                        </a:defRPr>
+                      </a:pPr>
+                      <a:r>
+                        <a:rPr sz="1000">
+                          <a:solidFill>
+                            <a:srgbClr val="333333"/>
+                          </a:solidFill>
+                        </a:rPr>
+                        <a:t>PATT — Passes into final third</a:t>
                       </a:r>
                     </a:p>
                   </a:txBody>
@@ -7564,8 +7744,21 @@
                     <a:bodyPr/>
                     <a:lstStyle/>
                     <a:p>
-                      <a:r>
-                        <a:t>Clearances</a:t>
+                      <a:pPr>
+                        <a:defRPr sz="1000" b="0">
+                          <a:solidFill>
+                            <a:srgbClr val="1C1C1C"/>
+                          </a:solidFill>
+                          <a:latin typeface="Calibri"/>
+                        </a:defRPr>
+                      </a:pPr>
+                      <a:r>
+                        <a:rPr sz="1000">
+                          <a:solidFill>
+                            <a:srgbClr val="333333"/>
+                          </a:solidFill>
+                        </a:rPr>
+                        <a:t>CLR — Clearances</a:t>
                       </a:r>
                     </a:p>
                   </a:txBody>
@@ -7671,7 +7864,7 @@
               </a:spcAft>
             </a:pPr>
             <a:r>
-              <a:rPr sz="1100">
+              <a:rPr sz="1200" b="0">
                 <a:solidFill>
                   <a:srgbClr val="333333"/>
                 </a:solidFill>
@@ -7681,102 +7874,106 @@
           </a:p>
           <a:p>
             <a:r>
-              <a:rPr sz="1100">
-                <a:solidFill>
-                  <a:srgbClr val="333333"/>
-                </a:solidFill>
-              </a:rPr>
-              <a:t>prior percentile → Year 1 in Bundesliga minutes</a:t>
-            </a:r>
-          </a:p>
-          <a:p>
-            <a:r>
-              <a:rPr sz="1100">
-                <a:solidFill>
-                  <a:srgbClr val="333333"/>
-                </a:solidFill>
-              </a:rPr>
-              <a:t/>
-            </a:r>
-          </a:p>
-          <a:p>
-            <a:r>
-              <a:rPr sz="1100">
-                <a:solidFill>
-                  <a:srgbClr val="333333"/>
-                </a:solidFill>
-              </a:rPr>
-              <a:t>Final-third passes  ρ=+0.30  p=0.005 *</a:t>
-            </a:r>
-          </a:p>
-          <a:p>
-            <a:r>
-              <a:rPr sz="1100">
-                <a:solidFill>
-                  <a:srgbClr val="333333"/>
-                </a:solidFill>
-              </a:rPr>
-              <a:t>Shot blocks  ρ=+0.27  p=0.011 *</a:t>
-            </a:r>
-          </a:p>
-          <a:p>
-            <a:r>
-              <a:rPr sz="1100">
-                <a:solidFill>
-                  <a:srgbClr val="333333"/>
-                </a:solidFill>
-              </a:rPr>
-              <a:t>Progressive carry distance  ρ=+0.24  p=0.025 *</a:t>
-            </a:r>
-          </a:p>
-          <a:p>
-            <a:r>
-              <a:rPr sz="1100">
-                <a:solidFill>
-                  <a:srgbClr val="333333"/>
-                </a:solidFill>
-              </a:rPr>
-              <a:t>Tackled take-ons  ρ=+0.23  p=0.030 *</a:t>
-            </a:r>
-          </a:p>
-          <a:p>
-            <a:r>
-              <a:rPr sz="1100">
-                <a:solidFill>
-                  <a:srgbClr val="333333"/>
-                </a:solidFill>
-              </a:rPr>
-              <a:t>Long pass attempts  ρ=+0.22  p=0.036 *</a:t>
-            </a:r>
-          </a:p>
-          <a:p>
-            <a:r>
-              <a:rPr sz="1100">
-                <a:solidFill>
-                  <a:srgbClr val="333333"/>
-                </a:solidFill>
-              </a:rPr>
-              <a:t>Defensive-third touches  ρ=+0.22  p=0.039 *</a:t>
-            </a:r>
-          </a:p>
-          <a:p>
-            <a:r>
-              <a:rPr sz="1100">
-                <a:solidFill>
-                  <a:srgbClr val="333333"/>
-                </a:solidFill>
-              </a:rPr>
-              <a:t/>
-            </a:r>
-          </a:p>
-          <a:p>
-            <a:r>
-              <a:rPr sz="1100">
-                <a:solidFill>
-                  <a:srgbClr val="333333"/>
-                </a:solidFill>
-              </a:rPr>
-              <a:t>* p&lt;0.05  ·  Final-third passes, shot blocks, progressive carry distance lead.</a:t>
+              <a:rPr sz="1200" b="0">
+                <a:solidFill>
+                  <a:srgbClr val="333333"/>
+                </a:solidFill>
+              </a:rPr>
+              <a:t>prior %ile → Year 1 in Bundesliga minutes</a:t>
+            </a:r>
+          </a:p>
+          <a:p>
+            <a:endParaRPr sz="1200" b="0">
+              <a:solidFill>
+                <a:srgbClr val="333333"/>
+              </a:solidFill>
+            </a:endParaRPr>
+          </a:p>
+          <a:p>
+            <a:r>
+              <a:rPr sz="1200" b="0">
+                <a:solidFill>
+                  <a:srgbClr val="333333"/>
+                </a:solidFill>
+              </a:rPr>
+              <a:t>FINAL  ρ=+0.30  p=0.005 *</a:t>
+            </a:r>
+          </a:p>
+          <a:p>
+            <a:r>
+              <a:rPr sz="1200" b="0">
+                <a:solidFill>
+                  <a:srgbClr val="333333"/>
+                </a:solidFill>
+              </a:rPr>
+              <a:t>SH  ρ=+0.27  p=0.011 *</a:t>
+            </a:r>
+          </a:p>
+          <a:p>
+            <a:r>
+              <a:rPr sz="1200" b="0">
+                <a:solidFill>
+                  <a:srgbClr val="333333"/>
+                </a:solidFill>
+              </a:rPr>
+              <a:t>PRGDI  ρ=+0.24  p=0.025 *</a:t>
+            </a:r>
+          </a:p>
+          <a:p>
+            <a:r>
+              <a:rPr sz="1200" b="0">
+                <a:solidFill>
+                  <a:srgbClr val="333333"/>
+                </a:solidFill>
+              </a:rPr>
+              <a:t>TKLD  ρ=+0.23  p=0.030 *</a:t>
+            </a:r>
+          </a:p>
+          <a:p>
+            <a:r>
+              <a:rPr sz="1200" b="0">
+                <a:solidFill>
+                  <a:srgbClr val="333333"/>
+                </a:solidFill>
+              </a:rPr>
+              <a:t>ATTLO  ρ=+0.22  p=0.036 *</a:t>
+            </a:r>
+          </a:p>
+          <a:p>
+            <a:r>
+              <a:rPr sz="1200" b="0">
+                <a:solidFill>
+                  <a:srgbClr val="333333"/>
+                </a:solidFill>
+              </a:rPr>
+              <a:t>DEF3R  ρ=+0.22  p=0.039 *</a:t>
+            </a:r>
+          </a:p>
+          <a:p>
+            <a:endParaRPr sz="1200" b="0">
+              <a:solidFill>
+                <a:srgbClr val="333333"/>
+              </a:solidFill>
+            </a:endParaRPr>
+          </a:p>
+          <a:p>
+            <a:r>
+              <a:rPr sz="1200" b="0">
+                <a:solidFill>
+                  <a:srgbClr val="333333"/>
+                </a:solidFill>
+              </a:rPr>
+              <a:t>* p&lt;0.05  ·  Final Third, shot blocks, progressive distance lead.</a:t>
+            </a:r>
+          </a:p>
+          <a:p>
+            <a:r>
+              <a:rPr sz="1200" b="0">
+                <a:solidFill>
+                  <a:srgbClr val="333333"/>
+                </a:solidFill>
+              </a:rPr>
+              <a:t>Metric codes: see Glossary slide.</a:t>
             </a:r>
           </a:p>
         </p:txBody>
@@ -7928,8 +8125,21 @@
                     <a:bodyPr/>
                     <a:lstStyle/>
                     <a:p>
-                      <a:r>
-                        <a:t>Final-third passes*</a:t>
+                      <a:pPr>
+                        <a:defRPr sz="1000" b="0">
+                          <a:solidFill>
+                            <a:srgbClr val="1C1C1C"/>
+                          </a:solidFill>
+                          <a:latin typeface="Calibri"/>
+                        </a:defRPr>
+                      </a:pPr>
+                      <a:r>
+                        <a:rPr sz="1000">
+                          <a:solidFill>
+                            <a:srgbClr val="333333"/>
+                          </a:solidFill>
+                        </a:rPr>
+                        <a:t>FINAL — Final Third*</a:t>
                       </a:r>
                     </a:p>
                   </a:txBody>
@@ -8009,8 +8219,21 @@
                     <a:bodyPr/>
                     <a:lstStyle/>
                     <a:p>
-                      <a:r>
-                        <a:t>Shot blocks*</a:t>
+                      <a:pPr>
+                        <a:defRPr sz="1000" b="0">
+                          <a:solidFill>
+                            <a:srgbClr val="1C1C1C"/>
+                          </a:solidFill>
+                          <a:latin typeface="Calibri"/>
+                        </a:defRPr>
+                      </a:pPr>
+                      <a:r>
+                        <a:rPr sz="1000">
+                          <a:solidFill>
+                            <a:srgbClr val="333333"/>
+                          </a:solidFill>
+                        </a:rPr>
+                        <a:t>SH — Shot Blocks*</a:t>
                       </a:r>
                     </a:p>
                   </a:txBody>
@@ -8090,8 +8313,21 @@
                     <a:bodyPr/>
                     <a:lstStyle/>
                     <a:p>
-                      <a:r>
-                        <a:t>Progressive carry distance*</a:t>
+                      <a:pPr>
+                        <a:defRPr sz="1000" b="0">
+                          <a:solidFill>
+                            <a:srgbClr val="1C1C1C"/>
+                          </a:solidFill>
+                          <a:latin typeface="Calibri"/>
+                        </a:defRPr>
+                      </a:pPr>
+                      <a:r>
+                        <a:rPr sz="1000" dirty="0">
+                          <a:solidFill>
+                            <a:srgbClr val="333333"/>
+                          </a:solidFill>
+                        </a:rPr>
+                        <a:t>PRGDI — PrgDist Total*</a:t>
                       </a:r>
                     </a:p>
                   </a:txBody>
@@ -8171,8 +8407,21 @@
                     <a:bodyPr/>
                     <a:lstStyle/>
                     <a:p>
-                      <a:r>
-                        <a:t>Tackled take-ons*</a:t>
+                      <a:pPr>
+                        <a:defRPr sz="1000" b="0">
+                          <a:solidFill>
+                            <a:srgbClr val="1C1C1C"/>
+                          </a:solidFill>
+                          <a:latin typeface="Calibri"/>
+                        </a:defRPr>
+                      </a:pPr>
+                      <a:r>
+                        <a:rPr sz="1000">
+                          <a:solidFill>
+                            <a:srgbClr val="333333"/>
+                          </a:solidFill>
+                        </a:rPr>
+                        <a:t>TKLD — Tkld Take*</a:t>
                       </a:r>
                     </a:p>
                   </a:txBody>
@@ -8252,8 +8501,21 @@
                     <a:bodyPr/>
                     <a:lstStyle/>
                     <a:p>
-                      <a:r>
-                        <a:t>Long pass attempts*</a:t>
+                      <a:pPr>
+                        <a:defRPr sz="1000" b="0">
+                          <a:solidFill>
+                            <a:srgbClr val="1C1C1C"/>
+                          </a:solidFill>
+                          <a:latin typeface="Calibri"/>
+                        </a:defRPr>
+                      </a:pPr>
+                      <a:r>
+                        <a:rPr sz="1000">
+                          <a:solidFill>
+                            <a:srgbClr val="333333"/>
+                          </a:solidFill>
+                        </a:rPr>
+                        <a:t>ATTLO — Att Long*</a:t>
                       </a:r>
                     </a:p>
                   </a:txBody>
@@ -8333,8 +8595,21 @@
                     <a:bodyPr/>
                     <a:lstStyle/>
                     <a:p>
-                      <a:r>
-                        <a:t>Defensive-third touches*</a:t>
+                      <a:pPr>
+                        <a:defRPr sz="1000" b="0">
+                          <a:solidFill>
+                            <a:srgbClr val="1C1C1C"/>
+                          </a:solidFill>
+                          <a:latin typeface="Calibri"/>
+                        </a:defRPr>
+                      </a:pPr>
+                      <a:r>
+                        <a:rPr sz="1000">
+                          <a:solidFill>
+                            <a:srgbClr val="333333"/>
+                          </a:solidFill>
+                        </a:rPr>
+                        <a:t>DEF3R — Def 3rd Touches*</a:t>
                       </a:r>
                     </a:p>
                   </a:txBody>
@@ -8414,8 +8689,16 @@
                     <a:bodyPr/>
                     <a:lstStyle/>
                     <a:p>
-                      <a:r>
-                        <a:t>Miscontrols (carries)</a:t>
+                      <a:pPr>
+                        <a:defRPr sz="1000" b="0">
+                          <a:solidFill>
+                            <a:srgbClr val="1C1C1C"/>
+                          </a:solidFill>
+                          <a:latin typeface="Calibri"/>
+                        </a:defRPr>
+                      </a:pPr>
+                      <a:r>
+                        <a:t>MIS — Mis Carries</a:t>
                       </a:r>
                     </a:p>
                   </a:txBody>
@@ -8485,9 +8768,23 @@
                     <a:bodyPr/>
                     <a:lstStyle/>
                     <a:p>
-                      <a:r>
-                        <a:t>Clearances</a:t>
-                      </a:r>
+                      <a:pPr>
+                        <a:defRPr sz="1000" b="0">
+                          <a:solidFill>
+                            <a:srgbClr val="1C1C1C"/>
+                          </a:solidFill>
+                          <a:latin typeface="Calibri"/>
+                        </a:defRPr>
+                      </a:pPr>
+                      <a:r>
+                        <a:rPr dirty="0"/>
+                        <a:t>CLR — Cl</a:t>
+                      </a:r>
+                      <a:r>
+                        <a:rPr lang="en-US" dirty="0"/>
+                        <a:t>earances</a:t>
+                      </a:r>
+                      <a:endParaRPr dirty="0"/>
                     </a:p>
                   </a:txBody>
                   <a:tcPr>
@@ -10984,67 +11281,27 @@
               </a:spcAft>
             </a:pPr>
             <a:r>
-              <a:rPr sz="1100">
-                <a:solidFill>
-                  <a:srgbClr val="333333"/>
-                </a:solidFill>
-              </a:rPr>
-              <a:t>FBref N=329 (only leagues with ≥8 players shown). StatsBomb N=96 — international priors are directional only.</a:t>
-            </a:r>
-          </a:p>
-          <a:p>
-            <a:r>
-              <a:rPr sz="1100">
-                <a:solidFill>
-                  <a:srgbClr val="333333"/>
-                </a:solidFill>
-              </a:rPr>
-              <a:t/>
-            </a:r>
-          </a:p>
-          <a:p>
-            <a:r>
-              <a:rPr sz="1100">
-                <a:solidFill>
-                  <a:srgbClr val="333333"/>
-                </a:solidFill>
-              </a:rPr>
-              <a:t>How to read these averages: each row is players who already moved from that competition into the Bundesliga. Clubs chose whom to sign, so this is not a random sample of everyone in that league.</a:t>
-            </a:r>
-          </a:p>
-          <a:p>
-            <a:r>
-              <a:rPr sz="1100">
-                <a:solidFill>
-                  <a:srgbClr val="333333"/>
-                </a:solidFill>
-              </a:rPr>
-              <a:t/>
-            </a:r>
-          </a:p>
-          <a:p>
-            <a:r>
-              <a:rPr sz="1100">
-                <a:solidFill>
-                  <a:srgbClr val="333333"/>
-                </a:solidFill>
-              </a:rPr>
-              <a:t>Short version: relative feeder averages are a useful scouting description of arrivals. They are not a causal claim that “coming from league X causes more minutes” or proves that league produces better transferable talent — that would need separating the league label from who gets signed and where they land. (The exploratory OLS later holds prior minutes / position / traits fixed and finds league gaps are modest.)</a:t>
-            </a:r>
-          </a:p>
-          <a:p>
-            <a:r>
-              <a:rPr sz="1100">
-                <a:solidFill>
-                  <a:srgbClr val="333333"/>
-                </a:solidFill>
-              </a:rPr>
-              <a:t/>
-            </a:r>
-          </a:p>
-          <a:p>
-            <a:r>
-              <a:rPr sz="1100">
+              <a:rPr sz="1100" b="0">
+                <a:solidFill>
+                  <a:srgbClr val="333333"/>
+                </a:solidFill>
+              </a:rPr>
+              <a:t>FBref N=329 (n≥8 players per league shown). StatsBomb N=96 — international priors are directional only.</a:t>
+            </a:r>
+          </a:p>
+          <a:p>
+            <a:r>
+              <a:rPr sz="1100" b="0">
+                <a:solidFill>
+                  <a:srgbClr val="333333"/>
+                </a:solidFill>
+              </a:rPr>
+              <a:t>Selection bias: these are players clubs already chose to sign from each feeder — not a random draw from that league. Means describe arrived cohorts, not “transfer from X causes minutes.”</a:t>
+            </a:r>
+          </a:p>
+          <a:p>
+            <a:r>
+              <a:rPr sz="1100" b="0">
                 <a:solidFill>
                   <a:srgbClr val="333333"/>
                 </a:solidFill>
@@ -11262,13 +11519,20 @@
             </a:r>
           </a:p>
           <a:p>
+            <a:endParaRPr sz="1200" b="0">
+              <a:solidFill>
+                <a:srgbClr val="333333"/>
+              </a:solidFill>
+            </a:endParaRPr>
+          </a:p>
+          <a:p>
             <a:r>
               <a:rPr sz="1200" b="0">
                 <a:solidFill>
                   <a:srgbClr val="333333"/>
                 </a:solidFill>
               </a:rPr>
-              <a:t/>
+              <a:t>Model 2 — league + traits</a:t>
             </a:r>
           </a:p>
           <a:p>
@@ -11278,7 +11542,7 @@
                   <a:srgbClr val="333333"/>
                 </a:solidFill>
               </a:rPr>
-              <a:t>Model 2 — league + traits</a:t>
+              <a:t>Year 1 minutes = Model 1 + prior trait percentiles</a:t>
             </a:r>
           </a:p>
           <a:p>
@@ -11288,7 +11552,7 @@
                   <a:srgbClr val="333333"/>
                 </a:solidFill>
               </a:rPr>
-              <a:t>Year 1 minutes = Model 1 + prior trait percentiles</a:t>
+              <a:t>                 (e.g. Final Third, Def Pen Touches, …)</a:t>
             </a:r>
           </a:p>
           <a:p>
@@ -11298,8 +11562,15 @@
                   <a:srgbClr val="333333"/>
                 </a:solidFill>
               </a:rPr>
-              <a:t>                 (e.g. Final Third, Def Pen Touches, …)</a:t>
-            </a:r>
+              <a:t>Question: once you know the prior profile, do league gaps shrink?</a:t>
+            </a:r>
+          </a:p>
+          <a:p>
+            <a:endParaRPr sz="1200" b="0">
+              <a:solidFill>
+                <a:srgbClr val="333333"/>
+              </a:solidFill>
+            </a:endParaRPr>
           </a:p>
           <a:p>
             <a:r>
@@ -11308,7 +11579,7 @@
                   <a:srgbClr val="333333"/>
                 </a:solidFill>
               </a:rPr>
-              <a:t>Question: once you know the prior profile, do league gaps shrink?</a:t>
+              <a:t>Model 3 — holdout check</a:t>
             </a:r>
           </a:p>
           <a:p>
@@ -11318,7 +11589,7 @@
                   <a:srgbClr val="333333"/>
                 </a:solidFill>
               </a:rPr>
-              <a:t/>
+              <a:t>Fit Model 2 on 80% of players; correlate predicted vs actual Year 1 minutes on the other 20%.</a:t>
             </a:r>
           </a:p>
           <a:p>
@@ -11328,38 +11599,15 @@
                   <a:srgbClr val="333333"/>
                 </a:solidFill>
               </a:rPr>
-              <a:t>Model 3 — holdout check</a:t>
-            </a:r>
-          </a:p>
-          <a:p>
-            <a:r>
-              <a:rPr sz="1200" b="0">
-                <a:solidFill>
-                  <a:srgbClr val="333333"/>
-                </a:solidFill>
-              </a:rPr>
-              <a:t>Fit Model 2 on 80% of players; correlate predicted vs actual Year 1 minutes on the other 20%.</a:t>
-            </a:r>
-          </a:p>
-          <a:p>
-            <a:r>
-              <a:rPr sz="1200" b="0">
-                <a:solidFill>
-                  <a:srgbClr val="333333"/>
-                </a:solidFill>
-              </a:rPr>
               <a:t>Question: is the fit just memorizing this sample?</a:t>
             </a:r>
           </a:p>
           <a:p>
-            <a:r>
-              <a:rPr sz="1200" b="0">
-                <a:solidFill>
-                  <a:srgbClr val="333333"/>
-                </a:solidFill>
-              </a:rPr>
-              <a:t/>
-            </a:r>
+            <a:endParaRPr sz="1200" b="0">
+              <a:solidFill>
+                <a:srgbClr val="333333"/>
+              </a:solidFill>
+            </a:endParaRPr>
           </a:p>
           <a:p>
             <a:r>
@@ -11983,8 +12231,15 @@
                     <a:bodyPr/>
                     <a:lstStyle/>
                     <a:p>
-                      <a:r>
-                        <a:t>Aerials lost (fewer = better)*</a:t>
+                      <a:pPr algn="ctr"/>
+                      <a:r>
+                        <a:rPr sz="1100" b="0">
+                          <a:solidFill>
+                            <a:srgbClr val="1C1C1C"/>
+                          </a:solidFill>
+                          <a:latin typeface="Arial"/>
+                        </a:rPr>
+                        <a:t>Lost Aerial*</a:t>
                       </a:r>
                     </a:p>
                   </a:txBody>
@@ -12040,8 +12295,15 @@
                     <a:bodyPr/>
                     <a:lstStyle/>
                     <a:p>
-                      <a:r>
-                        <a:t>Final-third passes</a:t>
+                      <a:pPr algn="ctr"/>
+                      <a:r>
+                        <a:rPr sz="1100" b="0">
+                          <a:solidFill>
+                            <a:srgbClr val="1C1C1C"/>
+                          </a:solidFill>
+                          <a:latin typeface="Arial"/>
+                        </a:rPr>
+                        <a:t>Final Third</a:t>
                       </a:r>
                     </a:p>
                   </a:txBody>
@@ -12097,8 +12359,15 @@
                     <a:bodyPr/>
                     <a:lstStyle/>
                     <a:p>
-                      <a:r>
-                        <a:t>Defensive penalty-area touches</a:t>
+                      <a:pPr algn="ctr"/>
+                      <a:r>
+                        <a:rPr sz="1100" b="0">
+                          <a:solidFill>
+                            <a:srgbClr val="1C1C1C"/>
+                          </a:solidFill>
+                          <a:latin typeface="Arial"/>
+                        </a:rPr>
+                        <a:t>Def Pen Touches</a:t>
                       </a:r>
                     </a:p>
                   </a:txBody>
@@ -12154,8 +12423,15 @@
                     <a:bodyPr/>
                     <a:lstStyle/>
                     <a:p>
-                      <a:r>
-                        <a:t>Progressive carry distance</a:t>
+                      <a:pPr algn="ctr"/>
+                      <a:r>
+                        <a:rPr sz="1100" b="0">
+                          <a:solidFill>
+                            <a:srgbClr val="1C1C1C"/>
+                          </a:solidFill>
+                          <a:latin typeface="Arial"/>
+                        </a:rPr>
+                        <a:t>PrgDist Total</a:t>
                       </a:r>
                     </a:p>
                   </a:txBody>
@@ -12211,8 +12487,24 @@
                     <a:bodyPr/>
                     <a:lstStyle/>
                     <a:p>
-                      <a:r>
-                        <a:t>Expected goals (xG)</a:t>
+                      <a:pPr algn="ctr"/>
+                      <a:r>
+                        <a:rPr sz="1100" b="0" dirty="0" err="1">
+                          <a:solidFill>
+                            <a:srgbClr val="1C1C1C"/>
+                          </a:solidFill>
+                          <a:latin typeface="Arial"/>
+                        </a:rPr>
+                        <a:t>xG</a:t>
+                      </a:r>
+                      <a:r>
+                        <a:rPr sz="1100" b="0" dirty="0">
+                          <a:solidFill>
+                            <a:srgbClr val="1C1C1C"/>
+                          </a:solidFill>
+                          <a:latin typeface="Arial"/>
+                        </a:rPr>
+                        <a:t> Per</a:t>
                       </a:r>
                     </a:p>
                   </a:txBody>
@@ -12294,92 +12586,76 @@
               </a:spcAft>
             </a:pPr>
             <a:r>
-              <a:rPr sz="1100">
-                <a:solidFill>
-                  <a:srgbClr val="333333"/>
-                </a:solidFill>
-              </a:rPr>
-              <a:t>Does the Ligue 1 result make sense?</a:t>
-            </a:r>
-          </a:p>
-          <a:p>
-            <a:r>
-              <a:rPr sz="1100">
-                <a:solidFill>
-                  <a:srgbClr val="333333"/>
-                </a:solidFill>
-              </a:rPr>
-              <a:t/>
-            </a:r>
-          </a:p>
-          <a:p>
-            <a:r>
-              <a:rPr sz="1100">
-                <a:solidFill>
-                  <a:srgbClr val="333333"/>
-                </a:solidFill>
-              </a:rPr>
-              <a:t>The table shows Ligue 1 arrivals with about +163 Year 1 minutes versus Serie A. That gap looks large, but p≈0.38 with N=117 — under usual standards it is not distinguishable from chance. In plain terms: we do not have clear evidence that Ligue 1 labels alone buy more first-season playing time once prior minutes and position are held fixed.</a:t>
-            </a:r>
-          </a:p>
-          <a:p>
-            <a:r>
-              <a:rPr sz="1100">
-                <a:solidFill>
-                  <a:srgbClr val="333333"/>
-                </a:solidFill>
-              </a:rPr>
-              <a:t/>
-            </a:r>
-          </a:p>
-          <a:p>
-            <a:r>
-              <a:rPr sz="1100">
-                <a:solidFill>
-                  <a:srgbClr val="333333"/>
-                </a:solidFill>
-              </a:rPr>
-              <a:t>What does look clearer: adding prior trait percentiles raises R² from about 0.09 to 0.22, so the player’s prior profile explains Year 1 minutes better than the league name. The holdout check (correlation ≈0.35) is only moderate — useful as exploration, not a strong forecast.</a:t>
-            </a:r>
-          </a:p>
-          <a:p>
-            <a:r>
-              <a:rPr sz="1100">
-                <a:solidFill>
-                  <a:srgbClr val="333333"/>
-                </a:solidFill>
-              </a:rPr>
-              <a:t/>
-            </a:r>
-          </a:p>
-          <a:p>
-            <a:r>
-              <a:rPr sz="1100">
-                <a:solidFill>
-                  <a:srgbClr val="333333"/>
-                </a:solidFill>
-              </a:rPr>
-              <a:t>Takeaway: prioritize portable traits and Year 1 minutes; treat feeder-league labels as a weak leftover signal.</a:t>
-            </a:r>
-          </a:p>
-          <a:p>
-            <a:r>
-              <a:rPr sz="1100">
-                <a:solidFill>
-                  <a:srgbClr val="333333"/>
-                </a:solidFill>
-              </a:rPr>
-              <a:t/>
-            </a:r>
-          </a:p>
-          <a:p>
-            <a:r>
-              <a:rPr sz="1100">
-                <a:solidFill>
-                  <a:srgbClr val="333333"/>
-                </a:solidFill>
-              </a:rPr>
-              <a:t>Serie A = baseline (lowest mean Year 1 minutes among Big-5 feeders in this subset).</a:t>
+              <a:rPr sz="1200" b="0">
+                <a:solidFill>
+                  <a:srgbClr val="333333"/>
+                </a:solidFill>
+              </a:rPr>
+              <a:t>Does this make sense?</a:t>
+            </a:r>
+          </a:p>
+          <a:p>
+            <a:r>
+              <a:rPr sz="1200" b="0">
+                <a:solidFill>
+                  <a:srgbClr val="333333"/>
+                </a:solidFill>
+              </a:rPr>
+              <a:t>Yes — Ligue 1’s +163 minutes vs Serie A looks large on the table but p≈0.38 (N=117): not statistically distinguishable from noise. Modest, non-significant league gaps are exactly what you’d expect if clubs already select carefully and league labels are weak once minutes/position are controlled.</a:t>
+            </a:r>
+          </a:p>
+          <a:p>
+            <a:endParaRPr sz="1200" b="0">
+              <a:solidFill>
+                <a:srgbClr val="333333"/>
+              </a:solidFill>
+            </a:endParaRPr>
+          </a:p>
+          <a:p>
+            <a:r>
+              <a:rPr sz="1200" b="0">
+                <a:solidFill>
+                  <a:srgbClr val="333333"/>
+                </a:solidFill>
+              </a:rPr>
+              <a:t>Adding traits raises R² (0.09 → 0.22): prior profile matters more than league label.</a:t>
+            </a:r>
+          </a:p>
+          <a:p>
+            <a:r>
+              <a:rPr sz="1200" b="0">
+                <a:solidFill>
+                  <a:srgbClr val="333333"/>
+                </a:solidFill>
+              </a:rPr>
+              <a:t>Model 3 holdout r≈0.35 = moderate match on held-out players (not a strong forecast).</a:t>
+            </a:r>
+          </a:p>
+          <a:p>
+            <a:r>
+              <a:rPr sz="1200" b="0">
+                <a:solidFill>
+                  <a:srgbClr val="333333"/>
+                </a:solidFill>
+              </a:rPr>
+              <a:t>Takeaway: scout portable traits + Year 1 minutes; league is a weak residual signal.</a:t>
+            </a:r>
+          </a:p>
+          <a:p>
+            <a:endParaRPr sz="1200" b="0">
+              <a:solidFill>
+                <a:srgbClr val="333333"/>
+              </a:solidFill>
+            </a:endParaRPr>
+          </a:p>
+          <a:p>
+            <a:r>
+              <a:rPr sz="1200" b="0">
+                <a:solidFill>
+                  <a:srgbClr val="333333"/>
+                </a:solidFill>
+              </a:rPr>
+              <a:t>Serie A = baseline (lowest mean Year 1 minutes among Big-5 feeders).</a:t>
             </a:r>
           </a:p>
         </p:txBody>
@@ -12788,22 +13064,12 @@
               </a:spcAft>
             </a:pPr>
             <a:r>
-              <a:rPr sz="1200">
-                <a:solidFill>
-                  <a:srgbClr val="333333"/>
-                </a:solidFill>
-              </a:rPr>
-              <a:t>Question</a:t>
-            </a:r>
-          </a:p>
-          <a:p>
-            <a:r>
-              <a:rPr sz="1200">
-                <a:solidFill>
-                  <a:srgbClr val="333333"/>
-                </a:solidFill>
-              </a:rPr>
-              <a:t>Which traits travel into the Bundesliga (Germany’s top men’s soccer league) — and which prior stats line up with Year 1 in Bundesliga minutes?</a:t>
+              <a:rPr sz="1200" b="0">
+                <a:solidFill>
+                  <a:srgbClr val="555555"/>
+                </a:solidFill>
+              </a:rPr>
+              <a:t>Research question → data scrape from FBref and StatsBomb → stability thresholds → redundancy thresholds → HTML player explorer → team-based significance findings</a:t>
             </a:r>
           </a:p>
         </p:txBody>
@@ -12888,7 +13154,7 @@
               </a:spcAft>
             </a:pPr>
             <a:r>
-              <a:rPr sz="1200">
+              <a:rPr sz="1200" b="0">
                 <a:solidFill>
                   <a:srgbClr val="333333"/>
                 </a:solidFill>
@@ -12898,12 +13164,12 @@
           </a:p>
           <a:p>
             <a:r>
-              <a:rPr sz="1200">
-                <a:solidFill>
-                  <a:srgbClr val="333333"/>
-                </a:solidFill>
-              </a:rPr>
-              <a:t>Which traits travel into the Bundesliga (Germany’s top men’s soccer league) — and which prior stats line up with Year 1 in Bundesliga minutes?</a:t>
+              <a:rPr sz="1200" b="0">
+                <a:solidFill>
+                  <a:srgbClr val="333333"/>
+                </a:solidFill>
+              </a:rPr>
+              <a:t>Which traits travel into the German Bundesliga — and which prior stats line up with Year 1 in Bundesliga minutes?</a:t>
             </a:r>
           </a:p>
         </p:txBody>
@@ -13122,7 +13388,7 @@
               </a:spcAft>
             </a:pPr>
             <a:r>
-              <a:rPr sz="1200" b="0">
+              <a:rPr sz="1200" b="0" dirty="0">
                 <a:solidFill>
                   <a:srgbClr val="333333"/>
                 </a:solidFill>
@@ -13132,7 +13398,7 @@
           </a:p>
           <a:p>
             <a:r>
-              <a:rPr sz="1200" b="0">
+              <a:rPr sz="1200" b="0" dirty="0">
                 <a:solidFill>
                   <a:srgbClr val="333333"/>
                 </a:solidFill>
@@ -13150,7 +13416,7 @@
         </p:nvSpPr>
         <p:spPr>
           <a:xfrm>
-            <a:off x="411480" y="3346704"/>
+            <a:off x="411480" y="3774215"/>
             <a:ext cx="329184" cy="329184"/>
           </a:xfrm>
           <a:prstGeom prst="ellipse">
@@ -13183,7 +13449,7 @@
           <a:p>
             <a:pPr algn="ctr"/>
             <a:r>
-              <a:rPr sz="1300" b="1">
+              <a:rPr sz="1300" b="1" dirty="0">
                 <a:solidFill>
                   <a:srgbClr val="FFFFFF"/>
                 </a:solidFill>
@@ -13202,7 +13468,7 @@
         </p:nvSpPr>
         <p:spPr>
           <a:xfrm>
-            <a:off x="832104" y="3310128"/>
+            <a:off x="832104" y="3511296"/>
             <a:ext cx="5029200" cy="487313"/>
           </a:xfrm>
           <a:prstGeom prst="rect">
@@ -13222,7 +13488,7 @@
               </a:spcAft>
             </a:pPr>
             <a:r>
-              <a:rPr sz="1100" b="0">
+              <a:rPr sz="1100" b="0" dirty="0">
                 <a:solidFill>
                   <a:srgbClr val="333333"/>
                 </a:solidFill>
@@ -13232,12 +13498,36 @@
           </a:p>
           <a:p>
             <a:r>
-              <a:rPr sz="1100" b="0">
-                <a:solidFill>
-                  <a:srgbClr val="333333"/>
-                </a:solidFill>
-              </a:rPr>
-              <a:t>FBref category gates → 43 of 105 metrics met the stability floor. StatsBomb Pearson r≥0.40 → 7 of 16.</a:t>
+              <a:rPr sz="1100" b="0" dirty="0" err="1">
+                <a:solidFill>
+                  <a:srgbClr val="333333"/>
+                </a:solidFill>
+              </a:rPr>
+              <a:t>FBref</a:t>
+            </a:r>
+            <a:r>
+              <a:rPr sz="1100" b="0" dirty="0">
+                <a:solidFill>
+                  <a:srgbClr val="333333"/>
+                </a:solidFill>
+              </a:rPr>
+              <a:t> category gates → 43 of 105 metrics met the stability floor. </a:t>
+            </a:r>
+            <a:r>
+              <a:rPr sz="1100" b="0" dirty="0" err="1">
+                <a:solidFill>
+                  <a:srgbClr val="333333"/>
+                </a:solidFill>
+              </a:rPr>
+              <a:t>StatsBomb</a:t>
+            </a:r>
+            <a:r>
+              <a:rPr sz="1100" b="0" dirty="0">
+                <a:solidFill>
+                  <a:srgbClr val="333333"/>
+                </a:solidFill>
+              </a:rPr>
+              <a:t> Pearson r≥0.40 → 7 of 16.</a:t>
             </a:r>
           </a:p>
         </p:txBody>
@@ -15876,7 +16166,7 @@
               </a:spcAft>
             </a:pPr>
             <a:r>
-              <a:rPr sz="1200">
+              <a:rPr sz="1200" b="0">
                 <a:solidFill>
                   <a:srgbClr val="333333"/>
                 </a:solidFill>
@@ -15886,57 +16176,27 @@
           </a:p>
           <a:p>
             <a:r>
-              <a:rPr sz="1200">
-                <a:solidFill>
-                  <a:srgbClr val="333333"/>
-                </a:solidFill>
-              </a:rPr>
-              <a:t/>
-            </a:r>
-          </a:p>
-          <a:p>
-            <a:r>
-              <a:rPr sz="1200">
-                <a:solidFill>
-                  <a:srgbClr val="333333"/>
-                </a:solidFill>
-              </a:rPr>
-              <a:t>Pearson r = stability: does a player’s ranking on a rate in the prior league tend to show up again in Year 1 in the Bundesliga?</a:t>
-            </a:r>
-          </a:p>
-          <a:p>
-            <a:r>
-              <a:rPr sz="1200">
-                <a:solidFill>
-                  <a:srgbClr val="333333"/>
-                </a:solidFill>
-              </a:rPr>
-              <a:t/>
-            </a:r>
-          </a:p>
-          <a:p>
-            <a:r>
-              <a:rPr sz="1200">
-                <a:solidFill>
-                  <a:srgbClr val="333333"/>
-                </a:solidFill>
-              </a:rPr>
-              <a:t>Success = more minutes in Year 1 in the Bundesliga (playing time), not goals or market value. Spearman ρ asks whether higher prior trait ranks line up with more first-season minutes.</a:t>
-            </a:r>
-          </a:p>
-          <a:p>
-            <a:r>
-              <a:rPr sz="1200">
-                <a:solidFill>
-                  <a:srgbClr val="333333"/>
-                </a:solidFill>
-              </a:rPr>
-              <a:t/>
-            </a:r>
-          </a:p>
-          <a:p>
-            <a:r>
-              <a:rPr sz="1200">
+              <a:rPr sz="1200" b="0">
+                <a:solidFill>
+                  <a:srgbClr val="333333"/>
+                </a:solidFill>
+              </a:rPr>
+              <a:t>Pearson r = stability (does the prior ranking of a rate recur in Year 1 in Bundesliga?).</a:t>
+            </a:r>
+          </a:p>
+          <a:p>
+            <a:r>
+              <a:rPr sz="1200" b="0">
+                <a:solidFill>
+                  <a:srgbClr val="333333"/>
+                </a:solidFill>
+              </a:rPr>
+              <a:t>Spearman ρ = success — yes: success means more Year 1 in Bundesliga minutes (playing time), not goals or market value. We ask whether higher prior trait ranks line up with more first-season minutes.</a:t>
+            </a:r>
+          </a:p>
+          <a:p>
+            <a:r>
+              <a:rPr sz="1200" b="0">
                 <a:solidFill>
                   <a:srgbClr val="333333"/>
                 </a:solidFill>
@@ -16745,7 +17005,7 @@
         <p:spPr>
           <a:xfrm>
             <a:off x="548640" y="411480"/>
-            <a:ext cx="10972800" cy="640080"/>
+            <a:ext cx="10972800" cy="523220"/>
           </a:xfrm>
           <a:prstGeom prst="rect">
             <a:avLst/>
@@ -16764,13 +17024,31 @@
               </a:spcAft>
             </a:pPr>
             <a:r>
-              <a:rPr sz="2800" b="1">
+              <a:rPr sz="2800" b="1" dirty="0">
                 <a:solidFill>
                   <a:srgbClr val="3D5A80"/>
                 </a:solidFill>
                 <a:latin typeface="Calibri"/>
               </a:rPr>
-              <a:t>DATA  ·  FBREF (PRIMARY)</a:t>
+              <a:t>DATA  ·  FBREF (</a:t>
+            </a:r>
+            <a:r>
+              <a:rPr lang="en-US" sz="2800" b="1" dirty="0">
+                <a:solidFill>
+                  <a:srgbClr val="3D5A80"/>
+                </a:solidFill>
+                <a:latin typeface="Calibri"/>
+              </a:rPr>
+              <a:t>Primary Source</a:t>
+            </a:r>
+            <a:r>
+              <a:rPr sz="2800" b="1" dirty="0">
+                <a:solidFill>
+                  <a:srgbClr val="3D5A80"/>
+                </a:solidFill>
+                <a:latin typeface="Calibri"/>
+              </a:rPr>
+              <a:t>)</a:t>
             </a:r>
           </a:p>
         </p:txBody>
@@ -16878,13 +17156,20 @@
             </a:r>
           </a:p>
           <a:p>
+            <a:endParaRPr sz="1200" b="0">
+              <a:solidFill>
+                <a:srgbClr val="333333"/>
+              </a:solidFill>
+            </a:endParaRPr>
+          </a:p>
+          <a:p>
             <a:r>
               <a:rPr sz="1200" b="0">
                 <a:solidFill>
                   <a:srgbClr val="333333"/>
                 </a:solidFill>
               </a:rPr>
-              <a:t/>
+              <a:t>Outside-league tables + player-page fills</a:t>
             </a:r>
           </a:p>
           <a:p>
@@ -16894,7 +17179,7 @@
                   <a:srgbClr val="333333"/>
                 </a:solidFill>
               </a:rPr>
-              <a:t>Outside-league tables + player-page fills</a:t>
+              <a:t>Analysis window: first Bundesliga end-years 2021–2025</a:t>
             </a:r>
           </a:p>
           <a:p>
@@ -16904,8 +17189,15 @@
                   <a:srgbClr val="333333"/>
                 </a:solidFill>
               </a:rPr>
-              <a:t>Analysis window: first Bundesliga end-years 2021–2025</a:t>
-            </a:r>
+              <a:t>Minutes: prior ≥300′ · Year 1 in Bundesliga ≥300′ → N=329 pairs · 19 leagues</a:t>
+            </a:r>
+          </a:p>
+          <a:p>
+            <a:endParaRPr sz="1200" b="0">
+              <a:solidFill>
+                <a:srgbClr val="333333"/>
+              </a:solidFill>
+            </a:endParaRPr>
           </a:p>
           <a:p>
             <a:r>
@@ -16914,38 +17206,15 @@
                   <a:srgbClr val="333333"/>
                 </a:solidFill>
               </a:rPr>
-              <a:t>Minutes: prior ≥300′ · Year 1 in Bundesliga ≥300′ → N=329 pairs · 19 leagues</a:t>
-            </a:r>
-          </a:p>
-          <a:p>
-            <a:r>
-              <a:rPr sz="1200" b="0">
-                <a:solidFill>
-                  <a:srgbClr val="333333"/>
-                </a:solidFill>
-              </a:rPr>
-              <a:t/>
-            </a:r>
-          </a:p>
-          <a:p>
-            <a:r>
-              <a:rPr sz="1200" b="0">
-                <a:solidFill>
-                  <a:srgbClr val="333333"/>
-                </a:solidFill>
-              </a:rPr>
               <a:t>League-relative scaling (mentioned once): we tried “how high vs peers in the same prior league” (z-score / percentile). It did not improve prior→Year 1 stability, so we keep absolute per-90 rates everywhere.</a:t>
             </a:r>
           </a:p>
           <a:p>
-            <a:r>
-              <a:rPr sz="1200" b="0">
-                <a:solidFill>
-                  <a:srgbClr val="333333"/>
-                </a:solidFill>
-              </a:rPr>
-              <a:t/>
-            </a:r>
+            <a:endParaRPr sz="1200" b="0">
+              <a:solidFill>
+                <a:srgbClr val="333333"/>
+              </a:solidFill>
+            </a:endParaRPr>
           </a:p>
           <a:p>
             <a:r>
@@ -17037,7 +17306,7 @@
         <p:spPr>
           <a:xfrm>
             <a:off x="548640" y="411480"/>
-            <a:ext cx="10972800" cy="640080"/>
+            <a:ext cx="10972800" cy="954107"/>
           </a:xfrm>
           <a:prstGeom prst="rect">
             <a:avLst/>
@@ -17056,13 +17325,31 @@
               </a:spcAft>
             </a:pPr>
             <a:r>
-              <a:rPr sz="2800" b="1">
+              <a:rPr sz="2800" b="1" dirty="0">
                 <a:solidFill>
                   <a:srgbClr val="3D5A80"/>
                 </a:solidFill>
                 <a:latin typeface="Calibri"/>
               </a:rPr>
-              <a:t>DATA  ·  STATSBOMB OPEN DATA (DEEP DIVE)</a:t>
+              <a:t>DATA  ·  STATSBOMB OPEN DATA (</a:t>
+            </a:r>
+            <a:r>
+              <a:rPr lang="en-US" sz="2800" b="1" dirty="0">
+                <a:solidFill>
+                  <a:srgbClr val="3D5A80"/>
+                </a:solidFill>
+                <a:latin typeface="Calibri"/>
+              </a:rPr>
+              <a:t>Deeper but secondary/smaller data source</a:t>
+            </a:r>
+            <a:r>
+              <a:rPr sz="2800" b="1" dirty="0">
+                <a:solidFill>
+                  <a:srgbClr val="3D5A80"/>
+                </a:solidFill>
+                <a:latin typeface="Calibri"/>
+              </a:rPr>
+              <a:t>)</a:t>
             </a:r>
           </a:p>
         </p:txBody>
@@ -17100,7 +17387,7 @@
               </a:spcAft>
             </a:pPr>
             <a:r>
-              <a:rPr sz="1100">
+              <a:rPr sz="1200" b="0">
                 <a:solidFill>
                   <a:srgbClr val="333333"/>
                 </a:solidFill>
@@ -17109,38 +17396,35 @@
             </a:r>
           </a:p>
           <a:p>
-            <a:r>
-              <a:rPr sz="1100">
-                <a:solidFill>
-                  <a:srgbClr val="333333"/>
-                </a:solidFill>
-              </a:rPr>
-              <a:t/>
-            </a:r>
-          </a:p>
-          <a:p>
-            <a:r>
-              <a:rPr sz="1100">
-                <a:solidFill>
-                  <a:srgbClr val="333333"/>
-                </a:solidFill>
-              </a:rPr>
-              <a:t>“Open” means free public StatsBomb match files anyone can download — not a paid data feed. Priors come from those open men’s competitions the player appeared in before the Bundesliga (club leagues and tournaments such as the World Cup, European Championship, and Champions League).</a:t>
-            </a:r>
-          </a:p>
-          <a:p>
-            <a:r>
-              <a:rPr sz="1100">
-                <a:solidFill>
-                  <a:srgbClr val="333333"/>
-                </a:solidFill>
-              </a:rPr>
-              <a:t>Bundesliga open dumps available: 2015/16 + 2023/24 only</a:t>
-            </a:r>
-          </a:p>
-          <a:p>
-            <a:r>
-              <a:rPr sz="1100">
+            <a:endParaRPr sz="1200" b="0">
+              <a:solidFill>
+                <a:srgbClr val="333333"/>
+              </a:solidFill>
+            </a:endParaRPr>
+          </a:p>
+          <a:p>
+            <a:r>
+              <a:rPr sz="1200" b="0">
+                <a:solidFill>
+                  <a:srgbClr val="333333"/>
+                </a:solidFill>
+              </a:rPr>
+              <a:t>Priors = any StatsBomb open men’s competition the player played before Bundesliga (club leagues and internationals — World Cup, Euro, Champions League, etc.).</a:t>
+            </a:r>
+          </a:p>
+          <a:p>
+            <a:r>
+              <a:rPr sz="1200" b="0">
+                <a:solidFill>
+                  <a:srgbClr val="333333"/>
+                </a:solidFill>
+              </a:rPr>
+              <a:t>1. Bundesliga open dumps: 2015/16 + 2023/24 only</a:t>
+            </a:r>
+          </a:p>
+          <a:p>
+            <a:r>
+              <a:rPr sz="1200" b="0">
                 <a:solidFill>
                   <a:srgbClr val="333333"/>
                 </a:solidFill>
@@ -17150,7 +17434,7 @@
           </a:p>
           <a:p>
             <a:r>
-              <a:rPr sz="1100">
+              <a:rPr sz="1200" b="0">
                 <a:solidFill>
                   <a:srgbClr val="333333"/>
                 </a:solidFill>
@@ -17159,23 +17443,20 @@
             </a:r>
           </a:p>
           <a:p>
-            <a:r>
-              <a:rPr sz="1100">
-                <a:solidFill>
-                  <a:srgbClr val="333333"/>
-                </a:solidFill>
-              </a:rPr>
-              <a:t/>
-            </a:r>
-          </a:p>
-          <a:p>
-            <a:r>
-              <a:rPr sz="1100">
-                <a:solidFill>
-                  <a:srgbClr val="333333"/>
-                </a:solidFill>
-              </a:rPr>
-              <a:t>Open-data thinness · two Bundesliga seasons · event check</a:t>
+            <a:endParaRPr sz="1200" b="0">
+              <a:solidFill>
+                <a:srgbClr val="333333"/>
+              </a:solidFill>
+            </a:endParaRPr>
+          </a:p>
+          <a:p>
+            <a:r>
+              <a:rPr sz="1200" b="0">
+                <a:solidFill>
+                  <a:srgbClr val="333333"/>
+                </a:solidFill>
+              </a:rPr>
+              <a:t>Open-data thinness · two BL seasons · event check</a:t>
             </a:r>
           </a:p>
         </p:txBody>
@@ -17387,7 +17668,7 @@
         <p:spPr>
           <a:xfrm>
             <a:off x="411480" y="1118846"/>
-            <a:ext cx="3036279" cy="2569934"/>
+            <a:ext cx="3036279" cy="3824124"/>
           </a:xfrm>
           <a:prstGeom prst="rect">
             <a:avLst/>
@@ -17408,7 +17689,7 @@
               <a:buChar char="•"/>
             </a:pPr>
             <a:r>
-              <a:rPr sz="1200" b="0">
+              <a:rPr sz="1200" b="0" dirty="0">
                 <a:solidFill>
                   <a:srgbClr val="333333"/>
                 </a:solidFill>
@@ -17422,18 +17703,15 @@
             </a:endParaRPr>
           </a:p>
           <a:p>
-            <a:r>
-              <a:rPr sz="1200" b="0">
-                <a:solidFill>
-                  <a:srgbClr val="333333"/>
-                </a:solidFill>
-              </a:rPr>
-              <a:t/>
-            </a:r>
-          </a:p>
-          <a:p>
-            <a:r>
-              <a:rPr sz="1200" b="0">
+            <a:endParaRPr lang="en-US" sz="1200" b="0" dirty="0">
+              <a:solidFill>
+                <a:srgbClr val="333333"/>
+              </a:solidFill>
+            </a:endParaRPr>
+          </a:p>
+          <a:p>
+            <a:r>
+              <a:rPr sz="1200" b="0" dirty="0">
                 <a:solidFill>
                   <a:srgbClr val="333333"/>
                 </a:solidFill>
@@ -17442,18 +17720,15 @@
             </a:r>
           </a:p>
           <a:p>
-            <a:r>
-              <a:rPr sz="1200" b="0">
-                <a:solidFill>
-                  <a:srgbClr val="333333"/>
-                </a:solidFill>
-              </a:rPr>
-              <a:t/>
-            </a:r>
-          </a:p>
-          <a:p>
-            <a:r>
-              <a:rPr sz="1200" b="0">
+            <a:endParaRPr sz="1200" b="0" dirty="0">
+              <a:solidFill>
+                <a:srgbClr val="333333"/>
+              </a:solidFill>
+            </a:endParaRPr>
+          </a:p>
+          <a:p>
+            <a:r>
+              <a:rPr sz="1200" b="0" dirty="0">
                 <a:solidFill>
                   <a:srgbClr val="333333"/>
                 </a:solidFill>
@@ -17463,7 +17738,7 @@
           </a:p>
           <a:p>
             <a:r>
-              <a:rPr sz="1200" b="0">
+              <a:rPr sz="1200" b="0" dirty="0">
                 <a:solidFill>
                   <a:srgbClr val="333333"/>
                 </a:solidFill>
@@ -17473,7 +17748,7 @@
           </a:p>
           <a:p>
             <a:r>
-              <a:rPr sz="1200" b="0">
+              <a:rPr sz="1200" b="0" dirty="0">
                 <a:solidFill>
                   <a:srgbClr val="333333"/>
                 </a:solidFill>
@@ -17483,27 +17758,51 @@
           </a:p>
           <a:p>
             <a:r>
-              <a:rPr sz="1200" b="0">
+              <a:rPr sz="1200" b="0" dirty="0">
                 <a:solidFill>
                   <a:srgbClr val="333333"/>
                 </a:solidFill>
               </a:rPr>
               <a:t>43 of 105 metrics pass → redundancy next</a:t>
             </a:r>
-          </a:p>
-          <a:p>
-            <a:r>
-              <a:rPr sz="1200" b="0">
-                <a:solidFill>
-                  <a:srgbClr val="333333"/>
-                </a:solidFill>
-              </a:rPr>
-              <a:t/>
-            </a:r>
-          </a:p>
-          <a:p>
-            <a:r>
-              <a:rPr sz="1200" b="0">
+            <a:endParaRPr lang="en-US" sz="1200" b="0" dirty="0">
+              <a:solidFill>
+                <a:srgbClr val="333333"/>
+              </a:solidFill>
+            </a:endParaRPr>
+          </a:p>
+          <a:p>
+            <a:endParaRPr lang="en-US" sz="1200" dirty="0">
+              <a:solidFill>
+                <a:srgbClr val="333333"/>
+              </a:solidFill>
+            </a:endParaRPr>
+          </a:p>
+          <a:p>
+            <a:r>
+              <a:rPr lang="en-US" sz="1200" dirty="0">
+                <a:solidFill>
+                  <a:srgbClr val="333333"/>
+                </a:solidFill>
+              </a:rPr>
+              <a:t>Defending Pearson threshold was lower because less metrics made it above the 0.6 cutoff and defending is inherently harder to calculate due to importance of non-represented on field positioning.</a:t>
+            </a:r>
+            <a:endParaRPr sz="1200" b="0" dirty="0">
+              <a:solidFill>
+                <a:srgbClr val="333333"/>
+              </a:solidFill>
+            </a:endParaRPr>
+          </a:p>
+          <a:p>
+            <a:endParaRPr sz="1200" b="0" dirty="0">
+              <a:solidFill>
+                <a:srgbClr val="333333"/>
+              </a:solidFill>
+            </a:endParaRPr>
+          </a:p>
+          <a:p>
+            <a:r>
+              <a:rPr sz="1200" b="0" dirty="0">
                 <a:solidFill>
                   <a:srgbClr val="333333"/>
                 </a:solidFill>
@@ -17513,7 +17812,7 @@
           </a:p>
           <a:p>
             <a:r>
-              <a:rPr sz="1200" b="0">
+              <a:rPr sz="1200" b="0" dirty="0">
                 <a:solidFill>
                   <a:srgbClr val="333333"/>
                 </a:solidFill>
@@ -17590,8 +17889,21 @@
                     <a:bodyPr/>
                     <a:lstStyle/>
                     <a:p>
-                      <a:r>
-                        <a:t>Code</a:t>
+                      <a:pPr>
+                        <a:defRPr sz="1100" b="1">
+                          <a:solidFill>
+                            <a:srgbClr val="FFFFFF"/>
+                          </a:solidFill>
+                          <a:latin typeface="Calibri"/>
+                        </a:defRPr>
+                      </a:pPr>
+                      <a:r>
+                        <a:rPr sz="1000" b="1" dirty="0">
+                          <a:solidFill>
+                            <a:schemeClr val="bg1"/>
+                          </a:solidFill>
+                        </a:rPr>
+                        <a:t>Abbrev</a:t>
                       </a:r>
                     </a:p>
                   </a:txBody>
@@ -17606,8 +17918,21 @@
                     <a:bodyPr/>
                     <a:lstStyle/>
                     <a:p>
-                      <a:r>
-                        <a:t>Metric (full name)</a:t>
+                      <a:pPr>
+                        <a:defRPr sz="1100" b="1">
+                          <a:solidFill>
+                            <a:srgbClr val="FFFFFF"/>
+                          </a:solidFill>
+                          <a:latin typeface="Calibri"/>
+                        </a:defRPr>
+                      </a:pPr>
+                      <a:r>
+                        <a:rPr sz="1000" b="1" dirty="0">
+                          <a:solidFill>
+                            <a:schemeClr val="bg1"/>
+                          </a:solidFill>
+                        </a:rPr>
+                        <a:t>Metric</a:t>
                       </a:r>
                     </a:p>
                   </a:txBody>
@@ -17745,8 +18070,21 @@
                     <a:bodyPr/>
                     <a:lstStyle/>
                     <a:p>
-                      <a:r>
-                        <a:t>Defensive penalty-area touches</a:t>
+                      <a:pPr>
+                        <a:defRPr sz="1100" b="0">
+                          <a:solidFill>
+                            <a:srgbClr val="1C1C1C"/>
+                          </a:solidFill>
+                          <a:latin typeface="Calibri"/>
+                        </a:defRPr>
+                      </a:pPr>
+                      <a:r>
+                        <a:rPr sz="1000">
+                          <a:solidFill>
+                            <a:srgbClr val="333333"/>
+                          </a:solidFill>
+                        </a:rPr>
+                        <a:t>Def Pen Touches</a:t>
                       </a:r>
                     </a:p>
                   </a:txBody>
@@ -17884,8 +18222,21 @@
                     <a:bodyPr/>
                     <a:lstStyle/>
                     <a:p>
-                      <a:r>
-                        <a:t>Progressive carries</a:t>
+                      <a:pPr>
+                        <a:defRPr sz="1100" b="0">
+                          <a:solidFill>
+                            <a:srgbClr val="1C1C1C"/>
+                          </a:solidFill>
+                          <a:latin typeface="Calibri"/>
+                        </a:defRPr>
+                      </a:pPr>
+                      <a:r>
+                        <a:rPr sz="1000">
+                          <a:solidFill>
+                            <a:srgbClr val="333333"/>
+                          </a:solidFill>
+                        </a:rPr>
+                        <a:t>PrgC Progression</a:t>
                       </a:r>
                     </a:p>
                   </a:txBody>
@@ -18023,8 +18374,21 @@
                     <a:bodyPr/>
                     <a:lstStyle/>
                     <a:p>
-                      <a:r>
-                        <a:t>Expected goals (xG)</a:t>
+                      <a:pPr>
+                        <a:defRPr sz="1100" b="0">
+                          <a:solidFill>
+                            <a:srgbClr val="1C1C1C"/>
+                          </a:solidFill>
+                          <a:latin typeface="Calibri"/>
+                        </a:defRPr>
+                      </a:pPr>
+                      <a:r>
+                        <a:rPr sz="1000">
+                          <a:solidFill>
+                            <a:srgbClr val="333333"/>
+                          </a:solidFill>
+                        </a:rPr>
+                        <a:t>xG Per</a:t>
                       </a:r>
                     </a:p>
                   </a:txBody>
@@ -18162,8 +18526,21 @@
                     <a:bodyPr/>
                     <a:lstStyle/>
                     <a:p>
-                      <a:r>
-                        <a:t>Non-penalty expected goals</a:t>
+                      <a:pPr>
+                        <a:defRPr sz="1100" b="0">
+                          <a:solidFill>
+                            <a:srgbClr val="1C1C1C"/>
+                          </a:solidFill>
+                          <a:latin typeface="Calibri"/>
+                        </a:defRPr>
+                      </a:pPr>
+                      <a:r>
+                        <a:rPr sz="1000">
+                          <a:solidFill>
+                            <a:srgbClr val="333333"/>
+                          </a:solidFill>
+                        </a:rPr>
+                        <a:t>npxG Per</a:t>
                       </a:r>
                     </a:p>
                   </a:txBody>
@@ -18301,8 +18678,21 @@
                     <a:bodyPr/>
                     <a:lstStyle/>
                     <a:p>
-                      <a:r>
-                        <a:t>Defensive-third touches</a:t>
+                      <a:pPr>
+                        <a:defRPr sz="1100" b="0">
+                          <a:solidFill>
+                            <a:srgbClr val="1C1C1C"/>
+                          </a:solidFill>
+                          <a:latin typeface="Calibri"/>
+                        </a:defRPr>
+                      </a:pPr>
+                      <a:r>
+                        <a:rPr sz="1000">
+                          <a:solidFill>
+                            <a:srgbClr val="333333"/>
+                          </a:solidFill>
+                        </a:rPr>
+                        <a:t>Def 3rd Touches</a:t>
                       </a:r>
                     </a:p>
                   </a:txBody>
@@ -18440,8 +18830,21 @@
                     <a:bodyPr/>
                     <a:lstStyle/>
                     <a:p>
-                      <a:r>
-                        <a:t>Progressive carry distance</a:t>
+                      <a:pPr>
+                        <a:defRPr sz="1100" b="0">
+                          <a:solidFill>
+                            <a:srgbClr val="1C1C1C"/>
+                          </a:solidFill>
+                          <a:latin typeface="Calibri"/>
+                        </a:defRPr>
+                      </a:pPr>
+                      <a:r>
+                        <a:rPr sz="1000">
+                          <a:solidFill>
+                            <a:srgbClr val="333333"/>
+                          </a:solidFill>
+                        </a:rPr>
+                        <a:t>PrgDist Total</a:t>
                       </a:r>
                     </a:p>
                   </a:txBody>
@@ -18579,8 +18982,21 @@
                     <a:bodyPr/>
                     <a:lstStyle/>
                     <a:p>
-                      <a:r>
-                        <a:t>Shots per 90</a:t>
+                      <a:pPr>
+                        <a:defRPr sz="1100" b="0">
+                          <a:solidFill>
+                            <a:srgbClr val="1C1C1C"/>
+                          </a:solidFill>
+                          <a:latin typeface="Calibri"/>
+                        </a:defRPr>
+                      </a:pPr>
+                      <a:r>
+                        <a:rPr sz="1000">
+                          <a:solidFill>
+                            <a:srgbClr val="333333"/>
+                          </a:solidFill>
+                        </a:rPr>
+                        <a:t>Sh/90 Standard</a:t>
                       </a:r>
                     </a:p>
                   </a:txBody>
@@ -18718,8 +19134,21 @@
                     <a:bodyPr/>
                     <a:lstStyle/>
                     <a:p>
-                      <a:r>
-                        <a:t>Shot blocks</a:t>
+                      <a:pPr>
+                        <a:defRPr sz="1100" b="0">
+                          <a:solidFill>
+                            <a:srgbClr val="1C1C1C"/>
+                          </a:solidFill>
+                          <a:latin typeface="Calibri"/>
+                        </a:defRPr>
+                      </a:pPr>
+                      <a:r>
+                        <a:rPr sz="1000">
+                          <a:solidFill>
+                            <a:srgbClr val="333333"/>
+                          </a:solidFill>
+                        </a:rPr>
+                        <a:t>Sh Standard</a:t>
                       </a:r>
                     </a:p>
                   </a:txBody>
@@ -18857,8 +19286,21 @@
                     <a:bodyPr/>
                     <a:lstStyle/>
                     <a:p>
-                      <a:r>
-                        <a:t>Non-pen xG + xAG</a:t>
+                      <a:pPr>
+                        <a:defRPr sz="1100" b="0">
+                          <a:solidFill>
+                            <a:srgbClr val="1C1C1C"/>
+                          </a:solidFill>
+                          <a:latin typeface="Calibri"/>
+                        </a:defRPr>
+                      </a:pPr>
+                      <a:r>
+                        <a:rPr sz="1000">
+                          <a:solidFill>
+                            <a:srgbClr val="333333"/>
+                          </a:solidFill>
+                        </a:rPr>
+                        <a:t>npxG+xAG Per</a:t>
                       </a:r>
                     </a:p>
                   </a:txBody>
@@ -18996,8 +19438,21 @@
                     <a:bodyPr/>
                     <a:lstStyle/>
                     <a:p>
-                      <a:r>
-                        <a:t>xG + xAG</a:t>
+                      <a:pPr>
+                        <a:defRPr sz="1100" b="0">
+                          <a:solidFill>
+                            <a:srgbClr val="1C1C1C"/>
+                          </a:solidFill>
+                          <a:latin typeface="Calibri"/>
+                        </a:defRPr>
+                      </a:pPr>
+                      <a:r>
+                        <a:rPr sz="1000">
+                          <a:solidFill>
+                            <a:srgbClr val="333333"/>
+                          </a:solidFill>
+                        </a:rPr>
+                        <a:t>xG+xAG Per</a:t>
                       </a:r>
                     </a:p>
                   </a:txBody>
@@ -19135,8 +19590,21 @@
                     <a:bodyPr/>
                     <a:lstStyle/>
                     <a:p>
-                      <a:r>
-                        <a:t>Long pass attempts</a:t>
+                      <a:pPr>
+                        <a:defRPr sz="1100" b="0">
+                          <a:solidFill>
+                            <a:srgbClr val="1C1C1C"/>
+                          </a:solidFill>
+                          <a:latin typeface="Calibri"/>
+                        </a:defRPr>
+                      </a:pPr>
+                      <a:r>
+                        <a:rPr sz="1000">
+                          <a:solidFill>
+                            <a:srgbClr val="333333"/>
+                          </a:solidFill>
+                        </a:rPr>
+                        <a:t>Att Long</a:t>
                       </a:r>
                     </a:p>
                   </a:txBody>
@@ -19274,8 +19742,21 @@
                     <a:bodyPr/>
                     <a:lstStyle/>
                     <a:p>
-                      <a:r>
-                        <a:t>Shots on target</a:t>
+                      <a:pPr>
+                        <a:defRPr sz="1100" b="0">
+                          <a:solidFill>
+                            <a:srgbClr val="1C1C1C"/>
+                          </a:solidFill>
+                          <a:latin typeface="Calibri"/>
+                        </a:defRPr>
+                      </a:pPr>
+                      <a:r>
+                        <a:rPr sz="1000">
+                          <a:solidFill>
+                            <a:srgbClr val="333333"/>
+                          </a:solidFill>
+                        </a:rPr>
+                        <a:t>SoT Standard</a:t>
                       </a:r>
                     </a:p>
                   </a:txBody>
@@ -19413,8 +19894,21 @@
                     <a:bodyPr/>
                     <a:lstStyle/>
                     <a:p>
-                      <a:r>
-                        <a:t>Shots on target per 90</a:t>
+                      <a:pPr>
+                        <a:defRPr sz="1100" b="0">
+                          <a:solidFill>
+                            <a:srgbClr val="1C1C1C"/>
+                          </a:solidFill>
+                          <a:latin typeface="Calibri"/>
+                        </a:defRPr>
+                      </a:pPr>
+                      <a:r>
+                        <a:rPr sz="1000">
+                          <a:solidFill>
+                            <a:srgbClr val="333333"/>
+                          </a:solidFill>
+                        </a:rPr>
+                        <a:t>SoT/90 Standard</a:t>
                       </a:r>
                     </a:p>
                   </a:txBody>
@@ -19552,8 +20046,21 @@
                     <a:bodyPr/>
                     <a:lstStyle/>
                     <a:p>
-                      <a:r>
-                        <a:t>Long pass completions</a:t>
+                      <a:pPr>
+                        <a:defRPr sz="1100" b="0">
+                          <a:solidFill>
+                            <a:srgbClr val="1C1C1C"/>
+                          </a:solidFill>
+                          <a:latin typeface="Calibri"/>
+                        </a:defRPr>
+                      </a:pPr>
+                      <a:r>
+                        <a:rPr sz="1000">
+                          <a:solidFill>
+                            <a:srgbClr val="333333"/>
+                          </a:solidFill>
+                        </a:rPr>
+                        <a:t>Cmp Long</a:t>
                       </a:r>
                     </a:p>
                   </a:txBody>
@@ -19691,8 +20198,21 @@
                     <a:bodyPr/>
                     <a:lstStyle/>
                     <a:p>
-                      <a:r>
-                        <a:t>Medium pass completions</a:t>
+                      <a:pPr>
+                        <a:defRPr sz="1100" b="0">
+                          <a:solidFill>
+                            <a:srgbClr val="1C1C1C"/>
+                          </a:solidFill>
+                          <a:latin typeface="Calibri"/>
+                        </a:defRPr>
+                      </a:pPr>
+                      <a:r>
+                        <a:rPr sz="1000">
+                          <a:solidFill>
+                            <a:srgbClr val="333333"/>
+                          </a:solidFill>
+                        </a:rPr>
+                        <a:t>Cmp Medium</a:t>
                       </a:r>
                     </a:p>
                   </a:txBody>
@@ -19830,8 +20350,21 @@
                     <a:bodyPr/>
                     <a:lstStyle/>
                     <a:p>
-                      <a:r>
-                        <a:t>Medium pass attempts</a:t>
+                      <a:pPr>
+                        <a:defRPr sz="1100" b="0">
+                          <a:solidFill>
+                            <a:srgbClr val="1C1C1C"/>
+                          </a:solidFill>
+                          <a:latin typeface="Calibri"/>
+                        </a:defRPr>
+                      </a:pPr>
+                      <a:r>
+                        <a:rPr sz="1000">
+                          <a:solidFill>
+                            <a:srgbClr val="333333"/>
+                          </a:solidFill>
+                        </a:rPr>
+                        <a:t>Att Medium</a:t>
                       </a:r>
                     </a:p>
                   </a:txBody>
@@ -19969,8 +20502,21 @@
                     <a:bodyPr/>
                     <a:lstStyle/>
                     <a:p>
-                      <a:r>
-                        <a:t>Total pass distance</a:t>
+                      <a:pPr>
+                        <a:defRPr sz="1100" b="0">
+                          <a:solidFill>
+                            <a:srgbClr val="1C1C1C"/>
+                          </a:solidFill>
+                          <a:latin typeface="Calibri"/>
+                        </a:defRPr>
+                      </a:pPr>
+                      <a:r>
+                        <a:rPr sz="1000">
+                          <a:solidFill>
+                            <a:srgbClr val="333333"/>
+                          </a:solidFill>
+                        </a:rPr>
+                        <a:t>TotDist Total</a:t>
                       </a:r>
                     </a:p>
                   </a:txBody>
@@ -20108,8 +20654,21 @@
                     <a:bodyPr/>
                     <a:lstStyle/>
                     <a:p>
-                      <a:r>
-                        <a:t>Progressive passes received (count)</a:t>
+                      <a:pPr>
+                        <a:defRPr sz="1100" b="0">
+                          <a:solidFill>
+                            <a:srgbClr val="1C1C1C"/>
+                          </a:solidFill>
+                          <a:latin typeface="Calibri"/>
+                        </a:defRPr>
+                      </a:pPr>
+                      <a:r>
+                        <a:rPr sz="1000">
+                          <a:solidFill>
+                            <a:srgbClr val="333333"/>
+                          </a:solidFill>
+                        </a:rPr>
+                        <a:t>PrgR Progression</a:t>
                       </a:r>
                     </a:p>
                   </a:txBody>
@@ -20247,8 +20806,21 @@
                     <a:bodyPr/>
                     <a:lstStyle/>
                     <a:p>
-                      <a:r>
-                        <a:t>Goals + assists</a:t>
+                      <a:pPr>
+                        <a:defRPr sz="1100" b="0">
+                          <a:solidFill>
+                            <a:srgbClr val="1C1C1C"/>
+                          </a:solidFill>
+                          <a:latin typeface="Calibri"/>
+                        </a:defRPr>
+                      </a:pPr>
+                      <a:r>
+                        <a:rPr sz="1000">
+                          <a:solidFill>
+                            <a:srgbClr val="333333"/>
+                          </a:solidFill>
+                        </a:rPr>
+                        <a:t>G+A Per</a:t>
                       </a:r>
                     </a:p>
                   </a:txBody>
@@ -20386,8 +20958,21 @@
                     <a:bodyPr/>
                     <a:lstStyle/>
                     <a:p>
-                      <a:r>
-                        <a:t>Free kicks</a:t>
+                      <a:pPr>
+                        <a:defRPr sz="1100" b="0">
+                          <a:solidFill>
+                            <a:srgbClr val="1C1C1C"/>
+                          </a:solidFill>
+                          <a:latin typeface="Calibri"/>
+                        </a:defRPr>
+                      </a:pPr>
+                      <a:r>
+                        <a:rPr sz="1000">
+                          <a:solidFill>
+                            <a:srgbClr val="333333"/>
+                          </a:solidFill>
+                        </a:rPr>
+                        <a:t>FK Standard</a:t>
                       </a:r>
                     </a:p>
                   </a:txBody>
@@ -20700,7 +21285,7 @@
               </a:spcAft>
             </a:pPr>
             <a:r>
-              <a:rPr sz="1100">
+              <a:rPr sz="1100" b="0" dirty="0">
                 <a:solidFill>
                   <a:srgbClr val="333333"/>
                 </a:solidFill>
@@ -20709,133 +21294,186 @@
             </a:r>
           </a:p>
           <a:p>
-            <a:r>
-              <a:rPr sz="1100">
-                <a:solidFill>
-                  <a:srgbClr val="333333"/>
-                </a:solidFill>
-              </a:rPr>
-              <a:t/>
-            </a:r>
-          </a:p>
-          <a:p>
-            <a:r>
-              <a:rPr sz="1100">
-                <a:solidFill>
-                  <a:srgbClr val="333333"/>
-                </a:solidFill>
-              </a:rPr>
-              <a:t>✓  Progressive passes (~10m+ toward goal)  r=0.74</a:t>
-            </a:r>
-          </a:p>
-          <a:p>
-            <a:r>
-              <a:rPr sz="1100">
-                <a:solidFill>
-                  <a:srgbClr val="333333"/>
-                </a:solidFill>
-              </a:rPr>
-              <a:t>✓  Dispossessed (inverted)  r=0.59</a:t>
-            </a:r>
-          </a:p>
-          <a:p>
-            <a:r>
-              <a:rPr sz="1100">
-                <a:solidFill>
-                  <a:srgbClr val="333333"/>
-                </a:solidFill>
-              </a:rPr>
-              <a:t>✓  Pressures  r=0.51</a:t>
-            </a:r>
-          </a:p>
-          <a:p>
-            <a:r>
-              <a:rPr sz="1100">
-                <a:solidFill>
-                  <a:srgbClr val="333333"/>
-                </a:solidFill>
-              </a:rPr>
-              <a:t>✓  Pass volume  r=0.49</a:t>
-            </a:r>
-          </a:p>
-          <a:p>
-            <a:r>
-              <a:rPr sz="1100">
-                <a:solidFill>
-                  <a:srgbClr val="333333"/>
-                </a:solidFill>
-              </a:rPr>
-              <a:t>✓  Clearances  r=0.47</a:t>
-            </a:r>
-          </a:p>
-          <a:p>
-            <a:r>
-              <a:rPr sz="1100">
-                <a:solidFill>
-                  <a:srgbClr val="333333"/>
-                </a:solidFill>
-              </a:rPr>
-              <a:t>✓  Successful dribbles  r=0.46</a:t>
-            </a:r>
-          </a:p>
-          <a:p>
-            <a:r>
-              <a:rPr sz="1100">
-                <a:solidFill>
-                  <a:srgbClr val="333333"/>
-                </a:solidFill>
-              </a:rPr>
-              <a:t>✓  Passes into final third  r=0.42</a:t>
-            </a:r>
-          </a:p>
-          <a:p>
-            <a:r>
-              <a:rPr sz="1100">
-                <a:solidFill>
-                  <a:srgbClr val="333333"/>
-                </a:solidFill>
-              </a:rPr>
-              <a:t>·  Shots  r=0.40 (out)</a:t>
-            </a:r>
-          </a:p>
-          <a:p>
-            <a:r>
-              <a:rPr sz="1100">
-                <a:solidFill>
-                  <a:srgbClr val="333333"/>
-                </a:solidFill>
-              </a:rPr>
-              <a:t>·  Progressive carries  r=0.38 (out)</a:t>
-            </a:r>
-          </a:p>
-          <a:p>
-            <a:r>
-              <a:rPr sz="1100">
-                <a:solidFill>
-                  <a:srgbClr val="333333"/>
-                </a:solidFill>
-              </a:rPr>
-              <a:t>·  Carries  r=0.38 (out)</a:t>
-            </a:r>
-          </a:p>
-          <a:p>
-            <a:r>
-              <a:rPr sz="1100">
-                <a:solidFill>
-                  <a:srgbClr val="333333"/>
-                </a:solidFill>
-              </a:rPr>
-              <a:t>·  Tackles  r=0.34 · Non-pen xG  r=0.30 · Fouls won  r=0.27</a:t>
-            </a:r>
-          </a:p>
-          <a:p>
-            <a:r>
-              <a:rPr sz="1100">
-                <a:solidFill>
-                  <a:srgbClr val="333333"/>
-                </a:solidFill>
-              </a:rPr>
-              <a:t>·  Interceptions  r=0.20 · Expected assists  r=0.13 · Aerials won  r=0.12</a:t>
+            <a:endParaRPr sz="1100" b="0" dirty="0">
+              <a:solidFill>
+                <a:srgbClr val="333333"/>
+              </a:solidFill>
+            </a:endParaRPr>
+          </a:p>
+          <a:p>
+            <a:r>
+              <a:rPr sz="1100" b="0" dirty="0">
+                <a:solidFill>
+                  <a:srgbClr val="333333"/>
+                </a:solidFill>
+              </a:rPr>
+              <a:t>✓  PPC  Progressive passes (~10m+ toward goal)  r=0.74</a:t>
+            </a:r>
+          </a:p>
+          <a:p>
+            <a:r>
+              <a:rPr sz="1100" b="0" dirty="0">
+                <a:solidFill>
+                  <a:srgbClr val="333333"/>
+                </a:solidFill>
+              </a:rPr>
+              <a:t>✓  DIS  Dispossessed (inverted)  r=0.59</a:t>
+            </a:r>
+          </a:p>
+          <a:p>
+            <a:r>
+              <a:rPr sz="1100" b="0" dirty="0">
+                <a:solidFill>
+                  <a:srgbClr val="333333"/>
+                </a:solidFill>
+              </a:rPr>
+              <a:t>✓  PRS  Pressures  r=0.51</a:t>
+            </a:r>
+          </a:p>
+          <a:p>
+            <a:r>
+              <a:rPr sz="1100" b="0" dirty="0">
+                <a:solidFill>
+                  <a:srgbClr val="333333"/>
+                </a:solidFill>
+              </a:rPr>
+              <a:t>✓  PAS  Pass volume  r=0.49</a:t>
+            </a:r>
+          </a:p>
+          <a:p>
+            <a:r>
+              <a:rPr sz="1100" b="0" dirty="0">
+                <a:solidFill>
+                  <a:srgbClr val="333333"/>
+                </a:solidFill>
+              </a:rPr>
+              <a:t>✓  CLR  Clearances  r=0.47</a:t>
+            </a:r>
+          </a:p>
+          <a:p>
+            <a:r>
+              <a:rPr sz="1100" b="0" dirty="0">
+                <a:solidFill>
+                  <a:srgbClr val="333333"/>
+                </a:solidFill>
+              </a:rPr>
+              <a:t>✓  DRB  Successful dribbles  r=0.46</a:t>
+            </a:r>
+          </a:p>
+          <a:p>
+            <a:r>
+              <a:rPr sz="1100" b="0" dirty="0">
+                <a:solidFill>
+                  <a:srgbClr val="333333"/>
+                </a:solidFill>
+              </a:rPr>
+              <a:t>✓  PATT  Passes into final third  r=0.42</a:t>
+            </a:r>
+          </a:p>
+          <a:p>
+            <a:r>
+              <a:rPr sz="1100" b="0" dirty="0">
+                <a:solidFill>
+                  <a:srgbClr val="333333"/>
+                </a:solidFill>
+              </a:rPr>
+              <a:t>·  SH  Shots  r=0.40</a:t>
+            </a:r>
+          </a:p>
+          <a:p>
+            <a:r>
+              <a:rPr sz="1100" b="0" dirty="0">
+                <a:solidFill>
+                  <a:srgbClr val="333333"/>
+                </a:solidFill>
+              </a:rPr>
+              <a:t>·  CFGP  Progressive carries  r=0.38</a:t>
+            </a:r>
+          </a:p>
+          <a:p>
+            <a:r>
+              <a:rPr sz="1100" b="0" dirty="0">
+                <a:solidFill>
+                  <a:srgbClr val="333333"/>
+                </a:solidFill>
+              </a:rPr>
+              <a:t>·  CRY  Carries  r=0.38</a:t>
+            </a:r>
+          </a:p>
+          <a:p>
+            <a:r>
+              <a:rPr sz="1100" b="0" dirty="0">
+                <a:solidFill>
+                  <a:srgbClr val="333333"/>
+                </a:solidFill>
+              </a:rPr>
+              <a:t>·  TAC  Tackles  r=0.34</a:t>
+            </a:r>
+          </a:p>
+          <a:p>
+            <a:r>
+              <a:rPr sz="1100" b="0" dirty="0">
+                <a:solidFill>
+                  <a:srgbClr val="333333"/>
+                </a:solidFill>
+              </a:rPr>
+              <a:t>·  XG  Non-pen </a:t>
+            </a:r>
+            <a:r>
+              <a:rPr sz="1100" b="0" dirty="0" err="1">
+                <a:solidFill>
+                  <a:srgbClr val="333333"/>
+                </a:solidFill>
+              </a:rPr>
+              <a:t>xG</a:t>
+            </a:r>
+            <a:r>
+              <a:rPr sz="1100" b="0" dirty="0">
+                <a:solidFill>
+                  <a:srgbClr val="333333"/>
+                </a:solidFill>
+              </a:rPr>
+              <a:t>  r=0.30</a:t>
+            </a:r>
+          </a:p>
+          <a:p>
+            <a:r>
+              <a:rPr sz="1100" b="0" dirty="0">
+                <a:solidFill>
+                  <a:srgbClr val="333333"/>
+                </a:solidFill>
+              </a:rPr>
+              <a:t>·  FLW  Fouls won  r=0.27</a:t>
+            </a:r>
+          </a:p>
+          <a:p>
+            <a:r>
+              <a:rPr sz="1100" b="0" dirty="0">
+                <a:solidFill>
+                  <a:srgbClr val="333333"/>
+                </a:solidFill>
+              </a:rPr>
+              <a:t>·  INT  Interceptions  r=0.20</a:t>
+            </a:r>
+          </a:p>
+          <a:p>
+            <a:r>
+              <a:rPr sz="1100" b="0" dirty="0">
+                <a:solidFill>
+                  <a:srgbClr val="333333"/>
+                </a:solidFill>
+              </a:rPr>
+              <a:t>·  XA  Expected assists  r=0.13</a:t>
+            </a:r>
+          </a:p>
+          <a:p>
+            <a:r>
+              <a:rPr sz="1100" b="0" dirty="0">
+                <a:solidFill>
+                  <a:srgbClr val="333333"/>
+                </a:solidFill>
+              </a:rPr>
+              <a:t>·  AER  Aerials won  r=0.12</a:t>
             </a:r>
           </a:p>
         </p:txBody>
@@ -20907,8 +21545,21 @@
                     <a:bodyPr/>
                     <a:lstStyle/>
                     <a:p>
-                      <a:r>
-                        <a:t>Code</a:t>
+                      <a:pPr>
+                        <a:defRPr sz="1200" b="1">
+                          <a:solidFill>
+                            <a:srgbClr val="FFFFFF"/>
+                          </a:solidFill>
+                          <a:latin typeface="Calibri"/>
+                        </a:defRPr>
+                      </a:pPr>
+                      <a:r>
+                        <a:rPr sz="1000" b="1" dirty="0">
+                          <a:solidFill>
+                            <a:srgbClr val="333333"/>
+                          </a:solidFill>
+                        </a:rPr>
+                        <a:t>Abbrev</a:t>
                       </a:r>
                     </a:p>
                   </a:txBody>
@@ -20923,8 +21574,21 @@
                     <a:bodyPr/>
                     <a:lstStyle/>
                     <a:p>
-                      <a:r>
-                        <a:t>Metric (full name)</a:t>
+                      <a:pPr>
+                        <a:defRPr sz="1200" b="1">
+                          <a:solidFill>
+                            <a:srgbClr val="FFFFFF"/>
+                          </a:solidFill>
+                          <a:latin typeface="Calibri"/>
+                        </a:defRPr>
+                      </a:pPr>
+                      <a:r>
+                        <a:rPr sz="1000" b="1">
+                          <a:solidFill>
+                            <a:srgbClr val="333333"/>
+                          </a:solidFill>
+                        </a:rPr>
+                        <a:t>Metric</a:t>
                       </a:r>
                     </a:p>
                   </a:txBody>
@@ -21062,7 +21726,20 @@
                     <a:bodyPr/>
                     <a:lstStyle/>
                     <a:p>
-                      <a:r>
+                      <a:pPr>
+                        <a:defRPr sz="1200" b="0">
+                          <a:solidFill>
+                            <a:srgbClr val="1C1C1C"/>
+                          </a:solidFill>
+                          <a:latin typeface="Calibri"/>
+                        </a:defRPr>
+                      </a:pPr>
+                      <a:r>
+                        <a:rPr sz="1000">
+                          <a:solidFill>
+                            <a:srgbClr val="333333"/>
+                          </a:solidFill>
+                        </a:rPr>
                         <a:t>Progressive passes</a:t>
                       </a:r>
                     </a:p>
@@ -21201,8 +21878,21 @@
                     <a:bodyPr/>
                     <a:lstStyle/>
                     <a:p>
-                      <a:r>
-                        <a:t>Dispossessed (inverted)</a:t>
+                      <a:pPr>
+                        <a:defRPr sz="1200" b="0">
+                          <a:solidFill>
+                            <a:srgbClr val="1C1C1C"/>
+                          </a:solidFill>
+                          <a:latin typeface="Calibri"/>
+                        </a:defRPr>
+                      </a:pPr>
+                      <a:r>
+                        <a:rPr sz="1000">
+                          <a:solidFill>
+                            <a:srgbClr val="333333"/>
+                          </a:solidFill>
+                        </a:rPr>
+                        <a:t>Dispossessed (inv)</a:t>
                       </a:r>
                     </a:p>
                   </a:txBody>
@@ -21340,7 +22030,20 @@
                     <a:bodyPr/>
                     <a:lstStyle/>
                     <a:p>
-                      <a:r>
+                      <a:pPr>
+                        <a:defRPr sz="1200" b="0">
+                          <a:solidFill>
+                            <a:srgbClr val="1C1C1C"/>
+                          </a:solidFill>
+                          <a:latin typeface="Calibri"/>
+                        </a:defRPr>
+                      </a:pPr>
+                      <a:r>
+                        <a:rPr sz="1000">
+                          <a:solidFill>
+                            <a:srgbClr val="333333"/>
+                          </a:solidFill>
+                        </a:rPr>
                         <a:t>Pressures</a:t>
                       </a:r>
                     </a:p>
@@ -21479,7 +22182,20 @@
                     <a:bodyPr/>
                     <a:lstStyle/>
                     <a:p>
-                      <a:r>
+                      <a:pPr>
+                        <a:defRPr sz="1200" b="0">
+                          <a:solidFill>
+                            <a:srgbClr val="1C1C1C"/>
+                          </a:solidFill>
+                          <a:latin typeface="Calibri"/>
+                        </a:defRPr>
+                      </a:pPr>
+                      <a:r>
+                        <a:rPr sz="1000">
+                          <a:solidFill>
+                            <a:srgbClr val="333333"/>
+                          </a:solidFill>
+                        </a:rPr>
                         <a:t>Pass volume</a:t>
                       </a:r>
                     </a:p>
@@ -21618,7 +22334,20 @@
                     <a:bodyPr/>
                     <a:lstStyle/>
                     <a:p>
-                      <a:r>
+                      <a:pPr>
+                        <a:defRPr sz="1200" b="0">
+                          <a:solidFill>
+                            <a:srgbClr val="1C1C1C"/>
+                          </a:solidFill>
+                          <a:latin typeface="Calibri"/>
+                        </a:defRPr>
+                      </a:pPr>
+                      <a:r>
+                        <a:rPr sz="1000">
+                          <a:solidFill>
+                            <a:srgbClr val="333333"/>
+                          </a:solidFill>
+                        </a:rPr>
                         <a:t>Clearances</a:t>
                       </a:r>
                     </a:p>
@@ -21757,7 +22486,20 @@
                     <a:bodyPr/>
                     <a:lstStyle/>
                     <a:p>
-                      <a:r>
+                      <a:pPr>
+                        <a:defRPr sz="1200" b="0">
+                          <a:solidFill>
+                            <a:srgbClr val="1C1C1C"/>
+                          </a:solidFill>
+                          <a:latin typeface="Calibri"/>
+                        </a:defRPr>
+                      </a:pPr>
+                      <a:r>
+                        <a:rPr sz="1000">
+                          <a:solidFill>
+                            <a:srgbClr val="333333"/>
+                          </a:solidFill>
+                        </a:rPr>
                         <a:t>Successful dribbles</a:t>
                       </a:r>
                     </a:p>
@@ -21896,7 +22638,20 @@
                     <a:bodyPr/>
                     <a:lstStyle/>
                     <a:p>
-                      <a:r>
+                      <a:pPr>
+                        <a:defRPr sz="1200" b="0">
+                          <a:solidFill>
+                            <a:srgbClr val="1C1C1C"/>
+                          </a:solidFill>
+                          <a:latin typeface="Calibri"/>
+                        </a:defRPr>
+                      </a:pPr>
+                      <a:r>
+                        <a:rPr sz="1000">
+                          <a:solidFill>
+                            <a:srgbClr val="333333"/>
+                          </a:solidFill>
+                        </a:rPr>
                         <a:t>Passes into final third</a:t>
                       </a:r>
                     </a:p>
@@ -22035,7 +22790,20 @@
                     <a:bodyPr/>
                     <a:lstStyle/>
                     <a:p>
-                      <a:r>
+                      <a:pPr>
+                        <a:defRPr sz="1200" b="0">
+                          <a:solidFill>
+                            <a:srgbClr val="1C1C1C"/>
+                          </a:solidFill>
+                          <a:latin typeface="Calibri"/>
+                        </a:defRPr>
+                      </a:pPr>
+                      <a:r>
+                        <a:rPr sz="1000">
+                          <a:solidFill>
+                            <a:srgbClr val="333333"/>
+                          </a:solidFill>
+                        </a:rPr>
                         <a:t>Shots</a:t>
                       </a:r>
                     </a:p>
@@ -22174,7 +22942,20 @@
                     <a:bodyPr/>
                     <a:lstStyle/>
                     <a:p>
-                      <a:r>
+                      <a:pPr>
+                        <a:defRPr sz="1200" b="0">
+                          <a:solidFill>
+                            <a:srgbClr val="1C1C1C"/>
+                          </a:solidFill>
+                          <a:latin typeface="Calibri"/>
+                        </a:defRPr>
+                      </a:pPr>
+                      <a:r>
+                        <a:rPr sz="1000">
+                          <a:solidFill>
+                            <a:srgbClr val="333333"/>
+                          </a:solidFill>
+                        </a:rPr>
                         <a:t>Progressive carries</a:t>
                       </a:r>
                     </a:p>
@@ -22313,7 +23094,20 @@
                     <a:bodyPr/>
                     <a:lstStyle/>
                     <a:p>
-                      <a:r>
+                      <a:pPr>
+                        <a:defRPr sz="1200" b="0">
+                          <a:solidFill>
+                            <a:srgbClr val="1C1C1C"/>
+                          </a:solidFill>
+                          <a:latin typeface="Calibri"/>
+                        </a:defRPr>
+                      </a:pPr>
+                      <a:r>
+                        <a:rPr sz="1000">
+                          <a:solidFill>
+                            <a:srgbClr val="333333"/>
+                          </a:solidFill>
+                        </a:rPr>
                         <a:t>Carries</a:t>
                       </a:r>
                     </a:p>
@@ -22452,7 +23246,20 @@
                     <a:bodyPr/>
                     <a:lstStyle/>
                     <a:p>
-                      <a:r>
+                      <a:pPr>
+                        <a:defRPr sz="1200" b="0">
+                          <a:solidFill>
+                            <a:srgbClr val="1C1C1C"/>
+                          </a:solidFill>
+                          <a:latin typeface="Calibri"/>
+                        </a:defRPr>
+                      </a:pPr>
+                      <a:r>
+                        <a:rPr sz="1000">
+                          <a:solidFill>
+                            <a:srgbClr val="333333"/>
+                          </a:solidFill>
+                        </a:rPr>
                         <a:t>Tackles</a:t>
                       </a:r>
                     </a:p>
@@ -22591,8 +23398,21 @@
                     <a:bodyPr/>
                     <a:lstStyle/>
                     <a:p>
-                      <a:r>
-                        <a:t>Non-penalty expected goals</a:t>
+                      <a:pPr>
+                        <a:defRPr sz="1200" b="0">
+                          <a:solidFill>
+                            <a:srgbClr val="1C1C1C"/>
+                          </a:solidFill>
+                          <a:latin typeface="Calibri"/>
+                        </a:defRPr>
+                      </a:pPr>
+                      <a:r>
+                        <a:rPr sz="1000">
+                          <a:solidFill>
+                            <a:srgbClr val="333333"/>
+                          </a:solidFill>
+                        </a:rPr>
+                        <a:t>Non-pen xG</a:t>
                       </a:r>
                     </a:p>
                   </a:txBody>
@@ -22730,7 +23550,20 @@
                     <a:bodyPr/>
                     <a:lstStyle/>
                     <a:p>
-                      <a:r>
+                      <a:pPr>
+                        <a:defRPr sz="1200" b="0">
+                          <a:solidFill>
+                            <a:srgbClr val="1C1C1C"/>
+                          </a:solidFill>
+                          <a:latin typeface="Calibri"/>
+                        </a:defRPr>
+                      </a:pPr>
+                      <a:r>
+                        <a:rPr sz="1000">
+                          <a:solidFill>
+                            <a:srgbClr val="333333"/>
+                          </a:solidFill>
+                        </a:rPr>
                         <a:t>Fouls won</a:t>
                       </a:r>
                     </a:p>
@@ -22869,7 +23702,20 @@
                     <a:bodyPr/>
                     <a:lstStyle/>
                     <a:p>
-                      <a:r>
+                      <a:pPr>
+                        <a:defRPr sz="1200" b="0">
+                          <a:solidFill>
+                            <a:srgbClr val="1C1C1C"/>
+                          </a:solidFill>
+                          <a:latin typeface="Calibri"/>
+                        </a:defRPr>
+                      </a:pPr>
+                      <a:r>
+                        <a:rPr sz="1000">
+                          <a:solidFill>
+                            <a:srgbClr val="333333"/>
+                          </a:solidFill>
+                        </a:rPr>
                         <a:t>Interceptions</a:t>
                       </a:r>
                     </a:p>
@@ -23008,7 +23854,20 @@
                     <a:bodyPr/>
                     <a:lstStyle/>
                     <a:p>
-                      <a:r>
+                      <a:pPr>
+                        <a:defRPr sz="1200" b="0">
+                          <a:solidFill>
+                            <a:srgbClr val="1C1C1C"/>
+                          </a:solidFill>
+                          <a:latin typeface="Calibri"/>
+                        </a:defRPr>
+                      </a:pPr>
+                      <a:r>
+                        <a:rPr sz="1000">
+                          <a:solidFill>
+                            <a:srgbClr val="333333"/>
+                          </a:solidFill>
+                        </a:rPr>
                         <a:t>Expected assists</a:t>
                       </a:r>
                     </a:p>
@@ -23147,7 +24006,20 @@
                     <a:bodyPr/>
                     <a:lstStyle/>
                     <a:p>
-                      <a:r>
+                      <a:pPr>
+                        <a:defRPr sz="1200" b="0">
+                          <a:solidFill>
+                            <a:srgbClr val="1C1C1C"/>
+                          </a:solidFill>
+                          <a:latin typeface="Calibri"/>
+                        </a:defRPr>
+                      </a:pPr>
+                      <a:r>
+                        <a:rPr sz="1000">
+                          <a:solidFill>
+                            <a:srgbClr val="333333"/>
+                          </a:solidFill>
+                        </a:rPr>
                         <a:t>Aerials won</a:t>
                       </a:r>
                     </a:p>
@@ -23263,7 +24135,7 @@
         </p:nvSpPr>
         <p:spPr>
           <a:xfrm>
-            <a:off x="411480" y="6263640"/>
+            <a:off x="280852" y="5897880"/>
             <a:ext cx="10972800" cy="274320"/>
           </a:xfrm>
           <a:prstGeom prst="rect">
@@ -23283,7 +24155,7 @@
               </a:spcAft>
             </a:pPr>
             <a:r>
-              <a:rPr sz="1100" b="0">
+              <a:rPr sz="1100" b="0" dirty="0">
                 <a:solidFill>
                   <a:srgbClr val="333333"/>
                 </a:solidFill>
@@ -23293,7 +24165,7 @@
           </a:p>
           <a:p>
             <a:r>
-              <a:rPr sz="1100" b="0">
+              <a:rPr sz="1100" b="0" dirty="0">
                 <a:solidFill>
                   <a:srgbClr val="333333"/>
                 </a:solidFill>
@@ -23302,18 +24174,15 @@
             </a:r>
           </a:p>
           <a:p>
-            <a:r>
-              <a:rPr sz="1100" b="0">
-                <a:solidFill>
-                  <a:srgbClr val="333333"/>
-                </a:solidFill>
-              </a:rPr>
-              <a:t/>
-            </a:r>
-          </a:p>
-          <a:p>
-            <a:r>
-              <a:rPr sz="1100" b="0">
+            <a:endParaRPr sz="1100" b="0" dirty="0">
+              <a:solidFill>
+                <a:srgbClr val="333333"/>
+              </a:solidFill>
+            </a:endParaRPr>
+          </a:p>
+          <a:p>
+            <a:r>
+              <a:rPr sz="1100" b="0" dirty="0">
                 <a:solidFill>
                   <a:srgbClr val="333333"/>
                 </a:solidFill>
@@ -23391,7 +24260,7 @@
         </p:nvSpPr>
         <p:spPr>
           <a:xfrm>
-            <a:off x="0" y="0"/>
+            <a:off x="305" y="0"/>
             <a:ext cx="12191695" cy="6858000"/>
           </a:xfrm>
           <a:prstGeom prst="rect">
@@ -23435,7 +24304,7 @@
         </p:nvSpPr>
         <p:spPr>
           <a:xfrm>
-            <a:off x="411480" y="201168"/>
+            <a:off x="411480" y="317639"/>
             <a:ext cx="10972800" cy="292388"/>
           </a:xfrm>
           <a:prstGeom prst="rect">
@@ -23586,102 +24455,163 @@
               </a:spcAft>
             </a:pPr>
             <a:r>
-              <a:rPr sz="1100">
-                <a:solidFill>
-                  <a:srgbClr val="333333"/>
-                </a:solidFill>
-              </a:rPr>
-              <a:t>StatsBomb shortlist (7)</a:t>
-            </a:r>
-          </a:p>
-          <a:p>
-            <a:r>
-              <a:rPr sz="1100">
-                <a:solidFill>
-                  <a:srgbClr val="333333"/>
-                </a:solidFill>
+              <a:rPr sz="1600" b="1" dirty="0" err="1">
+                <a:solidFill>
+                  <a:srgbClr val="3D5A80"/>
+                </a:solidFill>
+                <a:latin typeface="Calibri"/>
+              </a:rPr>
+              <a:t>StatsBomb</a:t>
+            </a:r>
+            <a:r>
+              <a:rPr sz="1600" b="1" dirty="0">
+                <a:solidFill>
+                  <a:srgbClr val="3D5A80"/>
+                </a:solidFill>
+                <a:latin typeface="Calibri"/>
+              </a:rPr>
+              <a:t> shortlist (7)</a:t>
+            </a:r>
+          </a:p>
+          <a:p>
+            <a:pPr>
+              <a:spcAft>
+                <a:spcPts val="300"/>
+              </a:spcAft>
+            </a:pPr>
+            <a:r>
+              <a:rPr sz="1200" b="0" dirty="0">
+                <a:solidFill>
+                  <a:srgbClr val="555555"/>
+                </a:solidFill>
+                <a:latin typeface="Calibri"/>
               </a:rPr>
               <a:t>Stability r≥0.40 · redundancy |r|≥0.85 (passes kept)</a:t>
             </a:r>
           </a:p>
           <a:p>
-            <a:r>
-              <a:rPr sz="1100">
-                <a:solidFill>
-                  <a:srgbClr val="333333"/>
-                </a:solidFill>
-              </a:rPr>
-              <a:t/>
-            </a:r>
-          </a:p>
-          <a:p>
-            <a:r>
-              <a:rPr sz="1100">
-                <a:solidFill>
-                  <a:srgbClr val="333333"/>
-                </a:solidFill>
-              </a:rPr>
-              <a:t>Progressive passes  r=0.74</a:t>
-            </a:r>
-          </a:p>
-          <a:p>
-            <a:r>
-              <a:rPr sz="1100">
-                <a:solidFill>
-                  <a:srgbClr val="333333"/>
-                </a:solidFill>
-              </a:rPr>
-              <a:t>Dispossessed (inverted)  r=0.59</a:t>
-            </a:r>
-          </a:p>
-          <a:p>
-            <a:r>
-              <a:rPr sz="1100">
-                <a:solidFill>
-                  <a:srgbClr val="333333"/>
-                </a:solidFill>
-              </a:rPr>
-              <a:t>Pressures  r=0.51</a:t>
-            </a:r>
-          </a:p>
-          <a:p>
-            <a:r>
-              <a:rPr sz="1100">
-                <a:solidFill>
-                  <a:srgbClr val="333333"/>
-                </a:solidFill>
-              </a:rPr>
-              <a:t>Pass volume  r=0.49</a:t>
-            </a:r>
-          </a:p>
-          <a:p>
-            <a:r>
-              <a:rPr sz="1100">
-                <a:solidFill>
-                  <a:srgbClr val="333333"/>
-                </a:solidFill>
-              </a:rPr>
-              <a:t>Clearances  r=0.47</a:t>
-            </a:r>
-          </a:p>
-          <a:p>
-            <a:r>
-              <a:rPr sz="1100">
-                <a:solidFill>
-                  <a:srgbClr val="333333"/>
-                </a:solidFill>
-              </a:rPr>
-              <a:t>Successful dribbles  r=0.46</a:t>
-            </a:r>
-          </a:p>
-          <a:p>
-            <a:r>
-              <a:rPr sz="1100">
-                <a:solidFill>
-                  <a:srgbClr val="333333"/>
-                </a:solidFill>
-              </a:rPr>
-              <a:t>Passes into final third  r=0.42</a:t>
+            <a:pPr>
+              <a:spcAft>
+                <a:spcPts val="300"/>
+              </a:spcAft>
+            </a:pPr>
+            <a:endParaRPr sz="1200" b="0" dirty="0">
+              <a:solidFill>
+                <a:srgbClr val="555555"/>
+              </a:solidFill>
+              <a:latin typeface="Calibri"/>
+            </a:endParaRPr>
+          </a:p>
+          <a:p>
+            <a:pPr>
+              <a:spcAft>
+                <a:spcPts val="300"/>
+              </a:spcAft>
+            </a:pPr>
+            <a:r>
+              <a:rPr sz="1300" b="0" dirty="0">
+                <a:solidFill>
+                  <a:srgbClr val="333333"/>
+                </a:solidFill>
+                <a:latin typeface="Calibri"/>
+              </a:rPr>
+              <a:t>PPC  Progressive passes  r=0.74</a:t>
+            </a:r>
+          </a:p>
+          <a:p>
+            <a:pPr>
+              <a:spcAft>
+                <a:spcPts val="300"/>
+              </a:spcAft>
+            </a:pPr>
+            <a:r>
+              <a:rPr sz="1300" b="0" dirty="0">
+                <a:solidFill>
+                  <a:srgbClr val="333333"/>
+                </a:solidFill>
+                <a:latin typeface="Calibri"/>
+              </a:rPr>
+              <a:t>DIS  Dispossessed (inv)  r=0.59</a:t>
+            </a:r>
+          </a:p>
+          <a:p>
+            <a:pPr>
+              <a:spcAft>
+                <a:spcPts val="300"/>
+              </a:spcAft>
+            </a:pPr>
+            <a:r>
+              <a:rPr sz="1300" b="0" dirty="0">
+                <a:solidFill>
+                  <a:srgbClr val="333333"/>
+                </a:solidFill>
+                <a:latin typeface="Calibri"/>
+              </a:rPr>
+              <a:t>PRS  Pressures  r=0.51</a:t>
+            </a:r>
+          </a:p>
+          <a:p>
+            <a:pPr>
+              <a:spcAft>
+                <a:spcPts val="300"/>
+              </a:spcAft>
+            </a:pPr>
+            <a:r>
+              <a:rPr sz="1300" b="0" dirty="0">
+                <a:solidFill>
+                  <a:srgbClr val="333333"/>
+                </a:solidFill>
+                <a:latin typeface="Calibri"/>
+              </a:rPr>
+              <a:t>PAS  Pass volume  r=0.49</a:t>
+            </a:r>
+          </a:p>
+          <a:p>
+            <a:pPr>
+              <a:spcAft>
+                <a:spcPts val="300"/>
+              </a:spcAft>
+            </a:pPr>
+            <a:r>
+              <a:rPr sz="1300" b="0" dirty="0">
+                <a:solidFill>
+                  <a:srgbClr val="333333"/>
+                </a:solidFill>
+                <a:latin typeface="Calibri"/>
+              </a:rPr>
+              <a:t>CLR  Clearances  r=0.47</a:t>
+            </a:r>
+          </a:p>
+          <a:p>
+            <a:pPr>
+              <a:spcAft>
+                <a:spcPts val="300"/>
+              </a:spcAft>
+            </a:pPr>
+            <a:r>
+              <a:rPr sz="1300" b="0" dirty="0">
+                <a:solidFill>
+                  <a:srgbClr val="333333"/>
+                </a:solidFill>
+                <a:latin typeface="Calibri"/>
+              </a:rPr>
+              <a:t>DRB  Dribbles completed  r=0.46</a:t>
+            </a:r>
+          </a:p>
+          <a:p>
+            <a:pPr>
+              <a:spcAft>
+                <a:spcPts val="300"/>
+              </a:spcAft>
+            </a:pPr>
+            <a:r>
+              <a:rPr sz="1300" b="0" dirty="0">
+                <a:solidFill>
+                  <a:srgbClr val="333333"/>
+                </a:solidFill>
+                <a:latin typeface="Calibri"/>
+              </a:rPr>
+              <a:t>PATT  Passes into final third  r=0.42</a:t>
             </a:r>
           </a:p>
         </p:txBody>
@@ -23797,7 +24727,7 @@
         </p:nvSpPr>
         <p:spPr>
           <a:xfrm>
-            <a:off x="6321083" y="1413801"/>
+            <a:off x="6318504" y="1373874"/>
             <a:ext cx="5212080" cy="1405513"/>
           </a:xfrm>
           <a:prstGeom prst="rect">
@@ -23817,17 +24747,25 @@
               </a:spcAft>
             </a:pPr>
             <a:r>
-              <a:rPr sz="1100">
-                <a:solidFill>
-                  <a:srgbClr val="333333"/>
-                </a:solidFill>
-              </a:rPr>
-              <a:t>FBref: 43 cleared stability → 32 kept</a:t>
-            </a:r>
-          </a:p>
-          <a:p>
-            <a:r>
-              <a:rPr sz="1100">
+              <a:rPr sz="1100" b="0" dirty="0" err="1">
+                <a:solidFill>
+                  <a:srgbClr val="333333"/>
+                </a:solidFill>
+              </a:rPr>
+              <a:t>FBref</a:t>
+            </a:r>
+            <a:r>
+              <a:rPr sz="1100" b="0" dirty="0">
+                <a:solidFill>
+                  <a:srgbClr val="333333"/>
+                </a:solidFill>
+              </a:rPr>
+              <a:t>: 43 cleared stability → 32 kept</a:t>
+            </a:r>
+          </a:p>
+          <a:p>
+            <a:r>
+              <a:rPr sz="1100" b="0" dirty="0">
                 <a:solidFill>
                   <a:srgbClr val="333333"/>
                 </a:solidFill>
@@ -23837,7 +24775,7 @@
           </a:p>
           <a:p>
             <a:r>
-              <a:rPr sz="1100">
+              <a:rPr sz="1100" b="0" dirty="0">
                 <a:solidFill>
                   <a:srgbClr val="333333"/>
                 </a:solidFill>
@@ -23847,7 +24785,7 @@
           </a:p>
           <a:p>
             <a:r>
-              <a:rPr sz="1100">
+              <a:rPr sz="1100" b="0" dirty="0">
                 <a:solidFill>
                   <a:srgbClr val="333333"/>
                 </a:solidFill>
@@ -23857,12 +24795,12 @@
           </a:p>
           <a:p>
             <a:r>
-              <a:rPr sz="1100">
-                <a:solidFill>
-                  <a:srgbClr val="333333"/>
-                </a:solidFill>
-              </a:rPr>
-              <a:t>Top stability examples: Defensive penalty-area touches (0.91) · Progressive carries (0.81) · Expected goals (0.80)</a:t>
+              <a:rPr sz="1100" b="0" dirty="0">
+                <a:solidFill>
+                  <a:srgbClr val="333333"/>
+                </a:solidFill>
+              </a:rPr>
+              <a:t>Top stability examples: DEFPE (0.91) · PRGC (0.81) · XG (0.80)</a:t>
             </a:r>
           </a:p>
         </p:txBody>
@@ -23875,7 +24813,7 @@
         </p:nvSpPr>
         <p:spPr>
           <a:xfrm>
-            <a:off x="6318504" y="2304288"/>
+            <a:off x="6318504" y="2708038"/>
             <a:ext cx="5212080" cy="237744"/>
           </a:xfrm>
           <a:prstGeom prst="rect">
@@ -23891,7 +24829,7 @@
           <a:p>
             <a:pPr algn="l"/>
             <a:r>
-              <a:rPr sz="1300" b="1">
+              <a:rPr sz="1300" b="1" dirty="0">
                 <a:solidFill>
                   <a:srgbClr val="222222"/>
                 </a:solidFill>
@@ -23909,7 +24847,7 @@
         </p:nvSpPr>
         <p:spPr>
           <a:xfrm>
-            <a:off x="6318504" y="2926080"/>
+            <a:off x="6318504" y="3222955"/>
             <a:ext cx="5212080" cy="237744"/>
           </a:xfrm>
           <a:prstGeom prst="rect">
@@ -23943,7 +24881,7 @@
         </p:nvSpPr>
         <p:spPr>
           <a:xfrm>
-            <a:off x="6318504" y="2542032"/>
+            <a:off x="6318504" y="2945782"/>
             <a:ext cx="5394960" cy="365760"/>
           </a:xfrm>
           <a:prstGeom prst="rect">
@@ -23959,12 +24897,12 @@
           <a:p>
             <a:pPr algn="l"/>
             <a:r>
-              <a:rPr sz="1000">
-                <a:solidFill>
-                  <a:srgbClr val="333333"/>
-                </a:solidFill>
-              </a:rPr>
-              <a:t>Expected goals (0.80) · Goals (0.66) · Shots on target (0.56)</a:t>
+              <a:rPr sz="1100" b="0" dirty="0">
+                <a:solidFill>
+                  <a:srgbClr val="333333"/>
+                </a:solidFill>
+              </a:rPr>
+              <a:t>XG (0.80)  ·  GLS (0.66)  ·  ATTSH (0.56)</a:t>
             </a:r>
           </a:p>
         </p:txBody>
@@ -23977,7 +24915,7 @@
         </p:nvSpPr>
         <p:spPr>
           <a:xfrm>
-            <a:off x="6318504" y="3611880"/>
+            <a:off x="6318504" y="3908755"/>
             <a:ext cx="5212080" cy="237744"/>
           </a:xfrm>
           <a:prstGeom prst="rect">
@@ -24011,7 +24949,7 @@
         </p:nvSpPr>
         <p:spPr>
           <a:xfrm>
-            <a:off x="6318504" y="3163824"/>
+            <a:off x="6318504" y="3460699"/>
             <a:ext cx="5394960" cy="365760"/>
           </a:xfrm>
           <a:prstGeom prst="rect">
@@ -24027,12 +24965,12 @@
           <a:p>
             <a:pPr algn="l"/>
             <a:r>
-              <a:rPr sz="900">
-                <a:solidFill>
-                  <a:srgbClr val="333333"/>
-                </a:solidFill>
-              </a:rPr>
-              <a:t>Progressive carries (0.81) · Progressive carry distance (0.79) · Key passes (0.65) · Final-third passes (0.62) · Medium completion % (0.64) · Crosses into box (0.59) · Crosses (0.68)</a:t>
+              <a:rPr sz="1100" b="0">
+                <a:solidFill>
+                  <a:srgbClr val="333333"/>
+                </a:solidFill>
+              </a:rPr>
+              <a:t>PRGC (0.81)  ·  PRGDI (0.79)  ·  KP (0.65)  ·  FINAL (0.62)  ·  CMPPE (0.64)  ·  CRSPA (0.59)  ·  CRS (0.68)</a:t>
             </a:r>
           </a:p>
         </p:txBody>
@@ -24045,7 +24983,7 @@
         </p:nvSpPr>
         <p:spPr>
           <a:xfrm>
-            <a:off x="6318504" y="4297680"/>
+            <a:off x="6318504" y="4594555"/>
             <a:ext cx="5212080" cy="237744"/>
           </a:xfrm>
           <a:prstGeom prst="rect">
@@ -24079,7 +25017,7 @@
         </p:nvSpPr>
         <p:spPr>
           <a:xfrm>
-            <a:off x="6318504" y="3849624"/>
+            <a:off x="6318504" y="4146499"/>
             <a:ext cx="5394960" cy="365760"/>
           </a:xfrm>
           <a:prstGeom prst="rect">
@@ -24095,12 +25033,12 @@
           <a:p>
             <a:pPr algn="l"/>
             <a:r>
-              <a:rPr sz="900">
-                <a:solidFill>
-                  <a:srgbClr val="333333"/>
-                </a:solidFill>
-              </a:rPr>
-              <a:t>Progressive receives (0.60) · Attacking-third touches (0.54) · Successful take-ons (0.65) · Miscontrols (0.37)</a:t>
+              <a:rPr sz="1100" b="0">
+                <a:solidFill>
+                  <a:srgbClr val="333333"/>
+                </a:solidFill>
+              </a:rPr>
+              <a:t>PRGRR (0.60)  ·  ATT3R (0.54)  ·  SUCC (0.65)  ·  MIS (0.37)</a:t>
             </a:r>
           </a:p>
         </p:txBody>
@@ -24113,7 +25051,7 @@
         </p:nvSpPr>
         <p:spPr>
           <a:xfrm>
-            <a:off x="6318504" y="5074920"/>
+            <a:off x="6318504" y="5371795"/>
             <a:ext cx="5212080" cy="237744"/>
           </a:xfrm>
           <a:prstGeom prst="rect">
@@ -24147,7 +25085,7 @@
         </p:nvSpPr>
         <p:spPr>
           <a:xfrm>
-            <a:off x="6318504" y="4535424"/>
+            <a:off x="6318504" y="4832299"/>
             <a:ext cx="5394960" cy="502920"/>
           </a:xfrm>
           <a:prstGeom prst="rect">
@@ -24163,12 +25101,12 @@
           <a:p>
             <a:pPr algn="l"/>
             <a:r>
-              <a:rPr sz="900">
-                <a:solidFill>
-                  <a:srgbClr val="333333"/>
-                </a:solidFill>
-              </a:rPr>
-              <a:t>Defensive box touches (0.91) · Clearances (0.67) · Tackled take-ons (0.59) · Aerials won (0.42) · Shot blocks (0.79) · Interceptions (0.57) · Aerials lost (0.42) · Aerial win % (0.50) · Defensive-third touches (0.79) · Tackle % (0.31) · Recoveries (0.40)</a:t>
+              <a:rPr sz="1100" b="0">
+                <a:solidFill>
+                  <a:srgbClr val="333333"/>
+                </a:solidFill>
+              </a:rPr>
+              <a:t>DEFPE (0.91)  ·  CLR (0.67)  ·  TKLD (0.59)  ·  WON (0.42)  ·  SH (0.79)  ·  INT (0.57)  ·  LOST (0.42)  ·  WONPE (0.50)  ·  DEF3R (0.79)  ·  TKLPE (0.31)  ·  RECOV (0.40)</a:t>
             </a:r>
           </a:p>
         </p:txBody>
@@ -24181,7 +25119,7 @@
         </p:nvSpPr>
         <p:spPr>
           <a:xfrm>
-            <a:off x="6318504" y="5312664"/>
+            <a:off x="6318504" y="5609539"/>
             <a:ext cx="5394960" cy="365760"/>
           </a:xfrm>
           <a:prstGeom prst="rect">
@@ -24196,12 +25134,12 @@
           <a:lstStyle/>
           <a:p>
             <a:r>
-              <a:rPr sz="1000">
-                <a:solidFill>
-                  <a:srgbClr val="333333"/>
-                </a:solidFill>
-              </a:rPr>
-              <a:t>Fouls drawn (0.53)</a:t>
+              <a:rPr sz="1100" b="0">
+                <a:solidFill>
+                  <a:srgbClr val="333333"/>
+                </a:solidFill>
+              </a:rPr>
+              <a:t>FLD (0.53)</a:t>
             </a:r>
           </a:p>
         </p:txBody>

</xml_diff>

<commit_message>
Merge manual slide wording and strengthen takeaways.
Keep trimming-the-metrics language on the success slide and state that prior player profile matters more than feeder-league label.

Co-authored-by: Cursor <cursoragent@cursor.com>
</commit_message>
<xml_diff>
--- a/bundesliga_transfer_traits.pptx
+++ b/bundesliga_transfer_traits.pptx
@@ -5698,7 +5698,7 @@
                   <a:srgbClr val="333333"/>
                 </a:solidFill>
               </a:rPr>
-              <a:t>Phase 2: after shortlisting, test what lines up with Bundesliga success.</a:t>
+              <a:t>Phase 2: after trimming the metrics to the portable shortlist, test what lines up with Bundesliga success.</a:t>
             </a:r>
           </a:p>
           <a:p>
@@ -6655,52 +6655,112 @@
               </a:spcAft>
             </a:pPr>
             <a:r>
-              <a:rPr sz="1200" b="0">
-                <a:solidFill>
-                  <a:srgbClr val="333333"/>
-                </a:solidFill>
-              </a:rPr>
-              <a:t>Primary success marker: minutes played in the player’s first 1. Bundesliga season (“Year 1 in Bundesliga minutes”).</a:t>
-            </a:r>
-          </a:p>
-          <a:p>
-            <a:r>
-              <a:rPr sz="1200" b="0">
-                <a:solidFill>
-                  <a:srgbClr val="333333"/>
-                </a:solidFill>
-              </a:rPr>
-              <a:t>Plain English: did the club trust and use the inbound player (playing-time success)?</a:t>
-            </a:r>
-          </a:p>
-          <a:p>
-            <a:r>
-              <a:rPr sz="1200" b="0">
-                <a:solidFill>
-                  <a:srgbClr val="333333"/>
-                </a:solidFill>
-              </a:rPr>
-              <a:t>Also reported (secondary): Year 1 minutes percentile (rank in cohort) and stable-trait score (how strong the Year 1 profile looks on portable traits).</a:t>
-            </a:r>
-          </a:p>
-          <a:p>
-            <a:r>
-              <a:rPr sz="1200" b="0">
-                <a:solidFill>
-                  <a:srgbClr val="333333"/>
-                </a:solidFill>
-              </a:rPr>
-              <a:t>Trait &amp; league tests ask: which prior signals line up with more Year 1 minutes?</a:t>
-            </a:r>
-          </a:p>
-          <a:p>
-            <a:r>
-              <a:rPr sz="1200" b="0">
-                <a:solidFill>
-                  <a:srgbClr val="333333"/>
-                </a:solidFill>
-              </a:rPr>
-              <a:t>Regression Δ Year 1 minutes = estimated extra first-season minutes vs a reference league (Serie A), holding controls.</a:t>
+              <a:rPr sz="1200">
+                <a:solidFill>
+                  <a:srgbClr val="333333"/>
+                </a:solidFill>
+              </a:rPr>
+              <a:t>Primary success marker: minutes played in the player’s first Bundesliga season (“Year 1 in Bundesliga minutes”).</a:t>
+            </a:r>
+          </a:p>
+          <a:p>
+            <a:r>
+              <a:rPr sz="1200">
+                <a:solidFill>
+                  <a:srgbClr val="333333"/>
+                </a:solidFill>
+              </a:rPr>
+              <a:t/>
+            </a:r>
+          </a:p>
+          <a:p>
+            <a:r>
+              <a:rPr sz="1200">
+                <a:solidFill>
+                  <a:srgbClr val="333333"/>
+                </a:solidFill>
+              </a:rPr>
+              <a:t>Success means the club gave the inbound player playing time — not goals scored and not market value.</a:t>
+            </a:r>
+          </a:p>
+          <a:p>
+            <a:r>
+              <a:rPr sz="1200">
+                <a:solidFill>
+                  <a:srgbClr val="333333"/>
+                </a:solidFill>
+              </a:rPr>
+              <a:t/>
+            </a:r>
+          </a:p>
+          <a:p>
+            <a:r>
+              <a:rPr sz="1200">
+                <a:solidFill>
+                  <a:srgbClr val="333333"/>
+                </a:solidFill>
+              </a:rPr>
+              <a:t>Also reported (secondary):</a:t>
+            </a:r>
+          </a:p>
+          <a:p>
+            <a:r>
+              <a:rPr sz="1200">
+                <a:solidFill>
+                  <a:srgbClr val="333333"/>
+                </a:solidFill>
+              </a:rPr>
+              <a:t>• Year 1 minutes percentile — where that player’s minutes rank among peers in the study</a:t>
+            </a:r>
+          </a:p>
+          <a:p>
+            <a:r>
+              <a:rPr sz="1200">
+                <a:solidFill>
+                  <a:srgbClr val="333333"/>
+                </a:solidFill>
+              </a:rPr>
+              <a:t>• Stable-trait score — how strong the Year 1 profile looks on the portable traits</a:t>
+            </a:r>
+          </a:p>
+          <a:p>
+            <a:r>
+              <a:rPr sz="1200">
+                <a:solidFill>
+                  <a:srgbClr val="333333"/>
+                </a:solidFill>
+              </a:rPr>
+              <a:t/>
+            </a:r>
+          </a:p>
+          <a:p>
+            <a:r>
+              <a:rPr sz="1200">
+                <a:solidFill>
+                  <a:srgbClr val="333333"/>
+                </a:solidFill>
+              </a:rPr>
+              <a:t>Trait and league tests ask: which prior signals line up with more Year 1 minutes?</a:t>
+            </a:r>
+          </a:p>
+          <a:p>
+            <a:r>
+              <a:rPr sz="1200">
+                <a:solidFill>
+                  <a:srgbClr val="333333"/>
+                </a:solidFill>
+              </a:rPr>
+              <a:t/>
+            </a:r>
+          </a:p>
+          <a:p>
+            <a:r>
+              <a:rPr sz="1200">
+                <a:solidFill>
+                  <a:srgbClr val="333333"/>
+                </a:solidFill>
+              </a:rPr>
+              <a:t>Regression Δ Year 1 minutes = estimated extra first-season minutes versus a reference league (Serie A), holding other controls fixed.</a:t>
             </a:r>
           </a:p>
         </p:txBody>
@@ -13993,7 +14053,7 @@
               </a:spcAft>
             </a:pPr>
             <a:r>
-              <a:rPr sz="1400" b="0">
+              <a:rPr sz="1300">
                 <a:solidFill>
                   <a:srgbClr val="333333"/>
                 </a:solidFill>
@@ -14008,16 +14068,18 @@
             </a:endParaRPr>
           </a:p>
           <a:p>
-            <a:endParaRPr lang="en-US" sz="2400" b="1" dirty="0">
-              <a:solidFill>
-                <a:srgbClr val="3D5A80"/>
-              </a:solidFill>
-              <a:latin typeface="Calibri"/>
-            </a:endParaRPr>
-          </a:p>
-          <a:p>
-            <a:r>
-              <a:rPr sz="1400" b="0">
+            <a:r>
+              <a:rPr sz="1300">
+                <a:solidFill>
+                  <a:srgbClr val="333333"/>
+                </a:solidFill>
+              </a:rPr>
+              <a:t/>
+            </a:r>
+          </a:p>
+          <a:p>
+            <a:r>
+              <a:rPr sz="1300">
                 <a:solidFill>
                   <a:srgbClr val="333333"/>
                 </a:solidFill>
@@ -14026,32 +14088,38 @@
             </a:r>
           </a:p>
           <a:p>
-            <a:endParaRPr sz="1400" b="0">
-              <a:solidFill>
-                <a:srgbClr val="333333"/>
-              </a:solidFill>
-            </a:endParaRPr>
-          </a:p>
-          <a:p>
-            <a:r>
-              <a:rPr sz="1400" b="0">
-                <a:solidFill>
-                  <a:srgbClr val="333333"/>
-                </a:solidFill>
-              </a:rPr>
-              <a:t>• Feeder-league gaps are modest; exploratory OLS (N=117) — traits matter more than league label</a:t>
-            </a:r>
-          </a:p>
-          <a:p>
-            <a:endParaRPr sz="1400" b="0">
-              <a:solidFill>
-                <a:srgbClr val="333333"/>
-              </a:solidFill>
-            </a:endParaRPr>
-          </a:p>
-          <a:p>
-            <a:r>
-              <a:rPr sz="1400" b="0">
+            <a:r>
+              <a:rPr sz="1300">
+                <a:solidFill>
+                  <a:srgbClr val="333333"/>
+                </a:solidFill>
+              </a:rPr>
+              <a:t/>
+            </a:r>
+          </a:p>
+          <a:p>
+            <a:r>
+              <a:rPr sz="1300">
+                <a:solidFill>
+                  <a:srgbClr val="333333"/>
+                </a:solidFill>
+              </a:rPr>
+              <a:t>• The player (prior trait profile) matters more than the feeder-league label: exploratory OLS (N=117) finds league gaps modest/non-significant once controls and traits are included, while adding traits raises fit more than league names alone</a:t>
+            </a:r>
+          </a:p>
+          <a:p>
+            <a:r>
+              <a:rPr sz="1300">
+                <a:solidFill>
+                  <a:srgbClr val="333333"/>
+                </a:solidFill>
+              </a:rPr>
+              <a:t/>
+            </a:r>
+          </a:p>
+          <a:p>
+            <a:r>
+              <a:rPr sz="1300">
                 <a:solidFill>
                   <a:srgbClr val="333333"/>
                 </a:solidFill>
@@ -14060,15 +14128,18 @@
             </a:r>
           </a:p>
           <a:p>
-            <a:endParaRPr sz="1400" b="0">
-              <a:solidFill>
-                <a:srgbClr val="333333"/>
-              </a:solidFill>
-            </a:endParaRPr>
-          </a:p>
-          <a:p>
-            <a:r>
-              <a:rPr sz="1400" b="0">
+            <a:r>
+              <a:rPr sz="1300">
+                <a:solidFill>
+                  <a:srgbClr val="333333"/>
+                </a:solidFill>
+              </a:rPr>
+              <a:t/>
+            </a:r>
+          </a:p>
+          <a:p>
+            <a:r>
+              <a:rPr sz="1300">
                 <a:solidFill>
                   <a:srgbClr val="333333"/>
                 </a:solidFill>

</xml_diff>

<commit_message>
Add feeder-to-Bundesliga graphics on title and design slides.
Show labeled prior-league badges converging into the Bundesliga destination so the inbound design is visible at a glance.

Co-authored-by: Cursor <cursoragent@cursor.com>
</commit_message>
<xml_diff>
--- a/bundesliga_transfer_traits.pptx
+++ b/bundesliga_transfer_traits.pptx
@@ -3240,49 +3240,12 @@
           <a:p>
             <a:pPr algn="l"/>
             <a:r>
-              <a:rPr sz="2800" b="1" dirty="0">
+              <a:rPr sz="2200" b="1">
                 <a:solidFill>
                   <a:srgbClr val="222222"/>
                 </a:solidFill>
-                <a:latin typeface="Georgia"/>
-              </a:rPr>
-              <a:t>Which traits</a:t>
-            </a:r>
-            <a:r>
-              <a:rPr lang="en-US" sz="2800" b="1" dirty="0">
-                <a:solidFill>
-                  <a:srgbClr val="222222"/>
-                </a:solidFill>
-                <a:latin typeface="Georgia"/>
-              </a:rPr>
-              <a:t> most accurately </a:t>
-            </a:r>
-            <a:r>
-              <a:rPr sz="2800" b="1" dirty="0">
-                <a:solidFill>
-                  <a:srgbClr val="222222"/>
-                </a:solidFill>
-                <a:latin typeface="Georgia"/>
-              </a:rPr>
-              <a:t>travel into the Bundesliga</a:t>
-            </a:r>
-            <a:r>
-              <a:rPr lang="en-US" sz="2800" b="1" dirty="0">
-                <a:solidFill>
-                  <a:srgbClr val="222222"/>
-                </a:solidFill>
-                <a:latin typeface="Georgia"/>
-              </a:rPr>
-              <a:t> from other professional soccer leagues</a:t>
-            </a:r>
-            <a:r>
-              <a:rPr sz="2800" b="1" dirty="0">
-                <a:solidFill>
-                  <a:srgbClr val="222222"/>
-                </a:solidFill>
-                <a:latin typeface="Georgia"/>
-              </a:rPr>
-              <a:t>?</a:t>
+              </a:rPr>
+              <a:t>Which traits most accurately travel into the Bundesliga (Germany’s top men’s soccer league) from other professional soccer leagues?</a:t>
             </a:r>
           </a:p>
         </p:txBody>
@@ -3403,6 +3366,30 @@
           </a:p>
         </p:txBody>
       </p:sp>
+      <p:pic>
+        <p:nvPicPr>
+          <p:cNvPr id="6" name="Picture 5" descr="feeder_to_bundesliga_title.png"/>
+          <p:cNvPicPr>
+            <a:picLocks noChangeAspect="1"/>
+          </p:cNvPicPr>
+          <p:nvPr/>
+        </p:nvPicPr>
+        <p:blipFill>
+          <a:blip r:embed="rId2"/>
+          <a:stretch>
+            <a:fillRect/>
+          </a:stretch>
+        </p:blipFill>
+        <p:spPr>
+          <a:xfrm>
+            <a:off x="400000" y="4000000"/>
+            <a:ext cx="11400000" cy="2992500"/>
+          </a:xfrm>
+          <a:prstGeom prst="rect">
+            <a:avLst/>
+          </a:prstGeom>
+        </p:spPr>
+      </p:pic>
     </p:spTree>
   </p:cSld>
   <p:clrMapOvr>
@@ -15684,8 +15671,8 @@
         </p:nvSpPr>
         <p:spPr>
           <a:xfrm>
-            <a:off x="502920" y="3886200"/>
-            <a:ext cx="5486400" cy="2331720"/>
+            <a:off x="502920" y="4300000"/>
+            <a:ext cx="5486400" cy="1991800"/>
           </a:xfrm>
           <a:prstGeom prst="roundRect">
             <a:avLst/>
@@ -15730,8 +15717,8 @@
         </p:nvSpPr>
         <p:spPr>
           <a:xfrm>
-            <a:off x="502920" y="3886200"/>
-            <a:ext cx="73152" cy="2331720"/>
+            <a:off x="502920" y="4300000"/>
+            <a:ext cx="73152" cy="1991800"/>
           </a:xfrm>
           <a:prstGeom prst="rect">
             <a:avLst/>
@@ -15774,7 +15761,7 @@
         </p:nvSpPr>
         <p:spPr>
           <a:xfrm>
-            <a:off x="704088" y="3995928"/>
+            <a:off x="704088" y="4300000"/>
             <a:ext cx="5166360" cy="918200"/>
           </a:xfrm>
           <a:prstGeom prst="rect">
@@ -15868,8 +15855,8 @@
         </p:nvSpPr>
         <p:spPr>
           <a:xfrm>
-            <a:off x="6172200" y="3886200"/>
-            <a:ext cx="5440680" cy="2331720"/>
+            <a:off x="6172200" y="4300000"/>
+            <a:ext cx="5440680" cy="1991800"/>
           </a:xfrm>
           <a:prstGeom prst="roundRect">
             <a:avLst/>
@@ -15914,8 +15901,8 @@
         </p:nvSpPr>
         <p:spPr>
           <a:xfrm>
-            <a:off x="6172200" y="3886200"/>
-            <a:ext cx="73152" cy="2331720"/>
+            <a:off x="6172200" y="4300000"/>
+            <a:ext cx="73152" cy="1991800"/>
           </a:xfrm>
           <a:prstGeom prst="rect">
             <a:avLst/>
@@ -15958,7 +15945,7 @@
         </p:nvSpPr>
         <p:spPr>
           <a:xfrm>
-            <a:off x="6373368" y="3995928"/>
+            <a:off x="6373368" y="4300000"/>
             <a:ext cx="5120640" cy="931024"/>
           </a:xfrm>
           <a:prstGeom prst="rect">
@@ -16024,6 +16011,30 @@
           </a:p>
         </p:txBody>
       </p:sp>
+      <p:pic>
+        <p:nvPicPr>
+          <p:cNvPr id="22" name="Picture 21" descr="feeder_to_bundesliga_design.png"/>
+          <p:cNvPicPr>
+            <a:picLocks noChangeAspect="1"/>
+          </p:cNvPicPr>
+          <p:nvPr/>
+        </p:nvPicPr>
+        <p:blipFill>
+          <a:blip r:embed="rId2"/>
+          <a:stretch>
+            <a:fillRect/>
+          </a:stretch>
+        </p:blipFill>
+        <p:spPr>
+          <a:xfrm>
+            <a:off x="350000" y="2650000"/>
+            <a:ext cx="11500000" cy="1600000"/>
+          </a:xfrm>
+          <a:prstGeom prst="rect">
+            <a:avLst/>
+          </a:prstGeom>
+        </p:spPr>
+      </p:pic>
     </p:spTree>
   </p:cSld>
   <p:clrMapOvr>

</xml_diff>

<commit_message>
Use downloaded league logos in feeder graphics where available.
Hybrid crest diagram keeps labeled badges for leagues Wikimedia blocked, with real logos for the rest.

Co-authored-by: Cursor <cursoragent@cursor.com>
</commit_message>
<xml_diff>
--- a/bundesliga_transfer_traits.pptx
+++ b/bundesliga_transfer_traits.pptx
@@ -3375,15 +3375,15 @@
           <p:nvPr/>
         </p:nvPicPr>
         <p:blipFill>
-          <a:blip r:embed="rId2"/>
+          <a:blip r:embed="rId3"/>
           <a:stretch>
             <a:fillRect/>
           </a:stretch>
         </p:blipFill>
         <p:spPr>
           <a:xfrm>
-            <a:off x="400000" y="4000000"/>
-            <a:ext cx="11400000" cy="2992500"/>
+            <a:off x="350000" y="3950000"/>
+            <a:ext cx="11500000" cy="3162500"/>
           </a:xfrm>
           <a:prstGeom prst="rect">
             <a:avLst/>
@@ -15671,7 +15671,7 @@
         </p:nvSpPr>
         <p:spPr>
           <a:xfrm>
-            <a:off x="502920" y="4300000"/>
+            <a:off x="502920" y="4550000"/>
             <a:ext cx="5486400" cy="1991800"/>
           </a:xfrm>
           <a:prstGeom prst="roundRect">
@@ -15717,7 +15717,7 @@
         </p:nvSpPr>
         <p:spPr>
           <a:xfrm>
-            <a:off x="502920" y="4300000"/>
+            <a:off x="502920" y="4550000"/>
             <a:ext cx="73152" cy="1991800"/>
           </a:xfrm>
           <a:prstGeom prst="rect">
@@ -15761,7 +15761,7 @@
         </p:nvSpPr>
         <p:spPr>
           <a:xfrm>
-            <a:off x="704088" y="4300000"/>
+            <a:off x="704088" y="4550000"/>
             <a:ext cx="5166360" cy="918200"/>
           </a:xfrm>
           <a:prstGeom prst="rect">
@@ -15855,7 +15855,7 @@
         </p:nvSpPr>
         <p:spPr>
           <a:xfrm>
-            <a:off x="6172200" y="4300000"/>
+            <a:off x="6172200" y="4550000"/>
             <a:ext cx="5440680" cy="1991800"/>
           </a:xfrm>
           <a:prstGeom prst="roundRect">
@@ -15901,7 +15901,7 @@
         </p:nvSpPr>
         <p:spPr>
           <a:xfrm>
-            <a:off x="6172200" y="4300000"/>
+            <a:off x="6172200" y="4550000"/>
             <a:ext cx="73152" cy="1991800"/>
           </a:xfrm>
           <a:prstGeom prst="rect">
@@ -15945,7 +15945,7 @@
         </p:nvSpPr>
         <p:spPr>
           <a:xfrm>
-            <a:off x="6373368" y="4300000"/>
+            <a:off x="6373368" y="4550000"/>
             <a:ext cx="5120640" cy="931024"/>
           </a:xfrm>
           <a:prstGeom prst="rect">
@@ -16020,15 +16020,15 @@
           <p:nvPr/>
         </p:nvPicPr>
         <p:blipFill>
-          <a:blip r:embed="rId2"/>
+          <a:blip r:embed="rId3"/>
           <a:stretch>
             <a:fillRect/>
           </a:stretch>
         </p:blipFill>
         <p:spPr>
           <a:xfrm>
-            <a:off x="350000" y="2650000"/>
-            <a:ext cx="11500000" cy="1600000"/>
+            <a:off x="300000" y="2550000"/>
+            <a:ext cx="11600000" cy="5220000"/>
           </a:xfrm>
           <a:prstGeom prst="rect">
             <a:avLst/>

</xml_diff>

<commit_message>
Save latest PowerPoint edits to the deliverable deck.
Co-authored-by: Cursor <cursoragent@cursor.com>
</commit_message>
<xml_diff>
--- a/bundesliga_transfer_traits.pptx
+++ b/bundesliga_transfer_traits.pptx
@@ -6836,16 +6836,7 @@
                 </a:solidFill>
                 <a:latin typeface="Georgia"/>
               </a:rPr>
-              <a:t>Weak </a:t>
-            </a:r>
-            <a:r>
-              <a:rPr lang="en-US" sz="1400" b="1" dirty="0" err="1">
-                <a:solidFill>
-                  <a:srgbClr val="1C1C1C"/>
-                </a:solidFill>
-                <a:latin typeface="Georgia"/>
-              </a:rPr>
-              <a:t>Signalling</a:t>
+              <a:t>Weak Signaling</a:t>
             </a:r>
             <a:endParaRPr sz="1400" b="1" dirty="0">
               <a:solidFill>
@@ -6884,7 +6875,7 @@
               </a:spcAft>
             </a:pPr>
             <a:r>
-              <a:rPr sz="1200" b="0">
+              <a:rPr sz="1200" b="0" dirty="0">
                 <a:solidFill>
                   <a:srgbClr val="333333"/>
                 </a:solidFill>
@@ -6894,7 +6885,7 @@
           </a:p>
           <a:p>
             <a:r>
-              <a:rPr sz="1200" b="0">
+              <a:rPr sz="1200" b="0" dirty="0">
                 <a:solidFill>
                   <a:srgbClr val="333333"/>
                 </a:solidFill>
@@ -6904,13 +6895,42 @@
           </a:p>
           <a:p>
             <a:r>
-              <a:rPr sz="1200" b="0">
-                <a:solidFill>
-                  <a:srgbClr val="333333"/>
-                </a:solidFill>
-              </a:rPr>
-              <a:t>Full interactive tables: interactive_player_explorer.html · README.md</a:t>
-            </a:r>
+              <a:rPr sz="1200" b="0" dirty="0">
+                <a:solidFill>
+                  <a:srgbClr val="333333"/>
+                </a:solidFill>
+              </a:rPr>
+              <a:t>Full interactive tables: </a:t>
+            </a:r>
+            <a:r>
+              <a:rPr sz="1200" b="0" dirty="0" err="1">
+                <a:solidFill>
+                  <a:srgbClr val="333333"/>
+                </a:solidFill>
+              </a:rPr>
+              <a:t>interactive_player_explorer.html</a:t>
+            </a:r>
+            <a:r>
+              <a:rPr sz="1200" b="0" dirty="0">
+                <a:solidFill>
+                  <a:srgbClr val="333333"/>
+                </a:solidFill>
+              </a:rPr>
+              <a:t> · </a:t>
+            </a:r>
+            <a:r>
+              <a:rPr sz="1200" b="0" dirty="0" err="1">
+                <a:solidFill>
+                  <a:srgbClr val="333333"/>
+                </a:solidFill>
+              </a:rPr>
+              <a:t>README.md</a:t>
+            </a:r>
+            <a:endParaRPr sz="1200" b="0" dirty="0">
+              <a:solidFill>
+                <a:srgbClr val="333333"/>
+              </a:solidFill>
+            </a:endParaRPr>
           </a:p>
         </p:txBody>
       </p:sp>
@@ -16912,7 +16932,7 @@
         <p:spPr>
           <a:xfrm>
             <a:off x="4480560" y="3282926"/>
-            <a:ext cx="3291840" cy="1395254"/>
+            <a:ext cx="3291840" cy="1436291"/>
           </a:xfrm>
           <a:prstGeom prst="rect">
             <a:avLst/>
@@ -16931,7 +16951,7 @@
               </a:spcAft>
             </a:pPr>
             <a:r>
-              <a:rPr sz="1200" b="0">
+              <a:rPr sz="1200" b="0" dirty="0">
                 <a:solidFill>
                   <a:srgbClr val="333333"/>
                 </a:solidFill>
@@ -16941,17 +16961,33 @@
           </a:p>
           <a:p>
             <a:r>
-              <a:rPr sz="1200" b="0">
-                <a:solidFill>
-                  <a:srgbClr val="333333"/>
-                </a:solidFill>
-              </a:rPr>
-              <a:t>Consistency ≠ “this player will succeed” — it means the ranking tends to travel.</a:t>
-            </a:r>
-          </a:p>
-          <a:p>
-            <a:r>
-              <a:rPr sz="1200" b="0">
+              <a:rPr sz="1200" b="0" dirty="0">
+                <a:solidFill>
+                  <a:srgbClr val="333333"/>
+                </a:solidFill>
+              </a:rPr>
+              <a:t>Consistency ≠ “this player will succeed” — it means the ranking tends to travel</a:t>
+            </a:r>
+            <a:r>
+              <a:rPr lang="en-US" sz="1200" b="0" dirty="0">
+                <a:solidFill>
+                  <a:srgbClr val="333333"/>
+                </a:solidFill>
+              </a:rPr>
+              <a:t> from one league to the Bundesliga</a:t>
+            </a:r>
+            <a:r>
+              <a:rPr sz="1200" b="0" dirty="0">
+                <a:solidFill>
+                  <a:srgbClr val="333333"/>
+                </a:solidFill>
+              </a:rPr>
+              <a:t>.</a:t>
+            </a:r>
+          </a:p>
+          <a:p>
+            <a:r>
+              <a:rPr sz="1200" b="0" dirty="0">
                 <a:solidFill>
                   <a:srgbClr val="333333"/>
                 </a:solidFill>
@@ -17326,7 +17362,7 @@
         <p:spPr>
           <a:xfrm>
             <a:off x="548640" y="1463040"/>
-            <a:ext cx="8876714" cy="2357056"/>
+            <a:ext cx="8876714" cy="1964640"/>
           </a:xfrm>
           <a:prstGeom prst="rect">
             <a:avLst/>
@@ -17354,7 +17390,7 @@
               </a:spcAft>
             </a:pPr>
             <a:r>
-              <a:rPr sz="1200" b="0">
+              <a:rPr sz="1200" b="0" dirty="0">
                 <a:solidFill>
                   <a:srgbClr val="333333"/>
                 </a:solidFill>
@@ -17363,7 +17399,7 @@
             </a:r>
           </a:p>
           <a:p>
-            <a:endParaRPr sz="1200" b="0">
+            <a:endParaRPr sz="1200" b="0" dirty="0">
               <a:solidFill>
                 <a:srgbClr val="333333"/>
               </a:solidFill>
@@ -17371,7 +17407,7 @@
           </a:p>
           <a:p>
             <a:r>
-              <a:rPr sz="1200" b="0">
+              <a:rPr sz="1200" b="0" dirty="0">
                 <a:solidFill>
                   <a:srgbClr val="333333"/>
                 </a:solidFill>
@@ -17381,7 +17417,7 @@
           </a:p>
           <a:p>
             <a:r>
-              <a:rPr sz="1200" b="0">
+              <a:rPr sz="1200" b="0" dirty="0">
                 <a:solidFill>
                   <a:srgbClr val="333333"/>
                 </a:solidFill>
@@ -17391,7 +17427,7 @@
           </a:p>
           <a:p>
             <a:r>
-              <a:rPr sz="1200" b="0">
+              <a:rPr sz="1200" b="0" dirty="0">
                 <a:solidFill>
                   <a:srgbClr val="333333"/>
                 </a:solidFill>
@@ -17400,7 +17436,7 @@
             </a:r>
           </a:p>
           <a:p>
-            <a:endParaRPr sz="1200" b="0">
+            <a:endParaRPr sz="1200" b="0" dirty="0">
               <a:solidFill>
                 <a:srgbClr val="333333"/>
               </a:solidFill>
@@ -17408,16 +17444,32 @@
           </a:p>
           <a:p>
             <a:r>
-              <a:rPr sz="1200" b="0">
-                <a:solidFill>
-                  <a:srgbClr val="333333"/>
-                </a:solidFill>
-              </a:rPr>
-              <a:t>League-relative scaling (mentioned once): we tried scoring each rate as “how high vs peers in the same prior league” (z-score / percentile). It did not improve prior→first-season consistency, so we keep absolute per-90-minute rates everywhere.</a:t>
-            </a:r>
-          </a:p>
-          <a:p>
-            <a:endParaRPr sz="1200" b="0">
+              <a:rPr sz="1200" b="0" dirty="0">
+                <a:solidFill>
+                  <a:srgbClr val="333333"/>
+                </a:solidFill>
+              </a:rPr>
+              <a:t>League-relative scaling (mentioned once): we tried scoring each rate as “how high vs peers in the same prior league” (z-score / percentile). It did not improve </a:t>
+            </a:r>
+            <a:r>
+              <a:rPr sz="1200" b="0" dirty="0" err="1">
+                <a:solidFill>
+                  <a:srgbClr val="333333"/>
+                </a:solidFill>
+              </a:rPr>
+              <a:t>prior→first-season</a:t>
+            </a:r>
+            <a:r>
+              <a:rPr sz="1200" b="0" dirty="0">
+                <a:solidFill>
+                  <a:srgbClr val="333333"/>
+                </a:solidFill>
+              </a:rPr>
+              <a:t> consistency, so we keep absolute per-90-minute rates everywhere.</a:t>
+            </a:r>
+          </a:p>
+          <a:p>
+            <a:endParaRPr sz="1200" b="0" dirty="0">
               <a:solidFill>
                 <a:srgbClr val="333333"/>
               </a:solidFill>
@@ -17425,7 +17477,15 @@
           </a:p>
           <a:p>
             <a:r>
-              <a:rPr sz="1200" b="0">
+              <a:rPr lang="en-US" sz="1200" b="0" dirty="0">
+                <a:solidFill>
+                  <a:srgbClr val="333333"/>
+                </a:solidFill>
+              </a:rPr>
+              <a:t>Time </a:t>
+            </a:r>
+            <a:r>
+              <a:rPr sz="1200" b="0" dirty="0">
                 <a:solidFill>
                   <a:srgbClr val="333333"/>
                 </a:solidFill>
@@ -17780,7 +17840,7 @@
         </p:nvSpPr>
         <p:spPr>
           <a:xfrm>
-            <a:off x="0" y="297180"/>
+            <a:off x="0" y="0"/>
             <a:ext cx="12191695" cy="6858000"/>
           </a:xfrm>
           <a:prstGeom prst="rect">
@@ -21302,7 +21362,7 @@
         </p:nvSpPr>
         <p:spPr>
           <a:xfrm>
-            <a:off x="0" y="297180"/>
+            <a:off x="305" y="0"/>
             <a:ext cx="12191695" cy="6858000"/>
           </a:xfrm>
           <a:prstGeom prst="rect">

</xml_diff>

<commit_message>
Align submit deliverables to the five package outputs only.
List deck, README, both HTML tools, and the proposal once in the README, proposal, and closing PPT slide.

Co-authored-by: Cursor <cursoragent@cursor.com>
</commit_message>
<xml_diff>
--- a/bundesliga_transfer_traits.pptx
+++ b/bundesliga_transfer_traits.pptx
@@ -15149,63 +15149,112 @@
               </a:spcAft>
             </a:pPr>
             <a:r>
-              <a:rPr sz="2600" b="0">
-                <a:solidFill>
-                  <a:srgbClr val="333333"/>
-                </a:solidFill>
-              </a:rPr>
-              <a:t>Deliverables</a:t>
-            </a:r>
-          </a:p>
-          <a:p>
-            <a:endParaRPr sz="2600" b="0">
-              <a:solidFill>
-                <a:srgbClr val="333333"/>
-              </a:solidFill>
-            </a:endParaRPr>
-          </a:p>
-          <a:p>
-            <a:r>
-              <a:rPr sz="2600" b="0">
-                <a:solidFill>
-                  <a:srgbClr val="333333"/>
-                </a:solidFill>
-              </a:rPr>
-              <a:t>1 · Cohort (with minute floors) · 2 · Stability · 3 · Redundancy · 4 · Explorer + success</a:t>
-            </a:r>
-          </a:p>
-          <a:p>
-            <a:endParaRPr sz="2600" b="0">
-              <a:solidFill>
-                <a:srgbClr val="333333"/>
-              </a:solidFill>
-            </a:endParaRPr>
-          </a:p>
-          <a:p>
-            <a:r>
-              <a:rPr sz="2600" b="0">
-                <a:solidFill>
-                  <a:srgbClr val="333333"/>
-                </a:solidFill>
-              </a:rPr>
-              <a:t>Repo: deck · README.md · interactive_player_explorer.html · stability_redundancy_inspector.html · projectproposal</a:t>
-            </a:r>
-          </a:p>
-          <a:p>
-            <a:endParaRPr sz="2600" b="0">
-              <a:solidFill>
-                <a:srgbClr val="333333"/>
-              </a:solidFill>
-            </a:endParaRPr>
-          </a:p>
-          <a:p>
-            <a:r>
-              <a:rPr sz="2600" b="0">
-                <a:solidFill>
-                  <a:srgbClr val="333333"/>
-                </a:solidFill>
-              </a:rPr>
-              <a:t>Stability floors: Football Reference Attacking/Passing/Other Pearson r ≥ 0.60 · Defending/Carrying Pearson r ≥ 0.50 · StatsBomb Pearson r ≥ 0.40 · final shortlists 32 / 7</a:t>
+              <a:rPr sz="2200" b="1">
+                <a:solidFill>
+                  <a:srgbClr val="3D5A80"/>
+                </a:solidFill>
+              </a:rPr>
+              <a:t>Deliverables (submit package — these five files only)</a:t>
+            </a:r>
+          </a:p>
+          <a:p>
+            <a:r>
+              <a:rPr sz="1400" b="0">
+                <a:solidFill>
+                  <a:srgbClr val="333333"/>
+                </a:solidFill>
+              </a:rPr>
+              <a:t/>
+            </a:r>
+          </a:p>
+          <a:p>
+            <a:r>
+              <a:rPr sz="1400" b="0">
+                <a:solidFill>
+                  <a:srgbClr val="333333"/>
+                </a:solidFill>
+              </a:rPr>
+              <a:t>1. bundesliga_transfer_traits.pptx — method + results deck</a:t>
+            </a:r>
+          </a:p>
+          <a:p>
+            <a:r>
+              <a:rPr sz="1400" b="0">
+                <a:solidFill>
+                  <a:srgbClr val="333333"/>
+                </a:solidFill>
+              </a:rPr>
+              <a:t>2. README.md — package overview + regression tables</a:t>
+            </a:r>
+          </a:p>
+          <a:p>
+            <a:r>
+              <a:rPr sz="1400" b="0">
+                <a:solidFill>
+                  <a:srgbClr val="333333"/>
+                </a:solidFill>
+              </a:rPr>
+              <a:t>3. interactive_player_explorer.html — success summary + player radar charts</a:t>
+            </a:r>
+          </a:p>
+          <a:p>
+            <a:r>
+              <a:rPr sz="1400" b="0">
+                <a:solidFill>
+                  <a:srgbClr val="333333"/>
+                </a:solidFill>
+              </a:rPr>
+              <a:t>4. stability_redundancy_inspector.html — consistency floors &amp; near-duplicate cuts</a:t>
+            </a:r>
+          </a:p>
+          <a:p>
+            <a:r>
+              <a:rPr sz="1400" b="0">
+                <a:solidFill>
+                  <a:srgbClr val="333333"/>
+                </a:solidFill>
+              </a:rPr>
+              <a:t>5. projectproposal.docx — proposal memo (projectproposal.txt = same memo, plain text)</a:t>
+            </a:r>
+          </a:p>
+          <a:p>
+            <a:r>
+              <a:rPr sz="1400" b="0">
+                <a:solidFill>
+                  <a:srgbClr val="333333"/>
+                </a:solidFill>
+              </a:rPr>
+              <a:t/>
+            </a:r>
+          </a:p>
+          <a:p>
+            <a:r>
+              <a:rPr sz="1400" b="0">
+                <a:solidFill>
+                  <a:srgbClr val="333333"/>
+                </a:solidFill>
+              </a:rPr>
+              <a:t>Pipeline (not separate files): cohort with minute floors → consistency check → drop near-duplicates → explorer + success tests</a:t>
+            </a:r>
+          </a:p>
+          <a:p>
+            <a:r>
+              <a:rPr sz="1400" b="0">
+                <a:solidFill>
+                  <a:srgbClr val="333333"/>
+                </a:solidFill>
+              </a:rPr>
+              <a:t/>
+            </a:r>
+          </a:p>
+          <a:p>
+            <a:r>
+              <a:rPr sz="1400" b="0">
+                <a:solidFill>
+                  <a:srgbClr val="333333"/>
+                </a:solidFill>
+              </a:rPr>
+              <a:t>Consistency floors: Football Reference Attacking/Passing/Other Pearson r ≥ 0.60 · Defending/Carrying Pearson r ≥ 0.50 · StatsBomb Pearson r ≥ 0.40 · final shortlists 32 / 7</a:t>
             </a:r>
           </a:p>
         </p:txBody>

</xml_diff>